<commit_message>
Add Chinese curriculum mechanism visualization
</commit_message>
<xml_diff>
--- a/agentQwen/slides/AgenticQwen_Curriculum_Cloud.pptx
+++ b/agentQwen/slides/AgenticQwen_Curriculum_Cloud.pptx
@@ -2,27 +2,28 @@
 <file path=ppt/presentation.xml><?xml version="1.0" encoding="utf-8"?>
 <p:presentation xmlns:p="http://schemas.openxmlformats.org/presentationml/2006/main">
   <p:sldMasterIdLst>
-    <p:sldMasterId xmlns:r="http://schemas.openxmlformats.org/officeDocument/2006/relationships" id="2147483648" r:id="R880e99608aa04f4e"/>
+    <p:sldMasterId xmlns:r="http://schemas.openxmlformats.org/officeDocument/2006/relationships" id="2147483648" r:id="Ra719b380f55b4361"/>
   </p:sldMasterIdLst>
   <p:notesMasterIdLst>
-    <p:notesMasterId xmlns:r="http://schemas.openxmlformats.org/officeDocument/2006/relationships" r:id="Rd26f16bfbc1f418b"/>
+    <p:notesMasterId xmlns:r="http://schemas.openxmlformats.org/officeDocument/2006/relationships" r:id="Ree4a924ef3a3468e"/>
   </p:notesMasterIdLst>
   <p:sldIdLst>
-    <p:sldId xmlns:r="http://schemas.openxmlformats.org/officeDocument/2006/relationships" id="256" r:id="Rb5b826654473407a"/>
-    <p:sldId xmlns:r="http://schemas.openxmlformats.org/officeDocument/2006/relationships" id="257" r:id="R26a1343413de475c"/>
-    <p:sldId xmlns:r="http://schemas.openxmlformats.org/officeDocument/2006/relationships" id="258" r:id="R1ede489ba94e4ef2"/>
-    <p:sldId xmlns:r="http://schemas.openxmlformats.org/officeDocument/2006/relationships" id="259" r:id="R6930b5f871814cb1"/>
-    <p:sldId xmlns:r="http://schemas.openxmlformats.org/officeDocument/2006/relationships" id="260" r:id="Rec25083f1abd41da"/>
-    <p:sldId xmlns:r="http://schemas.openxmlformats.org/officeDocument/2006/relationships" id="261" r:id="R47ca4fb817504079"/>
-    <p:sldId xmlns:r="http://schemas.openxmlformats.org/officeDocument/2006/relationships" id="262" r:id="Rc8b9aa54ca084025"/>
-    <p:sldId xmlns:r="http://schemas.openxmlformats.org/officeDocument/2006/relationships" id="263" r:id="Ref3165b762ce4a7c"/>
-    <p:sldId xmlns:r="http://schemas.openxmlformats.org/officeDocument/2006/relationships" id="264" r:id="R344be8668f574bb4"/>
-    <p:sldId xmlns:r="http://schemas.openxmlformats.org/officeDocument/2006/relationships" id="265" r:id="R2b27153c0e2b4ffa"/>
-    <p:sldId xmlns:r="http://schemas.openxmlformats.org/officeDocument/2006/relationships" id="266" r:id="R2afc83f7cec34c05"/>
-    <p:sldId xmlns:r="http://schemas.openxmlformats.org/officeDocument/2006/relationships" id="267" r:id="Rfbc105726e8c426d"/>
-    <p:sldId xmlns:r="http://schemas.openxmlformats.org/officeDocument/2006/relationships" id="268" r:id="R33b973cf6b404f42"/>
-    <p:sldId xmlns:r="http://schemas.openxmlformats.org/officeDocument/2006/relationships" id="269" r:id="Rea829d39129a4689"/>
-    <p:sldId xmlns:r="http://schemas.openxmlformats.org/officeDocument/2006/relationships" id="270" r:id="R7971f623aa5844d0"/>
+    <p:sldId xmlns:r="http://schemas.openxmlformats.org/officeDocument/2006/relationships" id="256" r:id="R4917e464529d4db1"/>
+    <p:sldId xmlns:r="http://schemas.openxmlformats.org/officeDocument/2006/relationships" id="257" r:id="R86473819c6054252"/>
+    <p:sldId xmlns:r="http://schemas.openxmlformats.org/officeDocument/2006/relationships" id="258" r:id="R83204962f6774ff0"/>
+    <p:sldId xmlns:r="http://schemas.openxmlformats.org/officeDocument/2006/relationships" id="259" r:id="R0b4e6b08ca00417e"/>
+    <p:sldId xmlns:r="http://schemas.openxmlformats.org/officeDocument/2006/relationships" id="260" r:id="R4cc6aa1b2cd14ced"/>
+    <p:sldId xmlns:r="http://schemas.openxmlformats.org/officeDocument/2006/relationships" id="261" r:id="Rd68cf32722424323"/>
+    <p:sldId xmlns:r="http://schemas.openxmlformats.org/officeDocument/2006/relationships" id="262" r:id="Rb05f5de24a014b7c"/>
+    <p:sldId xmlns:r="http://schemas.openxmlformats.org/officeDocument/2006/relationships" id="263" r:id="Rfb63ae7d86954df4"/>
+    <p:sldId xmlns:r="http://schemas.openxmlformats.org/officeDocument/2006/relationships" id="264" r:id="Rc6f8e9f6d6094098"/>
+    <p:sldId xmlns:r="http://schemas.openxmlformats.org/officeDocument/2006/relationships" id="265" r:id="Ra3c5bca19346440b"/>
+    <p:sldId xmlns:r="http://schemas.openxmlformats.org/officeDocument/2006/relationships" id="266" r:id="Ra55b4d2bfc044e82"/>
+    <p:sldId xmlns:r="http://schemas.openxmlformats.org/officeDocument/2006/relationships" id="267" r:id="R4834883ee617498c"/>
+    <p:sldId xmlns:r="http://schemas.openxmlformats.org/officeDocument/2006/relationships" id="268" r:id="R533bbe65ae574072"/>
+    <p:sldId xmlns:r="http://schemas.openxmlformats.org/officeDocument/2006/relationships" id="269" r:id="R666fcc2a72a2482f"/>
+    <p:sldId xmlns:r="http://schemas.openxmlformats.org/officeDocument/2006/relationships" id="270" r:id="R66f9074648ce45ee"/>
+    <p:sldId xmlns:r="http://schemas.openxmlformats.org/officeDocument/2006/relationships" id="271" r:id="R855a6d7538a34b57"/>
   </p:sldIdLst>
   <p:sldSz cx="12192000" cy="6858000"/>
   <p:notesSz cx="6858000" cy="9144000"/>
@@ -1031,6 +1032,101 @@
           <a:lstStyle xmlns:a="http://schemas.openxmlformats.org/drawingml/2006/main"/>
           <a:p xmlns:a="http://schemas.openxmlformats.org/drawingml/2006/main">
             <a:r>
+              <a:t>这张机制图解释为什么第二阶段数据不是随机扩充：失败路径被反译成新的环境状态、用户指令、智能体约束与分支工作流。</a:t>
+            </a:r>
+          </a:p>
+          <a:p xmlns:a="http://schemas.openxmlformats.org/drawingml/2006/main">
+            <a:r>
+              <a:t/>
+            </a:r>
+          </a:p>
+          <a:p xmlns:a="http://schemas.openxmlformats.org/drawingml/2006/main">
+            <a:r>
+              <a:t>[Sources]</a:t>
+            </a:r>
+          </a:p>
+          <a:p xmlns:a="http://schemas.openxmlformats.org/drawingml/2006/main">
+            <a:r>
+              <a:t>- /Users/hongbo/Documents/Codex/2026-08-02/https-yyhdbl-github-io/outputs/agenticqwen-reproduction/agenticqwen_report/images/figure4_curriculum_stage_flow.png</a:t>
+            </a:r>
+          </a:p>
+          <a:p xmlns:a="http://schemas.openxmlformats.org/drawingml/2006/main">
+            <a:r>
+              <a:t>- /Users/hongbo/Documents/Codex/2026-08-02/https-yyhdbl-github-io/outputs/agenticqwen-reproduction/artifacts/cloud_runs/qwen3-8b-qlora-20260804-v2/evidence/stage2/synthesis_manifest.json</a:t>
+            </a:r>
+          </a:p>
+          <a:p xmlns:a="http://schemas.openxmlformats.org/drawingml/2006/main">
+            <a:r>
+              <a:t>[/Sources]</a:t>
+            </a:r>
+          </a:p>
+        </p:txBody>
+      </p:sp>
+      <p:sp>
+        <p:nvSpPr>
+          <p:cNvPr id="4" name="Slide Number Placeholder 3"/>
+          <p:cNvSpPr>
+            <a:spLocks xmlns:a="http://schemas.openxmlformats.org/drawingml/2006/main" noGrp="1"/>
+          </p:cNvSpPr>
+          <p:nvPr>
+            <p:ph type="sldNum" idx="5"/>
+          </p:nvPr>
+        </p:nvSpPr>
+        <p:spPr/>
+        <p:txBody>
+          <a:bodyPr xmlns:a="http://schemas.openxmlformats.org/drawingml/2006/main"/>
+          <a:lstStyle xmlns:a="http://schemas.openxmlformats.org/drawingml/2006/main"/>
+          <a:p xmlns:a="http://schemas.openxmlformats.org/drawingml/2006/main"/>
+        </p:txBody>
+      </p:sp>
+    </p:spTree>
+  </p:cSld>
+  <p:clrMapOvr>
+    <a:masterClrMapping xmlns:a="http://schemas.openxmlformats.org/drawingml/2006/main"/>
+  </p:clrMapOvr>
+</p:notes>
+</file>
+
+<file path=ppt/notesSlides/notesSlide16.xml><?xml version="1.0" encoding="utf-8"?>
+<p:notes xmlns:p="http://schemas.openxmlformats.org/presentationml/2006/main">
+  <p:cSld>
+    <p:spTree>
+      <p:nvGrpSpPr>
+        <p:cNvPr id="1" name=""/>
+        <p:cNvGrpSpPr/>
+        <p:nvPr/>
+      </p:nvGrpSpPr>
+      <p:grpSpPr>
+        <a:xfrm xmlns:a="http://schemas.openxmlformats.org/drawingml/2006/main"/>
+      </p:grpSpPr>
+      <p:sp>
+        <p:nvSpPr>
+          <p:cNvPr id="2" name="Slide Image Placeholder 1"/>
+          <p:cNvSpPr>
+            <a:spLocks xmlns:a="http://schemas.openxmlformats.org/drawingml/2006/main" noGrp="1"/>
+          </p:cNvSpPr>
+          <p:nvPr>
+            <p:ph type="sldImg" idx="0"/>
+          </p:nvPr>
+        </p:nvSpPr>
+        <p:spPr/>
+      </p:sp>
+      <p:sp>
+        <p:nvSpPr>
+          <p:cNvPr id="3" name="Notes Placeholder 2"/>
+          <p:cNvSpPr>
+            <a:spLocks xmlns:a="http://schemas.openxmlformats.org/drawingml/2006/main" noGrp="1"/>
+          </p:cNvSpPr>
+          <p:nvPr>
+            <p:ph type="body" idx="1"/>
+          </p:nvPr>
+        </p:nvSpPr>
+        <p:spPr/>
+        <p:txBody>
+          <a:bodyPr xmlns:a="http://schemas.openxmlformats.org/drawingml/2006/main"/>
+          <a:lstStyle xmlns:a="http://schemas.openxmlformats.org/drawingml/2006/main"/>
+          <a:p xmlns:a="http://schemas.openxmlformats.org/drawingml/2006/main">
+            <a:r>
               <a:t>结尾把项目浓缩成一句可用于简历和面试、但不越过证据边界的话。</a:t>
             </a:r>
           </a:p>
@@ -1874,7 +1970,7 @@
   </p:cSld>
   <p:clrMap bg1="lt1" tx1="dk1" bg2="lt2" tx2="dk2" accent1="accent1" accent2="accent2" accent3="accent3" accent4="accent4" accent5="accent5" accent6="accent6" hlink="hlink" folHlink="folHlink"/>
   <p:sldLayoutIdLst>
-    <p:sldLayoutId xmlns:r="http://schemas.openxmlformats.org/officeDocument/2006/relationships" id="2147483649" r:id="R769bcf70e3d94bd6"/>
+    <p:sldLayoutId xmlns:r="http://schemas.openxmlformats.org/officeDocument/2006/relationships" id="2147483649" r:id="R5604e068f0af4db1"/>
   </p:sldLayoutIdLst>
   <p:txStyles>
     <p:titleStyle>
@@ -2425,7 +2521,7 @@
           <p:cNvPr id="14" name="cover-copper">
             <a:extLst xmlns:a="http://schemas.openxmlformats.org/drawingml/2006/main">
               <a:ext uri="{FF2B5EF4-FFF2-40B4-BE49-F238E27FC236}">
-                <a16:creationId xmlns:a16="http://schemas.microsoft.com/office/drawing/2014/main" id="{FD35BC74-7746-4487-8A3E-F04C07C1B12C}"/>
+                <a16:creationId xmlns:a16="http://schemas.microsoft.com/office/drawing/2014/main" id="{A3AAFC37-45FB-42D7-A21D-DFDCA3074656}"/>
               </a:ext>
             </a:extLst>
           </p:cNvPr>
@@ -2458,7 +2554,7 @@
           <p:cNvPr id="2" name="cover-teal">
             <a:extLst xmlns:a="http://schemas.openxmlformats.org/drawingml/2006/main">
               <a:ext uri="{FF2B5EF4-FFF2-40B4-BE49-F238E27FC236}">
-                <a16:creationId xmlns:a16="http://schemas.microsoft.com/office/drawing/2014/main" id="{83194C1F-7493-4DC6-998B-B3557F9A3A2E}"/>
+                <a16:creationId xmlns:a16="http://schemas.microsoft.com/office/drawing/2014/main" id="{9C5D5A58-4674-4A65-BD92-DB11D0946991}"/>
               </a:ext>
             </a:extLst>
           </p:cNvPr>
@@ -2491,7 +2587,7 @@
           <p:cNvPr id="3" name="cover-flourish">
             <a:extLst xmlns:a="http://schemas.openxmlformats.org/drawingml/2006/main">
               <a:ext uri="{FF2B5EF4-FFF2-40B4-BE49-F238E27FC236}">
-                <a16:creationId xmlns:a16="http://schemas.microsoft.com/office/drawing/2014/main" id="{489F3E91-BA60-4766-A347-5B2D0D9F3554}"/>
+                <a16:creationId xmlns:a16="http://schemas.microsoft.com/office/drawing/2014/main" id="{7B2D43DE-40DE-4B07-A594-C572A12CD766}"/>
               </a:ext>
             </a:extLst>
           </p:cNvPr>
@@ -2541,7 +2637,7 @@
           <p:cNvPr id="4" name="">
             <a:extLst xmlns:a="http://schemas.openxmlformats.org/drawingml/2006/main">
               <a:ext uri="{FF2B5EF4-FFF2-40B4-BE49-F238E27FC236}">
-                <a16:creationId xmlns:a16="http://schemas.microsoft.com/office/drawing/2014/main" id="{EAECF42B-C44F-4277-9976-6BDD098BB282}"/>
+                <a16:creationId xmlns:a16="http://schemas.microsoft.com/office/drawing/2014/main" id="{9687052F-7E46-4C5B-A43D-7BACFC0DDB8F}"/>
               </a:ext>
             </a:extLst>
           </p:cNvPr>
@@ -2572,7 +2668,7 @@
           <p:cNvPr id="5" name="cover-title">
             <a:extLst xmlns:a="http://schemas.openxmlformats.org/drawingml/2006/main">
               <a:ext uri="{FF2B5EF4-FFF2-40B4-BE49-F238E27FC236}">
-                <a16:creationId xmlns:a16="http://schemas.microsoft.com/office/drawing/2014/main" id="{38C4524A-B234-40EE-97BD-8349B74197E2}"/>
+                <a16:creationId xmlns:a16="http://schemas.microsoft.com/office/drawing/2014/main" id="{3F640336-60F9-4C90-A213-A52464F6D1CF}"/>
               </a:ext>
             </a:extLst>
           </p:cNvPr>
@@ -2647,7 +2743,7 @@
           <p:cNvPr id="6" name="cover-sub">
             <a:extLst xmlns:a="http://schemas.openxmlformats.org/drawingml/2006/main">
               <a:ext uri="{FF2B5EF4-FFF2-40B4-BE49-F238E27FC236}">
-                <a16:creationId xmlns:a16="http://schemas.microsoft.com/office/drawing/2014/main" id="{F7D2DB93-1CEE-454A-9470-3B3E91DB6280}"/>
+                <a16:creationId xmlns:a16="http://schemas.microsoft.com/office/drawing/2014/main" id="{C187B2FB-2F8D-45A4-9601-5FEF00B07C58}"/>
               </a:ext>
             </a:extLst>
           </p:cNvPr>
@@ -2697,7 +2793,7 @@
           <p:cNvPr id="7" name="cover-meta">
             <a:extLst xmlns:a="http://schemas.openxmlformats.org/drawingml/2006/main">
               <a:ext uri="{FF2B5EF4-FFF2-40B4-BE49-F238E27FC236}">
-                <a16:creationId xmlns:a16="http://schemas.microsoft.com/office/drawing/2014/main" id="{F5634DEC-90F3-4251-8744-50FBC65AC7D0}"/>
+                <a16:creationId xmlns:a16="http://schemas.microsoft.com/office/drawing/2014/main" id="{7F504254-A10E-4002-9718-8945F0F2208D}"/>
               </a:ext>
             </a:extLst>
           </p:cNvPr>
@@ -2764,7 +2860,7 @@
           <p:cNvPr id="8" name="cover-02">
             <a:extLst xmlns:a="http://schemas.openxmlformats.org/drawingml/2006/main">
               <a:ext uri="{FF2B5EF4-FFF2-40B4-BE49-F238E27FC236}">
-                <a16:creationId xmlns:a16="http://schemas.microsoft.com/office/drawing/2014/main" id="{8579F04E-2C40-4A6B-81DC-87043EA82EAA}"/>
+                <a16:creationId xmlns:a16="http://schemas.microsoft.com/office/drawing/2014/main" id="{EC9ABD35-5C30-4288-8D71-A9F3BB7D63A3}"/>
               </a:ext>
             </a:extLst>
           </p:cNvPr>
@@ -2814,7 +2910,7 @@
           <p:cNvPr id="9" name="cover-side">
             <a:extLst xmlns:a="http://schemas.openxmlformats.org/drawingml/2006/main">
               <a:ext uri="{FF2B5EF4-FFF2-40B4-BE49-F238E27FC236}">
-                <a16:creationId xmlns:a16="http://schemas.microsoft.com/office/drawing/2014/main" id="{AC742A20-9477-421A-B8D6-702E6AC90996}"/>
+                <a16:creationId xmlns:a16="http://schemas.microsoft.com/office/drawing/2014/main" id="{C7C54416-277F-492E-9399-632047F383A5}"/>
               </a:ext>
             </a:extLst>
           </p:cNvPr>
@@ -2910,7 +3006,7 @@
           <p:cNvPr id="10" name="cover-pass-bg">
             <a:extLst xmlns:a="http://schemas.openxmlformats.org/drawingml/2006/main">
               <a:ext uri="{FF2B5EF4-FFF2-40B4-BE49-F238E27FC236}">
-                <a16:creationId xmlns:a16="http://schemas.microsoft.com/office/drawing/2014/main" id="{CAB7573E-54F8-4293-A600-E4C80EF5588C}"/>
+                <a16:creationId xmlns:a16="http://schemas.microsoft.com/office/drawing/2014/main" id="{143A654D-107C-416C-AE04-8AB492D07692}"/>
               </a:ext>
             </a:extLst>
           </p:cNvPr>
@@ -2945,7 +3041,7 @@
           <p:cNvPr id="11" name="cover-pass-text">
             <a:extLst xmlns:a="http://schemas.openxmlformats.org/drawingml/2006/main">
               <a:ext uri="{FF2B5EF4-FFF2-40B4-BE49-F238E27FC236}">
-                <a16:creationId xmlns:a16="http://schemas.microsoft.com/office/drawing/2014/main" id="{4F33983F-AF54-47BC-9AC4-DE57CC990BCA}"/>
+                <a16:creationId xmlns:a16="http://schemas.microsoft.com/office/drawing/2014/main" id="{48177318-7308-406B-B50C-8BD614795F38}"/>
               </a:ext>
             </a:extLst>
           </p:cNvPr>
@@ -2995,7 +3091,7 @@
           <p:cNvPr id="12" name="cover-bfcl-bg">
             <a:extLst xmlns:a="http://schemas.openxmlformats.org/drawingml/2006/main">
               <a:ext uri="{FF2B5EF4-FFF2-40B4-BE49-F238E27FC236}">
-                <a16:creationId xmlns:a16="http://schemas.microsoft.com/office/drawing/2014/main" id="{2B293DFF-2F96-4820-9CC1-1C886D8DB215}"/>
+                <a16:creationId xmlns:a16="http://schemas.microsoft.com/office/drawing/2014/main" id="{D1493735-888F-4EE1-9F77-560C0DBB505B}"/>
               </a:ext>
             </a:extLst>
           </p:cNvPr>
@@ -3030,7 +3126,7 @@
           <p:cNvPr id="13" name="cover-bfcl-text">
             <a:extLst xmlns:a="http://schemas.openxmlformats.org/drawingml/2006/main">
               <a:ext uri="{FF2B5EF4-FFF2-40B4-BE49-F238E27FC236}">
-                <a16:creationId xmlns:a16="http://schemas.microsoft.com/office/drawing/2014/main" id="{46350DC8-648D-42DA-B767-6629A4CD1EAA}"/>
+                <a16:creationId xmlns:a16="http://schemas.microsoft.com/office/drawing/2014/main" id="{EA027DC0-4FB8-4A71-9CA2-53B7D24FE843}"/>
               </a:ext>
             </a:extLst>
           </p:cNvPr>
@@ -3078,7 +3174,7 @@
     </p:spTree>
     <p:extLst>
       <p:ext uri="{BB962C8B-B14F-4D97-AF65-F5344CB8AC3E}">
-        <p14:creationId xmlns:p14="http://schemas.microsoft.com/office/powerpoint/2010/main" val="326812905"/>
+        <p14:creationId xmlns:p14="http://schemas.microsoft.com/office/powerpoint/2010/main" val="2000420436"/>
       </p:ext>
     </p:extLst>
   </p:cSld>
@@ -3109,7 +3205,7 @@
           <p:cNvPr id="32" name="rail-10">
             <a:extLst xmlns:a="http://schemas.openxmlformats.org/drawingml/2006/main">
               <a:ext uri="{FF2B5EF4-FFF2-40B4-BE49-F238E27FC236}">
-                <a16:creationId xmlns:a16="http://schemas.microsoft.com/office/drawing/2014/main" id="{7AB2E8C9-F24A-41AD-AB02-E9CB79CDACFA}"/>
+                <a16:creationId xmlns:a16="http://schemas.microsoft.com/office/drawing/2014/main" id="{1B0C0F30-B05F-42A5-9FBF-D402549EC3B1}"/>
               </a:ext>
             </a:extLst>
           </p:cNvPr>
@@ -3142,7 +3238,7 @@
           <p:cNvPr id="2" name="flourish-10">
             <a:extLst xmlns:a="http://schemas.openxmlformats.org/drawingml/2006/main">
               <a:ext uri="{FF2B5EF4-FFF2-40B4-BE49-F238E27FC236}">
-                <a16:creationId xmlns:a16="http://schemas.microsoft.com/office/drawing/2014/main" id="{6AD45FE9-0A54-4104-938D-E052CADE50C7}"/>
+                <a16:creationId xmlns:a16="http://schemas.microsoft.com/office/drawing/2014/main" id="{803EAF10-B44D-459B-8271-7C7EF44AC11D}"/>
               </a:ext>
             </a:extLst>
           </p:cNvPr>
@@ -3192,7 +3288,7 @@
           <p:cNvPr id="3" name="chapter-10">
             <a:extLst xmlns:a="http://schemas.openxmlformats.org/drawingml/2006/main">
               <a:ext uri="{FF2B5EF4-FFF2-40B4-BE49-F238E27FC236}">
-                <a16:creationId xmlns:a16="http://schemas.microsoft.com/office/drawing/2014/main" id="{95494323-75D0-45CD-A700-76EB51F5E0C0}"/>
+                <a16:creationId xmlns:a16="http://schemas.microsoft.com/office/drawing/2014/main" id="{C6DED371-E487-40C1-AB71-E758E28042EC}"/>
               </a:ext>
             </a:extLst>
           </p:cNvPr>
@@ -3242,7 +3338,7 @@
           <p:cNvPr id="4" name="title-10">
             <a:extLst xmlns:a="http://schemas.openxmlformats.org/drawingml/2006/main">
               <a:ext uri="{FF2B5EF4-FFF2-40B4-BE49-F238E27FC236}">
-                <a16:creationId xmlns:a16="http://schemas.microsoft.com/office/drawing/2014/main" id="{15D1CBAC-FDDC-4116-B6CD-27504E7010CD}"/>
+                <a16:creationId xmlns:a16="http://schemas.microsoft.com/office/drawing/2014/main" id="{5508BE95-FECA-48F8-A55F-AC92C9133A7A}"/>
               </a:ext>
             </a:extLst>
           </p:cNvPr>
@@ -3292,7 +3388,7 @@
           <p:cNvPr id="5" name="subtitle-10">
             <a:extLst xmlns:a="http://schemas.openxmlformats.org/drawingml/2006/main">
               <a:ext uri="{FF2B5EF4-FFF2-40B4-BE49-F238E27FC236}">
-                <a16:creationId xmlns:a16="http://schemas.microsoft.com/office/drawing/2014/main" id="{FE5C48D3-296B-4A30-8565-1F4E0D9B8D7F}"/>
+                <a16:creationId xmlns:a16="http://schemas.microsoft.com/office/drawing/2014/main" id="{86D0FA3E-8752-43EA-9089-664621A30911}"/>
               </a:ext>
             </a:extLst>
           </p:cNvPr>
@@ -3342,7 +3438,7 @@
           <p:cNvPr id="6" name="">
             <a:extLst xmlns:a="http://schemas.openxmlformats.org/drawingml/2006/main">
               <a:ext uri="{FF2B5EF4-FFF2-40B4-BE49-F238E27FC236}">
-                <a16:creationId xmlns:a16="http://schemas.microsoft.com/office/drawing/2014/main" id="{9DDB3C98-BE99-4F07-9A28-5E718B230B73}"/>
+                <a16:creationId xmlns:a16="http://schemas.microsoft.com/office/drawing/2014/main" id="{8E144FF5-EC4F-469A-A1F8-B59A74832220}"/>
               </a:ext>
             </a:extLst>
           </p:cNvPr>
@@ -3373,7 +3469,7 @@
           <p:cNvPr id="7" name="page-10">
             <a:extLst xmlns:a="http://schemas.openxmlformats.org/drawingml/2006/main">
               <a:ext uri="{FF2B5EF4-FFF2-40B4-BE49-F238E27FC236}">
-                <a16:creationId xmlns:a16="http://schemas.microsoft.com/office/drawing/2014/main" id="{3382FCC1-6161-47D8-AE7D-AB1A16DE6467}"/>
+                <a16:creationId xmlns:a16="http://schemas.microsoft.com/office/drawing/2014/main" id="{07CFF9FD-6A49-4835-9CB6-2768F48F8123}"/>
               </a:ext>
             </a:extLst>
           </p:cNvPr>
@@ -3423,7 +3519,7 @@
           <p:cNvPr id="8" name="s2-label-0">
             <a:extLst xmlns:a="http://schemas.openxmlformats.org/drawingml/2006/main">
               <a:ext uri="{FF2B5EF4-FFF2-40B4-BE49-F238E27FC236}">
-                <a16:creationId xmlns:a16="http://schemas.microsoft.com/office/drawing/2014/main" id="{27F97F4A-9C27-400A-851B-1F4D280962D3}"/>
+                <a16:creationId xmlns:a16="http://schemas.microsoft.com/office/drawing/2014/main" id="{F71E654E-BB4F-4613-9CA7-4737629E7F20}"/>
               </a:ext>
             </a:extLst>
           </p:cNvPr>
@@ -3473,7 +3569,7 @@
           <p:cNvPr id="9" name="s2-track-a-0">
             <a:extLst xmlns:a="http://schemas.openxmlformats.org/drawingml/2006/main">
               <a:ext uri="{FF2B5EF4-FFF2-40B4-BE49-F238E27FC236}">
-                <a16:creationId xmlns:a16="http://schemas.microsoft.com/office/drawing/2014/main" id="{993813F2-88FA-4758-977D-F8AF2645C861}"/>
+                <a16:creationId xmlns:a16="http://schemas.microsoft.com/office/drawing/2014/main" id="{5D82D279-ECD4-449A-8161-7A42FDE41C19}"/>
               </a:ext>
             </a:extLst>
           </p:cNvPr>
@@ -3508,7 +3604,7 @@
           <p:cNvPr id="10" name="s2-a-0">
             <a:extLst xmlns:a="http://schemas.openxmlformats.org/drawingml/2006/main">
               <a:ext uri="{FF2B5EF4-FFF2-40B4-BE49-F238E27FC236}">
-                <a16:creationId xmlns:a16="http://schemas.microsoft.com/office/drawing/2014/main" id="{A445E0B8-07C2-4A67-A52E-6798C93723F2}"/>
+                <a16:creationId xmlns:a16="http://schemas.microsoft.com/office/drawing/2014/main" id="{0FC142B1-E9BC-44E9-B081-A588CD712335}"/>
               </a:ext>
             </a:extLst>
           </p:cNvPr>
@@ -3543,7 +3639,7 @@
           <p:cNvPr id="11" name="s2-track-b-0">
             <a:extLst xmlns:a="http://schemas.openxmlformats.org/drawingml/2006/main">
               <a:ext uri="{FF2B5EF4-FFF2-40B4-BE49-F238E27FC236}">
-                <a16:creationId xmlns:a16="http://schemas.microsoft.com/office/drawing/2014/main" id="{A1E3AC26-17D8-4ECA-A060-FE6A157801D1}"/>
+                <a16:creationId xmlns:a16="http://schemas.microsoft.com/office/drawing/2014/main" id="{FF665D72-AA16-4797-B241-ACC0172D0627}"/>
               </a:ext>
             </a:extLst>
           </p:cNvPr>
@@ -3578,7 +3674,7 @@
           <p:cNvPr id="12" name="s2-b-0">
             <a:extLst xmlns:a="http://schemas.openxmlformats.org/drawingml/2006/main">
               <a:ext uri="{FF2B5EF4-FFF2-40B4-BE49-F238E27FC236}">
-                <a16:creationId xmlns:a16="http://schemas.microsoft.com/office/drawing/2014/main" id="{CB8A285D-DF2E-4926-9F58-3E56F42D314C}"/>
+                <a16:creationId xmlns:a16="http://schemas.microsoft.com/office/drawing/2014/main" id="{9937E3BF-0ACE-436B-AC54-1EDE0F86C8F0}"/>
               </a:ext>
             </a:extLst>
           </p:cNvPr>
@@ -3613,7 +3709,7 @@
           <p:cNvPr id="13" name="s2-value-0">
             <a:extLst xmlns:a="http://schemas.openxmlformats.org/drawingml/2006/main">
               <a:ext uri="{FF2B5EF4-FFF2-40B4-BE49-F238E27FC236}">
-                <a16:creationId xmlns:a16="http://schemas.microsoft.com/office/drawing/2014/main" id="{752B6362-245D-4FEE-BDF6-5233D6D920CC}"/>
+                <a16:creationId xmlns:a16="http://schemas.microsoft.com/office/drawing/2014/main" id="{DF9757F1-1773-43C3-A155-BDBDF6A5CE58}"/>
               </a:ext>
             </a:extLst>
           </p:cNvPr>
@@ -3663,7 +3759,7 @@
           <p:cNvPr id="14" name="s2-label-1">
             <a:extLst xmlns:a="http://schemas.openxmlformats.org/drawingml/2006/main">
               <a:ext uri="{FF2B5EF4-FFF2-40B4-BE49-F238E27FC236}">
-                <a16:creationId xmlns:a16="http://schemas.microsoft.com/office/drawing/2014/main" id="{E909590E-695F-4AD7-B910-271032FEA2F3}"/>
+                <a16:creationId xmlns:a16="http://schemas.microsoft.com/office/drawing/2014/main" id="{626455D0-9689-415A-AB77-1802B32900E7}"/>
               </a:ext>
             </a:extLst>
           </p:cNvPr>
@@ -3713,7 +3809,7 @@
           <p:cNvPr id="15" name="s2-track-a-1">
             <a:extLst xmlns:a="http://schemas.openxmlformats.org/drawingml/2006/main">
               <a:ext uri="{FF2B5EF4-FFF2-40B4-BE49-F238E27FC236}">
-                <a16:creationId xmlns:a16="http://schemas.microsoft.com/office/drawing/2014/main" id="{F65FA252-096D-403A-AE10-685BCF09DCC8}"/>
+                <a16:creationId xmlns:a16="http://schemas.microsoft.com/office/drawing/2014/main" id="{7C4AC0B3-D96A-43AB-A0F0-949C753FB734}"/>
               </a:ext>
             </a:extLst>
           </p:cNvPr>
@@ -3748,7 +3844,7 @@
           <p:cNvPr id="16" name="s2-a-1">
             <a:extLst xmlns:a="http://schemas.openxmlformats.org/drawingml/2006/main">
               <a:ext uri="{FF2B5EF4-FFF2-40B4-BE49-F238E27FC236}">
-                <a16:creationId xmlns:a16="http://schemas.microsoft.com/office/drawing/2014/main" id="{F108CF85-7720-4FF9-97E4-58086EA66F18}"/>
+                <a16:creationId xmlns:a16="http://schemas.microsoft.com/office/drawing/2014/main" id="{61A274E0-0F6E-445F-AE80-8220D832E30E}"/>
               </a:ext>
             </a:extLst>
           </p:cNvPr>
@@ -3783,7 +3879,7 @@
           <p:cNvPr id="17" name="s2-track-b-1">
             <a:extLst xmlns:a="http://schemas.openxmlformats.org/drawingml/2006/main">
               <a:ext uri="{FF2B5EF4-FFF2-40B4-BE49-F238E27FC236}">
-                <a16:creationId xmlns:a16="http://schemas.microsoft.com/office/drawing/2014/main" id="{58EB0967-F917-4B3F-8A03-420DACB4EAF9}"/>
+                <a16:creationId xmlns:a16="http://schemas.microsoft.com/office/drawing/2014/main" id="{1799C0C8-F217-46F2-A58E-24B89581C4BB}"/>
               </a:ext>
             </a:extLst>
           </p:cNvPr>
@@ -3818,7 +3914,7 @@
           <p:cNvPr id="18" name="s2-b-1">
             <a:extLst xmlns:a="http://schemas.openxmlformats.org/drawingml/2006/main">
               <a:ext uri="{FF2B5EF4-FFF2-40B4-BE49-F238E27FC236}">
-                <a16:creationId xmlns:a16="http://schemas.microsoft.com/office/drawing/2014/main" id="{0004FAE3-9EC5-495E-AF8E-B93CFBE163A9}"/>
+                <a16:creationId xmlns:a16="http://schemas.microsoft.com/office/drawing/2014/main" id="{B5D985BC-ACD2-4432-BDAF-B219E3CC49B8}"/>
               </a:ext>
             </a:extLst>
           </p:cNvPr>
@@ -3853,7 +3949,7 @@
           <p:cNvPr id="19" name="s2-value-1">
             <a:extLst xmlns:a="http://schemas.openxmlformats.org/drawingml/2006/main">
               <a:ext uri="{FF2B5EF4-FFF2-40B4-BE49-F238E27FC236}">
-                <a16:creationId xmlns:a16="http://schemas.microsoft.com/office/drawing/2014/main" id="{39221785-714F-47E5-84C4-81BA5738F6B3}"/>
+                <a16:creationId xmlns:a16="http://schemas.microsoft.com/office/drawing/2014/main" id="{1DC48206-A967-4360-9C76-82C234D4057E}"/>
               </a:ext>
             </a:extLst>
           </p:cNvPr>
@@ -3903,7 +3999,7 @@
           <p:cNvPr id="20" name="">
             <a:extLst xmlns:a="http://schemas.openxmlformats.org/drawingml/2006/main">
               <a:ext uri="{FF2B5EF4-FFF2-40B4-BE49-F238E27FC236}">
-                <a16:creationId xmlns:a16="http://schemas.microsoft.com/office/drawing/2014/main" id="{F04AC764-6C13-4263-85A8-08F97A7B1484}"/>
+                <a16:creationId xmlns:a16="http://schemas.microsoft.com/office/drawing/2014/main" id="{F931E67B-7A24-4271-B237-E7F2FB0BED9F}"/>
               </a:ext>
             </a:extLst>
           </p:cNvPr>
@@ -3934,7 +4030,7 @@
           <p:cNvPr id="21" name="s2-step-value">
             <a:extLst xmlns:a="http://schemas.openxmlformats.org/drawingml/2006/main">
               <a:ext uri="{FF2B5EF4-FFF2-40B4-BE49-F238E27FC236}">
-                <a16:creationId xmlns:a16="http://schemas.microsoft.com/office/drawing/2014/main" id="{4BCBF4C1-D8A3-4F26-AB79-1F8526751144}"/>
+                <a16:creationId xmlns:a16="http://schemas.microsoft.com/office/drawing/2014/main" id="{5473DF4D-80E8-4BA9-B57A-FAC31474233A}"/>
               </a:ext>
             </a:extLst>
           </p:cNvPr>
@@ -3984,7 +4080,7 @@
           <p:cNvPr id="22" name="s2-step-label">
             <a:extLst xmlns:a="http://schemas.openxmlformats.org/drawingml/2006/main">
               <a:ext uri="{FF2B5EF4-FFF2-40B4-BE49-F238E27FC236}">
-                <a16:creationId xmlns:a16="http://schemas.microsoft.com/office/drawing/2014/main" id="{D330B866-5580-4134-8416-D5640DF3EC91}"/>
+                <a16:creationId xmlns:a16="http://schemas.microsoft.com/office/drawing/2014/main" id="{5DFF219E-EA5D-4572-BC9F-4F1C443A3353}"/>
               </a:ext>
             </a:extLst>
           </p:cNvPr>
@@ -4034,7 +4130,7 @@
           <p:cNvPr id="23" name="">
             <a:extLst xmlns:a="http://schemas.openxmlformats.org/drawingml/2006/main">
               <a:ext uri="{FF2B5EF4-FFF2-40B4-BE49-F238E27FC236}">
-                <a16:creationId xmlns:a16="http://schemas.microsoft.com/office/drawing/2014/main" id="{CF10B457-B55A-42ED-A3AF-D5F9141E9A56}"/>
+                <a16:creationId xmlns:a16="http://schemas.microsoft.com/office/drawing/2014/main" id="{AE2C46FB-CFF2-40E9-A76C-BD2A009BB815}"/>
               </a:ext>
             </a:extLst>
           </p:cNvPr>
@@ -4065,7 +4161,7 @@
           <p:cNvPr id="24" name="s2-time-value">
             <a:extLst xmlns:a="http://schemas.openxmlformats.org/drawingml/2006/main">
               <a:ext uri="{FF2B5EF4-FFF2-40B4-BE49-F238E27FC236}">
-                <a16:creationId xmlns:a16="http://schemas.microsoft.com/office/drawing/2014/main" id="{8CA6AC79-AABD-4820-BA5C-F60ABF9473B2}"/>
+                <a16:creationId xmlns:a16="http://schemas.microsoft.com/office/drawing/2014/main" id="{0DD66ADE-DD21-44FF-803B-8A1530D3B216}"/>
               </a:ext>
             </a:extLst>
           </p:cNvPr>
@@ -4115,7 +4211,7 @@
           <p:cNvPr id="25" name="s2-time-label">
             <a:extLst xmlns:a="http://schemas.openxmlformats.org/drawingml/2006/main">
               <a:ext uri="{FF2B5EF4-FFF2-40B4-BE49-F238E27FC236}">
-                <a16:creationId xmlns:a16="http://schemas.microsoft.com/office/drawing/2014/main" id="{3829969A-7670-4F16-A944-EF9264162AB5}"/>
+                <a16:creationId xmlns:a16="http://schemas.microsoft.com/office/drawing/2014/main" id="{76D1BA7F-7AC9-428D-8618-E1EF525FAAF1}"/>
               </a:ext>
             </a:extLst>
           </p:cNvPr>
@@ -4165,7 +4261,7 @@
           <p:cNvPr id="26" name="">
             <a:extLst xmlns:a="http://schemas.openxmlformats.org/drawingml/2006/main">
               <a:ext uri="{FF2B5EF4-FFF2-40B4-BE49-F238E27FC236}">
-                <a16:creationId xmlns:a16="http://schemas.microsoft.com/office/drawing/2014/main" id="{5B7C3B69-77EE-436C-A5F3-44E234442F66}"/>
+                <a16:creationId xmlns:a16="http://schemas.microsoft.com/office/drawing/2014/main" id="{BA10364E-EAC0-4967-AD92-B0BEDAF0D8F5}"/>
               </a:ext>
             </a:extLst>
           </p:cNvPr>
@@ -4196,7 +4292,7 @@
           <p:cNvPr id="27" name="s2-replay-value">
             <a:extLst xmlns:a="http://schemas.openxmlformats.org/drawingml/2006/main">
               <a:ext uri="{FF2B5EF4-FFF2-40B4-BE49-F238E27FC236}">
-                <a16:creationId xmlns:a16="http://schemas.microsoft.com/office/drawing/2014/main" id="{F0A24FA8-2ED2-4409-9165-BE26371EEAD9}"/>
+                <a16:creationId xmlns:a16="http://schemas.microsoft.com/office/drawing/2014/main" id="{6652B8A5-A8D7-4B94-8A0C-662C965ABF10}"/>
               </a:ext>
             </a:extLst>
           </p:cNvPr>
@@ -4246,7 +4342,7 @@
           <p:cNvPr id="28" name="s2-replay-label">
             <a:extLst xmlns:a="http://schemas.openxmlformats.org/drawingml/2006/main">
               <a:ext uri="{FF2B5EF4-FFF2-40B4-BE49-F238E27FC236}">
-                <a16:creationId xmlns:a16="http://schemas.microsoft.com/office/drawing/2014/main" id="{2C7171E7-7A7D-4D12-9760-E879098C398F}"/>
+                <a16:creationId xmlns:a16="http://schemas.microsoft.com/office/drawing/2014/main" id="{73990377-94F7-4E20-8B49-D6FF62FC74F4}"/>
               </a:ext>
             </a:extLst>
           </p:cNvPr>
@@ -4296,7 +4392,7 @@
           <p:cNvPr id="29" name="">
             <a:extLst xmlns:a="http://schemas.openxmlformats.org/drawingml/2006/main">
               <a:ext uri="{FF2B5EF4-FFF2-40B4-BE49-F238E27FC236}">
-                <a16:creationId xmlns:a16="http://schemas.microsoft.com/office/drawing/2014/main" id="{0C8E534D-C4B5-44CF-AFED-E8F095795A1A}"/>
+                <a16:creationId xmlns:a16="http://schemas.microsoft.com/office/drawing/2014/main" id="{29EBBD58-D4E7-40A5-8793-B199054532A2}"/>
               </a:ext>
             </a:extLst>
           </p:cNvPr>
@@ -4327,7 +4423,7 @@
           <p:cNvPr id="30" name="s2-gpu-value">
             <a:extLst xmlns:a="http://schemas.openxmlformats.org/drawingml/2006/main">
               <a:ext uri="{FF2B5EF4-FFF2-40B4-BE49-F238E27FC236}">
-                <a16:creationId xmlns:a16="http://schemas.microsoft.com/office/drawing/2014/main" id="{F25D386A-90A1-45EF-A94A-F21B98F6F2FA}"/>
+                <a16:creationId xmlns:a16="http://schemas.microsoft.com/office/drawing/2014/main" id="{F16D3C83-5F09-4525-8336-696522C8EB26}"/>
               </a:ext>
             </a:extLst>
           </p:cNvPr>
@@ -4377,7 +4473,7 @@
           <p:cNvPr id="31" name="s2-gpu-label">
             <a:extLst xmlns:a="http://schemas.openxmlformats.org/drawingml/2006/main">
               <a:ext uri="{FF2B5EF4-FFF2-40B4-BE49-F238E27FC236}">
-                <a16:creationId xmlns:a16="http://schemas.microsoft.com/office/drawing/2014/main" id="{72297E4E-54FF-4090-A455-8FF148BDB864}"/>
+                <a16:creationId xmlns:a16="http://schemas.microsoft.com/office/drawing/2014/main" id="{42161E20-FBAA-4347-8457-EDA93E632BE7}"/>
               </a:ext>
             </a:extLst>
           </p:cNvPr>
@@ -4425,7 +4521,7 @@
     </p:spTree>
     <p:extLst>
       <p:ext uri="{BB962C8B-B14F-4D97-AF65-F5344CB8AC3E}">
-        <p14:creationId xmlns:p14="http://schemas.microsoft.com/office/powerpoint/2010/main" val="1685631909"/>
+        <p14:creationId xmlns:p14="http://schemas.microsoft.com/office/powerpoint/2010/main" val="652854009"/>
       </p:ext>
     </p:extLst>
   </p:cSld>
@@ -4456,7 +4552,7 @@
           <p:cNvPr id="39" name="rail-11">
             <a:extLst xmlns:a="http://schemas.openxmlformats.org/drawingml/2006/main">
               <a:ext uri="{FF2B5EF4-FFF2-40B4-BE49-F238E27FC236}">
-                <a16:creationId xmlns:a16="http://schemas.microsoft.com/office/drawing/2014/main" id="{32B0AC8C-912B-4118-AD4F-97C4BD4A4BB3}"/>
+                <a16:creationId xmlns:a16="http://schemas.microsoft.com/office/drawing/2014/main" id="{4C4492C2-975B-4E8F-963A-428399FB667C}"/>
               </a:ext>
             </a:extLst>
           </p:cNvPr>
@@ -4489,7 +4585,7 @@
           <p:cNvPr id="2" name="flourish-11">
             <a:extLst xmlns:a="http://schemas.openxmlformats.org/drawingml/2006/main">
               <a:ext uri="{FF2B5EF4-FFF2-40B4-BE49-F238E27FC236}">
-                <a16:creationId xmlns:a16="http://schemas.microsoft.com/office/drawing/2014/main" id="{8CFA3639-F633-4722-84E4-BF62D6215103}"/>
+                <a16:creationId xmlns:a16="http://schemas.microsoft.com/office/drawing/2014/main" id="{2F38F26A-1A14-40C5-B30B-B7F0EEE54688}"/>
               </a:ext>
             </a:extLst>
           </p:cNvPr>
@@ -4539,7 +4635,7 @@
           <p:cNvPr id="3" name="chapter-11">
             <a:extLst xmlns:a="http://schemas.openxmlformats.org/drawingml/2006/main">
               <a:ext uri="{FF2B5EF4-FFF2-40B4-BE49-F238E27FC236}">
-                <a16:creationId xmlns:a16="http://schemas.microsoft.com/office/drawing/2014/main" id="{7DC667C8-913F-4D4E-AE34-5EE51FBCAA13}"/>
+                <a16:creationId xmlns:a16="http://schemas.microsoft.com/office/drawing/2014/main" id="{FCA9D017-56A0-4F04-9231-F8FFC3084AAA}"/>
               </a:ext>
             </a:extLst>
           </p:cNvPr>
@@ -4589,7 +4685,7 @@
           <p:cNvPr id="4" name="title-11">
             <a:extLst xmlns:a="http://schemas.openxmlformats.org/drawingml/2006/main">
               <a:ext uri="{FF2B5EF4-FFF2-40B4-BE49-F238E27FC236}">
-                <a16:creationId xmlns:a16="http://schemas.microsoft.com/office/drawing/2014/main" id="{4A1E05BE-2994-4B61-851B-70C30E39ABB0}"/>
+                <a16:creationId xmlns:a16="http://schemas.microsoft.com/office/drawing/2014/main" id="{566D63B9-AC1D-4880-A6EC-BBDF3F388BD8}"/>
               </a:ext>
             </a:extLst>
           </p:cNvPr>
@@ -4639,7 +4735,7 @@
           <p:cNvPr id="5" name="subtitle-11">
             <a:extLst xmlns:a="http://schemas.openxmlformats.org/drawingml/2006/main">
               <a:ext uri="{FF2B5EF4-FFF2-40B4-BE49-F238E27FC236}">
-                <a16:creationId xmlns:a16="http://schemas.microsoft.com/office/drawing/2014/main" id="{9F3C816F-FFE0-4A0C-B16B-625BAC97B323}"/>
+                <a16:creationId xmlns:a16="http://schemas.microsoft.com/office/drawing/2014/main" id="{3D5B72F6-BAD9-4020-B86A-B94234ABFD8C}"/>
               </a:ext>
             </a:extLst>
           </p:cNvPr>
@@ -4689,7 +4785,7 @@
           <p:cNvPr id="6" name="">
             <a:extLst xmlns:a="http://schemas.openxmlformats.org/drawingml/2006/main">
               <a:ext uri="{FF2B5EF4-FFF2-40B4-BE49-F238E27FC236}">
-                <a16:creationId xmlns:a16="http://schemas.microsoft.com/office/drawing/2014/main" id="{E82C2C17-C6BC-46E0-AB22-BE3BA469C20C}"/>
+                <a16:creationId xmlns:a16="http://schemas.microsoft.com/office/drawing/2014/main" id="{F2E4D061-1B5C-4778-A50A-6E53723F20E2}"/>
               </a:ext>
             </a:extLst>
           </p:cNvPr>
@@ -4720,7 +4816,7 @@
           <p:cNvPr id="7" name="page-11">
             <a:extLst xmlns:a="http://schemas.openxmlformats.org/drawingml/2006/main">
               <a:ext uri="{FF2B5EF4-FFF2-40B4-BE49-F238E27FC236}">
-                <a16:creationId xmlns:a16="http://schemas.microsoft.com/office/drawing/2014/main" id="{5DB848A5-CCB5-499F-BDAC-C4CAE92BC0C5}"/>
+                <a16:creationId xmlns:a16="http://schemas.microsoft.com/office/drawing/2014/main" id="{21B5A8F7-7118-4DF9-95E6-66E250C01D58}"/>
               </a:ext>
             </a:extLst>
           </p:cNvPr>
@@ -4770,7 +4866,7 @@
           <p:cNvPr id="8" name="traj-spine">
             <a:extLst xmlns:a="http://schemas.openxmlformats.org/drawingml/2006/main">
               <a:ext uri="{FF2B5EF4-FFF2-40B4-BE49-F238E27FC236}">
-                <a16:creationId xmlns:a16="http://schemas.microsoft.com/office/drawing/2014/main" id="{84A7B5A0-5300-44AF-A7B2-D74B352D6765}"/>
+                <a16:creationId xmlns:a16="http://schemas.microsoft.com/office/drawing/2014/main" id="{2370BF78-D8E4-4199-BF82-727D5CDF2675}"/>
               </a:ext>
             </a:extLst>
           </p:cNvPr>
@@ -4803,7 +4899,7 @@
           <p:cNvPr id="9" name="traj-dot-0">
             <a:extLst xmlns:a="http://schemas.openxmlformats.org/drawingml/2006/main">
               <a:ext uri="{FF2B5EF4-FFF2-40B4-BE49-F238E27FC236}">
-                <a16:creationId xmlns:a16="http://schemas.microsoft.com/office/drawing/2014/main" id="{5A34CC62-50B9-43E6-ADAC-A178B88C6977}"/>
+                <a16:creationId xmlns:a16="http://schemas.microsoft.com/office/drawing/2014/main" id="{CA88B178-F169-470B-AB1B-44460B6721A7}"/>
               </a:ext>
             </a:extLst>
           </p:cNvPr>
@@ -4838,7 +4934,7 @@
           <p:cNvPr id="10" name="traj-num-0">
             <a:extLst xmlns:a="http://schemas.openxmlformats.org/drawingml/2006/main">
               <a:ext uri="{FF2B5EF4-FFF2-40B4-BE49-F238E27FC236}">
-                <a16:creationId xmlns:a16="http://schemas.microsoft.com/office/drawing/2014/main" id="{3766D1E0-4DC0-43D5-9DBE-C448F5AA6852}"/>
+                <a16:creationId xmlns:a16="http://schemas.microsoft.com/office/drawing/2014/main" id="{62A863E7-CCD5-4A87-9E15-30F1877C3D6B}"/>
               </a:ext>
             </a:extLst>
           </p:cNvPr>
@@ -4888,7 +4984,7 @@
           <p:cNvPr id="11" name="traj-tool-0">
             <a:extLst xmlns:a="http://schemas.openxmlformats.org/drawingml/2006/main">
               <a:ext uri="{FF2B5EF4-FFF2-40B4-BE49-F238E27FC236}">
-                <a16:creationId xmlns:a16="http://schemas.microsoft.com/office/drawing/2014/main" id="{CE0DB62A-A950-40ED-BA1F-6F0127B39D45}"/>
+                <a16:creationId xmlns:a16="http://schemas.microsoft.com/office/drawing/2014/main" id="{46B6F65F-E16F-4249-A73E-150689D18F19}"/>
               </a:ext>
             </a:extLst>
           </p:cNvPr>
@@ -4938,7 +5034,7 @@
           <p:cNvPr id="12" name="traj-obs-0">
             <a:extLst xmlns:a="http://schemas.openxmlformats.org/drawingml/2006/main">
               <a:ext uri="{FF2B5EF4-FFF2-40B4-BE49-F238E27FC236}">
-                <a16:creationId xmlns:a16="http://schemas.microsoft.com/office/drawing/2014/main" id="{10B2484D-31C8-4E48-8CE1-59C9F2AFD9EE}"/>
+                <a16:creationId xmlns:a16="http://schemas.microsoft.com/office/drawing/2014/main" id="{B3662C79-C11C-4BEB-967B-69D12D14EC9D}"/>
               </a:ext>
             </a:extLst>
           </p:cNvPr>
@@ -4988,7 +5084,7 @@
           <p:cNvPr id="13" name="traj-dot-1">
             <a:extLst xmlns:a="http://schemas.openxmlformats.org/drawingml/2006/main">
               <a:ext uri="{FF2B5EF4-FFF2-40B4-BE49-F238E27FC236}">
-                <a16:creationId xmlns:a16="http://schemas.microsoft.com/office/drawing/2014/main" id="{9DB37410-0B0E-4E05-BB01-A7F72E7ED348}"/>
+                <a16:creationId xmlns:a16="http://schemas.microsoft.com/office/drawing/2014/main" id="{ED50F07C-72D0-47FA-B503-D1928266BC8A}"/>
               </a:ext>
             </a:extLst>
           </p:cNvPr>
@@ -5023,7 +5119,7 @@
           <p:cNvPr id="14" name="traj-num-1">
             <a:extLst xmlns:a="http://schemas.openxmlformats.org/drawingml/2006/main">
               <a:ext uri="{FF2B5EF4-FFF2-40B4-BE49-F238E27FC236}">
-                <a16:creationId xmlns:a16="http://schemas.microsoft.com/office/drawing/2014/main" id="{F219DB2F-9E7A-438D-A62A-D00741C74942}"/>
+                <a16:creationId xmlns:a16="http://schemas.microsoft.com/office/drawing/2014/main" id="{FF0A6BFE-E71E-45C5-BAFF-149DFAAAE8FA}"/>
               </a:ext>
             </a:extLst>
           </p:cNvPr>
@@ -5073,7 +5169,7 @@
           <p:cNvPr id="15" name="traj-tool-1">
             <a:extLst xmlns:a="http://schemas.openxmlformats.org/drawingml/2006/main">
               <a:ext uri="{FF2B5EF4-FFF2-40B4-BE49-F238E27FC236}">
-                <a16:creationId xmlns:a16="http://schemas.microsoft.com/office/drawing/2014/main" id="{99E8D366-4F49-4EA1-BE72-B1EEDAE5C7B1}"/>
+                <a16:creationId xmlns:a16="http://schemas.microsoft.com/office/drawing/2014/main" id="{DDF42A3A-DC3F-4ACF-AD63-A0686CCB7384}"/>
               </a:ext>
             </a:extLst>
           </p:cNvPr>
@@ -5123,7 +5219,7 @@
           <p:cNvPr id="16" name="traj-obs-1">
             <a:extLst xmlns:a="http://schemas.openxmlformats.org/drawingml/2006/main">
               <a:ext uri="{FF2B5EF4-FFF2-40B4-BE49-F238E27FC236}">
-                <a16:creationId xmlns:a16="http://schemas.microsoft.com/office/drawing/2014/main" id="{6E664F24-6115-44BF-8D92-76D5E8134ACD}"/>
+                <a16:creationId xmlns:a16="http://schemas.microsoft.com/office/drawing/2014/main" id="{2580ED2B-4DDF-4D77-9683-95D1EB44882E}"/>
               </a:ext>
             </a:extLst>
           </p:cNvPr>
@@ -5173,7 +5269,7 @@
           <p:cNvPr id="17" name="traj-dot-2">
             <a:extLst xmlns:a="http://schemas.openxmlformats.org/drawingml/2006/main">
               <a:ext uri="{FF2B5EF4-FFF2-40B4-BE49-F238E27FC236}">
-                <a16:creationId xmlns:a16="http://schemas.microsoft.com/office/drawing/2014/main" id="{05ECEE6D-EB3B-4EB1-8977-C74790DA6DA1}"/>
+                <a16:creationId xmlns:a16="http://schemas.microsoft.com/office/drawing/2014/main" id="{6427E7A2-DC47-46F8-937B-64C485457DAC}"/>
               </a:ext>
             </a:extLst>
           </p:cNvPr>
@@ -5208,7 +5304,7 @@
           <p:cNvPr id="18" name="traj-num-2">
             <a:extLst xmlns:a="http://schemas.openxmlformats.org/drawingml/2006/main">
               <a:ext uri="{FF2B5EF4-FFF2-40B4-BE49-F238E27FC236}">
-                <a16:creationId xmlns:a16="http://schemas.microsoft.com/office/drawing/2014/main" id="{37D5AA5B-AF9F-4F60-96C2-CF2EC2E49925}"/>
+                <a16:creationId xmlns:a16="http://schemas.microsoft.com/office/drawing/2014/main" id="{1B0899EA-6CB0-44BF-83E7-E58625D461FE}"/>
               </a:ext>
             </a:extLst>
           </p:cNvPr>
@@ -5258,7 +5354,7 @@
           <p:cNvPr id="19" name="traj-tool-2">
             <a:extLst xmlns:a="http://schemas.openxmlformats.org/drawingml/2006/main">
               <a:ext uri="{FF2B5EF4-FFF2-40B4-BE49-F238E27FC236}">
-                <a16:creationId xmlns:a16="http://schemas.microsoft.com/office/drawing/2014/main" id="{9071057A-1B6A-407B-BD01-9346C23A7F4F}"/>
+                <a16:creationId xmlns:a16="http://schemas.microsoft.com/office/drawing/2014/main" id="{A92BD459-CA1E-4AD3-8FCE-A098AD3C5A72}"/>
               </a:ext>
             </a:extLst>
           </p:cNvPr>
@@ -5308,7 +5404,7 @@
           <p:cNvPr id="20" name="traj-obs-2">
             <a:extLst xmlns:a="http://schemas.openxmlformats.org/drawingml/2006/main">
               <a:ext uri="{FF2B5EF4-FFF2-40B4-BE49-F238E27FC236}">
-                <a16:creationId xmlns:a16="http://schemas.microsoft.com/office/drawing/2014/main" id="{DA6D047C-38A6-40FF-8561-06D3567AF759}"/>
+                <a16:creationId xmlns:a16="http://schemas.microsoft.com/office/drawing/2014/main" id="{2FC37D54-D746-4AB6-BD55-E8BA45920561}"/>
               </a:ext>
             </a:extLst>
           </p:cNvPr>
@@ -5358,7 +5454,7 @@
           <p:cNvPr id="21" name="traj-dot-3">
             <a:extLst xmlns:a="http://schemas.openxmlformats.org/drawingml/2006/main">
               <a:ext uri="{FF2B5EF4-FFF2-40B4-BE49-F238E27FC236}">
-                <a16:creationId xmlns:a16="http://schemas.microsoft.com/office/drawing/2014/main" id="{D8D13430-4E38-45A1-9A3B-595312B62878}"/>
+                <a16:creationId xmlns:a16="http://schemas.microsoft.com/office/drawing/2014/main" id="{00970C02-1D6E-44D6-B48A-7E5ED1678BC8}"/>
               </a:ext>
             </a:extLst>
           </p:cNvPr>
@@ -5393,7 +5489,7 @@
           <p:cNvPr id="22" name="traj-num-3">
             <a:extLst xmlns:a="http://schemas.openxmlformats.org/drawingml/2006/main">
               <a:ext uri="{FF2B5EF4-FFF2-40B4-BE49-F238E27FC236}">
-                <a16:creationId xmlns:a16="http://schemas.microsoft.com/office/drawing/2014/main" id="{E21C0ADA-7E5F-411F-BE47-C95ECCAF7755}"/>
+                <a16:creationId xmlns:a16="http://schemas.microsoft.com/office/drawing/2014/main" id="{4DED6649-1C02-479A-ADCA-67D8A21A63B3}"/>
               </a:ext>
             </a:extLst>
           </p:cNvPr>
@@ -5443,7 +5539,7 @@
           <p:cNvPr id="23" name="traj-tool-3">
             <a:extLst xmlns:a="http://schemas.openxmlformats.org/drawingml/2006/main">
               <a:ext uri="{FF2B5EF4-FFF2-40B4-BE49-F238E27FC236}">
-                <a16:creationId xmlns:a16="http://schemas.microsoft.com/office/drawing/2014/main" id="{BC8C51ED-CA5B-4F05-894C-043FDC305A39}"/>
+                <a16:creationId xmlns:a16="http://schemas.microsoft.com/office/drawing/2014/main" id="{8F50EF22-5016-4259-94AE-014846981F3E}"/>
               </a:ext>
             </a:extLst>
           </p:cNvPr>
@@ -5493,7 +5589,7 @@
           <p:cNvPr id="24" name="traj-obs-3">
             <a:extLst xmlns:a="http://schemas.openxmlformats.org/drawingml/2006/main">
               <a:ext uri="{FF2B5EF4-FFF2-40B4-BE49-F238E27FC236}">
-                <a16:creationId xmlns:a16="http://schemas.microsoft.com/office/drawing/2014/main" id="{87A49A9E-F813-4F0B-80EA-A7F064499110}"/>
+                <a16:creationId xmlns:a16="http://schemas.microsoft.com/office/drawing/2014/main" id="{760B82CC-CBE2-44B7-BF9E-16CC4C842ABD}"/>
               </a:ext>
             </a:extLst>
           </p:cNvPr>
@@ -5543,7 +5639,7 @@
           <p:cNvPr id="25" name="traj-dot-4">
             <a:extLst xmlns:a="http://schemas.openxmlformats.org/drawingml/2006/main">
               <a:ext uri="{FF2B5EF4-FFF2-40B4-BE49-F238E27FC236}">
-                <a16:creationId xmlns:a16="http://schemas.microsoft.com/office/drawing/2014/main" id="{CF169F2B-CD94-4A86-A450-AA1A5B01A29D}"/>
+                <a16:creationId xmlns:a16="http://schemas.microsoft.com/office/drawing/2014/main" id="{64184EAA-CD88-4D0B-A3C9-2EF15FD186FF}"/>
               </a:ext>
             </a:extLst>
           </p:cNvPr>
@@ -5578,7 +5674,7 @@
           <p:cNvPr id="26" name="traj-num-4">
             <a:extLst xmlns:a="http://schemas.openxmlformats.org/drawingml/2006/main">
               <a:ext uri="{FF2B5EF4-FFF2-40B4-BE49-F238E27FC236}">
-                <a16:creationId xmlns:a16="http://schemas.microsoft.com/office/drawing/2014/main" id="{C4765C06-7F20-4F59-9E75-7DD82A89E0CE}"/>
+                <a16:creationId xmlns:a16="http://schemas.microsoft.com/office/drawing/2014/main" id="{E3B75EF7-1495-4F35-9E10-AB9DF3E1A37C}"/>
               </a:ext>
             </a:extLst>
           </p:cNvPr>
@@ -5628,7 +5724,7 @@
           <p:cNvPr id="27" name="traj-tool-4">
             <a:extLst xmlns:a="http://schemas.openxmlformats.org/drawingml/2006/main">
               <a:ext uri="{FF2B5EF4-FFF2-40B4-BE49-F238E27FC236}">
-                <a16:creationId xmlns:a16="http://schemas.microsoft.com/office/drawing/2014/main" id="{B9E50E5D-790F-4F28-AED0-E58523FE2D14}"/>
+                <a16:creationId xmlns:a16="http://schemas.microsoft.com/office/drawing/2014/main" id="{C3A4CC64-D0EA-4660-93E5-D4851945CF94}"/>
               </a:ext>
             </a:extLst>
           </p:cNvPr>
@@ -5678,7 +5774,7 @@
           <p:cNvPr id="28" name="traj-obs-4">
             <a:extLst xmlns:a="http://schemas.openxmlformats.org/drawingml/2006/main">
               <a:ext uri="{FF2B5EF4-FFF2-40B4-BE49-F238E27FC236}">
-                <a16:creationId xmlns:a16="http://schemas.microsoft.com/office/drawing/2014/main" id="{7A72579A-346E-429D-A0DE-3D99F44ED415}"/>
+                <a16:creationId xmlns:a16="http://schemas.microsoft.com/office/drawing/2014/main" id="{45D43A47-F780-4208-8179-D4B8096B8B36}"/>
               </a:ext>
             </a:extLst>
           </p:cNvPr>
@@ -5728,7 +5824,7 @@
           <p:cNvPr id="29" name="traj-dot-5">
             <a:extLst xmlns:a="http://schemas.openxmlformats.org/drawingml/2006/main">
               <a:ext uri="{FF2B5EF4-FFF2-40B4-BE49-F238E27FC236}">
-                <a16:creationId xmlns:a16="http://schemas.microsoft.com/office/drawing/2014/main" id="{EEA328EE-3BB4-426D-84B9-F18D7FDCF075}"/>
+                <a16:creationId xmlns:a16="http://schemas.microsoft.com/office/drawing/2014/main" id="{CB559767-FD2C-4A6B-B0C2-0380654DAD55}"/>
               </a:ext>
             </a:extLst>
           </p:cNvPr>
@@ -5763,7 +5859,7 @@
           <p:cNvPr id="30" name="traj-num-5">
             <a:extLst xmlns:a="http://schemas.openxmlformats.org/drawingml/2006/main">
               <a:ext uri="{FF2B5EF4-FFF2-40B4-BE49-F238E27FC236}">
-                <a16:creationId xmlns:a16="http://schemas.microsoft.com/office/drawing/2014/main" id="{84EAC05A-0C6B-4A6A-9507-B30D18EB818F}"/>
+                <a16:creationId xmlns:a16="http://schemas.microsoft.com/office/drawing/2014/main" id="{DC006D23-8068-4B61-9AE9-7CA89D73319D}"/>
               </a:ext>
             </a:extLst>
           </p:cNvPr>
@@ -5813,7 +5909,7 @@
           <p:cNvPr id="31" name="traj-tool-5">
             <a:extLst xmlns:a="http://schemas.openxmlformats.org/drawingml/2006/main">
               <a:ext uri="{FF2B5EF4-FFF2-40B4-BE49-F238E27FC236}">
-                <a16:creationId xmlns:a16="http://schemas.microsoft.com/office/drawing/2014/main" id="{BBEBA652-4376-4618-A8FC-2BEB39AE1EE4}"/>
+                <a16:creationId xmlns:a16="http://schemas.microsoft.com/office/drawing/2014/main" id="{9F18483B-F0FA-483B-A5CF-45F052A65822}"/>
               </a:ext>
             </a:extLst>
           </p:cNvPr>
@@ -5863,7 +5959,7 @@
           <p:cNvPr id="32" name="traj-obs-5">
             <a:extLst xmlns:a="http://schemas.openxmlformats.org/drawingml/2006/main">
               <a:ext uri="{FF2B5EF4-FFF2-40B4-BE49-F238E27FC236}">
-                <a16:creationId xmlns:a16="http://schemas.microsoft.com/office/drawing/2014/main" id="{DFC02D8F-5BAE-44A2-815E-583AF66889B5}"/>
+                <a16:creationId xmlns:a16="http://schemas.microsoft.com/office/drawing/2014/main" id="{A54DF042-5962-400D-901C-65CC92D1539F}"/>
               </a:ext>
             </a:extLst>
           </p:cNvPr>
@@ -5913,7 +6009,7 @@
           <p:cNvPr id="33" name="traj-dot-6">
             <a:extLst xmlns:a="http://schemas.openxmlformats.org/drawingml/2006/main">
               <a:ext uri="{FF2B5EF4-FFF2-40B4-BE49-F238E27FC236}">
-                <a16:creationId xmlns:a16="http://schemas.microsoft.com/office/drawing/2014/main" id="{E60DA736-1009-45CF-8DB6-FC8964FB5EA1}"/>
+                <a16:creationId xmlns:a16="http://schemas.microsoft.com/office/drawing/2014/main" id="{FF985EAF-9EC3-4990-9845-58CB1654506F}"/>
               </a:ext>
             </a:extLst>
           </p:cNvPr>
@@ -5948,7 +6044,7 @@
           <p:cNvPr id="34" name="traj-num-6">
             <a:extLst xmlns:a="http://schemas.openxmlformats.org/drawingml/2006/main">
               <a:ext uri="{FF2B5EF4-FFF2-40B4-BE49-F238E27FC236}">
-                <a16:creationId xmlns:a16="http://schemas.microsoft.com/office/drawing/2014/main" id="{7F162EE6-3DBE-4591-B6A5-2BBDBB8C10EB}"/>
+                <a16:creationId xmlns:a16="http://schemas.microsoft.com/office/drawing/2014/main" id="{79DD59DD-A2D1-44BF-BFBC-38DBD6745905}"/>
               </a:ext>
             </a:extLst>
           </p:cNvPr>
@@ -5998,7 +6094,7 @@
           <p:cNvPr id="35" name="traj-tool-6">
             <a:extLst xmlns:a="http://schemas.openxmlformats.org/drawingml/2006/main">
               <a:ext uri="{FF2B5EF4-FFF2-40B4-BE49-F238E27FC236}">
-                <a16:creationId xmlns:a16="http://schemas.microsoft.com/office/drawing/2014/main" id="{C8DC91DE-5528-4103-A410-7C694C2EF5DF}"/>
+                <a16:creationId xmlns:a16="http://schemas.microsoft.com/office/drawing/2014/main" id="{E7A8F17E-296B-41DA-A698-4EF3DD4D8D8E}"/>
               </a:ext>
             </a:extLst>
           </p:cNvPr>
@@ -6048,7 +6144,7 @@
           <p:cNvPr id="36" name="traj-obs-6">
             <a:extLst xmlns:a="http://schemas.openxmlformats.org/drawingml/2006/main">
               <a:ext uri="{FF2B5EF4-FFF2-40B4-BE49-F238E27FC236}">
-                <a16:creationId xmlns:a16="http://schemas.microsoft.com/office/drawing/2014/main" id="{3E1A000E-6095-4918-ADCB-F828E8FEF354}"/>
+                <a16:creationId xmlns:a16="http://schemas.microsoft.com/office/drawing/2014/main" id="{464DE9D5-0B9A-46EA-B0DF-A9CE3B5F7BB7}"/>
               </a:ext>
             </a:extLst>
           </p:cNvPr>
@@ -6098,7 +6194,7 @@
           <p:cNvPr id="37" name="traj-outcome-bg">
             <a:extLst xmlns:a="http://schemas.openxmlformats.org/drawingml/2006/main">
               <a:ext uri="{FF2B5EF4-FFF2-40B4-BE49-F238E27FC236}">
-                <a16:creationId xmlns:a16="http://schemas.microsoft.com/office/drawing/2014/main" id="{FEA44C8B-0039-4DAB-A98F-5FB971BCAC97}"/>
+                <a16:creationId xmlns:a16="http://schemas.microsoft.com/office/drawing/2014/main" id="{B42E0409-5A52-42AA-A0F3-7427A866A130}"/>
               </a:ext>
             </a:extLst>
           </p:cNvPr>
@@ -6133,7 +6229,7 @@
           <p:cNvPr id="38" name="traj-outcome-text">
             <a:extLst xmlns:a="http://schemas.openxmlformats.org/drawingml/2006/main">
               <a:ext uri="{FF2B5EF4-FFF2-40B4-BE49-F238E27FC236}">
-                <a16:creationId xmlns:a16="http://schemas.microsoft.com/office/drawing/2014/main" id="{157DC972-5915-4213-A82A-EEC93A6068EE}"/>
+                <a16:creationId xmlns:a16="http://schemas.microsoft.com/office/drawing/2014/main" id="{97DFC7AA-5327-413B-B7BC-C6FC5C29CF09}"/>
               </a:ext>
             </a:extLst>
           </p:cNvPr>
@@ -6181,7 +6277,7 @@
     </p:spTree>
     <p:extLst>
       <p:ext uri="{BB962C8B-B14F-4D97-AF65-F5344CB8AC3E}">
-        <p14:creationId xmlns:p14="http://schemas.microsoft.com/office/powerpoint/2010/main" val="1642034446"/>
+        <p14:creationId xmlns:p14="http://schemas.microsoft.com/office/powerpoint/2010/main" val="1893484392"/>
       </p:ext>
     </p:extLst>
   </p:cSld>
@@ -6212,7 +6308,7 @@
           <p:cNvPr id="14" name="rail-12">
             <a:extLst xmlns:a="http://schemas.openxmlformats.org/drawingml/2006/main">
               <a:ext uri="{FF2B5EF4-FFF2-40B4-BE49-F238E27FC236}">
-                <a16:creationId xmlns:a16="http://schemas.microsoft.com/office/drawing/2014/main" id="{40E1ECDB-976D-4FEF-9258-9EE91A434C9F}"/>
+                <a16:creationId xmlns:a16="http://schemas.microsoft.com/office/drawing/2014/main" id="{DDD572FA-BE18-4D05-93F4-C560BD739578}"/>
               </a:ext>
             </a:extLst>
           </p:cNvPr>
@@ -6245,7 +6341,7 @@
           <p:cNvPr id="2" name="flourish-12">
             <a:extLst xmlns:a="http://schemas.openxmlformats.org/drawingml/2006/main">
               <a:ext uri="{FF2B5EF4-FFF2-40B4-BE49-F238E27FC236}">
-                <a16:creationId xmlns:a16="http://schemas.microsoft.com/office/drawing/2014/main" id="{DF6B5F3C-27CB-47C9-9C13-1F2AC4B67CDD}"/>
+                <a16:creationId xmlns:a16="http://schemas.microsoft.com/office/drawing/2014/main" id="{D6E1A615-50BD-488C-AA56-25B01D597D53}"/>
               </a:ext>
             </a:extLst>
           </p:cNvPr>
@@ -6295,7 +6391,7 @@
           <p:cNvPr id="3" name="chapter-12">
             <a:extLst xmlns:a="http://schemas.openxmlformats.org/drawingml/2006/main">
               <a:ext uri="{FF2B5EF4-FFF2-40B4-BE49-F238E27FC236}">
-                <a16:creationId xmlns:a16="http://schemas.microsoft.com/office/drawing/2014/main" id="{3D5B3AFF-C34E-480A-9B74-DCC8B8F2F1E5}"/>
+                <a16:creationId xmlns:a16="http://schemas.microsoft.com/office/drawing/2014/main" id="{07BA4AFC-B19E-48A0-B192-7137DE7CBC42}"/>
               </a:ext>
             </a:extLst>
           </p:cNvPr>
@@ -6345,7 +6441,7 @@
           <p:cNvPr id="4" name="title-12">
             <a:extLst xmlns:a="http://schemas.openxmlformats.org/drawingml/2006/main">
               <a:ext uri="{FF2B5EF4-FFF2-40B4-BE49-F238E27FC236}">
-                <a16:creationId xmlns:a16="http://schemas.microsoft.com/office/drawing/2014/main" id="{E6200F65-847E-4735-98B1-83202E043548}"/>
+                <a16:creationId xmlns:a16="http://schemas.microsoft.com/office/drawing/2014/main" id="{6E375C03-380E-4F1A-8E5B-5984BE600DEB}"/>
               </a:ext>
             </a:extLst>
           </p:cNvPr>
@@ -6395,7 +6491,7 @@
           <p:cNvPr id="5" name="subtitle-12">
             <a:extLst xmlns:a="http://schemas.openxmlformats.org/drawingml/2006/main">
               <a:ext uri="{FF2B5EF4-FFF2-40B4-BE49-F238E27FC236}">
-                <a16:creationId xmlns:a16="http://schemas.microsoft.com/office/drawing/2014/main" id="{FBD871F1-3D67-49D7-9FEE-CA5FCA068FBF}"/>
+                <a16:creationId xmlns:a16="http://schemas.microsoft.com/office/drawing/2014/main" id="{B201DE40-35C5-49F9-B87F-D75C80B247BB}"/>
               </a:ext>
             </a:extLst>
           </p:cNvPr>
@@ -6445,7 +6541,7 @@
           <p:cNvPr id="6" name="">
             <a:extLst xmlns:a="http://schemas.openxmlformats.org/drawingml/2006/main">
               <a:ext uri="{FF2B5EF4-FFF2-40B4-BE49-F238E27FC236}">
-                <a16:creationId xmlns:a16="http://schemas.microsoft.com/office/drawing/2014/main" id="{541F781B-4C19-42F6-BF4F-63A16705A05B}"/>
+                <a16:creationId xmlns:a16="http://schemas.microsoft.com/office/drawing/2014/main" id="{F498A79D-04B9-4F06-A7C7-C6DC0551185A}"/>
               </a:ext>
             </a:extLst>
           </p:cNvPr>
@@ -6476,7 +6572,7 @@
           <p:cNvPr id="7" name="page-12">
             <a:extLst xmlns:a="http://schemas.openxmlformats.org/drawingml/2006/main">
               <a:ext uri="{FF2B5EF4-FFF2-40B4-BE49-F238E27FC236}">
-                <a16:creationId xmlns:a16="http://schemas.microsoft.com/office/drawing/2014/main" id="{DA36DC4C-F121-420B-A008-379F3DFB6A0B}"/>
+                <a16:creationId xmlns:a16="http://schemas.microsoft.com/office/drawing/2014/main" id="{D695FACD-A559-4BE0-867D-6B67F48BB845}"/>
               </a:ext>
             </a:extLst>
           </p:cNvPr>
@@ -6526,7 +6622,7 @@
           <p:cNvPr id="8" name="benchmark-status">
             <a:extLst xmlns:a="http://schemas.openxmlformats.org/drawingml/2006/main">
               <a:ext uri="{FF2B5EF4-FFF2-40B4-BE49-F238E27FC236}">
-                <a16:creationId xmlns:a16="http://schemas.microsoft.com/office/drawing/2014/main" id="{A1A32519-EF0C-4737-96D5-6EF37590612D}"/>
+                <a16:creationId xmlns:a16="http://schemas.microsoft.com/office/drawing/2014/main" id="{F367758A-4CA3-4AF0-A35D-9BDAF2C9AA24}"/>
               </a:ext>
             </a:extLst>
           </p:cNvPr>
@@ -6576,7 +6672,7 @@
           <p:cNvPr id="9" name="benchmark-label">
             <a:extLst xmlns:a="http://schemas.openxmlformats.org/drawingml/2006/main">
               <a:ext uri="{FF2B5EF4-FFF2-40B4-BE49-F238E27FC236}">
-                <a16:creationId xmlns:a16="http://schemas.microsoft.com/office/drawing/2014/main" id="{18C88A72-C982-4C98-8CB7-F116F725B4E4}"/>
+                <a16:creationId xmlns:a16="http://schemas.microsoft.com/office/drawing/2014/main" id="{DB49F4AC-D3E0-475F-9FBF-0948E6FE49A6}"/>
               </a:ext>
             </a:extLst>
           </p:cNvPr>
@@ -6626,7 +6722,7 @@
           <p:cNvPr id="10" name="">
             <a:extLst xmlns:a="http://schemas.openxmlformats.org/drawingml/2006/main">
               <a:ext uri="{FF2B5EF4-FFF2-40B4-BE49-F238E27FC236}">
-                <a16:creationId xmlns:a16="http://schemas.microsoft.com/office/drawing/2014/main" id="{5011D147-C3C7-4452-B1B2-225D3995A1AC}"/>
+                <a16:creationId xmlns:a16="http://schemas.microsoft.com/office/drawing/2014/main" id="{F288954A-930B-4756-9F26-5713A8BA75A5}"/>
               </a:ext>
             </a:extLst>
           </p:cNvPr>
@@ -6657,7 +6753,7 @@
           <p:cNvPr id="11" name="benchmark-ready">
             <a:extLst xmlns:a="http://schemas.openxmlformats.org/drawingml/2006/main">
               <a:ext uri="{FF2B5EF4-FFF2-40B4-BE49-F238E27FC236}">
-                <a16:creationId xmlns:a16="http://schemas.microsoft.com/office/drawing/2014/main" id="{81039E90-7802-4199-86D8-1185C510BEFF}"/>
+                <a16:creationId xmlns:a16="http://schemas.microsoft.com/office/drawing/2014/main" id="{D214A887-D680-439E-85FD-FD163D96CA2D}"/>
               </a:ext>
             </a:extLst>
           </p:cNvPr>
@@ -6707,7 +6803,7 @@
           <p:cNvPr id="12" name="benchmark-list">
             <a:extLst xmlns:a="http://schemas.openxmlformats.org/drawingml/2006/main">
               <a:ext uri="{FF2B5EF4-FFF2-40B4-BE49-F238E27FC236}">
-                <a16:creationId xmlns:a16="http://schemas.microsoft.com/office/drawing/2014/main" id="{EA422855-D1EB-48FE-9A41-D03927A18D79}"/>
+                <a16:creationId xmlns:a16="http://schemas.microsoft.com/office/drawing/2014/main" id="{4BDC74FA-7D56-42A9-872F-34CB9867BD39}"/>
               </a:ext>
             </a:extLst>
           </p:cNvPr>
@@ -6824,7 +6920,7 @@
           <p:cNvPr id="13" name="benchmark-boundary">
             <a:extLst xmlns:a="http://schemas.openxmlformats.org/drawingml/2006/main">
               <a:ext uri="{FF2B5EF4-FFF2-40B4-BE49-F238E27FC236}">
-                <a16:creationId xmlns:a16="http://schemas.microsoft.com/office/drawing/2014/main" id="{78FE92EE-B67E-484A-B5AA-00E3986891D8}"/>
+                <a16:creationId xmlns:a16="http://schemas.microsoft.com/office/drawing/2014/main" id="{5C95BACE-DFEC-49E5-BDDA-591521848B38}"/>
               </a:ext>
             </a:extLst>
           </p:cNvPr>
@@ -6872,7 +6968,7 @@
     </p:spTree>
     <p:extLst>
       <p:ext uri="{BB962C8B-B14F-4D97-AF65-F5344CB8AC3E}">
-        <p14:creationId xmlns:p14="http://schemas.microsoft.com/office/powerpoint/2010/main" val="221132816"/>
+        <p14:creationId xmlns:p14="http://schemas.microsoft.com/office/powerpoint/2010/main" val="152435134"/>
       </p:ext>
     </p:extLst>
   </p:cSld>
@@ -6903,7 +6999,7 @@
           <p:cNvPr id="42" name="rail-13">
             <a:extLst xmlns:a="http://schemas.openxmlformats.org/drawingml/2006/main">
               <a:ext uri="{FF2B5EF4-FFF2-40B4-BE49-F238E27FC236}">
-                <a16:creationId xmlns:a16="http://schemas.microsoft.com/office/drawing/2014/main" id="{74AD711B-9A8F-4D38-ABAC-6CB042B233CC}"/>
+                <a16:creationId xmlns:a16="http://schemas.microsoft.com/office/drawing/2014/main" id="{0D9DE5F4-5E63-4C66-A4DE-FF332603F81D}"/>
               </a:ext>
             </a:extLst>
           </p:cNvPr>
@@ -6936,7 +7032,7 @@
           <p:cNvPr id="2" name="flourish-13">
             <a:extLst xmlns:a="http://schemas.openxmlformats.org/drawingml/2006/main">
               <a:ext uri="{FF2B5EF4-FFF2-40B4-BE49-F238E27FC236}">
-                <a16:creationId xmlns:a16="http://schemas.microsoft.com/office/drawing/2014/main" id="{1AA58F17-4A8C-467A-B5D7-AF99D858972F}"/>
+                <a16:creationId xmlns:a16="http://schemas.microsoft.com/office/drawing/2014/main" id="{4C9D9011-0028-4C8D-AD5B-FA84AFB82375}"/>
               </a:ext>
             </a:extLst>
           </p:cNvPr>
@@ -6986,7 +7082,7 @@
           <p:cNvPr id="3" name="chapter-13">
             <a:extLst xmlns:a="http://schemas.openxmlformats.org/drawingml/2006/main">
               <a:ext uri="{FF2B5EF4-FFF2-40B4-BE49-F238E27FC236}">
-                <a16:creationId xmlns:a16="http://schemas.microsoft.com/office/drawing/2014/main" id="{B7AD629F-1748-48B7-BD39-290E4B566A34}"/>
+                <a16:creationId xmlns:a16="http://schemas.microsoft.com/office/drawing/2014/main" id="{584EA228-56B9-46FE-908B-766B7774AB33}"/>
               </a:ext>
             </a:extLst>
           </p:cNvPr>
@@ -7036,7 +7132,7 @@
           <p:cNvPr id="4" name="title-13">
             <a:extLst xmlns:a="http://schemas.openxmlformats.org/drawingml/2006/main">
               <a:ext uri="{FF2B5EF4-FFF2-40B4-BE49-F238E27FC236}">
-                <a16:creationId xmlns:a16="http://schemas.microsoft.com/office/drawing/2014/main" id="{991EAD79-9D77-45D1-8FFE-8D511C106521}"/>
+                <a16:creationId xmlns:a16="http://schemas.microsoft.com/office/drawing/2014/main" id="{5871BEE6-F00B-43F0-9180-6F960C46678B}"/>
               </a:ext>
             </a:extLst>
           </p:cNvPr>
@@ -7086,7 +7182,7 @@
           <p:cNvPr id="5" name="subtitle-13">
             <a:extLst xmlns:a="http://schemas.openxmlformats.org/drawingml/2006/main">
               <a:ext uri="{FF2B5EF4-FFF2-40B4-BE49-F238E27FC236}">
-                <a16:creationId xmlns:a16="http://schemas.microsoft.com/office/drawing/2014/main" id="{92964F60-FE9E-428F-8A5E-8BD6991EC280}"/>
+                <a16:creationId xmlns:a16="http://schemas.microsoft.com/office/drawing/2014/main" id="{EFCF8E04-A11A-4772-A868-7B61B3359D5C}"/>
               </a:ext>
             </a:extLst>
           </p:cNvPr>
@@ -7136,7 +7232,7 @@
           <p:cNvPr id="6" name="">
             <a:extLst xmlns:a="http://schemas.openxmlformats.org/drawingml/2006/main">
               <a:ext uri="{FF2B5EF4-FFF2-40B4-BE49-F238E27FC236}">
-                <a16:creationId xmlns:a16="http://schemas.microsoft.com/office/drawing/2014/main" id="{5C91297E-812D-4576-A33D-4CC60253FC5C}"/>
+                <a16:creationId xmlns:a16="http://schemas.microsoft.com/office/drawing/2014/main" id="{5389300C-03DB-4D8F-B4B9-331F5A266E8B}"/>
               </a:ext>
             </a:extLst>
           </p:cNvPr>
@@ -7167,7 +7263,7 @@
           <p:cNvPr id="7" name="page-13">
             <a:extLst xmlns:a="http://schemas.openxmlformats.org/drawingml/2006/main">
               <a:ext uri="{FF2B5EF4-FFF2-40B4-BE49-F238E27FC236}">
-                <a16:creationId xmlns:a16="http://schemas.microsoft.com/office/drawing/2014/main" id="{80A6C82D-2BD5-4131-ACB6-61A20CF6C415}"/>
+                <a16:creationId xmlns:a16="http://schemas.microsoft.com/office/drawing/2014/main" id="{7106A1D3-A93D-4374-9CAC-03E9BB35767A}"/>
               </a:ext>
             </a:extLst>
           </p:cNvPr>
@@ -7217,7 +7313,7 @@
           <p:cNvPr id="8" name="audit-bg-0">
             <a:extLst xmlns:a="http://schemas.openxmlformats.org/drawingml/2006/main">
               <a:ext uri="{FF2B5EF4-FFF2-40B4-BE49-F238E27FC236}">
-                <a16:creationId xmlns:a16="http://schemas.microsoft.com/office/drawing/2014/main" id="{3E5DDF54-453E-48D1-8DF1-0F4444D16513}"/>
+                <a16:creationId xmlns:a16="http://schemas.microsoft.com/office/drawing/2014/main" id="{4EC6590A-8A44-46D0-BFD7-3DB09124496C}"/>
               </a:ext>
             </a:extLst>
           </p:cNvPr>
@@ -7252,7 +7348,7 @@
           <p:cNvPr id="9" name="audit-pill-0-bg">
             <a:extLst xmlns:a="http://schemas.openxmlformats.org/drawingml/2006/main">
               <a:ext uri="{FF2B5EF4-FFF2-40B4-BE49-F238E27FC236}">
-                <a16:creationId xmlns:a16="http://schemas.microsoft.com/office/drawing/2014/main" id="{6123178F-DE69-4214-841A-132702BAEFD1}"/>
+                <a16:creationId xmlns:a16="http://schemas.microsoft.com/office/drawing/2014/main" id="{12418A66-600C-446F-A84B-A899EA7D314F}"/>
               </a:ext>
             </a:extLst>
           </p:cNvPr>
@@ -7287,7 +7383,7 @@
           <p:cNvPr id="10" name="audit-pill-0-text">
             <a:extLst xmlns:a="http://schemas.openxmlformats.org/drawingml/2006/main">
               <a:ext uri="{FF2B5EF4-FFF2-40B4-BE49-F238E27FC236}">
-                <a16:creationId xmlns:a16="http://schemas.microsoft.com/office/drawing/2014/main" id="{A84E7B14-048F-4D91-960C-2CEFD48AE22C}"/>
+                <a16:creationId xmlns:a16="http://schemas.microsoft.com/office/drawing/2014/main" id="{8D6C95F3-8812-4708-A3C4-057F04476BB0}"/>
               </a:ext>
             </a:extLst>
           </p:cNvPr>
@@ -7337,7 +7433,7 @@
           <p:cNvPr id="11" name="audit-name-0">
             <a:extLst xmlns:a="http://schemas.openxmlformats.org/drawingml/2006/main">
               <a:ext uri="{FF2B5EF4-FFF2-40B4-BE49-F238E27FC236}">
-                <a16:creationId xmlns:a16="http://schemas.microsoft.com/office/drawing/2014/main" id="{53739D3B-BA07-4265-99D4-6C1A7831594B}"/>
+                <a16:creationId xmlns:a16="http://schemas.microsoft.com/office/drawing/2014/main" id="{579B145D-F80C-4589-860D-E1CD06B4A1AF}"/>
               </a:ext>
             </a:extLst>
           </p:cNvPr>
@@ -7387,7 +7483,7 @@
           <p:cNvPr id="12" name="audit-bg-1">
             <a:extLst xmlns:a="http://schemas.openxmlformats.org/drawingml/2006/main">
               <a:ext uri="{FF2B5EF4-FFF2-40B4-BE49-F238E27FC236}">
-                <a16:creationId xmlns:a16="http://schemas.microsoft.com/office/drawing/2014/main" id="{EDC770E5-A736-430D-8A22-0D2DFBF74CE4}"/>
+                <a16:creationId xmlns:a16="http://schemas.microsoft.com/office/drawing/2014/main" id="{F777CD7A-F9E8-442A-9454-78A22FDE2697}"/>
               </a:ext>
             </a:extLst>
           </p:cNvPr>
@@ -7422,7 +7518,7 @@
           <p:cNvPr id="13" name="audit-pill-1-bg">
             <a:extLst xmlns:a="http://schemas.openxmlformats.org/drawingml/2006/main">
               <a:ext uri="{FF2B5EF4-FFF2-40B4-BE49-F238E27FC236}">
-                <a16:creationId xmlns:a16="http://schemas.microsoft.com/office/drawing/2014/main" id="{DBE79B82-E727-475C-B82C-DB8647F1DD5F}"/>
+                <a16:creationId xmlns:a16="http://schemas.microsoft.com/office/drawing/2014/main" id="{24828A97-F42F-453A-98B1-FB01D9770C5C}"/>
               </a:ext>
             </a:extLst>
           </p:cNvPr>
@@ -7457,7 +7553,7 @@
           <p:cNvPr id="14" name="audit-pill-1-text">
             <a:extLst xmlns:a="http://schemas.openxmlformats.org/drawingml/2006/main">
               <a:ext uri="{FF2B5EF4-FFF2-40B4-BE49-F238E27FC236}">
-                <a16:creationId xmlns:a16="http://schemas.microsoft.com/office/drawing/2014/main" id="{E15769A4-9EA7-403C-A245-4898DBE77DC4}"/>
+                <a16:creationId xmlns:a16="http://schemas.microsoft.com/office/drawing/2014/main" id="{EE714E34-97FC-4D50-AFAB-F307366EAFA9}"/>
               </a:ext>
             </a:extLst>
           </p:cNvPr>
@@ -7507,7 +7603,7 @@
           <p:cNvPr id="15" name="audit-name-1">
             <a:extLst xmlns:a="http://schemas.openxmlformats.org/drawingml/2006/main">
               <a:ext uri="{FF2B5EF4-FFF2-40B4-BE49-F238E27FC236}">
-                <a16:creationId xmlns:a16="http://schemas.microsoft.com/office/drawing/2014/main" id="{44A4706B-ED2A-4485-A861-3C3F4AAF577B}"/>
+                <a16:creationId xmlns:a16="http://schemas.microsoft.com/office/drawing/2014/main" id="{CF7B3216-7E23-4CA8-8CCA-3E30B6D57362}"/>
               </a:ext>
             </a:extLst>
           </p:cNvPr>
@@ -7557,7 +7653,7 @@
           <p:cNvPr id="16" name="audit-bg-2">
             <a:extLst xmlns:a="http://schemas.openxmlformats.org/drawingml/2006/main">
               <a:ext uri="{FF2B5EF4-FFF2-40B4-BE49-F238E27FC236}">
-                <a16:creationId xmlns:a16="http://schemas.microsoft.com/office/drawing/2014/main" id="{9C1010E3-E5E8-4AA2-A149-911287E9BB56}"/>
+                <a16:creationId xmlns:a16="http://schemas.microsoft.com/office/drawing/2014/main" id="{F0FAD1DE-36E3-465E-9267-357D40EB6E0A}"/>
               </a:ext>
             </a:extLst>
           </p:cNvPr>
@@ -7592,7 +7688,7 @@
           <p:cNvPr id="17" name="audit-pill-2-bg">
             <a:extLst xmlns:a="http://schemas.openxmlformats.org/drawingml/2006/main">
               <a:ext uri="{FF2B5EF4-FFF2-40B4-BE49-F238E27FC236}">
-                <a16:creationId xmlns:a16="http://schemas.microsoft.com/office/drawing/2014/main" id="{C9616E78-BBA1-4B4D-8BB7-C067EF1591DA}"/>
+                <a16:creationId xmlns:a16="http://schemas.microsoft.com/office/drawing/2014/main" id="{4A15B2F3-745A-4EA4-8C2D-40D23C2B02DB}"/>
               </a:ext>
             </a:extLst>
           </p:cNvPr>
@@ -7627,7 +7723,7 @@
           <p:cNvPr id="18" name="audit-pill-2-text">
             <a:extLst xmlns:a="http://schemas.openxmlformats.org/drawingml/2006/main">
               <a:ext uri="{FF2B5EF4-FFF2-40B4-BE49-F238E27FC236}">
-                <a16:creationId xmlns:a16="http://schemas.microsoft.com/office/drawing/2014/main" id="{52047A99-3A52-485B-96F7-C6E06BDA0ADA}"/>
+                <a16:creationId xmlns:a16="http://schemas.microsoft.com/office/drawing/2014/main" id="{62E18F8C-9F6D-42DF-83BD-42192C538831}"/>
               </a:ext>
             </a:extLst>
           </p:cNvPr>
@@ -7677,7 +7773,7 @@
           <p:cNvPr id="19" name="audit-name-2">
             <a:extLst xmlns:a="http://schemas.openxmlformats.org/drawingml/2006/main">
               <a:ext uri="{FF2B5EF4-FFF2-40B4-BE49-F238E27FC236}">
-                <a16:creationId xmlns:a16="http://schemas.microsoft.com/office/drawing/2014/main" id="{32DCFD43-8D74-4383-91C5-220FB3EA0AD4}"/>
+                <a16:creationId xmlns:a16="http://schemas.microsoft.com/office/drawing/2014/main" id="{EAC05EDF-6C56-4530-B014-A370A24E2A3B}"/>
               </a:ext>
             </a:extLst>
           </p:cNvPr>
@@ -7727,7 +7823,7 @@
           <p:cNvPr id="20" name="audit-bg-3">
             <a:extLst xmlns:a="http://schemas.openxmlformats.org/drawingml/2006/main">
               <a:ext uri="{FF2B5EF4-FFF2-40B4-BE49-F238E27FC236}">
-                <a16:creationId xmlns:a16="http://schemas.microsoft.com/office/drawing/2014/main" id="{8145A910-EB50-4897-8345-E4DCD9C7CA77}"/>
+                <a16:creationId xmlns:a16="http://schemas.microsoft.com/office/drawing/2014/main" id="{B802658B-CCBE-41DF-8263-A5B336FF7286}"/>
               </a:ext>
             </a:extLst>
           </p:cNvPr>
@@ -7762,7 +7858,7 @@
           <p:cNvPr id="21" name="audit-pill-3-bg">
             <a:extLst xmlns:a="http://schemas.openxmlformats.org/drawingml/2006/main">
               <a:ext uri="{FF2B5EF4-FFF2-40B4-BE49-F238E27FC236}">
-                <a16:creationId xmlns:a16="http://schemas.microsoft.com/office/drawing/2014/main" id="{C4A34ACC-DEFD-422A-BCE6-1DB1B8AC2870}"/>
+                <a16:creationId xmlns:a16="http://schemas.microsoft.com/office/drawing/2014/main" id="{5C64083B-D89C-44B6-B64B-7BEE2DF67129}"/>
               </a:ext>
             </a:extLst>
           </p:cNvPr>
@@ -7797,7 +7893,7 @@
           <p:cNvPr id="22" name="audit-pill-3-text">
             <a:extLst xmlns:a="http://schemas.openxmlformats.org/drawingml/2006/main">
               <a:ext uri="{FF2B5EF4-FFF2-40B4-BE49-F238E27FC236}">
-                <a16:creationId xmlns:a16="http://schemas.microsoft.com/office/drawing/2014/main" id="{16D4A90C-F801-4B79-A06E-FD01FE80235D}"/>
+                <a16:creationId xmlns:a16="http://schemas.microsoft.com/office/drawing/2014/main" id="{5B4FC5F8-8CD0-4405-BCED-B68912EB7087}"/>
               </a:ext>
             </a:extLst>
           </p:cNvPr>
@@ -7847,7 +7943,7 @@
           <p:cNvPr id="23" name="audit-name-3">
             <a:extLst xmlns:a="http://schemas.openxmlformats.org/drawingml/2006/main">
               <a:ext uri="{FF2B5EF4-FFF2-40B4-BE49-F238E27FC236}">
-                <a16:creationId xmlns:a16="http://schemas.microsoft.com/office/drawing/2014/main" id="{6439BE29-8B70-4ABA-8E78-960C72528D92}"/>
+                <a16:creationId xmlns:a16="http://schemas.microsoft.com/office/drawing/2014/main" id="{45DC1173-565A-41CB-B38B-C173AF1FCF56}"/>
               </a:ext>
             </a:extLst>
           </p:cNvPr>
@@ -7897,7 +7993,7 @@
           <p:cNvPr id="24" name="audit-bg-4">
             <a:extLst xmlns:a="http://schemas.openxmlformats.org/drawingml/2006/main">
               <a:ext uri="{FF2B5EF4-FFF2-40B4-BE49-F238E27FC236}">
-                <a16:creationId xmlns:a16="http://schemas.microsoft.com/office/drawing/2014/main" id="{DF1C5E54-820C-466F-B360-231B8913451D}"/>
+                <a16:creationId xmlns:a16="http://schemas.microsoft.com/office/drawing/2014/main" id="{6F77BBF1-AD06-473F-91C0-53E144A94569}"/>
               </a:ext>
             </a:extLst>
           </p:cNvPr>
@@ -7932,7 +8028,7 @@
           <p:cNvPr id="25" name="audit-pill-4-bg">
             <a:extLst xmlns:a="http://schemas.openxmlformats.org/drawingml/2006/main">
               <a:ext uri="{FF2B5EF4-FFF2-40B4-BE49-F238E27FC236}">
-                <a16:creationId xmlns:a16="http://schemas.microsoft.com/office/drawing/2014/main" id="{8C6B8735-20D1-44E6-A72E-33FD09C61557}"/>
+                <a16:creationId xmlns:a16="http://schemas.microsoft.com/office/drawing/2014/main" id="{AD1C736F-8E60-40CD-BA9C-DE289DACC4C9}"/>
               </a:ext>
             </a:extLst>
           </p:cNvPr>
@@ -7967,7 +8063,7 @@
           <p:cNvPr id="26" name="audit-pill-4-text">
             <a:extLst xmlns:a="http://schemas.openxmlformats.org/drawingml/2006/main">
               <a:ext uri="{FF2B5EF4-FFF2-40B4-BE49-F238E27FC236}">
-                <a16:creationId xmlns:a16="http://schemas.microsoft.com/office/drawing/2014/main" id="{2D07BA68-BA53-4357-AF29-A4CEAD023A7F}"/>
+                <a16:creationId xmlns:a16="http://schemas.microsoft.com/office/drawing/2014/main" id="{ED43FFF8-99C9-4F3F-B20E-AA9187D405EB}"/>
               </a:ext>
             </a:extLst>
           </p:cNvPr>
@@ -8017,7 +8113,7 @@
           <p:cNvPr id="27" name="audit-name-4">
             <a:extLst xmlns:a="http://schemas.openxmlformats.org/drawingml/2006/main">
               <a:ext uri="{FF2B5EF4-FFF2-40B4-BE49-F238E27FC236}">
-                <a16:creationId xmlns:a16="http://schemas.microsoft.com/office/drawing/2014/main" id="{C43B7CF1-6783-420F-A57B-823EB29252C1}"/>
+                <a16:creationId xmlns:a16="http://schemas.microsoft.com/office/drawing/2014/main" id="{FADCCF9D-232B-4EBD-A382-A9913F777987}"/>
               </a:ext>
             </a:extLst>
           </p:cNvPr>
@@ -8067,7 +8163,7 @@
           <p:cNvPr id="28" name="audit-bg-5">
             <a:extLst xmlns:a="http://schemas.openxmlformats.org/drawingml/2006/main">
               <a:ext uri="{FF2B5EF4-FFF2-40B4-BE49-F238E27FC236}">
-                <a16:creationId xmlns:a16="http://schemas.microsoft.com/office/drawing/2014/main" id="{5C3D28DC-D281-4F95-9014-BAF392202F1F}"/>
+                <a16:creationId xmlns:a16="http://schemas.microsoft.com/office/drawing/2014/main" id="{232BDD5E-74BF-4532-8A00-C59047589D83}"/>
               </a:ext>
             </a:extLst>
           </p:cNvPr>
@@ -8102,7 +8198,7 @@
           <p:cNvPr id="29" name="audit-pill-5-bg">
             <a:extLst xmlns:a="http://schemas.openxmlformats.org/drawingml/2006/main">
               <a:ext uri="{FF2B5EF4-FFF2-40B4-BE49-F238E27FC236}">
-                <a16:creationId xmlns:a16="http://schemas.microsoft.com/office/drawing/2014/main" id="{C69DC357-3D0B-4F97-BE5D-2E2F558F7623}"/>
+                <a16:creationId xmlns:a16="http://schemas.microsoft.com/office/drawing/2014/main" id="{90927129-03E4-495C-BDA1-14136F46C263}"/>
               </a:ext>
             </a:extLst>
           </p:cNvPr>
@@ -8137,7 +8233,7 @@
           <p:cNvPr id="30" name="audit-pill-5-text">
             <a:extLst xmlns:a="http://schemas.openxmlformats.org/drawingml/2006/main">
               <a:ext uri="{FF2B5EF4-FFF2-40B4-BE49-F238E27FC236}">
-                <a16:creationId xmlns:a16="http://schemas.microsoft.com/office/drawing/2014/main" id="{A0E723DD-6A1F-4B39-97B6-4AB752B4176A}"/>
+                <a16:creationId xmlns:a16="http://schemas.microsoft.com/office/drawing/2014/main" id="{A3374A7B-96E0-4158-B3C6-08C8EF5B88D7}"/>
               </a:ext>
             </a:extLst>
           </p:cNvPr>
@@ -8187,7 +8283,7 @@
           <p:cNvPr id="31" name="audit-name-5">
             <a:extLst xmlns:a="http://schemas.openxmlformats.org/drawingml/2006/main">
               <a:ext uri="{FF2B5EF4-FFF2-40B4-BE49-F238E27FC236}">
-                <a16:creationId xmlns:a16="http://schemas.microsoft.com/office/drawing/2014/main" id="{5F68A948-0BF1-4D15-9EE9-E045E4A0C402}"/>
+                <a16:creationId xmlns:a16="http://schemas.microsoft.com/office/drawing/2014/main" id="{865CE0CF-2F5E-43AE-BB30-5BBC85A0D441}"/>
               </a:ext>
             </a:extLst>
           </p:cNvPr>
@@ -8237,7 +8333,7 @@
           <p:cNvPr id="32" name="audit-bg-6">
             <a:extLst xmlns:a="http://schemas.openxmlformats.org/drawingml/2006/main">
               <a:ext uri="{FF2B5EF4-FFF2-40B4-BE49-F238E27FC236}">
-                <a16:creationId xmlns:a16="http://schemas.microsoft.com/office/drawing/2014/main" id="{516459A4-7D11-46B2-A7C8-ABB6476E27BD}"/>
+                <a16:creationId xmlns:a16="http://schemas.microsoft.com/office/drawing/2014/main" id="{BCAA550C-B281-4ECD-A287-2519D044CFAF}"/>
               </a:ext>
             </a:extLst>
           </p:cNvPr>
@@ -8272,7 +8368,7 @@
           <p:cNvPr id="33" name="audit-pill-6-bg">
             <a:extLst xmlns:a="http://schemas.openxmlformats.org/drawingml/2006/main">
               <a:ext uri="{FF2B5EF4-FFF2-40B4-BE49-F238E27FC236}">
-                <a16:creationId xmlns:a16="http://schemas.microsoft.com/office/drawing/2014/main" id="{AEF252A2-DD7A-4857-BE76-70725A647E18}"/>
+                <a16:creationId xmlns:a16="http://schemas.microsoft.com/office/drawing/2014/main" id="{503D3275-8E04-4FA4-B154-ED3215F849AC}"/>
               </a:ext>
             </a:extLst>
           </p:cNvPr>
@@ -8307,7 +8403,7 @@
           <p:cNvPr id="34" name="audit-pill-6-text">
             <a:extLst xmlns:a="http://schemas.openxmlformats.org/drawingml/2006/main">
               <a:ext uri="{FF2B5EF4-FFF2-40B4-BE49-F238E27FC236}">
-                <a16:creationId xmlns:a16="http://schemas.microsoft.com/office/drawing/2014/main" id="{6A675681-8FDD-4BC5-82FB-E36ECFA5AE7E}"/>
+                <a16:creationId xmlns:a16="http://schemas.microsoft.com/office/drawing/2014/main" id="{F9C70E7C-9E3B-40F4-98BE-C2D703C017D8}"/>
               </a:ext>
             </a:extLst>
           </p:cNvPr>
@@ -8357,7 +8453,7 @@
           <p:cNvPr id="35" name="audit-name-6">
             <a:extLst xmlns:a="http://schemas.openxmlformats.org/drawingml/2006/main">
               <a:ext uri="{FF2B5EF4-FFF2-40B4-BE49-F238E27FC236}">
-                <a16:creationId xmlns:a16="http://schemas.microsoft.com/office/drawing/2014/main" id="{E5293469-DAC2-45AE-A361-130CAD44148B}"/>
+                <a16:creationId xmlns:a16="http://schemas.microsoft.com/office/drawing/2014/main" id="{781F0F7A-F68F-447B-B2E1-D2AD6F25EFC3}"/>
               </a:ext>
             </a:extLst>
           </p:cNvPr>
@@ -8407,7 +8503,7 @@
           <p:cNvPr id="36" name="audit-bg-7">
             <a:extLst xmlns:a="http://schemas.openxmlformats.org/drawingml/2006/main">
               <a:ext uri="{FF2B5EF4-FFF2-40B4-BE49-F238E27FC236}">
-                <a16:creationId xmlns:a16="http://schemas.microsoft.com/office/drawing/2014/main" id="{55CAA6A4-4068-41A8-9225-9FE73EE06130}"/>
+                <a16:creationId xmlns:a16="http://schemas.microsoft.com/office/drawing/2014/main" id="{0E4E70A1-F5D7-46B5-A42B-0B58D4DCB2F3}"/>
               </a:ext>
             </a:extLst>
           </p:cNvPr>
@@ -8442,7 +8538,7 @@
           <p:cNvPr id="37" name="audit-pill-7-bg">
             <a:extLst xmlns:a="http://schemas.openxmlformats.org/drawingml/2006/main">
               <a:ext uri="{FF2B5EF4-FFF2-40B4-BE49-F238E27FC236}">
-                <a16:creationId xmlns:a16="http://schemas.microsoft.com/office/drawing/2014/main" id="{A8240034-F59A-4F38-B9CC-0B2A281A3926}"/>
+                <a16:creationId xmlns:a16="http://schemas.microsoft.com/office/drawing/2014/main" id="{EE51A294-3279-4D49-9DCA-67EE35BBE629}"/>
               </a:ext>
             </a:extLst>
           </p:cNvPr>
@@ -8477,7 +8573,7 @@
           <p:cNvPr id="38" name="audit-pill-7-text">
             <a:extLst xmlns:a="http://schemas.openxmlformats.org/drawingml/2006/main">
               <a:ext uri="{FF2B5EF4-FFF2-40B4-BE49-F238E27FC236}">
-                <a16:creationId xmlns:a16="http://schemas.microsoft.com/office/drawing/2014/main" id="{78F498ED-A89D-4874-B5AE-B60CF5373D8F}"/>
+                <a16:creationId xmlns:a16="http://schemas.microsoft.com/office/drawing/2014/main" id="{F93E7FE2-F67B-4C4A-AE68-2CC765374873}"/>
               </a:ext>
             </a:extLst>
           </p:cNvPr>
@@ -8527,7 +8623,7 @@
           <p:cNvPr id="39" name="audit-name-7">
             <a:extLst xmlns:a="http://schemas.openxmlformats.org/drawingml/2006/main">
               <a:ext uri="{FF2B5EF4-FFF2-40B4-BE49-F238E27FC236}">
-                <a16:creationId xmlns:a16="http://schemas.microsoft.com/office/drawing/2014/main" id="{E0947D54-2B91-469F-9B66-CDF91EF69EAA}"/>
+                <a16:creationId xmlns:a16="http://schemas.microsoft.com/office/drawing/2014/main" id="{A208E6B5-9538-4916-BB1B-6E4DB477B57F}"/>
               </a:ext>
             </a:extLst>
           </p:cNvPr>
@@ -8577,7 +8673,7 @@
           <p:cNvPr id="40" name="audit-hash">
             <a:extLst xmlns:a="http://schemas.openxmlformats.org/drawingml/2006/main">
               <a:ext uri="{FF2B5EF4-FFF2-40B4-BE49-F238E27FC236}">
-                <a16:creationId xmlns:a16="http://schemas.microsoft.com/office/drawing/2014/main" id="{15E0D5F2-895D-4161-9737-3DABBC5F7FD6}"/>
+                <a16:creationId xmlns:a16="http://schemas.microsoft.com/office/drawing/2014/main" id="{A6A3CB89-31A3-4753-B183-7F921A6F3AB9}"/>
               </a:ext>
             </a:extLst>
           </p:cNvPr>
@@ -8612,7 +8708,7 @@
           <p:cNvPr id="41" name="audit-hash-text">
             <a:extLst xmlns:a="http://schemas.openxmlformats.org/drawingml/2006/main">
               <a:ext uri="{FF2B5EF4-FFF2-40B4-BE49-F238E27FC236}">
-                <a16:creationId xmlns:a16="http://schemas.microsoft.com/office/drawing/2014/main" id="{9306D957-E3AD-4E92-A710-40AA73582DA2}"/>
+                <a16:creationId xmlns:a16="http://schemas.microsoft.com/office/drawing/2014/main" id="{57A9DF8F-944C-4BFD-8B77-D5D9AB7D54FA}"/>
               </a:ext>
             </a:extLst>
           </p:cNvPr>
@@ -8660,7 +8756,7 @@
     </p:spTree>
     <p:extLst>
       <p:ext uri="{BB962C8B-B14F-4D97-AF65-F5344CB8AC3E}">
-        <p14:creationId xmlns:p14="http://schemas.microsoft.com/office/powerpoint/2010/main" val="708563341"/>
+        <p14:creationId xmlns:p14="http://schemas.microsoft.com/office/powerpoint/2010/main" val="1751903266"/>
       </p:ext>
     </p:extLst>
   </p:cSld>
@@ -8691,7 +8787,7 @@
           <p:cNvPr id="26" name="rail-14">
             <a:extLst xmlns:a="http://schemas.openxmlformats.org/drawingml/2006/main">
               <a:ext uri="{FF2B5EF4-FFF2-40B4-BE49-F238E27FC236}">
-                <a16:creationId xmlns:a16="http://schemas.microsoft.com/office/drawing/2014/main" id="{D66BC6ED-AE24-440C-B2B2-63B010B9C19C}"/>
+                <a16:creationId xmlns:a16="http://schemas.microsoft.com/office/drawing/2014/main" id="{25878F85-45AD-4474-97D3-0DE312F6DCE9}"/>
               </a:ext>
             </a:extLst>
           </p:cNvPr>
@@ -8724,7 +8820,7 @@
           <p:cNvPr id="2" name="flourish-14">
             <a:extLst xmlns:a="http://schemas.openxmlformats.org/drawingml/2006/main">
               <a:ext uri="{FF2B5EF4-FFF2-40B4-BE49-F238E27FC236}">
-                <a16:creationId xmlns:a16="http://schemas.microsoft.com/office/drawing/2014/main" id="{F1D9685E-90CF-4AE2-9459-57BC2820280B}"/>
+                <a16:creationId xmlns:a16="http://schemas.microsoft.com/office/drawing/2014/main" id="{465E7617-89A4-4020-8502-E27B5D915468}"/>
               </a:ext>
             </a:extLst>
           </p:cNvPr>
@@ -8774,7 +8870,7 @@
           <p:cNvPr id="3" name="chapter-14">
             <a:extLst xmlns:a="http://schemas.openxmlformats.org/drawingml/2006/main">
               <a:ext uri="{FF2B5EF4-FFF2-40B4-BE49-F238E27FC236}">
-                <a16:creationId xmlns:a16="http://schemas.microsoft.com/office/drawing/2014/main" id="{134D75AA-47DA-4A85-9280-117B38EE8E8F}"/>
+                <a16:creationId xmlns:a16="http://schemas.microsoft.com/office/drawing/2014/main" id="{46441381-2804-4C0F-8A95-EC888422AD6D}"/>
               </a:ext>
             </a:extLst>
           </p:cNvPr>
@@ -8824,7 +8920,7 @@
           <p:cNvPr id="4" name="title-14">
             <a:extLst xmlns:a="http://schemas.openxmlformats.org/drawingml/2006/main">
               <a:ext uri="{FF2B5EF4-FFF2-40B4-BE49-F238E27FC236}">
-                <a16:creationId xmlns:a16="http://schemas.microsoft.com/office/drawing/2014/main" id="{8AE5B2C7-9095-418B-BFC4-53CCA0C2768E}"/>
+                <a16:creationId xmlns:a16="http://schemas.microsoft.com/office/drawing/2014/main" id="{433FDDB3-CF41-4CE8-BF94-74AC4B725E54}"/>
               </a:ext>
             </a:extLst>
           </p:cNvPr>
@@ -8874,7 +8970,7 @@
           <p:cNvPr id="5" name="subtitle-14">
             <a:extLst xmlns:a="http://schemas.openxmlformats.org/drawingml/2006/main">
               <a:ext uri="{FF2B5EF4-FFF2-40B4-BE49-F238E27FC236}">
-                <a16:creationId xmlns:a16="http://schemas.microsoft.com/office/drawing/2014/main" id="{88EE1A60-0A87-4FA5-B4D7-5EE21B27A236}"/>
+                <a16:creationId xmlns:a16="http://schemas.microsoft.com/office/drawing/2014/main" id="{B3C98081-3E07-4EEC-A8D0-FBFF10C85D02}"/>
               </a:ext>
             </a:extLst>
           </p:cNvPr>
@@ -8924,7 +9020,7 @@
           <p:cNvPr id="6" name="">
             <a:extLst xmlns:a="http://schemas.openxmlformats.org/drawingml/2006/main">
               <a:ext uri="{FF2B5EF4-FFF2-40B4-BE49-F238E27FC236}">
-                <a16:creationId xmlns:a16="http://schemas.microsoft.com/office/drawing/2014/main" id="{0F3A9339-9818-458A-BE78-EF9A62C91FD6}"/>
+                <a16:creationId xmlns:a16="http://schemas.microsoft.com/office/drawing/2014/main" id="{93C13F5D-5C13-44ED-95E9-0ECE90BD8146}"/>
               </a:ext>
             </a:extLst>
           </p:cNvPr>
@@ -8955,7 +9051,7 @@
           <p:cNvPr id="7" name="page-14">
             <a:extLst xmlns:a="http://schemas.openxmlformats.org/drawingml/2006/main">
               <a:ext uri="{FF2B5EF4-FFF2-40B4-BE49-F238E27FC236}">
-                <a16:creationId xmlns:a16="http://schemas.microsoft.com/office/drawing/2014/main" id="{5822D706-366D-4D89-9410-1503CE8518FC}"/>
+                <a16:creationId xmlns:a16="http://schemas.microsoft.com/office/drawing/2014/main" id="{535AD28C-A20A-4603-B10B-2345FA98A735}"/>
               </a:ext>
             </a:extLst>
           </p:cNvPr>
@@ -9005,7 +9101,7 @@
           <p:cNvPr id="8" name="limit-0">
             <a:extLst xmlns:a="http://schemas.openxmlformats.org/drawingml/2006/main">
               <a:ext uri="{FF2B5EF4-FFF2-40B4-BE49-F238E27FC236}">
-                <a16:creationId xmlns:a16="http://schemas.microsoft.com/office/drawing/2014/main" id="{5D414C6E-ADA7-4190-ABF5-033E84912013}"/>
+                <a16:creationId xmlns:a16="http://schemas.microsoft.com/office/drawing/2014/main" id="{4D081161-9394-4130-9171-7BF23D98B92E}"/>
               </a:ext>
             </a:extLst>
           </p:cNvPr>
@@ -9040,7 +9136,7 @@
           <p:cNvPr id="9" name="limit-k-0">
             <a:extLst xmlns:a="http://schemas.openxmlformats.org/drawingml/2006/main">
               <a:ext uri="{FF2B5EF4-FFF2-40B4-BE49-F238E27FC236}">
-                <a16:creationId xmlns:a16="http://schemas.microsoft.com/office/drawing/2014/main" id="{E25A3DF9-788F-47F8-9159-38AACC74070C}"/>
+                <a16:creationId xmlns:a16="http://schemas.microsoft.com/office/drawing/2014/main" id="{0274CA48-FD60-48BC-A6AB-A7BD51B79636}"/>
               </a:ext>
             </a:extLst>
           </p:cNvPr>
@@ -9090,7 +9186,7 @@
           <p:cNvPr id="10" name="limit-v-0-0">
             <a:extLst xmlns:a="http://schemas.openxmlformats.org/drawingml/2006/main">
               <a:ext uri="{FF2B5EF4-FFF2-40B4-BE49-F238E27FC236}">
-                <a16:creationId xmlns:a16="http://schemas.microsoft.com/office/drawing/2014/main" id="{2504EDFA-72D2-4A14-A36E-0A8A03CEB2FE}"/>
+                <a16:creationId xmlns:a16="http://schemas.microsoft.com/office/drawing/2014/main" id="{622F7840-4090-42BD-BC0D-68B0F2ED8C12}"/>
               </a:ext>
             </a:extLst>
           </p:cNvPr>
@@ -9140,7 +9236,7 @@
           <p:cNvPr id="11" name="limit-v-0-1">
             <a:extLst xmlns:a="http://schemas.openxmlformats.org/drawingml/2006/main">
               <a:ext uri="{FF2B5EF4-FFF2-40B4-BE49-F238E27FC236}">
-                <a16:creationId xmlns:a16="http://schemas.microsoft.com/office/drawing/2014/main" id="{6913D246-BC05-4277-9641-BF67D48DB452}"/>
+                <a16:creationId xmlns:a16="http://schemas.microsoft.com/office/drawing/2014/main" id="{020C50F2-69A5-4D98-88E2-E5065356F9F5}"/>
               </a:ext>
             </a:extLst>
           </p:cNvPr>
@@ -9190,7 +9286,7 @@
           <p:cNvPr id="12" name="limit-v-0-2">
             <a:extLst xmlns:a="http://schemas.openxmlformats.org/drawingml/2006/main">
               <a:ext uri="{FF2B5EF4-FFF2-40B4-BE49-F238E27FC236}">
-                <a16:creationId xmlns:a16="http://schemas.microsoft.com/office/drawing/2014/main" id="{89790299-7734-4561-8C1D-158B6BDAE29A}"/>
+                <a16:creationId xmlns:a16="http://schemas.microsoft.com/office/drawing/2014/main" id="{908A66F7-4212-45F5-A8F2-41F42FEFFEA4}"/>
               </a:ext>
             </a:extLst>
           </p:cNvPr>
@@ -9240,7 +9336,7 @@
           <p:cNvPr id="13" name="limit-v-0-3">
             <a:extLst xmlns:a="http://schemas.openxmlformats.org/drawingml/2006/main">
               <a:ext uri="{FF2B5EF4-FFF2-40B4-BE49-F238E27FC236}">
-                <a16:creationId xmlns:a16="http://schemas.microsoft.com/office/drawing/2014/main" id="{71CA2ED3-6042-478C-A439-AD558C78EF69}"/>
+                <a16:creationId xmlns:a16="http://schemas.microsoft.com/office/drawing/2014/main" id="{CF3FD820-3EC4-4354-9883-5FCF072D07C8}"/>
               </a:ext>
             </a:extLst>
           </p:cNvPr>
@@ -9290,7 +9386,7 @@
           <p:cNvPr id="14" name="limit-1">
             <a:extLst xmlns:a="http://schemas.openxmlformats.org/drawingml/2006/main">
               <a:ext uri="{FF2B5EF4-FFF2-40B4-BE49-F238E27FC236}">
-                <a16:creationId xmlns:a16="http://schemas.microsoft.com/office/drawing/2014/main" id="{6D4A8FC9-8ED2-44AC-83D4-B47C5A7BF6BF}"/>
+                <a16:creationId xmlns:a16="http://schemas.microsoft.com/office/drawing/2014/main" id="{FA766BE1-21F0-4306-A9A2-7178B3E68FB8}"/>
               </a:ext>
             </a:extLst>
           </p:cNvPr>
@@ -9325,7 +9421,7 @@
           <p:cNvPr id="15" name="limit-k-1">
             <a:extLst xmlns:a="http://schemas.openxmlformats.org/drawingml/2006/main">
               <a:ext uri="{FF2B5EF4-FFF2-40B4-BE49-F238E27FC236}">
-                <a16:creationId xmlns:a16="http://schemas.microsoft.com/office/drawing/2014/main" id="{57F53AC2-5FAD-42DE-8079-2D36F86397B7}"/>
+                <a16:creationId xmlns:a16="http://schemas.microsoft.com/office/drawing/2014/main" id="{ACB87A61-8B36-407F-8E80-D84694424C29}"/>
               </a:ext>
             </a:extLst>
           </p:cNvPr>
@@ -9375,7 +9471,7 @@
           <p:cNvPr id="16" name="limit-v-1-0">
             <a:extLst xmlns:a="http://schemas.openxmlformats.org/drawingml/2006/main">
               <a:ext uri="{FF2B5EF4-FFF2-40B4-BE49-F238E27FC236}">
-                <a16:creationId xmlns:a16="http://schemas.microsoft.com/office/drawing/2014/main" id="{C7BCFD24-01A7-4C19-8778-4F39A015FF4A}"/>
+                <a16:creationId xmlns:a16="http://schemas.microsoft.com/office/drawing/2014/main" id="{EE2DC23B-8AC8-4CCF-9D5F-BCEE6668C0FB}"/>
               </a:ext>
             </a:extLst>
           </p:cNvPr>
@@ -9425,7 +9521,7 @@
           <p:cNvPr id="17" name="limit-v-1-1">
             <a:extLst xmlns:a="http://schemas.openxmlformats.org/drawingml/2006/main">
               <a:ext uri="{FF2B5EF4-FFF2-40B4-BE49-F238E27FC236}">
-                <a16:creationId xmlns:a16="http://schemas.microsoft.com/office/drawing/2014/main" id="{2670B3E8-DCBA-4AF3-9D64-3586D2083FD0}"/>
+                <a16:creationId xmlns:a16="http://schemas.microsoft.com/office/drawing/2014/main" id="{74AA7CE8-CB16-418E-BE48-3DD248F31A83}"/>
               </a:ext>
             </a:extLst>
           </p:cNvPr>
@@ -9475,7 +9571,7 @@
           <p:cNvPr id="18" name="limit-v-1-2">
             <a:extLst xmlns:a="http://schemas.openxmlformats.org/drawingml/2006/main">
               <a:ext uri="{FF2B5EF4-FFF2-40B4-BE49-F238E27FC236}">
-                <a16:creationId xmlns:a16="http://schemas.microsoft.com/office/drawing/2014/main" id="{7A2F61D0-907A-4816-9707-A46E74CA3A5C}"/>
+                <a16:creationId xmlns:a16="http://schemas.microsoft.com/office/drawing/2014/main" id="{5B4D3BF8-F0CB-4D50-8AFD-03755767D792}"/>
               </a:ext>
             </a:extLst>
           </p:cNvPr>
@@ -9525,7 +9621,7 @@
           <p:cNvPr id="19" name="limit-v-1-3">
             <a:extLst xmlns:a="http://schemas.openxmlformats.org/drawingml/2006/main">
               <a:ext uri="{FF2B5EF4-FFF2-40B4-BE49-F238E27FC236}">
-                <a16:creationId xmlns:a16="http://schemas.microsoft.com/office/drawing/2014/main" id="{15CE8E0B-40FA-4BFF-8EA0-E72315C4EA24}"/>
+                <a16:creationId xmlns:a16="http://schemas.microsoft.com/office/drawing/2014/main" id="{70D038E0-CE25-4A83-A26D-0D33C72A1935}"/>
               </a:ext>
             </a:extLst>
           </p:cNvPr>
@@ -9575,7 +9671,7 @@
           <p:cNvPr id="20" name="limit-2">
             <a:extLst xmlns:a="http://schemas.openxmlformats.org/drawingml/2006/main">
               <a:ext uri="{FF2B5EF4-FFF2-40B4-BE49-F238E27FC236}">
-                <a16:creationId xmlns:a16="http://schemas.microsoft.com/office/drawing/2014/main" id="{3681B199-2D54-40AA-935C-3C27A8D4AE7F}"/>
+                <a16:creationId xmlns:a16="http://schemas.microsoft.com/office/drawing/2014/main" id="{AEF4DA64-53F3-4ADB-9B97-B267240F4F42}"/>
               </a:ext>
             </a:extLst>
           </p:cNvPr>
@@ -9610,7 +9706,7 @@
           <p:cNvPr id="21" name="limit-k-2">
             <a:extLst xmlns:a="http://schemas.openxmlformats.org/drawingml/2006/main">
               <a:ext uri="{FF2B5EF4-FFF2-40B4-BE49-F238E27FC236}">
-                <a16:creationId xmlns:a16="http://schemas.microsoft.com/office/drawing/2014/main" id="{81EAC642-F620-4662-B1C2-9AC21AE5B88D}"/>
+                <a16:creationId xmlns:a16="http://schemas.microsoft.com/office/drawing/2014/main" id="{5F906CAC-C8C0-4652-B53A-D27A87AB7812}"/>
               </a:ext>
             </a:extLst>
           </p:cNvPr>
@@ -9660,7 +9756,7 @@
           <p:cNvPr id="22" name="limit-v-2-0">
             <a:extLst xmlns:a="http://schemas.openxmlformats.org/drawingml/2006/main">
               <a:ext uri="{FF2B5EF4-FFF2-40B4-BE49-F238E27FC236}">
-                <a16:creationId xmlns:a16="http://schemas.microsoft.com/office/drawing/2014/main" id="{5EDC853E-D50B-4279-8EDF-DFF5A92BD533}"/>
+                <a16:creationId xmlns:a16="http://schemas.microsoft.com/office/drawing/2014/main" id="{45664DD8-BFDE-4F3E-94F5-B209F175E4B1}"/>
               </a:ext>
             </a:extLst>
           </p:cNvPr>
@@ -9710,7 +9806,7 @@
           <p:cNvPr id="23" name="limit-v-2-1">
             <a:extLst xmlns:a="http://schemas.openxmlformats.org/drawingml/2006/main">
               <a:ext uri="{FF2B5EF4-FFF2-40B4-BE49-F238E27FC236}">
-                <a16:creationId xmlns:a16="http://schemas.microsoft.com/office/drawing/2014/main" id="{8F2D74AE-BBB0-45CE-8413-F210F1AE91C6}"/>
+                <a16:creationId xmlns:a16="http://schemas.microsoft.com/office/drawing/2014/main" id="{E638F73C-1F38-433B-B5B4-EE4DDD2A8F43}"/>
               </a:ext>
             </a:extLst>
           </p:cNvPr>
@@ -9760,7 +9856,7 @@
           <p:cNvPr id="24" name="limit-v-2-2">
             <a:extLst xmlns:a="http://schemas.openxmlformats.org/drawingml/2006/main">
               <a:ext uri="{FF2B5EF4-FFF2-40B4-BE49-F238E27FC236}">
-                <a16:creationId xmlns:a16="http://schemas.microsoft.com/office/drawing/2014/main" id="{CBF2CE12-6B51-4AA4-9868-BA42AC2775D9}"/>
+                <a16:creationId xmlns:a16="http://schemas.microsoft.com/office/drawing/2014/main" id="{A04D9E3B-5866-4571-8748-A3BFA2970B43}"/>
               </a:ext>
             </a:extLst>
           </p:cNvPr>
@@ -9810,7 +9906,7 @@
           <p:cNvPr id="25" name="limit-v-2-3">
             <a:extLst xmlns:a="http://schemas.openxmlformats.org/drawingml/2006/main">
               <a:ext uri="{FF2B5EF4-FFF2-40B4-BE49-F238E27FC236}">
-                <a16:creationId xmlns:a16="http://schemas.microsoft.com/office/drawing/2014/main" id="{54F6A40F-98EC-4929-8167-731D2C2E4532}"/>
+                <a16:creationId xmlns:a16="http://schemas.microsoft.com/office/drawing/2014/main" id="{4E26C4B4-65A6-454E-A66C-DDE8065AB78F}"/>
               </a:ext>
             </a:extLst>
           </p:cNvPr>
@@ -9858,7 +9954,7 @@
     </p:spTree>
     <p:extLst>
       <p:ext uri="{BB962C8B-B14F-4D97-AF65-F5344CB8AC3E}">
-        <p14:creationId xmlns:p14="http://schemas.microsoft.com/office/powerpoint/2010/main" val="1661833607"/>
+        <p14:creationId xmlns:p14="http://schemas.microsoft.com/office/powerpoint/2010/main" val="576466821"/>
       </p:ext>
     </p:extLst>
   </p:cSld>
@@ -9866,6 +9962,271 @@
 </file>
 
 <file path=ppt/slides/slide15.xml><?xml version="1.0" encoding="utf-8"?>
+<p:sld xmlns:p="http://schemas.openxmlformats.org/presentationml/2006/main">
+  <p:cSld>
+    <p:bg>
+      <p:bgPr>
+        <a:solidFill xmlns:a="http://schemas.openxmlformats.org/drawingml/2006/main">
+          <a:srgbClr val="FFFDFC"/>
+        </a:solidFill>
+      </p:bgPr>
+    </p:bg>
+    <p:spTree>
+      <p:nvGrpSpPr>
+        <p:cNvPr id="1" name=""/>
+        <p:cNvGrpSpPr/>
+        <p:nvPr/>
+      </p:nvGrpSpPr>
+      <p:grpSpPr>
+        <a:xfrm xmlns:a="http://schemas.openxmlformats.org/drawingml/2006/main"/>
+      </p:grpSpPr>
+      <p:sp>
+        <p:nvSpPr>
+          <p:cNvPr id="7" name="mechanism-rail">
+            <a:extLst xmlns:a="http://schemas.openxmlformats.org/drawingml/2006/main">
+              <a:ext uri="{FF2B5EF4-FFF2-40B4-BE49-F238E27FC236}">
+                <a16:creationId xmlns:a16="http://schemas.microsoft.com/office/drawing/2014/main" id="{60069568-E8A0-49BB-8755-1149E7363046}"/>
+              </a:ext>
+            </a:extLst>
+          </p:cNvPr>
+          <p:cNvSpPr>
+            <a:spLocks xmlns:a="http://schemas.openxmlformats.org/drawingml/2006/main" noGrp="1"/>
+          </p:cNvSpPr>
+          <p:nvPr/>
+        </p:nvSpPr>
+        <p:spPr>
+          <a:xfrm xmlns:a="http://schemas.openxmlformats.org/drawingml/2006/main">
+            <a:off x="0" y="0"/>
+            <a:ext cx="285750" cy="6858000"/>
+          </a:xfrm>
+          <a:prstGeom xmlns:a="http://schemas.openxmlformats.org/drawingml/2006/main" prst="rect">
+            <a:avLst/>
+          </a:prstGeom>
+          <a:solidFill xmlns:a="http://schemas.openxmlformats.org/drawingml/2006/main">
+            <a:srgbClr val="071A2B"/>
+          </a:solidFill>
+          <a:ln xmlns:a="http://schemas.openxmlformats.org/drawingml/2006/main" w="0">
+            <a:solidFill>
+              <a:srgbClr val="071A2B"/>
+            </a:solidFill>
+            <a:prstDash val="solid"/>
+          </a:ln>
+        </p:spPr>
+      </p:sp>
+      <p:sp>
+        <p:nvSpPr>
+          <p:cNvPr id="2" name="mechanism-title">
+            <a:extLst xmlns:a="http://schemas.openxmlformats.org/drawingml/2006/main">
+              <a:ext uri="{FF2B5EF4-FFF2-40B4-BE49-F238E27FC236}">
+                <a16:creationId xmlns:a16="http://schemas.microsoft.com/office/drawing/2014/main" id="{06610291-7952-4240-80ED-B74A118CE0C7}"/>
+              </a:ext>
+            </a:extLst>
+          </p:cNvPr>
+          <p:cNvSpPr>
+            <a:spLocks xmlns:a="http://schemas.openxmlformats.org/drawingml/2006/main" noGrp="1"/>
+          </p:cNvSpPr>
+          <p:nvPr/>
+        </p:nvSpPr>
+        <p:spPr>
+          <a:xfrm xmlns:a="http://schemas.openxmlformats.org/drawingml/2006/main">
+            <a:off x="742950" y="228600"/>
+            <a:ext cx="6858000" cy="428625"/>
+          </a:xfrm>
+          <a:prstGeom xmlns:a="http://schemas.openxmlformats.org/drawingml/2006/main" prst="rect">
+            <a:avLst/>
+          </a:prstGeom>
+          <a:noFill xmlns:a="http://schemas.openxmlformats.org/drawingml/2006/main"/>
+          <a:ln xmlns:a="http://schemas.openxmlformats.org/drawingml/2006/main" w="0">
+            <a:noFill/>
+            <a:prstDash val="solid"/>
+          </a:ln>
+        </p:spPr>
+        <p:txBody>
+          <a:bodyPr xmlns:a="http://schemas.openxmlformats.org/drawingml/2006/main" anchor="t"/>
+          <a:lstStyle xmlns:a="http://schemas.openxmlformats.org/drawingml/2006/main"/>
+          <a:p xmlns:a="http://schemas.openxmlformats.org/drawingml/2006/main">
+            <a:pPr>
+              <a:defRPr sz="2400" b="1">
+                <a:solidFill>
+                  <a:srgbClr val="071A2B"/>
+                </a:solidFill>
+              </a:defRPr>
+            </a:pPr>
+            <a:r>
+              <a:rPr sz="2400" b="1">
+                <a:solidFill>
+                  <a:srgbClr val="071A2B"/>
+                </a:solidFill>
+              </a:rPr>
+              <a:t>失败驱动的课程学习闭环</a:t>
+            </a:r>
+          </a:p>
+        </p:txBody>
+      </p:sp>
+      <p:sp>
+        <p:nvSpPr>
+          <p:cNvPr id="3" name="mechanism-subtitle">
+            <a:extLst xmlns:a="http://schemas.openxmlformats.org/drawingml/2006/main">
+              <a:ext uri="{FF2B5EF4-FFF2-40B4-BE49-F238E27FC236}">
+                <a16:creationId xmlns:a16="http://schemas.microsoft.com/office/drawing/2014/main" id="{78710CC1-03A9-4958-91F8-4E305B5C8E84}"/>
+              </a:ext>
+            </a:extLst>
+          </p:cNvPr>
+          <p:cNvSpPr>
+            <a:spLocks xmlns:a="http://schemas.openxmlformats.org/drawingml/2006/main" noGrp="1"/>
+          </p:cNvSpPr>
+          <p:nvPr/>
+        </p:nvSpPr>
+        <p:spPr>
+          <a:xfrm xmlns:a="http://schemas.openxmlformats.org/drawingml/2006/main">
+            <a:off x="7477125" y="323850"/>
+            <a:ext cx="3762375" cy="266700"/>
+          </a:xfrm>
+          <a:prstGeom xmlns:a="http://schemas.openxmlformats.org/drawingml/2006/main" prst="rect">
+            <a:avLst/>
+          </a:prstGeom>
+          <a:noFill xmlns:a="http://schemas.openxmlformats.org/drawingml/2006/main"/>
+          <a:ln xmlns:a="http://schemas.openxmlformats.org/drawingml/2006/main" w="0">
+            <a:noFill/>
+            <a:prstDash val="solid"/>
+          </a:ln>
+        </p:spPr>
+        <p:txBody>
+          <a:bodyPr xmlns:a="http://schemas.openxmlformats.org/drawingml/2006/main" anchor="t"/>
+          <a:lstStyle xmlns:a="http://schemas.openxmlformats.org/drawingml/2006/main"/>
+          <a:p xmlns:a="http://schemas.openxmlformats.org/drawingml/2006/main">
+            <a:pPr algn="r">
+              <a:defRPr sz="1125" b="1">
+                <a:solidFill>
+                  <a:srgbClr val="0B797B"/>
+                </a:solidFill>
+              </a:defRPr>
+            </a:pPr>
+            <a:r>
+              <a:rPr sz="1125" b="1">
+                <a:solidFill>
+                  <a:srgbClr val="0B797B"/>
+                </a:solidFill>
+              </a:rPr>
+              <a:t>基础工具链 → 轨迹审计 → 定向合成 → 带分支的持续训练</a:t>
+            </a:r>
+          </a:p>
+        </p:txBody>
+      </p:sp>
+      <p:sp>
+        <p:nvSpPr>
+          <p:cNvPr id="4" name="">
+            <a:extLst xmlns:a="http://schemas.openxmlformats.org/drawingml/2006/main">
+              <a:ext uri="{FF2B5EF4-FFF2-40B4-BE49-F238E27FC236}">
+                <a16:creationId xmlns:a16="http://schemas.microsoft.com/office/drawing/2014/main" id="{18D1AF44-9D8B-4A5B-807F-68F59D014D0D}"/>
+              </a:ext>
+            </a:extLst>
+          </p:cNvPr>
+          <p:cNvSpPr>
+            <a:spLocks xmlns:a="http://schemas.openxmlformats.org/drawingml/2006/main" noGrp="1"/>
+          </p:cNvSpPr>
+          <p:nvPr/>
+        </p:nvSpPr>
+        <p:spPr>
+          <a:xfrm xmlns:a="http://schemas.openxmlformats.org/drawingml/2006/main">
+            <a:off x="723900" y="723900"/>
+            <a:ext cx="10515600" cy="0"/>
+          </a:xfrm>
+          <a:prstGeom xmlns:a="http://schemas.openxmlformats.org/drawingml/2006/main" prst="line">
+            <a:avLst/>
+          </a:prstGeom>
+          <a:noFill xmlns:a="http://schemas.openxmlformats.org/drawingml/2006/main"/>
+          <a:ln xmlns:a="http://schemas.openxmlformats.org/drawingml/2006/main" w="9525">
+            <a:solidFill>
+              <a:srgbClr val="CAD9D8"/>
+            </a:solidFill>
+            <a:prstDash val="solid"/>
+          </a:ln>
+        </p:spPr>
+      </p:sp>
+      <p:pic>
+        <p:nvPicPr>
+          <p:cNvPr id="11" name=""/>
+          <p:cNvPicPr>
+            <a:picLocks xmlns:a="http://schemas.openxmlformats.org/drawingml/2006/main" noChangeAspect="1"/>
+          </p:cNvPicPr>
+          <p:nvPr/>
+        </p:nvPicPr>
+        <p:blipFill>
+          <a:blip xmlns:r="http://schemas.openxmlformats.org/officeDocument/2006/relationships" xmlns:a="http://schemas.openxmlformats.org/drawingml/2006/main" r:embed="R2d89d394b910480e"/>
+          <a:stretch xmlns:a="http://schemas.openxmlformats.org/drawingml/2006/main"/>
+        </p:blipFill>
+        <p:spPr>
+          <a:xfrm xmlns:a="http://schemas.openxmlformats.org/drawingml/2006/main">
+            <a:off x="1619250" y="839203"/>
+            <a:ext cx="8953500" cy="5560595"/>
+          </a:xfrm>
+          <a:prstGeom xmlns:a="http://schemas.openxmlformats.org/drawingml/2006/main" prst="rect">
+            <a:avLst/>
+          </a:prstGeom>
+        </p:spPr>
+      </p:pic>
+      <p:sp>
+        <p:nvSpPr>
+          <p:cNvPr id="6" name="mechanism-page">
+            <a:extLst xmlns:a="http://schemas.openxmlformats.org/drawingml/2006/main">
+              <a:ext uri="{FF2B5EF4-FFF2-40B4-BE49-F238E27FC236}">
+                <a16:creationId xmlns:a16="http://schemas.microsoft.com/office/drawing/2014/main" id="{A0FEAC8A-F28A-43A0-892C-F2867B397D7A}"/>
+              </a:ext>
+            </a:extLst>
+          </p:cNvPr>
+          <p:cNvSpPr>
+            <a:spLocks xmlns:a="http://schemas.openxmlformats.org/drawingml/2006/main" noGrp="1"/>
+          </p:cNvSpPr>
+          <p:nvPr/>
+        </p:nvSpPr>
+        <p:spPr>
+          <a:xfrm xmlns:a="http://schemas.openxmlformats.org/drawingml/2006/main">
+            <a:off x="10715625" y="6419850"/>
+            <a:ext cx="523875" cy="190500"/>
+          </a:xfrm>
+          <a:prstGeom xmlns:a="http://schemas.openxmlformats.org/drawingml/2006/main" prst="rect">
+            <a:avLst/>
+          </a:prstGeom>
+          <a:noFill xmlns:a="http://schemas.openxmlformats.org/drawingml/2006/main"/>
+          <a:ln xmlns:a="http://schemas.openxmlformats.org/drawingml/2006/main" w="0">
+            <a:noFill/>
+            <a:prstDash val="solid"/>
+          </a:ln>
+        </p:spPr>
+        <p:txBody>
+          <a:bodyPr xmlns:a="http://schemas.openxmlformats.org/drawingml/2006/main" anchor="t"/>
+          <a:lstStyle xmlns:a="http://schemas.openxmlformats.org/drawingml/2006/main"/>
+          <a:p xmlns:a="http://schemas.openxmlformats.org/drawingml/2006/main">
+            <a:pPr algn="r">
+              <a:defRPr sz="900">
+                <a:solidFill>
+                  <a:srgbClr val="64747B"/>
+                </a:solidFill>
+              </a:defRPr>
+            </a:pPr>
+            <a:r>
+              <a:rPr sz="900">
+                <a:solidFill>
+                  <a:srgbClr val="64747B"/>
+                </a:solidFill>
+              </a:rPr>
+              <a:t>15</a:t>
+            </a:r>
+          </a:p>
+        </p:txBody>
+      </p:sp>
+    </p:spTree>
+    <p:extLst>
+      <p:ext uri="{BB962C8B-B14F-4D97-AF65-F5344CB8AC3E}">
+        <p14:creationId xmlns:p14="http://schemas.microsoft.com/office/powerpoint/2010/main" val="1945553522"/>
+      </p:ext>
+    </p:extLst>
+  </p:cSld>
+</p:sld>
+</file>
+
+<file path=ppt/slides/slide16.xml><?xml version="1.0" encoding="utf-8"?>
 <p:sld xmlns:p="http://schemas.openxmlformats.org/presentationml/2006/main">
   <p:cSld>
     <p:bg>
@@ -9886,10 +10247,10 @@
       </p:grpSpPr>
       <p:sp>
         <p:nvSpPr>
-          <p:cNvPr id="11" name="copper-15">
-            <a:extLst xmlns:a="http://schemas.openxmlformats.org/drawingml/2006/main">
-              <a:ext uri="{FF2B5EF4-FFF2-40B4-BE49-F238E27FC236}">
-                <a16:creationId xmlns:a16="http://schemas.microsoft.com/office/drawing/2014/main" id="{C1D1E369-6028-45E0-8C6E-104C3E919186}"/>
+          <p:cNvPr id="11" name="copper-16">
+            <a:extLst xmlns:a="http://schemas.openxmlformats.org/drawingml/2006/main">
+              <a:ext uri="{FF2B5EF4-FFF2-40B4-BE49-F238E27FC236}">
+                <a16:creationId xmlns:a16="http://schemas.microsoft.com/office/drawing/2014/main" id="{00D8CF15-435B-463A-B2FC-62BD04C502F6}"/>
               </a:ext>
             </a:extLst>
           </p:cNvPr>
@@ -9919,10 +10280,10 @@
       </p:sp>
       <p:sp>
         <p:nvSpPr>
-          <p:cNvPr id="2" name="chapter-script-15">
-            <a:extLst xmlns:a="http://schemas.openxmlformats.org/drawingml/2006/main">
-              <a:ext uri="{FF2B5EF4-FFF2-40B4-BE49-F238E27FC236}">
-                <a16:creationId xmlns:a16="http://schemas.microsoft.com/office/drawing/2014/main" id="{F4E811F0-1639-42A9-A0FD-6335B116936F}"/>
+          <p:cNvPr id="2" name="chapter-script-16">
+            <a:extLst xmlns:a="http://schemas.openxmlformats.org/drawingml/2006/main">
+              <a:ext uri="{FF2B5EF4-FFF2-40B4-BE49-F238E27FC236}">
+                <a16:creationId xmlns:a16="http://schemas.microsoft.com/office/drawing/2014/main" id="{D825881C-2264-4CF0-9EBF-A84D96159525}"/>
               </a:ext>
             </a:extLst>
           </p:cNvPr>
@@ -9969,10 +10330,10 @@
       </p:sp>
       <p:sp>
         <p:nvSpPr>
-          <p:cNvPr id="3" name="roman-15">
-            <a:extLst xmlns:a="http://schemas.openxmlformats.org/drawingml/2006/main">
-              <a:ext uri="{FF2B5EF4-FFF2-40B4-BE49-F238E27FC236}">
-                <a16:creationId xmlns:a16="http://schemas.microsoft.com/office/drawing/2014/main" id="{77646FE5-44F2-4FF3-AE94-72126792FD64}"/>
+          <p:cNvPr id="3" name="roman-16">
+            <a:extLst xmlns:a="http://schemas.openxmlformats.org/drawingml/2006/main">
+              <a:ext uri="{FF2B5EF4-FFF2-40B4-BE49-F238E27FC236}">
+                <a16:creationId xmlns:a16="http://schemas.microsoft.com/office/drawing/2014/main" id="{E081764A-6A03-4851-881F-76727670F3F7}"/>
               </a:ext>
             </a:extLst>
           </p:cNvPr>
@@ -10022,7 +10383,7 @@
           <p:cNvPr id="4" name="">
             <a:extLst xmlns:a="http://schemas.openxmlformats.org/drawingml/2006/main">
               <a:ext uri="{FF2B5EF4-FFF2-40B4-BE49-F238E27FC236}">
-                <a16:creationId xmlns:a16="http://schemas.microsoft.com/office/drawing/2014/main" id="{F5C48EA9-492D-4799-8735-95CD59210DE7}"/>
+                <a16:creationId xmlns:a16="http://schemas.microsoft.com/office/drawing/2014/main" id="{CC35A5A0-E634-49FE-A386-FF0399BFBF50}"/>
               </a:ext>
             </a:extLst>
           </p:cNvPr>
@@ -10050,10 +10411,10 @@
       </p:sp>
       <p:sp>
         <p:nvSpPr>
-          <p:cNvPr id="5" name="zh-15">
-            <a:extLst xmlns:a="http://schemas.openxmlformats.org/drawingml/2006/main">
-              <a:ext uri="{FF2B5EF4-FFF2-40B4-BE49-F238E27FC236}">
-                <a16:creationId xmlns:a16="http://schemas.microsoft.com/office/drawing/2014/main" id="{2C6EECB3-02DB-430E-91DC-893FF7091CF0}"/>
+          <p:cNvPr id="5" name="zh-16">
+            <a:extLst xmlns:a="http://schemas.openxmlformats.org/drawingml/2006/main">
+              <a:ext uri="{FF2B5EF4-FFF2-40B4-BE49-F238E27FC236}">
+                <a16:creationId xmlns:a16="http://schemas.microsoft.com/office/drawing/2014/main" id="{06FECFF6-D814-4F2E-821D-44CBEC0380DA}"/>
               </a:ext>
             </a:extLst>
           </p:cNvPr>
@@ -10100,10 +10461,10 @@
       </p:sp>
       <p:sp>
         <p:nvSpPr>
-          <p:cNvPr id="6" name="en-15">
-            <a:extLst xmlns:a="http://schemas.openxmlformats.org/drawingml/2006/main">
-              <a:ext uri="{FF2B5EF4-FFF2-40B4-BE49-F238E27FC236}">
-                <a16:creationId xmlns:a16="http://schemas.microsoft.com/office/drawing/2014/main" id="{95B2CDB1-36BD-46DE-9567-10D375D98D1D}"/>
+          <p:cNvPr id="6" name="en-16">
+            <a:extLst xmlns:a="http://schemas.openxmlformats.org/drawingml/2006/main">
+              <a:ext uri="{FF2B5EF4-FFF2-40B4-BE49-F238E27FC236}">
+                <a16:creationId xmlns:a16="http://schemas.microsoft.com/office/drawing/2014/main" id="{CB8D4588-FA2B-4839-AB15-E10F2DBA90FD}"/>
               </a:ext>
             </a:extLst>
           </p:cNvPr>
@@ -10150,10 +10511,10 @@
       </p:sp>
       <p:sp>
         <p:nvSpPr>
-          <p:cNvPr id="7" name="body-15">
-            <a:extLst xmlns:a="http://schemas.openxmlformats.org/drawingml/2006/main">
-              <a:ext uri="{FF2B5EF4-FFF2-40B4-BE49-F238E27FC236}">
-                <a16:creationId xmlns:a16="http://schemas.microsoft.com/office/drawing/2014/main" id="{0F2283DB-02D9-4FD1-A9B6-40923C409F11}"/>
+          <p:cNvPr id="7" name="body-16">
+            <a:extLst xmlns:a="http://schemas.openxmlformats.org/drawingml/2006/main">
+              <a:ext uri="{FF2B5EF4-FFF2-40B4-BE49-F238E27FC236}">
+                <a16:creationId xmlns:a16="http://schemas.microsoft.com/office/drawing/2014/main" id="{5AD912BE-1B89-4661-9590-C2870389C8F1}"/>
               </a:ext>
             </a:extLst>
           </p:cNvPr>
@@ -10204,10 +10565,10 @@
       </p:sp>
       <p:sp>
         <p:nvSpPr>
-          <p:cNvPr id="8" name="chapter-pill-15-bg">
-            <a:extLst xmlns:a="http://schemas.openxmlformats.org/drawingml/2006/main">
-              <a:ext uri="{FF2B5EF4-FFF2-40B4-BE49-F238E27FC236}">
-                <a16:creationId xmlns:a16="http://schemas.microsoft.com/office/drawing/2014/main" id="{EF075E07-66FA-4BB8-8CA1-D100E56CF5B2}"/>
+          <p:cNvPr id="8" name="chapter-pill-16-bg">
+            <a:extLst xmlns:a="http://schemas.openxmlformats.org/drawingml/2006/main">
+              <a:ext uri="{FF2B5EF4-FFF2-40B4-BE49-F238E27FC236}">
+                <a16:creationId xmlns:a16="http://schemas.microsoft.com/office/drawing/2014/main" id="{E4F35A34-DE46-471D-8AFA-D2D31965A81E}"/>
               </a:ext>
             </a:extLst>
           </p:cNvPr>
@@ -10239,10 +10600,10 @@
       </p:sp>
       <p:sp>
         <p:nvSpPr>
-          <p:cNvPr id="9" name="chapter-pill-15-text">
-            <a:extLst xmlns:a="http://schemas.openxmlformats.org/drawingml/2006/main">
-              <a:ext uri="{FF2B5EF4-FFF2-40B4-BE49-F238E27FC236}">
-                <a16:creationId xmlns:a16="http://schemas.microsoft.com/office/drawing/2014/main" id="{B95CAC9F-6626-40E5-AACB-C1FCD917AFE0}"/>
+          <p:cNvPr id="9" name="chapter-pill-16-text">
+            <a:extLst xmlns:a="http://schemas.openxmlformats.org/drawingml/2006/main">
+              <a:ext uri="{FF2B5EF4-FFF2-40B4-BE49-F238E27FC236}">
+                <a16:creationId xmlns:a16="http://schemas.microsoft.com/office/drawing/2014/main" id="{7CCA2D2A-6E36-429C-95D1-9A5EB0DC1C6C}"/>
               </a:ext>
             </a:extLst>
           </p:cNvPr>
@@ -10282,7 +10643,7 @@
                   <a:srgbClr val="FFFFFF"/>
                 </a:solidFill>
               </a:rPr>
-              <a:t>CHAPTER 15</a:t>
+              <a:t>CHAPTER 16</a:t>
             </a:r>
           </a:p>
         </p:txBody>
@@ -10292,7 +10653,7 @@
           <p:cNvPr id="10" name="close-command">
             <a:extLst xmlns:a="http://schemas.openxmlformats.org/drawingml/2006/main">
               <a:ext uri="{FF2B5EF4-FFF2-40B4-BE49-F238E27FC236}">
-                <a16:creationId xmlns:a16="http://schemas.microsoft.com/office/drawing/2014/main" id="{48813148-D2E7-42A8-BC08-D014AB53700C}"/>
+                <a16:creationId xmlns:a16="http://schemas.microsoft.com/office/drawing/2014/main" id="{6F7EBECD-8804-4645-A1A3-E6D24895D1F3}"/>
               </a:ext>
             </a:extLst>
           </p:cNvPr>
@@ -10340,7 +10701,7 @@
     </p:spTree>
     <p:extLst>
       <p:ext uri="{BB962C8B-B14F-4D97-AF65-F5344CB8AC3E}">
-        <p14:creationId xmlns:p14="http://schemas.microsoft.com/office/powerpoint/2010/main" val="1713034845"/>
+        <p14:creationId xmlns:p14="http://schemas.microsoft.com/office/powerpoint/2010/main" val="716297403"/>
       </p:ext>
     </p:extLst>
   </p:cSld>
@@ -10371,7 +10732,7 @@
           <p:cNvPr id="25" name="rail-2">
             <a:extLst xmlns:a="http://schemas.openxmlformats.org/drawingml/2006/main">
               <a:ext uri="{FF2B5EF4-FFF2-40B4-BE49-F238E27FC236}">
-                <a16:creationId xmlns:a16="http://schemas.microsoft.com/office/drawing/2014/main" id="{2451B014-88DA-4D9C-9503-7EA5C6C7C0C2}"/>
+                <a16:creationId xmlns:a16="http://schemas.microsoft.com/office/drawing/2014/main" id="{FB3045A7-9F89-44AB-ACA5-235AA9735881}"/>
               </a:ext>
             </a:extLst>
           </p:cNvPr>
@@ -10404,7 +10765,7 @@
           <p:cNvPr id="2" name="flourish-2">
             <a:extLst xmlns:a="http://schemas.openxmlformats.org/drawingml/2006/main">
               <a:ext uri="{FF2B5EF4-FFF2-40B4-BE49-F238E27FC236}">
-                <a16:creationId xmlns:a16="http://schemas.microsoft.com/office/drawing/2014/main" id="{2B28CBB1-B6B0-4E62-B2C9-7C64E781548D}"/>
+                <a16:creationId xmlns:a16="http://schemas.microsoft.com/office/drawing/2014/main" id="{2D49E8B1-2B71-4D15-8EB5-D5DB47CCAE50}"/>
               </a:ext>
             </a:extLst>
           </p:cNvPr>
@@ -10454,7 +10815,7 @@
           <p:cNvPr id="3" name="chapter-2">
             <a:extLst xmlns:a="http://schemas.openxmlformats.org/drawingml/2006/main">
               <a:ext uri="{FF2B5EF4-FFF2-40B4-BE49-F238E27FC236}">
-                <a16:creationId xmlns:a16="http://schemas.microsoft.com/office/drawing/2014/main" id="{A8AFC2B8-D691-4B27-9FE8-9AB95CE5068E}"/>
+                <a16:creationId xmlns:a16="http://schemas.microsoft.com/office/drawing/2014/main" id="{4EF1AD9C-301C-4EB8-B21F-F3D65AD90FDC}"/>
               </a:ext>
             </a:extLst>
           </p:cNvPr>
@@ -10504,7 +10865,7 @@
           <p:cNvPr id="4" name="title-2">
             <a:extLst xmlns:a="http://schemas.openxmlformats.org/drawingml/2006/main">
               <a:ext uri="{FF2B5EF4-FFF2-40B4-BE49-F238E27FC236}">
-                <a16:creationId xmlns:a16="http://schemas.microsoft.com/office/drawing/2014/main" id="{12B308CF-7673-45F0-BA67-04F949810DE0}"/>
+                <a16:creationId xmlns:a16="http://schemas.microsoft.com/office/drawing/2014/main" id="{001C9E60-C946-4B5D-A47B-5B60DEB2A889}"/>
               </a:ext>
             </a:extLst>
           </p:cNvPr>
@@ -10554,7 +10915,7 @@
           <p:cNvPr id="5" name="subtitle-2">
             <a:extLst xmlns:a="http://schemas.openxmlformats.org/drawingml/2006/main">
               <a:ext uri="{FF2B5EF4-FFF2-40B4-BE49-F238E27FC236}">
-                <a16:creationId xmlns:a16="http://schemas.microsoft.com/office/drawing/2014/main" id="{6CF5E43A-8B02-4389-BF1B-0785611C171A}"/>
+                <a16:creationId xmlns:a16="http://schemas.microsoft.com/office/drawing/2014/main" id="{354CE198-CB8D-4827-A2C4-34B7B5FED27B}"/>
               </a:ext>
             </a:extLst>
           </p:cNvPr>
@@ -10604,7 +10965,7 @@
           <p:cNvPr id="6" name="">
             <a:extLst xmlns:a="http://schemas.openxmlformats.org/drawingml/2006/main">
               <a:ext uri="{FF2B5EF4-FFF2-40B4-BE49-F238E27FC236}">
-                <a16:creationId xmlns:a16="http://schemas.microsoft.com/office/drawing/2014/main" id="{04776EDC-A859-4377-9CC5-3FCC0384F1BE}"/>
+                <a16:creationId xmlns:a16="http://schemas.microsoft.com/office/drawing/2014/main" id="{9330C672-FEBF-449C-B65E-0364982E02F1}"/>
               </a:ext>
             </a:extLst>
           </p:cNvPr>
@@ -10635,7 +10996,7 @@
           <p:cNvPr id="7" name="page-2">
             <a:extLst xmlns:a="http://schemas.openxmlformats.org/drawingml/2006/main">
               <a:ext uri="{FF2B5EF4-FFF2-40B4-BE49-F238E27FC236}">
-                <a16:creationId xmlns:a16="http://schemas.microsoft.com/office/drawing/2014/main" id="{BB85206D-5267-42C4-B0AF-56B5820950AF}"/>
+                <a16:creationId xmlns:a16="http://schemas.microsoft.com/office/drawing/2014/main" id="{F2CBA293-D4A8-40A9-93A7-F2040252D18C}"/>
               </a:ext>
             </a:extLst>
           </p:cNvPr>
@@ -10685,7 +11046,7 @@
           <p:cNvPr id="8" name="map-0">
             <a:extLst xmlns:a="http://schemas.openxmlformats.org/drawingml/2006/main">
               <a:ext uri="{FF2B5EF4-FFF2-40B4-BE49-F238E27FC236}">
-                <a16:creationId xmlns:a16="http://schemas.microsoft.com/office/drawing/2014/main" id="{EC4650B3-DF64-406D-AFA1-5CA72913B3B1}"/>
+                <a16:creationId xmlns:a16="http://schemas.microsoft.com/office/drawing/2014/main" id="{B3076578-15F6-485D-9F4D-17A7CCDB07CD}"/>
               </a:ext>
             </a:extLst>
           </p:cNvPr>
@@ -10720,7 +11081,7 @@
           <p:cNvPr id="9" name="map-num-0">
             <a:extLst xmlns:a="http://schemas.openxmlformats.org/drawingml/2006/main">
               <a:ext uri="{FF2B5EF4-FFF2-40B4-BE49-F238E27FC236}">
-                <a16:creationId xmlns:a16="http://schemas.microsoft.com/office/drawing/2014/main" id="{D8710FB8-9682-4A20-B7C7-600E151BA4AA}"/>
+                <a16:creationId xmlns:a16="http://schemas.microsoft.com/office/drawing/2014/main" id="{B41B83D5-09BC-40FB-8390-3C57D06E1F7B}"/>
               </a:ext>
             </a:extLst>
           </p:cNvPr>
@@ -10770,7 +11131,7 @@
           <p:cNvPr id="10" name="map-name-0">
             <a:extLst xmlns:a="http://schemas.openxmlformats.org/drawingml/2006/main">
               <a:ext uri="{FF2B5EF4-FFF2-40B4-BE49-F238E27FC236}">
-                <a16:creationId xmlns:a16="http://schemas.microsoft.com/office/drawing/2014/main" id="{5F91B682-6092-4A4E-A924-E2B450E787A1}"/>
+                <a16:creationId xmlns:a16="http://schemas.microsoft.com/office/drawing/2014/main" id="{A5D19396-80FD-4F41-9B7C-329D867A4F40}"/>
               </a:ext>
             </a:extLst>
           </p:cNvPr>
@@ -10820,7 +11181,7 @@
           <p:cNvPr id="11" name="map-body-0">
             <a:extLst xmlns:a="http://schemas.openxmlformats.org/drawingml/2006/main">
               <a:ext uri="{FF2B5EF4-FFF2-40B4-BE49-F238E27FC236}">
-                <a16:creationId xmlns:a16="http://schemas.microsoft.com/office/drawing/2014/main" id="{45D593F5-274A-4475-A617-3EAC506B750A}"/>
+                <a16:creationId xmlns:a16="http://schemas.microsoft.com/office/drawing/2014/main" id="{5AD31A33-0222-4272-B9C3-E6ED04AEE2AC}"/>
               </a:ext>
             </a:extLst>
           </p:cNvPr>
@@ -10874,7 +11235,7 @@
           <p:cNvPr id="12" name="map-1">
             <a:extLst xmlns:a="http://schemas.openxmlformats.org/drawingml/2006/main">
               <a:ext uri="{FF2B5EF4-FFF2-40B4-BE49-F238E27FC236}">
-                <a16:creationId xmlns:a16="http://schemas.microsoft.com/office/drawing/2014/main" id="{0F25DEA1-A305-47A4-972F-44491F23AD35}"/>
+                <a16:creationId xmlns:a16="http://schemas.microsoft.com/office/drawing/2014/main" id="{2F90A48D-A4C9-4AFE-BF55-E426F8A612AC}"/>
               </a:ext>
             </a:extLst>
           </p:cNvPr>
@@ -10909,7 +11270,7 @@
           <p:cNvPr id="13" name="map-num-1">
             <a:extLst xmlns:a="http://schemas.openxmlformats.org/drawingml/2006/main">
               <a:ext uri="{FF2B5EF4-FFF2-40B4-BE49-F238E27FC236}">
-                <a16:creationId xmlns:a16="http://schemas.microsoft.com/office/drawing/2014/main" id="{C6B4D170-BB84-44CE-8B85-ED4FB99B00B9}"/>
+                <a16:creationId xmlns:a16="http://schemas.microsoft.com/office/drawing/2014/main" id="{58D90723-67D1-4025-AA42-97E5418B19E9}"/>
               </a:ext>
             </a:extLst>
           </p:cNvPr>
@@ -10959,7 +11320,7 @@
           <p:cNvPr id="14" name="map-name-1">
             <a:extLst xmlns:a="http://schemas.openxmlformats.org/drawingml/2006/main">
               <a:ext uri="{FF2B5EF4-FFF2-40B4-BE49-F238E27FC236}">
-                <a16:creationId xmlns:a16="http://schemas.microsoft.com/office/drawing/2014/main" id="{361BE20F-A506-4760-A291-4233AC2F3C2F}"/>
+                <a16:creationId xmlns:a16="http://schemas.microsoft.com/office/drawing/2014/main" id="{BFC846E9-5506-4FD6-8DAC-C9002471FB38}"/>
               </a:ext>
             </a:extLst>
           </p:cNvPr>
@@ -11009,7 +11370,7 @@
           <p:cNvPr id="15" name="map-body-1">
             <a:extLst xmlns:a="http://schemas.openxmlformats.org/drawingml/2006/main">
               <a:ext uri="{FF2B5EF4-FFF2-40B4-BE49-F238E27FC236}">
-                <a16:creationId xmlns:a16="http://schemas.microsoft.com/office/drawing/2014/main" id="{D168189B-D7FB-4A3A-BDF9-D3895090EBBC}"/>
+                <a16:creationId xmlns:a16="http://schemas.microsoft.com/office/drawing/2014/main" id="{A3D6B6EE-00BA-4B63-AB1D-E859C22D9F4C}"/>
               </a:ext>
             </a:extLst>
           </p:cNvPr>
@@ -11063,7 +11424,7 @@
           <p:cNvPr id="16" name="map-2">
             <a:extLst xmlns:a="http://schemas.openxmlformats.org/drawingml/2006/main">
               <a:ext uri="{FF2B5EF4-FFF2-40B4-BE49-F238E27FC236}">
-                <a16:creationId xmlns:a16="http://schemas.microsoft.com/office/drawing/2014/main" id="{E7493912-05E5-4BE2-8405-6746E7EAFFB5}"/>
+                <a16:creationId xmlns:a16="http://schemas.microsoft.com/office/drawing/2014/main" id="{8A30C880-45E1-4609-9EDA-0D159663646F}"/>
               </a:ext>
             </a:extLst>
           </p:cNvPr>
@@ -11098,7 +11459,7 @@
           <p:cNvPr id="17" name="map-num-2">
             <a:extLst xmlns:a="http://schemas.openxmlformats.org/drawingml/2006/main">
               <a:ext uri="{FF2B5EF4-FFF2-40B4-BE49-F238E27FC236}">
-                <a16:creationId xmlns:a16="http://schemas.microsoft.com/office/drawing/2014/main" id="{842B5C57-ECD2-48B6-8352-BB089F398CA3}"/>
+                <a16:creationId xmlns:a16="http://schemas.microsoft.com/office/drawing/2014/main" id="{06DA1D34-88C3-4CDF-A43E-F7DC4B504961}"/>
               </a:ext>
             </a:extLst>
           </p:cNvPr>
@@ -11148,7 +11509,7 @@
           <p:cNvPr id="18" name="map-name-2">
             <a:extLst xmlns:a="http://schemas.openxmlformats.org/drawingml/2006/main">
               <a:ext uri="{FF2B5EF4-FFF2-40B4-BE49-F238E27FC236}">
-                <a16:creationId xmlns:a16="http://schemas.microsoft.com/office/drawing/2014/main" id="{AD834ED3-E732-4DE4-AD05-43C806CA24C4}"/>
+                <a16:creationId xmlns:a16="http://schemas.microsoft.com/office/drawing/2014/main" id="{94D8AED2-4157-4C19-AA0B-4CC23F81DF24}"/>
               </a:ext>
             </a:extLst>
           </p:cNvPr>
@@ -11198,7 +11559,7 @@
           <p:cNvPr id="19" name="map-body-2">
             <a:extLst xmlns:a="http://schemas.openxmlformats.org/drawingml/2006/main">
               <a:ext uri="{FF2B5EF4-FFF2-40B4-BE49-F238E27FC236}">
-                <a16:creationId xmlns:a16="http://schemas.microsoft.com/office/drawing/2014/main" id="{125620DE-6CB8-45A5-A8C5-A69DDA0ABD59}"/>
+                <a16:creationId xmlns:a16="http://schemas.microsoft.com/office/drawing/2014/main" id="{41A46D2A-48C0-420A-8A94-3E872E5F71C7}"/>
               </a:ext>
             </a:extLst>
           </p:cNvPr>
@@ -11252,7 +11613,7 @@
           <p:cNvPr id="20" name="map-3">
             <a:extLst xmlns:a="http://schemas.openxmlformats.org/drawingml/2006/main">
               <a:ext uri="{FF2B5EF4-FFF2-40B4-BE49-F238E27FC236}">
-                <a16:creationId xmlns:a16="http://schemas.microsoft.com/office/drawing/2014/main" id="{27F0D8A3-26F1-4ABA-928E-1356E18CCCAC}"/>
+                <a16:creationId xmlns:a16="http://schemas.microsoft.com/office/drawing/2014/main" id="{4C259CF4-D2E1-4D11-80F2-D7386ACFBE0F}"/>
               </a:ext>
             </a:extLst>
           </p:cNvPr>
@@ -11287,7 +11648,7 @@
           <p:cNvPr id="21" name="map-num-3">
             <a:extLst xmlns:a="http://schemas.openxmlformats.org/drawingml/2006/main">
               <a:ext uri="{FF2B5EF4-FFF2-40B4-BE49-F238E27FC236}">
-                <a16:creationId xmlns:a16="http://schemas.microsoft.com/office/drawing/2014/main" id="{0CBFA913-8A82-46F8-A724-251CCAC3750E}"/>
+                <a16:creationId xmlns:a16="http://schemas.microsoft.com/office/drawing/2014/main" id="{1FF5E1D0-157E-4DAD-B517-9FD895398011}"/>
               </a:ext>
             </a:extLst>
           </p:cNvPr>
@@ -11337,7 +11698,7 @@
           <p:cNvPr id="22" name="map-name-3">
             <a:extLst xmlns:a="http://schemas.openxmlformats.org/drawingml/2006/main">
               <a:ext uri="{FF2B5EF4-FFF2-40B4-BE49-F238E27FC236}">
-                <a16:creationId xmlns:a16="http://schemas.microsoft.com/office/drawing/2014/main" id="{84588DB2-6F94-40DC-8756-61D320771697}"/>
+                <a16:creationId xmlns:a16="http://schemas.microsoft.com/office/drawing/2014/main" id="{3E245304-9DFE-4520-BE9F-A722AC71FCB3}"/>
               </a:ext>
             </a:extLst>
           </p:cNvPr>
@@ -11387,7 +11748,7 @@
           <p:cNvPr id="23" name="map-body-3">
             <a:extLst xmlns:a="http://schemas.openxmlformats.org/drawingml/2006/main">
               <a:ext uri="{FF2B5EF4-FFF2-40B4-BE49-F238E27FC236}">
-                <a16:creationId xmlns:a16="http://schemas.microsoft.com/office/drawing/2014/main" id="{05F2D8F4-CBAC-4E92-BA52-AA51E4DA8338}"/>
+                <a16:creationId xmlns:a16="http://schemas.microsoft.com/office/drawing/2014/main" id="{0C5C0F28-C0D6-4033-967E-10CB238AD08F}"/>
               </a:ext>
             </a:extLst>
           </p:cNvPr>
@@ -11441,7 +11802,7 @@
           <p:cNvPr id="24" name="map-foot">
             <a:extLst xmlns:a="http://schemas.openxmlformats.org/drawingml/2006/main">
               <a:ext uri="{FF2B5EF4-FFF2-40B4-BE49-F238E27FC236}">
-                <a16:creationId xmlns:a16="http://schemas.microsoft.com/office/drawing/2014/main" id="{41C63D9A-D182-41C4-B56C-38A3B065B381}"/>
+                <a16:creationId xmlns:a16="http://schemas.microsoft.com/office/drawing/2014/main" id="{91BF29D2-E03D-4834-9693-80745AE002D0}"/>
               </a:ext>
             </a:extLst>
           </p:cNvPr>
@@ -11489,7 +11850,7 @@
     </p:spTree>
     <p:extLst>
       <p:ext uri="{BB962C8B-B14F-4D97-AF65-F5344CB8AC3E}">
-        <p14:creationId xmlns:p14="http://schemas.microsoft.com/office/powerpoint/2010/main" val="94759145"/>
+        <p14:creationId xmlns:p14="http://schemas.microsoft.com/office/powerpoint/2010/main" val="767403440"/>
       </p:ext>
     </p:extLst>
   </p:cSld>
@@ -11520,7 +11881,7 @@
           <p:cNvPr id="21" name="rail-3">
             <a:extLst xmlns:a="http://schemas.openxmlformats.org/drawingml/2006/main">
               <a:ext uri="{FF2B5EF4-FFF2-40B4-BE49-F238E27FC236}">
-                <a16:creationId xmlns:a16="http://schemas.microsoft.com/office/drawing/2014/main" id="{14EBD430-1ED8-40DE-B01A-184CC17CD11B}"/>
+                <a16:creationId xmlns:a16="http://schemas.microsoft.com/office/drawing/2014/main" id="{C448909E-28A0-414C-8694-FEE172ECCCCA}"/>
               </a:ext>
             </a:extLst>
           </p:cNvPr>
@@ -11553,7 +11914,7 @@
           <p:cNvPr id="2" name="flourish-3">
             <a:extLst xmlns:a="http://schemas.openxmlformats.org/drawingml/2006/main">
               <a:ext uri="{FF2B5EF4-FFF2-40B4-BE49-F238E27FC236}">
-                <a16:creationId xmlns:a16="http://schemas.microsoft.com/office/drawing/2014/main" id="{4BFF832F-1BDF-4413-B65C-6AD4A5047DD2}"/>
+                <a16:creationId xmlns:a16="http://schemas.microsoft.com/office/drawing/2014/main" id="{DCCC71E3-39ED-45DB-9CE4-0A8545BF57A1}"/>
               </a:ext>
             </a:extLst>
           </p:cNvPr>
@@ -11603,7 +11964,7 @@
           <p:cNvPr id="3" name="chapter-3">
             <a:extLst xmlns:a="http://schemas.openxmlformats.org/drawingml/2006/main">
               <a:ext uri="{FF2B5EF4-FFF2-40B4-BE49-F238E27FC236}">
-                <a16:creationId xmlns:a16="http://schemas.microsoft.com/office/drawing/2014/main" id="{17A1AACD-CCD3-4C1E-BCF0-C1509B97A14B}"/>
+                <a16:creationId xmlns:a16="http://schemas.microsoft.com/office/drawing/2014/main" id="{21E25124-6AC6-47F4-B99C-7FC91AC4A30A}"/>
               </a:ext>
             </a:extLst>
           </p:cNvPr>
@@ -11653,7 +12014,7 @@
           <p:cNvPr id="4" name="title-3">
             <a:extLst xmlns:a="http://schemas.openxmlformats.org/drawingml/2006/main">
               <a:ext uri="{FF2B5EF4-FFF2-40B4-BE49-F238E27FC236}">
-                <a16:creationId xmlns:a16="http://schemas.microsoft.com/office/drawing/2014/main" id="{EF88651F-7D95-4D2B-9344-FBF61EEEFDFA}"/>
+                <a16:creationId xmlns:a16="http://schemas.microsoft.com/office/drawing/2014/main" id="{D097B408-F2E6-46D8-85EB-1E08757EAA32}"/>
               </a:ext>
             </a:extLst>
           </p:cNvPr>
@@ -11703,7 +12064,7 @@
           <p:cNvPr id="5" name="subtitle-3">
             <a:extLst xmlns:a="http://schemas.openxmlformats.org/drawingml/2006/main">
               <a:ext uri="{FF2B5EF4-FFF2-40B4-BE49-F238E27FC236}">
-                <a16:creationId xmlns:a16="http://schemas.microsoft.com/office/drawing/2014/main" id="{92B55FAA-5E5A-4015-9E7E-79AC9260B4D5}"/>
+                <a16:creationId xmlns:a16="http://schemas.microsoft.com/office/drawing/2014/main" id="{58EAAD43-3D76-4FE5-A637-660949BA6C82}"/>
               </a:ext>
             </a:extLst>
           </p:cNvPr>
@@ -11753,7 +12114,7 @@
           <p:cNvPr id="6" name="">
             <a:extLst xmlns:a="http://schemas.openxmlformats.org/drawingml/2006/main">
               <a:ext uri="{FF2B5EF4-FFF2-40B4-BE49-F238E27FC236}">
-                <a16:creationId xmlns:a16="http://schemas.microsoft.com/office/drawing/2014/main" id="{0ABDCF44-E232-4807-A4D4-1BAFC3AFE5C2}"/>
+                <a16:creationId xmlns:a16="http://schemas.microsoft.com/office/drawing/2014/main" id="{3772449D-32AA-47B7-B9D0-775341E7FBF3}"/>
               </a:ext>
             </a:extLst>
           </p:cNvPr>
@@ -11784,7 +12145,7 @@
           <p:cNvPr id="7" name="page-3">
             <a:extLst xmlns:a="http://schemas.openxmlformats.org/drawingml/2006/main">
               <a:ext uri="{FF2B5EF4-FFF2-40B4-BE49-F238E27FC236}">
-                <a16:creationId xmlns:a16="http://schemas.microsoft.com/office/drawing/2014/main" id="{C46813BC-CD4F-4BDA-A8B5-4CA88CA243D7}"/>
+                <a16:creationId xmlns:a16="http://schemas.microsoft.com/office/drawing/2014/main" id="{A13779EB-600C-4D15-B9B7-7FAAC968605D}"/>
               </a:ext>
             </a:extLst>
           </p:cNvPr>
@@ -11838,7 +12199,7 @@
           <p:nvPr/>
         </p:nvPicPr>
         <p:blipFill>
-          <a:blip xmlns:r="http://schemas.openxmlformats.org/officeDocument/2006/relationships" xmlns:a="http://schemas.openxmlformats.org/drawingml/2006/main" r:embed="Radd9a3baef614888"/>
+          <a:blip xmlns:r="http://schemas.openxmlformats.org/officeDocument/2006/relationships" xmlns:a="http://schemas.openxmlformats.org/drawingml/2006/main" r:embed="R1386b6d36b3142a5"/>
           <a:stretch xmlns:a="http://schemas.openxmlformats.org/drawingml/2006/main"/>
         </p:blipFill>
         <p:spPr>
@@ -11856,7 +12217,7 @@
           <p:cNvPr id="9" name="">
             <a:extLst xmlns:a="http://schemas.openxmlformats.org/drawingml/2006/main">
               <a:ext uri="{FF2B5EF4-FFF2-40B4-BE49-F238E27FC236}">
-                <a16:creationId xmlns:a16="http://schemas.microsoft.com/office/drawing/2014/main" id="{75771650-356C-4417-BB5F-82AEA2A3942F}"/>
+                <a16:creationId xmlns:a16="http://schemas.microsoft.com/office/drawing/2014/main" id="{11BA1D3D-2E4B-4649-B036-99C776B916F9}"/>
               </a:ext>
             </a:extLst>
           </p:cNvPr>
@@ -11887,7 +12248,7 @@
           <p:cNvPr id="10" name="paper-k-0">
             <a:extLst xmlns:a="http://schemas.openxmlformats.org/drawingml/2006/main">
               <a:ext uri="{FF2B5EF4-FFF2-40B4-BE49-F238E27FC236}">
-                <a16:creationId xmlns:a16="http://schemas.microsoft.com/office/drawing/2014/main" id="{4E192D67-969D-4DEA-BC14-C374B2F8264A}"/>
+                <a16:creationId xmlns:a16="http://schemas.microsoft.com/office/drawing/2014/main" id="{61B6BDF8-BC3A-4BF8-89E2-9405A57CE6E0}"/>
               </a:ext>
             </a:extLst>
           </p:cNvPr>
@@ -11937,7 +12298,7 @@
           <p:cNvPr id="11" name="paper-v-0">
             <a:extLst xmlns:a="http://schemas.openxmlformats.org/drawingml/2006/main">
               <a:ext uri="{FF2B5EF4-FFF2-40B4-BE49-F238E27FC236}">
-                <a16:creationId xmlns:a16="http://schemas.microsoft.com/office/drawing/2014/main" id="{F1D94B29-D9C5-4FCC-B9D5-298C85E2CC49}"/>
+                <a16:creationId xmlns:a16="http://schemas.microsoft.com/office/drawing/2014/main" id="{1DBC807D-0031-479E-BA24-DD96FC4532BC}"/>
               </a:ext>
             </a:extLst>
           </p:cNvPr>
@@ -11987,7 +12348,7 @@
           <p:cNvPr id="12" name="">
             <a:extLst xmlns:a="http://schemas.openxmlformats.org/drawingml/2006/main">
               <a:ext uri="{FF2B5EF4-FFF2-40B4-BE49-F238E27FC236}">
-                <a16:creationId xmlns:a16="http://schemas.microsoft.com/office/drawing/2014/main" id="{52CF862F-4F23-4D39-AADC-C533D4AB34BB}"/>
+                <a16:creationId xmlns:a16="http://schemas.microsoft.com/office/drawing/2014/main" id="{D3E3C497-6685-419A-BD8B-D013D5083E3F}"/>
               </a:ext>
             </a:extLst>
           </p:cNvPr>
@@ -12018,7 +12379,7 @@
           <p:cNvPr id="13" name="paper-k-1">
             <a:extLst xmlns:a="http://schemas.openxmlformats.org/drawingml/2006/main">
               <a:ext uri="{FF2B5EF4-FFF2-40B4-BE49-F238E27FC236}">
-                <a16:creationId xmlns:a16="http://schemas.microsoft.com/office/drawing/2014/main" id="{943D1EFB-0BB8-47ED-818A-6C664745829E}"/>
+                <a16:creationId xmlns:a16="http://schemas.microsoft.com/office/drawing/2014/main" id="{ABE7734A-0590-4C50-A826-5B46543B2E51}"/>
               </a:ext>
             </a:extLst>
           </p:cNvPr>
@@ -12068,7 +12429,7 @@
           <p:cNvPr id="14" name="paper-v-1">
             <a:extLst xmlns:a="http://schemas.openxmlformats.org/drawingml/2006/main">
               <a:ext uri="{FF2B5EF4-FFF2-40B4-BE49-F238E27FC236}">
-                <a16:creationId xmlns:a16="http://schemas.microsoft.com/office/drawing/2014/main" id="{1B1AD8E6-6CAF-41B8-9B5E-8A95E5185815}"/>
+                <a16:creationId xmlns:a16="http://schemas.microsoft.com/office/drawing/2014/main" id="{C7344D9A-1BD7-4918-87CA-A9A81FFF960C}"/>
               </a:ext>
             </a:extLst>
           </p:cNvPr>
@@ -12118,7 +12479,7 @@
           <p:cNvPr id="15" name="">
             <a:extLst xmlns:a="http://schemas.openxmlformats.org/drawingml/2006/main">
               <a:ext uri="{FF2B5EF4-FFF2-40B4-BE49-F238E27FC236}">
-                <a16:creationId xmlns:a16="http://schemas.microsoft.com/office/drawing/2014/main" id="{17F21CBB-C933-4934-A726-7DBDDAE7651E}"/>
+                <a16:creationId xmlns:a16="http://schemas.microsoft.com/office/drawing/2014/main" id="{6A949409-DCBB-4153-95B7-0F70397B1C5E}"/>
               </a:ext>
             </a:extLst>
           </p:cNvPr>
@@ -12149,7 +12510,7 @@
           <p:cNvPr id="16" name="paper-k-2">
             <a:extLst xmlns:a="http://schemas.openxmlformats.org/drawingml/2006/main">
               <a:ext uri="{FF2B5EF4-FFF2-40B4-BE49-F238E27FC236}">
-                <a16:creationId xmlns:a16="http://schemas.microsoft.com/office/drawing/2014/main" id="{A76499DA-FDE8-4837-BD0D-A1ED09CBBBCB}"/>
+                <a16:creationId xmlns:a16="http://schemas.microsoft.com/office/drawing/2014/main" id="{F50E3CF7-9814-48D5-9A03-F4389A7D57DD}"/>
               </a:ext>
             </a:extLst>
           </p:cNvPr>
@@ -12199,7 +12560,7 @@
           <p:cNvPr id="17" name="paper-v-2">
             <a:extLst xmlns:a="http://schemas.openxmlformats.org/drawingml/2006/main">
               <a:ext uri="{FF2B5EF4-FFF2-40B4-BE49-F238E27FC236}">
-                <a16:creationId xmlns:a16="http://schemas.microsoft.com/office/drawing/2014/main" id="{2A1E1737-2F14-4B8A-9948-24F70E51B7EF}"/>
+                <a16:creationId xmlns:a16="http://schemas.microsoft.com/office/drawing/2014/main" id="{190A7723-DFBB-4753-9FE9-1E162698CE7A}"/>
               </a:ext>
             </a:extLst>
           </p:cNvPr>
@@ -12249,7 +12610,7 @@
           <p:cNvPr id="18" name="">
             <a:extLst xmlns:a="http://schemas.openxmlformats.org/drawingml/2006/main">
               <a:ext uri="{FF2B5EF4-FFF2-40B4-BE49-F238E27FC236}">
-                <a16:creationId xmlns:a16="http://schemas.microsoft.com/office/drawing/2014/main" id="{920946B0-50B0-492D-9B77-A0F56876B66A}"/>
+                <a16:creationId xmlns:a16="http://schemas.microsoft.com/office/drawing/2014/main" id="{B1225BEF-6AC0-4589-8A08-5761BE4C2F87}"/>
               </a:ext>
             </a:extLst>
           </p:cNvPr>
@@ -12280,7 +12641,7 @@
           <p:cNvPr id="19" name="paper-k-3">
             <a:extLst xmlns:a="http://schemas.openxmlformats.org/drawingml/2006/main">
               <a:ext uri="{FF2B5EF4-FFF2-40B4-BE49-F238E27FC236}">
-                <a16:creationId xmlns:a16="http://schemas.microsoft.com/office/drawing/2014/main" id="{73358AF8-423E-43D7-9118-E46275471CFF}"/>
+                <a16:creationId xmlns:a16="http://schemas.microsoft.com/office/drawing/2014/main" id="{E4AA910C-1384-4344-96A1-04ADFB40836C}"/>
               </a:ext>
             </a:extLst>
           </p:cNvPr>
@@ -12330,7 +12691,7 @@
           <p:cNvPr id="20" name="paper-v-3">
             <a:extLst xmlns:a="http://schemas.openxmlformats.org/drawingml/2006/main">
               <a:ext uri="{FF2B5EF4-FFF2-40B4-BE49-F238E27FC236}">
-                <a16:creationId xmlns:a16="http://schemas.microsoft.com/office/drawing/2014/main" id="{D9C18988-2B4D-4B45-AD1C-9A34007FB7F4}"/>
+                <a16:creationId xmlns:a16="http://schemas.microsoft.com/office/drawing/2014/main" id="{D8264B1B-4B80-41CF-9E5F-972CED1FDF46}"/>
               </a:ext>
             </a:extLst>
           </p:cNvPr>
@@ -12378,7 +12739,7 @@
     </p:spTree>
     <p:extLst>
       <p:ext uri="{BB962C8B-B14F-4D97-AF65-F5344CB8AC3E}">
-        <p14:creationId xmlns:p14="http://schemas.microsoft.com/office/powerpoint/2010/main" val="2015676381"/>
+        <p14:creationId xmlns:p14="http://schemas.microsoft.com/office/powerpoint/2010/main" val="1165520447"/>
       </p:ext>
     </p:extLst>
   </p:cSld>
@@ -12409,7 +12770,7 @@
           <p:cNvPr id="40" name="rail-4">
             <a:extLst xmlns:a="http://schemas.openxmlformats.org/drawingml/2006/main">
               <a:ext uri="{FF2B5EF4-FFF2-40B4-BE49-F238E27FC236}">
-                <a16:creationId xmlns:a16="http://schemas.microsoft.com/office/drawing/2014/main" id="{588669C9-DB02-4493-A0D7-538E265E2856}"/>
+                <a16:creationId xmlns:a16="http://schemas.microsoft.com/office/drawing/2014/main" id="{FAB719B0-85F2-4363-8124-EF4D433F5CAC}"/>
               </a:ext>
             </a:extLst>
           </p:cNvPr>
@@ -12442,7 +12803,7 @@
           <p:cNvPr id="2" name="flourish-4">
             <a:extLst xmlns:a="http://schemas.openxmlformats.org/drawingml/2006/main">
               <a:ext uri="{FF2B5EF4-FFF2-40B4-BE49-F238E27FC236}">
-                <a16:creationId xmlns:a16="http://schemas.microsoft.com/office/drawing/2014/main" id="{78A3B7C3-02A1-4D96-9863-A908B8FB449E}"/>
+                <a16:creationId xmlns:a16="http://schemas.microsoft.com/office/drawing/2014/main" id="{60463ABC-548E-4F09-9B89-8F51FCD3DD89}"/>
               </a:ext>
             </a:extLst>
           </p:cNvPr>
@@ -12492,7 +12853,7 @@
           <p:cNvPr id="3" name="chapter-4">
             <a:extLst xmlns:a="http://schemas.openxmlformats.org/drawingml/2006/main">
               <a:ext uri="{FF2B5EF4-FFF2-40B4-BE49-F238E27FC236}">
-                <a16:creationId xmlns:a16="http://schemas.microsoft.com/office/drawing/2014/main" id="{DAB71A8A-BF1B-4E3B-9BA9-28A3D432F28C}"/>
+                <a16:creationId xmlns:a16="http://schemas.microsoft.com/office/drawing/2014/main" id="{0B7E107C-D828-4592-91F1-B5A10D0E3764}"/>
               </a:ext>
             </a:extLst>
           </p:cNvPr>
@@ -12542,7 +12903,7 @@
           <p:cNvPr id="4" name="title-4">
             <a:extLst xmlns:a="http://schemas.openxmlformats.org/drawingml/2006/main">
               <a:ext uri="{FF2B5EF4-FFF2-40B4-BE49-F238E27FC236}">
-                <a16:creationId xmlns:a16="http://schemas.microsoft.com/office/drawing/2014/main" id="{B228C582-AAA7-4E46-AC5C-E01863B7CCB8}"/>
+                <a16:creationId xmlns:a16="http://schemas.microsoft.com/office/drawing/2014/main" id="{07B1BC35-DB75-4FCA-B2A1-23F2D81C393E}"/>
               </a:ext>
             </a:extLst>
           </p:cNvPr>
@@ -12592,7 +12953,7 @@
           <p:cNvPr id="5" name="subtitle-4">
             <a:extLst xmlns:a="http://schemas.openxmlformats.org/drawingml/2006/main">
               <a:ext uri="{FF2B5EF4-FFF2-40B4-BE49-F238E27FC236}">
-                <a16:creationId xmlns:a16="http://schemas.microsoft.com/office/drawing/2014/main" id="{D8DD4F4F-6BBA-49B1-BFDB-60A87F184138}"/>
+                <a16:creationId xmlns:a16="http://schemas.microsoft.com/office/drawing/2014/main" id="{AA639F36-EC26-45CA-815E-05D7CF18FBD8}"/>
               </a:ext>
             </a:extLst>
           </p:cNvPr>
@@ -12642,7 +13003,7 @@
           <p:cNvPr id="6" name="">
             <a:extLst xmlns:a="http://schemas.openxmlformats.org/drawingml/2006/main">
               <a:ext uri="{FF2B5EF4-FFF2-40B4-BE49-F238E27FC236}">
-                <a16:creationId xmlns:a16="http://schemas.microsoft.com/office/drawing/2014/main" id="{33D3D404-4E90-469C-B05B-1B8CD5297778}"/>
+                <a16:creationId xmlns:a16="http://schemas.microsoft.com/office/drawing/2014/main" id="{A0BBA86D-C373-47A7-A3C3-AC07D7DAA3E4}"/>
               </a:ext>
             </a:extLst>
           </p:cNvPr>
@@ -12673,7 +13034,7 @@
           <p:cNvPr id="7" name="page-4">
             <a:extLst xmlns:a="http://schemas.openxmlformats.org/drawingml/2006/main">
               <a:ext uri="{FF2B5EF4-FFF2-40B4-BE49-F238E27FC236}">
-                <a16:creationId xmlns:a16="http://schemas.microsoft.com/office/drawing/2014/main" id="{4A42D60B-B7F5-4972-9327-8BBCA348FBE2}"/>
+                <a16:creationId xmlns:a16="http://schemas.microsoft.com/office/drawing/2014/main" id="{3402E95D-BA0D-4C28-A277-E1AB804B5C7E}"/>
               </a:ext>
             </a:extLst>
           </p:cNvPr>
@@ -12723,7 +13084,7 @@
           <p:cNvPr id="8" name="">
             <a:extLst xmlns:a="http://schemas.openxmlformats.org/drawingml/2006/main">
               <a:ext uri="{FF2B5EF4-FFF2-40B4-BE49-F238E27FC236}">
-                <a16:creationId xmlns:a16="http://schemas.microsoft.com/office/drawing/2014/main" id="{5F7B6185-15AE-459D-88F2-C7C65681A9FC}"/>
+                <a16:creationId xmlns:a16="http://schemas.microsoft.com/office/drawing/2014/main" id="{E6895FA1-FD8F-4ABF-9951-E030CF0B1809}"/>
               </a:ext>
             </a:extLst>
           </p:cNvPr>
@@ -12754,7 +13115,7 @@
           <p:cNvPr id="9" name="">
             <a:extLst xmlns:a="http://schemas.openxmlformats.org/drawingml/2006/main">
               <a:ext uri="{FF2B5EF4-FFF2-40B4-BE49-F238E27FC236}">
-                <a16:creationId xmlns:a16="http://schemas.microsoft.com/office/drawing/2014/main" id="{2D463DB2-37FA-40A7-BFA9-345D02252A75}"/>
+                <a16:creationId xmlns:a16="http://schemas.microsoft.com/office/drawing/2014/main" id="{89937483-2027-4B14-B0F1-FD893443E731}"/>
               </a:ext>
             </a:extLst>
           </p:cNvPr>
@@ -12785,7 +13146,7 @@
           <p:cNvPr id="10" name="">
             <a:extLst xmlns:a="http://schemas.openxmlformats.org/drawingml/2006/main">
               <a:ext uri="{FF2B5EF4-FFF2-40B4-BE49-F238E27FC236}">
-                <a16:creationId xmlns:a16="http://schemas.microsoft.com/office/drawing/2014/main" id="{16AB56DE-84A4-444D-B75C-C69C9CCE560D}"/>
+                <a16:creationId xmlns:a16="http://schemas.microsoft.com/office/drawing/2014/main" id="{0C03178C-BFBF-432D-9B3B-43F352AFF7BD}"/>
               </a:ext>
             </a:extLst>
           </p:cNvPr>
@@ -12816,7 +13177,7 @@
           <p:cNvPr id="11" name="">
             <a:extLst xmlns:a="http://schemas.openxmlformats.org/drawingml/2006/main">
               <a:ext uri="{FF2B5EF4-FFF2-40B4-BE49-F238E27FC236}">
-                <a16:creationId xmlns:a16="http://schemas.microsoft.com/office/drawing/2014/main" id="{24B8291A-DCC8-4571-830E-733CB84EF1EE}"/>
+                <a16:creationId xmlns:a16="http://schemas.microsoft.com/office/drawing/2014/main" id="{90BC699F-0C80-4F25-AB5D-DC69D0806636}"/>
               </a:ext>
             </a:extLst>
           </p:cNvPr>
@@ -12847,7 +13208,7 @@
           <p:cNvPr id="12" name="arch-0">
             <a:extLst xmlns:a="http://schemas.openxmlformats.org/drawingml/2006/main">
               <a:ext uri="{FF2B5EF4-FFF2-40B4-BE49-F238E27FC236}">
-                <a16:creationId xmlns:a16="http://schemas.microsoft.com/office/drawing/2014/main" id="{14924BCD-5D81-4D54-AB19-6ABFCB3BB668}"/>
+                <a16:creationId xmlns:a16="http://schemas.microsoft.com/office/drawing/2014/main" id="{D3CA13E0-9865-4AEC-A9E8-DD744A27702F}"/>
               </a:ext>
             </a:extLst>
           </p:cNvPr>
@@ -12882,7 +13243,7 @@
           <p:cNvPr id="13" name="arch-k-0">
             <a:extLst xmlns:a="http://schemas.openxmlformats.org/drawingml/2006/main">
               <a:ext uri="{FF2B5EF4-FFF2-40B4-BE49-F238E27FC236}">
-                <a16:creationId xmlns:a16="http://schemas.microsoft.com/office/drawing/2014/main" id="{CBEA8915-D124-4511-979D-98B45C320210}"/>
+                <a16:creationId xmlns:a16="http://schemas.microsoft.com/office/drawing/2014/main" id="{3FCFB56F-EA43-452D-87F7-631C47F784C6}"/>
               </a:ext>
             </a:extLst>
           </p:cNvPr>
@@ -12932,7 +13293,7 @@
           <p:cNvPr id="14" name="arch-v-0">
             <a:extLst xmlns:a="http://schemas.openxmlformats.org/drawingml/2006/main">
               <a:ext uri="{FF2B5EF4-FFF2-40B4-BE49-F238E27FC236}">
-                <a16:creationId xmlns:a16="http://schemas.microsoft.com/office/drawing/2014/main" id="{08263594-99AA-454A-80F7-F17493DFE61E}"/>
+                <a16:creationId xmlns:a16="http://schemas.microsoft.com/office/drawing/2014/main" id="{BBB7A0D7-58A8-490B-9CC1-23F6D5CB246F}"/>
               </a:ext>
             </a:extLst>
           </p:cNvPr>
@@ -12982,7 +13343,7 @@
           <p:cNvPr id="15" name="arch-1">
             <a:extLst xmlns:a="http://schemas.openxmlformats.org/drawingml/2006/main">
               <a:ext uri="{FF2B5EF4-FFF2-40B4-BE49-F238E27FC236}">
-                <a16:creationId xmlns:a16="http://schemas.microsoft.com/office/drawing/2014/main" id="{2E7012E5-E512-4B92-992D-65E85FEC7AAB}"/>
+                <a16:creationId xmlns:a16="http://schemas.microsoft.com/office/drawing/2014/main" id="{FAD12B50-2D09-4C7C-A6CB-5BF72E3F6222}"/>
               </a:ext>
             </a:extLst>
           </p:cNvPr>
@@ -13017,7 +13378,7 @@
           <p:cNvPr id="16" name="arch-k-1">
             <a:extLst xmlns:a="http://schemas.openxmlformats.org/drawingml/2006/main">
               <a:ext uri="{FF2B5EF4-FFF2-40B4-BE49-F238E27FC236}">
-                <a16:creationId xmlns:a16="http://schemas.microsoft.com/office/drawing/2014/main" id="{A337F2BC-522E-418C-9649-96505B44E996}"/>
+                <a16:creationId xmlns:a16="http://schemas.microsoft.com/office/drawing/2014/main" id="{9132A5E1-BB5A-4F9A-AB0B-6C33D4793F32}"/>
               </a:ext>
             </a:extLst>
           </p:cNvPr>
@@ -13067,7 +13428,7 @@
           <p:cNvPr id="17" name="arch-v-1">
             <a:extLst xmlns:a="http://schemas.openxmlformats.org/drawingml/2006/main">
               <a:ext uri="{FF2B5EF4-FFF2-40B4-BE49-F238E27FC236}">
-                <a16:creationId xmlns:a16="http://schemas.microsoft.com/office/drawing/2014/main" id="{4BF46644-2B63-4452-9862-569668D5092B}"/>
+                <a16:creationId xmlns:a16="http://schemas.microsoft.com/office/drawing/2014/main" id="{59626A19-12F3-4B9F-929D-603C5DE48CC5}"/>
               </a:ext>
             </a:extLst>
           </p:cNvPr>
@@ -13134,7 +13495,7 @@
           <p:cNvPr id="18" name="arch-2">
             <a:extLst xmlns:a="http://schemas.openxmlformats.org/drawingml/2006/main">
               <a:ext uri="{FF2B5EF4-FFF2-40B4-BE49-F238E27FC236}">
-                <a16:creationId xmlns:a16="http://schemas.microsoft.com/office/drawing/2014/main" id="{C64D1B21-FA90-4377-9F72-F61848414D34}"/>
+                <a16:creationId xmlns:a16="http://schemas.microsoft.com/office/drawing/2014/main" id="{8624BF6A-0E77-4806-AF44-61C3366C4A26}"/>
               </a:ext>
             </a:extLst>
           </p:cNvPr>
@@ -13169,7 +13530,7 @@
           <p:cNvPr id="19" name="arch-k-2">
             <a:extLst xmlns:a="http://schemas.openxmlformats.org/drawingml/2006/main">
               <a:ext uri="{FF2B5EF4-FFF2-40B4-BE49-F238E27FC236}">
-                <a16:creationId xmlns:a16="http://schemas.microsoft.com/office/drawing/2014/main" id="{CD98464F-4943-4D02-92C8-A415FE505D6E}"/>
+                <a16:creationId xmlns:a16="http://schemas.microsoft.com/office/drawing/2014/main" id="{785D45FB-1638-471F-B0CC-8394C2B7802B}"/>
               </a:ext>
             </a:extLst>
           </p:cNvPr>
@@ -13219,7 +13580,7 @@
           <p:cNvPr id="20" name="arch-v-2">
             <a:extLst xmlns:a="http://schemas.openxmlformats.org/drawingml/2006/main">
               <a:ext uri="{FF2B5EF4-FFF2-40B4-BE49-F238E27FC236}">
-                <a16:creationId xmlns:a16="http://schemas.microsoft.com/office/drawing/2014/main" id="{88B29030-693A-4BF1-AD88-65D5A3A401EA}"/>
+                <a16:creationId xmlns:a16="http://schemas.microsoft.com/office/drawing/2014/main" id="{C474FD7E-CC52-4D0E-BEC8-C5FCB1BD03BB}"/>
               </a:ext>
             </a:extLst>
           </p:cNvPr>
@@ -13286,7 +13647,7 @@
           <p:cNvPr id="21" name="arch-3">
             <a:extLst xmlns:a="http://schemas.openxmlformats.org/drawingml/2006/main">
               <a:ext uri="{FF2B5EF4-FFF2-40B4-BE49-F238E27FC236}">
-                <a16:creationId xmlns:a16="http://schemas.microsoft.com/office/drawing/2014/main" id="{877845EC-B627-464D-8310-B8135E8F8FAF}"/>
+                <a16:creationId xmlns:a16="http://schemas.microsoft.com/office/drawing/2014/main" id="{517E08CB-9B91-4A77-B7DE-F01566E7B80A}"/>
               </a:ext>
             </a:extLst>
           </p:cNvPr>
@@ -13321,7 +13682,7 @@
           <p:cNvPr id="22" name="arch-k-3">
             <a:extLst xmlns:a="http://schemas.openxmlformats.org/drawingml/2006/main">
               <a:ext uri="{FF2B5EF4-FFF2-40B4-BE49-F238E27FC236}">
-                <a16:creationId xmlns:a16="http://schemas.microsoft.com/office/drawing/2014/main" id="{A47A0070-8FE6-4649-AF09-76006CA512AD}"/>
+                <a16:creationId xmlns:a16="http://schemas.microsoft.com/office/drawing/2014/main" id="{2E9252F8-AAD8-4349-BD10-E80BE82A287B}"/>
               </a:ext>
             </a:extLst>
           </p:cNvPr>
@@ -13371,7 +13732,7 @@
           <p:cNvPr id="23" name="arch-v-3">
             <a:extLst xmlns:a="http://schemas.openxmlformats.org/drawingml/2006/main">
               <a:ext uri="{FF2B5EF4-FFF2-40B4-BE49-F238E27FC236}">
-                <a16:creationId xmlns:a16="http://schemas.microsoft.com/office/drawing/2014/main" id="{D22B7718-E33A-4A3A-8805-694792D37079}"/>
+                <a16:creationId xmlns:a16="http://schemas.microsoft.com/office/drawing/2014/main" id="{16230A77-0D4C-4CE0-A8EC-73E25E6245E0}"/>
               </a:ext>
             </a:extLst>
           </p:cNvPr>
@@ -13438,7 +13799,7 @@
           <p:cNvPr id="24" name="arch-4">
             <a:extLst xmlns:a="http://schemas.openxmlformats.org/drawingml/2006/main">
               <a:ext uri="{FF2B5EF4-FFF2-40B4-BE49-F238E27FC236}">
-                <a16:creationId xmlns:a16="http://schemas.microsoft.com/office/drawing/2014/main" id="{301427D7-580D-4866-AE12-F434C7820624}"/>
+                <a16:creationId xmlns:a16="http://schemas.microsoft.com/office/drawing/2014/main" id="{9AC39F44-B52E-44CD-A554-3398CE8F6F2B}"/>
               </a:ext>
             </a:extLst>
           </p:cNvPr>
@@ -13473,7 +13834,7 @@
           <p:cNvPr id="25" name="arch-k-4">
             <a:extLst xmlns:a="http://schemas.openxmlformats.org/drawingml/2006/main">
               <a:ext uri="{FF2B5EF4-FFF2-40B4-BE49-F238E27FC236}">
-                <a16:creationId xmlns:a16="http://schemas.microsoft.com/office/drawing/2014/main" id="{B73DC8C2-452D-4602-9114-61416BAA9760}"/>
+                <a16:creationId xmlns:a16="http://schemas.microsoft.com/office/drawing/2014/main" id="{576E9E7D-927A-4669-A74D-6C5DF765AF84}"/>
               </a:ext>
             </a:extLst>
           </p:cNvPr>
@@ -13523,7 +13884,7 @@
           <p:cNvPr id="26" name="arch-v-4">
             <a:extLst xmlns:a="http://schemas.openxmlformats.org/drawingml/2006/main">
               <a:ext uri="{FF2B5EF4-FFF2-40B4-BE49-F238E27FC236}">
-                <a16:creationId xmlns:a16="http://schemas.microsoft.com/office/drawing/2014/main" id="{A81E2F08-6E6B-4254-99D8-806B008AB344}"/>
+                <a16:creationId xmlns:a16="http://schemas.microsoft.com/office/drawing/2014/main" id="{3C8944B6-4514-497B-A64A-52B1B10AA9F5}"/>
               </a:ext>
             </a:extLst>
           </p:cNvPr>
@@ -13590,7 +13951,7 @@
           <p:cNvPr id="27" name="arch-loop">
             <a:extLst xmlns:a="http://schemas.openxmlformats.org/drawingml/2006/main">
               <a:ext uri="{FF2B5EF4-FFF2-40B4-BE49-F238E27FC236}">
-                <a16:creationId xmlns:a16="http://schemas.microsoft.com/office/drawing/2014/main" id="{223B8CE2-F957-4B74-B362-77AB82FFD73A}"/>
+                <a16:creationId xmlns:a16="http://schemas.microsoft.com/office/drawing/2014/main" id="{FB9F1A31-55D0-4BC3-9295-81B3FD23A254}"/>
               </a:ext>
             </a:extLst>
           </p:cNvPr>
@@ -13640,7 +14001,7 @@
           <p:cNvPr id="28" name="">
             <a:extLst xmlns:a="http://schemas.openxmlformats.org/drawingml/2006/main">
               <a:ext uri="{FF2B5EF4-FFF2-40B4-BE49-F238E27FC236}">
-                <a16:creationId xmlns:a16="http://schemas.microsoft.com/office/drawing/2014/main" id="{B6ACEB31-24A3-41B1-BCF8-A85950D98DEB}"/>
+                <a16:creationId xmlns:a16="http://schemas.microsoft.com/office/drawing/2014/main" id="{301F6B2D-F5D4-43B7-8681-463C4874B519}"/>
               </a:ext>
             </a:extLst>
           </p:cNvPr>
@@ -13671,7 +14032,7 @@
           <p:cNvPr id="29" name="arch-tools-value">
             <a:extLst xmlns:a="http://schemas.openxmlformats.org/drawingml/2006/main">
               <a:ext uri="{FF2B5EF4-FFF2-40B4-BE49-F238E27FC236}">
-                <a16:creationId xmlns:a16="http://schemas.microsoft.com/office/drawing/2014/main" id="{545A30A7-99DB-4C47-A589-CD1D360A64DC}"/>
+                <a16:creationId xmlns:a16="http://schemas.microsoft.com/office/drawing/2014/main" id="{152113FD-B70B-4EE6-8895-77F9336D895B}"/>
               </a:ext>
             </a:extLst>
           </p:cNvPr>
@@ -13721,7 +14082,7 @@
           <p:cNvPr id="30" name="arch-tools-label">
             <a:extLst xmlns:a="http://schemas.openxmlformats.org/drawingml/2006/main">
               <a:ext uri="{FF2B5EF4-FFF2-40B4-BE49-F238E27FC236}">
-                <a16:creationId xmlns:a16="http://schemas.microsoft.com/office/drawing/2014/main" id="{603BD7EA-3143-47D6-A549-F00664AF229E}"/>
+                <a16:creationId xmlns:a16="http://schemas.microsoft.com/office/drawing/2014/main" id="{16117018-2EF4-49BC-8688-D53D0A28E536}"/>
               </a:ext>
             </a:extLst>
           </p:cNvPr>
@@ -13771,7 +14132,7 @@
           <p:cNvPr id="31" name="">
             <a:extLst xmlns:a="http://schemas.openxmlformats.org/drawingml/2006/main">
               <a:ext uri="{FF2B5EF4-FFF2-40B4-BE49-F238E27FC236}">
-                <a16:creationId xmlns:a16="http://schemas.microsoft.com/office/drawing/2014/main" id="{7484981D-1F04-4264-BE74-3826E1F344CB}"/>
+                <a16:creationId xmlns:a16="http://schemas.microsoft.com/office/drawing/2014/main" id="{25C91793-514F-405C-BF99-5A4C5F64E83F}"/>
               </a:ext>
             </a:extLst>
           </p:cNvPr>
@@ -13802,7 +14163,7 @@
           <p:cNvPr id="32" name="arch-group-value">
             <a:extLst xmlns:a="http://schemas.openxmlformats.org/drawingml/2006/main">
               <a:ext uri="{FF2B5EF4-FFF2-40B4-BE49-F238E27FC236}">
-                <a16:creationId xmlns:a16="http://schemas.microsoft.com/office/drawing/2014/main" id="{CEEB4AB8-EE32-4421-AE4A-90A78D8B96A9}"/>
+                <a16:creationId xmlns:a16="http://schemas.microsoft.com/office/drawing/2014/main" id="{B3FAD89E-BDDA-4BF7-9BB9-26861AA0DC10}"/>
               </a:ext>
             </a:extLst>
           </p:cNvPr>
@@ -13852,7 +14213,7 @@
           <p:cNvPr id="33" name="arch-group-label">
             <a:extLst xmlns:a="http://schemas.openxmlformats.org/drawingml/2006/main">
               <a:ext uri="{FF2B5EF4-FFF2-40B4-BE49-F238E27FC236}">
-                <a16:creationId xmlns:a16="http://schemas.microsoft.com/office/drawing/2014/main" id="{8046CB6B-E89B-4359-9B04-AAAAE544A4F1}"/>
+                <a16:creationId xmlns:a16="http://schemas.microsoft.com/office/drawing/2014/main" id="{518AB7B6-A619-4926-B9F7-1D34B12AB560}"/>
               </a:ext>
             </a:extLst>
           </p:cNvPr>
@@ -13902,7 +14263,7 @@
           <p:cNvPr id="34" name="">
             <a:extLst xmlns:a="http://schemas.openxmlformats.org/drawingml/2006/main">
               <a:ext uri="{FF2B5EF4-FFF2-40B4-BE49-F238E27FC236}">
-                <a16:creationId xmlns:a16="http://schemas.microsoft.com/office/drawing/2014/main" id="{2842E2F8-A32C-44C1-95B0-636201624C06}"/>
+                <a16:creationId xmlns:a16="http://schemas.microsoft.com/office/drawing/2014/main" id="{A2473A35-E148-4D3A-83FD-5D1BA9031450}"/>
               </a:ext>
             </a:extLst>
           </p:cNvPr>
@@ -13933,7 +14294,7 @@
           <p:cNvPr id="35" name="arch-max-value">
             <a:extLst xmlns:a="http://schemas.openxmlformats.org/drawingml/2006/main">
               <a:ext uri="{FF2B5EF4-FFF2-40B4-BE49-F238E27FC236}">
-                <a16:creationId xmlns:a16="http://schemas.microsoft.com/office/drawing/2014/main" id="{3AFC8C1F-61AA-4851-9A03-D5321C652605}"/>
+                <a16:creationId xmlns:a16="http://schemas.microsoft.com/office/drawing/2014/main" id="{B81FD465-2588-468D-860B-E6232836F653}"/>
               </a:ext>
             </a:extLst>
           </p:cNvPr>
@@ -13983,7 +14344,7 @@
           <p:cNvPr id="36" name="arch-max-label">
             <a:extLst xmlns:a="http://schemas.openxmlformats.org/drawingml/2006/main">
               <a:ext uri="{FF2B5EF4-FFF2-40B4-BE49-F238E27FC236}">
-                <a16:creationId xmlns:a16="http://schemas.microsoft.com/office/drawing/2014/main" id="{7C4990C8-66E3-43FE-8D74-47EB35E2DABB}"/>
+                <a16:creationId xmlns:a16="http://schemas.microsoft.com/office/drawing/2014/main" id="{D6365DC1-2AC2-4647-8154-E32235075A18}"/>
               </a:ext>
             </a:extLst>
           </p:cNvPr>
@@ -14033,7 +14394,7 @@
           <p:cNvPr id="37" name="">
             <a:extLst xmlns:a="http://schemas.openxmlformats.org/drawingml/2006/main">
               <a:ext uri="{FF2B5EF4-FFF2-40B4-BE49-F238E27FC236}">
-                <a16:creationId xmlns:a16="http://schemas.microsoft.com/office/drawing/2014/main" id="{1BE631E6-9713-4358-AC41-91F79D49A9C3}"/>
+                <a16:creationId xmlns:a16="http://schemas.microsoft.com/office/drawing/2014/main" id="{CBD4A62C-9A56-4049-ACCD-5CCF63B39A6C}"/>
               </a:ext>
             </a:extLst>
           </p:cNvPr>
@@ -14064,7 +14425,7 @@
           <p:cNvPr id="38" name="arch-token-value">
             <a:extLst xmlns:a="http://schemas.openxmlformats.org/drawingml/2006/main">
               <a:ext uri="{FF2B5EF4-FFF2-40B4-BE49-F238E27FC236}">
-                <a16:creationId xmlns:a16="http://schemas.microsoft.com/office/drawing/2014/main" id="{7510D2DD-2F8F-4BBF-BB58-7AF9C4A5C412}"/>
+                <a16:creationId xmlns:a16="http://schemas.microsoft.com/office/drawing/2014/main" id="{4F969F96-6DA3-4E18-B6B2-50D0B6B54B15}"/>
               </a:ext>
             </a:extLst>
           </p:cNvPr>
@@ -14114,7 +14475,7 @@
           <p:cNvPr id="39" name="arch-token-label">
             <a:extLst xmlns:a="http://schemas.openxmlformats.org/drawingml/2006/main">
               <a:ext uri="{FF2B5EF4-FFF2-40B4-BE49-F238E27FC236}">
-                <a16:creationId xmlns:a16="http://schemas.microsoft.com/office/drawing/2014/main" id="{425EB80B-744E-41CC-BFAC-04F2B2E7D14E}"/>
+                <a16:creationId xmlns:a16="http://schemas.microsoft.com/office/drawing/2014/main" id="{6FFE486E-FAEB-400D-B1ED-C55CA4688AB4}"/>
               </a:ext>
             </a:extLst>
           </p:cNvPr>
@@ -14162,7 +14523,7 @@
     </p:spTree>
     <p:extLst>
       <p:ext uri="{BB962C8B-B14F-4D97-AF65-F5344CB8AC3E}">
-        <p14:creationId xmlns:p14="http://schemas.microsoft.com/office/powerpoint/2010/main" val="688070056"/>
+        <p14:creationId xmlns:p14="http://schemas.microsoft.com/office/powerpoint/2010/main" val="1010553513"/>
       </p:ext>
     </p:extLst>
   </p:cSld>
@@ -14193,7 +14554,7 @@
           <p:cNvPr id="37" name="rail-5">
             <a:extLst xmlns:a="http://schemas.openxmlformats.org/drawingml/2006/main">
               <a:ext uri="{FF2B5EF4-FFF2-40B4-BE49-F238E27FC236}">
-                <a16:creationId xmlns:a16="http://schemas.microsoft.com/office/drawing/2014/main" id="{3A74F872-C670-4F15-9480-C55151C7F33A}"/>
+                <a16:creationId xmlns:a16="http://schemas.microsoft.com/office/drawing/2014/main" id="{2094FDDC-AAA4-47E5-AA9C-B0ECD0CAEC4C}"/>
               </a:ext>
             </a:extLst>
           </p:cNvPr>
@@ -14226,7 +14587,7 @@
           <p:cNvPr id="2" name="flourish-5">
             <a:extLst xmlns:a="http://schemas.openxmlformats.org/drawingml/2006/main">
               <a:ext uri="{FF2B5EF4-FFF2-40B4-BE49-F238E27FC236}">
-                <a16:creationId xmlns:a16="http://schemas.microsoft.com/office/drawing/2014/main" id="{5CE8E187-E4E4-4906-9EBF-11397CAD2C8A}"/>
+                <a16:creationId xmlns:a16="http://schemas.microsoft.com/office/drawing/2014/main" id="{92B4759B-5F80-4968-8CCA-1B755213B8B5}"/>
               </a:ext>
             </a:extLst>
           </p:cNvPr>
@@ -14276,7 +14637,7 @@
           <p:cNvPr id="3" name="chapter-5">
             <a:extLst xmlns:a="http://schemas.openxmlformats.org/drawingml/2006/main">
               <a:ext uri="{FF2B5EF4-FFF2-40B4-BE49-F238E27FC236}">
-                <a16:creationId xmlns:a16="http://schemas.microsoft.com/office/drawing/2014/main" id="{00A2A3EA-C134-46B1-8753-01B56E3B6F81}"/>
+                <a16:creationId xmlns:a16="http://schemas.microsoft.com/office/drawing/2014/main" id="{EEF9D07C-491E-4BF3-B606-C03B887DAE73}"/>
               </a:ext>
             </a:extLst>
           </p:cNvPr>
@@ -14326,7 +14687,7 @@
           <p:cNvPr id="4" name="title-5">
             <a:extLst xmlns:a="http://schemas.openxmlformats.org/drawingml/2006/main">
               <a:ext uri="{FF2B5EF4-FFF2-40B4-BE49-F238E27FC236}">
-                <a16:creationId xmlns:a16="http://schemas.microsoft.com/office/drawing/2014/main" id="{F79E6CFA-114A-488B-A259-88C70C5D7717}"/>
+                <a16:creationId xmlns:a16="http://schemas.microsoft.com/office/drawing/2014/main" id="{6318FABC-6A1C-4344-8B37-212409B23FBC}"/>
               </a:ext>
             </a:extLst>
           </p:cNvPr>
@@ -14376,7 +14737,7 @@
           <p:cNvPr id="5" name="subtitle-5">
             <a:extLst xmlns:a="http://schemas.openxmlformats.org/drawingml/2006/main">
               <a:ext uri="{FF2B5EF4-FFF2-40B4-BE49-F238E27FC236}">
-                <a16:creationId xmlns:a16="http://schemas.microsoft.com/office/drawing/2014/main" id="{26EA4B09-87FE-42B9-B8BD-1C9BC3DC4AB6}"/>
+                <a16:creationId xmlns:a16="http://schemas.microsoft.com/office/drawing/2014/main" id="{8BF47AD2-4F5F-4543-9929-0B5420F087E8}"/>
               </a:ext>
             </a:extLst>
           </p:cNvPr>
@@ -14426,7 +14787,7 @@
           <p:cNvPr id="6" name="">
             <a:extLst xmlns:a="http://schemas.openxmlformats.org/drawingml/2006/main">
               <a:ext uri="{FF2B5EF4-FFF2-40B4-BE49-F238E27FC236}">
-                <a16:creationId xmlns:a16="http://schemas.microsoft.com/office/drawing/2014/main" id="{D695CE43-D5E9-4D48-9B17-A42C1D5698E9}"/>
+                <a16:creationId xmlns:a16="http://schemas.microsoft.com/office/drawing/2014/main" id="{1DE34055-5F6E-4C1B-8761-D72185A4B7A5}"/>
               </a:ext>
             </a:extLst>
           </p:cNvPr>
@@ -14457,7 +14818,7 @@
           <p:cNvPr id="7" name="page-5">
             <a:extLst xmlns:a="http://schemas.openxmlformats.org/drawingml/2006/main">
               <a:ext uri="{FF2B5EF4-FFF2-40B4-BE49-F238E27FC236}">
-                <a16:creationId xmlns:a16="http://schemas.microsoft.com/office/drawing/2014/main" id="{17AFAC49-7760-49E9-8AFC-2599EB44DB65}"/>
+                <a16:creationId xmlns:a16="http://schemas.microsoft.com/office/drawing/2014/main" id="{BEE0012E-30D1-4B0D-9EE4-88A618889E24}"/>
               </a:ext>
             </a:extLst>
           </p:cNvPr>
@@ -14507,7 +14868,7 @@
           <p:cNvPr id="8" name="">
             <a:extLst xmlns:a="http://schemas.openxmlformats.org/drawingml/2006/main">
               <a:ext uri="{FF2B5EF4-FFF2-40B4-BE49-F238E27FC236}">
-                <a16:creationId xmlns:a16="http://schemas.microsoft.com/office/drawing/2014/main" id="{78C12FA4-061C-4967-966A-227B3B0E91A9}"/>
+                <a16:creationId xmlns:a16="http://schemas.microsoft.com/office/drawing/2014/main" id="{CD114763-4CDA-452F-9DD6-95F53A4C442D}"/>
               </a:ext>
             </a:extLst>
           </p:cNvPr>
@@ -14538,7 +14899,7 @@
           <p:cNvPr id="9" name="">
             <a:extLst xmlns:a="http://schemas.openxmlformats.org/drawingml/2006/main">
               <a:ext uri="{FF2B5EF4-FFF2-40B4-BE49-F238E27FC236}">
-                <a16:creationId xmlns:a16="http://schemas.microsoft.com/office/drawing/2014/main" id="{685A1F7F-C5E0-4A4B-8E4E-35888BECD8FC}"/>
+                <a16:creationId xmlns:a16="http://schemas.microsoft.com/office/drawing/2014/main" id="{D7F7B5F8-3741-4DDB-B979-E8812A5FFD67}"/>
               </a:ext>
             </a:extLst>
           </p:cNvPr>
@@ -14569,7 +14930,7 @@
           <p:cNvPr id="10" name="">
             <a:extLst xmlns:a="http://schemas.openxmlformats.org/drawingml/2006/main">
               <a:ext uri="{FF2B5EF4-FFF2-40B4-BE49-F238E27FC236}">
-                <a16:creationId xmlns:a16="http://schemas.microsoft.com/office/drawing/2014/main" id="{8E8FB40F-691D-4460-BD34-3A3D581351D0}"/>
+                <a16:creationId xmlns:a16="http://schemas.microsoft.com/office/drawing/2014/main" id="{4AD6FA10-DD06-4836-A947-62D8DC6B53AB}"/>
               </a:ext>
             </a:extLst>
           </p:cNvPr>
@@ -14600,7 +14961,7 @@
           <p:cNvPr id="11" name="">
             <a:extLst xmlns:a="http://schemas.openxmlformats.org/drawingml/2006/main">
               <a:ext uri="{FF2B5EF4-FFF2-40B4-BE49-F238E27FC236}">
-                <a16:creationId xmlns:a16="http://schemas.microsoft.com/office/drawing/2014/main" id="{F06FEE12-231B-4DAF-B7F1-E2EDC9D08C35}"/>
+                <a16:creationId xmlns:a16="http://schemas.microsoft.com/office/drawing/2014/main" id="{75283312-8757-46F4-BA77-243C6DC482B7}"/>
               </a:ext>
             </a:extLst>
           </p:cNvPr>
@@ -14631,7 +14992,7 @@
           <p:cNvPr id="12" name="">
             <a:extLst xmlns:a="http://schemas.openxmlformats.org/drawingml/2006/main">
               <a:ext uri="{FF2B5EF4-FFF2-40B4-BE49-F238E27FC236}">
-                <a16:creationId xmlns:a16="http://schemas.microsoft.com/office/drawing/2014/main" id="{097FF737-6068-4907-9192-577DF5E88624}"/>
+                <a16:creationId xmlns:a16="http://schemas.microsoft.com/office/drawing/2014/main" id="{1FFE53E2-D4C5-4633-A716-24021DFCEF21}"/>
               </a:ext>
             </a:extLst>
           </p:cNvPr>
@@ -14662,7 +15023,7 @@
           <p:cNvPr id="13" name="">
             <a:extLst xmlns:a="http://schemas.openxmlformats.org/drawingml/2006/main">
               <a:ext uri="{FF2B5EF4-FFF2-40B4-BE49-F238E27FC236}">
-                <a16:creationId xmlns:a16="http://schemas.microsoft.com/office/drawing/2014/main" id="{09C3E5F3-7A00-47AA-AA94-0558ACDA6142}"/>
+                <a16:creationId xmlns:a16="http://schemas.microsoft.com/office/drawing/2014/main" id="{02DB93A0-A673-4E0F-A7BC-045D27C30511}"/>
               </a:ext>
             </a:extLst>
           </p:cNvPr>
@@ -14693,7 +15054,7 @@
           <p:cNvPr id="14" name="state-dot-0">
             <a:extLst xmlns:a="http://schemas.openxmlformats.org/drawingml/2006/main">
               <a:ext uri="{FF2B5EF4-FFF2-40B4-BE49-F238E27FC236}">
-                <a16:creationId xmlns:a16="http://schemas.microsoft.com/office/drawing/2014/main" id="{AF414D62-4530-4080-B365-BD936C71236D}"/>
+                <a16:creationId xmlns:a16="http://schemas.microsoft.com/office/drawing/2014/main" id="{63FC8175-AC6E-477F-8202-088632D60EDA}"/>
               </a:ext>
             </a:extLst>
           </p:cNvPr>
@@ -14728,7 +15089,7 @@
           <p:cNvPr id="15" name="state-n-0">
             <a:extLst xmlns:a="http://schemas.openxmlformats.org/drawingml/2006/main">
               <a:ext uri="{FF2B5EF4-FFF2-40B4-BE49-F238E27FC236}">
-                <a16:creationId xmlns:a16="http://schemas.microsoft.com/office/drawing/2014/main" id="{19DFA6DF-05B4-4D4F-AD95-608878CE10CA}"/>
+                <a16:creationId xmlns:a16="http://schemas.microsoft.com/office/drawing/2014/main" id="{4803034F-FB45-4B2C-9BAB-6435ECC583A3}"/>
               </a:ext>
             </a:extLst>
           </p:cNvPr>
@@ -14778,7 +15139,7 @@
           <p:cNvPr id="16" name="state-label-0">
             <a:extLst xmlns:a="http://schemas.openxmlformats.org/drawingml/2006/main">
               <a:ext uri="{FF2B5EF4-FFF2-40B4-BE49-F238E27FC236}">
-                <a16:creationId xmlns:a16="http://schemas.microsoft.com/office/drawing/2014/main" id="{7DDF5CB5-E9AA-41C8-9DD5-2801AB49B2CC}"/>
+                <a16:creationId xmlns:a16="http://schemas.microsoft.com/office/drawing/2014/main" id="{3E606BDC-D9A4-47A8-823D-E4D3F5CEDF67}"/>
               </a:ext>
             </a:extLst>
           </p:cNvPr>
@@ -14828,7 +15189,7 @@
           <p:cNvPr id="17" name="state-dot-1">
             <a:extLst xmlns:a="http://schemas.openxmlformats.org/drawingml/2006/main">
               <a:ext uri="{FF2B5EF4-FFF2-40B4-BE49-F238E27FC236}">
-                <a16:creationId xmlns:a16="http://schemas.microsoft.com/office/drawing/2014/main" id="{1094E079-9A5C-41C7-80DD-D174DD29AA3D}"/>
+                <a16:creationId xmlns:a16="http://schemas.microsoft.com/office/drawing/2014/main" id="{65E02B2A-0990-4240-8DFB-AB0A5E663671}"/>
               </a:ext>
             </a:extLst>
           </p:cNvPr>
@@ -14863,7 +15224,7 @@
           <p:cNvPr id="18" name="state-n-1">
             <a:extLst xmlns:a="http://schemas.openxmlformats.org/drawingml/2006/main">
               <a:ext uri="{FF2B5EF4-FFF2-40B4-BE49-F238E27FC236}">
-                <a16:creationId xmlns:a16="http://schemas.microsoft.com/office/drawing/2014/main" id="{DD00628E-54BF-4704-A056-0A8F72F36C07}"/>
+                <a16:creationId xmlns:a16="http://schemas.microsoft.com/office/drawing/2014/main" id="{01E9B9D5-D340-43C3-BC2A-DC1159189C2B}"/>
               </a:ext>
             </a:extLst>
           </p:cNvPr>
@@ -14913,7 +15274,7 @@
           <p:cNvPr id="19" name="state-label-1">
             <a:extLst xmlns:a="http://schemas.openxmlformats.org/drawingml/2006/main">
               <a:ext uri="{FF2B5EF4-FFF2-40B4-BE49-F238E27FC236}">
-                <a16:creationId xmlns:a16="http://schemas.microsoft.com/office/drawing/2014/main" id="{F3AFFD08-C6CF-4316-8B80-7FC62B382B47}"/>
+                <a16:creationId xmlns:a16="http://schemas.microsoft.com/office/drawing/2014/main" id="{4D1DC6F7-F8D4-476F-80FC-D4484394E193}"/>
               </a:ext>
             </a:extLst>
           </p:cNvPr>
@@ -14963,7 +15324,7 @@
           <p:cNvPr id="20" name="state-dot-2">
             <a:extLst xmlns:a="http://schemas.openxmlformats.org/drawingml/2006/main">
               <a:ext uri="{FF2B5EF4-FFF2-40B4-BE49-F238E27FC236}">
-                <a16:creationId xmlns:a16="http://schemas.microsoft.com/office/drawing/2014/main" id="{8EE0DD5A-765B-4061-AE22-1635FF7C6DF4}"/>
+                <a16:creationId xmlns:a16="http://schemas.microsoft.com/office/drawing/2014/main" id="{49C319CF-CB45-46B2-8E1A-407901661917}"/>
               </a:ext>
             </a:extLst>
           </p:cNvPr>
@@ -14998,7 +15359,7 @@
           <p:cNvPr id="21" name="state-n-2">
             <a:extLst xmlns:a="http://schemas.openxmlformats.org/drawingml/2006/main">
               <a:ext uri="{FF2B5EF4-FFF2-40B4-BE49-F238E27FC236}">
-                <a16:creationId xmlns:a16="http://schemas.microsoft.com/office/drawing/2014/main" id="{C90C3C4B-F79D-4307-B0F2-8EAA6D26BECF}"/>
+                <a16:creationId xmlns:a16="http://schemas.microsoft.com/office/drawing/2014/main" id="{CB40BA31-4081-4E3C-A939-31C3F84A9ABD}"/>
               </a:ext>
             </a:extLst>
           </p:cNvPr>
@@ -15048,7 +15409,7 @@
           <p:cNvPr id="22" name="state-label-2">
             <a:extLst xmlns:a="http://schemas.openxmlformats.org/drawingml/2006/main">
               <a:ext uri="{FF2B5EF4-FFF2-40B4-BE49-F238E27FC236}">
-                <a16:creationId xmlns:a16="http://schemas.microsoft.com/office/drawing/2014/main" id="{462DA47A-61F3-4853-B82F-D48BB8F8F375}"/>
+                <a16:creationId xmlns:a16="http://schemas.microsoft.com/office/drawing/2014/main" id="{EBFD0874-7CAC-4D93-BBD8-7685CDA3D84A}"/>
               </a:ext>
             </a:extLst>
           </p:cNvPr>
@@ -15098,7 +15459,7 @@
           <p:cNvPr id="23" name="state-dot-3">
             <a:extLst xmlns:a="http://schemas.openxmlformats.org/drawingml/2006/main">
               <a:ext uri="{FF2B5EF4-FFF2-40B4-BE49-F238E27FC236}">
-                <a16:creationId xmlns:a16="http://schemas.microsoft.com/office/drawing/2014/main" id="{5F0FCD80-E599-49F8-BA8B-C061F3EF661C}"/>
+                <a16:creationId xmlns:a16="http://schemas.microsoft.com/office/drawing/2014/main" id="{902258E9-08A3-42ED-AA98-DEB8445D7E4C}"/>
               </a:ext>
             </a:extLst>
           </p:cNvPr>
@@ -15133,7 +15494,7 @@
           <p:cNvPr id="24" name="state-n-3">
             <a:extLst xmlns:a="http://schemas.openxmlformats.org/drawingml/2006/main">
               <a:ext uri="{FF2B5EF4-FFF2-40B4-BE49-F238E27FC236}">
-                <a16:creationId xmlns:a16="http://schemas.microsoft.com/office/drawing/2014/main" id="{A9C2A606-3E8D-401C-9286-9F1F5FBBFAD0}"/>
+                <a16:creationId xmlns:a16="http://schemas.microsoft.com/office/drawing/2014/main" id="{C5048FC5-93F9-4F24-B1BF-20E2E23FA753}"/>
               </a:ext>
             </a:extLst>
           </p:cNvPr>
@@ -15183,7 +15544,7 @@
           <p:cNvPr id="25" name="state-label-3">
             <a:extLst xmlns:a="http://schemas.openxmlformats.org/drawingml/2006/main">
               <a:ext uri="{FF2B5EF4-FFF2-40B4-BE49-F238E27FC236}">
-                <a16:creationId xmlns:a16="http://schemas.microsoft.com/office/drawing/2014/main" id="{514D7991-C161-4A32-8F48-230853865F69}"/>
+                <a16:creationId xmlns:a16="http://schemas.microsoft.com/office/drawing/2014/main" id="{725195B2-EE46-4753-B1B5-AAAD69DF6273}"/>
               </a:ext>
             </a:extLst>
           </p:cNvPr>
@@ -15233,7 +15594,7 @@
           <p:cNvPr id="26" name="state-dot-4">
             <a:extLst xmlns:a="http://schemas.openxmlformats.org/drawingml/2006/main">
               <a:ext uri="{FF2B5EF4-FFF2-40B4-BE49-F238E27FC236}">
-                <a16:creationId xmlns:a16="http://schemas.microsoft.com/office/drawing/2014/main" id="{94196B6C-5C5B-4C93-9DE3-9873168811ED}"/>
+                <a16:creationId xmlns:a16="http://schemas.microsoft.com/office/drawing/2014/main" id="{D277972F-F15F-4CE6-9C79-EC24766612DD}"/>
               </a:ext>
             </a:extLst>
           </p:cNvPr>
@@ -15268,7 +15629,7 @@
           <p:cNvPr id="27" name="state-n-4">
             <a:extLst xmlns:a="http://schemas.openxmlformats.org/drawingml/2006/main">
               <a:ext uri="{FF2B5EF4-FFF2-40B4-BE49-F238E27FC236}">
-                <a16:creationId xmlns:a16="http://schemas.microsoft.com/office/drawing/2014/main" id="{A7EA4D3F-5E8D-40CB-B94F-BC30CE996A63}"/>
+                <a16:creationId xmlns:a16="http://schemas.microsoft.com/office/drawing/2014/main" id="{AD7CAD2B-D6F7-4667-B082-60E72EF63C4C}"/>
               </a:ext>
             </a:extLst>
           </p:cNvPr>
@@ -15318,7 +15679,7 @@
           <p:cNvPr id="28" name="state-label-4">
             <a:extLst xmlns:a="http://schemas.openxmlformats.org/drawingml/2006/main">
               <a:ext uri="{FF2B5EF4-FFF2-40B4-BE49-F238E27FC236}">
-                <a16:creationId xmlns:a16="http://schemas.microsoft.com/office/drawing/2014/main" id="{1D2FE167-C437-42AD-8A24-5DECF82BC86F}"/>
+                <a16:creationId xmlns:a16="http://schemas.microsoft.com/office/drawing/2014/main" id="{8FF3D2A7-8503-4E36-88CC-B99C9A87F3B4}"/>
               </a:ext>
             </a:extLst>
           </p:cNvPr>
@@ -15368,7 +15729,7 @@
           <p:cNvPr id="29" name="state-dot-5">
             <a:extLst xmlns:a="http://schemas.openxmlformats.org/drawingml/2006/main">
               <a:ext uri="{FF2B5EF4-FFF2-40B4-BE49-F238E27FC236}">
-                <a16:creationId xmlns:a16="http://schemas.microsoft.com/office/drawing/2014/main" id="{EF1B6584-466E-47B2-911E-F04FA571145F}"/>
+                <a16:creationId xmlns:a16="http://schemas.microsoft.com/office/drawing/2014/main" id="{3683D5CF-8C69-4ABB-9435-C87CA6B0546B}"/>
               </a:ext>
             </a:extLst>
           </p:cNvPr>
@@ -15403,7 +15764,7 @@
           <p:cNvPr id="30" name="state-n-5">
             <a:extLst xmlns:a="http://schemas.openxmlformats.org/drawingml/2006/main">
               <a:ext uri="{FF2B5EF4-FFF2-40B4-BE49-F238E27FC236}">
-                <a16:creationId xmlns:a16="http://schemas.microsoft.com/office/drawing/2014/main" id="{BDA35F32-F4CA-4D13-A211-D43610AE3E41}"/>
+                <a16:creationId xmlns:a16="http://schemas.microsoft.com/office/drawing/2014/main" id="{4F7D6F6D-0472-455D-B1DB-0A234EAB9045}"/>
               </a:ext>
             </a:extLst>
           </p:cNvPr>
@@ -15453,7 +15814,7 @@
           <p:cNvPr id="31" name="state-label-5">
             <a:extLst xmlns:a="http://schemas.openxmlformats.org/drawingml/2006/main">
               <a:ext uri="{FF2B5EF4-FFF2-40B4-BE49-F238E27FC236}">
-                <a16:creationId xmlns:a16="http://schemas.microsoft.com/office/drawing/2014/main" id="{0484C9BC-F208-4559-9ED0-10E7FE6AC3B3}"/>
+                <a16:creationId xmlns:a16="http://schemas.microsoft.com/office/drawing/2014/main" id="{7C1E89E9-A1B1-41C5-88D0-EFB0385D905C}"/>
               </a:ext>
             </a:extLst>
           </p:cNvPr>
@@ -15503,7 +15864,7 @@
           <p:cNvPr id="32" name="state-dot-6">
             <a:extLst xmlns:a="http://schemas.openxmlformats.org/drawingml/2006/main">
               <a:ext uri="{FF2B5EF4-FFF2-40B4-BE49-F238E27FC236}">
-                <a16:creationId xmlns:a16="http://schemas.microsoft.com/office/drawing/2014/main" id="{523A666A-3BA1-4B3F-B322-7AE45CD51CAB}"/>
+                <a16:creationId xmlns:a16="http://schemas.microsoft.com/office/drawing/2014/main" id="{DB41665F-CA63-4CBB-BE66-EE84DE46FC97}"/>
               </a:ext>
             </a:extLst>
           </p:cNvPr>
@@ -15538,7 +15899,7 @@
           <p:cNvPr id="33" name="state-n-6">
             <a:extLst xmlns:a="http://schemas.openxmlformats.org/drawingml/2006/main">
               <a:ext uri="{FF2B5EF4-FFF2-40B4-BE49-F238E27FC236}">
-                <a16:creationId xmlns:a16="http://schemas.microsoft.com/office/drawing/2014/main" id="{3A038B71-7CE3-417C-93DC-FB1089AF732A}"/>
+                <a16:creationId xmlns:a16="http://schemas.microsoft.com/office/drawing/2014/main" id="{A4CBD019-A44E-4471-B0DF-B04ACA0844D3}"/>
               </a:ext>
             </a:extLst>
           </p:cNvPr>
@@ -15588,7 +15949,7 @@
           <p:cNvPr id="34" name="state-label-6">
             <a:extLst xmlns:a="http://schemas.openxmlformats.org/drawingml/2006/main">
               <a:ext uri="{FF2B5EF4-FFF2-40B4-BE49-F238E27FC236}">
-                <a16:creationId xmlns:a16="http://schemas.microsoft.com/office/drawing/2014/main" id="{02F891A4-25DA-4D8A-A7DB-AF832B19E304}"/>
+                <a16:creationId xmlns:a16="http://schemas.microsoft.com/office/drawing/2014/main" id="{71F906D2-1859-46F9-A413-1688DE052CD2}"/>
               </a:ext>
             </a:extLst>
           </p:cNvPr>
@@ -15638,7 +15999,7 @@
           <p:cNvPr id="35" name="state-guard">
             <a:extLst xmlns:a="http://schemas.openxmlformats.org/drawingml/2006/main">
               <a:ext uri="{FF2B5EF4-FFF2-40B4-BE49-F238E27FC236}">
-                <a16:creationId xmlns:a16="http://schemas.microsoft.com/office/drawing/2014/main" id="{FDC6088C-BB60-4B17-8E29-A8B417B7E926}"/>
+                <a16:creationId xmlns:a16="http://schemas.microsoft.com/office/drawing/2014/main" id="{501C1B85-A2E2-4724-B4AF-1894AC110F12}"/>
               </a:ext>
             </a:extLst>
           </p:cNvPr>
@@ -15673,7 +16034,7 @@
           <p:cNvPr id="36" name="state-guard-text">
             <a:extLst xmlns:a="http://schemas.openxmlformats.org/drawingml/2006/main">
               <a:ext uri="{FF2B5EF4-FFF2-40B4-BE49-F238E27FC236}">
-                <a16:creationId xmlns:a16="http://schemas.microsoft.com/office/drawing/2014/main" id="{1DC9B8BE-0193-45A2-BC8A-FE316A815142}"/>
+                <a16:creationId xmlns:a16="http://schemas.microsoft.com/office/drawing/2014/main" id="{0B9D895C-9904-45C3-8902-86A4CB4F2A6A}"/>
               </a:ext>
             </a:extLst>
           </p:cNvPr>
@@ -15721,7 +16082,7 @@
     </p:spTree>
     <p:extLst>
       <p:ext uri="{BB962C8B-B14F-4D97-AF65-F5344CB8AC3E}">
-        <p14:creationId xmlns:p14="http://schemas.microsoft.com/office/powerpoint/2010/main" val="741672697"/>
+        <p14:creationId xmlns:p14="http://schemas.microsoft.com/office/powerpoint/2010/main" val="900252057"/>
       </p:ext>
     </p:extLst>
   </p:cSld>
@@ -15752,7 +16113,7 @@
           <p:cNvPr id="24" name="rail-6">
             <a:extLst xmlns:a="http://schemas.openxmlformats.org/drawingml/2006/main">
               <a:ext uri="{FF2B5EF4-FFF2-40B4-BE49-F238E27FC236}">
-                <a16:creationId xmlns:a16="http://schemas.microsoft.com/office/drawing/2014/main" id="{6483D5D0-1A39-4526-BA5B-BAE372C80ECD}"/>
+                <a16:creationId xmlns:a16="http://schemas.microsoft.com/office/drawing/2014/main" id="{8E34DFAC-52B8-45F5-BD60-C10D965719A6}"/>
               </a:ext>
             </a:extLst>
           </p:cNvPr>
@@ -15785,7 +16146,7 @@
           <p:cNvPr id="2" name="flourish-6">
             <a:extLst xmlns:a="http://schemas.openxmlformats.org/drawingml/2006/main">
               <a:ext uri="{FF2B5EF4-FFF2-40B4-BE49-F238E27FC236}">
-                <a16:creationId xmlns:a16="http://schemas.microsoft.com/office/drawing/2014/main" id="{91F4854A-08E3-4DAF-B5BD-58C129E36FE0}"/>
+                <a16:creationId xmlns:a16="http://schemas.microsoft.com/office/drawing/2014/main" id="{3829E511-9B08-495D-B42F-49F0739AC554}"/>
               </a:ext>
             </a:extLst>
           </p:cNvPr>
@@ -15835,7 +16196,7 @@
           <p:cNvPr id="3" name="chapter-6">
             <a:extLst xmlns:a="http://schemas.openxmlformats.org/drawingml/2006/main">
               <a:ext uri="{FF2B5EF4-FFF2-40B4-BE49-F238E27FC236}">
-                <a16:creationId xmlns:a16="http://schemas.microsoft.com/office/drawing/2014/main" id="{7C762449-6DCF-4B4C-AAEA-2E5EB347E033}"/>
+                <a16:creationId xmlns:a16="http://schemas.microsoft.com/office/drawing/2014/main" id="{B82E452F-82A4-441F-9CCE-6E63E81B6C5E}"/>
               </a:ext>
             </a:extLst>
           </p:cNvPr>
@@ -15885,7 +16246,7 @@
           <p:cNvPr id="4" name="title-6">
             <a:extLst xmlns:a="http://schemas.openxmlformats.org/drawingml/2006/main">
               <a:ext uri="{FF2B5EF4-FFF2-40B4-BE49-F238E27FC236}">
-                <a16:creationId xmlns:a16="http://schemas.microsoft.com/office/drawing/2014/main" id="{79BD756C-A0BE-4D43-8438-0BA31C2A9E72}"/>
+                <a16:creationId xmlns:a16="http://schemas.microsoft.com/office/drawing/2014/main" id="{661E7785-7E56-442E-9CC6-1849F6F69662}"/>
               </a:ext>
             </a:extLst>
           </p:cNvPr>
@@ -15935,7 +16296,7 @@
           <p:cNvPr id="5" name="subtitle-6">
             <a:extLst xmlns:a="http://schemas.openxmlformats.org/drawingml/2006/main">
               <a:ext uri="{FF2B5EF4-FFF2-40B4-BE49-F238E27FC236}">
-                <a16:creationId xmlns:a16="http://schemas.microsoft.com/office/drawing/2014/main" id="{6152B6C1-8BBC-4A5E-8C37-FCF8147A2FA5}"/>
+                <a16:creationId xmlns:a16="http://schemas.microsoft.com/office/drawing/2014/main" id="{E9DB2D25-A168-455C-97BA-89928E6ADB37}"/>
               </a:ext>
             </a:extLst>
           </p:cNvPr>
@@ -15985,7 +16346,7 @@
           <p:cNvPr id="6" name="">
             <a:extLst xmlns:a="http://schemas.openxmlformats.org/drawingml/2006/main">
               <a:ext uri="{FF2B5EF4-FFF2-40B4-BE49-F238E27FC236}">
-                <a16:creationId xmlns:a16="http://schemas.microsoft.com/office/drawing/2014/main" id="{EF9AD9DB-8714-4A3E-AB15-49A4BC0BB2E6}"/>
+                <a16:creationId xmlns:a16="http://schemas.microsoft.com/office/drawing/2014/main" id="{5ECA770E-FBCD-44D2-BA49-4B650DDFC46B}"/>
               </a:ext>
             </a:extLst>
           </p:cNvPr>
@@ -16016,7 +16377,7 @@
           <p:cNvPr id="7" name="page-6">
             <a:extLst xmlns:a="http://schemas.openxmlformats.org/drawingml/2006/main">
               <a:ext uri="{FF2B5EF4-FFF2-40B4-BE49-F238E27FC236}">
-                <a16:creationId xmlns:a16="http://schemas.microsoft.com/office/drawing/2014/main" id="{34E30512-6AF0-41B4-BBE8-34A0DC4D03B3}"/>
+                <a16:creationId xmlns:a16="http://schemas.microsoft.com/office/drawing/2014/main" id="{9E7CA43B-0BDE-4D97-B822-B551DC2F2881}"/>
               </a:ext>
             </a:extLst>
           </p:cNvPr>
@@ -16066,7 +16427,7 @@
           <p:cNvPr id="8" name="grpo-formula">
             <a:extLst xmlns:a="http://schemas.openxmlformats.org/drawingml/2006/main">
               <a:ext uri="{FF2B5EF4-FFF2-40B4-BE49-F238E27FC236}">
-                <a16:creationId xmlns:a16="http://schemas.microsoft.com/office/drawing/2014/main" id="{3C7BCB56-31E8-41BC-BB4B-7773D64611DA}"/>
+                <a16:creationId xmlns:a16="http://schemas.microsoft.com/office/drawing/2014/main" id="{4A7D5546-650D-4360-BC28-1356AB033739}"/>
               </a:ext>
             </a:extLst>
           </p:cNvPr>
@@ -16101,7 +16462,7 @@
           <p:cNvPr id="9" name="grpo-formula-title">
             <a:extLst xmlns:a="http://schemas.openxmlformats.org/drawingml/2006/main">
               <a:ext uri="{FF2B5EF4-FFF2-40B4-BE49-F238E27FC236}">
-                <a16:creationId xmlns:a16="http://schemas.microsoft.com/office/drawing/2014/main" id="{73B7A8F2-82D4-44BC-9AE5-8F6AAE9A3C09}"/>
+                <a16:creationId xmlns:a16="http://schemas.microsoft.com/office/drawing/2014/main" id="{AC913690-5278-4067-8B33-A55B864E5166}"/>
               </a:ext>
             </a:extLst>
           </p:cNvPr>
@@ -16151,7 +16512,7 @@
           <p:cNvPr id="10" name="grpo-formula-main">
             <a:extLst xmlns:a="http://schemas.openxmlformats.org/drawingml/2006/main">
               <a:ext uri="{FF2B5EF4-FFF2-40B4-BE49-F238E27FC236}">
-                <a16:creationId xmlns:a16="http://schemas.microsoft.com/office/drawing/2014/main" id="{A414BB40-803E-400D-B029-C908785187E4}"/>
+                <a16:creationId xmlns:a16="http://schemas.microsoft.com/office/drawing/2014/main" id="{925CECF0-616E-4497-93E0-F26FC5EFC49E}"/>
               </a:ext>
             </a:extLst>
           </p:cNvPr>
@@ -16201,7 +16562,7 @@
           <p:cNvPr id="11" name="grpo-reward">
             <a:extLst xmlns:a="http://schemas.openxmlformats.org/drawingml/2006/main">
               <a:ext uri="{FF2B5EF4-FFF2-40B4-BE49-F238E27FC236}">
-                <a16:creationId xmlns:a16="http://schemas.microsoft.com/office/drawing/2014/main" id="{6D26D211-03BD-455D-A32E-71CA6CDD379F}"/>
+                <a16:creationId xmlns:a16="http://schemas.microsoft.com/office/drawing/2014/main" id="{5A067FBC-3D92-4EC1-9D83-B74B085C92E5}"/>
               </a:ext>
             </a:extLst>
           </p:cNvPr>
@@ -16251,7 +16612,7 @@
           <p:cNvPr id="12" name="grpo-num-0">
             <a:extLst xmlns:a="http://schemas.openxmlformats.org/drawingml/2006/main">
               <a:ext uri="{FF2B5EF4-FFF2-40B4-BE49-F238E27FC236}">
-                <a16:creationId xmlns:a16="http://schemas.microsoft.com/office/drawing/2014/main" id="{3C49B0F7-5240-444D-BBE1-4BB70AD2FE0F}"/>
+                <a16:creationId xmlns:a16="http://schemas.microsoft.com/office/drawing/2014/main" id="{A1C38DD2-5966-484C-995E-1376656D9A40}"/>
               </a:ext>
             </a:extLst>
           </p:cNvPr>
@@ -16301,7 +16662,7 @@
           <p:cNvPr id="13" name="grpo-head-0">
             <a:extLst xmlns:a="http://schemas.openxmlformats.org/drawingml/2006/main">
               <a:ext uri="{FF2B5EF4-FFF2-40B4-BE49-F238E27FC236}">
-                <a16:creationId xmlns:a16="http://schemas.microsoft.com/office/drawing/2014/main" id="{74DA4F65-B6F7-41DE-8A72-B74092F15DC8}"/>
+                <a16:creationId xmlns:a16="http://schemas.microsoft.com/office/drawing/2014/main" id="{140FA9B8-4A05-42EB-ADC4-A9F7CE19F001}"/>
               </a:ext>
             </a:extLst>
           </p:cNvPr>
@@ -16351,7 +16712,7 @@
           <p:cNvPr id="14" name="grpo-sub-0">
             <a:extLst xmlns:a="http://schemas.openxmlformats.org/drawingml/2006/main">
               <a:ext uri="{FF2B5EF4-FFF2-40B4-BE49-F238E27FC236}">
-                <a16:creationId xmlns:a16="http://schemas.microsoft.com/office/drawing/2014/main" id="{784E2192-A030-46C8-8D21-14221C95DA37}"/>
+                <a16:creationId xmlns:a16="http://schemas.microsoft.com/office/drawing/2014/main" id="{DF7F0D4F-17A5-44ED-B240-2247F92FAB05}"/>
               </a:ext>
             </a:extLst>
           </p:cNvPr>
@@ -16401,7 +16762,7 @@
           <p:cNvPr id="15" name="grpo-num-1">
             <a:extLst xmlns:a="http://schemas.openxmlformats.org/drawingml/2006/main">
               <a:ext uri="{FF2B5EF4-FFF2-40B4-BE49-F238E27FC236}">
-                <a16:creationId xmlns:a16="http://schemas.microsoft.com/office/drawing/2014/main" id="{E9363982-FE77-4E89-8C68-A462A9E4270F}"/>
+                <a16:creationId xmlns:a16="http://schemas.microsoft.com/office/drawing/2014/main" id="{DAA633D4-1A46-42C3-93F2-FCE1BCACA9FE}"/>
               </a:ext>
             </a:extLst>
           </p:cNvPr>
@@ -16451,7 +16812,7 @@
           <p:cNvPr id="16" name="grpo-head-1">
             <a:extLst xmlns:a="http://schemas.openxmlformats.org/drawingml/2006/main">
               <a:ext uri="{FF2B5EF4-FFF2-40B4-BE49-F238E27FC236}">
-                <a16:creationId xmlns:a16="http://schemas.microsoft.com/office/drawing/2014/main" id="{7BFFD635-737E-44F0-A6DC-8601304C829B}"/>
+                <a16:creationId xmlns:a16="http://schemas.microsoft.com/office/drawing/2014/main" id="{ADB907FA-F719-4F1F-98FF-6BCDC664192C}"/>
               </a:ext>
             </a:extLst>
           </p:cNvPr>
@@ -16501,7 +16862,7 @@
           <p:cNvPr id="17" name="grpo-sub-1">
             <a:extLst xmlns:a="http://schemas.openxmlformats.org/drawingml/2006/main">
               <a:ext uri="{FF2B5EF4-FFF2-40B4-BE49-F238E27FC236}">
-                <a16:creationId xmlns:a16="http://schemas.microsoft.com/office/drawing/2014/main" id="{3AAEFD1D-5F32-4DDB-9D4C-A2EE631413C4}"/>
+                <a16:creationId xmlns:a16="http://schemas.microsoft.com/office/drawing/2014/main" id="{03E9C828-2A75-44D0-B22B-4B8EBE019DD2}"/>
               </a:ext>
             </a:extLst>
           </p:cNvPr>
@@ -16551,7 +16912,7 @@
           <p:cNvPr id="18" name="grpo-num-2">
             <a:extLst xmlns:a="http://schemas.openxmlformats.org/drawingml/2006/main">
               <a:ext uri="{FF2B5EF4-FFF2-40B4-BE49-F238E27FC236}">
-                <a16:creationId xmlns:a16="http://schemas.microsoft.com/office/drawing/2014/main" id="{715A6099-023B-4003-84F5-D253062D4601}"/>
+                <a16:creationId xmlns:a16="http://schemas.microsoft.com/office/drawing/2014/main" id="{F7A78C62-6202-4F29-BE13-C896E101656D}"/>
               </a:ext>
             </a:extLst>
           </p:cNvPr>
@@ -16601,7 +16962,7 @@
           <p:cNvPr id="19" name="grpo-head-2">
             <a:extLst xmlns:a="http://schemas.openxmlformats.org/drawingml/2006/main">
               <a:ext uri="{FF2B5EF4-FFF2-40B4-BE49-F238E27FC236}">
-                <a16:creationId xmlns:a16="http://schemas.microsoft.com/office/drawing/2014/main" id="{63906E79-1150-466B-A685-6DB62A2B2240}"/>
+                <a16:creationId xmlns:a16="http://schemas.microsoft.com/office/drawing/2014/main" id="{6C864AB7-4ACB-4689-9451-E6504833BAAD}"/>
               </a:ext>
             </a:extLst>
           </p:cNvPr>
@@ -16651,7 +17012,7 @@
           <p:cNvPr id="20" name="grpo-sub-2">
             <a:extLst xmlns:a="http://schemas.openxmlformats.org/drawingml/2006/main">
               <a:ext uri="{FF2B5EF4-FFF2-40B4-BE49-F238E27FC236}">
-                <a16:creationId xmlns:a16="http://schemas.microsoft.com/office/drawing/2014/main" id="{8272B02D-F35C-4CD1-B70F-9CFF2DF9D0AA}"/>
+                <a16:creationId xmlns:a16="http://schemas.microsoft.com/office/drawing/2014/main" id="{2B090EC3-D255-44FD-A8DB-E9F2548C331E}"/>
               </a:ext>
             </a:extLst>
           </p:cNvPr>
@@ -16701,7 +17062,7 @@
           <p:cNvPr id="21" name="grpo-num-3">
             <a:extLst xmlns:a="http://schemas.openxmlformats.org/drawingml/2006/main">
               <a:ext uri="{FF2B5EF4-FFF2-40B4-BE49-F238E27FC236}">
-                <a16:creationId xmlns:a16="http://schemas.microsoft.com/office/drawing/2014/main" id="{206E68D6-30C1-4A12-B50C-FD838D847774}"/>
+                <a16:creationId xmlns:a16="http://schemas.microsoft.com/office/drawing/2014/main" id="{5B729BBC-9488-4CE0-9EFF-EF07DE0C018C}"/>
               </a:ext>
             </a:extLst>
           </p:cNvPr>
@@ -16751,7 +17112,7 @@
           <p:cNvPr id="22" name="grpo-head-3">
             <a:extLst xmlns:a="http://schemas.openxmlformats.org/drawingml/2006/main">
               <a:ext uri="{FF2B5EF4-FFF2-40B4-BE49-F238E27FC236}">
-                <a16:creationId xmlns:a16="http://schemas.microsoft.com/office/drawing/2014/main" id="{D932FE98-9770-454F-9E44-8AB70EDF8503}"/>
+                <a16:creationId xmlns:a16="http://schemas.microsoft.com/office/drawing/2014/main" id="{68FAA930-D6CA-4953-8187-8598C8C36DBA}"/>
               </a:ext>
             </a:extLst>
           </p:cNvPr>
@@ -16801,7 +17162,7 @@
           <p:cNvPr id="23" name="grpo-sub-3">
             <a:extLst xmlns:a="http://schemas.openxmlformats.org/drawingml/2006/main">
               <a:ext uri="{FF2B5EF4-FFF2-40B4-BE49-F238E27FC236}">
-                <a16:creationId xmlns:a16="http://schemas.microsoft.com/office/drawing/2014/main" id="{3A217642-FDB8-494F-AFC1-5F38451C780C}"/>
+                <a16:creationId xmlns:a16="http://schemas.microsoft.com/office/drawing/2014/main" id="{4F303807-DA32-42A9-BB87-E8232A82B15D}"/>
               </a:ext>
             </a:extLst>
           </p:cNvPr>
@@ -16849,7 +17210,7 @@
     </p:spTree>
     <p:extLst>
       <p:ext uri="{BB962C8B-B14F-4D97-AF65-F5344CB8AC3E}">
-        <p14:creationId xmlns:p14="http://schemas.microsoft.com/office/powerpoint/2010/main" val="1165603200"/>
+        <p14:creationId xmlns:p14="http://schemas.microsoft.com/office/powerpoint/2010/main" val="154623489"/>
       </p:ext>
     </p:extLst>
   </p:cSld>
@@ -16880,7 +17241,7 @@
           <p:cNvPr id="10" name="copper-7">
             <a:extLst xmlns:a="http://schemas.openxmlformats.org/drawingml/2006/main">
               <a:ext uri="{FF2B5EF4-FFF2-40B4-BE49-F238E27FC236}">
-                <a16:creationId xmlns:a16="http://schemas.microsoft.com/office/drawing/2014/main" id="{65A51076-7086-4826-84A5-F41DF1F416BD}"/>
+                <a16:creationId xmlns:a16="http://schemas.microsoft.com/office/drawing/2014/main" id="{2D0D3A88-30E8-46C6-A740-94CD1277C8DD}"/>
               </a:ext>
             </a:extLst>
           </p:cNvPr>
@@ -16913,7 +17274,7 @@
           <p:cNvPr id="2" name="chapter-script-7">
             <a:extLst xmlns:a="http://schemas.openxmlformats.org/drawingml/2006/main">
               <a:ext uri="{FF2B5EF4-FFF2-40B4-BE49-F238E27FC236}">
-                <a16:creationId xmlns:a16="http://schemas.microsoft.com/office/drawing/2014/main" id="{74E139B3-8CA1-4FEC-8777-CD0F624B9E4B}"/>
+                <a16:creationId xmlns:a16="http://schemas.microsoft.com/office/drawing/2014/main" id="{103E7A67-6F90-4501-89D7-BCF937B17722}"/>
               </a:ext>
             </a:extLst>
           </p:cNvPr>
@@ -16963,7 +17324,7 @@
           <p:cNvPr id="3" name="roman-7">
             <a:extLst xmlns:a="http://schemas.openxmlformats.org/drawingml/2006/main">
               <a:ext uri="{FF2B5EF4-FFF2-40B4-BE49-F238E27FC236}">
-                <a16:creationId xmlns:a16="http://schemas.microsoft.com/office/drawing/2014/main" id="{64C9BE2B-5695-4301-BA32-316C1446C64B}"/>
+                <a16:creationId xmlns:a16="http://schemas.microsoft.com/office/drawing/2014/main" id="{64908B81-6EE9-43FD-9D0C-355E6C4D6128}"/>
               </a:ext>
             </a:extLst>
           </p:cNvPr>
@@ -17013,7 +17374,7 @@
           <p:cNvPr id="4" name="">
             <a:extLst xmlns:a="http://schemas.openxmlformats.org/drawingml/2006/main">
               <a:ext uri="{FF2B5EF4-FFF2-40B4-BE49-F238E27FC236}">
-                <a16:creationId xmlns:a16="http://schemas.microsoft.com/office/drawing/2014/main" id="{9FD69108-2055-4276-8CDA-4667BE41A62D}"/>
+                <a16:creationId xmlns:a16="http://schemas.microsoft.com/office/drawing/2014/main" id="{2C122DDE-6D14-49AA-A229-EB7CC06456BA}"/>
               </a:ext>
             </a:extLst>
           </p:cNvPr>
@@ -17044,7 +17405,7 @@
           <p:cNvPr id="5" name="zh-7">
             <a:extLst xmlns:a="http://schemas.openxmlformats.org/drawingml/2006/main">
               <a:ext uri="{FF2B5EF4-FFF2-40B4-BE49-F238E27FC236}">
-                <a16:creationId xmlns:a16="http://schemas.microsoft.com/office/drawing/2014/main" id="{66B918FA-D4A2-4196-8F19-A75D8B574220}"/>
+                <a16:creationId xmlns:a16="http://schemas.microsoft.com/office/drawing/2014/main" id="{84F2515F-9A05-4FC2-801E-5EDB9C0E1B07}"/>
               </a:ext>
             </a:extLst>
           </p:cNvPr>
@@ -17094,7 +17455,7 @@
           <p:cNvPr id="6" name="en-7">
             <a:extLst xmlns:a="http://schemas.openxmlformats.org/drawingml/2006/main">
               <a:ext uri="{FF2B5EF4-FFF2-40B4-BE49-F238E27FC236}">
-                <a16:creationId xmlns:a16="http://schemas.microsoft.com/office/drawing/2014/main" id="{3B3DE3BC-DC21-42D2-8A87-0AFFD04258B0}"/>
+                <a16:creationId xmlns:a16="http://schemas.microsoft.com/office/drawing/2014/main" id="{C1B5A502-2DF0-41AD-9CAD-D47A88FF9CF7}"/>
               </a:ext>
             </a:extLst>
           </p:cNvPr>
@@ -17144,7 +17505,7 @@
           <p:cNvPr id="7" name="body-7">
             <a:extLst xmlns:a="http://schemas.openxmlformats.org/drawingml/2006/main">
               <a:ext uri="{FF2B5EF4-FFF2-40B4-BE49-F238E27FC236}">
-                <a16:creationId xmlns:a16="http://schemas.microsoft.com/office/drawing/2014/main" id="{09C29923-C049-442C-9536-860F1BC94BE4}"/>
+                <a16:creationId xmlns:a16="http://schemas.microsoft.com/office/drawing/2014/main" id="{71DE6C71-CD8A-4E8C-9C09-FEF4D67C8247}"/>
               </a:ext>
             </a:extLst>
           </p:cNvPr>
@@ -17198,7 +17559,7 @@
           <p:cNvPr id="8" name="chapter-pill-7-bg">
             <a:extLst xmlns:a="http://schemas.openxmlformats.org/drawingml/2006/main">
               <a:ext uri="{FF2B5EF4-FFF2-40B4-BE49-F238E27FC236}">
-                <a16:creationId xmlns:a16="http://schemas.microsoft.com/office/drawing/2014/main" id="{3A2D8987-D30D-4138-86F6-D095BC329116}"/>
+                <a16:creationId xmlns:a16="http://schemas.microsoft.com/office/drawing/2014/main" id="{D1ECF22E-FB49-4AE9-A20A-3749AC0E21B8}"/>
               </a:ext>
             </a:extLst>
           </p:cNvPr>
@@ -17233,7 +17594,7 @@
           <p:cNvPr id="9" name="chapter-pill-7-text">
             <a:extLst xmlns:a="http://schemas.openxmlformats.org/drawingml/2006/main">
               <a:ext uri="{FF2B5EF4-FFF2-40B4-BE49-F238E27FC236}">
-                <a16:creationId xmlns:a16="http://schemas.microsoft.com/office/drawing/2014/main" id="{8B0BBDE6-95FB-4B95-83D5-83AFAF085851}"/>
+                <a16:creationId xmlns:a16="http://schemas.microsoft.com/office/drawing/2014/main" id="{EEA15F4D-F92F-4FF6-9D17-E5759244D29B}"/>
               </a:ext>
             </a:extLst>
           </p:cNvPr>
@@ -17281,7 +17642,7 @@
     </p:spTree>
     <p:extLst>
       <p:ext uri="{BB962C8B-B14F-4D97-AF65-F5344CB8AC3E}">
-        <p14:creationId xmlns:p14="http://schemas.microsoft.com/office/powerpoint/2010/main" val="156891840"/>
+        <p14:creationId xmlns:p14="http://schemas.microsoft.com/office/powerpoint/2010/main" val="1043003140"/>
       </p:ext>
     </p:extLst>
   </p:cSld>
@@ -17312,7 +17673,7 @@
           <p:cNvPr id="26" name="rail-8">
             <a:extLst xmlns:a="http://schemas.openxmlformats.org/drawingml/2006/main">
               <a:ext uri="{FF2B5EF4-FFF2-40B4-BE49-F238E27FC236}">
-                <a16:creationId xmlns:a16="http://schemas.microsoft.com/office/drawing/2014/main" id="{FCFD8B8F-161F-4F20-BC65-E209046BDB27}"/>
+                <a16:creationId xmlns:a16="http://schemas.microsoft.com/office/drawing/2014/main" id="{89DC2FAB-96E6-4B6B-A603-34A3892DC0B3}"/>
               </a:ext>
             </a:extLst>
           </p:cNvPr>
@@ -17345,7 +17706,7 @@
           <p:cNvPr id="2" name="flourish-8">
             <a:extLst xmlns:a="http://schemas.openxmlformats.org/drawingml/2006/main">
               <a:ext uri="{FF2B5EF4-FFF2-40B4-BE49-F238E27FC236}">
-                <a16:creationId xmlns:a16="http://schemas.microsoft.com/office/drawing/2014/main" id="{5DA072C7-8907-4ECC-BAD2-7ACF68264C99}"/>
+                <a16:creationId xmlns:a16="http://schemas.microsoft.com/office/drawing/2014/main" id="{65D7453B-351D-4948-82B8-11D81D9FD921}"/>
               </a:ext>
             </a:extLst>
           </p:cNvPr>
@@ -17395,7 +17756,7 @@
           <p:cNvPr id="3" name="chapter-8">
             <a:extLst xmlns:a="http://schemas.openxmlformats.org/drawingml/2006/main">
               <a:ext uri="{FF2B5EF4-FFF2-40B4-BE49-F238E27FC236}">
-                <a16:creationId xmlns:a16="http://schemas.microsoft.com/office/drawing/2014/main" id="{36547C24-23B8-4823-8505-0ED5D8EE56FB}"/>
+                <a16:creationId xmlns:a16="http://schemas.microsoft.com/office/drawing/2014/main" id="{6855146B-47DF-4E82-8F50-6D21062263AA}"/>
               </a:ext>
             </a:extLst>
           </p:cNvPr>
@@ -17445,7 +17806,7 @@
           <p:cNvPr id="4" name="title-8">
             <a:extLst xmlns:a="http://schemas.openxmlformats.org/drawingml/2006/main">
               <a:ext uri="{FF2B5EF4-FFF2-40B4-BE49-F238E27FC236}">
-                <a16:creationId xmlns:a16="http://schemas.microsoft.com/office/drawing/2014/main" id="{2D0177BB-F830-4452-A87C-0A6DC371AE12}"/>
+                <a16:creationId xmlns:a16="http://schemas.microsoft.com/office/drawing/2014/main" id="{643EE5EB-0938-49DE-A0EE-EBC158850213}"/>
               </a:ext>
             </a:extLst>
           </p:cNvPr>
@@ -17495,7 +17856,7 @@
           <p:cNvPr id="5" name="subtitle-8">
             <a:extLst xmlns:a="http://schemas.openxmlformats.org/drawingml/2006/main">
               <a:ext uri="{FF2B5EF4-FFF2-40B4-BE49-F238E27FC236}">
-                <a16:creationId xmlns:a16="http://schemas.microsoft.com/office/drawing/2014/main" id="{7DCBE2CC-44D1-4C8E-8C09-57A357353B13}"/>
+                <a16:creationId xmlns:a16="http://schemas.microsoft.com/office/drawing/2014/main" id="{17491E6E-3108-496F-8008-C7B1553335B8}"/>
               </a:ext>
             </a:extLst>
           </p:cNvPr>
@@ -17545,7 +17906,7 @@
           <p:cNvPr id="6" name="">
             <a:extLst xmlns:a="http://schemas.openxmlformats.org/drawingml/2006/main">
               <a:ext uri="{FF2B5EF4-FFF2-40B4-BE49-F238E27FC236}">
-                <a16:creationId xmlns:a16="http://schemas.microsoft.com/office/drawing/2014/main" id="{B75CA810-585E-4C4B-925B-2C9CB95A202E}"/>
+                <a16:creationId xmlns:a16="http://schemas.microsoft.com/office/drawing/2014/main" id="{6A94DA86-F268-46AE-A336-70F3E076447B}"/>
               </a:ext>
             </a:extLst>
           </p:cNvPr>
@@ -17576,7 +17937,7 @@
           <p:cNvPr id="7" name="page-8">
             <a:extLst xmlns:a="http://schemas.openxmlformats.org/drawingml/2006/main">
               <a:ext uri="{FF2B5EF4-FFF2-40B4-BE49-F238E27FC236}">
-                <a16:creationId xmlns:a16="http://schemas.microsoft.com/office/drawing/2014/main" id="{EA32342B-CD61-4B63-84A8-51CB4EFDA3EB}"/>
+                <a16:creationId xmlns:a16="http://schemas.microsoft.com/office/drawing/2014/main" id="{5E7C2AB9-0E44-4F5A-A784-AE7725C7E1A0}"/>
               </a:ext>
             </a:extLst>
           </p:cNvPr>
@@ -17626,7 +17987,7 @@
           <p:cNvPr id="8" name="">
             <a:extLst xmlns:a="http://schemas.openxmlformats.org/drawingml/2006/main">
               <a:ext uri="{FF2B5EF4-FFF2-40B4-BE49-F238E27FC236}">
-                <a16:creationId xmlns:a16="http://schemas.microsoft.com/office/drawing/2014/main" id="{62B89628-912C-4676-901C-34C0E95F7115}"/>
+                <a16:creationId xmlns:a16="http://schemas.microsoft.com/office/drawing/2014/main" id="{493FAEF5-B6D6-4DD4-805E-F0D5F91E86D1}"/>
               </a:ext>
             </a:extLst>
           </p:cNvPr>
@@ -17657,7 +18018,7 @@
           <p:cNvPr id="9" name="s1-before-value">
             <a:extLst xmlns:a="http://schemas.openxmlformats.org/drawingml/2006/main">
               <a:ext uri="{FF2B5EF4-FFF2-40B4-BE49-F238E27FC236}">
-                <a16:creationId xmlns:a16="http://schemas.microsoft.com/office/drawing/2014/main" id="{9CDF49D3-851C-4B8E-9618-32F8196CEAEB}"/>
+                <a16:creationId xmlns:a16="http://schemas.microsoft.com/office/drawing/2014/main" id="{51859399-6D11-4F15-ACE0-AEE2F3788155}"/>
               </a:ext>
             </a:extLst>
           </p:cNvPr>
@@ -17707,7 +18068,7 @@
           <p:cNvPr id="10" name="s1-before-label">
             <a:extLst xmlns:a="http://schemas.openxmlformats.org/drawingml/2006/main">
               <a:ext uri="{FF2B5EF4-FFF2-40B4-BE49-F238E27FC236}">
-                <a16:creationId xmlns:a16="http://schemas.microsoft.com/office/drawing/2014/main" id="{F5E7F416-DCD5-4DA9-9FCB-82C45E63A1BA}"/>
+                <a16:creationId xmlns:a16="http://schemas.microsoft.com/office/drawing/2014/main" id="{53487718-D3BC-4ACF-A90B-CB33D80E2FD1}"/>
               </a:ext>
             </a:extLst>
           </p:cNvPr>
@@ -17757,7 +18118,7 @@
           <p:cNvPr id="11" name="">
             <a:extLst xmlns:a="http://schemas.openxmlformats.org/drawingml/2006/main">
               <a:ext uri="{FF2B5EF4-FFF2-40B4-BE49-F238E27FC236}">
-                <a16:creationId xmlns:a16="http://schemas.microsoft.com/office/drawing/2014/main" id="{07506367-7D55-45C7-966C-C5D417D97689}"/>
+                <a16:creationId xmlns:a16="http://schemas.microsoft.com/office/drawing/2014/main" id="{CDA1F6E8-22FE-44BC-8D82-3F85E770D407}"/>
               </a:ext>
             </a:extLst>
           </p:cNvPr>
@@ -17788,7 +18149,7 @@
           <p:cNvPr id="12" name="s1-after-value">
             <a:extLst xmlns:a="http://schemas.openxmlformats.org/drawingml/2006/main">
               <a:ext uri="{FF2B5EF4-FFF2-40B4-BE49-F238E27FC236}">
-                <a16:creationId xmlns:a16="http://schemas.microsoft.com/office/drawing/2014/main" id="{D53D13D7-0D0E-4A97-B964-5CA802D441C1}"/>
+                <a16:creationId xmlns:a16="http://schemas.microsoft.com/office/drawing/2014/main" id="{A149F6A4-AA79-45ED-9D06-41F032275EDC}"/>
               </a:ext>
             </a:extLst>
           </p:cNvPr>
@@ -17838,7 +18199,7 @@
           <p:cNvPr id="13" name="s1-after-label">
             <a:extLst xmlns:a="http://schemas.openxmlformats.org/drawingml/2006/main">
               <a:ext uri="{FF2B5EF4-FFF2-40B4-BE49-F238E27FC236}">
-                <a16:creationId xmlns:a16="http://schemas.microsoft.com/office/drawing/2014/main" id="{3EC8BC32-F39F-4E04-ADA0-DF06C1B27803}"/>
+                <a16:creationId xmlns:a16="http://schemas.microsoft.com/office/drawing/2014/main" id="{0D9C9845-6E83-4BC7-ABD7-7362D07002F8}"/>
               </a:ext>
             </a:extLst>
           </p:cNvPr>
@@ -17888,7 +18249,7 @@
           <p:cNvPr id="14" name="">
             <a:extLst xmlns:a="http://schemas.openxmlformats.org/drawingml/2006/main">
               <a:ext uri="{FF2B5EF4-FFF2-40B4-BE49-F238E27FC236}">
-                <a16:creationId xmlns:a16="http://schemas.microsoft.com/office/drawing/2014/main" id="{6E23BF0E-8CE9-4E03-B380-296E94D9CEEB}"/>
+                <a16:creationId xmlns:a16="http://schemas.microsoft.com/office/drawing/2014/main" id="{606550C2-0F89-42EB-853F-08DFDD1B3D63}"/>
               </a:ext>
             </a:extLst>
           </p:cNvPr>
@@ -17919,7 +18280,7 @@
           <p:cNvPr id="15" name="s1-delta-value">
             <a:extLst xmlns:a="http://schemas.openxmlformats.org/drawingml/2006/main">
               <a:ext uri="{FF2B5EF4-FFF2-40B4-BE49-F238E27FC236}">
-                <a16:creationId xmlns:a16="http://schemas.microsoft.com/office/drawing/2014/main" id="{3C6AA3C6-30E8-4D7C-8C9C-08FB48D1F968}"/>
+                <a16:creationId xmlns:a16="http://schemas.microsoft.com/office/drawing/2014/main" id="{1CD30539-465E-47E6-B67D-408E89DFE3D8}"/>
               </a:ext>
             </a:extLst>
           </p:cNvPr>
@@ -17969,7 +18330,7 @@
           <p:cNvPr id="16" name="s1-delta-label">
             <a:extLst xmlns:a="http://schemas.openxmlformats.org/drawingml/2006/main">
               <a:ext uri="{FF2B5EF4-FFF2-40B4-BE49-F238E27FC236}">
-                <a16:creationId xmlns:a16="http://schemas.microsoft.com/office/drawing/2014/main" id="{8EC582B2-208F-4FA1-BE3F-A7616D6C9AFA}"/>
+                <a16:creationId xmlns:a16="http://schemas.microsoft.com/office/drawing/2014/main" id="{4EDADD55-DCE9-4A02-85A2-C55740172535}"/>
               </a:ext>
             </a:extLst>
           </p:cNvPr>
@@ -18019,7 +18380,7 @@
           <p:cNvPr id="17" name="">
             <a:extLst xmlns:a="http://schemas.openxmlformats.org/drawingml/2006/main">
               <a:ext uri="{FF2B5EF4-FFF2-40B4-BE49-F238E27FC236}">
-                <a16:creationId xmlns:a16="http://schemas.microsoft.com/office/drawing/2014/main" id="{7DA03FDD-CA67-4C38-AC6F-457A63F91AE1}"/>
+                <a16:creationId xmlns:a16="http://schemas.microsoft.com/office/drawing/2014/main" id="{86EE1E75-A946-409D-B07D-BAE18FF1486C}"/>
               </a:ext>
             </a:extLst>
           </p:cNvPr>
@@ -18050,7 +18411,7 @@
           <p:cNvPr id="18" name="s1-steps-value">
             <a:extLst xmlns:a="http://schemas.openxmlformats.org/drawingml/2006/main">
               <a:ext uri="{FF2B5EF4-FFF2-40B4-BE49-F238E27FC236}">
-                <a16:creationId xmlns:a16="http://schemas.microsoft.com/office/drawing/2014/main" id="{FEFDAD11-B1AE-4F74-A013-BE664D2A398A}"/>
+                <a16:creationId xmlns:a16="http://schemas.microsoft.com/office/drawing/2014/main" id="{C70631FD-35A3-48A6-8961-EB1ECD55F194}"/>
               </a:ext>
             </a:extLst>
           </p:cNvPr>
@@ -18100,7 +18461,7 @@
           <p:cNvPr id="19" name="s1-steps-label">
             <a:extLst xmlns:a="http://schemas.openxmlformats.org/drawingml/2006/main">
               <a:ext uri="{FF2B5EF4-FFF2-40B4-BE49-F238E27FC236}">
-                <a16:creationId xmlns:a16="http://schemas.microsoft.com/office/drawing/2014/main" id="{42B92875-411C-415E-AFF9-482873BA565B}"/>
+                <a16:creationId xmlns:a16="http://schemas.microsoft.com/office/drawing/2014/main" id="{30D49BC0-7A95-4371-86BE-1A240146B1BA}"/>
               </a:ext>
             </a:extLst>
           </p:cNvPr>
@@ -18150,7 +18511,7 @@
           <p:cNvPr id="20" name="failure-head">
             <a:extLst xmlns:a="http://schemas.openxmlformats.org/drawingml/2006/main">
               <a:ext uri="{FF2B5EF4-FFF2-40B4-BE49-F238E27FC236}">
-                <a16:creationId xmlns:a16="http://schemas.microsoft.com/office/drawing/2014/main" id="{B9D44BCE-C3FD-4DA6-A070-62DD973B2E92}"/>
+                <a16:creationId xmlns:a16="http://schemas.microsoft.com/office/drawing/2014/main" id="{1D8960C3-6D08-45F6-900B-271CA880318F}"/>
               </a:ext>
             </a:extLst>
           </p:cNvPr>
@@ -18200,7 +18561,7 @@
           <p:cNvPr id="21" name="failure-name-0">
             <a:extLst xmlns:a="http://schemas.openxmlformats.org/drawingml/2006/main">
               <a:ext uri="{FF2B5EF4-FFF2-40B4-BE49-F238E27FC236}">
-                <a16:creationId xmlns:a16="http://schemas.microsoft.com/office/drawing/2014/main" id="{D6D33F69-6F25-4E9F-A1FD-32817536AB00}"/>
+                <a16:creationId xmlns:a16="http://schemas.microsoft.com/office/drawing/2014/main" id="{ED6730B5-6EB2-4F3A-B40A-5A95D24CE6D6}"/>
               </a:ext>
             </a:extLst>
           </p:cNvPr>
@@ -18250,7 +18611,7 @@
           <p:cNvPr id="22" name="failure-track-0">
             <a:extLst xmlns:a="http://schemas.openxmlformats.org/drawingml/2006/main">
               <a:ext uri="{FF2B5EF4-FFF2-40B4-BE49-F238E27FC236}">
-                <a16:creationId xmlns:a16="http://schemas.microsoft.com/office/drawing/2014/main" id="{8252CD06-17F0-4CF0-90AD-1C271FA2F3BB}"/>
+                <a16:creationId xmlns:a16="http://schemas.microsoft.com/office/drawing/2014/main" id="{45B56BD2-1B2A-46C6-82C0-56B9274D8CFF}"/>
               </a:ext>
             </a:extLst>
           </p:cNvPr>
@@ -18285,7 +18646,7 @@
           <p:cNvPr id="23" name="failure-before-0">
             <a:extLst xmlns:a="http://schemas.openxmlformats.org/drawingml/2006/main">
               <a:ext uri="{FF2B5EF4-FFF2-40B4-BE49-F238E27FC236}">
-                <a16:creationId xmlns:a16="http://schemas.microsoft.com/office/drawing/2014/main" id="{4E5699EE-70B7-4A90-8BF7-9560C5EC92A3}"/>
+                <a16:creationId xmlns:a16="http://schemas.microsoft.com/office/drawing/2014/main" id="{4944F625-F200-402B-B89D-6B596B6519A8}"/>
               </a:ext>
             </a:extLst>
           </p:cNvPr>
@@ -18320,7 +18681,7 @@
           <p:cNvPr id="24" name="failure-after-0">
             <a:extLst xmlns:a="http://schemas.openxmlformats.org/drawingml/2006/main">
               <a:ext uri="{FF2B5EF4-FFF2-40B4-BE49-F238E27FC236}">
-                <a16:creationId xmlns:a16="http://schemas.microsoft.com/office/drawing/2014/main" id="{68BC575F-2B82-4C63-93ED-5AA1A66B86D3}"/>
+                <a16:creationId xmlns:a16="http://schemas.microsoft.com/office/drawing/2014/main" id="{950AE88C-2A6F-49E5-8AAA-8F185DA14F67}"/>
               </a:ext>
             </a:extLst>
           </p:cNvPr>
@@ -18355,7 +18716,7 @@
           <p:cNvPr id="25" name="failure-count-0">
             <a:extLst xmlns:a="http://schemas.openxmlformats.org/drawingml/2006/main">
               <a:ext uri="{FF2B5EF4-FFF2-40B4-BE49-F238E27FC236}">
-                <a16:creationId xmlns:a16="http://schemas.microsoft.com/office/drawing/2014/main" id="{86F0BDEC-6630-4D7E-8B91-7601484059BB}"/>
+                <a16:creationId xmlns:a16="http://schemas.microsoft.com/office/drawing/2014/main" id="{0EE3FED2-3B7F-4615-80E9-C39578EF5BE7}"/>
               </a:ext>
             </a:extLst>
           </p:cNvPr>
@@ -18403,7 +18764,7 @@
     </p:spTree>
     <p:extLst>
       <p:ext uri="{BB962C8B-B14F-4D97-AF65-F5344CB8AC3E}">
-        <p14:creationId xmlns:p14="http://schemas.microsoft.com/office/powerpoint/2010/main" val="889108465"/>
+        <p14:creationId xmlns:p14="http://schemas.microsoft.com/office/powerpoint/2010/main" val="960418331"/>
       </p:ext>
     </p:extLst>
   </p:cSld>
@@ -18434,7 +18795,7 @@
           <p:cNvPr id="20" name="rail-9">
             <a:extLst xmlns:a="http://schemas.openxmlformats.org/drawingml/2006/main">
               <a:ext uri="{FF2B5EF4-FFF2-40B4-BE49-F238E27FC236}">
-                <a16:creationId xmlns:a16="http://schemas.microsoft.com/office/drawing/2014/main" id="{10BB12B0-2537-467C-83B8-58E18BA2A688}"/>
+                <a16:creationId xmlns:a16="http://schemas.microsoft.com/office/drawing/2014/main" id="{FD4A4525-6EE8-4749-BA7F-22D5D0891B88}"/>
               </a:ext>
             </a:extLst>
           </p:cNvPr>
@@ -18467,7 +18828,7 @@
           <p:cNvPr id="2" name="flourish-9">
             <a:extLst xmlns:a="http://schemas.openxmlformats.org/drawingml/2006/main">
               <a:ext uri="{FF2B5EF4-FFF2-40B4-BE49-F238E27FC236}">
-                <a16:creationId xmlns:a16="http://schemas.microsoft.com/office/drawing/2014/main" id="{6C1702A2-CB10-47D6-B645-F2256FA8AF5D}"/>
+                <a16:creationId xmlns:a16="http://schemas.microsoft.com/office/drawing/2014/main" id="{EF205CBF-DE63-4CBB-93A0-7D211D8DE9EB}"/>
               </a:ext>
             </a:extLst>
           </p:cNvPr>
@@ -18517,7 +18878,7 @@
           <p:cNvPr id="3" name="chapter-9">
             <a:extLst xmlns:a="http://schemas.openxmlformats.org/drawingml/2006/main">
               <a:ext uri="{FF2B5EF4-FFF2-40B4-BE49-F238E27FC236}">
-                <a16:creationId xmlns:a16="http://schemas.microsoft.com/office/drawing/2014/main" id="{7CFCA27B-F31A-4BD1-AD40-3565C8648702}"/>
+                <a16:creationId xmlns:a16="http://schemas.microsoft.com/office/drawing/2014/main" id="{EB300018-4D19-4EB3-A7C2-99B0839590AE}"/>
               </a:ext>
             </a:extLst>
           </p:cNvPr>
@@ -18567,7 +18928,7 @@
           <p:cNvPr id="4" name="title-9">
             <a:extLst xmlns:a="http://schemas.openxmlformats.org/drawingml/2006/main">
               <a:ext uri="{FF2B5EF4-FFF2-40B4-BE49-F238E27FC236}">
-                <a16:creationId xmlns:a16="http://schemas.microsoft.com/office/drawing/2014/main" id="{20D6013B-E2B1-4722-97C9-662C1A5AC548}"/>
+                <a16:creationId xmlns:a16="http://schemas.microsoft.com/office/drawing/2014/main" id="{49C23FFD-5366-411C-BF5E-9D752630B3F7}"/>
               </a:ext>
             </a:extLst>
           </p:cNvPr>
@@ -18617,7 +18978,7 @@
           <p:cNvPr id="5" name="subtitle-9">
             <a:extLst xmlns:a="http://schemas.openxmlformats.org/drawingml/2006/main">
               <a:ext uri="{FF2B5EF4-FFF2-40B4-BE49-F238E27FC236}">
-                <a16:creationId xmlns:a16="http://schemas.microsoft.com/office/drawing/2014/main" id="{0CCC5819-D85D-4E13-831D-5479AD78DA45}"/>
+                <a16:creationId xmlns:a16="http://schemas.microsoft.com/office/drawing/2014/main" id="{37FC97D5-E9B3-4FC8-A4F9-7C679EBAE8DB}"/>
               </a:ext>
             </a:extLst>
           </p:cNvPr>
@@ -18667,7 +19028,7 @@
           <p:cNvPr id="6" name="">
             <a:extLst xmlns:a="http://schemas.openxmlformats.org/drawingml/2006/main">
               <a:ext uri="{FF2B5EF4-FFF2-40B4-BE49-F238E27FC236}">
-                <a16:creationId xmlns:a16="http://schemas.microsoft.com/office/drawing/2014/main" id="{D4DA101F-4F85-4E24-ABEA-73A437DAF51C}"/>
+                <a16:creationId xmlns:a16="http://schemas.microsoft.com/office/drawing/2014/main" id="{8A9E8B2D-E9B1-472D-9285-DBF36A5391D4}"/>
               </a:ext>
             </a:extLst>
           </p:cNvPr>
@@ -18698,7 +19059,7 @@
           <p:cNvPr id="7" name="page-9">
             <a:extLst xmlns:a="http://schemas.openxmlformats.org/drawingml/2006/main">
               <a:ext uri="{FF2B5EF4-FFF2-40B4-BE49-F238E27FC236}">
-                <a16:creationId xmlns:a16="http://schemas.microsoft.com/office/drawing/2014/main" id="{53499129-E926-49B3-BEBF-45F8F9443283}"/>
+                <a16:creationId xmlns:a16="http://schemas.microsoft.com/office/drawing/2014/main" id="{9785AE88-804F-4407-B97B-D548959BDAB4}"/>
               </a:ext>
             </a:extLst>
           </p:cNvPr>
@@ -18748,7 +19109,7 @@
           <p:cNvPr id="8" name="">
             <a:extLst xmlns:a="http://schemas.openxmlformats.org/drawingml/2006/main">
               <a:ext uri="{FF2B5EF4-FFF2-40B4-BE49-F238E27FC236}">
-                <a16:creationId xmlns:a16="http://schemas.microsoft.com/office/drawing/2014/main" id="{6843CBA0-58EC-48B1-B06E-168A196D864F}"/>
+                <a16:creationId xmlns:a16="http://schemas.microsoft.com/office/drawing/2014/main" id="{3EADFBD1-22FA-48E8-BFE4-A2F7F764F5E5}"/>
               </a:ext>
             </a:extLst>
           </p:cNvPr>
@@ -18779,7 +19140,7 @@
           <p:cNvPr id="9" name="">
             <a:extLst xmlns:a="http://schemas.openxmlformats.org/drawingml/2006/main">
               <a:ext uri="{FF2B5EF4-FFF2-40B4-BE49-F238E27FC236}">
-                <a16:creationId xmlns:a16="http://schemas.microsoft.com/office/drawing/2014/main" id="{30AFF141-A396-42AA-8366-791CACC2DE23}"/>
+                <a16:creationId xmlns:a16="http://schemas.microsoft.com/office/drawing/2014/main" id="{17730680-3BDA-495A-AA37-8D62D0ABC7C8}"/>
               </a:ext>
             </a:extLst>
           </p:cNvPr>
@@ -18810,7 +19171,7 @@
           <p:cNvPr id="10" name="synth-left">
             <a:extLst xmlns:a="http://schemas.openxmlformats.org/drawingml/2006/main">
               <a:ext uri="{FF2B5EF4-FFF2-40B4-BE49-F238E27FC236}">
-                <a16:creationId xmlns:a16="http://schemas.microsoft.com/office/drawing/2014/main" id="{84E98836-CB5E-4448-803F-57927E4F43B5}"/>
+                <a16:creationId xmlns:a16="http://schemas.microsoft.com/office/drawing/2014/main" id="{EF9B339A-FA85-4841-BA3D-0D8E836A8131}"/>
               </a:ext>
             </a:extLst>
           </p:cNvPr>
@@ -18845,7 +19206,7 @@
           <p:cNvPr id="11" name="synth-mid">
             <a:extLst xmlns:a="http://schemas.openxmlformats.org/drawingml/2006/main">
               <a:ext uri="{FF2B5EF4-FFF2-40B4-BE49-F238E27FC236}">
-                <a16:creationId xmlns:a16="http://schemas.microsoft.com/office/drawing/2014/main" id="{C45EC3E3-DB86-42D5-9912-E6CCC5340702}"/>
+                <a16:creationId xmlns:a16="http://schemas.microsoft.com/office/drawing/2014/main" id="{A252D822-A481-4C5A-94A5-751731E00F5B}"/>
               </a:ext>
             </a:extLst>
           </p:cNvPr>
@@ -18880,7 +19241,7 @@
           <p:cNvPr id="12" name="synth-right">
             <a:extLst xmlns:a="http://schemas.openxmlformats.org/drawingml/2006/main">
               <a:ext uri="{FF2B5EF4-FFF2-40B4-BE49-F238E27FC236}">
-                <a16:creationId xmlns:a16="http://schemas.microsoft.com/office/drawing/2014/main" id="{021BF42E-3B40-4820-97F4-8759FB364343}"/>
+                <a16:creationId xmlns:a16="http://schemas.microsoft.com/office/drawing/2014/main" id="{EB7D6562-61AA-4117-81A7-758DDE975434}"/>
               </a:ext>
             </a:extLst>
           </p:cNvPr>
@@ -18915,7 +19276,7 @@
           <p:cNvPr id="13" name="synth-left-k">
             <a:extLst xmlns:a="http://schemas.openxmlformats.org/drawingml/2006/main">
               <a:ext uri="{FF2B5EF4-FFF2-40B4-BE49-F238E27FC236}">
-                <a16:creationId xmlns:a16="http://schemas.microsoft.com/office/drawing/2014/main" id="{74DD8B50-450D-4218-8100-4D0AE3FB01CD}"/>
+                <a16:creationId xmlns:a16="http://schemas.microsoft.com/office/drawing/2014/main" id="{51D0642A-2601-45B4-BFA8-FAB8A7C6C6FF}"/>
               </a:ext>
             </a:extLst>
           </p:cNvPr>
@@ -18965,7 +19326,7 @@
           <p:cNvPr id="14" name="synth-left-v">
             <a:extLst xmlns:a="http://schemas.openxmlformats.org/drawingml/2006/main">
               <a:ext uri="{FF2B5EF4-FFF2-40B4-BE49-F238E27FC236}">
-                <a16:creationId xmlns:a16="http://schemas.microsoft.com/office/drawing/2014/main" id="{A2815C15-D902-4125-8BA1-8B9922001A7E}"/>
+                <a16:creationId xmlns:a16="http://schemas.microsoft.com/office/drawing/2014/main" id="{7B549C91-EE17-4390-846C-9584B0B0BAEE}"/>
               </a:ext>
             </a:extLst>
           </p:cNvPr>
@@ -19032,7 +19393,7 @@
           <p:cNvPr id="15" name="synth-mid-k">
             <a:extLst xmlns:a="http://schemas.openxmlformats.org/drawingml/2006/main">
               <a:ext uri="{FF2B5EF4-FFF2-40B4-BE49-F238E27FC236}">
-                <a16:creationId xmlns:a16="http://schemas.microsoft.com/office/drawing/2014/main" id="{DE96780C-4F4F-4310-8B1F-567B143103B3}"/>
+                <a16:creationId xmlns:a16="http://schemas.microsoft.com/office/drawing/2014/main" id="{C16D24B0-A13F-4A6B-BC06-BC6895E55A13}"/>
               </a:ext>
             </a:extLst>
           </p:cNvPr>
@@ -19099,7 +19460,7 @@
           <p:cNvPr id="16" name="synth-mid-v">
             <a:extLst xmlns:a="http://schemas.openxmlformats.org/drawingml/2006/main">
               <a:ext uri="{FF2B5EF4-FFF2-40B4-BE49-F238E27FC236}">
-                <a16:creationId xmlns:a16="http://schemas.microsoft.com/office/drawing/2014/main" id="{476B322D-357D-4B66-AAEE-EC24E66D3098}"/>
+                <a16:creationId xmlns:a16="http://schemas.microsoft.com/office/drawing/2014/main" id="{7AB9CBB9-D106-4C47-8346-42D9FB374C34}"/>
               </a:ext>
             </a:extLst>
           </p:cNvPr>
@@ -19216,7 +19577,7 @@
           <p:cNvPr id="17" name="synth-right-k">
             <a:extLst xmlns:a="http://schemas.openxmlformats.org/drawingml/2006/main">
               <a:ext uri="{FF2B5EF4-FFF2-40B4-BE49-F238E27FC236}">
-                <a16:creationId xmlns:a16="http://schemas.microsoft.com/office/drawing/2014/main" id="{44811041-E9F1-4FDA-853E-3BEE61B67C5D}"/>
+                <a16:creationId xmlns:a16="http://schemas.microsoft.com/office/drawing/2014/main" id="{08CBE57A-1537-4F84-A4F5-36023C5963FA}"/>
               </a:ext>
             </a:extLst>
           </p:cNvPr>
@@ -19266,7 +19627,7 @@
           <p:cNvPr id="18" name="synth-right-v">
             <a:extLst xmlns:a="http://schemas.openxmlformats.org/drawingml/2006/main">
               <a:ext uri="{FF2B5EF4-FFF2-40B4-BE49-F238E27FC236}">
-                <a16:creationId xmlns:a16="http://schemas.microsoft.com/office/drawing/2014/main" id="{D5592C5E-20B6-4101-A48C-D4AFF227F146}"/>
+                <a16:creationId xmlns:a16="http://schemas.microsoft.com/office/drawing/2014/main" id="{F40F0917-7CB4-4D39-94B3-327537BAACF2}"/>
               </a:ext>
             </a:extLst>
           </p:cNvPr>
@@ -19350,7 +19711,7 @@
           <p:cNvPr id="19" name="synth-hash">
             <a:extLst xmlns:a="http://schemas.openxmlformats.org/drawingml/2006/main">
               <a:ext uri="{FF2B5EF4-FFF2-40B4-BE49-F238E27FC236}">
-                <a16:creationId xmlns:a16="http://schemas.microsoft.com/office/drawing/2014/main" id="{835AB4C4-A63C-44BE-808A-5EECCDFA8109}"/>
+                <a16:creationId xmlns:a16="http://schemas.microsoft.com/office/drawing/2014/main" id="{FBE6BD74-65FA-4192-B6DB-7D7E6F1441C0}"/>
               </a:ext>
             </a:extLst>
           </p:cNvPr>
@@ -19398,7 +19759,7 @@
     </p:spTree>
     <p:extLst>
       <p:ext uri="{BB962C8B-B14F-4D97-AF65-F5344CB8AC3E}">
-        <p14:creationId xmlns:p14="http://schemas.microsoft.com/office/powerpoint/2010/main" val="40648063"/>
+        <p14:creationId xmlns:p14="http://schemas.microsoft.com/office/powerpoint/2010/main" val="1658170826"/>
       </p:ext>
     </p:extLst>
   </p:cSld>

</xml_diff>

<commit_message>
docs(agentQwen): feature curriculum flywheel figure
</commit_message>
<xml_diff>
--- a/agentQwen/slides/AgenticQwen_Curriculum_Cloud.pptx
+++ b/agentQwen/slides/AgenticQwen_Curriculum_Cloud.pptx
@@ -2,28 +2,28 @@
 <file path=ppt/presentation.xml><?xml version="1.0" encoding="utf-8"?>
 <p:presentation xmlns:p="http://schemas.openxmlformats.org/presentationml/2006/main">
   <p:sldMasterIdLst>
-    <p:sldMasterId xmlns:r="http://schemas.openxmlformats.org/officeDocument/2006/relationships" id="2147483648" r:id="Ra719b380f55b4361"/>
+    <p:sldMasterId xmlns:r="http://schemas.openxmlformats.org/officeDocument/2006/relationships" id="2147483648" r:id="Rea7945ff65214b83"/>
   </p:sldMasterIdLst>
   <p:notesMasterIdLst>
-    <p:notesMasterId xmlns:r="http://schemas.openxmlformats.org/officeDocument/2006/relationships" r:id="Ree4a924ef3a3468e"/>
+    <p:notesMasterId xmlns:r="http://schemas.openxmlformats.org/officeDocument/2006/relationships" r:id="R4d1d0244504e4682"/>
   </p:notesMasterIdLst>
   <p:sldIdLst>
-    <p:sldId xmlns:r="http://schemas.openxmlformats.org/officeDocument/2006/relationships" id="256" r:id="R4917e464529d4db1"/>
-    <p:sldId xmlns:r="http://schemas.openxmlformats.org/officeDocument/2006/relationships" id="257" r:id="R86473819c6054252"/>
-    <p:sldId xmlns:r="http://schemas.openxmlformats.org/officeDocument/2006/relationships" id="258" r:id="R83204962f6774ff0"/>
-    <p:sldId xmlns:r="http://schemas.openxmlformats.org/officeDocument/2006/relationships" id="259" r:id="R0b4e6b08ca00417e"/>
-    <p:sldId xmlns:r="http://schemas.openxmlformats.org/officeDocument/2006/relationships" id="260" r:id="R4cc6aa1b2cd14ced"/>
-    <p:sldId xmlns:r="http://schemas.openxmlformats.org/officeDocument/2006/relationships" id="261" r:id="Rd68cf32722424323"/>
-    <p:sldId xmlns:r="http://schemas.openxmlformats.org/officeDocument/2006/relationships" id="262" r:id="Rb05f5de24a014b7c"/>
-    <p:sldId xmlns:r="http://schemas.openxmlformats.org/officeDocument/2006/relationships" id="263" r:id="Rfb63ae7d86954df4"/>
-    <p:sldId xmlns:r="http://schemas.openxmlformats.org/officeDocument/2006/relationships" id="264" r:id="Rc6f8e9f6d6094098"/>
-    <p:sldId xmlns:r="http://schemas.openxmlformats.org/officeDocument/2006/relationships" id="265" r:id="Ra3c5bca19346440b"/>
-    <p:sldId xmlns:r="http://schemas.openxmlformats.org/officeDocument/2006/relationships" id="266" r:id="Ra55b4d2bfc044e82"/>
-    <p:sldId xmlns:r="http://schemas.openxmlformats.org/officeDocument/2006/relationships" id="267" r:id="R4834883ee617498c"/>
-    <p:sldId xmlns:r="http://schemas.openxmlformats.org/officeDocument/2006/relationships" id="268" r:id="R533bbe65ae574072"/>
-    <p:sldId xmlns:r="http://schemas.openxmlformats.org/officeDocument/2006/relationships" id="269" r:id="R666fcc2a72a2482f"/>
-    <p:sldId xmlns:r="http://schemas.openxmlformats.org/officeDocument/2006/relationships" id="270" r:id="R66f9074648ce45ee"/>
-    <p:sldId xmlns:r="http://schemas.openxmlformats.org/officeDocument/2006/relationships" id="271" r:id="R855a6d7538a34b57"/>
+    <p:sldId xmlns:r="http://schemas.openxmlformats.org/officeDocument/2006/relationships" id="256" r:id="R606b404bc82f43b0"/>
+    <p:sldId xmlns:r="http://schemas.openxmlformats.org/officeDocument/2006/relationships" id="257" r:id="R5304f1ad7f244320"/>
+    <p:sldId xmlns:r="http://schemas.openxmlformats.org/officeDocument/2006/relationships" id="258" r:id="Rdf3e6f09db9147b4"/>
+    <p:sldId xmlns:r="http://schemas.openxmlformats.org/officeDocument/2006/relationships" id="259" r:id="R6386e4396efc49e1"/>
+    <p:sldId xmlns:r="http://schemas.openxmlformats.org/officeDocument/2006/relationships" id="260" r:id="R1eba2ba32150480e"/>
+    <p:sldId xmlns:r="http://schemas.openxmlformats.org/officeDocument/2006/relationships" id="261" r:id="R6071695009bc4d4f"/>
+    <p:sldId xmlns:r="http://schemas.openxmlformats.org/officeDocument/2006/relationships" id="262" r:id="Ra47d4c59e78b4f36"/>
+    <p:sldId xmlns:r="http://schemas.openxmlformats.org/officeDocument/2006/relationships" id="263" r:id="R55c9d5de37cc42e5"/>
+    <p:sldId xmlns:r="http://schemas.openxmlformats.org/officeDocument/2006/relationships" id="264" r:id="R3b516797b71043ce"/>
+    <p:sldId xmlns:r="http://schemas.openxmlformats.org/officeDocument/2006/relationships" id="265" r:id="R1ab56bd3df44479b"/>
+    <p:sldId xmlns:r="http://schemas.openxmlformats.org/officeDocument/2006/relationships" id="266" r:id="Ra47422d5456a4345"/>
+    <p:sldId xmlns:r="http://schemas.openxmlformats.org/officeDocument/2006/relationships" id="267" r:id="R2fe78f62c9d745ee"/>
+    <p:sldId xmlns:r="http://schemas.openxmlformats.org/officeDocument/2006/relationships" id="268" r:id="Ra78fc8d3dd184f4c"/>
+    <p:sldId xmlns:r="http://schemas.openxmlformats.org/officeDocument/2006/relationships" id="269" r:id="R47642ecfba7f4a6f"/>
+    <p:sldId xmlns:r="http://schemas.openxmlformats.org/officeDocument/2006/relationships" id="270" r:id="R921d96d02d9849a7"/>
+    <p:sldId xmlns:r="http://schemas.openxmlformats.org/officeDocument/2006/relationships" id="271" r:id="R18bb3c58be2148fe"/>
   </p:sldIdLst>
   <p:sldSz cx="12192000" cy="6858000"/>
   <p:notesSz cx="6858000" cy="9144000"/>
@@ -1970,7 +1970,7 @@
   </p:cSld>
   <p:clrMap bg1="lt1" tx1="dk1" bg2="lt2" tx2="dk2" accent1="accent1" accent2="accent2" accent3="accent3" accent4="accent4" accent5="accent5" accent6="accent6" hlink="hlink" folHlink="folHlink"/>
   <p:sldLayoutIdLst>
-    <p:sldLayoutId xmlns:r="http://schemas.openxmlformats.org/officeDocument/2006/relationships" id="2147483649" r:id="R5604e068f0af4db1"/>
+    <p:sldLayoutId xmlns:r="http://schemas.openxmlformats.org/officeDocument/2006/relationships" id="2147483649" r:id="R6db9c6a7199c4d5c"/>
   </p:sldLayoutIdLst>
   <p:txStyles>
     <p:titleStyle>
@@ -2521,7 +2521,7 @@
           <p:cNvPr id="14" name="cover-copper">
             <a:extLst xmlns:a="http://schemas.openxmlformats.org/drawingml/2006/main">
               <a:ext uri="{FF2B5EF4-FFF2-40B4-BE49-F238E27FC236}">
-                <a16:creationId xmlns:a16="http://schemas.microsoft.com/office/drawing/2014/main" id="{A3AAFC37-45FB-42D7-A21D-DFDCA3074656}"/>
+                <a16:creationId xmlns:a16="http://schemas.microsoft.com/office/drawing/2014/main" id="{0A22D651-C953-4AA3-8B6B-FD46006DCBF9}"/>
               </a:ext>
             </a:extLst>
           </p:cNvPr>
@@ -2554,7 +2554,7 @@
           <p:cNvPr id="2" name="cover-teal">
             <a:extLst xmlns:a="http://schemas.openxmlformats.org/drawingml/2006/main">
               <a:ext uri="{FF2B5EF4-FFF2-40B4-BE49-F238E27FC236}">
-                <a16:creationId xmlns:a16="http://schemas.microsoft.com/office/drawing/2014/main" id="{9C5D5A58-4674-4A65-BD92-DB11D0946991}"/>
+                <a16:creationId xmlns:a16="http://schemas.microsoft.com/office/drawing/2014/main" id="{49CE55D6-4171-46E4-BE59-06099F83191A}"/>
               </a:ext>
             </a:extLst>
           </p:cNvPr>
@@ -2587,7 +2587,7 @@
           <p:cNvPr id="3" name="cover-flourish">
             <a:extLst xmlns:a="http://schemas.openxmlformats.org/drawingml/2006/main">
               <a:ext uri="{FF2B5EF4-FFF2-40B4-BE49-F238E27FC236}">
-                <a16:creationId xmlns:a16="http://schemas.microsoft.com/office/drawing/2014/main" id="{7B2D43DE-40DE-4B07-A594-C572A12CD766}"/>
+                <a16:creationId xmlns:a16="http://schemas.microsoft.com/office/drawing/2014/main" id="{329A963F-16F5-475C-9955-641A23D848A1}"/>
               </a:ext>
             </a:extLst>
           </p:cNvPr>
@@ -2637,7 +2637,7 @@
           <p:cNvPr id="4" name="">
             <a:extLst xmlns:a="http://schemas.openxmlformats.org/drawingml/2006/main">
               <a:ext uri="{FF2B5EF4-FFF2-40B4-BE49-F238E27FC236}">
-                <a16:creationId xmlns:a16="http://schemas.microsoft.com/office/drawing/2014/main" id="{9687052F-7E46-4C5B-A43D-7BACFC0DDB8F}"/>
+                <a16:creationId xmlns:a16="http://schemas.microsoft.com/office/drawing/2014/main" id="{48ECE487-E945-4785-93F3-F2EC23CB5042}"/>
               </a:ext>
             </a:extLst>
           </p:cNvPr>
@@ -2668,7 +2668,7 @@
           <p:cNvPr id="5" name="cover-title">
             <a:extLst xmlns:a="http://schemas.openxmlformats.org/drawingml/2006/main">
               <a:ext uri="{FF2B5EF4-FFF2-40B4-BE49-F238E27FC236}">
-                <a16:creationId xmlns:a16="http://schemas.microsoft.com/office/drawing/2014/main" id="{3F640336-60F9-4C90-A213-A52464F6D1CF}"/>
+                <a16:creationId xmlns:a16="http://schemas.microsoft.com/office/drawing/2014/main" id="{2BE12064-07AB-4A46-B19A-DD6A9B73CE50}"/>
               </a:ext>
             </a:extLst>
           </p:cNvPr>
@@ -2743,7 +2743,7 @@
           <p:cNvPr id="6" name="cover-sub">
             <a:extLst xmlns:a="http://schemas.openxmlformats.org/drawingml/2006/main">
               <a:ext uri="{FF2B5EF4-FFF2-40B4-BE49-F238E27FC236}">
-                <a16:creationId xmlns:a16="http://schemas.microsoft.com/office/drawing/2014/main" id="{C187B2FB-2F8D-45A4-9601-5FEF00B07C58}"/>
+                <a16:creationId xmlns:a16="http://schemas.microsoft.com/office/drawing/2014/main" id="{FD6DC556-103D-4CA0-B414-993B23B9624A}"/>
               </a:ext>
             </a:extLst>
           </p:cNvPr>
@@ -2793,7 +2793,7 @@
           <p:cNvPr id="7" name="cover-meta">
             <a:extLst xmlns:a="http://schemas.openxmlformats.org/drawingml/2006/main">
               <a:ext uri="{FF2B5EF4-FFF2-40B4-BE49-F238E27FC236}">
-                <a16:creationId xmlns:a16="http://schemas.microsoft.com/office/drawing/2014/main" id="{7F504254-A10E-4002-9718-8945F0F2208D}"/>
+                <a16:creationId xmlns:a16="http://schemas.microsoft.com/office/drawing/2014/main" id="{190ECAE5-CA11-4C20-95A2-CC3FC57B23AA}"/>
               </a:ext>
             </a:extLst>
           </p:cNvPr>
@@ -2860,7 +2860,7 @@
           <p:cNvPr id="8" name="cover-02">
             <a:extLst xmlns:a="http://schemas.openxmlformats.org/drawingml/2006/main">
               <a:ext uri="{FF2B5EF4-FFF2-40B4-BE49-F238E27FC236}">
-                <a16:creationId xmlns:a16="http://schemas.microsoft.com/office/drawing/2014/main" id="{EC9ABD35-5C30-4288-8D71-A9F3BB7D63A3}"/>
+                <a16:creationId xmlns:a16="http://schemas.microsoft.com/office/drawing/2014/main" id="{4D8F7612-4D96-4C56-9588-82C25A0DBFAE}"/>
               </a:ext>
             </a:extLst>
           </p:cNvPr>
@@ -2910,7 +2910,7 @@
           <p:cNvPr id="9" name="cover-side">
             <a:extLst xmlns:a="http://schemas.openxmlformats.org/drawingml/2006/main">
               <a:ext uri="{FF2B5EF4-FFF2-40B4-BE49-F238E27FC236}">
-                <a16:creationId xmlns:a16="http://schemas.microsoft.com/office/drawing/2014/main" id="{C7C54416-277F-492E-9399-632047F383A5}"/>
+                <a16:creationId xmlns:a16="http://schemas.microsoft.com/office/drawing/2014/main" id="{88CF6F2D-DDCF-4103-8C53-8A5EC7B7F9E5}"/>
               </a:ext>
             </a:extLst>
           </p:cNvPr>
@@ -3006,7 +3006,7 @@
           <p:cNvPr id="10" name="cover-pass-bg">
             <a:extLst xmlns:a="http://schemas.openxmlformats.org/drawingml/2006/main">
               <a:ext uri="{FF2B5EF4-FFF2-40B4-BE49-F238E27FC236}">
-                <a16:creationId xmlns:a16="http://schemas.microsoft.com/office/drawing/2014/main" id="{143A654D-107C-416C-AE04-8AB492D07692}"/>
+                <a16:creationId xmlns:a16="http://schemas.microsoft.com/office/drawing/2014/main" id="{7C624002-72A8-4741-A747-887E4B2DF06A}"/>
               </a:ext>
             </a:extLst>
           </p:cNvPr>
@@ -3041,7 +3041,7 @@
           <p:cNvPr id="11" name="cover-pass-text">
             <a:extLst xmlns:a="http://schemas.openxmlformats.org/drawingml/2006/main">
               <a:ext uri="{FF2B5EF4-FFF2-40B4-BE49-F238E27FC236}">
-                <a16:creationId xmlns:a16="http://schemas.microsoft.com/office/drawing/2014/main" id="{48177318-7308-406B-B50C-8BD614795F38}"/>
+                <a16:creationId xmlns:a16="http://schemas.microsoft.com/office/drawing/2014/main" id="{A6EF7121-366E-47E7-9846-21B7248D1002}"/>
               </a:ext>
             </a:extLst>
           </p:cNvPr>
@@ -3091,7 +3091,7 @@
           <p:cNvPr id="12" name="cover-bfcl-bg">
             <a:extLst xmlns:a="http://schemas.openxmlformats.org/drawingml/2006/main">
               <a:ext uri="{FF2B5EF4-FFF2-40B4-BE49-F238E27FC236}">
-                <a16:creationId xmlns:a16="http://schemas.microsoft.com/office/drawing/2014/main" id="{D1493735-888F-4EE1-9F77-560C0DBB505B}"/>
+                <a16:creationId xmlns:a16="http://schemas.microsoft.com/office/drawing/2014/main" id="{BD518565-72C8-47F3-A5E0-0058D4AB7837}"/>
               </a:ext>
             </a:extLst>
           </p:cNvPr>
@@ -3126,7 +3126,7 @@
           <p:cNvPr id="13" name="cover-bfcl-text">
             <a:extLst xmlns:a="http://schemas.openxmlformats.org/drawingml/2006/main">
               <a:ext uri="{FF2B5EF4-FFF2-40B4-BE49-F238E27FC236}">
-                <a16:creationId xmlns:a16="http://schemas.microsoft.com/office/drawing/2014/main" id="{EA027DC0-4FB8-4A71-9CA2-53B7D24FE843}"/>
+                <a16:creationId xmlns:a16="http://schemas.microsoft.com/office/drawing/2014/main" id="{48714DF7-2C3A-4E5A-8E5B-174FB3BB3C30}"/>
               </a:ext>
             </a:extLst>
           </p:cNvPr>
@@ -3174,7 +3174,7 @@
     </p:spTree>
     <p:extLst>
       <p:ext uri="{BB962C8B-B14F-4D97-AF65-F5344CB8AC3E}">
-        <p14:creationId xmlns:p14="http://schemas.microsoft.com/office/powerpoint/2010/main" val="2000420436"/>
+        <p14:creationId xmlns:p14="http://schemas.microsoft.com/office/powerpoint/2010/main" val="610844466"/>
       </p:ext>
     </p:extLst>
   </p:cSld>
@@ -3205,7 +3205,7 @@
           <p:cNvPr id="32" name="rail-10">
             <a:extLst xmlns:a="http://schemas.openxmlformats.org/drawingml/2006/main">
               <a:ext uri="{FF2B5EF4-FFF2-40B4-BE49-F238E27FC236}">
-                <a16:creationId xmlns:a16="http://schemas.microsoft.com/office/drawing/2014/main" id="{1B0C0F30-B05F-42A5-9FBF-D402549EC3B1}"/>
+                <a16:creationId xmlns:a16="http://schemas.microsoft.com/office/drawing/2014/main" id="{C6B19692-0D44-419A-AB27-8714EF4BEA90}"/>
               </a:ext>
             </a:extLst>
           </p:cNvPr>
@@ -3238,7 +3238,7 @@
           <p:cNvPr id="2" name="flourish-10">
             <a:extLst xmlns:a="http://schemas.openxmlformats.org/drawingml/2006/main">
               <a:ext uri="{FF2B5EF4-FFF2-40B4-BE49-F238E27FC236}">
-                <a16:creationId xmlns:a16="http://schemas.microsoft.com/office/drawing/2014/main" id="{803EAF10-B44D-459B-8271-7C7EF44AC11D}"/>
+                <a16:creationId xmlns:a16="http://schemas.microsoft.com/office/drawing/2014/main" id="{E00154BE-B5CE-491C-A6FF-7810EE3B352C}"/>
               </a:ext>
             </a:extLst>
           </p:cNvPr>
@@ -3288,7 +3288,7 @@
           <p:cNvPr id="3" name="chapter-10">
             <a:extLst xmlns:a="http://schemas.openxmlformats.org/drawingml/2006/main">
               <a:ext uri="{FF2B5EF4-FFF2-40B4-BE49-F238E27FC236}">
-                <a16:creationId xmlns:a16="http://schemas.microsoft.com/office/drawing/2014/main" id="{C6DED371-E487-40C1-AB71-E758E28042EC}"/>
+                <a16:creationId xmlns:a16="http://schemas.microsoft.com/office/drawing/2014/main" id="{EE849D94-4615-4BCC-AB29-E8FB87450170}"/>
               </a:ext>
             </a:extLst>
           </p:cNvPr>
@@ -3338,7 +3338,7 @@
           <p:cNvPr id="4" name="title-10">
             <a:extLst xmlns:a="http://schemas.openxmlformats.org/drawingml/2006/main">
               <a:ext uri="{FF2B5EF4-FFF2-40B4-BE49-F238E27FC236}">
-                <a16:creationId xmlns:a16="http://schemas.microsoft.com/office/drawing/2014/main" id="{5508BE95-FECA-48F8-A55F-AC92C9133A7A}"/>
+                <a16:creationId xmlns:a16="http://schemas.microsoft.com/office/drawing/2014/main" id="{61BF481A-6FA1-4EF4-B0DB-9A6C1F782819}"/>
               </a:ext>
             </a:extLst>
           </p:cNvPr>
@@ -3388,7 +3388,7 @@
           <p:cNvPr id="5" name="subtitle-10">
             <a:extLst xmlns:a="http://schemas.openxmlformats.org/drawingml/2006/main">
               <a:ext uri="{FF2B5EF4-FFF2-40B4-BE49-F238E27FC236}">
-                <a16:creationId xmlns:a16="http://schemas.microsoft.com/office/drawing/2014/main" id="{86D0FA3E-8752-43EA-9089-664621A30911}"/>
+                <a16:creationId xmlns:a16="http://schemas.microsoft.com/office/drawing/2014/main" id="{EAAF3144-7939-4A5B-847F-053E5A914895}"/>
               </a:ext>
             </a:extLst>
           </p:cNvPr>
@@ -3438,7 +3438,7 @@
           <p:cNvPr id="6" name="">
             <a:extLst xmlns:a="http://schemas.openxmlformats.org/drawingml/2006/main">
               <a:ext uri="{FF2B5EF4-FFF2-40B4-BE49-F238E27FC236}">
-                <a16:creationId xmlns:a16="http://schemas.microsoft.com/office/drawing/2014/main" id="{8E144FF5-EC4F-469A-A1F8-B59A74832220}"/>
+                <a16:creationId xmlns:a16="http://schemas.microsoft.com/office/drawing/2014/main" id="{B17E7479-BA7E-4BF5-87A5-EE4083DFF78B}"/>
               </a:ext>
             </a:extLst>
           </p:cNvPr>
@@ -3469,7 +3469,7 @@
           <p:cNvPr id="7" name="page-10">
             <a:extLst xmlns:a="http://schemas.openxmlformats.org/drawingml/2006/main">
               <a:ext uri="{FF2B5EF4-FFF2-40B4-BE49-F238E27FC236}">
-                <a16:creationId xmlns:a16="http://schemas.microsoft.com/office/drawing/2014/main" id="{07CFF9FD-6A49-4835-9CB6-2768F48F8123}"/>
+                <a16:creationId xmlns:a16="http://schemas.microsoft.com/office/drawing/2014/main" id="{A1AD820B-9560-47BA-9D68-DFBD05FFC625}"/>
               </a:ext>
             </a:extLst>
           </p:cNvPr>
@@ -3519,7 +3519,7 @@
           <p:cNvPr id="8" name="s2-label-0">
             <a:extLst xmlns:a="http://schemas.openxmlformats.org/drawingml/2006/main">
               <a:ext uri="{FF2B5EF4-FFF2-40B4-BE49-F238E27FC236}">
-                <a16:creationId xmlns:a16="http://schemas.microsoft.com/office/drawing/2014/main" id="{F71E654E-BB4F-4613-9CA7-4737629E7F20}"/>
+                <a16:creationId xmlns:a16="http://schemas.microsoft.com/office/drawing/2014/main" id="{5288852F-040B-4617-B5F1-FCE1D78698C0}"/>
               </a:ext>
             </a:extLst>
           </p:cNvPr>
@@ -3569,7 +3569,7 @@
           <p:cNvPr id="9" name="s2-track-a-0">
             <a:extLst xmlns:a="http://schemas.openxmlformats.org/drawingml/2006/main">
               <a:ext uri="{FF2B5EF4-FFF2-40B4-BE49-F238E27FC236}">
-                <a16:creationId xmlns:a16="http://schemas.microsoft.com/office/drawing/2014/main" id="{5D82D279-ECD4-449A-8161-7A42FDE41C19}"/>
+                <a16:creationId xmlns:a16="http://schemas.microsoft.com/office/drawing/2014/main" id="{5CB56315-7780-4E7C-A4AC-C2E13B7527A0}"/>
               </a:ext>
             </a:extLst>
           </p:cNvPr>
@@ -3604,7 +3604,7 @@
           <p:cNvPr id="10" name="s2-a-0">
             <a:extLst xmlns:a="http://schemas.openxmlformats.org/drawingml/2006/main">
               <a:ext uri="{FF2B5EF4-FFF2-40B4-BE49-F238E27FC236}">
-                <a16:creationId xmlns:a16="http://schemas.microsoft.com/office/drawing/2014/main" id="{0FC142B1-E9BC-44E9-B081-A588CD712335}"/>
+                <a16:creationId xmlns:a16="http://schemas.microsoft.com/office/drawing/2014/main" id="{13DD2263-F356-4330-B36D-1962A0C28B08}"/>
               </a:ext>
             </a:extLst>
           </p:cNvPr>
@@ -3639,7 +3639,7 @@
           <p:cNvPr id="11" name="s2-track-b-0">
             <a:extLst xmlns:a="http://schemas.openxmlformats.org/drawingml/2006/main">
               <a:ext uri="{FF2B5EF4-FFF2-40B4-BE49-F238E27FC236}">
-                <a16:creationId xmlns:a16="http://schemas.microsoft.com/office/drawing/2014/main" id="{FF665D72-AA16-4797-B241-ACC0172D0627}"/>
+                <a16:creationId xmlns:a16="http://schemas.microsoft.com/office/drawing/2014/main" id="{01119389-3DC4-473E-8D0B-019291FD614D}"/>
               </a:ext>
             </a:extLst>
           </p:cNvPr>
@@ -3674,7 +3674,7 @@
           <p:cNvPr id="12" name="s2-b-0">
             <a:extLst xmlns:a="http://schemas.openxmlformats.org/drawingml/2006/main">
               <a:ext uri="{FF2B5EF4-FFF2-40B4-BE49-F238E27FC236}">
-                <a16:creationId xmlns:a16="http://schemas.microsoft.com/office/drawing/2014/main" id="{9937E3BF-0ACE-436B-AC54-1EDE0F86C8F0}"/>
+                <a16:creationId xmlns:a16="http://schemas.microsoft.com/office/drawing/2014/main" id="{ADE730FF-4176-4A8D-94DF-BEB879880099}"/>
               </a:ext>
             </a:extLst>
           </p:cNvPr>
@@ -3709,7 +3709,7 @@
           <p:cNvPr id="13" name="s2-value-0">
             <a:extLst xmlns:a="http://schemas.openxmlformats.org/drawingml/2006/main">
               <a:ext uri="{FF2B5EF4-FFF2-40B4-BE49-F238E27FC236}">
-                <a16:creationId xmlns:a16="http://schemas.microsoft.com/office/drawing/2014/main" id="{DF9757F1-1773-43C3-A155-BDBDF6A5CE58}"/>
+                <a16:creationId xmlns:a16="http://schemas.microsoft.com/office/drawing/2014/main" id="{4CCB58AF-D849-4C5F-A910-93485322C391}"/>
               </a:ext>
             </a:extLst>
           </p:cNvPr>
@@ -3759,7 +3759,7 @@
           <p:cNvPr id="14" name="s2-label-1">
             <a:extLst xmlns:a="http://schemas.openxmlformats.org/drawingml/2006/main">
               <a:ext uri="{FF2B5EF4-FFF2-40B4-BE49-F238E27FC236}">
-                <a16:creationId xmlns:a16="http://schemas.microsoft.com/office/drawing/2014/main" id="{626455D0-9689-415A-AB77-1802B32900E7}"/>
+                <a16:creationId xmlns:a16="http://schemas.microsoft.com/office/drawing/2014/main" id="{8471F093-F785-4019-9E94-D0A6DB193B94}"/>
               </a:ext>
             </a:extLst>
           </p:cNvPr>
@@ -3809,7 +3809,7 @@
           <p:cNvPr id="15" name="s2-track-a-1">
             <a:extLst xmlns:a="http://schemas.openxmlformats.org/drawingml/2006/main">
               <a:ext uri="{FF2B5EF4-FFF2-40B4-BE49-F238E27FC236}">
-                <a16:creationId xmlns:a16="http://schemas.microsoft.com/office/drawing/2014/main" id="{7C4AC0B3-D96A-43AB-A0F0-949C753FB734}"/>
+                <a16:creationId xmlns:a16="http://schemas.microsoft.com/office/drawing/2014/main" id="{FB57BC36-139C-43AF-AE9B-4F9C52272930}"/>
               </a:ext>
             </a:extLst>
           </p:cNvPr>
@@ -3844,7 +3844,7 @@
           <p:cNvPr id="16" name="s2-a-1">
             <a:extLst xmlns:a="http://schemas.openxmlformats.org/drawingml/2006/main">
               <a:ext uri="{FF2B5EF4-FFF2-40B4-BE49-F238E27FC236}">
-                <a16:creationId xmlns:a16="http://schemas.microsoft.com/office/drawing/2014/main" id="{61A274E0-0F6E-445F-AE80-8220D832E30E}"/>
+                <a16:creationId xmlns:a16="http://schemas.microsoft.com/office/drawing/2014/main" id="{072C0C04-E116-443F-BE05-968674C3D31E}"/>
               </a:ext>
             </a:extLst>
           </p:cNvPr>
@@ -3879,7 +3879,7 @@
           <p:cNvPr id="17" name="s2-track-b-1">
             <a:extLst xmlns:a="http://schemas.openxmlformats.org/drawingml/2006/main">
               <a:ext uri="{FF2B5EF4-FFF2-40B4-BE49-F238E27FC236}">
-                <a16:creationId xmlns:a16="http://schemas.microsoft.com/office/drawing/2014/main" id="{1799C0C8-F217-46F2-A58E-24B89581C4BB}"/>
+                <a16:creationId xmlns:a16="http://schemas.microsoft.com/office/drawing/2014/main" id="{3AAF5E1C-7997-4FA5-8144-7A8117E0DAEE}"/>
               </a:ext>
             </a:extLst>
           </p:cNvPr>
@@ -3914,7 +3914,7 @@
           <p:cNvPr id="18" name="s2-b-1">
             <a:extLst xmlns:a="http://schemas.openxmlformats.org/drawingml/2006/main">
               <a:ext uri="{FF2B5EF4-FFF2-40B4-BE49-F238E27FC236}">
-                <a16:creationId xmlns:a16="http://schemas.microsoft.com/office/drawing/2014/main" id="{B5D985BC-ACD2-4432-BDAF-B219E3CC49B8}"/>
+                <a16:creationId xmlns:a16="http://schemas.microsoft.com/office/drawing/2014/main" id="{E92194CE-522F-4A55-BA27-4B722C5DA00C}"/>
               </a:ext>
             </a:extLst>
           </p:cNvPr>
@@ -3949,7 +3949,7 @@
           <p:cNvPr id="19" name="s2-value-1">
             <a:extLst xmlns:a="http://schemas.openxmlformats.org/drawingml/2006/main">
               <a:ext uri="{FF2B5EF4-FFF2-40B4-BE49-F238E27FC236}">
-                <a16:creationId xmlns:a16="http://schemas.microsoft.com/office/drawing/2014/main" id="{1DC48206-A967-4360-9C76-82C234D4057E}"/>
+                <a16:creationId xmlns:a16="http://schemas.microsoft.com/office/drawing/2014/main" id="{AF728E05-5BE8-4918-91CE-2B45E1EF9C5F}"/>
               </a:ext>
             </a:extLst>
           </p:cNvPr>
@@ -3999,7 +3999,7 @@
           <p:cNvPr id="20" name="">
             <a:extLst xmlns:a="http://schemas.openxmlformats.org/drawingml/2006/main">
               <a:ext uri="{FF2B5EF4-FFF2-40B4-BE49-F238E27FC236}">
-                <a16:creationId xmlns:a16="http://schemas.microsoft.com/office/drawing/2014/main" id="{F931E67B-7A24-4271-B237-E7F2FB0BED9F}"/>
+                <a16:creationId xmlns:a16="http://schemas.microsoft.com/office/drawing/2014/main" id="{D7701E91-97B1-4CA5-AF8B-56424B40EA07}"/>
               </a:ext>
             </a:extLst>
           </p:cNvPr>
@@ -4030,7 +4030,7 @@
           <p:cNvPr id="21" name="s2-step-value">
             <a:extLst xmlns:a="http://schemas.openxmlformats.org/drawingml/2006/main">
               <a:ext uri="{FF2B5EF4-FFF2-40B4-BE49-F238E27FC236}">
-                <a16:creationId xmlns:a16="http://schemas.microsoft.com/office/drawing/2014/main" id="{5473DF4D-80E8-4BA9-B57A-FAC31474233A}"/>
+                <a16:creationId xmlns:a16="http://schemas.microsoft.com/office/drawing/2014/main" id="{518D27E0-5C61-429F-855D-2EDCAAA27AEB}"/>
               </a:ext>
             </a:extLst>
           </p:cNvPr>
@@ -4080,7 +4080,7 @@
           <p:cNvPr id="22" name="s2-step-label">
             <a:extLst xmlns:a="http://schemas.openxmlformats.org/drawingml/2006/main">
               <a:ext uri="{FF2B5EF4-FFF2-40B4-BE49-F238E27FC236}">
-                <a16:creationId xmlns:a16="http://schemas.microsoft.com/office/drawing/2014/main" id="{5DFF219E-EA5D-4572-BC9F-4F1C443A3353}"/>
+                <a16:creationId xmlns:a16="http://schemas.microsoft.com/office/drawing/2014/main" id="{F0D8968E-036A-45CC-9A5F-850FF1C269B3}"/>
               </a:ext>
             </a:extLst>
           </p:cNvPr>
@@ -4130,7 +4130,7 @@
           <p:cNvPr id="23" name="">
             <a:extLst xmlns:a="http://schemas.openxmlformats.org/drawingml/2006/main">
               <a:ext uri="{FF2B5EF4-FFF2-40B4-BE49-F238E27FC236}">
-                <a16:creationId xmlns:a16="http://schemas.microsoft.com/office/drawing/2014/main" id="{AE2C46FB-CFF2-40E9-A76C-BD2A009BB815}"/>
+                <a16:creationId xmlns:a16="http://schemas.microsoft.com/office/drawing/2014/main" id="{F88F88ED-631B-4238-9A65-8D363E19CDAF}"/>
               </a:ext>
             </a:extLst>
           </p:cNvPr>
@@ -4161,7 +4161,7 @@
           <p:cNvPr id="24" name="s2-time-value">
             <a:extLst xmlns:a="http://schemas.openxmlformats.org/drawingml/2006/main">
               <a:ext uri="{FF2B5EF4-FFF2-40B4-BE49-F238E27FC236}">
-                <a16:creationId xmlns:a16="http://schemas.microsoft.com/office/drawing/2014/main" id="{0DD66ADE-DD21-44FF-803B-8A1530D3B216}"/>
+                <a16:creationId xmlns:a16="http://schemas.microsoft.com/office/drawing/2014/main" id="{373DC0CA-A7CC-4D77-8677-08879BBFFE80}"/>
               </a:ext>
             </a:extLst>
           </p:cNvPr>
@@ -4211,7 +4211,7 @@
           <p:cNvPr id="25" name="s2-time-label">
             <a:extLst xmlns:a="http://schemas.openxmlformats.org/drawingml/2006/main">
               <a:ext uri="{FF2B5EF4-FFF2-40B4-BE49-F238E27FC236}">
-                <a16:creationId xmlns:a16="http://schemas.microsoft.com/office/drawing/2014/main" id="{76D1BA7F-7AC9-428D-8618-E1EF525FAAF1}"/>
+                <a16:creationId xmlns:a16="http://schemas.microsoft.com/office/drawing/2014/main" id="{5FECCEFA-94CF-4302-9A60-7D6576573EE1}"/>
               </a:ext>
             </a:extLst>
           </p:cNvPr>
@@ -4261,7 +4261,7 @@
           <p:cNvPr id="26" name="">
             <a:extLst xmlns:a="http://schemas.openxmlformats.org/drawingml/2006/main">
               <a:ext uri="{FF2B5EF4-FFF2-40B4-BE49-F238E27FC236}">
-                <a16:creationId xmlns:a16="http://schemas.microsoft.com/office/drawing/2014/main" id="{BA10364E-EAC0-4967-AD92-B0BEDAF0D8F5}"/>
+                <a16:creationId xmlns:a16="http://schemas.microsoft.com/office/drawing/2014/main" id="{96409DB0-22F4-4285-8938-50063C2BBD57}"/>
               </a:ext>
             </a:extLst>
           </p:cNvPr>
@@ -4292,7 +4292,7 @@
           <p:cNvPr id="27" name="s2-replay-value">
             <a:extLst xmlns:a="http://schemas.openxmlformats.org/drawingml/2006/main">
               <a:ext uri="{FF2B5EF4-FFF2-40B4-BE49-F238E27FC236}">
-                <a16:creationId xmlns:a16="http://schemas.microsoft.com/office/drawing/2014/main" id="{6652B8A5-A8D7-4B94-8A0C-662C965ABF10}"/>
+                <a16:creationId xmlns:a16="http://schemas.microsoft.com/office/drawing/2014/main" id="{232C82E8-76CB-4ABF-805F-5A03E33F2222}"/>
               </a:ext>
             </a:extLst>
           </p:cNvPr>
@@ -4342,7 +4342,7 @@
           <p:cNvPr id="28" name="s2-replay-label">
             <a:extLst xmlns:a="http://schemas.openxmlformats.org/drawingml/2006/main">
               <a:ext uri="{FF2B5EF4-FFF2-40B4-BE49-F238E27FC236}">
-                <a16:creationId xmlns:a16="http://schemas.microsoft.com/office/drawing/2014/main" id="{73990377-94F7-4E20-8B49-D6FF62FC74F4}"/>
+                <a16:creationId xmlns:a16="http://schemas.microsoft.com/office/drawing/2014/main" id="{FC590F31-BBC9-47C0-B00E-46F694CF3882}"/>
               </a:ext>
             </a:extLst>
           </p:cNvPr>
@@ -4392,7 +4392,7 @@
           <p:cNvPr id="29" name="">
             <a:extLst xmlns:a="http://schemas.openxmlformats.org/drawingml/2006/main">
               <a:ext uri="{FF2B5EF4-FFF2-40B4-BE49-F238E27FC236}">
-                <a16:creationId xmlns:a16="http://schemas.microsoft.com/office/drawing/2014/main" id="{29EBBD58-D4E7-40A5-8793-B199054532A2}"/>
+                <a16:creationId xmlns:a16="http://schemas.microsoft.com/office/drawing/2014/main" id="{CAF25E5D-A6B2-4349-A9E8-0274B55C43B7}"/>
               </a:ext>
             </a:extLst>
           </p:cNvPr>
@@ -4423,7 +4423,7 @@
           <p:cNvPr id="30" name="s2-gpu-value">
             <a:extLst xmlns:a="http://schemas.openxmlformats.org/drawingml/2006/main">
               <a:ext uri="{FF2B5EF4-FFF2-40B4-BE49-F238E27FC236}">
-                <a16:creationId xmlns:a16="http://schemas.microsoft.com/office/drawing/2014/main" id="{F16D3C83-5F09-4525-8336-696522C8EB26}"/>
+                <a16:creationId xmlns:a16="http://schemas.microsoft.com/office/drawing/2014/main" id="{1FF82135-94E7-461C-B7DF-CA33C21C61A1}"/>
               </a:ext>
             </a:extLst>
           </p:cNvPr>
@@ -4473,7 +4473,7 @@
           <p:cNvPr id="31" name="s2-gpu-label">
             <a:extLst xmlns:a="http://schemas.openxmlformats.org/drawingml/2006/main">
               <a:ext uri="{FF2B5EF4-FFF2-40B4-BE49-F238E27FC236}">
-                <a16:creationId xmlns:a16="http://schemas.microsoft.com/office/drawing/2014/main" id="{42161E20-FBAA-4347-8457-EDA93E632BE7}"/>
+                <a16:creationId xmlns:a16="http://schemas.microsoft.com/office/drawing/2014/main" id="{E34962AA-1E06-4F77-9BFD-934E23A9C564}"/>
               </a:ext>
             </a:extLst>
           </p:cNvPr>
@@ -4521,7 +4521,7 @@
     </p:spTree>
     <p:extLst>
       <p:ext uri="{BB962C8B-B14F-4D97-AF65-F5344CB8AC3E}">
-        <p14:creationId xmlns:p14="http://schemas.microsoft.com/office/powerpoint/2010/main" val="652854009"/>
+        <p14:creationId xmlns:p14="http://schemas.microsoft.com/office/powerpoint/2010/main" val="740780276"/>
       </p:ext>
     </p:extLst>
   </p:cSld>
@@ -4552,7 +4552,7 @@
           <p:cNvPr id="39" name="rail-11">
             <a:extLst xmlns:a="http://schemas.openxmlformats.org/drawingml/2006/main">
               <a:ext uri="{FF2B5EF4-FFF2-40B4-BE49-F238E27FC236}">
-                <a16:creationId xmlns:a16="http://schemas.microsoft.com/office/drawing/2014/main" id="{4C4492C2-975B-4E8F-963A-428399FB667C}"/>
+                <a16:creationId xmlns:a16="http://schemas.microsoft.com/office/drawing/2014/main" id="{0F01EF6B-63EE-46CE-AEC0-A10CFC6CBA69}"/>
               </a:ext>
             </a:extLst>
           </p:cNvPr>
@@ -4585,7 +4585,7 @@
           <p:cNvPr id="2" name="flourish-11">
             <a:extLst xmlns:a="http://schemas.openxmlformats.org/drawingml/2006/main">
               <a:ext uri="{FF2B5EF4-FFF2-40B4-BE49-F238E27FC236}">
-                <a16:creationId xmlns:a16="http://schemas.microsoft.com/office/drawing/2014/main" id="{2F38F26A-1A14-40C5-B30B-B7F0EEE54688}"/>
+                <a16:creationId xmlns:a16="http://schemas.microsoft.com/office/drawing/2014/main" id="{432C530B-89F6-45F0-9A62-2B17B438EA89}"/>
               </a:ext>
             </a:extLst>
           </p:cNvPr>
@@ -4635,7 +4635,7 @@
           <p:cNvPr id="3" name="chapter-11">
             <a:extLst xmlns:a="http://schemas.openxmlformats.org/drawingml/2006/main">
               <a:ext uri="{FF2B5EF4-FFF2-40B4-BE49-F238E27FC236}">
-                <a16:creationId xmlns:a16="http://schemas.microsoft.com/office/drawing/2014/main" id="{FCA9D017-56A0-4F04-9231-F8FFC3084AAA}"/>
+                <a16:creationId xmlns:a16="http://schemas.microsoft.com/office/drawing/2014/main" id="{EA995694-0084-45B9-8FDA-3F755E0D9534}"/>
               </a:ext>
             </a:extLst>
           </p:cNvPr>
@@ -4685,7 +4685,7 @@
           <p:cNvPr id="4" name="title-11">
             <a:extLst xmlns:a="http://schemas.openxmlformats.org/drawingml/2006/main">
               <a:ext uri="{FF2B5EF4-FFF2-40B4-BE49-F238E27FC236}">
-                <a16:creationId xmlns:a16="http://schemas.microsoft.com/office/drawing/2014/main" id="{566D63B9-AC1D-4880-A6EC-BBDF3F388BD8}"/>
+                <a16:creationId xmlns:a16="http://schemas.microsoft.com/office/drawing/2014/main" id="{F135672C-524A-4DE5-A8B0-D35B7E79BE41}"/>
               </a:ext>
             </a:extLst>
           </p:cNvPr>
@@ -4735,7 +4735,7 @@
           <p:cNvPr id="5" name="subtitle-11">
             <a:extLst xmlns:a="http://schemas.openxmlformats.org/drawingml/2006/main">
               <a:ext uri="{FF2B5EF4-FFF2-40B4-BE49-F238E27FC236}">
-                <a16:creationId xmlns:a16="http://schemas.microsoft.com/office/drawing/2014/main" id="{3D5B72F6-BAD9-4020-B86A-B94234ABFD8C}"/>
+                <a16:creationId xmlns:a16="http://schemas.microsoft.com/office/drawing/2014/main" id="{A104AD44-4749-45A6-A5F0-9662ABBBE654}"/>
               </a:ext>
             </a:extLst>
           </p:cNvPr>
@@ -4785,7 +4785,7 @@
           <p:cNvPr id="6" name="">
             <a:extLst xmlns:a="http://schemas.openxmlformats.org/drawingml/2006/main">
               <a:ext uri="{FF2B5EF4-FFF2-40B4-BE49-F238E27FC236}">
-                <a16:creationId xmlns:a16="http://schemas.microsoft.com/office/drawing/2014/main" id="{F2E4D061-1B5C-4778-A50A-6E53723F20E2}"/>
+                <a16:creationId xmlns:a16="http://schemas.microsoft.com/office/drawing/2014/main" id="{EC57AF87-BA96-4233-AF64-0DBEAE25FDC4}"/>
               </a:ext>
             </a:extLst>
           </p:cNvPr>
@@ -4816,7 +4816,7 @@
           <p:cNvPr id="7" name="page-11">
             <a:extLst xmlns:a="http://schemas.openxmlformats.org/drawingml/2006/main">
               <a:ext uri="{FF2B5EF4-FFF2-40B4-BE49-F238E27FC236}">
-                <a16:creationId xmlns:a16="http://schemas.microsoft.com/office/drawing/2014/main" id="{21B5A8F7-7118-4DF9-95E6-66E250C01D58}"/>
+                <a16:creationId xmlns:a16="http://schemas.microsoft.com/office/drawing/2014/main" id="{CFA9DF39-F2DC-453D-B81F-2A57FBB049BB}"/>
               </a:ext>
             </a:extLst>
           </p:cNvPr>
@@ -4866,7 +4866,7 @@
           <p:cNvPr id="8" name="traj-spine">
             <a:extLst xmlns:a="http://schemas.openxmlformats.org/drawingml/2006/main">
               <a:ext uri="{FF2B5EF4-FFF2-40B4-BE49-F238E27FC236}">
-                <a16:creationId xmlns:a16="http://schemas.microsoft.com/office/drawing/2014/main" id="{2370BF78-D8E4-4199-BF82-727D5CDF2675}"/>
+                <a16:creationId xmlns:a16="http://schemas.microsoft.com/office/drawing/2014/main" id="{DC75547B-04E8-4388-898B-5C060DC353CA}"/>
               </a:ext>
             </a:extLst>
           </p:cNvPr>
@@ -4899,7 +4899,7 @@
           <p:cNvPr id="9" name="traj-dot-0">
             <a:extLst xmlns:a="http://schemas.openxmlformats.org/drawingml/2006/main">
               <a:ext uri="{FF2B5EF4-FFF2-40B4-BE49-F238E27FC236}">
-                <a16:creationId xmlns:a16="http://schemas.microsoft.com/office/drawing/2014/main" id="{CA88B178-F169-470B-AB1B-44460B6721A7}"/>
+                <a16:creationId xmlns:a16="http://schemas.microsoft.com/office/drawing/2014/main" id="{C8F70D9B-F784-4DEE-B2F3-A4A0C7E18E57}"/>
               </a:ext>
             </a:extLst>
           </p:cNvPr>
@@ -4934,7 +4934,7 @@
           <p:cNvPr id="10" name="traj-num-0">
             <a:extLst xmlns:a="http://schemas.openxmlformats.org/drawingml/2006/main">
               <a:ext uri="{FF2B5EF4-FFF2-40B4-BE49-F238E27FC236}">
-                <a16:creationId xmlns:a16="http://schemas.microsoft.com/office/drawing/2014/main" id="{62A863E7-CCD5-4A87-9E15-30F1877C3D6B}"/>
+                <a16:creationId xmlns:a16="http://schemas.microsoft.com/office/drawing/2014/main" id="{D23037C4-5DE2-42E1-97C7-20DCB9F0C7DD}"/>
               </a:ext>
             </a:extLst>
           </p:cNvPr>
@@ -4984,7 +4984,7 @@
           <p:cNvPr id="11" name="traj-tool-0">
             <a:extLst xmlns:a="http://schemas.openxmlformats.org/drawingml/2006/main">
               <a:ext uri="{FF2B5EF4-FFF2-40B4-BE49-F238E27FC236}">
-                <a16:creationId xmlns:a16="http://schemas.microsoft.com/office/drawing/2014/main" id="{46B6F65F-E16F-4249-A73E-150689D18F19}"/>
+                <a16:creationId xmlns:a16="http://schemas.microsoft.com/office/drawing/2014/main" id="{25262CB1-A164-4DD6-99D0-4281D36D4773}"/>
               </a:ext>
             </a:extLst>
           </p:cNvPr>
@@ -5034,7 +5034,7 @@
           <p:cNvPr id="12" name="traj-obs-0">
             <a:extLst xmlns:a="http://schemas.openxmlformats.org/drawingml/2006/main">
               <a:ext uri="{FF2B5EF4-FFF2-40B4-BE49-F238E27FC236}">
-                <a16:creationId xmlns:a16="http://schemas.microsoft.com/office/drawing/2014/main" id="{B3662C79-C11C-4BEB-967B-69D12D14EC9D}"/>
+                <a16:creationId xmlns:a16="http://schemas.microsoft.com/office/drawing/2014/main" id="{2F43E74B-C511-4EEC-988E-A8822A577EC5}"/>
               </a:ext>
             </a:extLst>
           </p:cNvPr>
@@ -5084,7 +5084,7 @@
           <p:cNvPr id="13" name="traj-dot-1">
             <a:extLst xmlns:a="http://schemas.openxmlformats.org/drawingml/2006/main">
               <a:ext uri="{FF2B5EF4-FFF2-40B4-BE49-F238E27FC236}">
-                <a16:creationId xmlns:a16="http://schemas.microsoft.com/office/drawing/2014/main" id="{ED50F07C-72D0-47FA-B503-D1928266BC8A}"/>
+                <a16:creationId xmlns:a16="http://schemas.microsoft.com/office/drawing/2014/main" id="{9D2791AA-BB3A-454B-9A57-D64E94119975}"/>
               </a:ext>
             </a:extLst>
           </p:cNvPr>
@@ -5119,7 +5119,7 @@
           <p:cNvPr id="14" name="traj-num-1">
             <a:extLst xmlns:a="http://schemas.openxmlformats.org/drawingml/2006/main">
               <a:ext uri="{FF2B5EF4-FFF2-40B4-BE49-F238E27FC236}">
-                <a16:creationId xmlns:a16="http://schemas.microsoft.com/office/drawing/2014/main" id="{FF0A6BFE-E71E-45C5-BAFF-149DFAAAE8FA}"/>
+                <a16:creationId xmlns:a16="http://schemas.microsoft.com/office/drawing/2014/main" id="{DE93DADA-758D-45DB-9C44-EA0FE946AC8F}"/>
               </a:ext>
             </a:extLst>
           </p:cNvPr>
@@ -5169,7 +5169,7 @@
           <p:cNvPr id="15" name="traj-tool-1">
             <a:extLst xmlns:a="http://schemas.openxmlformats.org/drawingml/2006/main">
               <a:ext uri="{FF2B5EF4-FFF2-40B4-BE49-F238E27FC236}">
-                <a16:creationId xmlns:a16="http://schemas.microsoft.com/office/drawing/2014/main" id="{DDF42A3A-DC3F-4ACF-AD63-A0686CCB7384}"/>
+                <a16:creationId xmlns:a16="http://schemas.microsoft.com/office/drawing/2014/main" id="{C7C0E9C7-A056-4E90-83DB-07F43A713384}"/>
               </a:ext>
             </a:extLst>
           </p:cNvPr>
@@ -5219,7 +5219,7 @@
           <p:cNvPr id="16" name="traj-obs-1">
             <a:extLst xmlns:a="http://schemas.openxmlformats.org/drawingml/2006/main">
               <a:ext uri="{FF2B5EF4-FFF2-40B4-BE49-F238E27FC236}">
-                <a16:creationId xmlns:a16="http://schemas.microsoft.com/office/drawing/2014/main" id="{2580ED2B-4DDF-4D77-9683-95D1EB44882E}"/>
+                <a16:creationId xmlns:a16="http://schemas.microsoft.com/office/drawing/2014/main" id="{1DBF575B-B63A-44BB-A946-BC263DE074D6}"/>
               </a:ext>
             </a:extLst>
           </p:cNvPr>
@@ -5269,7 +5269,7 @@
           <p:cNvPr id="17" name="traj-dot-2">
             <a:extLst xmlns:a="http://schemas.openxmlformats.org/drawingml/2006/main">
               <a:ext uri="{FF2B5EF4-FFF2-40B4-BE49-F238E27FC236}">
-                <a16:creationId xmlns:a16="http://schemas.microsoft.com/office/drawing/2014/main" id="{6427E7A2-DC47-46F8-937B-64C485457DAC}"/>
+                <a16:creationId xmlns:a16="http://schemas.microsoft.com/office/drawing/2014/main" id="{AF94B954-C75E-4CF1-B30B-09B673B806F3}"/>
               </a:ext>
             </a:extLst>
           </p:cNvPr>
@@ -5304,7 +5304,7 @@
           <p:cNvPr id="18" name="traj-num-2">
             <a:extLst xmlns:a="http://schemas.openxmlformats.org/drawingml/2006/main">
               <a:ext uri="{FF2B5EF4-FFF2-40B4-BE49-F238E27FC236}">
-                <a16:creationId xmlns:a16="http://schemas.microsoft.com/office/drawing/2014/main" id="{1B0899EA-6CB0-44BF-83E7-E58625D461FE}"/>
+                <a16:creationId xmlns:a16="http://schemas.microsoft.com/office/drawing/2014/main" id="{70AED5EB-52DF-4CC1-918D-B12D8389424F}"/>
               </a:ext>
             </a:extLst>
           </p:cNvPr>
@@ -5354,7 +5354,7 @@
           <p:cNvPr id="19" name="traj-tool-2">
             <a:extLst xmlns:a="http://schemas.openxmlformats.org/drawingml/2006/main">
               <a:ext uri="{FF2B5EF4-FFF2-40B4-BE49-F238E27FC236}">
-                <a16:creationId xmlns:a16="http://schemas.microsoft.com/office/drawing/2014/main" id="{A92BD459-CA1E-4AD3-8FCE-A098AD3C5A72}"/>
+                <a16:creationId xmlns:a16="http://schemas.microsoft.com/office/drawing/2014/main" id="{2C23F83E-C3AE-41D5-B7B8-29F6D44714E0}"/>
               </a:ext>
             </a:extLst>
           </p:cNvPr>
@@ -5404,7 +5404,7 @@
           <p:cNvPr id="20" name="traj-obs-2">
             <a:extLst xmlns:a="http://schemas.openxmlformats.org/drawingml/2006/main">
               <a:ext uri="{FF2B5EF4-FFF2-40B4-BE49-F238E27FC236}">
-                <a16:creationId xmlns:a16="http://schemas.microsoft.com/office/drawing/2014/main" id="{2FC37D54-D746-4AB6-BD55-E8BA45920561}"/>
+                <a16:creationId xmlns:a16="http://schemas.microsoft.com/office/drawing/2014/main" id="{E4DFC978-D59A-4D27-8828-12DE90B01089}"/>
               </a:ext>
             </a:extLst>
           </p:cNvPr>
@@ -5454,7 +5454,7 @@
           <p:cNvPr id="21" name="traj-dot-3">
             <a:extLst xmlns:a="http://schemas.openxmlformats.org/drawingml/2006/main">
               <a:ext uri="{FF2B5EF4-FFF2-40B4-BE49-F238E27FC236}">
-                <a16:creationId xmlns:a16="http://schemas.microsoft.com/office/drawing/2014/main" id="{00970C02-1D6E-44D6-B48A-7E5ED1678BC8}"/>
+                <a16:creationId xmlns:a16="http://schemas.microsoft.com/office/drawing/2014/main" id="{F0394C59-8F4F-42DE-874A-0766AA20AF7A}"/>
               </a:ext>
             </a:extLst>
           </p:cNvPr>
@@ -5489,7 +5489,7 @@
           <p:cNvPr id="22" name="traj-num-3">
             <a:extLst xmlns:a="http://schemas.openxmlformats.org/drawingml/2006/main">
               <a:ext uri="{FF2B5EF4-FFF2-40B4-BE49-F238E27FC236}">
-                <a16:creationId xmlns:a16="http://schemas.microsoft.com/office/drawing/2014/main" id="{4DED6649-1C02-479A-ADCA-67D8A21A63B3}"/>
+                <a16:creationId xmlns:a16="http://schemas.microsoft.com/office/drawing/2014/main" id="{590BE3E3-2060-4A7B-936E-4443BD14D99B}"/>
               </a:ext>
             </a:extLst>
           </p:cNvPr>
@@ -5539,7 +5539,7 @@
           <p:cNvPr id="23" name="traj-tool-3">
             <a:extLst xmlns:a="http://schemas.openxmlformats.org/drawingml/2006/main">
               <a:ext uri="{FF2B5EF4-FFF2-40B4-BE49-F238E27FC236}">
-                <a16:creationId xmlns:a16="http://schemas.microsoft.com/office/drawing/2014/main" id="{8F50EF22-5016-4259-94AE-014846981F3E}"/>
+                <a16:creationId xmlns:a16="http://schemas.microsoft.com/office/drawing/2014/main" id="{F80E561B-8F55-4934-AE67-FB3F66306A98}"/>
               </a:ext>
             </a:extLst>
           </p:cNvPr>
@@ -5589,7 +5589,7 @@
           <p:cNvPr id="24" name="traj-obs-3">
             <a:extLst xmlns:a="http://schemas.openxmlformats.org/drawingml/2006/main">
               <a:ext uri="{FF2B5EF4-FFF2-40B4-BE49-F238E27FC236}">
-                <a16:creationId xmlns:a16="http://schemas.microsoft.com/office/drawing/2014/main" id="{760B82CC-CBE2-44B7-BF9E-16CC4C842ABD}"/>
+                <a16:creationId xmlns:a16="http://schemas.microsoft.com/office/drawing/2014/main" id="{D4AE48B6-B475-4F76-AD08-0E2E66C46B2E}"/>
               </a:ext>
             </a:extLst>
           </p:cNvPr>
@@ -5639,7 +5639,7 @@
           <p:cNvPr id="25" name="traj-dot-4">
             <a:extLst xmlns:a="http://schemas.openxmlformats.org/drawingml/2006/main">
               <a:ext uri="{FF2B5EF4-FFF2-40B4-BE49-F238E27FC236}">
-                <a16:creationId xmlns:a16="http://schemas.microsoft.com/office/drawing/2014/main" id="{64184EAA-CD88-4D0B-A3C9-2EF15FD186FF}"/>
+                <a16:creationId xmlns:a16="http://schemas.microsoft.com/office/drawing/2014/main" id="{6FC548C1-1B14-4DFF-BD83-B5606A05DEEA}"/>
               </a:ext>
             </a:extLst>
           </p:cNvPr>
@@ -5674,7 +5674,7 @@
           <p:cNvPr id="26" name="traj-num-4">
             <a:extLst xmlns:a="http://schemas.openxmlformats.org/drawingml/2006/main">
               <a:ext uri="{FF2B5EF4-FFF2-40B4-BE49-F238E27FC236}">
-                <a16:creationId xmlns:a16="http://schemas.microsoft.com/office/drawing/2014/main" id="{E3B75EF7-1495-4F35-9E10-AB9DF3E1A37C}"/>
+                <a16:creationId xmlns:a16="http://schemas.microsoft.com/office/drawing/2014/main" id="{BFE22536-D06A-4F10-8389-C0DCA08CEFFB}"/>
               </a:ext>
             </a:extLst>
           </p:cNvPr>
@@ -5724,7 +5724,7 @@
           <p:cNvPr id="27" name="traj-tool-4">
             <a:extLst xmlns:a="http://schemas.openxmlformats.org/drawingml/2006/main">
               <a:ext uri="{FF2B5EF4-FFF2-40B4-BE49-F238E27FC236}">
-                <a16:creationId xmlns:a16="http://schemas.microsoft.com/office/drawing/2014/main" id="{C3A4CC64-D0EA-4660-93E5-D4851945CF94}"/>
+                <a16:creationId xmlns:a16="http://schemas.microsoft.com/office/drawing/2014/main" id="{AECC7637-40E9-4FB3-BE73-20A0F4519599}"/>
               </a:ext>
             </a:extLst>
           </p:cNvPr>
@@ -5774,7 +5774,7 @@
           <p:cNvPr id="28" name="traj-obs-4">
             <a:extLst xmlns:a="http://schemas.openxmlformats.org/drawingml/2006/main">
               <a:ext uri="{FF2B5EF4-FFF2-40B4-BE49-F238E27FC236}">
-                <a16:creationId xmlns:a16="http://schemas.microsoft.com/office/drawing/2014/main" id="{45D43A47-F780-4208-8179-D4B8096B8B36}"/>
+                <a16:creationId xmlns:a16="http://schemas.microsoft.com/office/drawing/2014/main" id="{87E339A4-860B-4BFC-BC56-F0E0B61377F9}"/>
               </a:ext>
             </a:extLst>
           </p:cNvPr>
@@ -5824,7 +5824,7 @@
           <p:cNvPr id="29" name="traj-dot-5">
             <a:extLst xmlns:a="http://schemas.openxmlformats.org/drawingml/2006/main">
               <a:ext uri="{FF2B5EF4-FFF2-40B4-BE49-F238E27FC236}">
-                <a16:creationId xmlns:a16="http://schemas.microsoft.com/office/drawing/2014/main" id="{CB559767-FD2C-4A6B-B0C2-0380654DAD55}"/>
+                <a16:creationId xmlns:a16="http://schemas.microsoft.com/office/drawing/2014/main" id="{AF89F9B8-CD1F-442B-A759-37E7A0E6A87D}"/>
               </a:ext>
             </a:extLst>
           </p:cNvPr>
@@ -5859,7 +5859,7 @@
           <p:cNvPr id="30" name="traj-num-5">
             <a:extLst xmlns:a="http://schemas.openxmlformats.org/drawingml/2006/main">
               <a:ext uri="{FF2B5EF4-FFF2-40B4-BE49-F238E27FC236}">
-                <a16:creationId xmlns:a16="http://schemas.microsoft.com/office/drawing/2014/main" id="{DC006D23-8068-4B61-9AE9-7CA89D73319D}"/>
+                <a16:creationId xmlns:a16="http://schemas.microsoft.com/office/drawing/2014/main" id="{24BB051D-8FFC-4DBF-A710-D057FC26123F}"/>
               </a:ext>
             </a:extLst>
           </p:cNvPr>
@@ -5909,7 +5909,7 @@
           <p:cNvPr id="31" name="traj-tool-5">
             <a:extLst xmlns:a="http://schemas.openxmlformats.org/drawingml/2006/main">
               <a:ext uri="{FF2B5EF4-FFF2-40B4-BE49-F238E27FC236}">
-                <a16:creationId xmlns:a16="http://schemas.microsoft.com/office/drawing/2014/main" id="{9F18483B-F0FA-483B-A5CF-45F052A65822}"/>
+                <a16:creationId xmlns:a16="http://schemas.microsoft.com/office/drawing/2014/main" id="{75C6DEE8-B15B-4A81-8CCD-15359D5182D2}"/>
               </a:ext>
             </a:extLst>
           </p:cNvPr>
@@ -5959,7 +5959,7 @@
           <p:cNvPr id="32" name="traj-obs-5">
             <a:extLst xmlns:a="http://schemas.openxmlformats.org/drawingml/2006/main">
               <a:ext uri="{FF2B5EF4-FFF2-40B4-BE49-F238E27FC236}">
-                <a16:creationId xmlns:a16="http://schemas.microsoft.com/office/drawing/2014/main" id="{A54DF042-5962-400D-901C-65CC92D1539F}"/>
+                <a16:creationId xmlns:a16="http://schemas.microsoft.com/office/drawing/2014/main" id="{7802E3D6-3E23-43CD-8C9F-0A652B76D92D}"/>
               </a:ext>
             </a:extLst>
           </p:cNvPr>
@@ -6009,7 +6009,7 @@
           <p:cNvPr id="33" name="traj-dot-6">
             <a:extLst xmlns:a="http://schemas.openxmlformats.org/drawingml/2006/main">
               <a:ext uri="{FF2B5EF4-FFF2-40B4-BE49-F238E27FC236}">
-                <a16:creationId xmlns:a16="http://schemas.microsoft.com/office/drawing/2014/main" id="{FF985EAF-9EC3-4990-9845-58CB1654506F}"/>
+                <a16:creationId xmlns:a16="http://schemas.microsoft.com/office/drawing/2014/main" id="{8A0D250F-4CED-4F9B-A821-85F0A78F2C4C}"/>
               </a:ext>
             </a:extLst>
           </p:cNvPr>
@@ -6044,7 +6044,7 @@
           <p:cNvPr id="34" name="traj-num-6">
             <a:extLst xmlns:a="http://schemas.openxmlformats.org/drawingml/2006/main">
               <a:ext uri="{FF2B5EF4-FFF2-40B4-BE49-F238E27FC236}">
-                <a16:creationId xmlns:a16="http://schemas.microsoft.com/office/drawing/2014/main" id="{79DD59DD-A2D1-44BF-BFBC-38DBD6745905}"/>
+                <a16:creationId xmlns:a16="http://schemas.microsoft.com/office/drawing/2014/main" id="{E0A417D9-3D2D-4C91-87F6-42BF47856AB6}"/>
               </a:ext>
             </a:extLst>
           </p:cNvPr>
@@ -6094,7 +6094,7 @@
           <p:cNvPr id="35" name="traj-tool-6">
             <a:extLst xmlns:a="http://schemas.openxmlformats.org/drawingml/2006/main">
               <a:ext uri="{FF2B5EF4-FFF2-40B4-BE49-F238E27FC236}">
-                <a16:creationId xmlns:a16="http://schemas.microsoft.com/office/drawing/2014/main" id="{E7A8F17E-296B-41DA-A698-4EF3DD4D8D8E}"/>
+                <a16:creationId xmlns:a16="http://schemas.microsoft.com/office/drawing/2014/main" id="{B03F13E5-F588-45C4-BB3F-1037D8765C98}"/>
               </a:ext>
             </a:extLst>
           </p:cNvPr>
@@ -6144,7 +6144,7 @@
           <p:cNvPr id="36" name="traj-obs-6">
             <a:extLst xmlns:a="http://schemas.openxmlformats.org/drawingml/2006/main">
               <a:ext uri="{FF2B5EF4-FFF2-40B4-BE49-F238E27FC236}">
-                <a16:creationId xmlns:a16="http://schemas.microsoft.com/office/drawing/2014/main" id="{464DE9D5-0B9A-46EA-B0DF-A9CE3B5F7BB7}"/>
+                <a16:creationId xmlns:a16="http://schemas.microsoft.com/office/drawing/2014/main" id="{01E9F964-A657-4C68-AA4E-6949F0D19274}"/>
               </a:ext>
             </a:extLst>
           </p:cNvPr>
@@ -6194,7 +6194,7 @@
           <p:cNvPr id="37" name="traj-outcome-bg">
             <a:extLst xmlns:a="http://schemas.openxmlformats.org/drawingml/2006/main">
               <a:ext uri="{FF2B5EF4-FFF2-40B4-BE49-F238E27FC236}">
-                <a16:creationId xmlns:a16="http://schemas.microsoft.com/office/drawing/2014/main" id="{B42E0409-5A52-42AA-A0F3-7427A866A130}"/>
+                <a16:creationId xmlns:a16="http://schemas.microsoft.com/office/drawing/2014/main" id="{0E1B44D5-FCCC-44E2-A5AE-00F194C5B1AE}"/>
               </a:ext>
             </a:extLst>
           </p:cNvPr>
@@ -6229,7 +6229,7 @@
           <p:cNvPr id="38" name="traj-outcome-text">
             <a:extLst xmlns:a="http://schemas.openxmlformats.org/drawingml/2006/main">
               <a:ext uri="{FF2B5EF4-FFF2-40B4-BE49-F238E27FC236}">
-                <a16:creationId xmlns:a16="http://schemas.microsoft.com/office/drawing/2014/main" id="{97DFC7AA-5327-413B-B7BC-C6FC5C29CF09}"/>
+                <a16:creationId xmlns:a16="http://schemas.microsoft.com/office/drawing/2014/main" id="{3F7AD9FA-52B4-43A7-B4B6-419A635BF2BE}"/>
               </a:ext>
             </a:extLst>
           </p:cNvPr>
@@ -6277,7 +6277,7 @@
     </p:spTree>
     <p:extLst>
       <p:ext uri="{BB962C8B-B14F-4D97-AF65-F5344CB8AC3E}">
-        <p14:creationId xmlns:p14="http://schemas.microsoft.com/office/powerpoint/2010/main" val="1893484392"/>
+        <p14:creationId xmlns:p14="http://schemas.microsoft.com/office/powerpoint/2010/main" val="1166656885"/>
       </p:ext>
     </p:extLst>
   </p:cSld>
@@ -6308,7 +6308,7 @@
           <p:cNvPr id="14" name="rail-12">
             <a:extLst xmlns:a="http://schemas.openxmlformats.org/drawingml/2006/main">
               <a:ext uri="{FF2B5EF4-FFF2-40B4-BE49-F238E27FC236}">
-                <a16:creationId xmlns:a16="http://schemas.microsoft.com/office/drawing/2014/main" id="{DDD572FA-BE18-4D05-93F4-C560BD739578}"/>
+                <a16:creationId xmlns:a16="http://schemas.microsoft.com/office/drawing/2014/main" id="{A984D337-9C3C-41A4-88E8-92B6440D27B2}"/>
               </a:ext>
             </a:extLst>
           </p:cNvPr>
@@ -6341,7 +6341,7 @@
           <p:cNvPr id="2" name="flourish-12">
             <a:extLst xmlns:a="http://schemas.openxmlformats.org/drawingml/2006/main">
               <a:ext uri="{FF2B5EF4-FFF2-40B4-BE49-F238E27FC236}">
-                <a16:creationId xmlns:a16="http://schemas.microsoft.com/office/drawing/2014/main" id="{D6E1A615-50BD-488C-AA56-25B01D597D53}"/>
+                <a16:creationId xmlns:a16="http://schemas.microsoft.com/office/drawing/2014/main" id="{9AD2B6A5-D52D-4700-815C-0559E6DF5A25}"/>
               </a:ext>
             </a:extLst>
           </p:cNvPr>
@@ -6391,7 +6391,7 @@
           <p:cNvPr id="3" name="chapter-12">
             <a:extLst xmlns:a="http://schemas.openxmlformats.org/drawingml/2006/main">
               <a:ext uri="{FF2B5EF4-FFF2-40B4-BE49-F238E27FC236}">
-                <a16:creationId xmlns:a16="http://schemas.microsoft.com/office/drawing/2014/main" id="{07BA4AFC-B19E-48A0-B192-7137DE7CBC42}"/>
+                <a16:creationId xmlns:a16="http://schemas.microsoft.com/office/drawing/2014/main" id="{561371D5-F5A6-4F37-A50B-7150EA8F9ECD}"/>
               </a:ext>
             </a:extLst>
           </p:cNvPr>
@@ -6441,7 +6441,7 @@
           <p:cNvPr id="4" name="title-12">
             <a:extLst xmlns:a="http://schemas.openxmlformats.org/drawingml/2006/main">
               <a:ext uri="{FF2B5EF4-FFF2-40B4-BE49-F238E27FC236}">
-                <a16:creationId xmlns:a16="http://schemas.microsoft.com/office/drawing/2014/main" id="{6E375C03-380E-4F1A-8E5B-5984BE600DEB}"/>
+                <a16:creationId xmlns:a16="http://schemas.microsoft.com/office/drawing/2014/main" id="{7A504ABA-9BDB-4198-99A0-93BBB3CA735D}"/>
               </a:ext>
             </a:extLst>
           </p:cNvPr>
@@ -6491,7 +6491,7 @@
           <p:cNvPr id="5" name="subtitle-12">
             <a:extLst xmlns:a="http://schemas.openxmlformats.org/drawingml/2006/main">
               <a:ext uri="{FF2B5EF4-FFF2-40B4-BE49-F238E27FC236}">
-                <a16:creationId xmlns:a16="http://schemas.microsoft.com/office/drawing/2014/main" id="{B201DE40-35C5-49F9-B87F-D75C80B247BB}"/>
+                <a16:creationId xmlns:a16="http://schemas.microsoft.com/office/drawing/2014/main" id="{0F997E42-AE1E-48C5-91D2-2F88B07B93BB}"/>
               </a:ext>
             </a:extLst>
           </p:cNvPr>
@@ -6541,7 +6541,7 @@
           <p:cNvPr id="6" name="">
             <a:extLst xmlns:a="http://schemas.openxmlformats.org/drawingml/2006/main">
               <a:ext uri="{FF2B5EF4-FFF2-40B4-BE49-F238E27FC236}">
-                <a16:creationId xmlns:a16="http://schemas.microsoft.com/office/drawing/2014/main" id="{F498A79D-04B9-4F06-A7C7-C6DC0551185A}"/>
+                <a16:creationId xmlns:a16="http://schemas.microsoft.com/office/drawing/2014/main" id="{EB5B6B54-A759-41EF-A1FF-B1524416B983}"/>
               </a:ext>
             </a:extLst>
           </p:cNvPr>
@@ -6572,7 +6572,7 @@
           <p:cNvPr id="7" name="page-12">
             <a:extLst xmlns:a="http://schemas.openxmlformats.org/drawingml/2006/main">
               <a:ext uri="{FF2B5EF4-FFF2-40B4-BE49-F238E27FC236}">
-                <a16:creationId xmlns:a16="http://schemas.microsoft.com/office/drawing/2014/main" id="{D695FACD-A559-4BE0-867D-6B67F48BB845}"/>
+                <a16:creationId xmlns:a16="http://schemas.microsoft.com/office/drawing/2014/main" id="{439F076A-BCC2-49F5-A297-6EFDBA9C1481}"/>
               </a:ext>
             </a:extLst>
           </p:cNvPr>
@@ -6622,7 +6622,7 @@
           <p:cNvPr id="8" name="benchmark-status">
             <a:extLst xmlns:a="http://schemas.openxmlformats.org/drawingml/2006/main">
               <a:ext uri="{FF2B5EF4-FFF2-40B4-BE49-F238E27FC236}">
-                <a16:creationId xmlns:a16="http://schemas.microsoft.com/office/drawing/2014/main" id="{F367758A-4CA3-4AF0-A35D-9BDAF2C9AA24}"/>
+                <a16:creationId xmlns:a16="http://schemas.microsoft.com/office/drawing/2014/main" id="{01D2B942-E666-4238-94FE-3885935FE395}"/>
               </a:ext>
             </a:extLst>
           </p:cNvPr>
@@ -6672,7 +6672,7 @@
           <p:cNvPr id="9" name="benchmark-label">
             <a:extLst xmlns:a="http://schemas.openxmlformats.org/drawingml/2006/main">
               <a:ext uri="{FF2B5EF4-FFF2-40B4-BE49-F238E27FC236}">
-                <a16:creationId xmlns:a16="http://schemas.microsoft.com/office/drawing/2014/main" id="{DB49F4AC-D3E0-475F-9FBF-0948E6FE49A6}"/>
+                <a16:creationId xmlns:a16="http://schemas.microsoft.com/office/drawing/2014/main" id="{3C72E84F-8AB8-4C7E-9232-3065B31F5DC7}"/>
               </a:ext>
             </a:extLst>
           </p:cNvPr>
@@ -6722,7 +6722,7 @@
           <p:cNvPr id="10" name="">
             <a:extLst xmlns:a="http://schemas.openxmlformats.org/drawingml/2006/main">
               <a:ext uri="{FF2B5EF4-FFF2-40B4-BE49-F238E27FC236}">
-                <a16:creationId xmlns:a16="http://schemas.microsoft.com/office/drawing/2014/main" id="{F288954A-930B-4756-9F26-5713A8BA75A5}"/>
+                <a16:creationId xmlns:a16="http://schemas.microsoft.com/office/drawing/2014/main" id="{E06BC403-4C1F-4FE7-98FC-9522A2787465}"/>
               </a:ext>
             </a:extLst>
           </p:cNvPr>
@@ -6753,7 +6753,7 @@
           <p:cNvPr id="11" name="benchmark-ready">
             <a:extLst xmlns:a="http://schemas.openxmlformats.org/drawingml/2006/main">
               <a:ext uri="{FF2B5EF4-FFF2-40B4-BE49-F238E27FC236}">
-                <a16:creationId xmlns:a16="http://schemas.microsoft.com/office/drawing/2014/main" id="{D214A887-D680-439E-85FD-FD163D96CA2D}"/>
+                <a16:creationId xmlns:a16="http://schemas.microsoft.com/office/drawing/2014/main" id="{AEEE6967-3D77-4F34-A460-D5E983AD8F19}"/>
               </a:ext>
             </a:extLst>
           </p:cNvPr>
@@ -6803,7 +6803,7 @@
           <p:cNvPr id="12" name="benchmark-list">
             <a:extLst xmlns:a="http://schemas.openxmlformats.org/drawingml/2006/main">
               <a:ext uri="{FF2B5EF4-FFF2-40B4-BE49-F238E27FC236}">
-                <a16:creationId xmlns:a16="http://schemas.microsoft.com/office/drawing/2014/main" id="{4BDC74FA-7D56-42A9-872F-34CB9867BD39}"/>
+                <a16:creationId xmlns:a16="http://schemas.microsoft.com/office/drawing/2014/main" id="{0F90DE71-DAF6-4BFE-90A8-7A64A27D4FF3}"/>
               </a:ext>
             </a:extLst>
           </p:cNvPr>
@@ -6920,7 +6920,7 @@
           <p:cNvPr id="13" name="benchmark-boundary">
             <a:extLst xmlns:a="http://schemas.openxmlformats.org/drawingml/2006/main">
               <a:ext uri="{FF2B5EF4-FFF2-40B4-BE49-F238E27FC236}">
-                <a16:creationId xmlns:a16="http://schemas.microsoft.com/office/drawing/2014/main" id="{5C95BACE-DFEC-49E5-BDDA-591521848B38}"/>
+                <a16:creationId xmlns:a16="http://schemas.microsoft.com/office/drawing/2014/main" id="{EBD72A3C-0A66-4D2B-BE04-44349F8ADA5B}"/>
               </a:ext>
             </a:extLst>
           </p:cNvPr>
@@ -6968,7 +6968,7 @@
     </p:spTree>
     <p:extLst>
       <p:ext uri="{BB962C8B-B14F-4D97-AF65-F5344CB8AC3E}">
-        <p14:creationId xmlns:p14="http://schemas.microsoft.com/office/powerpoint/2010/main" val="152435134"/>
+        <p14:creationId xmlns:p14="http://schemas.microsoft.com/office/powerpoint/2010/main" val="352939769"/>
       </p:ext>
     </p:extLst>
   </p:cSld>
@@ -6999,7 +6999,7 @@
           <p:cNvPr id="42" name="rail-13">
             <a:extLst xmlns:a="http://schemas.openxmlformats.org/drawingml/2006/main">
               <a:ext uri="{FF2B5EF4-FFF2-40B4-BE49-F238E27FC236}">
-                <a16:creationId xmlns:a16="http://schemas.microsoft.com/office/drawing/2014/main" id="{0D9DE5F4-5E63-4C66-A4DE-FF332603F81D}"/>
+                <a16:creationId xmlns:a16="http://schemas.microsoft.com/office/drawing/2014/main" id="{4D2449D2-A449-46F3-9605-5795C0120B5E}"/>
               </a:ext>
             </a:extLst>
           </p:cNvPr>
@@ -7032,7 +7032,7 @@
           <p:cNvPr id="2" name="flourish-13">
             <a:extLst xmlns:a="http://schemas.openxmlformats.org/drawingml/2006/main">
               <a:ext uri="{FF2B5EF4-FFF2-40B4-BE49-F238E27FC236}">
-                <a16:creationId xmlns:a16="http://schemas.microsoft.com/office/drawing/2014/main" id="{4C9D9011-0028-4C8D-AD5B-FA84AFB82375}"/>
+                <a16:creationId xmlns:a16="http://schemas.microsoft.com/office/drawing/2014/main" id="{E793C783-C2B4-4059-AF67-B70D2C6B4FCE}"/>
               </a:ext>
             </a:extLst>
           </p:cNvPr>
@@ -7082,7 +7082,7 @@
           <p:cNvPr id="3" name="chapter-13">
             <a:extLst xmlns:a="http://schemas.openxmlformats.org/drawingml/2006/main">
               <a:ext uri="{FF2B5EF4-FFF2-40B4-BE49-F238E27FC236}">
-                <a16:creationId xmlns:a16="http://schemas.microsoft.com/office/drawing/2014/main" id="{584EA228-56B9-46FE-908B-766B7774AB33}"/>
+                <a16:creationId xmlns:a16="http://schemas.microsoft.com/office/drawing/2014/main" id="{8421FB8A-D7DD-4485-ACE1-1DA3E2D95F7F}"/>
               </a:ext>
             </a:extLst>
           </p:cNvPr>
@@ -7132,7 +7132,7 @@
           <p:cNvPr id="4" name="title-13">
             <a:extLst xmlns:a="http://schemas.openxmlformats.org/drawingml/2006/main">
               <a:ext uri="{FF2B5EF4-FFF2-40B4-BE49-F238E27FC236}">
-                <a16:creationId xmlns:a16="http://schemas.microsoft.com/office/drawing/2014/main" id="{5871BEE6-F00B-43F0-9180-6F960C46678B}"/>
+                <a16:creationId xmlns:a16="http://schemas.microsoft.com/office/drawing/2014/main" id="{C3B9567E-9EAD-47D5-BA88-D94E2272398B}"/>
               </a:ext>
             </a:extLst>
           </p:cNvPr>
@@ -7182,7 +7182,7 @@
           <p:cNvPr id="5" name="subtitle-13">
             <a:extLst xmlns:a="http://schemas.openxmlformats.org/drawingml/2006/main">
               <a:ext uri="{FF2B5EF4-FFF2-40B4-BE49-F238E27FC236}">
-                <a16:creationId xmlns:a16="http://schemas.microsoft.com/office/drawing/2014/main" id="{EFCF8E04-A11A-4772-A868-7B61B3359D5C}"/>
+                <a16:creationId xmlns:a16="http://schemas.microsoft.com/office/drawing/2014/main" id="{0EF67892-131C-4489-93DE-C417A056827C}"/>
               </a:ext>
             </a:extLst>
           </p:cNvPr>
@@ -7232,7 +7232,7 @@
           <p:cNvPr id="6" name="">
             <a:extLst xmlns:a="http://schemas.openxmlformats.org/drawingml/2006/main">
               <a:ext uri="{FF2B5EF4-FFF2-40B4-BE49-F238E27FC236}">
-                <a16:creationId xmlns:a16="http://schemas.microsoft.com/office/drawing/2014/main" id="{5389300C-03DB-4D8F-B4B9-331F5A266E8B}"/>
+                <a16:creationId xmlns:a16="http://schemas.microsoft.com/office/drawing/2014/main" id="{1F84950F-00B5-484E-A738-9E117D0BA980}"/>
               </a:ext>
             </a:extLst>
           </p:cNvPr>
@@ -7263,7 +7263,7 @@
           <p:cNvPr id="7" name="page-13">
             <a:extLst xmlns:a="http://schemas.openxmlformats.org/drawingml/2006/main">
               <a:ext uri="{FF2B5EF4-FFF2-40B4-BE49-F238E27FC236}">
-                <a16:creationId xmlns:a16="http://schemas.microsoft.com/office/drawing/2014/main" id="{7106A1D3-A93D-4374-9CAC-03E9BB35767A}"/>
+                <a16:creationId xmlns:a16="http://schemas.microsoft.com/office/drawing/2014/main" id="{B149894F-1736-47BC-8911-2BECBF65E6D8}"/>
               </a:ext>
             </a:extLst>
           </p:cNvPr>
@@ -7313,7 +7313,7 @@
           <p:cNvPr id="8" name="audit-bg-0">
             <a:extLst xmlns:a="http://schemas.openxmlformats.org/drawingml/2006/main">
               <a:ext uri="{FF2B5EF4-FFF2-40B4-BE49-F238E27FC236}">
-                <a16:creationId xmlns:a16="http://schemas.microsoft.com/office/drawing/2014/main" id="{4EC6590A-8A44-46D0-BFD7-3DB09124496C}"/>
+                <a16:creationId xmlns:a16="http://schemas.microsoft.com/office/drawing/2014/main" id="{E18390E8-4C00-4338-A862-90E4E28DFA04}"/>
               </a:ext>
             </a:extLst>
           </p:cNvPr>
@@ -7348,7 +7348,7 @@
           <p:cNvPr id="9" name="audit-pill-0-bg">
             <a:extLst xmlns:a="http://schemas.openxmlformats.org/drawingml/2006/main">
               <a:ext uri="{FF2B5EF4-FFF2-40B4-BE49-F238E27FC236}">
-                <a16:creationId xmlns:a16="http://schemas.microsoft.com/office/drawing/2014/main" id="{12418A66-600C-446F-A84B-A899EA7D314F}"/>
+                <a16:creationId xmlns:a16="http://schemas.microsoft.com/office/drawing/2014/main" id="{9E785704-8EDC-476E-B248-7C2E130725E7}"/>
               </a:ext>
             </a:extLst>
           </p:cNvPr>
@@ -7383,7 +7383,7 @@
           <p:cNvPr id="10" name="audit-pill-0-text">
             <a:extLst xmlns:a="http://schemas.openxmlformats.org/drawingml/2006/main">
               <a:ext uri="{FF2B5EF4-FFF2-40B4-BE49-F238E27FC236}">
-                <a16:creationId xmlns:a16="http://schemas.microsoft.com/office/drawing/2014/main" id="{8D6C95F3-8812-4708-A3C4-057F04476BB0}"/>
+                <a16:creationId xmlns:a16="http://schemas.microsoft.com/office/drawing/2014/main" id="{4B5A7504-1152-49D0-9347-F5744142E916}"/>
               </a:ext>
             </a:extLst>
           </p:cNvPr>
@@ -7433,7 +7433,7 @@
           <p:cNvPr id="11" name="audit-name-0">
             <a:extLst xmlns:a="http://schemas.openxmlformats.org/drawingml/2006/main">
               <a:ext uri="{FF2B5EF4-FFF2-40B4-BE49-F238E27FC236}">
-                <a16:creationId xmlns:a16="http://schemas.microsoft.com/office/drawing/2014/main" id="{579B145D-F80C-4589-860D-E1CD06B4A1AF}"/>
+                <a16:creationId xmlns:a16="http://schemas.microsoft.com/office/drawing/2014/main" id="{590892B8-3BA1-4532-8E75-1389839232AB}"/>
               </a:ext>
             </a:extLst>
           </p:cNvPr>
@@ -7483,7 +7483,7 @@
           <p:cNvPr id="12" name="audit-bg-1">
             <a:extLst xmlns:a="http://schemas.openxmlformats.org/drawingml/2006/main">
               <a:ext uri="{FF2B5EF4-FFF2-40B4-BE49-F238E27FC236}">
-                <a16:creationId xmlns:a16="http://schemas.microsoft.com/office/drawing/2014/main" id="{F777CD7A-F9E8-442A-9454-78A22FDE2697}"/>
+                <a16:creationId xmlns:a16="http://schemas.microsoft.com/office/drawing/2014/main" id="{EFB26290-595E-412E-8798-B81B9B0F664E}"/>
               </a:ext>
             </a:extLst>
           </p:cNvPr>
@@ -7518,7 +7518,7 @@
           <p:cNvPr id="13" name="audit-pill-1-bg">
             <a:extLst xmlns:a="http://schemas.openxmlformats.org/drawingml/2006/main">
               <a:ext uri="{FF2B5EF4-FFF2-40B4-BE49-F238E27FC236}">
-                <a16:creationId xmlns:a16="http://schemas.microsoft.com/office/drawing/2014/main" id="{24828A97-F42F-453A-98B1-FB01D9770C5C}"/>
+                <a16:creationId xmlns:a16="http://schemas.microsoft.com/office/drawing/2014/main" id="{8BACFDE8-EF38-4396-99ED-D1172B8F2C94}"/>
               </a:ext>
             </a:extLst>
           </p:cNvPr>
@@ -7553,7 +7553,7 @@
           <p:cNvPr id="14" name="audit-pill-1-text">
             <a:extLst xmlns:a="http://schemas.openxmlformats.org/drawingml/2006/main">
               <a:ext uri="{FF2B5EF4-FFF2-40B4-BE49-F238E27FC236}">
-                <a16:creationId xmlns:a16="http://schemas.microsoft.com/office/drawing/2014/main" id="{EE714E34-97FC-4D50-AFAB-F307366EAFA9}"/>
+                <a16:creationId xmlns:a16="http://schemas.microsoft.com/office/drawing/2014/main" id="{21EA203D-BCAA-4C3D-A7AB-ADE7E0445287}"/>
               </a:ext>
             </a:extLst>
           </p:cNvPr>
@@ -7603,7 +7603,7 @@
           <p:cNvPr id="15" name="audit-name-1">
             <a:extLst xmlns:a="http://schemas.openxmlformats.org/drawingml/2006/main">
               <a:ext uri="{FF2B5EF4-FFF2-40B4-BE49-F238E27FC236}">
-                <a16:creationId xmlns:a16="http://schemas.microsoft.com/office/drawing/2014/main" id="{CF7B3216-7E23-4CA8-8CCA-3E30B6D57362}"/>
+                <a16:creationId xmlns:a16="http://schemas.microsoft.com/office/drawing/2014/main" id="{4EF6F57A-79D8-491D-AA3C-F3996918FCCD}"/>
               </a:ext>
             </a:extLst>
           </p:cNvPr>
@@ -7653,7 +7653,7 @@
           <p:cNvPr id="16" name="audit-bg-2">
             <a:extLst xmlns:a="http://schemas.openxmlformats.org/drawingml/2006/main">
               <a:ext uri="{FF2B5EF4-FFF2-40B4-BE49-F238E27FC236}">
-                <a16:creationId xmlns:a16="http://schemas.microsoft.com/office/drawing/2014/main" id="{F0FAD1DE-36E3-465E-9267-357D40EB6E0A}"/>
+                <a16:creationId xmlns:a16="http://schemas.microsoft.com/office/drawing/2014/main" id="{02219D7D-0782-4C3D-A51E-D6BE02A60962}"/>
               </a:ext>
             </a:extLst>
           </p:cNvPr>
@@ -7688,7 +7688,7 @@
           <p:cNvPr id="17" name="audit-pill-2-bg">
             <a:extLst xmlns:a="http://schemas.openxmlformats.org/drawingml/2006/main">
               <a:ext uri="{FF2B5EF4-FFF2-40B4-BE49-F238E27FC236}">
-                <a16:creationId xmlns:a16="http://schemas.microsoft.com/office/drawing/2014/main" id="{4A15B2F3-745A-4EA4-8C2D-40D23C2B02DB}"/>
+                <a16:creationId xmlns:a16="http://schemas.microsoft.com/office/drawing/2014/main" id="{2CDC8CB2-C78B-4051-BC7D-CB8F90E666DF}"/>
               </a:ext>
             </a:extLst>
           </p:cNvPr>
@@ -7723,7 +7723,7 @@
           <p:cNvPr id="18" name="audit-pill-2-text">
             <a:extLst xmlns:a="http://schemas.openxmlformats.org/drawingml/2006/main">
               <a:ext uri="{FF2B5EF4-FFF2-40B4-BE49-F238E27FC236}">
-                <a16:creationId xmlns:a16="http://schemas.microsoft.com/office/drawing/2014/main" id="{62E18F8C-9F6D-42DF-83BD-42192C538831}"/>
+                <a16:creationId xmlns:a16="http://schemas.microsoft.com/office/drawing/2014/main" id="{C49F3254-1DC2-4A3E-BE03-32439F29FD4C}"/>
               </a:ext>
             </a:extLst>
           </p:cNvPr>
@@ -7773,7 +7773,7 @@
           <p:cNvPr id="19" name="audit-name-2">
             <a:extLst xmlns:a="http://schemas.openxmlformats.org/drawingml/2006/main">
               <a:ext uri="{FF2B5EF4-FFF2-40B4-BE49-F238E27FC236}">
-                <a16:creationId xmlns:a16="http://schemas.microsoft.com/office/drawing/2014/main" id="{EAC05EDF-6C56-4530-B014-A370A24E2A3B}"/>
+                <a16:creationId xmlns:a16="http://schemas.microsoft.com/office/drawing/2014/main" id="{42C1948D-F8B5-4C2F-BEE7-87ED30B5EB50}"/>
               </a:ext>
             </a:extLst>
           </p:cNvPr>
@@ -7823,7 +7823,7 @@
           <p:cNvPr id="20" name="audit-bg-3">
             <a:extLst xmlns:a="http://schemas.openxmlformats.org/drawingml/2006/main">
               <a:ext uri="{FF2B5EF4-FFF2-40B4-BE49-F238E27FC236}">
-                <a16:creationId xmlns:a16="http://schemas.microsoft.com/office/drawing/2014/main" id="{B802658B-CCBE-41DF-8263-A5B336FF7286}"/>
+                <a16:creationId xmlns:a16="http://schemas.microsoft.com/office/drawing/2014/main" id="{66D4C7D0-9504-48FD-BB8E-745411994683}"/>
               </a:ext>
             </a:extLst>
           </p:cNvPr>
@@ -7858,7 +7858,7 @@
           <p:cNvPr id="21" name="audit-pill-3-bg">
             <a:extLst xmlns:a="http://schemas.openxmlformats.org/drawingml/2006/main">
               <a:ext uri="{FF2B5EF4-FFF2-40B4-BE49-F238E27FC236}">
-                <a16:creationId xmlns:a16="http://schemas.microsoft.com/office/drawing/2014/main" id="{5C64083B-D89C-44B6-B64B-7BEE2DF67129}"/>
+                <a16:creationId xmlns:a16="http://schemas.microsoft.com/office/drawing/2014/main" id="{9CA4CE5E-532C-4750-956E-2FE4F3089081}"/>
               </a:ext>
             </a:extLst>
           </p:cNvPr>
@@ -7893,7 +7893,7 @@
           <p:cNvPr id="22" name="audit-pill-3-text">
             <a:extLst xmlns:a="http://schemas.openxmlformats.org/drawingml/2006/main">
               <a:ext uri="{FF2B5EF4-FFF2-40B4-BE49-F238E27FC236}">
-                <a16:creationId xmlns:a16="http://schemas.microsoft.com/office/drawing/2014/main" id="{5B4FC5F8-8CD0-4405-BCED-B68912EB7087}"/>
+                <a16:creationId xmlns:a16="http://schemas.microsoft.com/office/drawing/2014/main" id="{D770A415-D1C5-4FBE-9829-249205C636B6}"/>
               </a:ext>
             </a:extLst>
           </p:cNvPr>
@@ -7943,7 +7943,7 @@
           <p:cNvPr id="23" name="audit-name-3">
             <a:extLst xmlns:a="http://schemas.openxmlformats.org/drawingml/2006/main">
               <a:ext uri="{FF2B5EF4-FFF2-40B4-BE49-F238E27FC236}">
-                <a16:creationId xmlns:a16="http://schemas.microsoft.com/office/drawing/2014/main" id="{45DC1173-565A-41CB-B38B-C173AF1FCF56}"/>
+                <a16:creationId xmlns:a16="http://schemas.microsoft.com/office/drawing/2014/main" id="{23DF560D-6762-4598-A68B-FD9860B92396}"/>
               </a:ext>
             </a:extLst>
           </p:cNvPr>
@@ -7993,7 +7993,7 @@
           <p:cNvPr id="24" name="audit-bg-4">
             <a:extLst xmlns:a="http://schemas.openxmlformats.org/drawingml/2006/main">
               <a:ext uri="{FF2B5EF4-FFF2-40B4-BE49-F238E27FC236}">
-                <a16:creationId xmlns:a16="http://schemas.microsoft.com/office/drawing/2014/main" id="{6F77BBF1-AD06-473F-91C0-53E144A94569}"/>
+                <a16:creationId xmlns:a16="http://schemas.microsoft.com/office/drawing/2014/main" id="{9369210E-7414-4FD8-816F-397B1423B268}"/>
               </a:ext>
             </a:extLst>
           </p:cNvPr>
@@ -8028,7 +8028,7 @@
           <p:cNvPr id="25" name="audit-pill-4-bg">
             <a:extLst xmlns:a="http://schemas.openxmlformats.org/drawingml/2006/main">
               <a:ext uri="{FF2B5EF4-FFF2-40B4-BE49-F238E27FC236}">
-                <a16:creationId xmlns:a16="http://schemas.microsoft.com/office/drawing/2014/main" id="{AD1C736F-8E60-40CD-BA9C-DE289DACC4C9}"/>
+                <a16:creationId xmlns:a16="http://schemas.microsoft.com/office/drawing/2014/main" id="{2D92F620-EFE9-47F1-B900-542B2C0021D7}"/>
               </a:ext>
             </a:extLst>
           </p:cNvPr>
@@ -8063,7 +8063,7 @@
           <p:cNvPr id="26" name="audit-pill-4-text">
             <a:extLst xmlns:a="http://schemas.openxmlformats.org/drawingml/2006/main">
               <a:ext uri="{FF2B5EF4-FFF2-40B4-BE49-F238E27FC236}">
-                <a16:creationId xmlns:a16="http://schemas.microsoft.com/office/drawing/2014/main" id="{ED43FFF8-99C9-4F3F-B20E-AA9187D405EB}"/>
+                <a16:creationId xmlns:a16="http://schemas.microsoft.com/office/drawing/2014/main" id="{567233B0-9BA3-4E60-A2EE-B8018C306C0E}"/>
               </a:ext>
             </a:extLst>
           </p:cNvPr>
@@ -8113,7 +8113,7 @@
           <p:cNvPr id="27" name="audit-name-4">
             <a:extLst xmlns:a="http://schemas.openxmlformats.org/drawingml/2006/main">
               <a:ext uri="{FF2B5EF4-FFF2-40B4-BE49-F238E27FC236}">
-                <a16:creationId xmlns:a16="http://schemas.microsoft.com/office/drawing/2014/main" id="{FADCCF9D-232B-4EBD-A382-A9913F777987}"/>
+                <a16:creationId xmlns:a16="http://schemas.microsoft.com/office/drawing/2014/main" id="{042EBF2A-71A8-41BD-8D9E-0894A275E528}"/>
               </a:ext>
             </a:extLst>
           </p:cNvPr>
@@ -8163,7 +8163,7 @@
           <p:cNvPr id="28" name="audit-bg-5">
             <a:extLst xmlns:a="http://schemas.openxmlformats.org/drawingml/2006/main">
               <a:ext uri="{FF2B5EF4-FFF2-40B4-BE49-F238E27FC236}">
-                <a16:creationId xmlns:a16="http://schemas.microsoft.com/office/drawing/2014/main" id="{232BDD5E-74BF-4532-8A00-C59047589D83}"/>
+                <a16:creationId xmlns:a16="http://schemas.microsoft.com/office/drawing/2014/main" id="{26C5818B-1C3F-44F9-ADF3-21A98414A76D}"/>
               </a:ext>
             </a:extLst>
           </p:cNvPr>
@@ -8198,7 +8198,7 @@
           <p:cNvPr id="29" name="audit-pill-5-bg">
             <a:extLst xmlns:a="http://schemas.openxmlformats.org/drawingml/2006/main">
               <a:ext uri="{FF2B5EF4-FFF2-40B4-BE49-F238E27FC236}">
-                <a16:creationId xmlns:a16="http://schemas.microsoft.com/office/drawing/2014/main" id="{90927129-03E4-495C-BDA1-14136F46C263}"/>
+                <a16:creationId xmlns:a16="http://schemas.microsoft.com/office/drawing/2014/main" id="{388CEC4D-08A4-4238-86AE-B134786BC765}"/>
               </a:ext>
             </a:extLst>
           </p:cNvPr>
@@ -8233,7 +8233,7 @@
           <p:cNvPr id="30" name="audit-pill-5-text">
             <a:extLst xmlns:a="http://schemas.openxmlformats.org/drawingml/2006/main">
               <a:ext uri="{FF2B5EF4-FFF2-40B4-BE49-F238E27FC236}">
-                <a16:creationId xmlns:a16="http://schemas.microsoft.com/office/drawing/2014/main" id="{A3374A7B-96E0-4158-B3C6-08C8EF5B88D7}"/>
+                <a16:creationId xmlns:a16="http://schemas.microsoft.com/office/drawing/2014/main" id="{B848046E-C889-4653-98C6-83A630C4FA48}"/>
               </a:ext>
             </a:extLst>
           </p:cNvPr>
@@ -8283,7 +8283,7 @@
           <p:cNvPr id="31" name="audit-name-5">
             <a:extLst xmlns:a="http://schemas.openxmlformats.org/drawingml/2006/main">
               <a:ext uri="{FF2B5EF4-FFF2-40B4-BE49-F238E27FC236}">
-                <a16:creationId xmlns:a16="http://schemas.microsoft.com/office/drawing/2014/main" id="{865CE0CF-2F5E-43AE-BB30-5BBC85A0D441}"/>
+                <a16:creationId xmlns:a16="http://schemas.microsoft.com/office/drawing/2014/main" id="{2BD07168-858A-4E3C-88F9-0AD19D5DDCBF}"/>
               </a:ext>
             </a:extLst>
           </p:cNvPr>
@@ -8333,7 +8333,7 @@
           <p:cNvPr id="32" name="audit-bg-6">
             <a:extLst xmlns:a="http://schemas.openxmlformats.org/drawingml/2006/main">
               <a:ext uri="{FF2B5EF4-FFF2-40B4-BE49-F238E27FC236}">
-                <a16:creationId xmlns:a16="http://schemas.microsoft.com/office/drawing/2014/main" id="{BCAA550C-B281-4ECD-A287-2519D044CFAF}"/>
+                <a16:creationId xmlns:a16="http://schemas.microsoft.com/office/drawing/2014/main" id="{5F8F0E62-ABCF-4938-9E11-5BCC8B456401}"/>
               </a:ext>
             </a:extLst>
           </p:cNvPr>
@@ -8368,7 +8368,7 @@
           <p:cNvPr id="33" name="audit-pill-6-bg">
             <a:extLst xmlns:a="http://schemas.openxmlformats.org/drawingml/2006/main">
               <a:ext uri="{FF2B5EF4-FFF2-40B4-BE49-F238E27FC236}">
-                <a16:creationId xmlns:a16="http://schemas.microsoft.com/office/drawing/2014/main" id="{503D3275-8E04-4FA4-B154-ED3215F849AC}"/>
+                <a16:creationId xmlns:a16="http://schemas.microsoft.com/office/drawing/2014/main" id="{5BEB3EA9-73AD-4D66-BB11-EB6A90528457}"/>
               </a:ext>
             </a:extLst>
           </p:cNvPr>
@@ -8403,7 +8403,7 @@
           <p:cNvPr id="34" name="audit-pill-6-text">
             <a:extLst xmlns:a="http://schemas.openxmlformats.org/drawingml/2006/main">
               <a:ext uri="{FF2B5EF4-FFF2-40B4-BE49-F238E27FC236}">
-                <a16:creationId xmlns:a16="http://schemas.microsoft.com/office/drawing/2014/main" id="{F9C70E7C-9E3B-40F4-98BE-C2D703C017D8}"/>
+                <a16:creationId xmlns:a16="http://schemas.microsoft.com/office/drawing/2014/main" id="{552EE86E-2D7F-4013-89BF-7C03AD28B20D}"/>
               </a:ext>
             </a:extLst>
           </p:cNvPr>
@@ -8453,7 +8453,7 @@
           <p:cNvPr id="35" name="audit-name-6">
             <a:extLst xmlns:a="http://schemas.openxmlformats.org/drawingml/2006/main">
               <a:ext uri="{FF2B5EF4-FFF2-40B4-BE49-F238E27FC236}">
-                <a16:creationId xmlns:a16="http://schemas.microsoft.com/office/drawing/2014/main" id="{781F0F7A-F68F-447B-B2E1-D2AD6F25EFC3}"/>
+                <a16:creationId xmlns:a16="http://schemas.microsoft.com/office/drawing/2014/main" id="{E1EBC173-5E98-44C1-8F93-B52EDECD7DE1}"/>
               </a:ext>
             </a:extLst>
           </p:cNvPr>
@@ -8503,7 +8503,7 @@
           <p:cNvPr id="36" name="audit-bg-7">
             <a:extLst xmlns:a="http://schemas.openxmlformats.org/drawingml/2006/main">
               <a:ext uri="{FF2B5EF4-FFF2-40B4-BE49-F238E27FC236}">
-                <a16:creationId xmlns:a16="http://schemas.microsoft.com/office/drawing/2014/main" id="{0E4E70A1-F5D7-46B5-A42B-0B58D4DCB2F3}"/>
+                <a16:creationId xmlns:a16="http://schemas.microsoft.com/office/drawing/2014/main" id="{F99EEAF8-D532-4F56-8E1B-86078270154B}"/>
               </a:ext>
             </a:extLst>
           </p:cNvPr>
@@ -8538,7 +8538,7 @@
           <p:cNvPr id="37" name="audit-pill-7-bg">
             <a:extLst xmlns:a="http://schemas.openxmlformats.org/drawingml/2006/main">
               <a:ext uri="{FF2B5EF4-FFF2-40B4-BE49-F238E27FC236}">
-                <a16:creationId xmlns:a16="http://schemas.microsoft.com/office/drawing/2014/main" id="{EE51A294-3279-4D49-9DCA-67EE35BBE629}"/>
+                <a16:creationId xmlns:a16="http://schemas.microsoft.com/office/drawing/2014/main" id="{34DAD203-4088-403E-A561-F7A332816DED}"/>
               </a:ext>
             </a:extLst>
           </p:cNvPr>
@@ -8573,7 +8573,7 @@
           <p:cNvPr id="38" name="audit-pill-7-text">
             <a:extLst xmlns:a="http://schemas.openxmlformats.org/drawingml/2006/main">
               <a:ext uri="{FF2B5EF4-FFF2-40B4-BE49-F238E27FC236}">
-                <a16:creationId xmlns:a16="http://schemas.microsoft.com/office/drawing/2014/main" id="{F93E7FE2-F67B-4C4A-AE68-2CC765374873}"/>
+                <a16:creationId xmlns:a16="http://schemas.microsoft.com/office/drawing/2014/main" id="{DA0E974D-718C-465D-80C2-50996045DD75}"/>
               </a:ext>
             </a:extLst>
           </p:cNvPr>
@@ -8623,7 +8623,7 @@
           <p:cNvPr id="39" name="audit-name-7">
             <a:extLst xmlns:a="http://schemas.openxmlformats.org/drawingml/2006/main">
               <a:ext uri="{FF2B5EF4-FFF2-40B4-BE49-F238E27FC236}">
-                <a16:creationId xmlns:a16="http://schemas.microsoft.com/office/drawing/2014/main" id="{A208E6B5-9538-4916-BB1B-6E4DB477B57F}"/>
+                <a16:creationId xmlns:a16="http://schemas.microsoft.com/office/drawing/2014/main" id="{30F453F1-5D94-4365-8E01-8B1095A55190}"/>
               </a:ext>
             </a:extLst>
           </p:cNvPr>
@@ -8673,7 +8673,7 @@
           <p:cNvPr id="40" name="audit-hash">
             <a:extLst xmlns:a="http://schemas.openxmlformats.org/drawingml/2006/main">
               <a:ext uri="{FF2B5EF4-FFF2-40B4-BE49-F238E27FC236}">
-                <a16:creationId xmlns:a16="http://schemas.microsoft.com/office/drawing/2014/main" id="{A6A3CB89-31A3-4753-B183-7F921A6F3AB9}"/>
+                <a16:creationId xmlns:a16="http://schemas.microsoft.com/office/drawing/2014/main" id="{70D5A568-8ABC-4193-867E-452D91615394}"/>
               </a:ext>
             </a:extLst>
           </p:cNvPr>
@@ -8708,7 +8708,7 @@
           <p:cNvPr id="41" name="audit-hash-text">
             <a:extLst xmlns:a="http://schemas.openxmlformats.org/drawingml/2006/main">
               <a:ext uri="{FF2B5EF4-FFF2-40B4-BE49-F238E27FC236}">
-                <a16:creationId xmlns:a16="http://schemas.microsoft.com/office/drawing/2014/main" id="{57A9DF8F-944C-4BFD-8B77-D5D9AB7D54FA}"/>
+                <a16:creationId xmlns:a16="http://schemas.microsoft.com/office/drawing/2014/main" id="{9ADBDD96-75D7-4BEF-958E-99DFFE3706E4}"/>
               </a:ext>
             </a:extLst>
           </p:cNvPr>
@@ -8756,7 +8756,7 @@
     </p:spTree>
     <p:extLst>
       <p:ext uri="{BB962C8B-B14F-4D97-AF65-F5344CB8AC3E}">
-        <p14:creationId xmlns:p14="http://schemas.microsoft.com/office/powerpoint/2010/main" val="1751903266"/>
+        <p14:creationId xmlns:p14="http://schemas.microsoft.com/office/powerpoint/2010/main" val="1067733725"/>
       </p:ext>
     </p:extLst>
   </p:cSld>
@@ -8787,7 +8787,7 @@
           <p:cNvPr id="26" name="rail-14">
             <a:extLst xmlns:a="http://schemas.openxmlformats.org/drawingml/2006/main">
               <a:ext uri="{FF2B5EF4-FFF2-40B4-BE49-F238E27FC236}">
-                <a16:creationId xmlns:a16="http://schemas.microsoft.com/office/drawing/2014/main" id="{25878F85-45AD-4474-97D3-0DE312F6DCE9}"/>
+                <a16:creationId xmlns:a16="http://schemas.microsoft.com/office/drawing/2014/main" id="{51535F1D-A575-4799-ADA8-7C1DF786BCEF}"/>
               </a:ext>
             </a:extLst>
           </p:cNvPr>
@@ -8820,7 +8820,7 @@
           <p:cNvPr id="2" name="flourish-14">
             <a:extLst xmlns:a="http://schemas.openxmlformats.org/drawingml/2006/main">
               <a:ext uri="{FF2B5EF4-FFF2-40B4-BE49-F238E27FC236}">
-                <a16:creationId xmlns:a16="http://schemas.microsoft.com/office/drawing/2014/main" id="{465E7617-89A4-4020-8502-E27B5D915468}"/>
+                <a16:creationId xmlns:a16="http://schemas.microsoft.com/office/drawing/2014/main" id="{15AAD097-5167-4892-ACA9-071EA2CC7372}"/>
               </a:ext>
             </a:extLst>
           </p:cNvPr>
@@ -8870,7 +8870,7 @@
           <p:cNvPr id="3" name="chapter-14">
             <a:extLst xmlns:a="http://schemas.openxmlformats.org/drawingml/2006/main">
               <a:ext uri="{FF2B5EF4-FFF2-40B4-BE49-F238E27FC236}">
-                <a16:creationId xmlns:a16="http://schemas.microsoft.com/office/drawing/2014/main" id="{46441381-2804-4C0F-8A95-EC888422AD6D}"/>
+                <a16:creationId xmlns:a16="http://schemas.microsoft.com/office/drawing/2014/main" id="{601EB705-5983-4A03-89F0-9F917D1C880E}"/>
               </a:ext>
             </a:extLst>
           </p:cNvPr>
@@ -8920,7 +8920,7 @@
           <p:cNvPr id="4" name="title-14">
             <a:extLst xmlns:a="http://schemas.openxmlformats.org/drawingml/2006/main">
               <a:ext uri="{FF2B5EF4-FFF2-40B4-BE49-F238E27FC236}">
-                <a16:creationId xmlns:a16="http://schemas.microsoft.com/office/drawing/2014/main" id="{433FDDB3-CF41-4CE8-BF94-74AC4B725E54}"/>
+                <a16:creationId xmlns:a16="http://schemas.microsoft.com/office/drawing/2014/main" id="{3F39B751-A65C-4F71-B891-07F680175C99}"/>
               </a:ext>
             </a:extLst>
           </p:cNvPr>
@@ -8970,7 +8970,7 @@
           <p:cNvPr id="5" name="subtitle-14">
             <a:extLst xmlns:a="http://schemas.openxmlformats.org/drawingml/2006/main">
               <a:ext uri="{FF2B5EF4-FFF2-40B4-BE49-F238E27FC236}">
-                <a16:creationId xmlns:a16="http://schemas.microsoft.com/office/drawing/2014/main" id="{B3C98081-3E07-4EEC-A8D0-FBFF10C85D02}"/>
+                <a16:creationId xmlns:a16="http://schemas.microsoft.com/office/drawing/2014/main" id="{318EB085-A843-42CB-8B85-D003D73E58C6}"/>
               </a:ext>
             </a:extLst>
           </p:cNvPr>
@@ -9020,7 +9020,7 @@
           <p:cNvPr id="6" name="">
             <a:extLst xmlns:a="http://schemas.openxmlformats.org/drawingml/2006/main">
               <a:ext uri="{FF2B5EF4-FFF2-40B4-BE49-F238E27FC236}">
-                <a16:creationId xmlns:a16="http://schemas.microsoft.com/office/drawing/2014/main" id="{93C13F5D-5C13-44ED-95E9-0ECE90BD8146}"/>
+                <a16:creationId xmlns:a16="http://schemas.microsoft.com/office/drawing/2014/main" id="{B2F086C7-CE60-4E27-946F-D559109B890C}"/>
               </a:ext>
             </a:extLst>
           </p:cNvPr>
@@ -9051,7 +9051,7 @@
           <p:cNvPr id="7" name="page-14">
             <a:extLst xmlns:a="http://schemas.openxmlformats.org/drawingml/2006/main">
               <a:ext uri="{FF2B5EF4-FFF2-40B4-BE49-F238E27FC236}">
-                <a16:creationId xmlns:a16="http://schemas.microsoft.com/office/drawing/2014/main" id="{535AD28C-A20A-4603-B10B-2345FA98A735}"/>
+                <a16:creationId xmlns:a16="http://schemas.microsoft.com/office/drawing/2014/main" id="{B3510A3B-73A0-4301-A9A8-FF09D87B26A5}"/>
               </a:ext>
             </a:extLst>
           </p:cNvPr>
@@ -9101,7 +9101,7 @@
           <p:cNvPr id="8" name="limit-0">
             <a:extLst xmlns:a="http://schemas.openxmlformats.org/drawingml/2006/main">
               <a:ext uri="{FF2B5EF4-FFF2-40B4-BE49-F238E27FC236}">
-                <a16:creationId xmlns:a16="http://schemas.microsoft.com/office/drawing/2014/main" id="{4D081161-9394-4130-9171-7BF23D98B92E}"/>
+                <a16:creationId xmlns:a16="http://schemas.microsoft.com/office/drawing/2014/main" id="{E6F22D8C-BA29-4387-BE30-59A44A541D7A}"/>
               </a:ext>
             </a:extLst>
           </p:cNvPr>
@@ -9136,7 +9136,7 @@
           <p:cNvPr id="9" name="limit-k-0">
             <a:extLst xmlns:a="http://schemas.openxmlformats.org/drawingml/2006/main">
               <a:ext uri="{FF2B5EF4-FFF2-40B4-BE49-F238E27FC236}">
-                <a16:creationId xmlns:a16="http://schemas.microsoft.com/office/drawing/2014/main" id="{0274CA48-FD60-48BC-A6AB-A7BD51B79636}"/>
+                <a16:creationId xmlns:a16="http://schemas.microsoft.com/office/drawing/2014/main" id="{5774EE42-2AE9-4C39-A261-503CCAB9C96C}"/>
               </a:ext>
             </a:extLst>
           </p:cNvPr>
@@ -9186,7 +9186,7 @@
           <p:cNvPr id="10" name="limit-v-0-0">
             <a:extLst xmlns:a="http://schemas.openxmlformats.org/drawingml/2006/main">
               <a:ext uri="{FF2B5EF4-FFF2-40B4-BE49-F238E27FC236}">
-                <a16:creationId xmlns:a16="http://schemas.microsoft.com/office/drawing/2014/main" id="{622F7840-4090-42BD-BC0D-68B0F2ED8C12}"/>
+                <a16:creationId xmlns:a16="http://schemas.microsoft.com/office/drawing/2014/main" id="{73888BBB-C226-4B14-B760-5B08C284054C}"/>
               </a:ext>
             </a:extLst>
           </p:cNvPr>
@@ -9236,7 +9236,7 @@
           <p:cNvPr id="11" name="limit-v-0-1">
             <a:extLst xmlns:a="http://schemas.openxmlformats.org/drawingml/2006/main">
               <a:ext uri="{FF2B5EF4-FFF2-40B4-BE49-F238E27FC236}">
-                <a16:creationId xmlns:a16="http://schemas.microsoft.com/office/drawing/2014/main" id="{020C50F2-69A5-4D98-88E2-E5065356F9F5}"/>
+                <a16:creationId xmlns:a16="http://schemas.microsoft.com/office/drawing/2014/main" id="{FBB22901-198A-4F72-932E-3D7B29D5DE19}"/>
               </a:ext>
             </a:extLst>
           </p:cNvPr>
@@ -9286,7 +9286,7 @@
           <p:cNvPr id="12" name="limit-v-0-2">
             <a:extLst xmlns:a="http://schemas.openxmlformats.org/drawingml/2006/main">
               <a:ext uri="{FF2B5EF4-FFF2-40B4-BE49-F238E27FC236}">
-                <a16:creationId xmlns:a16="http://schemas.microsoft.com/office/drawing/2014/main" id="{908A66F7-4212-45F5-A8F2-41F42FEFFEA4}"/>
+                <a16:creationId xmlns:a16="http://schemas.microsoft.com/office/drawing/2014/main" id="{45885CF8-C680-4125-9FE3-B595BF7468DD}"/>
               </a:ext>
             </a:extLst>
           </p:cNvPr>
@@ -9336,7 +9336,7 @@
           <p:cNvPr id="13" name="limit-v-0-3">
             <a:extLst xmlns:a="http://schemas.openxmlformats.org/drawingml/2006/main">
               <a:ext uri="{FF2B5EF4-FFF2-40B4-BE49-F238E27FC236}">
-                <a16:creationId xmlns:a16="http://schemas.microsoft.com/office/drawing/2014/main" id="{CF3FD820-3EC4-4354-9883-5FCF072D07C8}"/>
+                <a16:creationId xmlns:a16="http://schemas.microsoft.com/office/drawing/2014/main" id="{7B0B6E46-7F8B-43B8-A5CD-AEE8F358E839}"/>
               </a:ext>
             </a:extLst>
           </p:cNvPr>
@@ -9386,7 +9386,7 @@
           <p:cNvPr id="14" name="limit-1">
             <a:extLst xmlns:a="http://schemas.openxmlformats.org/drawingml/2006/main">
               <a:ext uri="{FF2B5EF4-FFF2-40B4-BE49-F238E27FC236}">
-                <a16:creationId xmlns:a16="http://schemas.microsoft.com/office/drawing/2014/main" id="{FA766BE1-21F0-4306-A9A2-7178B3E68FB8}"/>
+                <a16:creationId xmlns:a16="http://schemas.microsoft.com/office/drawing/2014/main" id="{AE5D5C6A-A3CB-4DE5-A80C-BDCDD46802F4}"/>
               </a:ext>
             </a:extLst>
           </p:cNvPr>
@@ -9421,7 +9421,7 @@
           <p:cNvPr id="15" name="limit-k-1">
             <a:extLst xmlns:a="http://schemas.openxmlformats.org/drawingml/2006/main">
               <a:ext uri="{FF2B5EF4-FFF2-40B4-BE49-F238E27FC236}">
-                <a16:creationId xmlns:a16="http://schemas.microsoft.com/office/drawing/2014/main" id="{ACB87A61-8B36-407F-8E80-D84694424C29}"/>
+                <a16:creationId xmlns:a16="http://schemas.microsoft.com/office/drawing/2014/main" id="{80A22A39-E52C-4EF8-83F9-A9EA74461822}"/>
               </a:ext>
             </a:extLst>
           </p:cNvPr>
@@ -9471,7 +9471,7 @@
           <p:cNvPr id="16" name="limit-v-1-0">
             <a:extLst xmlns:a="http://schemas.openxmlformats.org/drawingml/2006/main">
               <a:ext uri="{FF2B5EF4-FFF2-40B4-BE49-F238E27FC236}">
-                <a16:creationId xmlns:a16="http://schemas.microsoft.com/office/drawing/2014/main" id="{EE2DC23B-8AC8-4CCF-9D5F-BCEE6668C0FB}"/>
+                <a16:creationId xmlns:a16="http://schemas.microsoft.com/office/drawing/2014/main" id="{168C3CA6-17FC-497C-9CC2-EEE56C6A254C}"/>
               </a:ext>
             </a:extLst>
           </p:cNvPr>
@@ -9521,7 +9521,7 @@
           <p:cNvPr id="17" name="limit-v-1-1">
             <a:extLst xmlns:a="http://schemas.openxmlformats.org/drawingml/2006/main">
               <a:ext uri="{FF2B5EF4-FFF2-40B4-BE49-F238E27FC236}">
-                <a16:creationId xmlns:a16="http://schemas.microsoft.com/office/drawing/2014/main" id="{74AA7CE8-CB16-418E-BE48-3DD248F31A83}"/>
+                <a16:creationId xmlns:a16="http://schemas.microsoft.com/office/drawing/2014/main" id="{5124EEDD-6AC5-4C85-956F-7C1C8F6CB611}"/>
               </a:ext>
             </a:extLst>
           </p:cNvPr>
@@ -9571,7 +9571,7 @@
           <p:cNvPr id="18" name="limit-v-1-2">
             <a:extLst xmlns:a="http://schemas.openxmlformats.org/drawingml/2006/main">
               <a:ext uri="{FF2B5EF4-FFF2-40B4-BE49-F238E27FC236}">
-                <a16:creationId xmlns:a16="http://schemas.microsoft.com/office/drawing/2014/main" id="{5B4D3BF8-F0CB-4D50-8AFD-03755767D792}"/>
+                <a16:creationId xmlns:a16="http://schemas.microsoft.com/office/drawing/2014/main" id="{A998EA74-E44C-4BAA-B304-42A0A0A43FF6}"/>
               </a:ext>
             </a:extLst>
           </p:cNvPr>
@@ -9621,7 +9621,7 @@
           <p:cNvPr id="19" name="limit-v-1-3">
             <a:extLst xmlns:a="http://schemas.openxmlformats.org/drawingml/2006/main">
               <a:ext uri="{FF2B5EF4-FFF2-40B4-BE49-F238E27FC236}">
-                <a16:creationId xmlns:a16="http://schemas.microsoft.com/office/drawing/2014/main" id="{70D038E0-CE25-4A83-A26D-0D33C72A1935}"/>
+                <a16:creationId xmlns:a16="http://schemas.microsoft.com/office/drawing/2014/main" id="{6984425E-ADC3-43FC-B310-ABFF5658E294}"/>
               </a:ext>
             </a:extLst>
           </p:cNvPr>
@@ -9671,7 +9671,7 @@
           <p:cNvPr id="20" name="limit-2">
             <a:extLst xmlns:a="http://schemas.openxmlformats.org/drawingml/2006/main">
               <a:ext uri="{FF2B5EF4-FFF2-40B4-BE49-F238E27FC236}">
-                <a16:creationId xmlns:a16="http://schemas.microsoft.com/office/drawing/2014/main" id="{AEF4DA64-53F3-4ADB-9B97-B267240F4F42}"/>
+                <a16:creationId xmlns:a16="http://schemas.microsoft.com/office/drawing/2014/main" id="{4BEC41D0-DDA5-40EE-8E22-D7BC06BFC549}"/>
               </a:ext>
             </a:extLst>
           </p:cNvPr>
@@ -9706,7 +9706,7 @@
           <p:cNvPr id="21" name="limit-k-2">
             <a:extLst xmlns:a="http://schemas.openxmlformats.org/drawingml/2006/main">
               <a:ext uri="{FF2B5EF4-FFF2-40B4-BE49-F238E27FC236}">
-                <a16:creationId xmlns:a16="http://schemas.microsoft.com/office/drawing/2014/main" id="{5F906CAC-C8C0-4652-B53A-D27A87AB7812}"/>
+                <a16:creationId xmlns:a16="http://schemas.microsoft.com/office/drawing/2014/main" id="{0D5CF265-A655-47AA-971F-27FEA53B788F}"/>
               </a:ext>
             </a:extLst>
           </p:cNvPr>
@@ -9756,7 +9756,7 @@
           <p:cNvPr id="22" name="limit-v-2-0">
             <a:extLst xmlns:a="http://schemas.openxmlformats.org/drawingml/2006/main">
               <a:ext uri="{FF2B5EF4-FFF2-40B4-BE49-F238E27FC236}">
-                <a16:creationId xmlns:a16="http://schemas.microsoft.com/office/drawing/2014/main" id="{45664DD8-BFDE-4F3E-94F5-B209F175E4B1}"/>
+                <a16:creationId xmlns:a16="http://schemas.microsoft.com/office/drawing/2014/main" id="{08DAC514-C3E3-43CD-87D7-F2BCEB5F1973}"/>
               </a:ext>
             </a:extLst>
           </p:cNvPr>
@@ -9806,7 +9806,7 @@
           <p:cNvPr id="23" name="limit-v-2-1">
             <a:extLst xmlns:a="http://schemas.openxmlformats.org/drawingml/2006/main">
               <a:ext uri="{FF2B5EF4-FFF2-40B4-BE49-F238E27FC236}">
-                <a16:creationId xmlns:a16="http://schemas.microsoft.com/office/drawing/2014/main" id="{E638F73C-1F38-433B-B5B4-EE4DDD2A8F43}"/>
+                <a16:creationId xmlns:a16="http://schemas.microsoft.com/office/drawing/2014/main" id="{7F0B4D1F-EECD-410F-BB79-95AD2B49AC75}"/>
               </a:ext>
             </a:extLst>
           </p:cNvPr>
@@ -9856,7 +9856,7 @@
           <p:cNvPr id="24" name="limit-v-2-2">
             <a:extLst xmlns:a="http://schemas.openxmlformats.org/drawingml/2006/main">
               <a:ext uri="{FF2B5EF4-FFF2-40B4-BE49-F238E27FC236}">
-                <a16:creationId xmlns:a16="http://schemas.microsoft.com/office/drawing/2014/main" id="{A04D9E3B-5866-4571-8748-A3BFA2970B43}"/>
+                <a16:creationId xmlns:a16="http://schemas.microsoft.com/office/drawing/2014/main" id="{17F844C4-6B42-4A60-8501-559DB975BF0D}"/>
               </a:ext>
             </a:extLst>
           </p:cNvPr>
@@ -9906,7 +9906,7 @@
           <p:cNvPr id="25" name="limit-v-2-3">
             <a:extLst xmlns:a="http://schemas.openxmlformats.org/drawingml/2006/main">
               <a:ext uri="{FF2B5EF4-FFF2-40B4-BE49-F238E27FC236}">
-                <a16:creationId xmlns:a16="http://schemas.microsoft.com/office/drawing/2014/main" id="{4E26C4B4-65A6-454E-A66C-DDE8065AB78F}"/>
+                <a16:creationId xmlns:a16="http://schemas.microsoft.com/office/drawing/2014/main" id="{9E8D51AC-4F4A-4259-9753-0A7705ED81C1}"/>
               </a:ext>
             </a:extLst>
           </p:cNvPr>
@@ -9954,7 +9954,7 @@
     </p:spTree>
     <p:extLst>
       <p:ext uri="{BB962C8B-B14F-4D97-AF65-F5344CB8AC3E}">
-        <p14:creationId xmlns:p14="http://schemas.microsoft.com/office/powerpoint/2010/main" val="576466821"/>
+        <p14:creationId xmlns:p14="http://schemas.microsoft.com/office/powerpoint/2010/main" val="589666834"/>
       </p:ext>
     </p:extLst>
   </p:cSld>
@@ -9985,7 +9985,7 @@
           <p:cNvPr id="7" name="mechanism-rail">
             <a:extLst xmlns:a="http://schemas.openxmlformats.org/drawingml/2006/main">
               <a:ext uri="{FF2B5EF4-FFF2-40B4-BE49-F238E27FC236}">
-                <a16:creationId xmlns:a16="http://schemas.microsoft.com/office/drawing/2014/main" id="{60069568-E8A0-49BB-8755-1149E7363046}"/>
+                <a16:creationId xmlns:a16="http://schemas.microsoft.com/office/drawing/2014/main" id="{468AF987-B726-4EB5-B88C-CF6AA42E4E3A}"/>
               </a:ext>
             </a:extLst>
           </p:cNvPr>
@@ -10018,7 +10018,7 @@
           <p:cNvPr id="2" name="mechanism-title">
             <a:extLst xmlns:a="http://schemas.openxmlformats.org/drawingml/2006/main">
               <a:ext uri="{FF2B5EF4-FFF2-40B4-BE49-F238E27FC236}">
-                <a16:creationId xmlns:a16="http://schemas.microsoft.com/office/drawing/2014/main" id="{06610291-7952-4240-80ED-B74A118CE0C7}"/>
+                <a16:creationId xmlns:a16="http://schemas.microsoft.com/office/drawing/2014/main" id="{DDAEF585-7984-44B8-B55E-35398F7441F9}"/>
               </a:ext>
             </a:extLst>
           </p:cNvPr>
@@ -10068,7 +10068,7 @@
           <p:cNvPr id="3" name="mechanism-subtitle">
             <a:extLst xmlns:a="http://schemas.openxmlformats.org/drawingml/2006/main">
               <a:ext uri="{FF2B5EF4-FFF2-40B4-BE49-F238E27FC236}">
-                <a16:creationId xmlns:a16="http://schemas.microsoft.com/office/drawing/2014/main" id="{78710CC1-03A9-4958-91F8-4E305B5C8E84}"/>
+                <a16:creationId xmlns:a16="http://schemas.microsoft.com/office/drawing/2014/main" id="{1AE09CB3-A913-40E8-9CFA-615A4624F0B5}"/>
               </a:ext>
             </a:extLst>
           </p:cNvPr>
@@ -10118,7 +10118,7 @@
           <p:cNvPr id="4" name="">
             <a:extLst xmlns:a="http://schemas.openxmlformats.org/drawingml/2006/main">
               <a:ext uri="{FF2B5EF4-FFF2-40B4-BE49-F238E27FC236}">
-                <a16:creationId xmlns:a16="http://schemas.microsoft.com/office/drawing/2014/main" id="{18D1AF44-9D8B-4A5B-807F-68F59D014D0D}"/>
+                <a16:creationId xmlns:a16="http://schemas.microsoft.com/office/drawing/2014/main" id="{0820BAB4-72A9-43EE-93A9-FA4485580BBE}"/>
               </a:ext>
             </a:extLst>
           </p:cNvPr>
@@ -10153,13 +10153,13 @@
           <p:nvPr/>
         </p:nvPicPr>
         <p:blipFill>
-          <a:blip xmlns:r="http://schemas.openxmlformats.org/officeDocument/2006/relationships" xmlns:a="http://schemas.openxmlformats.org/drawingml/2006/main" r:embed="R2d89d394b910480e"/>
+          <a:blip xmlns:r="http://schemas.openxmlformats.org/officeDocument/2006/relationships" xmlns:a="http://schemas.openxmlformats.org/drawingml/2006/main" r:embed="Rd4c7a094aa2646bb"/>
           <a:stretch xmlns:a="http://schemas.openxmlformats.org/drawingml/2006/main"/>
         </p:blipFill>
         <p:spPr>
           <a:xfrm xmlns:a="http://schemas.openxmlformats.org/drawingml/2006/main">
-            <a:off x="1619250" y="839203"/>
-            <a:ext cx="8953500" cy="5560595"/>
+            <a:off x="1619250" y="1099989"/>
+            <a:ext cx="8953500" cy="5039021"/>
           </a:xfrm>
           <a:prstGeom xmlns:a="http://schemas.openxmlformats.org/drawingml/2006/main" prst="rect">
             <a:avLst/>
@@ -10171,7 +10171,7 @@
           <p:cNvPr id="6" name="mechanism-page">
             <a:extLst xmlns:a="http://schemas.openxmlformats.org/drawingml/2006/main">
               <a:ext uri="{FF2B5EF4-FFF2-40B4-BE49-F238E27FC236}">
-                <a16:creationId xmlns:a16="http://schemas.microsoft.com/office/drawing/2014/main" id="{A0FEAC8A-F28A-43A0-892C-F2867B397D7A}"/>
+                <a16:creationId xmlns:a16="http://schemas.microsoft.com/office/drawing/2014/main" id="{EA940490-31A4-4DA0-8E18-E42DF97D61BD}"/>
               </a:ext>
             </a:extLst>
           </p:cNvPr>
@@ -10219,7 +10219,7 @@
     </p:spTree>
     <p:extLst>
       <p:ext uri="{BB962C8B-B14F-4D97-AF65-F5344CB8AC3E}">
-        <p14:creationId xmlns:p14="http://schemas.microsoft.com/office/powerpoint/2010/main" val="1945553522"/>
+        <p14:creationId xmlns:p14="http://schemas.microsoft.com/office/powerpoint/2010/main" val="1845188322"/>
       </p:ext>
     </p:extLst>
   </p:cSld>
@@ -10250,7 +10250,7 @@
           <p:cNvPr id="11" name="copper-16">
             <a:extLst xmlns:a="http://schemas.openxmlformats.org/drawingml/2006/main">
               <a:ext uri="{FF2B5EF4-FFF2-40B4-BE49-F238E27FC236}">
-                <a16:creationId xmlns:a16="http://schemas.microsoft.com/office/drawing/2014/main" id="{00D8CF15-435B-463A-B2FC-62BD04C502F6}"/>
+                <a16:creationId xmlns:a16="http://schemas.microsoft.com/office/drawing/2014/main" id="{69A0B52E-0F5E-4C4E-84D5-2EB07AD078A7}"/>
               </a:ext>
             </a:extLst>
           </p:cNvPr>
@@ -10283,7 +10283,7 @@
           <p:cNvPr id="2" name="chapter-script-16">
             <a:extLst xmlns:a="http://schemas.openxmlformats.org/drawingml/2006/main">
               <a:ext uri="{FF2B5EF4-FFF2-40B4-BE49-F238E27FC236}">
-                <a16:creationId xmlns:a16="http://schemas.microsoft.com/office/drawing/2014/main" id="{D825881C-2264-4CF0-9EBF-A84D96159525}"/>
+                <a16:creationId xmlns:a16="http://schemas.microsoft.com/office/drawing/2014/main" id="{E076BC11-02C1-4AA1-B242-A5A00C0D9BAC}"/>
               </a:ext>
             </a:extLst>
           </p:cNvPr>
@@ -10333,7 +10333,7 @@
           <p:cNvPr id="3" name="roman-16">
             <a:extLst xmlns:a="http://schemas.openxmlformats.org/drawingml/2006/main">
               <a:ext uri="{FF2B5EF4-FFF2-40B4-BE49-F238E27FC236}">
-                <a16:creationId xmlns:a16="http://schemas.microsoft.com/office/drawing/2014/main" id="{E081764A-6A03-4851-881F-76727670F3F7}"/>
+                <a16:creationId xmlns:a16="http://schemas.microsoft.com/office/drawing/2014/main" id="{94B0A66A-38A4-4FFC-807D-40FB1E3C746B}"/>
               </a:ext>
             </a:extLst>
           </p:cNvPr>
@@ -10383,7 +10383,7 @@
           <p:cNvPr id="4" name="">
             <a:extLst xmlns:a="http://schemas.openxmlformats.org/drawingml/2006/main">
               <a:ext uri="{FF2B5EF4-FFF2-40B4-BE49-F238E27FC236}">
-                <a16:creationId xmlns:a16="http://schemas.microsoft.com/office/drawing/2014/main" id="{CC35A5A0-E634-49FE-A386-FF0399BFBF50}"/>
+                <a16:creationId xmlns:a16="http://schemas.microsoft.com/office/drawing/2014/main" id="{8B10209B-2E18-4447-8F40-933D21814AA9}"/>
               </a:ext>
             </a:extLst>
           </p:cNvPr>
@@ -10414,7 +10414,7 @@
           <p:cNvPr id="5" name="zh-16">
             <a:extLst xmlns:a="http://schemas.openxmlformats.org/drawingml/2006/main">
               <a:ext uri="{FF2B5EF4-FFF2-40B4-BE49-F238E27FC236}">
-                <a16:creationId xmlns:a16="http://schemas.microsoft.com/office/drawing/2014/main" id="{06FECFF6-D814-4F2E-821D-44CBEC0380DA}"/>
+                <a16:creationId xmlns:a16="http://schemas.microsoft.com/office/drawing/2014/main" id="{E6AA5AEA-2806-48A3-AC37-D8D0411DDFC9}"/>
               </a:ext>
             </a:extLst>
           </p:cNvPr>
@@ -10464,7 +10464,7 @@
           <p:cNvPr id="6" name="en-16">
             <a:extLst xmlns:a="http://schemas.openxmlformats.org/drawingml/2006/main">
               <a:ext uri="{FF2B5EF4-FFF2-40B4-BE49-F238E27FC236}">
-                <a16:creationId xmlns:a16="http://schemas.microsoft.com/office/drawing/2014/main" id="{CB8D4588-FA2B-4839-AB15-E10F2DBA90FD}"/>
+                <a16:creationId xmlns:a16="http://schemas.microsoft.com/office/drawing/2014/main" id="{CC4BD1B9-902E-4D89-98BB-E7B9592A3A66}"/>
               </a:ext>
             </a:extLst>
           </p:cNvPr>
@@ -10514,7 +10514,7 @@
           <p:cNvPr id="7" name="body-16">
             <a:extLst xmlns:a="http://schemas.openxmlformats.org/drawingml/2006/main">
               <a:ext uri="{FF2B5EF4-FFF2-40B4-BE49-F238E27FC236}">
-                <a16:creationId xmlns:a16="http://schemas.microsoft.com/office/drawing/2014/main" id="{5AD912BE-1B89-4661-9590-C2870389C8F1}"/>
+                <a16:creationId xmlns:a16="http://schemas.microsoft.com/office/drawing/2014/main" id="{1B89B987-F299-4CAA-9E66-5812922C9B11}"/>
               </a:ext>
             </a:extLst>
           </p:cNvPr>
@@ -10568,7 +10568,7 @@
           <p:cNvPr id="8" name="chapter-pill-16-bg">
             <a:extLst xmlns:a="http://schemas.openxmlformats.org/drawingml/2006/main">
               <a:ext uri="{FF2B5EF4-FFF2-40B4-BE49-F238E27FC236}">
-                <a16:creationId xmlns:a16="http://schemas.microsoft.com/office/drawing/2014/main" id="{E4F35A34-DE46-471D-8AFA-D2D31965A81E}"/>
+                <a16:creationId xmlns:a16="http://schemas.microsoft.com/office/drawing/2014/main" id="{6159B46F-FAA5-4C8D-9CE7-BCFAC1AF4A25}"/>
               </a:ext>
             </a:extLst>
           </p:cNvPr>
@@ -10603,7 +10603,7 @@
           <p:cNvPr id="9" name="chapter-pill-16-text">
             <a:extLst xmlns:a="http://schemas.openxmlformats.org/drawingml/2006/main">
               <a:ext uri="{FF2B5EF4-FFF2-40B4-BE49-F238E27FC236}">
-                <a16:creationId xmlns:a16="http://schemas.microsoft.com/office/drawing/2014/main" id="{7CCA2D2A-6E36-429C-95D1-9A5EB0DC1C6C}"/>
+                <a16:creationId xmlns:a16="http://schemas.microsoft.com/office/drawing/2014/main" id="{A873AC04-3E9F-4132-BC21-587FE75D0D9A}"/>
               </a:ext>
             </a:extLst>
           </p:cNvPr>
@@ -10653,7 +10653,7 @@
           <p:cNvPr id="10" name="close-command">
             <a:extLst xmlns:a="http://schemas.openxmlformats.org/drawingml/2006/main">
               <a:ext uri="{FF2B5EF4-FFF2-40B4-BE49-F238E27FC236}">
-                <a16:creationId xmlns:a16="http://schemas.microsoft.com/office/drawing/2014/main" id="{6F7EBECD-8804-4645-A1A3-E6D24895D1F3}"/>
+                <a16:creationId xmlns:a16="http://schemas.microsoft.com/office/drawing/2014/main" id="{C7A82972-D710-46E4-8648-6AE16F04BE90}"/>
               </a:ext>
             </a:extLst>
           </p:cNvPr>
@@ -10701,7 +10701,7 @@
     </p:spTree>
     <p:extLst>
       <p:ext uri="{BB962C8B-B14F-4D97-AF65-F5344CB8AC3E}">
-        <p14:creationId xmlns:p14="http://schemas.microsoft.com/office/powerpoint/2010/main" val="716297403"/>
+        <p14:creationId xmlns:p14="http://schemas.microsoft.com/office/powerpoint/2010/main" val="657582875"/>
       </p:ext>
     </p:extLst>
   </p:cSld>
@@ -10732,7 +10732,7 @@
           <p:cNvPr id="25" name="rail-2">
             <a:extLst xmlns:a="http://schemas.openxmlformats.org/drawingml/2006/main">
               <a:ext uri="{FF2B5EF4-FFF2-40B4-BE49-F238E27FC236}">
-                <a16:creationId xmlns:a16="http://schemas.microsoft.com/office/drawing/2014/main" id="{FB3045A7-9F89-44AB-ACA5-235AA9735881}"/>
+                <a16:creationId xmlns:a16="http://schemas.microsoft.com/office/drawing/2014/main" id="{39C6AB00-80E0-4688-9AB7-9B8AAD3616A7}"/>
               </a:ext>
             </a:extLst>
           </p:cNvPr>
@@ -10765,7 +10765,7 @@
           <p:cNvPr id="2" name="flourish-2">
             <a:extLst xmlns:a="http://schemas.openxmlformats.org/drawingml/2006/main">
               <a:ext uri="{FF2B5EF4-FFF2-40B4-BE49-F238E27FC236}">
-                <a16:creationId xmlns:a16="http://schemas.microsoft.com/office/drawing/2014/main" id="{2D49E8B1-2B71-4D15-8EB5-D5DB47CCAE50}"/>
+                <a16:creationId xmlns:a16="http://schemas.microsoft.com/office/drawing/2014/main" id="{3034A68A-8082-4CDB-AF65-7FD0BAF1643D}"/>
               </a:ext>
             </a:extLst>
           </p:cNvPr>
@@ -10815,7 +10815,7 @@
           <p:cNvPr id="3" name="chapter-2">
             <a:extLst xmlns:a="http://schemas.openxmlformats.org/drawingml/2006/main">
               <a:ext uri="{FF2B5EF4-FFF2-40B4-BE49-F238E27FC236}">
-                <a16:creationId xmlns:a16="http://schemas.microsoft.com/office/drawing/2014/main" id="{4EF1AD9C-301C-4EB8-B21F-F3D65AD90FDC}"/>
+                <a16:creationId xmlns:a16="http://schemas.microsoft.com/office/drawing/2014/main" id="{79AB3039-0783-45E7-9319-8FE1765DB34E}"/>
               </a:ext>
             </a:extLst>
           </p:cNvPr>
@@ -10865,7 +10865,7 @@
           <p:cNvPr id="4" name="title-2">
             <a:extLst xmlns:a="http://schemas.openxmlformats.org/drawingml/2006/main">
               <a:ext uri="{FF2B5EF4-FFF2-40B4-BE49-F238E27FC236}">
-                <a16:creationId xmlns:a16="http://schemas.microsoft.com/office/drawing/2014/main" id="{001C9E60-C946-4B5D-A47B-5B60DEB2A889}"/>
+                <a16:creationId xmlns:a16="http://schemas.microsoft.com/office/drawing/2014/main" id="{0739C487-E8C9-474F-8D36-73EB4CD23BF0}"/>
               </a:ext>
             </a:extLst>
           </p:cNvPr>
@@ -10915,7 +10915,7 @@
           <p:cNvPr id="5" name="subtitle-2">
             <a:extLst xmlns:a="http://schemas.openxmlformats.org/drawingml/2006/main">
               <a:ext uri="{FF2B5EF4-FFF2-40B4-BE49-F238E27FC236}">
-                <a16:creationId xmlns:a16="http://schemas.microsoft.com/office/drawing/2014/main" id="{354CE198-CB8D-4827-A2C4-34B7B5FED27B}"/>
+                <a16:creationId xmlns:a16="http://schemas.microsoft.com/office/drawing/2014/main" id="{90BEAE92-36E7-4E87-BCFE-769504B834B2}"/>
               </a:ext>
             </a:extLst>
           </p:cNvPr>
@@ -10965,7 +10965,7 @@
           <p:cNvPr id="6" name="">
             <a:extLst xmlns:a="http://schemas.openxmlformats.org/drawingml/2006/main">
               <a:ext uri="{FF2B5EF4-FFF2-40B4-BE49-F238E27FC236}">
-                <a16:creationId xmlns:a16="http://schemas.microsoft.com/office/drawing/2014/main" id="{9330C672-FEBF-449C-B65E-0364982E02F1}"/>
+                <a16:creationId xmlns:a16="http://schemas.microsoft.com/office/drawing/2014/main" id="{AAD8BD17-52B8-4776-BA2D-1292D217999B}"/>
               </a:ext>
             </a:extLst>
           </p:cNvPr>
@@ -10996,7 +10996,7 @@
           <p:cNvPr id="7" name="page-2">
             <a:extLst xmlns:a="http://schemas.openxmlformats.org/drawingml/2006/main">
               <a:ext uri="{FF2B5EF4-FFF2-40B4-BE49-F238E27FC236}">
-                <a16:creationId xmlns:a16="http://schemas.microsoft.com/office/drawing/2014/main" id="{F2CBA293-D4A8-40A9-93A7-F2040252D18C}"/>
+                <a16:creationId xmlns:a16="http://schemas.microsoft.com/office/drawing/2014/main" id="{F2D5A237-C7C7-4C3B-81A5-FB9A98D3B2B8}"/>
               </a:ext>
             </a:extLst>
           </p:cNvPr>
@@ -11046,7 +11046,7 @@
           <p:cNvPr id="8" name="map-0">
             <a:extLst xmlns:a="http://schemas.openxmlformats.org/drawingml/2006/main">
               <a:ext uri="{FF2B5EF4-FFF2-40B4-BE49-F238E27FC236}">
-                <a16:creationId xmlns:a16="http://schemas.microsoft.com/office/drawing/2014/main" id="{B3076578-15F6-485D-9F4D-17A7CCDB07CD}"/>
+                <a16:creationId xmlns:a16="http://schemas.microsoft.com/office/drawing/2014/main" id="{322A9FA2-EA4B-41B1-97B8-FEC2D56BB598}"/>
               </a:ext>
             </a:extLst>
           </p:cNvPr>
@@ -11081,7 +11081,7 @@
           <p:cNvPr id="9" name="map-num-0">
             <a:extLst xmlns:a="http://schemas.openxmlformats.org/drawingml/2006/main">
               <a:ext uri="{FF2B5EF4-FFF2-40B4-BE49-F238E27FC236}">
-                <a16:creationId xmlns:a16="http://schemas.microsoft.com/office/drawing/2014/main" id="{B41B83D5-09BC-40FB-8390-3C57D06E1F7B}"/>
+                <a16:creationId xmlns:a16="http://schemas.microsoft.com/office/drawing/2014/main" id="{798389D7-E659-429C-AC4E-6FEEA6B79CE1}"/>
               </a:ext>
             </a:extLst>
           </p:cNvPr>
@@ -11131,7 +11131,7 @@
           <p:cNvPr id="10" name="map-name-0">
             <a:extLst xmlns:a="http://schemas.openxmlformats.org/drawingml/2006/main">
               <a:ext uri="{FF2B5EF4-FFF2-40B4-BE49-F238E27FC236}">
-                <a16:creationId xmlns:a16="http://schemas.microsoft.com/office/drawing/2014/main" id="{A5D19396-80FD-4F41-9B7C-329D867A4F40}"/>
+                <a16:creationId xmlns:a16="http://schemas.microsoft.com/office/drawing/2014/main" id="{0CA8D4EB-1908-4702-9BCC-E296C22116D8}"/>
               </a:ext>
             </a:extLst>
           </p:cNvPr>
@@ -11181,7 +11181,7 @@
           <p:cNvPr id="11" name="map-body-0">
             <a:extLst xmlns:a="http://schemas.openxmlformats.org/drawingml/2006/main">
               <a:ext uri="{FF2B5EF4-FFF2-40B4-BE49-F238E27FC236}">
-                <a16:creationId xmlns:a16="http://schemas.microsoft.com/office/drawing/2014/main" id="{5AD31A33-0222-4272-B9C3-E6ED04AEE2AC}"/>
+                <a16:creationId xmlns:a16="http://schemas.microsoft.com/office/drawing/2014/main" id="{973BC3FB-D032-449B-95AC-DD7DBC5DF5EC}"/>
               </a:ext>
             </a:extLst>
           </p:cNvPr>
@@ -11235,7 +11235,7 @@
           <p:cNvPr id="12" name="map-1">
             <a:extLst xmlns:a="http://schemas.openxmlformats.org/drawingml/2006/main">
               <a:ext uri="{FF2B5EF4-FFF2-40B4-BE49-F238E27FC236}">
-                <a16:creationId xmlns:a16="http://schemas.microsoft.com/office/drawing/2014/main" id="{2F90A48D-A4C9-4AFE-BF55-E426F8A612AC}"/>
+                <a16:creationId xmlns:a16="http://schemas.microsoft.com/office/drawing/2014/main" id="{11D9E507-CE18-44B0-908A-0C3123C3730B}"/>
               </a:ext>
             </a:extLst>
           </p:cNvPr>
@@ -11270,7 +11270,7 @@
           <p:cNvPr id="13" name="map-num-1">
             <a:extLst xmlns:a="http://schemas.openxmlformats.org/drawingml/2006/main">
               <a:ext uri="{FF2B5EF4-FFF2-40B4-BE49-F238E27FC236}">
-                <a16:creationId xmlns:a16="http://schemas.microsoft.com/office/drawing/2014/main" id="{58D90723-67D1-4025-AA42-97E5418B19E9}"/>
+                <a16:creationId xmlns:a16="http://schemas.microsoft.com/office/drawing/2014/main" id="{4FE0DE80-7625-495E-867F-F626E7F54512}"/>
               </a:ext>
             </a:extLst>
           </p:cNvPr>
@@ -11320,7 +11320,7 @@
           <p:cNvPr id="14" name="map-name-1">
             <a:extLst xmlns:a="http://schemas.openxmlformats.org/drawingml/2006/main">
               <a:ext uri="{FF2B5EF4-FFF2-40B4-BE49-F238E27FC236}">
-                <a16:creationId xmlns:a16="http://schemas.microsoft.com/office/drawing/2014/main" id="{BFC846E9-5506-4FD6-8DAC-C9002471FB38}"/>
+                <a16:creationId xmlns:a16="http://schemas.microsoft.com/office/drawing/2014/main" id="{2749930E-38D8-4DF1-9C8A-D75BA2F9E74D}"/>
               </a:ext>
             </a:extLst>
           </p:cNvPr>
@@ -11370,7 +11370,7 @@
           <p:cNvPr id="15" name="map-body-1">
             <a:extLst xmlns:a="http://schemas.openxmlformats.org/drawingml/2006/main">
               <a:ext uri="{FF2B5EF4-FFF2-40B4-BE49-F238E27FC236}">
-                <a16:creationId xmlns:a16="http://schemas.microsoft.com/office/drawing/2014/main" id="{A3D6B6EE-00BA-4B63-AB1D-E859C22D9F4C}"/>
+                <a16:creationId xmlns:a16="http://schemas.microsoft.com/office/drawing/2014/main" id="{2022192D-E33A-4F4A-8F11-0B051DF8C08B}"/>
               </a:ext>
             </a:extLst>
           </p:cNvPr>
@@ -11424,7 +11424,7 @@
           <p:cNvPr id="16" name="map-2">
             <a:extLst xmlns:a="http://schemas.openxmlformats.org/drawingml/2006/main">
               <a:ext uri="{FF2B5EF4-FFF2-40B4-BE49-F238E27FC236}">
-                <a16:creationId xmlns:a16="http://schemas.microsoft.com/office/drawing/2014/main" id="{8A30C880-45E1-4609-9EDA-0D159663646F}"/>
+                <a16:creationId xmlns:a16="http://schemas.microsoft.com/office/drawing/2014/main" id="{72BEF085-9EB9-4AE3-8CEA-EE981495D674}"/>
               </a:ext>
             </a:extLst>
           </p:cNvPr>
@@ -11459,7 +11459,7 @@
           <p:cNvPr id="17" name="map-num-2">
             <a:extLst xmlns:a="http://schemas.openxmlformats.org/drawingml/2006/main">
               <a:ext uri="{FF2B5EF4-FFF2-40B4-BE49-F238E27FC236}">
-                <a16:creationId xmlns:a16="http://schemas.microsoft.com/office/drawing/2014/main" id="{06DA1D34-88C3-4CDF-A43E-F7DC4B504961}"/>
+                <a16:creationId xmlns:a16="http://schemas.microsoft.com/office/drawing/2014/main" id="{B53AB7E3-D0F8-46F8-B225-3E04B9826AD2}"/>
               </a:ext>
             </a:extLst>
           </p:cNvPr>
@@ -11509,7 +11509,7 @@
           <p:cNvPr id="18" name="map-name-2">
             <a:extLst xmlns:a="http://schemas.openxmlformats.org/drawingml/2006/main">
               <a:ext uri="{FF2B5EF4-FFF2-40B4-BE49-F238E27FC236}">
-                <a16:creationId xmlns:a16="http://schemas.microsoft.com/office/drawing/2014/main" id="{94D8AED2-4157-4C19-AA0B-4CC23F81DF24}"/>
+                <a16:creationId xmlns:a16="http://schemas.microsoft.com/office/drawing/2014/main" id="{26AC4D05-7787-4A80-9182-9EB39390079C}"/>
               </a:ext>
             </a:extLst>
           </p:cNvPr>
@@ -11559,7 +11559,7 @@
           <p:cNvPr id="19" name="map-body-2">
             <a:extLst xmlns:a="http://schemas.openxmlformats.org/drawingml/2006/main">
               <a:ext uri="{FF2B5EF4-FFF2-40B4-BE49-F238E27FC236}">
-                <a16:creationId xmlns:a16="http://schemas.microsoft.com/office/drawing/2014/main" id="{41A46D2A-48C0-420A-8A94-3E872E5F71C7}"/>
+                <a16:creationId xmlns:a16="http://schemas.microsoft.com/office/drawing/2014/main" id="{525DDCCA-14AB-4475-8D3B-D931A5300785}"/>
               </a:ext>
             </a:extLst>
           </p:cNvPr>
@@ -11613,7 +11613,7 @@
           <p:cNvPr id="20" name="map-3">
             <a:extLst xmlns:a="http://schemas.openxmlformats.org/drawingml/2006/main">
               <a:ext uri="{FF2B5EF4-FFF2-40B4-BE49-F238E27FC236}">
-                <a16:creationId xmlns:a16="http://schemas.microsoft.com/office/drawing/2014/main" id="{4C259CF4-D2E1-4D11-80F2-D7386ACFBE0F}"/>
+                <a16:creationId xmlns:a16="http://schemas.microsoft.com/office/drawing/2014/main" id="{8FF360D8-3B04-483E-9497-3054C3726578}"/>
               </a:ext>
             </a:extLst>
           </p:cNvPr>
@@ -11648,7 +11648,7 @@
           <p:cNvPr id="21" name="map-num-3">
             <a:extLst xmlns:a="http://schemas.openxmlformats.org/drawingml/2006/main">
               <a:ext uri="{FF2B5EF4-FFF2-40B4-BE49-F238E27FC236}">
-                <a16:creationId xmlns:a16="http://schemas.microsoft.com/office/drawing/2014/main" id="{1FF5E1D0-157E-4DAD-B517-9FD895398011}"/>
+                <a16:creationId xmlns:a16="http://schemas.microsoft.com/office/drawing/2014/main" id="{FA8D37A4-619A-4C53-AA29-E4F2023B6F3A}"/>
               </a:ext>
             </a:extLst>
           </p:cNvPr>
@@ -11698,7 +11698,7 @@
           <p:cNvPr id="22" name="map-name-3">
             <a:extLst xmlns:a="http://schemas.openxmlformats.org/drawingml/2006/main">
               <a:ext uri="{FF2B5EF4-FFF2-40B4-BE49-F238E27FC236}">
-                <a16:creationId xmlns:a16="http://schemas.microsoft.com/office/drawing/2014/main" id="{3E245304-9DFE-4520-BE9F-A722AC71FCB3}"/>
+                <a16:creationId xmlns:a16="http://schemas.microsoft.com/office/drawing/2014/main" id="{C25F1259-D72C-46F3-A044-C40DFACF89D4}"/>
               </a:ext>
             </a:extLst>
           </p:cNvPr>
@@ -11748,7 +11748,7 @@
           <p:cNvPr id="23" name="map-body-3">
             <a:extLst xmlns:a="http://schemas.openxmlformats.org/drawingml/2006/main">
               <a:ext uri="{FF2B5EF4-FFF2-40B4-BE49-F238E27FC236}">
-                <a16:creationId xmlns:a16="http://schemas.microsoft.com/office/drawing/2014/main" id="{0C5C0F28-C0D6-4033-967E-10CB238AD08F}"/>
+                <a16:creationId xmlns:a16="http://schemas.microsoft.com/office/drawing/2014/main" id="{30E1A9DD-0404-4580-B6A8-5F010F981C6F}"/>
               </a:ext>
             </a:extLst>
           </p:cNvPr>
@@ -11802,7 +11802,7 @@
           <p:cNvPr id="24" name="map-foot">
             <a:extLst xmlns:a="http://schemas.openxmlformats.org/drawingml/2006/main">
               <a:ext uri="{FF2B5EF4-FFF2-40B4-BE49-F238E27FC236}">
-                <a16:creationId xmlns:a16="http://schemas.microsoft.com/office/drawing/2014/main" id="{91BF29D2-E03D-4834-9693-80745AE002D0}"/>
+                <a16:creationId xmlns:a16="http://schemas.microsoft.com/office/drawing/2014/main" id="{DC7077EA-C832-4BDA-AEDD-D9B516AF6C18}"/>
               </a:ext>
             </a:extLst>
           </p:cNvPr>
@@ -11850,7 +11850,7 @@
     </p:spTree>
     <p:extLst>
       <p:ext uri="{BB962C8B-B14F-4D97-AF65-F5344CB8AC3E}">
-        <p14:creationId xmlns:p14="http://schemas.microsoft.com/office/powerpoint/2010/main" val="767403440"/>
+        <p14:creationId xmlns:p14="http://schemas.microsoft.com/office/powerpoint/2010/main" val="1366980109"/>
       </p:ext>
     </p:extLst>
   </p:cSld>
@@ -11881,7 +11881,7 @@
           <p:cNvPr id="21" name="rail-3">
             <a:extLst xmlns:a="http://schemas.openxmlformats.org/drawingml/2006/main">
               <a:ext uri="{FF2B5EF4-FFF2-40B4-BE49-F238E27FC236}">
-                <a16:creationId xmlns:a16="http://schemas.microsoft.com/office/drawing/2014/main" id="{C448909E-28A0-414C-8694-FEE172ECCCCA}"/>
+                <a16:creationId xmlns:a16="http://schemas.microsoft.com/office/drawing/2014/main" id="{5D3B8405-6D9E-4CB3-B41D-C51C331C57B7}"/>
               </a:ext>
             </a:extLst>
           </p:cNvPr>
@@ -11914,7 +11914,7 @@
           <p:cNvPr id="2" name="flourish-3">
             <a:extLst xmlns:a="http://schemas.openxmlformats.org/drawingml/2006/main">
               <a:ext uri="{FF2B5EF4-FFF2-40B4-BE49-F238E27FC236}">
-                <a16:creationId xmlns:a16="http://schemas.microsoft.com/office/drawing/2014/main" id="{DCCC71E3-39ED-45DB-9CE4-0A8545BF57A1}"/>
+                <a16:creationId xmlns:a16="http://schemas.microsoft.com/office/drawing/2014/main" id="{E19CA2E1-14CE-4BEE-85F8-1E5C761C588B}"/>
               </a:ext>
             </a:extLst>
           </p:cNvPr>
@@ -11964,7 +11964,7 @@
           <p:cNvPr id="3" name="chapter-3">
             <a:extLst xmlns:a="http://schemas.openxmlformats.org/drawingml/2006/main">
               <a:ext uri="{FF2B5EF4-FFF2-40B4-BE49-F238E27FC236}">
-                <a16:creationId xmlns:a16="http://schemas.microsoft.com/office/drawing/2014/main" id="{21E25124-6AC6-47F4-B99C-7FC91AC4A30A}"/>
+                <a16:creationId xmlns:a16="http://schemas.microsoft.com/office/drawing/2014/main" id="{5A4E3F51-ED70-401F-8369-C87422C4C2A0}"/>
               </a:ext>
             </a:extLst>
           </p:cNvPr>
@@ -12014,7 +12014,7 @@
           <p:cNvPr id="4" name="title-3">
             <a:extLst xmlns:a="http://schemas.openxmlformats.org/drawingml/2006/main">
               <a:ext uri="{FF2B5EF4-FFF2-40B4-BE49-F238E27FC236}">
-                <a16:creationId xmlns:a16="http://schemas.microsoft.com/office/drawing/2014/main" id="{D097B408-F2E6-46D8-85EB-1E08757EAA32}"/>
+                <a16:creationId xmlns:a16="http://schemas.microsoft.com/office/drawing/2014/main" id="{56EBF8CC-D705-42A4-8502-50CD4FEB79FD}"/>
               </a:ext>
             </a:extLst>
           </p:cNvPr>
@@ -12064,7 +12064,7 @@
           <p:cNvPr id="5" name="subtitle-3">
             <a:extLst xmlns:a="http://schemas.openxmlformats.org/drawingml/2006/main">
               <a:ext uri="{FF2B5EF4-FFF2-40B4-BE49-F238E27FC236}">
-                <a16:creationId xmlns:a16="http://schemas.microsoft.com/office/drawing/2014/main" id="{58EAAD43-3D76-4FE5-A637-660949BA6C82}"/>
+                <a16:creationId xmlns:a16="http://schemas.microsoft.com/office/drawing/2014/main" id="{606A6262-205A-4779-B3AD-70BAE88A668A}"/>
               </a:ext>
             </a:extLst>
           </p:cNvPr>
@@ -12114,7 +12114,7 @@
           <p:cNvPr id="6" name="">
             <a:extLst xmlns:a="http://schemas.openxmlformats.org/drawingml/2006/main">
               <a:ext uri="{FF2B5EF4-FFF2-40B4-BE49-F238E27FC236}">
-                <a16:creationId xmlns:a16="http://schemas.microsoft.com/office/drawing/2014/main" id="{3772449D-32AA-47B7-B9D0-775341E7FBF3}"/>
+                <a16:creationId xmlns:a16="http://schemas.microsoft.com/office/drawing/2014/main" id="{C121E721-452D-487C-9A4C-8A379385FE96}"/>
               </a:ext>
             </a:extLst>
           </p:cNvPr>
@@ -12145,7 +12145,7 @@
           <p:cNvPr id="7" name="page-3">
             <a:extLst xmlns:a="http://schemas.openxmlformats.org/drawingml/2006/main">
               <a:ext uri="{FF2B5EF4-FFF2-40B4-BE49-F238E27FC236}">
-                <a16:creationId xmlns:a16="http://schemas.microsoft.com/office/drawing/2014/main" id="{A13779EB-600C-4D15-B9B7-7FAAC968605D}"/>
+                <a16:creationId xmlns:a16="http://schemas.microsoft.com/office/drawing/2014/main" id="{8FF4B582-F3A2-4FB4-AD48-8F18FC90FEA6}"/>
               </a:ext>
             </a:extLst>
           </p:cNvPr>
@@ -12199,7 +12199,7 @@
           <p:nvPr/>
         </p:nvPicPr>
         <p:blipFill>
-          <a:blip xmlns:r="http://schemas.openxmlformats.org/officeDocument/2006/relationships" xmlns:a="http://schemas.openxmlformats.org/drawingml/2006/main" r:embed="R1386b6d36b3142a5"/>
+          <a:blip xmlns:r="http://schemas.openxmlformats.org/officeDocument/2006/relationships" xmlns:a="http://schemas.openxmlformats.org/drawingml/2006/main" r:embed="Ra82f6f11675f48ec"/>
           <a:stretch xmlns:a="http://schemas.openxmlformats.org/drawingml/2006/main"/>
         </p:blipFill>
         <p:spPr>
@@ -12217,7 +12217,7 @@
           <p:cNvPr id="9" name="">
             <a:extLst xmlns:a="http://schemas.openxmlformats.org/drawingml/2006/main">
               <a:ext uri="{FF2B5EF4-FFF2-40B4-BE49-F238E27FC236}">
-                <a16:creationId xmlns:a16="http://schemas.microsoft.com/office/drawing/2014/main" id="{11BA1D3D-2E4B-4649-B036-99C776B916F9}"/>
+                <a16:creationId xmlns:a16="http://schemas.microsoft.com/office/drawing/2014/main" id="{096C0D8D-7541-4937-B039-2EA5F239A93F}"/>
               </a:ext>
             </a:extLst>
           </p:cNvPr>
@@ -12248,7 +12248,7 @@
           <p:cNvPr id="10" name="paper-k-0">
             <a:extLst xmlns:a="http://schemas.openxmlformats.org/drawingml/2006/main">
               <a:ext uri="{FF2B5EF4-FFF2-40B4-BE49-F238E27FC236}">
-                <a16:creationId xmlns:a16="http://schemas.microsoft.com/office/drawing/2014/main" id="{61B6BDF8-BC3A-4BF8-89E2-9405A57CE6E0}"/>
+                <a16:creationId xmlns:a16="http://schemas.microsoft.com/office/drawing/2014/main" id="{81E60B18-59CC-4AA4-B246-2154FABCA0F1}"/>
               </a:ext>
             </a:extLst>
           </p:cNvPr>
@@ -12298,7 +12298,7 @@
           <p:cNvPr id="11" name="paper-v-0">
             <a:extLst xmlns:a="http://schemas.openxmlformats.org/drawingml/2006/main">
               <a:ext uri="{FF2B5EF4-FFF2-40B4-BE49-F238E27FC236}">
-                <a16:creationId xmlns:a16="http://schemas.microsoft.com/office/drawing/2014/main" id="{1DBC807D-0031-479E-BA24-DD96FC4532BC}"/>
+                <a16:creationId xmlns:a16="http://schemas.microsoft.com/office/drawing/2014/main" id="{00EBF084-41C8-4058-81D2-E9997CECEDBA}"/>
               </a:ext>
             </a:extLst>
           </p:cNvPr>
@@ -12348,7 +12348,7 @@
           <p:cNvPr id="12" name="">
             <a:extLst xmlns:a="http://schemas.openxmlformats.org/drawingml/2006/main">
               <a:ext uri="{FF2B5EF4-FFF2-40B4-BE49-F238E27FC236}">
-                <a16:creationId xmlns:a16="http://schemas.microsoft.com/office/drawing/2014/main" id="{D3E3C497-6685-419A-BD8B-D013D5083E3F}"/>
+                <a16:creationId xmlns:a16="http://schemas.microsoft.com/office/drawing/2014/main" id="{B382B7EE-EFC3-4D39-8D0D-199D2CDE5EB7}"/>
               </a:ext>
             </a:extLst>
           </p:cNvPr>
@@ -12379,7 +12379,7 @@
           <p:cNvPr id="13" name="paper-k-1">
             <a:extLst xmlns:a="http://schemas.openxmlformats.org/drawingml/2006/main">
               <a:ext uri="{FF2B5EF4-FFF2-40B4-BE49-F238E27FC236}">
-                <a16:creationId xmlns:a16="http://schemas.microsoft.com/office/drawing/2014/main" id="{ABE7734A-0590-4C50-A826-5B46543B2E51}"/>
+                <a16:creationId xmlns:a16="http://schemas.microsoft.com/office/drawing/2014/main" id="{C3209759-9341-4AA5-AE0D-109A6751184E}"/>
               </a:ext>
             </a:extLst>
           </p:cNvPr>
@@ -12429,7 +12429,7 @@
           <p:cNvPr id="14" name="paper-v-1">
             <a:extLst xmlns:a="http://schemas.openxmlformats.org/drawingml/2006/main">
               <a:ext uri="{FF2B5EF4-FFF2-40B4-BE49-F238E27FC236}">
-                <a16:creationId xmlns:a16="http://schemas.microsoft.com/office/drawing/2014/main" id="{C7344D9A-1BD7-4918-87CA-A9A81FFF960C}"/>
+                <a16:creationId xmlns:a16="http://schemas.microsoft.com/office/drawing/2014/main" id="{9432115A-C090-4F6D-964F-D3B9D9C20795}"/>
               </a:ext>
             </a:extLst>
           </p:cNvPr>
@@ -12479,7 +12479,7 @@
           <p:cNvPr id="15" name="">
             <a:extLst xmlns:a="http://schemas.openxmlformats.org/drawingml/2006/main">
               <a:ext uri="{FF2B5EF4-FFF2-40B4-BE49-F238E27FC236}">
-                <a16:creationId xmlns:a16="http://schemas.microsoft.com/office/drawing/2014/main" id="{6A949409-DCBB-4153-95B7-0F70397B1C5E}"/>
+                <a16:creationId xmlns:a16="http://schemas.microsoft.com/office/drawing/2014/main" id="{8FC65A7C-2283-4593-989A-2E7AE3744FAF}"/>
               </a:ext>
             </a:extLst>
           </p:cNvPr>
@@ -12510,7 +12510,7 @@
           <p:cNvPr id="16" name="paper-k-2">
             <a:extLst xmlns:a="http://schemas.openxmlformats.org/drawingml/2006/main">
               <a:ext uri="{FF2B5EF4-FFF2-40B4-BE49-F238E27FC236}">
-                <a16:creationId xmlns:a16="http://schemas.microsoft.com/office/drawing/2014/main" id="{F50E3CF7-9814-48D5-9A03-F4389A7D57DD}"/>
+                <a16:creationId xmlns:a16="http://schemas.microsoft.com/office/drawing/2014/main" id="{DEFB3AE3-67EA-47AE-B065-98AA466CB67C}"/>
               </a:ext>
             </a:extLst>
           </p:cNvPr>
@@ -12560,7 +12560,7 @@
           <p:cNvPr id="17" name="paper-v-2">
             <a:extLst xmlns:a="http://schemas.openxmlformats.org/drawingml/2006/main">
               <a:ext uri="{FF2B5EF4-FFF2-40B4-BE49-F238E27FC236}">
-                <a16:creationId xmlns:a16="http://schemas.microsoft.com/office/drawing/2014/main" id="{190A7723-DFBB-4753-9FE9-1E162698CE7A}"/>
+                <a16:creationId xmlns:a16="http://schemas.microsoft.com/office/drawing/2014/main" id="{2D8F8A85-E003-43F1-BD38-60CFD79AB6E9}"/>
               </a:ext>
             </a:extLst>
           </p:cNvPr>
@@ -12610,7 +12610,7 @@
           <p:cNvPr id="18" name="">
             <a:extLst xmlns:a="http://schemas.openxmlformats.org/drawingml/2006/main">
               <a:ext uri="{FF2B5EF4-FFF2-40B4-BE49-F238E27FC236}">
-                <a16:creationId xmlns:a16="http://schemas.microsoft.com/office/drawing/2014/main" id="{B1225BEF-6AC0-4589-8A08-5761BE4C2F87}"/>
+                <a16:creationId xmlns:a16="http://schemas.microsoft.com/office/drawing/2014/main" id="{32A5FA17-CF6D-4847-8930-EB8C075A6C1F}"/>
               </a:ext>
             </a:extLst>
           </p:cNvPr>
@@ -12641,7 +12641,7 @@
           <p:cNvPr id="19" name="paper-k-3">
             <a:extLst xmlns:a="http://schemas.openxmlformats.org/drawingml/2006/main">
               <a:ext uri="{FF2B5EF4-FFF2-40B4-BE49-F238E27FC236}">
-                <a16:creationId xmlns:a16="http://schemas.microsoft.com/office/drawing/2014/main" id="{E4AA910C-1384-4344-96A1-04ADFB40836C}"/>
+                <a16:creationId xmlns:a16="http://schemas.microsoft.com/office/drawing/2014/main" id="{4082D73F-D614-406D-A9FA-DB97B8F55047}"/>
               </a:ext>
             </a:extLst>
           </p:cNvPr>
@@ -12691,7 +12691,7 @@
           <p:cNvPr id="20" name="paper-v-3">
             <a:extLst xmlns:a="http://schemas.openxmlformats.org/drawingml/2006/main">
               <a:ext uri="{FF2B5EF4-FFF2-40B4-BE49-F238E27FC236}">
-                <a16:creationId xmlns:a16="http://schemas.microsoft.com/office/drawing/2014/main" id="{D8264B1B-4B80-41CF-9E5F-972CED1FDF46}"/>
+                <a16:creationId xmlns:a16="http://schemas.microsoft.com/office/drawing/2014/main" id="{C7A88290-65FE-4036-A6DC-5569BE039AB8}"/>
               </a:ext>
             </a:extLst>
           </p:cNvPr>
@@ -12739,7 +12739,7 @@
     </p:spTree>
     <p:extLst>
       <p:ext uri="{BB962C8B-B14F-4D97-AF65-F5344CB8AC3E}">
-        <p14:creationId xmlns:p14="http://schemas.microsoft.com/office/powerpoint/2010/main" val="1165520447"/>
+        <p14:creationId xmlns:p14="http://schemas.microsoft.com/office/powerpoint/2010/main" val="1665567531"/>
       </p:ext>
     </p:extLst>
   </p:cSld>
@@ -12770,7 +12770,7 @@
           <p:cNvPr id="40" name="rail-4">
             <a:extLst xmlns:a="http://schemas.openxmlformats.org/drawingml/2006/main">
               <a:ext uri="{FF2B5EF4-FFF2-40B4-BE49-F238E27FC236}">
-                <a16:creationId xmlns:a16="http://schemas.microsoft.com/office/drawing/2014/main" id="{FAB719B0-85F2-4363-8124-EF4D433F5CAC}"/>
+                <a16:creationId xmlns:a16="http://schemas.microsoft.com/office/drawing/2014/main" id="{E9E59F5F-0E45-4BE7-8C8C-DBFED9B8DD43}"/>
               </a:ext>
             </a:extLst>
           </p:cNvPr>
@@ -12803,7 +12803,7 @@
           <p:cNvPr id="2" name="flourish-4">
             <a:extLst xmlns:a="http://schemas.openxmlformats.org/drawingml/2006/main">
               <a:ext uri="{FF2B5EF4-FFF2-40B4-BE49-F238E27FC236}">
-                <a16:creationId xmlns:a16="http://schemas.microsoft.com/office/drawing/2014/main" id="{60463ABC-548E-4F09-9B89-8F51FCD3DD89}"/>
+                <a16:creationId xmlns:a16="http://schemas.microsoft.com/office/drawing/2014/main" id="{E100F91C-F930-4D46-AAD5-DA6C6949D88D}"/>
               </a:ext>
             </a:extLst>
           </p:cNvPr>
@@ -12853,7 +12853,7 @@
           <p:cNvPr id="3" name="chapter-4">
             <a:extLst xmlns:a="http://schemas.openxmlformats.org/drawingml/2006/main">
               <a:ext uri="{FF2B5EF4-FFF2-40B4-BE49-F238E27FC236}">
-                <a16:creationId xmlns:a16="http://schemas.microsoft.com/office/drawing/2014/main" id="{0B7E107C-D828-4592-91F1-B5A10D0E3764}"/>
+                <a16:creationId xmlns:a16="http://schemas.microsoft.com/office/drawing/2014/main" id="{B6E4666D-6F65-4403-B127-CE52B0F512A4}"/>
               </a:ext>
             </a:extLst>
           </p:cNvPr>
@@ -12903,7 +12903,7 @@
           <p:cNvPr id="4" name="title-4">
             <a:extLst xmlns:a="http://schemas.openxmlformats.org/drawingml/2006/main">
               <a:ext uri="{FF2B5EF4-FFF2-40B4-BE49-F238E27FC236}">
-                <a16:creationId xmlns:a16="http://schemas.microsoft.com/office/drawing/2014/main" id="{07B1BC35-DB75-4FCA-B2A1-23F2D81C393E}"/>
+                <a16:creationId xmlns:a16="http://schemas.microsoft.com/office/drawing/2014/main" id="{94DD244E-EEDA-4F38-B1CD-B663E6727A48}"/>
               </a:ext>
             </a:extLst>
           </p:cNvPr>
@@ -12953,7 +12953,7 @@
           <p:cNvPr id="5" name="subtitle-4">
             <a:extLst xmlns:a="http://schemas.openxmlformats.org/drawingml/2006/main">
               <a:ext uri="{FF2B5EF4-FFF2-40B4-BE49-F238E27FC236}">
-                <a16:creationId xmlns:a16="http://schemas.microsoft.com/office/drawing/2014/main" id="{AA639F36-EC26-45CA-815E-05D7CF18FBD8}"/>
+                <a16:creationId xmlns:a16="http://schemas.microsoft.com/office/drawing/2014/main" id="{2EAE2C5A-0D9F-43CB-B6C9-10671A40E0CF}"/>
               </a:ext>
             </a:extLst>
           </p:cNvPr>
@@ -13003,7 +13003,7 @@
           <p:cNvPr id="6" name="">
             <a:extLst xmlns:a="http://schemas.openxmlformats.org/drawingml/2006/main">
               <a:ext uri="{FF2B5EF4-FFF2-40B4-BE49-F238E27FC236}">
-                <a16:creationId xmlns:a16="http://schemas.microsoft.com/office/drawing/2014/main" id="{A0BBA86D-C373-47A7-A3C3-AC07D7DAA3E4}"/>
+                <a16:creationId xmlns:a16="http://schemas.microsoft.com/office/drawing/2014/main" id="{B890FB67-4A60-43A7-ABD1-2D71DD79D116}"/>
               </a:ext>
             </a:extLst>
           </p:cNvPr>
@@ -13034,7 +13034,7 @@
           <p:cNvPr id="7" name="page-4">
             <a:extLst xmlns:a="http://schemas.openxmlformats.org/drawingml/2006/main">
               <a:ext uri="{FF2B5EF4-FFF2-40B4-BE49-F238E27FC236}">
-                <a16:creationId xmlns:a16="http://schemas.microsoft.com/office/drawing/2014/main" id="{3402E95D-BA0D-4C28-A277-E1AB804B5C7E}"/>
+                <a16:creationId xmlns:a16="http://schemas.microsoft.com/office/drawing/2014/main" id="{FFE5E00D-211D-4393-9EF0-8F221A562DE8}"/>
               </a:ext>
             </a:extLst>
           </p:cNvPr>
@@ -13084,7 +13084,7 @@
           <p:cNvPr id="8" name="">
             <a:extLst xmlns:a="http://schemas.openxmlformats.org/drawingml/2006/main">
               <a:ext uri="{FF2B5EF4-FFF2-40B4-BE49-F238E27FC236}">
-                <a16:creationId xmlns:a16="http://schemas.microsoft.com/office/drawing/2014/main" id="{E6895FA1-FD8F-4ABF-9951-E030CF0B1809}"/>
+                <a16:creationId xmlns:a16="http://schemas.microsoft.com/office/drawing/2014/main" id="{4FC7625F-C935-4460-A146-D040245BF218}"/>
               </a:ext>
             </a:extLst>
           </p:cNvPr>
@@ -13115,7 +13115,7 @@
           <p:cNvPr id="9" name="">
             <a:extLst xmlns:a="http://schemas.openxmlformats.org/drawingml/2006/main">
               <a:ext uri="{FF2B5EF4-FFF2-40B4-BE49-F238E27FC236}">
-                <a16:creationId xmlns:a16="http://schemas.microsoft.com/office/drawing/2014/main" id="{89937483-2027-4B14-B0F1-FD893443E731}"/>
+                <a16:creationId xmlns:a16="http://schemas.microsoft.com/office/drawing/2014/main" id="{9C89CF2B-27E4-4C49-BCF1-83076BE8FD6C}"/>
               </a:ext>
             </a:extLst>
           </p:cNvPr>
@@ -13146,7 +13146,7 @@
           <p:cNvPr id="10" name="">
             <a:extLst xmlns:a="http://schemas.openxmlformats.org/drawingml/2006/main">
               <a:ext uri="{FF2B5EF4-FFF2-40B4-BE49-F238E27FC236}">
-                <a16:creationId xmlns:a16="http://schemas.microsoft.com/office/drawing/2014/main" id="{0C03178C-BFBF-432D-9B3B-43F352AFF7BD}"/>
+                <a16:creationId xmlns:a16="http://schemas.microsoft.com/office/drawing/2014/main" id="{9E3D1CBE-DEB3-4810-B82A-9051F95506FD}"/>
               </a:ext>
             </a:extLst>
           </p:cNvPr>
@@ -13177,7 +13177,7 @@
           <p:cNvPr id="11" name="">
             <a:extLst xmlns:a="http://schemas.openxmlformats.org/drawingml/2006/main">
               <a:ext uri="{FF2B5EF4-FFF2-40B4-BE49-F238E27FC236}">
-                <a16:creationId xmlns:a16="http://schemas.microsoft.com/office/drawing/2014/main" id="{90BC699F-0C80-4F25-AB5D-DC69D0806636}"/>
+                <a16:creationId xmlns:a16="http://schemas.microsoft.com/office/drawing/2014/main" id="{37681327-F996-41F1-B7A2-501B27ADA11F}"/>
               </a:ext>
             </a:extLst>
           </p:cNvPr>
@@ -13208,7 +13208,7 @@
           <p:cNvPr id="12" name="arch-0">
             <a:extLst xmlns:a="http://schemas.openxmlformats.org/drawingml/2006/main">
               <a:ext uri="{FF2B5EF4-FFF2-40B4-BE49-F238E27FC236}">
-                <a16:creationId xmlns:a16="http://schemas.microsoft.com/office/drawing/2014/main" id="{D3CA13E0-9865-4AEC-A9E8-DD744A27702F}"/>
+                <a16:creationId xmlns:a16="http://schemas.microsoft.com/office/drawing/2014/main" id="{6B82774A-535C-47B5-A0AD-E6EF2799A31D}"/>
               </a:ext>
             </a:extLst>
           </p:cNvPr>
@@ -13243,7 +13243,7 @@
           <p:cNvPr id="13" name="arch-k-0">
             <a:extLst xmlns:a="http://schemas.openxmlformats.org/drawingml/2006/main">
               <a:ext uri="{FF2B5EF4-FFF2-40B4-BE49-F238E27FC236}">
-                <a16:creationId xmlns:a16="http://schemas.microsoft.com/office/drawing/2014/main" id="{3FCFB56F-EA43-452D-87F7-631C47F784C6}"/>
+                <a16:creationId xmlns:a16="http://schemas.microsoft.com/office/drawing/2014/main" id="{8506D3DF-2224-488A-872D-1204D0DEF03B}"/>
               </a:ext>
             </a:extLst>
           </p:cNvPr>
@@ -13293,7 +13293,7 @@
           <p:cNvPr id="14" name="arch-v-0">
             <a:extLst xmlns:a="http://schemas.openxmlformats.org/drawingml/2006/main">
               <a:ext uri="{FF2B5EF4-FFF2-40B4-BE49-F238E27FC236}">
-                <a16:creationId xmlns:a16="http://schemas.microsoft.com/office/drawing/2014/main" id="{BBB7A0D7-58A8-490B-9CC1-23F6D5CB246F}"/>
+                <a16:creationId xmlns:a16="http://schemas.microsoft.com/office/drawing/2014/main" id="{01E06543-D5C1-455D-A945-1FA318E08B69}"/>
               </a:ext>
             </a:extLst>
           </p:cNvPr>
@@ -13343,7 +13343,7 @@
           <p:cNvPr id="15" name="arch-1">
             <a:extLst xmlns:a="http://schemas.openxmlformats.org/drawingml/2006/main">
               <a:ext uri="{FF2B5EF4-FFF2-40B4-BE49-F238E27FC236}">
-                <a16:creationId xmlns:a16="http://schemas.microsoft.com/office/drawing/2014/main" id="{FAD12B50-2D09-4C7C-A6CB-5BF72E3F6222}"/>
+                <a16:creationId xmlns:a16="http://schemas.microsoft.com/office/drawing/2014/main" id="{3D25D797-DE2C-45D0-AAB5-09C7910DA6E6}"/>
               </a:ext>
             </a:extLst>
           </p:cNvPr>
@@ -13378,7 +13378,7 @@
           <p:cNvPr id="16" name="arch-k-1">
             <a:extLst xmlns:a="http://schemas.openxmlformats.org/drawingml/2006/main">
               <a:ext uri="{FF2B5EF4-FFF2-40B4-BE49-F238E27FC236}">
-                <a16:creationId xmlns:a16="http://schemas.microsoft.com/office/drawing/2014/main" id="{9132A5E1-BB5A-4F9A-AB0B-6C33D4793F32}"/>
+                <a16:creationId xmlns:a16="http://schemas.microsoft.com/office/drawing/2014/main" id="{62AB2D31-E2AC-43D8-86F0-71A5D6751DED}"/>
               </a:ext>
             </a:extLst>
           </p:cNvPr>
@@ -13428,7 +13428,7 @@
           <p:cNvPr id="17" name="arch-v-1">
             <a:extLst xmlns:a="http://schemas.openxmlformats.org/drawingml/2006/main">
               <a:ext uri="{FF2B5EF4-FFF2-40B4-BE49-F238E27FC236}">
-                <a16:creationId xmlns:a16="http://schemas.microsoft.com/office/drawing/2014/main" id="{59626A19-12F3-4B9F-929D-603C5DE48CC5}"/>
+                <a16:creationId xmlns:a16="http://schemas.microsoft.com/office/drawing/2014/main" id="{56FFB859-E2C3-4E70-B6A9-F2C5AF5A48A9}"/>
               </a:ext>
             </a:extLst>
           </p:cNvPr>
@@ -13495,7 +13495,7 @@
           <p:cNvPr id="18" name="arch-2">
             <a:extLst xmlns:a="http://schemas.openxmlformats.org/drawingml/2006/main">
               <a:ext uri="{FF2B5EF4-FFF2-40B4-BE49-F238E27FC236}">
-                <a16:creationId xmlns:a16="http://schemas.microsoft.com/office/drawing/2014/main" id="{8624BF6A-0E77-4806-AF44-61C3366C4A26}"/>
+                <a16:creationId xmlns:a16="http://schemas.microsoft.com/office/drawing/2014/main" id="{EDBF17AB-ED54-4C6C-BA4F-FF805F1A6147}"/>
               </a:ext>
             </a:extLst>
           </p:cNvPr>
@@ -13530,7 +13530,7 @@
           <p:cNvPr id="19" name="arch-k-2">
             <a:extLst xmlns:a="http://schemas.openxmlformats.org/drawingml/2006/main">
               <a:ext uri="{FF2B5EF4-FFF2-40B4-BE49-F238E27FC236}">
-                <a16:creationId xmlns:a16="http://schemas.microsoft.com/office/drawing/2014/main" id="{785D45FB-1638-471F-B0CC-8394C2B7802B}"/>
+                <a16:creationId xmlns:a16="http://schemas.microsoft.com/office/drawing/2014/main" id="{CBD45942-0774-4215-BB63-3425EE1ED498}"/>
               </a:ext>
             </a:extLst>
           </p:cNvPr>
@@ -13580,7 +13580,7 @@
           <p:cNvPr id="20" name="arch-v-2">
             <a:extLst xmlns:a="http://schemas.openxmlformats.org/drawingml/2006/main">
               <a:ext uri="{FF2B5EF4-FFF2-40B4-BE49-F238E27FC236}">
-                <a16:creationId xmlns:a16="http://schemas.microsoft.com/office/drawing/2014/main" id="{C474FD7E-CC52-4D0E-BEC8-C5FCB1BD03BB}"/>
+                <a16:creationId xmlns:a16="http://schemas.microsoft.com/office/drawing/2014/main" id="{4D9A7B68-7528-40EF-94BE-4D9DEDE89325}"/>
               </a:ext>
             </a:extLst>
           </p:cNvPr>
@@ -13647,7 +13647,7 @@
           <p:cNvPr id="21" name="arch-3">
             <a:extLst xmlns:a="http://schemas.openxmlformats.org/drawingml/2006/main">
               <a:ext uri="{FF2B5EF4-FFF2-40B4-BE49-F238E27FC236}">
-                <a16:creationId xmlns:a16="http://schemas.microsoft.com/office/drawing/2014/main" id="{517E08CB-9B91-4A77-B7DE-F01566E7B80A}"/>
+                <a16:creationId xmlns:a16="http://schemas.microsoft.com/office/drawing/2014/main" id="{3AC05581-FFA3-4EDB-9686-25AA83E50B12}"/>
               </a:ext>
             </a:extLst>
           </p:cNvPr>
@@ -13682,7 +13682,7 @@
           <p:cNvPr id="22" name="arch-k-3">
             <a:extLst xmlns:a="http://schemas.openxmlformats.org/drawingml/2006/main">
               <a:ext uri="{FF2B5EF4-FFF2-40B4-BE49-F238E27FC236}">
-                <a16:creationId xmlns:a16="http://schemas.microsoft.com/office/drawing/2014/main" id="{2E9252F8-AAD8-4349-BD10-E80BE82A287B}"/>
+                <a16:creationId xmlns:a16="http://schemas.microsoft.com/office/drawing/2014/main" id="{0CF34868-33CD-4018-9E4F-C6A46A274FAE}"/>
               </a:ext>
             </a:extLst>
           </p:cNvPr>
@@ -13732,7 +13732,7 @@
           <p:cNvPr id="23" name="arch-v-3">
             <a:extLst xmlns:a="http://schemas.openxmlformats.org/drawingml/2006/main">
               <a:ext uri="{FF2B5EF4-FFF2-40B4-BE49-F238E27FC236}">
-                <a16:creationId xmlns:a16="http://schemas.microsoft.com/office/drawing/2014/main" id="{16230A77-0D4C-4CE0-A8EC-73E25E6245E0}"/>
+                <a16:creationId xmlns:a16="http://schemas.microsoft.com/office/drawing/2014/main" id="{CF5AC2D5-B0DB-4B40-8507-BA3CBBDAD9ED}"/>
               </a:ext>
             </a:extLst>
           </p:cNvPr>
@@ -13799,7 +13799,7 @@
           <p:cNvPr id="24" name="arch-4">
             <a:extLst xmlns:a="http://schemas.openxmlformats.org/drawingml/2006/main">
               <a:ext uri="{FF2B5EF4-FFF2-40B4-BE49-F238E27FC236}">
-                <a16:creationId xmlns:a16="http://schemas.microsoft.com/office/drawing/2014/main" id="{9AC39F44-B52E-44CD-A554-3398CE8F6F2B}"/>
+                <a16:creationId xmlns:a16="http://schemas.microsoft.com/office/drawing/2014/main" id="{C81B2248-D1B8-4002-B791-7FE0CEEC71C7}"/>
               </a:ext>
             </a:extLst>
           </p:cNvPr>
@@ -13834,7 +13834,7 @@
           <p:cNvPr id="25" name="arch-k-4">
             <a:extLst xmlns:a="http://schemas.openxmlformats.org/drawingml/2006/main">
               <a:ext uri="{FF2B5EF4-FFF2-40B4-BE49-F238E27FC236}">
-                <a16:creationId xmlns:a16="http://schemas.microsoft.com/office/drawing/2014/main" id="{576E9E7D-927A-4669-A74D-6C5DF765AF84}"/>
+                <a16:creationId xmlns:a16="http://schemas.microsoft.com/office/drawing/2014/main" id="{33D28780-A538-4B05-9299-CFDB7D36C250}"/>
               </a:ext>
             </a:extLst>
           </p:cNvPr>
@@ -13884,7 +13884,7 @@
           <p:cNvPr id="26" name="arch-v-4">
             <a:extLst xmlns:a="http://schemas.openxmlformats.org/drawingml/2006/main">
               <a:ext uri="{FF2B5EF4-FFF2-40B4-BE49-F238E27FC236}">
-                <a16:creationId xmlns:a16="http://schemas.microsoft.com/office/drawing/2014/main" id="{3C8944B6-4514-497B-A64A-52B1B10AA9F5}"/>
+                <a16:creationId xmlns:a16="http://schemas.microsoft.com/office/drawing/2014/main" id="{3F8CEBDA-6CE9-481F-BDB6-D86C7CD48433}"/>
               </a:ext>
             </a:extLst>
           </p:cNvPr>
@@ -13951,7 +13951,7 @@
           <p:cNvPr id="27" name="arch-loop">
             <a:extLst xmlns:a="http://schemas.openxmlformats.org/drawingml/2006/main">
               <a:ext uri="{FF2B5EF4-FFF2-40B4-BE49-F238E27FC236}">
-                <a16:creationId xmlns:a16="http://schemas.microsoft.com/office/drawing/2014/main" id="{FB9F1A31-55D0-4BC3-9295-81B3FD23A254}"/>
+                <a16:creationId xmlns:a16="http://schemas.microsoft.com/office/drawing/2014/main" id="{EED8A4B3-6FA2-448B-9642-A3B9C659725B}"/>
               </a:ext>
             </a:extLst>
           </p:cNvPr>
@@ -14001,7 +14001,7 @@
           <p:cNvPr id="28" name="">
             <a:extLst xmlns:a="http://schemas.openxmlformats.org/drawingml/2006/main">
               <a:ext uri="{FF2B5EF4-FFF2-40B4-BE49-F238E27FC236}">
-                <a16:creationId xmlns:a16="http://schemas.microsoft.com/office/drawing/2014/main" id="{301F6B2D-F5D4-43B7-8681-463C4874B519}"/>
+                <a16:creationId xmlns:a16="http://schemas.microsoft.com/office/drawing/2014/main" id="{5531A032-E084-4AA9-8F0D-F203E558267A}"/>
               </a:ext>
             </a:extLst>
           </p:cNvPr>
@@ -14032,7 +14032,7 @@
           <p:cNvPr id="29" name="arch-tools-value">
             <a:extLst xmlns:a="http://schemas.openxmlformats.org/drawingml/2006/main">
               <a:ext uri="{FF2B5EF4-FFF2-40B4-BE49-F238E27FC236}">
-                <a16:creationId xmlns:a16="http://schemas.microsoft.com/office/drawing/2014/main" id="{152113FD-B70B-4EE6-8895-77F9336D895B}"/>
+                <a16:creationId xmlns:a16="http://schemas.microsoft.com/office/drawing/2014/main" id="{A2009986-9B25-4C5D-AC9B-ED5A6D0CF27E}"/>
               </a:ext>
             </a:extLst>
           </p:cNvPr>
@@ -14082,7 +14082,7 @@
           <p:cNvPr id="30" name="arch-tools-label">
             <a:extLst xmlns:a="http://schemas.openxmlformats.org/drawingml/2006/main">
               <a:ext uri="{FF2B5EF4-FFF2-40B4-BE49-F238E27FC236}">
-                <a16:creationId xmlns:a16="http://schemas.microsoft.com/office/drawing/2014/main" id="{16117018-2EF4-49BC-8688-D53D0A28E536}"/>
+                <a16:creationId xmlns:a16="http://schemas.microsoft.com/office/drawing/2014/main" id="{63B7DE04-36D8-4A16-A212-F74EE3F9455A}"/>
               </a:ext>
             </a:extLst>
           </p:cNvPr>
@@ -14132,7 +14132,7 @@
           <p:cNvPr id="31" name="">
             <a:extLst xmlns:a="http://schemas.openxmlformats.org/drawingml/2006/main">
               <a:ext uri="{FF2B5EF4-FFF2-40B4-BE49-F238E27FC236}">
-                <a16:creationId xmlns:a16="http://schemas.microsoft.com/office/drawing/2014/main" id="{25C91793-514F-405C-BF99-5A4C5F64E83F}"/>
+                <a16:creationId xmlns:a16="http://schemas.microsoft.com/office/drawing/2014/main" id="{C1D23482-56AB-4513-A466-D52E23BDCA9C}"/>
               </a:ext>
             </a:extLst>
           </p:cNvPr>
@@ -14163,7 +14163,7 @@
           <p:cNvPr id="32" name="arch-group-value">
             <a:extLst xmlns:a="http://schemas.openxmlformats.org/drawingml/2006/main">
               <a:ext uri="{FF2B5EF4-FFF2-40B4-BE49-F238E27FC236}">
-                <a16:creationId xmlns:a16="http://schemas.microsoft.com/office/drawing/2014/main" id="{B3FAD89E-BDDA-4BF7-9BB9-26861AA0DC10}"/>
+                <a16:creationId xmlns:a16="http://schemas.microsoft.com/office/drawing/2014/main" id="{CC93E92A-E5DF-4712-814E-C5D11B583780}"/>
               </a:ext>
             </a:extLst>
           </p:cNvPr>
@@ -14213,7 +14213,7 @@
           <p:cNvPr id="33" name="arch-group-label">
             <a:extLst xmlns:a="http://schemas.openxmlformats.org/drawingml/2006/main">
               <a:ext uri="{FF2B5EF4-FFF2-40B4-BE49-F238E27FC236}">
-                <a16:creationId xmlns:a16="http://schemas.microsoft.com/office/drawing/2014/main" id="{518AB7B6-A619-4926-B9F7-1D34B12AB560}"/>
+                <a16:creationId xmlns:a16="http://schemas.microsoft.com/office/drawing/2014/main" id="{7B8EEB50-A202-497E-AFE9-2E5D267FD0C2}"/>
               </a:ext>
             </a:extLst>
           </p:cNvPr>
@@ -14263,7 +14263,7 @@
           <p:cNvPr id="34" name="">
             <a:extLst xmlns:a="http://schemas.openxmlformats.org/drawingml/2006/main">
               <a:ext uri="{FF2B5EF4-FFF2-40B4-BE49-F238E27FC236}">
-                <a16:creationId xmlns:a16="http://schemas.microsoft.com/office/drawing/2014/main" id="{A2473A35-E148-4D3A-83FD-5D1BA9031450}"/>
+                <a16:creationId xmlns:a16="http://schemas.microsoft.com/office/drawing/2014/main" id="{FA5540FC-FE8F-480B-8E26-9A4F2056FBD8}"/>
               </a:ext>
             </a:extLst>
           </p:cNvPr>
@@ -14294,7 +14294,7 @@
           <p:cNvPr id="35" name="arch-max-value">
             <a:extLst xmlns:a="http://schemas.openxmlformats.org/drawingml/2006/main">
               <a:ext uri="{FF2B5EF4-FFF2-40B4-BE49-F238E27FC236}">
-                <a16:creationId xmlns:a16="http://schemas.microsoft.com/office/drawing/2014/main" id="{B81FD465-2588-468D-860B-E6232836F653}"/>
+                <a16:creationId xmlns:a16="http://schemas.microsoft.com/office/drawing/2014/main" id="{768E1B46-B243-47A0-A2E6-D3297554367D}"/>
               </a:ext>
             </a:extLst>
           </p:cNvPr>
@@ -14344,7 +14344,7 @@
           <p:cNvPr id="36" name="arch-max-label">
             <a:extLst xmlns:a="http://schemas.openxmlformats.org/drawingml/2006/main">
               <a:ext uri="{FF2B5EF4-FFF2-40B4-BE49-F238E27FC236}">
-                <a16:creationId xmlns:a16="http://schemas.microsoft.com/office/drawing/2014/main" id="{D6365DC1-2AC2-4647-8154-E32235075A18}"/>
+                <a16:creationId xmlns:a16="http://schemas.microsoft.com/office/drawing/2014/main" id="{23982825-558B-4716-94BA-13E91509F7B6}"/>
               </a:ext>
             </a:extLst>
           </p:cNvPr>
@@ -14394,7 +14394,7 @@
           <p:cNvPr id="37" name="">
             <a:extLst xmlns:a="http://schemas.openxmlformats.org/drawingml/2006/main">
               <a:ext uri="{FF2B5EF4-FFF2-40B4-BE49-F238E27FC236}">
-                <a16:creationId xmlns:a16="http://schemas.microsoft.com/office/drawing/2014/main" id="{CBD4A62C-9A56-4049-ACCD-5CCF63B39A6C}"/>
+                <a16:creationId xmlns:a16="http://schemas.microsoft.com/office/drawing/2014/main" id="{629DD5E3-DF64-4181-9F5B-27262414CB6C}"/>
               </a:ext>
             </a:extLst>
           </p:cNvPr>
@@ -14425,7 +14425,7 @@
           <p:cNvPr id="38" name="arch-token-value">
             <a:extLst xmlns:a="http://schemas.openxmlformats.org/drawingml/2006/main">
               <a:ext uri="{FF2B5EF4-FFF2-40B4-BE49-F238E27FC236}">
-                <a16:creationId xmlns:a16="http://schemas.microsoft.com/office/drawing/2014/main" id="{4F969F96-6DA3-4E18-B6B2-50D0B6B54B15}"/>
+                <a16:creationId xmlns:a16="http://schemas.microsoft.com/office/drawing/2014/main" id="{54372F1D-819E-4158-943F-ED70DDED5DA7}"/>
               </a:ext>
             </a:extLst>
           </p:cNvPr>
@@ -14475,7 +14475,7 @@
           <p:cNvPr id="39" name="arch-token-label">
             <a:extLst xmlns:a="http://schemas.openxmlformats.org/drawingml/2006/main">
               <a:ext uri="{FF2B5EF4-FFF2-40B4-BE49-F238E27FC236}">
-                <a16:creationId xmlns:a16="http://schemas.microsoft.com/office/drawing/2014/main" id="{6FFE486E-FAEB-400D-B1ED-C55CA4688AB4}"/>
+                <a16:creationId xmlns:a16="http://schemas.microsoft.com/office/drawing/2014/main" id="{FCA33248-8CFE-49D8-A5AA-1179C14F9472}"/>
               </a:ext>
             </a:extLst>
           </p:cNvPr>
@@ -14523,7 +14523,7 @@
     </p:spTree>
     <p:extLst>
       <p:ext uri="{BB962C8B-B14F-4D97-AF65-F5344CB8AC3E}">
-        <p14:creationId xmlns:p14="http://schemas.microsoft.com/office/powerpoint/2010/main" val="1010553513"/>
+        <p14:creationId xmlns:p14="http://schemas.microsoft.com/office/powerpoint/2010/main" val="1231843830"/>
       </p:ext>
     </p:extLst>
   </p:cSld>
@@ -14554,7 +14554,7 @@
           <p:cNvPr id="37" name="rail-5">
             <a:extLst xmlns:a="http://schemas.openxmlformats.org/drawingml/2006/main">
               <a:ext uri="{FF2B5EF4-FFF2-40B4-BE49-F238E27FC236}">
-                <a16:creationId xmlns:a16="http://schemas.microsoft.com/office/drawing/2014/main" id="{2094FDDC-AAA4-47E5-AA9C-B0ECD0CAEC4C}"/>
+                <a16:creationId xmlns:a16="http://schemas.microsoft.com/office/drawing/2014/main" id="{4D02E208-639D-4EB9-A9A6-9B4883214922}"/>
               </a:ext>
             </a:extLst>
           </p:cNvPr>
@@ -14587,7 +14587,7 @@
           <p:cNvPr id="2" name="flourish-5">
             <a:extLst xmlns:a="http://schemas.openxmlformats.org/drawingml/2006/main">
               <a:ext uri="{FF2B5EF4-FFF2-40B4-BE49-F238E27FC236}">
-                <a16:creationId xmlns:a16="http://schemas.microsoft.com/office/drawing/2014/main" id="{92B4759B-5F80-4968-8CCA-1B755213B8B5}"/>
+                <a16:creationId xmlns:a16="http://schemas.microsoft.com/office/drawing/2014/main" id="{F2353754-F881-47AB-A0AC-96DEC7869F33}"/>
               </a:ext>
             </a:extLst>
           </p:cNvPr>
@@ -14637,7 +14637,7 @@
           <p:cNvPr id="3" name="chapter-5">
             <a:extLst xmlns:a="http://schemas.openxmlformats.org/drawingml/2006/main">
               <a:ext uri="{FF2B5EF4-FFF2-40B4-BE49-F238E27FC236}">
-                <a16:creationId xmlns:a16="http://schemas.microsoft.com/office/drawing/2014/main" id="{EEF9D07C-491E-4BF3-B606-C03B887DAE73}"/>
+                <a16:creationId xmlns:a16="http://schemas.microsoft.com/office/drawing/2014/main" id="{FA030FF4-79F5-4BB5-B907-8389BC2B0E48}"/>
               </a:ext>
             </a:extLst>
           </p:cNvPr>
@@ -14687,7 +14687,7 @@
           <p:cNvPr id="4" name="title-5">
             <a:extLst xmlns:a="http://schemas.openxmlformats.org/drawingml/2006/main">
               <a:ext uri="{FF2B5EF4-FFF2-40B4-BE49-F238E27FC236}">
-                <a16:creationId xmlns:a16="http://schemas.microsoft.com/office/drawing/2014/main" id="{6318FABC-6A1C-4344-8B37-212409B23FBC}"/>
+                <a16:creationId xmlns:a16="http://schemas.microsoft.com/office/drawing/2014/main" id="{5D7A8EB1-B63D-4A1F-91CF-C8071081ECBA}"/>
               </a:ext>
             </a:extLst>
           </p:cNvPr>
@@ -14737,7 +14737,7 @@
           <p:cNvPr id="5" name="subtitle-5">
             <a:extLst xmlns:a="http://schemas.openxmlformats.org/drawingml/2006/main">
               <a:ext uri="{FF2B5EF4-FFF2-40B4-BE49-F238E27FC236}">
-                <a16:creationId xmlns:a16="http://schemas.microsoft.com/office/drawing/2014/main" id="{8BF47AD2-4F5F-4543-9929-0B5420F087E8}"/>
+                <a16:creationId xmlns:a16="http://schemas.microsoft.com/office/drawing/2014/main" id="{84CDB97D-1EEF-4269-BF23-E5CE6332F888}"/>
               </a:ext>
             </a:extLst>
           </p:cNvPr>
@@ -14787,7 +14787,7 @@
           <p:cNvPr id="6" name="">
             <a:extLst xmlns:a="http://schemas.openxmlformats.org/drawingml/2006/main">
               <a:ext uri="{FF2B5EF4-FFF2-40B4-BE49-F238E27FC236}">
-                <a16:creationId xmlns:a16="http://schemas.microsoft.com/office/drawing/2014/main" id="{1DE34055-5F6E-4C1B-8761-D72185A4B7A5}"/>
+                <a16:creationId xmlns:a16="http://schemas.microsoft.com/office/drawing/2014/main" id="{891CB09B-4EFC-49F6-A7F3-672265C0188A}"/>
               </a:ext>
             </a:extLst>
           </p:cNvPr>
@@ -14818,7 +14818,7 @@
           <p:cNvPr id="7" name="page-5">
             <a:extLst xmlns:a="http://schemas.openxmlformats.org/drawingml/2006/main">
               <a:ext uri="{FF2B5EF4-FFF2-40B4-BE49-F238E27FC236}">
-                <a16:creationId xmlns:a16="http://schemas.microsoft.com/office/drawing/2014/main" id="{BEE0012E-30D1-4B0D-9EE4-88A618889E24}"/>
+                <a16:creationId xmlns:a16="http://schemas.microsoft.com/office/drawing/2014/main" id="{55AC8BE0-6B44-4E17-96E3-18F760572E54}"/>
               </a:ext>
             </a:extLst>
           </p:cNvPr>
@@ -14868,7 +14868,7 @@
           <p:cNvPr id="8" name="">
             <a:extLst xmlns:a="http://schemas.openxmlformats.org/drawingml/2006/main">
               <a:ext uri="{FF2B5EF4-FFF2-40B4-BE49-F238E27FC236}">
-                <a16:creationId xmlns:a16="http://schemas.microsoft.com/office/drawing/2014/main" id="{CD114763-4CDA-452F-9DD6-95F53A4C442D}"/>
+                <a16:creationId xmlns:a16="http://schemas.microsoft.com/office/drawing/2014/main" id="{A2A16F02-99B1-4B0B-94CF-366A8DB25C34}"/>
               </a:ext>
             </a:extLst>
           </p:cNvPr>
@@ -14899,7 +14899,7 @@
           <p:cNvPr id="9" name="">
             <a:extLst xmlns:a="http://schemas.openxmlformats.org/drawingml/2006/main">
               <a:ext uri="{FF2B5EF4-FFF2-40B4-BE49-F238E27FC236}">
-                <a16:creationId xmlns:a16="http://schemas.microsoft.com/office/drawing/2014/main" id="{D7F7B5F8-3741-4DDB-B979-E8812A5FFD67}"/>
+                <a16:creationId xmlns:a16="http://schemas.microsoft.com/office/drawing/2014/main" id="{B3887594-90AE-44B1-92D3-801C40E65475}"/>
               </a:ext>
             </a:extLst>
           </p:cNvPr>
@@ -14930,7 +14930,7 @@
           <p:cNvPr id="10" name="">
             <a:extLst xmlns:a="http://schemas.openxmlformats.org/drawingml/2006/main">
               <a:ext uri="{FF2B5EF4-FFF2-40B4-BE49-F238E27FC236}">
-                <a16:creationId xmlns:a16="http://schemas.microsoft.com/office/drawing/2014/main" id="{4AD6FA10-DD06-4836-A947-62D8DC6B53AB}"/>
+                <a16:creationId xmlns:a16="http://schemas.microsoft.com/office/drawing/2014/main" id="{E0FB6290-A3C9-4FB6-9B1A-714B75C70950}"/>
               </a:ext>
             </a:extLst>
           </p:cNvPr>
@@ -14961,7 +14961,7 @@
           <p:cNvPr id="11" name="">
             <a:extLst xmlns:a="http://schemas.openxmlformats.org/drawingml/2006/main">
               <a:ext uri="{FF2B5EF4-FFF2-40B4-BE49-F238E27FC236}">
-                <a16:creationId xmlns:a16="http://schemas.microsoft.com/office/drawing/2014/main" id="{75283312-8757-46F4-BA77-243C6DC482B7}"/>
+                <a16:creationId xmlns:a16="http://schemas.microsoft.com/office/drawing/2014/main" id="{C68A739E-27AE-44B8-95EC-7869D2337CA1}"/>
               </a:ext>
             </a:extLst>
           </p:cNvPr>
@@ -14992,7 +14992,7 @@
           <p:cNvPr id="12" name="">
             <a:extLst xmlns:a="http://schemas.openxmlformats.org/drawingml/2006/main">
               <a:ext uri="{FF2B5EF4-FFF2-40B4-BE49-F238E27FC236}">
-                <a16:creationId xmlns:a16="http://schemas.microsoft.com/office/drawing/2014/main" id="{1FFE53E2-D4C5-4633-A716-24021DFCEF21}"/>
+                <a16:creationId xmlns:a16="http://schemas.microsoft.com/office/drawing/2014/main" id="{2189E8CD-D7D2-4392-8093-81B3C0A38010}"/>
               </a:ext>
             </a:extLst>
           </p:cNvPr>
@@ -15023,7 +15023,7 @@
           <p:cNvPr id="13" name="">
             <a:extLst xmlns:a="http://schemas.openxmlformats.org/drawingml/2006/main">
               <a:ext uri="{FF2B5EF4-FFF2-40B4-BE49-F238E27FC236}">
-                <a16:creationId xmlns:a16="http://schemas.microsoft.com/office/drawing/2014/main" id="{02DB93A0-A673-4E0F-A7BC-045D27C30511}"/>
+                <a16:creationId xmlns:a16="http://schemas.microsoft.com/office/drawing/2014/main" id="{D04BCE65-BCD2-46CC-BC5A-329EAA89D772}"/>
               </a:ext>
             </a:extLst>
           </p:cNvPr>
@@ -15054,7 +15054,7 @@
           <p:cNvPr id="14" name="state-dot-0">
             <a:extLst xmlns:a="http://schemas.openxmlformats.org/drawingml/2006/main">
               <a:ext uri="{FF2B5EF4-FFF2-40B4-BE49-F238E27FC236}">
-                <a16:creationId xmlns:a16="http://schemas.microsoft.com/office/drawing/2014/main" id="{63FC8175-AC6E-477F-8202-088632D60EDA}"/>
+                <a16:creationId xmlns:a16="http://schemas.microsoft.com/office/drawing/2014/main" id="{CE126283-A038-4F5C-B750-B3F841610A25}"/>
               </a:ext>
             </a:extLst>
           </p:cNvPr>
@@ -15089,7 +15089,7 @@
           <p:cNvPr id="15" name="state-n-0">
             <a:extLst xmlns:a="http://schemas.openxmlformats.org/drawingml/2006/main">
               <a:ext uri="{FF2B5EF4-FFF2-40B4-BE49-F238E27FC236}">
-                <a16:creationId xmlns:a16="http://schemas.microsoft.com/office/drawing/2014/main" id="{4803034F-FB45-4B2C-9BAB-6435ECC583A3}"/>
+                <a16:creationId xmlns:a16="http://schemas.microsoft.com/office/drawing/2014/main" id="{6B5225F3-1B5E-45CC-8BCC-6955F96A661D}"/>
               </a:ext>
             </a:extLst>
           </p:cNvPr>
@@ -15139,7 +15139,7 @@
           <p:cNvPr id="16" name="state-label-0">
             <a:extLst xmlns:a="http://schemas.openxmlformats.org/drawingml/2006/main">
               <a:ext uri="{FF2B5EF4-FFF2-40B4-BE49-F238E27FC236}">
-                <a16:creationId xmlns:a16="http://schemas.microsoft.com/office/drawing/2014/main" id="{3E606BDC-D9A4-47A8-823D-E4D3F5CEDF67}"/>
+                <a16:creationId xmlns:a16="http://schemas.microsoft.com/office/drawing/2014/main" id="{F9B6568D-D529-4C96-A71A-F6CD6E6A9587}"/>
               </a:ext>
             </a:extLst>
           </p:cNvPr>
@@ -15189,7 +15189,7 @@
           <p:cNvPr id="17" name="state-dot-1">
             <a:extLst xmlns:a="http://schemas.openxmlformats.org/drawingml/2006/main">
               <a:ext uri="{FF2B5EF4-FFF2-40B4-BE49-F238E27FC236}">
-                <a16:creationId xmlns:a16="http://schemas.microsoft.com/office/drawing/2014/main" id="{65E02B2A-0990-4240-8DFB-AB0A5E663671}"/>
+                <a16:creationId xmlns:a16="http://schemas.microsoft.com/office/drawing/2014/main" id="{EDF8E3D6-833A-40D4-A01A-BD8F8F5E470D}"/>
               </a:ext>
             </a:extLst>
           </p:cNvPr>
@@ -15224,7 +15224,7 @@
           <p:cNvPr id="18" name="state-n-1">
             <a:extLst xmlns:a="http://schemas.openxmlformats.org/drawingml/2006/main">
               <a:ext uri="{FF2B5EF4-FFF2-40B4-BE49-F238E27FC236}">
-                <a16:creationId xmlns:a16="http://schemas.microsoft.com/office/drawing/2014/main" id="{01E9B9D5-D340-43C3-BC2A-DC1159189C2B}"/>
+                <a16:creationId xmlns:a16="http://schemas.microsoft.com/office/drawing/2014/main" id="{FD5DA091-6BBD-4E1B-BE7B-BC3DEEA59F39}"/>
               </a:ext>
             </a:extLst>
           </p:cNvPr>
@@ -15274,7 +15274,7 @@
           <p:cNvPr id="19" name="state-label-1">
             <a:extLst xmlns:a="http://schemas.openxmlformats.org/drawingml/2006/main">
               <a:ext uri="{FF2B5EF4-FFF2-40B4-BE49-F238E27FC236}">
-                <a16:creationId xmlns:a16="http://schemas.microsoft.com/office/drawing/2014/main" id="{4D1DC6F7-F8D4-476F-80FC-D4484394E193}"/>
+                <a16:creationId xmlns:a16="http://schemas.microsoft.com/office/drawing/2014/main" id="{B2847533-1222-47D3-9499-585B09D71A23}"/>
               </a:ext>
             </a:extLst>
           </p:cNvPr>
@@ -15324,7 +15324,7 @@
           <p:cNvPr id="20" name="state-dot-2">
             <a:extLst xmlns:a="http://schemas.openxmlformats.org/drawingml/2006/main">
               <a:ext uri="{FF2B5EF4-FFF2-40B4-BE49-F238E27FC236}">
-                <a16:creationId xmlns:a16="http://schemas.microsoft.com/office/drawing/2014/main" id="{49C319CF-CB45-46B2-8E1A-407901661917}"/>
+                <a16:creationId xmlns:a16="http://schemas.microsoft.com/office/drawing/2014/main" id="{3FF6BB2A-22C6-4724-A624-82A01E2183E6}"/>
               </a:ext>
             </a:extLst>
           </p:cNvPr>
@@ -15359,7 +15359,7 @@
           <p:cNvPr id="21" name="state-n-2">
             <a:extLst xmlns:a="http://schemas.openxmlformats.org/drawingml/2006/main">
               <a:ext uri="{FF2B5EF4-FFF2-40B4-BE49-F238E27FC236}">
-                <a16:creationId xmlns:a16="http://schemas.microsoft.com/office/drawing/2014/main" id="{CB40BA31-4081-4E3C-A939-31C3F84A9ABD}"/>
+                <a16:creationId xmlns:a16="http://schemas.microsoft.com/office/drawing/2014/main" id="{00561299-3D92-453C-A8DE-CE70354DF6FE}"/>
               </a:ext>
             </a:extLst>
           </p:cNvPr>
@@ -15409,7 +15409,7 @@
           <p:cNvPr id="22" name="state-label-2">
             <a:extLst xmlns:a="http://schemas.openxmlformats.org/drawingml/2006/main">
               <a:ext uri="{FF2B5EF4-FFF2-40B4-BE49-F238E27FC236}">
-                <a16:creationId xmlns:a16="http://schemas.microsoft.com/office/drawing/2014/main" id="{EBFD0874-7CAC-4D93-BBD8-7685CDA3D84A}"/>
+                <a16:creationId xmlns:a16="http://schemas.microsoft.com/office/drawing/2014/main" id="{71F18C0F-81CB-440D-A8B5-1FA64515E07D}"/>
               </a:ext>
             </a:extLst>
           </p:cNvPr>
@@ -15459,7 +15459,7 @@
           <p:cNvPr id="23" name="state-dot-3">
             <a:extLst xmlns:a="http://schemas.openxmlformats.org/drawingml/2006/main">
               <a:ext uri="{FF2B5EF4-FFF2-40B4-BE49-F238E27FC236}">
-                <a16:creationId xmlns:a16="http://schemas.microsoft.com/office/drawing/2014/main" id="{902258E9-08A3-42ED-AA98-DEB8445D7E4C}"/>
+                <a16:creationId xmlns:a16="http://schemas.microsoft.com/office/drawing/2014/main" id="{6163BDD7-CC95-489A-8A0E-4FC640B725A5}"/>
               </a:ext>
             </a:extLst>
           </p:cNvPr>
@@ -15494,7 +15494,7 @@
           <p:cNvPr id="24" name="state-n-3">
             <a:extLst xmlns:a="http://schemas.openxmlformats.org/drawingml/2006/main">
               <a:ext uri="{FF2B5EF4-FFF2-40B4-BE49-F238E27FC236}">
-                <a16:creationId xmlns:a16="http://schemas.microsoft.com/office/drawing/2014/main" id="{C5048FC5-93F9-4F24-B1BF-20E2E23FA753}"/>
+                <a16:creationId xmlns:a16="http://schemas.microsoft.com/office/drawing/2014/main" id="{92B03E2B-A0B1-497A-B23C-98398D8CC237}"/>
               </a:ext>
             </a:extLst>
           </p:cNvPr>
@@ -15544,7 +15544,7 @@
           <p:cNvPr id="25" name="state-label-3">
             <a:extLst xmlns:a="http://schemas.openxmlformats.org/drawingml/2006/main">
               <a:ext uri="{FF2B5EF4-FFF2-40B4-BE49-F238E27FC236}">
-                <a16:creationId xmlns:a16="http://schemas.microsoft.com/office/drawing/2014/main" id="{725195B2-EE46-4753-B1B5-AAAD69DF6273}"/>
+                <a16:creationId xmlns:a16="http://schemas.microsoft.com/office/drawing/2014/main" id="{38050D48-9E5C-497C-A141-99251682AD4B}"/>
               </a:ext>
             </a:extLst>
           </p:cNvPr>
@@ -15594,7 +15594,7 @@
           <p:cNvPr id="26" name="state-dot-4">
             <a:extLst xmlns:a="http://schemas.openxmlformats.org/drawingml/2006/main">
               <a:ext uri="{FF2B5EF4-FFF2-40B4-BE49-F238E27FC236}">
-                <a16:creationId xmlns:a16="http://schemas.microsoft.com/office/drawing/2014/main" id="{D277972F-F15F-4CE6-9C79-EC24766612DD}"/>
+                <a16:creationId xmlns:a16="http://schemas.microsoft.com/office/drawing/2014/main" id="{C6BC4F10-64D4-4094-9237-0AB858269E11}"/>
               </a:ext>
             </a:extLst>
           </p:cNvPr>
@@ -15629,7 +15629,7 @@
           <p:cNvPr id="27" name="state-n-4">
             <a:extLst xmlns:a="http://schemas.openxmlformats.org/drawingml/2006/main">
               <a:ext uri="{FF2B5EF4-FFF2-40B4-BE49-F238E27FC236}">
-                <a16:creationId xmlns:a16="http://schemas.microsoft.com/office/drawing/2014/main" id="{AD7CAD2B-D6F7-4667-B082-60E72EF63C4C}"/>
+                <a16:creationId xmlns:a16="http://schemas.microsoft.com/office/drawing/2014/main" id="{6CF8985C-C8DA-48D2-B5E7-DF66F6675597}"/>
               </a:ext>
             </a:extLst>
           </p:cNvPr>
@@ -15679,7 +15679,7 @@
           <p:cNvPr id="28" name="state-label-4">
             <a:extLst xmlns:a="http://schemas.openxmlformats.org/drawingml/2006/main">
               <a:ext uri="{FF2B5EF4-FFF2-40B4-BE49-F238E27FC236}">
-                <a16:creationId xmlns:a16="http://schemas.microsoft.com/office/drawing/2014/main" id="{8FF3D2A7-8503-4E36-88CC-B99C9A87F3B4}"/>
+                <a16:creationId xmlns:a16="http://schemas.microsoft.com/office/drawing/2014/main" id="{61155C8F-82B1-4D21-866A-38001EDCBAE4}"/>
               </a:ext>
             </a:extLst>
           </p:cNvPr>
@@ -15729,7 +15729,7 @@
           <p:cNvPr id="29" name="state-dot-5">
             <a:extLst xmlns:a="http://schemas.openxmlformats.org/drawingml/2006/main">
               <a:ext uri="{FF2B5EF4-FFF2-40B4-BE49-F238E27FC236}">
-                <a16:creationId xmlns:a16="http://schemas.microsoft.com/office/drawing/2014/main" id="{3683D5CF-8C69-4ABB-9435-C87CA6B0546B}"/>
+                <a16:creationId xmlns:a16="http://schemas.microsoft.com/office/drawing/2014/main" id="{0418815E-8169-4B65-B417-ED02D21E5BD2}"/>
               </a:ext>
             </a:extLst>
           </p:cNvPr>
@@ -15764,7 +15764,7 @@
           <p:cNvPr id="30" name="state-n-5">
             <a:extLst xmlns:a="http://schemas.openxmlformats.org/drawingml/2006/main">
               <a:ext uri="{FF2B5EF4-FFF2-40B4-BE49-F238E27FC236}">
-                <a16:creationId xmlns:a16="http://schemas.microsoft.com/office/drawing/2014/main" id="{4F7D6F6D-0472-455D-B1DB-0A234EAB9045}"/>
+                <a16:creationId xmlns:a16="http://schemas.microsoft.com/office/drawing/2014/main" id="{9AD7CBB8-9FCC-4018-8BB9-0E2F27A09F2B}"/>
               </a:ext>
             </a:extLst>
           </p:cNvPr>
@@ -15814,7 +15814,7 @@
           <p:cNvPr id="31" name="state-label-5">
             <a:extLst xmlns:a="http://schemas.openxmlformats.org/drawingml/2006/main">
               <a:ext uri="{FF2B5EF4-FFF2-40B4-BE49-F238E27FC236}">
-                <a16:creationId xmlns:a16="http://schemas.microsoft.com/office/drawing/2014/main" id="{7C1E89E9-A1B1-41C5-88D0-EFB0385D905C}"/>
+                <a16:creationId xmlns:a16="http://schemas.microsoft.com/office/drawing/2014/main" id="{1962910B-74D6-4E88-BEAE-E9933AC4CB04}"/>
               </a:ext>
             </a:extLst>
           </p:cNvPr>
@@ -15864,7 +15864,7 @@
           <p:cNvPr id="32" name="state-dot-6">
             <a:extLst xmlns:a="http://schemas.openxmlformats.org/drawingml/2006/main">
               <a:ext uri="{FF2B5EF4-FFF2-40B4-BE49-F238E27FC236}">
-                <a16:creationId xmlns:a16="http://schemas.microsoft.com/office/drawing/2014/main" id="{DB41665F-CA63-4CBB-BE66-EE84DE46FC97}"/>
+                <a16:creationId xmlns:a16="http://schemas.microsoft.com/office/drawing/2014/main" id="{CA094696-3592-4E4E-AA18-34B480CEB8E2}"/>
               </a:ext>
             </a:extLst>
           </p:cNvPr>
@@ -15899,7 +15899,7 @@
           <p:cNvPr id="33" name="state-n-6">
             <a:extLst xmlns:a="http://schemas.openxmlformats.org/drawingml/2006/main">
               <a:ext uri="{FF2B5EF4-FFF2-40B4-BE49-F238E27FC236}">
-                <a16:creationId xmlns:a16="http://schemas.microsoft.com/office/drawing/2014/main" id="{A4CBD019-A44E-4471-B0DF-B04ACA0844D3}"/>
+                <a16:creationId xmlns:a16="http://schemas.microsoft.com/office/drawing/2014/main" id="{4E89DB94-6029-4810-9123-9116E62307C5}"/>
               </a:ext>
             </a:extLst>
           </p:cNvPr>
@@ -15949,7 +15949,7 @@
           <p:cNvPr id="34" name="state-label-6">
             <a:extLst xmlns:a="http://schemas.openxmlformats.org/drawingml/2006/main">
               <a:ext uri="{FF2B5EF4-FFF2-40B4-BE49-F238E27FC236}">
-                <a16:creationId xmlns:a16="http://schemas.microsoft.com/office/drawing/2014/main" id="{71F906D2-1859-46F9-A413-1688DE052CD2}"/>
+                <a16:creationId xmlns:a16="http://schemas.microsoft.com/office/drawing/2014/main" id="{E4A63DCF-080A-4B23-BE91-1A5493341154}"/>
               </a:ext>
             </a:extLst>
           </p:cNvPr>
@@ -15999,7 +15999,7 @@
           <p:cNvPr id="35" name="state-guard">
             <a:extLst xmlns:a="http://schemas.openxmlformats.org/drawingml/2006/main">
               <a:ext uri="{FF2B5EF4-FFF2-40B4-BE49-F238E27FC236}">
-                <a16:creationId xmlns:a16="http://schemas.microsoft.com/office/drawing/2014/main" id="{501C1B85-A2E2-4724-B4AF-1894AC110F12}"/>
+                <a16:creationId xmlns:a16="http://schemas.microsoft.com/office/drawing/2014/main" id="{3FF09005-8710-47B7-8BF6-FB24A7955A7F}"/>
               </a:ext>
             </a:extLst>
           </p:cNvPr>
@@ -16034,7 +16034,7 @@
           <p:cNvPr id="36" name="state-guard-text">
             <a:extLst xmlns:a="http://schemas.openxmlformats.org/drawingml/2006/main">
               <a:ext uri="{FF2B5EF4-FFF2-40B4-BE49-F238E27FC236}">
-                <a16:creationId xmlns:a16="http://schemas.microsoft.com/office/drawing/2014/main" id="{0B9D895C-9904-45C3-8902-86A4CB4F2A6A}"/>
+                <a16:creationId xmlns:a16="http://schemas.microsoft.com/office/drawing/2014/main" id="{BCCF84B2-3FE3-4B3B-82C4-404257A35370}"/>
               </a:ext>
             </a:extLst>
           </p:cNvPr>
@@ -16082,7 +16082,7 @@
     </p:spTree>
     <p:extLst>
       <p:ext uri="{BB962C8B-B14F-4D97-AF65-F5344CB8AC3E}">
-        <p14:creationId xmlns:p14="http://schemas.microsoft.com/office/powerpoint/2010/main" val="900252057"/>
+        <p14:creationId xmlns:p14="http://schemas.microsoft.com/office/powerpoint/2010/main" val="1346657268"/>
       </p:ext>
     </p:extLst>
   </p:cSld>
@@ -16113,7 +16113,7 @@
           <p:cNvPr id="24" name="rail-6">
             <a:extLst xmlns:a="http://schemas.openxmlformats.org/drawingml/2006/main">
               <a:ext uri="{FF2B5EF4-FFF2-40B4-BE49-F238E27FC236}">
-                <a16:creationId xmlns:a16="http://schemas.microsoft.com/office/drawing/2014/main" id="{8E34DFAC-52B8-45F5-BD60-C10D965719A6}"/>
+                <a16:creationId xmlns:a16="http://schemas.microsoft.com/office/drawing/2014/main" id="{BCAA05A5-28DA-4F68-8B41-C19B33692E22}"/>
               </a:ext>
             </a:extLst>
           </p:cNvPr>
@@ -16146,7 +16146,7 @@
           <p:cNvPr id="2" name="flourish-6">
             <a:extLst xmlns:a="http://schemas.openxmlformats.org/drawingml/2006/main">
               <a:ext uri="{FF2B5EF4-FFF2-40B4-BE49-F238E27FC236}">
-                <a16:creationId xmlns:a16="http://schemas.microsoft.com/office/drawing/2014/main" id="{3829E511-9B08-495D-B42F-49F0739AC554}"/>
+                <a16:creationId xmlns:a16="http://schemas.microsoft.com/office/drawing/2014/main" id="{3A9CB027-ABC3-47DB-A122-22980D3A263E}"/>
               </a:ext>
             </a:extLst>
           </p:cNvPr>
@@ -16196,7 +16196,7 @@
           <p:cNvPr id="3" name="chapter-6">
             <a:extLst xmlns:a="http://schemas.openxmlformats.org/drawingml/2006/main">
               <a:ext uri="{FF2B5EF4-FFF2-40B4-BE49-F238E27FC236}">
-                <a16:creationId xmlns:a16="http://schemas.microsoft.com/office/drawing/2014/main" id="{B82E452F-82A4-441F-9CCE-6E63E81B6C5E}"/>
+                <a16:creationId xmlns:a16="http://schemas.microsoft.com/office/drawing/2014/main" id="{6294523F-142E-4C76-BF58-87FCB65728BE}"/>
               </a:ext>
             </a:extLst>
           </p:cNvPr>
@@ -16246,7 +16246,7 @@
           <p:cNvPr id="4" name="title-6">
             <a:extLst xmlns:a="http://schemas.openxmlformats.org/drawingml/2006/main">
               <a:ext uri="{FF2B5EF4-FFF2-40B4-BE49-F238E27FC236}">
-                <a16:creationId xmlns:a16="http://schemas.microsoft.com/office/drawing/2014/main" id="{661E7785-7E56-442E-9CC6-1849F6F69662}"/>
+                <a16:creationId xmlns:a16="http://schemas.microsoft.com/office/drawing/2014/main" id="{B1FB5992-AD19-44D9-9A17-966B430F9EA7}"/>
               </a:ext>
             </a:extLst>
           </p:cNvPr>
@@ -16296,7 +16296,7 @@
           <p:cNvPr id="5" name="subtitle-6">
             <a:extLst xmlns:a="http://schemas.openxmlformats.org/drawingml/2006/main">
               <a:ext uri="{FF2B5EF4-FFF2-40B4-BE49-F238E27FC236}">
-                <a16:creationId xmlns:a16="http://schemas.microsoft.com/office/drawing/2014/main" id="{E9DB2D25-A168-455C-97BA-89928E6ADB37}"/>
+                <a16:creationId xmlns:a16="http://schemas.microsoft.com/office/drawing/2014/main" id="{6D578DF2-01C2-4419-A0FB-AC476C805BA6}"/>
               </a:ext>
             </a:extLst>
           </p:cNvPr>
@@ -16346,7 +16346,7 @@
           <p:cNvPr id="6" name="">
             <a:extLst xmlns:a="http://schemas.openxmlformats.org/drawingml/2006/main">
               <a:ext uri="{FF2B5EF4-FFF2-40B4-BE49-F238E27FC236}">
-                <a16:creationId xmlns:a16="http://schemas.microsoft.com/office/drawing/2014/main" id="{5ECA770E-FBCD-44D2-BA49-4B650DDFC46B}"/>
+                <a16:creationId xmlns:a16="http://schemas.microsoft.com/office/drawing/2014/main" id="{036CE4B7-E144-4A20-B5EE-EFB19B7744DB}"/>
               </a:ext>
             </a:extLst>
           </p:cNvPr>
@@ -16377,7 +16377,7 @@
           <p:cNvPr id="7" name="page-6">
             <a:extLst xmlns:a="http://schemas.openxmlformats.org/drawingml/2006/main">
               <a:ext uri="{FF2B5EF4-FFF2-40B4-BE49-F238E27FC236}">
-                <a16:creationId xmlns:a16="http://schemas.microsoft.com/office/drawing/2014/main" id="{9E7CA43B-0BDE-4D97-B822-B551DC2F2881}"/>
+                <a16:creationId xmlns:a16="http://schemas.microsoft.com/office/drawing/2014/main" id="{CC687F5C-18E1-4E35-A758-4ADA970F0423}"/>
               </a:ext>
             </a:extLst>
           </p:cNvPr>
@@ -16427,7 +16427,7 @@
           <p:cNvPr id="8" name="grpo-formula">
             <a:extLst xmlns:a="http://schemas.openxmlformats.org/drawingml/2006/main">
               <a:ext uri="{FF2B5EF4-FFF2-40B4-BE49-F238E27FC236}">
-                <a16:creationId xmlns:a16="http://schemas.microsoft.com/office/drawing/2014/main" id="{4A7D5546-650D-4360-BC28-1356AB033739}"/>
+                <a16:creationId xmlns:a16="http://schemas.microsoft.com/office/drawing/2014/main" id="{98C4A971-91F8-4573-AF86-87C76BEA5544}"/>
               </a:ext>
             </a:extLst>
           </p:cNvPr>
@@ -16462,7 +16462,7 @@
           <p:cNvPr id="9" name="grpo-formula-title">
             <a:extLst xmlns:a="http://schemas.openxmlformats.org/drawingml/2006/main">
               <a:ext uri="{FF2B5EF4-FFF2-40B4-BE49-F238E27FC236}">
-                <a16:creationId xmlns:a16="http://schemas.microsoft.com/office/drawing/2014/main" id="{AC913690-5278-4067-8B33-A55B864E5166}"/>
+                <a16:creationId xmlns:a16="http://schemas.microsoft.com/office/drawing/2014/main" id="{07F4DFF1-D44E-4DB7-AC3A-EFE0D3B0ADD0}"/>
               </a:ext>
             </a:extLst>
           </p:cNvPr>
@@ -16512,7 +16512,7 @@
           <p:cNvPr id="10" name="grpo-formula-main">
             <a:extLst xmlns:a="http://schemas.openxmlformats.org/drawingml/2006/main">
               <a:ext uri="{FF2B5EF4-FFF2-40B4-BE49-F238E27FC236}">
-                <a16:creationId xmlns:a16="http://schemas.microsoft.com/office/drawing/2014/main" id="{925CECF0-616E-4497-93E0-F26FC5EFC49E}"/>
+                <a16:creationId xmlns:a16="http://schemas.microsoft.com/office/drawing/2014/main" id="{6C8F6B7A-D97B-4493-B394-A9A0070FB8BD}"/>
               </a:ext>
             </a:extLst>
           </p:cNvPr>
@@ -16562,7 +16562,7 @@
           <p:cNvPr id="11" name="grpo-reward">
             <a:extLst xmlns:a="http://schemas.openxmlformats.org/drawingml/2006/main">
               <a:ext uri="{FF2B5EF4-FFF2-40B4-BE49-F238E27FC236}">
-                <a16:creationId xmlns:a16="http://schemas.microsoft.com/office/drawing/2014/main" id="{5A067FBC-3D92-4EC1-9D83-B74B085C92E5}"/>
+                <a16:creationId xmlns:a16="http://schemas.microsoft.com/office/drawing/2014/main" id="{5356876F-CE20-40DD-9195-0F8863994E46}"/>
               </a:ext>
             </a:extLst>
           </p:cNvPr>
@@ -16612,7 +16612,7 @@
           <p:cNvPr id="12" name="grpo-num-0">
             <a:extLst xmlns:a="http://schemas.openxmlformats.org/drawingml/2006/main">
               <a:ext uri="{FF2B5EF4-FFF2-40B4-BE49-F238E27FC236}">
-                <a16:creationId xmlns:a16="http://schemas.microsoft.com/office/drawing/2014/main" id="{A1C38DD2-5966-484C-995E-1376656D9A40}"/>
+                <a16:creationId xmlns:a16="http://schemas.microsoft.com/office/drawing/2014/main" id="{F41725E5-95FD-499C-86CC-AAA40C9F2684}"/>
               </a:ext>
             </a:extLst>
           </p:cNvPr>
@@ -16662,7 +16662,7 @@
           <p:cNvPr id="13" name="grpo-head-0">
             <a:extLst xmlns:a="http://schemas.openxmlformats.org/drawingml/2006/main">
               <a:ext uri="{FF2B5EF4-FFF2-40B4-BE49-F238E27FC236}">
-                <a16:creationId xmlns:a16="http://schemas.microsoft.com/office/drawing/2014/main" id="{140FA9B8-4A05-42EB-ADC4-A9F7CE19F001}"/>
+                <a16:creationId xmlns:a16="http://schemas.microsoft.com/office/drawing/2014/main" id="{46346720-E3C8-4C2A-B19C-72138C413998}"/>
               </a:ext>
             </a:extLst>
           </p:cNvPr>
@@ -16712,7 +16712,7 @@
           <p:cNvPr id="14" name="grpo-sub-0">
             <a:extLst xmlns:a="http://schemas.openxmlformats.org/drawingml/2006/main">
               <a:ext uri="{FF2B5EF4-FFF2-40B4-BE49-F238E27FC236}">
-                <a16:creationId xmlns:a16="http://schemas.microsoft.com/office/drawing/2014/main" id="{DF7F0D4F-17A5-44ED-B240-2247F92FAB05}"/>
+                <a16:creationId xmlns:a16="http://schemas.microsoft.com/office/drawing/2014/main" id="{420814CA-143D-4E2B-AEB9-DC9706BE4AD6}"/>
               </a:ext>
             </a:extLst>
           </p:cNvPr>
@@ -16762,7 +16762,7 @@
           <p:cNvPr id="15" name="grpo-num-1">
             <a:extLst xmlns:a="http://schemas.openxmlformats.org/drawingml/2006/main">
               <a:ext uri="{FF2B5EF4-FFF2-40B4-BE49-F238E27FC236}">
-                <a16:creationId xmlns:a16="http://schemas.microsoft.com/office/drawing/2014/main" id="{DAA633D4-1A46-42C3-93F2-FCE1BCACA9FE}"/>
+                <a16:creationId xmlns:a16="http://schemas.microsoft.com/office/drawing/2014/main" id="{FD2C9AB9-CCF8-4140-A603-9BF932CD4246}"/>
               </a:ext>
             </a:extLst>
           </p:cNvPr>
@@ -16812,7 +16812,7 @@
           <p:cNvPr id="16" name="grpo-head-1">
             <a:extLst xmlns:a="http://schemas.openxmlformats.org/drawingml/2006/main">
               <a:ext uri="{FF2B5EF4-FFF2-40B4-BE49-F238E27FC236}">
-                <a16:creationId xmlns:a16="http://schemas.microsoft.com/office/drawing/2014/main" id="{ADB907FA-F719-4F1F-98FF-6BCDC664192C}"/>
+                <a16:creationId xmlns:a16="http://schemas.microsoft.com/office/drawing/2014/main" id="{5625E605-1F28-4300-B46B-538333B8C4CB}"/>
               </a:ext>
             </a:extLst>
           </p:cNvPr>
@@ -16862,7 +16862,7 @@
           <p:cNvPr id="17" name="grpo-sub-1">
             <a:extLst xmlns:a="http://schemas.openxmlformats.org/drawingml/2006/main">
               <a:ext uri="{FF2B5EF4-FFF2-40B4-BE49-F238E27FC236}">
-                <a16:creationId xmlns:a16="http://schemas.microsoft.com/office/drawing/2014/main" id="{03E9C828-2A75-44D0-B22B-4B8EBE019DD2}"/>
+                <a16:creationId xmlns:a16="http://schemas.microsoft.com/office/drawing/2014/main" id="{E54D189D-9FCD-484B-ADA9-EB1C76FB486F}"/>
               </a:ext>
             </a:extLst>
           </p:cNvPr>
@@ -16912,7 +16912,7 @@
           <p:cNvPr id="18" name="grpo-num-2">
             <a:extLst xmlns:a="http://schemas.openxmlformats.org/drawingml/2006/main">
               <a:ext uri="{FF2B5EF4-FFF2-40B4-BE49-F238E27FC236}">
-                <a16:creationId xmlns:a16="http://schemas.microsoft.com/office/drawing/2014/main" id="{F7A78C62-6202-4F29-BE13-C896E101656D}"/>
+                <a16:creationId xmlns:a16="http://schemas.microsoft.com/office/drawing/2014/main" id="{C6A5256D-CC42-4D41-BFD1-39D4D4C8425B}"/>
               </a:ext>
             </a:extLst>
           </p:cNvPr>
@@ -16962,7 +16962,7 @@
           <p:cNvPr id="19" name="grpo-head-2">
             <a:extLst xmlns:a="http://schemas.openxmlformats.org/drawingml/2006/main">
               <a:ext uri="{FF2B5EF4-FFF2-40B4-BE49-F238E27FC236}">
-                <a16:creationId xmlns:a16="http://schemas.microsoft.com/office/drawing/2014/main" id="{6C864AB7-4ACB-4689-9451-E6504833BAAD}"/>
+                <a16:creationId xmlns:a16="http://schemas.microsoft.com/office/drawing/2014/main" id="{C8D910D9-85E9-41CE-BA4F-231B5BC686F7}"/>
               </a:ext>
             </a:extLst>
           </p:cNvPr>
@@ -17012,7 +17012,7 @@
           <p:cNvPr id="20" name="grpo-sub-2">
             <a:extLst xmlns:a="http://schemas.openxmlformats.org/drawingml/2006/main">
               <a:ext uri="{FF2B5EF4-FFF2-40B4-BE49-F238E27FC236}">
-                <a16:creationId xmlns:a16="http://schemas.microsoft.com/office/drawing/2014/main" id="{2B090EC3-D255-44FD-A8DB-E9F2548C331E}"/>
+                <a16:creationId xmlns:a16="http://schemas.microsoft.com/office/drawing/2014/main" id="{9B1D5AE4-9B9B-43AE-936C-42A140016315}"/>
               </a:ext>
             </a:extLst>
           </p:cNvPr>
@@ -17062,7 +17062,7 @@
           <p:cNvPr id="21" name="grpo-num-3">
             <a:extLst xmlns:a="http://schemas.openxmlformats.org/drawingml/2006/main">
               <a:ext uri="{FF2B5EF4-FFF2-40B4-BE49-F238E27FC236}">
-                <a16:creationId xmlns:a16="http://schemas.microsoft.com/office/drawing/2014/main" id="{5B729BBC-9488-4CE0-9EFF-EF07DE0C018C}"/>
+                <a16:creationId xmlns:a16="http://schemas.microsoft.com/office/drawing/2014/main" id="{57B35903-ACC5-4C90-A75B-A4C9CEEAE799}"/>
               </a:ext>
             </a:extLst>
           </p:cNvPr>
@@ -17112,7 +17112,7 @@
           <p:cNvPr id="22" name="grpo-head-3">
             <a:extLst xmlns:a="http://schemas.openxmlformats.org/drawingml/2006/main">
               <a:ext uri="{FF2B5EF4-FFF2-40B4-BE49-F238E27FC236}">
-                <a16:creationId xmlns:a16="http://schemas.microsoft.com/office/drawing/2014/main" id="{68FAA930-D6CA-4953-8187-8598C8C36DBA}"/>
+                <a16:creationId xmlns:a16="http://schemas.microsoft.com/office/drawing/2014/main" id="{C02005E9-FD66-4539-BDE7-58D0116568FF}"/>
               </a:ext>
             </a:extLst>
           </p:cNvPr>
@@ -17162,7 +17162,7 @@
           <p:cNvPr id="23" name="grpo-sub-3">
             <a:extLst xmlns:a="http://schemas.openxmlformats.org/drawingml/2006/main">
               <a:ext uri="{FF2B5EF4-FFF2-40B4-BE49-F238E27FC236}">
-                <a16:creationId xmlns:a16="http://schemas.microsoft.com/office/drawing/2014/main" id="{4F303807-DA32-42A9-BB87-E8232A82B15D}"/>
+                <a16:creationId xmlns:a16="http://schemas.microsoft.com/office/drawing/2014/main" id="{2AC60FAB-6713-4C2F-9900-FF7C224D6F86}"/>
               </a:ext>
             </a:extLst>
           </p:cNvPr>
@@ -17210,7 +17210,7 @@
     </p:spTree>
     <p:extLst>
       <p:ext uri="{BB962C8B-B14F-4D97-AF65-F5344CB8AC3E}">
-        <p14:creationId xmlns:p14="http://schemas.microsoft.com/office/powerpoint/2010/main" val="154623489"/>
+        <p14:creationId xmlns:p14="http://schemas.microsoft.com/office/powerpoint/2010/main" val="1427664023"/>
       </p:ext>
     </p:extLst>
   </p:cSld>
@@ -17241,7 +17241,7 @@
           <p:cNvPr id="10" name="copper-7">
             <a:extLst xmlns:a="http://schemas.openxmlformats.org/drawingml/2006/main">
               <a:ext uri="{FF2B5EF4-FFF2-40B4-BE49-F238E27FC236}">
-                <a16:creationId xmlns:a16="http://schemas.microsoft.com/office/drawing/2014/main" id="{2D0D3A88-30E8-46C6-A740-94CD1277C8DD}"/>
+                <a16:creationId xmlns:a16="http://schemas.microsoft.com/office/drawing/2014/main" id="{5DFDFC0E-0AFA-4F61-A49B-901B29071648}"/>
               </a:ext>
             </a:extLst>
           </p:cNvPr>
@@ -17274,7 +17274,7 @@
           <p:cNvPr id="2" name="chapter-script-7">
             <a:extLst xmlns:a="http://schemas.openxmlformats.org/drawingml/2006/main">
               <a:ext uri="{FF2B5EF4-FFF2-40B4-BE49-F238E27FC236}">
-                <a16:creationId xmlns:a16="http://schemas.microsoft.com/office/drawing/2014/main" id="{103E7A67-6F90-4501-89D7-BCF937B17722}"/>
+                <a16:creationId xmlns:a16="http://schemas.microsoft.com/office/drawing/2014/main" id="{DB331F41-7F78-45FF-A16D-71A814FD8523}"/>
               </a:ext>
             </a:extLst>
           </p:cNvPr>
@@ -17324,7 +17324,7 @@
           <p:cNvPr id="3" name="roman-7">
             <a:extLst xmlns:a="http://schemas.openxmlformats.org/drawingml/2006/main">
               <a:ext uri="{FF2B5EF4-FFF2-40B4-BE49-F238E27FC236}">
-                <a16:creationId xmlns:a16="http://schemas.microsoft.com/office/drawing/2014/main" id="{64908B81-6EE9-43FD-9D0C-355E6C4D6128}"/>
+                <a16:creationId xmlns:a16="http://schemas.microsoft.com/office/drawing/2014/main" id="{2953FD2C-B7E5-424E-A4F3-055EFA6FEDDB}"/>
               </a:ext>
             </a:extLst>
           </p:cNvPr>
@@ -17374,7 +17374,7 @@
           <p:cNvPr id="4" name="">
             <a:extLst xmlns:a="http://schemas.openxmlformats.org/drawingml/2006/main">
               <a:ext uri="{FF2B5EF4-FFF2-40B4-BE49-F238E27FC236}">
-                <a16:creationId xmlns:a16="http://schemas.microsoft.com/office/drawing/2014/main" id="{2C122DDE-6D14-49AA-A229-EB7CC06456BA}"/>
+                <a16:creationId xmlns:a16="http://schemas.microsoft.com/office/drawing/2014/main" id="{514C573A-00B3-48CA-8A32-DAE146595145}"/>
               </a:ext>
             </a:extLst>
           </p:cNvPr>
@@ -17405,7 +17405,7 @@
           <p:cNvPr id="5" name="zh-7">
             <a:extLst xmlns:a="http://schemas.openxmlformats.org/drawingml/2006/main">
               <a:ext uri="{FF2B5EF4-FFF2-40B4-BE49-F238E27FC236}">
-                <a16:creationId xmlns:a16="http://schemas.microsoft.com/office/drawing/2014/main" id="{84F2515F-9A05-4FC2-801E-5EDB9C0E1B07}"/>
+                <a16:creationId xmlns:a16="http://schemas.microsoft.com/office/drawing/2014/main" id="{8D0D8BAA-66E7-4E73-B4A4-1CA3AADE34B5}"/>
               </a:ext>
             </a:extLst>
           </p:cNvPr>
@@ -17455,7 +17455,7 @@
           <p:cNvPr id="6" name="en-7">
             <a:extLst xmlns:a="http://schemas.openxmlformats.org/drawingml/2006/main">
               <a:ext uri="{FF2B5EF4-FFF2-40B4-BE49-F238E27FC236}">
-                <a16:creationId xmlns:a16="http://schemas.microsoft.com/office/drawing/2014/main" id="{C1B5A502-2DF0-41AD-9CAD-D47A88FF9CF7}"/>
+                <a16:creationId xmlns:a16="http://schemas.microsoft.com/office/drawing/2014/main" id="{1E17C02B-8774-44CD-9AB7-99A9A14C6D1E}"/>
               </a:ext>
             </a:extLst>
           </p:cNvPr>
@@ -17505,7 +17505,7 @@
           <p:cNvPr id="7" name="body-7">
             <a:extLst xmlns:a="http://schemas.openxmlformats.org/drawingml/2006/main">
               <a:ext uri="{FF2B5EF4-FFF2-40B4-BE49-F238E27FC236}">
-                <a16:creationId xmlns:a16="http://schemas.microsoft.com/office/drawing/2014/main" id="{71DE6C71-CD8A-4E8C-9C09-FEF4D67C8247}"/>
+                <a16:creationId xmlns:a16="http://schemas.microsoft.com/office/drawing/2014/main" id="{8F5EDA68-BA96-4F2F-9A9E-0BFF51E35EE8}"/>
               </a:ext>
             </a:extLst>
           </p:cNvPr>
@@ -17559,7 +17559,7 @@
           <p:cNvPr id="8" name="chapter-pill-7-bg">
             <a:extLst xmlns:a="http://schemas.openxmlformats.org/drawingml/2006/main">
               <a:ext uri="{FF2B5EF4-FFF2-40B4-BE49-F238E27FC236}">
-                <a16:creationId xmlns:a16="http://schemas.microsoft.com/office/drawing/2014/main" id="{D1ECF22E-FB49-4AE9-A20A-3749AC0E21B8}"/>
+                <a16:creationId xmlns:a16="http://schemas.microsoft.com/office/drawing/2014/main" id="{7E920D57-743B-437C-91FC-B0AD4F27FAD6}"/>
               </a:ext>
             </a:extLst>
           </p:cNvPr>
@@ -17594,7 +17594,7 @@
           <p:cNvPr id="9" name="chapter-pill-7-text">
             <a:extLst xmlns:a="http://schemas.openxmlformats.org/drawingml/2006/main">
               <a:ext uri="{FF2B5EF4-FFF2-40B4-BE49-F238E27FC236}">
-                <a16:creationId xmlns:a16="http://schemas.microsoft.com/office/drawing/2014/main" id="{EEA15F4D-F92F-4FF6-9D17-E5759244D29B}"/>
+                <a16:creationId xmlns:a16="http://schemas.microsoft.com/office/drawing/2014/main" id="{6035B461-DC46-47FF-B354-89750044F9EB}"/>
               </a:ext>
             </a:extLst>
           </p:cNvPr>
@@ -17642,7 +17642,7 @@
     </p:spTree>
     <p:extLst>
       <p:ext uri="{BB962C8B-B14F-4D97-AF65-F5344CB8AC3E}">
-        <p14:creationId xmlns:p14="http://schemas.microsoft.com/office/powerpoint/2010/main" val="1043003140"/>
+        <p14:creationId xmlns:p14="http://schemas.microsoft.com/office/powerpoint/2010/main" val="1123570574"/>
       </p:ext>
     </p:extLst>
   </p:cSld>
@@ -17673,7 +17673,7 @@
           <p:cNvPr id="26" name="rail-8">
             <a:extLst xmlns:a="http://schemas.openxmlformats.org/drawingml/2006/main">
               <a:ext uri="{FF2B5EF4-FFF2-40B4-BE49-F238E27FC236}">
-                <a16:creationId xmlns:a16="http://schemas.microsoft.com/office/drawing/2014/main" id="{89DC2FAB-96E6-4B6B-A603-34A3892DC0B3}"/>
+                <a16:creationId xmlns:a16="http://schemas.microsoft.com/office/drawing/2014/main" id="{D8391327-3467-47BE-A746-7E413447B7C6}"/>
               </a:ext>
             </a:extLst>
           </p:cNvPr>
@@ -17706,7 +17706,7 @@
           <p:cNvPr id="2" name="flourish-8">
             <a:extLst xmlns:a="http://schemas.openxmlformats.org/drawingml/2006/main">
               <a:ext uri="{FF2B5EF4-FFF2-40B4-BE49-F238E27FC236}">
-                <a16:creationId xmlns:a16="http://schemas.microsoft.com/office/drawing/2014/main" id="{65D7453B-351D-4948-82B8-11D81D9FD921}"/>
+                <a16:creationId xmlns:a16="http://schemas.microsoft.com/office/drawing/2014/main" id="{46C9AB09-42CD-457E-B73C-28EE97908DA4}"/>
               </a:ext>
             </a:extLst>
           </p:cNvPr>
@@ -17756,7 +17756,7 @@
           <p:cNvPr id="3" name="chapter-8">
             <a:extLst xmlns:a="http://schemas.openxmlformats.org/drawingml/2006/main">
               <a:ext uri="{FF2B5EF4-FFF2-40B4-BE49-F238E27FC236}">
-                <a16:creationId xmlns:a16="http://schemas.microsoft.com/office/drawing/2014/main" id="{6855146B-47DF-4E82-8F50-6D21062263AA}"/>
+                <a16:creationId xmlns:a16="http://schemas.microsoft.com/office/drawing/2014/main" id="{FFAF42DA-DCC1-48F1-9321-5FF4F8B0074B}"/>
               </a:ext>
             </a:extLst>
           </p:cNvPr>
@@ -17806,7 +17806,7 @@
           <p:cNvPr id="4" name="title-8">
             <a:extLst xmlns:a="http://schemas.openxmlformats.org/drawingml/2006/main">
               <a:ext uri="{FF2B5EF4-FFF2-40B4-BE49-F238E27FC236}">
-                <a16:creationId xmlns:a16="http://schemas.microsoft.com/office/drawing/2014/main" id="{643EE5EB-0938-49DE-A0EE-EBC158850213}"/>
+                <a16:creationId xmlns:a16="http://schemas.microsoft.com/office/drawing/2014/main" id="{39D12A8E-B5D7-48B5-9EF1-92F45CCEF1E3}"/>
               </a:ext>
             </a:extLst>
           </p:cNvPr>
@@ -17856,7 +17856,7 @@
           <p:cNvPr id="5" name="subtitle-8">
             <a:extLst xmlns:a="http://schemas.openxmlformats.org/drawingml/2006/main">
               <a:ext uri="{FF2B5EF4-FFF2-40B4-BE49-F238E27FC236}">
-                <a16:creationId xmlns:a16="http://schemas.microsoft.com/office/drawing/2014/main" id="{17491E6E-3108-496F-8008-C7B1553335B8}"/>
+                <a16:creationId xmlns:a16="http://schemas.microsoft.com/office/drawing/2014/main" id="{909D991E-252C-442D-B313-776231396B23}"/>
               </a:ext>
             </a:extLst>
           </p:cNvPr>
@@ -17906,7 +17906,7 @@
           <p:cNvPr id="6" name="">
             <a:extLst xmlns:a="http://schemas.openxmlformats.org/drawingml/2006/main">
               <a:ext uri="{FF2B5EF4-FFF2-40B4-BE49-F238E27FC236}">
-                <a16:creationId xmlns:a16="http://schemas.microsoft.com/office/drawing/2014/main" id="{6A94DA86-F268-46AE-A336-70F3E076447B}"/>
+                <a16:creationId xmlns:a16="http://schemas.microsoft.com/office/drawing/2014/main" id="{4B3CEF65-02E3-4C41-8D9F-41EE41DEE84F}"/>
               </a:ext>
             </a:extLst>
           </p:cNvPr>
@@ -17937,7 +17937,7 @@
           <p:cNvPr id="7" name="page-8">
             <a:extLst xmlns:a="http://schemas.openxmlformats.org/drawingml/2006/main">
               <a:ext uri="{FF2B5EF4-FFF2-40B4-BE49-F238E27FC236}">
-                <a16:creationId xmlns:a16="http://schemas.microsoft.com/office/drawing/2014/main" id="{5E7C2AB9-0E44-4F5A-A784-AE7725C7E1A0}"/>
+                <a16:creationId xmlns:a16="http://schemas.microsoft.com/office/drawing/2014/main" id="{31F041FA-CF49-4A59-9527-90CE2CA3C062}"/>
               </a:ext>
             </a:extLst>
           </p:cNvPr>
@@ -17987,7 +17987,7 @@
           <p:cNvPr id="8" name="">
             <a:extLst xmlns:a="http://schemas.openxmlformats.org/drawingml/2006/main">
               <a:ext uri="{FF2B5EF4-FFF2-40B4-BE49-F238E27FC236}">
-                <a16:creationId xmlns:a16="http://schemas.microsoft.com/office/drawing/2014/main" id="{493FAEF5-B6D6-4DD4-805E-F0D5F91E86D1}"/>
+                <a16:creationId xmlns:a16="http://schemas.microsoft.com/office/drawing/2014/main" id="{78E2A55F-7891-47D0-AF13-6EB8DEC75C1C}"/>
               </a:ext>
             </a:extLst>
           </p:cNvPr>
@@ -18018,7 +18018,7 @@
           <p:cNvPr id="9" name="s1-before-value">
             <a:extLst xmlns:a="http://schemas.openxmlformats.org/drawingml/2006/main">
               <a:ext uri="{FF2B5EF4-FFF2-40B4-BE49-F238E27FC236}">
-                <a16:creationId xmlns:a16="http://schemas.microsoft.com/office/drawing/2014/main" id="{51859399-6D11-4F15-ACE0-AEE2F3788155}"/>
+                <a16:creationId xmlns:a16="http://schemas.microsoft.com/office/drawing/2014/main" id="{1C0608AC-2845-4F78-85EE-18D31533CCC5}"/>
               </a:ext>
             </a:extLst>
           </p:cNvPr>
@@ -18068,7 +18068,7 @@
           <p:cNvPr id="10" name="s1-before-label">
             <a:extLst xmlns:a="http://schemas.openxmlformats.org/drawingml/2006/main">
               <a:ext uri="{FF2B5EF4-FFF2-40B4-BE49-F238E27FC236}">
-                <a16:creationId xmlns:a16="http://schemas.microsoft.com/office/drawing/2014/main" id="{53487718-D3BC-4ACF-A90B-CB33D80E2FD1}"/>
+                <a16:creationId xmlns:a16="http://schemas.microsoft.com/office/drawing/2014/main" id="{04624CA6-3897-4196-98A3-5EA004A84168}"/>
               </a:ext>
             </a:extLst>
           </p:cNvPr>
@@ -18118,7 +18118,7 @@
           <p:cNvPr id="11" name="">
             <a:extLst xmlns:a="http://schemas.openxmlformats.org/drawingml/2006/main">
               <a:ext uri="{FF2B5EF4-FFF2-40B4-BE49-F238E27FC236}">
-                <a16:creationId xmlns:a16="http://schemas.microsoft.com/office/drawing/2014/main" id="{CDA1F6E8-22FE-44BC-8D82-3F85E770D407}"/>
+                <a16:creationId xmlns:a16="http://schemas.microsoft.com/office/drawing/2014/main" id="{8609C180-BA98-48CB-8B10-122627B234A8}"/>
               </a:ext>
             </a:extLst>
           </p:cNvPr>
@@ -18149,7 +18149,7 @@
           <p:cNvPr id="12" name="s1-after-value">
             <a:extLst xmlns:a="http://schemas.openxmlformats.org/drawingml/2006/main">
               <a:ext uri="{FF2B5EF4-FFF2-40B4-BE49-F238E27FC236}">
-                <a16:creationId xmlns:a16="http://schemas.microsoft.com/office/drawing/2014/main" id="{A149F6A4-AA79-45ED-9D06-41F032275EDC}"/>
+                <a16:creationId xmlns:a16="http://schemas.microsoft.com/office/drawing/2014/main" id="{A47FA299-EF01-4309-88A2-1A19874F1818}"/>
               </a:ext>
             </a:extLst>
           </p:cNvPr>
@@ -18199,7 +18199,7 @@
           <p:cNvPr id="13" name="s1-after-label">
             <a:extLst xmlns:a="http://schemas.openxmlformats.org/drawingml/2006/main">
               <a:ext uri="{FF2B5EF4-FFF2-40B4-BE49-F238E27FC236}">
-                <a16:creationId xmlns:a16="http://schemas.microsoft.com/office/drawing/2014/main" id="{0D9C9845-6E83-4BC7-ABD7-7362D07002F8}"/>
+                <a16:creationId xmlns:a16="http://schemas.microsoft.com/office/drawing/2014/main" id="{7FA813F2-F9EE-4635-98E0-E192F3171C4A}"/>
               </a:ext>
             </a:extLst>
           </p:cNvPr>
@@ -18249,7 +18249,7 @@
           <p:cNvPr id="14" name="">
             <a:extLst xmlns:a="http://schemas.openxmlformats.org/drawingml/2006/main">
               <a:ext uri="{FF2B5EF4-FFF2-40B4-BE49-F238E27FC236}">
-                <a16:creationId xmlns:a16="http://schemas.microsoft.com/office/drawing/2014/main" id="{606550C2-0F89-42EB-853F-08DFDD1B3D63}"/>
+                <a16:creationId xmlns:a16="http://schemas.microsoft.com/office/drawing/2014/main" id="{36C4F12B-71E8-4049-9EC3-7BED064D177B}"/>
               </a:ext>
             </a:extLst>
           </p:cNvPr>
@@ -18280,7 +18280,7 @@
           <p:cNvPr id="15" name="s1-delta-value">
             <a:extLst xmlns:a="http://schemas.openxmlformats.org/drawingml/2006/main">
               <a:ext uri="{FF2B5EF4-FFF2-40B4-BE49-F238E27FC236}">
-                <a16:creationId xmlns:a16="http://schemas.microsoft.com/office/drawing/2014/main" id="{1CD30539-465E-47E6-B67D-408E89DFE3D8}"/>
+                <a16:creationId xmlns:a16="http://schemas.microsoft.com/office/drawing/2014/main" id="{6FF36055-7F2B-4FAE-AEED-81FEE17580CF}"/>
               </a:ext>
             </a:extLst>
           </p:cNvPr>
@@ -18330,7 +18330,7 @@
           <p:cNvPr id="16" name="s1-delta-label">
             <a:extLst xmlns:a="http://schemas.openxmlformats.org/drawingml/2006/main">
               <a:ext uri="{FF2B5EF4-FFF2-40B4-BE49-F238E27FC236}">
-                <a16:creationId xmlns:a16="http://schemas.microsoft.com/office/drawing/2014/main" id="{4EDADD55-DCE9-4A02-85A2-C55740172535}"/>
+                <a16:creationId xmlns:a16="http://schemas.microsoft.com/office/drawing/2014/main" id="{73680A00-5E0B-47E1-AE2A-40E2FB04A185}"/>
               </a:ext>
             </a:extLst>
           </p:cNvPr>
@@ -18380,7 +18380,7 @@
           <p:cNvPr id="17" name="">
             <a:extLst xmlns:a="http://schemas.openxmlformats.org/drawingml/2006/main">
               <a:ext uri="{FF2B5EF4-FFF2-40B4-BE49-F238E27FC236}">
-                <a16:creationId xmlns:a16="http://schemas.microsoft.com/office/drawing/2014/main" id="{86EE1E75-A946-409D-B07D-BAE18FF1486C}"/>
+                <a16:creationId xmlns:a16="http://schemas.microsoft.com/office/drawing/2014/main" id="{8C44683A-B32C-4CC7-8263-FD8AFB9B258B}"/>
               </a:ext>
             </a:extLst>
           </p:cNvPr>
@@ -18411,7 +18411,7 @@
           <p:cNvPr id="18" name="s1-steps-value">
             <a:extLst xmlns:a="http://schemas.openxmlformats.org/drawingml/2006/main">
               <a:ext uri="{FF2B5EF4-FFF2-40B4-BE49-F238E27FC236}">
-                <a16:creationId xmlns:a16="http://schemas.microsoft.com/office/drawing/2014/main" id="{C70631FD-35A3-48A6-8961-EB1ECD55F194}"/>
+                <a16:creationId xmlns:a16="http://schemas.microsoft.com/office/drawing/2014/main" id="{55F7870D-C6CA-489A-A51F-6D256BD4F0EA}"/>
               </a:ext>
             </a:extLst>
           </p:cNvPr>
@@ -18461,7 +18461,7 @@
           <p:cNvPr id="19" name="s1-steps-label">
             <a:extLst xmlns:a="http://schemas.openxmlformats.org/drawingml/2006/main">
               <a:ext uri="{FF2B5EF4-FFF2-40B4-BE49-F238E27FC236}">
-                <a16:creationId xmlns:a16="http://schemas.microsoft.com/office/drawing/2014/main" id="{30D49BC0-7A95-4371-86BE-1A240146B1BA}"/>
+                <a16:creationId xmlns:a16="http://schemas.microsoft.com/office/drawing/2014/main" id="{09A3D27D-3B64-4FE3-BD17-6F2676DA4365}"/>
               </a:ext>
             </a:extLst>
           </p:cNvPr>
@@ -18511,7 +18511,7 @@
           <p:cNvPr id="20" name="failure-head">
             <a:extLst xmlns:a="http://schemas.openxmlformats.org/drawingml/2006/main">
               <a:ext uri="{FF2B5EF4-FFF2-40B4-BE49-F238E27FC236}">
-                <a16:creationId xmlns:a16="http://schemas.microsoft.com/office/drawing/2014/main" id="{1D8960C3-6D08-45F6-900B-271CA880318F}"/>
+                <a16:creationId xmlns:a16="http://schemas.microsoft.com/office/drawing/2014/main" id="{13037BF1-45CA-4B95-9F4D-7EC1E0DF0624}"/>
               </a:ext>
             </a:extLst>
           </p:cNvPr>
@@ -18561,7 +18561,7 @@
           <p:cNvPr id="21" name="failure-name-0">
             <a:extLst xmlns:a="http://schemas.openxmlformats.org/drawingml/2006/main">
               <a:ext uri="{FF2B5EF4-FFF2-40B4-BE49-F238E27FC236}">
-                <a16:creationId xmlns:a16="http://schemas.microsoft.com/office/drawing/2014/main" id="{ED6730B5-6EB2-4F3A-B40A-5A95D24CE6D6}"/>
+                <a16:creationId xmlns:a16="http://schemas.microsoft.com/office/drawing/2014/main" id="{E24E53B8-3C59-4DAE-B980-41FAACDB94FD}"/>
               </a:ext>
             </a:extLst>
           </p:cNvPr>
@@ -18611,7 +18611,7 @@
           <p:cNvPr id="22" name="failure-track-0">
             <a:extLst xmlns:a="http://schemas.openxmlformats.org/drawingml/2006/main">
               <a:ext uri="{FF2B5EF4-FFF2-40B4-BE49-F238E27FC236}">
-                <a16:creationId xmlns:a16="http://schemas.microsoft.com/office/drawing/2014/main" id="{45B56BD2-1B2A-46C6-82C0-56B9274D8CFF}"/>
+                <a16:creationId xmlns:a16="http://schemas.microsoft.com/office/drawing/2014/main" id="{D01A6B1B-0A9F-4D99-80B8-D3F3A381CCB7}"/>
               </a:ext>
             </a:extLst>
           </p:cNvPr>
@@ -18646,7 +18646,7 @@
           <p:cNvPr id="23" name="failure-before-0">
             <a:extLst xmlns:a="http://schemas.openxmlformats.org/drawingml/2006/main">
               <a:ext uri="{FF2B5EF4-FFF2-40B4-BE49-F238E27FC236}">
-                <a16:creationId xmlns:a16="http://schemas.microsoft.com/office/drawing/2014/main" id="{4944F625-F200-402B-B89D-6B596B6519A8}"/>
+                <a16:creationId xmlns:a16="http://schemas.microsoft.com/office/drawing/2014/main" id="{82042E93-91F6-420B-854F-6169FF61E16D}"/>
               </a:ext>
             </a:extLst>
           </p:cNvPr>
@@ -18681,7 +18681,7 @@
           <p:cNvPr id="24" name="failure-after-0">
             <a:extLst xmlns:a="http://schemas.openxmlformats.org/drawingml/2006/main">
               <a:ext uri="{FF2B5EF4-FFF2-40B4-BE49-F238E27FC236}">
-                <a16:creationId xmlns:a16="http://schemas.microsoft.com/office/drawing/2014/main" id="{950AE88C-2A6F-49E5-8AAA-8F185DA14F67}"/>
+                <a16:creationId xmlns:a16="http://schemas.microsoft.com/office/drawing/2014/main" id="{9478D7AB-4CB9-44F7-A237-95717A67687E}"/>
               </a:ext>
             </a:extLst>
           </p:cNvPr>
@@ -18716,7 +18716,7 @@
           <p:cNvPr id="25" name="failure-count-0">
             <a:extLst xmlns:a="http://schemas.openxmlformats.org/drawingml/2006/main">
               <a:ext uri="{FF2B5EF4-FFF2-40B4-BE49-F238E27FC236}">
-                <a16:creationId xmlns:a16="http://schemas.microsoft.com/office/drawing/2014/main" id="{0EE3FED2-3B7F-4615-80E9-C39578EF5BE7}"/>
+                <a16:creationId xmlns:a16="http://schemas.microsoft.com/office/drawing/2014/main" id="{AEA7C6C8-B26C-48DD-864A-8A395104C68E}"/>
               </a:ext>
             </a:extLst>
           </p:cNvPr>
@@ -18764,7 +18764,7 @@
     </p:spTree>
     <p:extLst>
       <p:ext uri="{BB962C8B-B14F-4D97-AF65-F5344CB8AC3E}">
-        <p14:creationId xmlns:p14="http://schemas.microsoft.com/office/powerpoint/2010/main" val="960418331"/>
+        <p14:creationId xmlns:p14="http://schemas.microsoft.com/office/powerpoint/2010/main" val="68153127"/>
       </p:ext>
     </p:extLst>
   </p:cSld>
@@ -18795,7 +18795,7 @@
           <p:cNvPr id="20" name="rail-9">
             <a:extLst xmlns:a="http://schemas.openxmlformats.org/drawingml/2006/main">
               <a:ext uri="{FF2B5EF4-FFF2-40B4-BE49-F238E27FC236}">
-                <a16:creationId xmlns:a16="http://schemas.microsoft.com/office/drawing/2014/main" id="{FD4A4525-6EE8-4749-BA7F-22D5D0891B88}"/>
+                <a16:creationId xmlns:a16="http://schemas.microsoft.com/office/drawing/2014/main" id="{1F2B7517-5E2C-4E5F-A91B-03A059FB7FA2}"/>
               </a:ext>
             </a:extLst>
           </p:cNvPr>
@@ -18828,7 +18828,7 @@
           <p:cNvPr id="2" name="flourish-9">
             <a:extLst xmlns:a="http://schemas.openxmlformats.org/drawingml/2006/main">
               <a:ext uri="{FF2B5EF4-FFF2-40B4-BE49-F238E27FC236}">
-                <a16:creationId xmlns:a16="http://schemas.microsoft.com/office/drawing/2014/main" id="{EF205CBF-DE63-4CBB-93A0-7D211D8DE9EB}"/>
+                <a16:creationId xmlns:a16="http://schemas.microsoft.com/office/drawing/2014/main" id="{982387D9-7BDA-40FB-A771-6F0A49A1F12E}"/>
               </a:ext>
             </a:extLst>
           </p:cNvPr>
@@ -18878,7 +18878,7 @@
           <p:cNvPr id="3" name="chapter-9">
             <a:extLst xmlns:a="http://schemas.openxmlformats.org/drawingml/2006/main">
               <a:ext uri="{FF2B5EF4-FFF2-40B4-BE49-F238E27FC236}">
-                <a16:creationId xmlns:a16="http://schemas.microsoft.com/office/drawing/2014/main" id="{EB300018-4D19-4EB3-A7C2-99B0839590AE}"/>
+                <a16:creationId xmlns:a16="http://schemas.microsoft.com/office/drawing/2014/main" id="{42A3D572-5F4D-42F7-A9E9-4BE67B7135AE}"/>
               </a:ext>
             </a:extLst>
           </p:cNvPr>
@@ -18928,7 +18928,7 @@
           <p:cNvPr id="4" name="title-9">
             <a:extLst xmlns:a="http://schemas.openxmlformats.org/drawingml/2006/main">
               <a:ext uri="{FF2B5EF4-FFF2-40B4-BE49-F238E27FC236}">
-                <a16:creationId xmlns:a16="http://schemas.microsoft.com/office/drawing/2014/main" id="{49C23FFD-5366-411C-BF5E-9D752630B3F7}"/>
+                <a16:creationId xmlns:a16="http://schemas.microsoft.com/office/drawing/2014/main" id="{6A83479E-C6BD-40EB-B617-C8ED4B9CF71F}"/>
               </a:ext>
             </a:extLst>
           </p:cNvPr>
@@ -18978,7 +18978,7 @@
           <p:cNvPr id="5" name="subtitle-9">
             <a:extLst xmlns:a="http://schemas.openxmlformats.org/drawingml/2006/main">
               <a:ext uri="{FF2B5EF4-FFF2-40B4-BE49-F238E27FC236}">
-                <a16:creationId xmlns:a16="http://schemas.microsoft.com/office/drawing/2014/main" id="{37FC97D5-E9B3-4FC8-A4F9-7C679EBAE8DB}"/>
+                <a16:creationId xmlns:a16="http://schemas.microsoft.com/office/drawing/2014/main" id="{1482DBD7-034D-4E51-8BFB-C9C4CC51C4A6}"/>
               </a:ext>
             </a:extLst>
           </p:cNvPr>
@@ -19028,7 +19028,7 @@
           <p:cNvPr id="6" name="">
             <a:extLst xmlns:a="http://schemas.openxmlformats.org/drawingml/2006/main">
               <a:ext uri="{FF2B5EF4-FFF2-40B4-BE49-F238E27FC236}">
-                <a16:creationId xmlns:a16="http://schemas.microsoft.com/office/drawing/2014/main" id="{8A9E8B2D-E9B1-472D-9285-DBF36A5391D4}"/>
+                <a16:creationId xmlns:a16="http://schemas.microsoft.com/office/drawing/2014/main" id="{52AEFCCD-6FBE-4EDC-85DC-291E07C17C33}"/>
               </a:ext>
             </a:extLst>
           </p:cNvPr>
@@ -19059,7 +19059,7 @@
           <p:cNvPr id="7" name="page-9">
             <a:extLst xmlns:a="http://schemas.openxmlformats.org/drawingml/2006/main">
               <a:ext uri="{FF2B5EF4-FFF2-40B4-BE49-F238E27FC236}">
-                <a16:creationId xmlns:a16="http://schemas.microsoft.com/office/drawing/2014/main" id="{9785AE88-804F-4407-B97B-D548959BDAB4}"/>
+                <a16:creationId xmlns:a16="http://schemas.microsoft.com/office/drawing/2014/main" id="{A1F4788C-EA70-4459-8834-72CFDEAB53AC}"/>
               </a:ext>
             </a:extLst>
           </p:cNvPr>
@@ -19109,7 +19109,7 @@
           <p:cNvPr id="8" name="">
             <a:extLst xmlns:a="http://schemas.openxmlformats.org/drawingml/2006/main">
               <a:ext uri="{FF2B5EF4-FFF2-40B4-BE49-F238E27FC236}">
-                <a16:creationId xmlns:a16="http://schemas.microsoft.com/office/drawing/2014/main" id="{3EADFBD1-22FA-48E8-BFE4-A2F7F764F5E5}"/>
+                <a16:creationId xmlns:a16="http://schemas.microsoft.com/office/drawing/2014/main" id="{6C346D1E-45C8-4B97-BA41-DE80FE660BC8}"/>
               </a:ext>
             </a:extLst>
           </p:cNvPr>
@@ -19140,7 +19140,7 @@
           <p:cNvPr id="9" name="">
             <a:extLst xmlns:a="http://schemas.openxmlformats.org/drawingml/2006/main">
               <a:ext uri="{FF2B5EF4-FFF2-40B4-BE49-F238E27FC236}">
-                <a16:creationId xmlns:a16="http://schemas.microsoft.com/office/drawing/2014/main" id="{17730680-3BDA-495A-AA37-8D62D0ABC7C8}"/>
+                <a16:creationId xmlns:a16="http://schemas.microsoft.com/office/drawing/2014/main" id="{F1E9D0BD-BA3A-42BB-817A-62138E994EB6}"/>
               </a:ext>
             </a:extLst>
           </p:cNvPr>
@@ -19171,7 +19171,7 @@
           <p:cNvPr id="10" name="synth-left">
             <a:extLst xmlns:a="http://schemas.openxmlformats.org/drawingml/2006/main">
               <a:ext uri="{FF2B5EF4-FFF2-40B4-BE49-F238E27FC236}">
-                <a16:creationId xmlns:a16="http://schemas.microsoft.com/office/drawing/2014/main" id="{EF9B339A-FA85-4841-BA3D-0D8E836A8131}"/>
+                <a16:creationId xmlns:a16="http://schemas.microsoft.com/office/drawing/2014/main" id="{2E43D0FA-7096-4B31-9058-C35694D1EAEC}"/>
               </a:ext>
             </a:extLst>
           </p:cNvPr>
@@ -19206,7 +19206,7 @@
           <p:cNvPr id="11" name="synth-mid">
             <a:extLst xmlns:a="http://schemas.openxmlformats.org/drawingml/2006/main">
               <a:ext uri="{FF2B5EF4-FFF2-40B4-BE49-F238E27FC236}">
-                <a16:creationId xmlns:a16="http://schemas.microsoft.com/office/drawing/2014/main" id="{A252D822-A481-4C5A-94A5-751731E00F5B}"/>
+                <a16:creationId xmlns:a16="http://schemas.microsoft.com/office/drawing/2014/main" id="{ED6CD5BE-CDCC-4E92-AC60-26F963683C42}"/>
               </a:ext>
             </a:extLst>
           </p:cNvPr>
@@ -19241,7 +19241,7 @@
           <p:cNvPr id="12" name="synth-right">
             <a:extLst xmlns:a="http://schemas.openxmlformats.org/drawingml/2006/main">
               <a:ext uri="{FF2B5EF4-FFF2-40B4-BE49-F238E27FC236}">
-                <a16:creationId xmlns:a16="http://schemas.microsoft.com/office/drawing/2014/main" id="{EB7D6562-61AA-4117-81A7-758DDE975434}"/>
+                <a16:creationId xmlns:a16="http://schemas.microsoft.com/office/drawing/2014/main" id="{C2BCF01D-BB8D-46C3-8450-C760C24D7B76}"/>
               </a:ext>
             </a:extLst>
           </p:cNvPr>
@@ -19276,7 +19276,7 @@
           <p:cNvPr id="13" name="synth-left-k">
             <a:extLst xmlns:a="http://schemas.openxmlformats.org/drawingml/2006/main">
               <a:ext uri="{FF2B5EF4-FFF2-40B4-BE49-F238E27FC236}">
-                <a16:creationId xmlns:a16="http://schemas.microsoft.com/office/drawing/2014/main" id="{51D0642A-2601-45B4-BFA8-FAB8A7C6C6FF}"/>
+                <a16:creationId xmlns:a16="http://schemas.microsoft.com/office/drawing/2014/main" id="{904EB983-4246-4296-9C9E-A2CCE0DC3576}"/>
               </a:ext>
             </a:extLst>
           </p:cNvPr>
@@ -19326,7 +19326,7 @@
           <p:cNvPr id="14" name="synth-left-v">
             <a:extLst xmlns:a="http://schemas.openxmlformats.org/drawingml/2006/main">
               <a:ext uri="{FF2B5EF4-FFF2-40B4-BE49-F238E27FC236}">
-                <a16:creationId xmlns:a16="http://schemas.microsoft.com/office/drawing/2014/main" id="{7B549C91-EE17-4390-846C-9584B0B0BAEE}"/>
+                <a16:creationId xmlns:a16="http://schemas.microsoft.com/office/drawing/2014/main" id="{36C13FFA-84AB-4AFE-B7BC-F088E6E75148}"/>
               </a:ext>
             </a:extLst>
           </p:cNvPr>
@@ -19393,7 +19393,7 @@
           <p:cNvPr id="15" name="synth-mid-k">
             <a:extLst xmlns:a="http://schemas.openxmlformats.org/drawingml/2006/main">
               <a:ext uri="{FF2B5EF4-FFF2-40B4-BE49-F238E27FC236}">
-                <a16:creationId xmlns:a16="http://schemas.microsoft.com/office/drawing/2014/main" id="{C16D24B0-A13F-4A6B-BC06-BC6895E55A13}"/>
+                <a16:creationId xmlns:a16="http://schemas.microsoft.com/office/drawing/2014/main" id="{9D2A2012-433F-43BA-BF2E-D36A2F3536B3}"/>
               </a:ext>
             </a:extLst>
           </p:cNvPr>
@@ -19460,7 +19460,7 @@
           <p:cNvPr id="16" name="synth-mid-v">
             <a:extLst xmlns:a="http://schemas.openxmlformats.org/drawingml/2006/main">
               <a:ext uri="{FF2B5EF4-FFF2-40B4-BE49-F238E27FC236}">
-                <a16:creationId xmlns:a16="http://schemas.microsoft.com/office/drawing/2014/main" id="{7AB9CBB9-D106-4C47-8346-42D9FB374C34}"/>
+                <a16:creationId xmlns:a16="http://schemas.microsoft.com/office/drawing/2014/main" id="{754452FF-1BA5-4EEE-8209-BAD97C1C8F6F}"/>
               </a:ext>
             </a:extLst>
           </p:cNvPr>
@@ -19577,7 +19577,7 @@
           <p:cNvPr id="17" name="synth-right-k">
             <a:extLst xmlns:a="http://schemas.openxmlformats.org/drawingml/2006/main">
               <a:ext uri="{FF2B5EF4-FFF2-40B4-BE49-F238E27FC236}">
-                <a16:creationId xmlns:a16="http://schemas.microsoft.com/office/drawing/2014/main" id="{08CBE57A-1537-4F84-A4F5-36023C5963FA}"/>
+                <a16:creationId xmlns:a16="http://schemas.microsoft.com/office/drawing/2014/main" id="{9FC74C2D-7AA5-41EB-856F-5FCECD09E6CD}"/>
               </a:ext>
             </a:extLst>
           </p:cNvPr>
@@ -19627,7 +19627,7 @@
           <p:cNvPr id="18" name="synth-right-v">
             <a:extLst xmlns:a="http://schemas.openxmlformats.org/drawingml/2006/main">
               <a:ext uri="{FF2B5EF4-FFF2-40B4-BE49-F238E27FC236}">
-                <a16:creationId xmlns:a16="http://schemas.microsoft.com/office/drawing/2014/main" id="{F40F0917-7CB4-4D39-94B3-327537BAACF2}"/>
+                <a16:creationId xmlns:a16="http://schemas.microsoft.com/office/drawing/2014/main" id="{E8A91F2A-C5DB-4E71-BCC5-5EF03D38996E}"/>
               </a:ext>
             </a:extLst>
           </p:cNvPr>
@@ -19711,7 +19711,7 @@
           <p:cNvPr id="19" name="synth-hash">
             <a:extLst xmlns:a="http://schemas.openxmlformats.org/drawingml/2006/main">
               <a:ext uri="{FF2B5EF4-FFF2-40B4-BE49-F238E27FC236}">
-                <a16:creationId xmlns:a16="http://schemas.microsoft.com/office/drawing/2014/main" id="{FBE6BD74-65FA-4192-B6DB-7D7E6F1441C0}"/>
+                <a16:creationId xmlns:a16="http://schemas.microsoft.com/office/drawing/2014/main" id="{85C966BD-C507-43EB-B5A2-98B9E59C7B95}"/>
               </a:ext>
             </a:extLst>
           </p:cNvPr>
@@ -19759,7 +19759,7 @@
     </p:spTree>
     <p:extLst>
       <p:ext uri="{BB962C8B-B14F-4D97-AF65-F5344CB8AC3E}">
-        <p14:creationId xmlns:p14="http://schemas.microsoft.com/office/powerpoint/2010/main" val="1658170826"/>
+        <p14:creationId xmlns:p14="http://schemas.microsoft.com/office/powerpoint/2010/main" val="1387776807"/>
       </p:ext>
     </p:extLst>
   </p:cSld>

</xml_diff>

<commit_message>
feat(agentQwen): add audited official GRPO curriculum
</commit_message>
<xml_diff>
--- a/agentQwen/slides/AgenticQwen_Curriculum_Cloud.pptx
+++ b/agentQwen/slides/AgenticQwen_Curriculum_Cloud.pptx
@@ -2,28 +2,28 @@
 <file path=ppt/presentation.xml><?xml version="1.0" encoding="utf-8"?>
 <p:presentation xmlns:p="http://schemas.openxmlformats.org/presentationml/2006/main">
   <p:sldMasterIdLst>
-    <p:sldMasterId xmlns:r="http://schemas.openxmlformats.org/officeDocument/2006/relationships" id="2147483648" r:id="Rea7945ff65214b83"/>
+    <p:sldMasterId xmlns:r="http://schemas.openxmlformats.org/officeDocument/2006/relationships" id="2147483648" r:id="Rd4d97c303ec746d2"/>
   </p:sldMasterIdLst>
   <p:notesMasterIdLst>
-    <p:notesMasterId xmlns:r="http://schemas.openxmlformats.org/officeDocument/2006/relationships" r:id="R4d1d0244504e4682"/>
+    <p:notesMasterId xmlns:r="http://schemas.openxmlformats.org/officeDocument/2006/relationships" r:id="Rf9abbe40be764e7e"/>
   </p:notesMasterIdLst>
   <p:sldIdLst>
-    <p:sldId xmlns:r="http://schemas.openxmlformats.org/officeDocument/2006/relationships" id="256" r:id="R606b404bc82f43b0"/>
-    <p:sldId xmlns:r="http://schemas.openxmlformats.org/officeDocument/2006/relationships" id="257" r:id="R5304f1ad7f244320"/>
-    <p:sldId xmlns:r="http://schemas.openxmlformats.org/officeDocument/2006/relationships" id="258" r:id="Rdf3e6f09db9147b4"/>
-    <p:sldId xmlns:r="http://schemas.openxmlformats.org/officeDocument/2006/relationships" id="259" r:id="R6386e4396efc49e1"/>
-    <p:sldId xmlns:r="http://schemas.openxmlformats.org/officeDocument/2006/relationships" id="260" r:id="R1eba2ba32150480e"/>
-    <p:sldId xmlns:r="http://schemas.openxmlformats.org/officeDocument/2006/relationships" id="261" r:id="R6071695009bc4d4f"/>
-    <p:sldId xmlns:r="http://schemas.openxmlformats.org/officeDocument/2006/relationships" id="262" r:id="Ra47d4c59e78b4f36"/>
-    <p:sldId xmlns:r="http://schemas.openxmlformats.org/officeDocument/2006/relationships" id="263" r:id="R55c9d5de37cc42e5"/>
-    <p:sldId xmlns:r="http://schemas.openxmlformats.org/officeDocument/2006/relationships" id="264" r:id="R3b516797b71043ce"/>
-    <p:sldId xmlns:r="http://schemas.openxmlformats.org/officeDocument/2006/relationships" id="265" r:id="R1ab56bd3df44479b"/>
-    <p:sldId xmlns:r="http://schemas.openxmlformats.org/officeDocument/2006/relationships" id="266" r:id="Ra47422d5456a4345"/>
-    <p:sldId xmlns:r="http://schemas.openxmlformats.org/officeDocument/2006/relationships" id="267" r:id="R2fe78f62c9d745ee"/>
-    <p:sldId xmlns:r="http://schemas.openxmlformats.org/officeDocument/2006/relationships" id="268" r:id="Ra78fc8d3dd184f4c"/>
-    <p:sldId xmlns:r="http://schemas.openxmlformats.org/officeDocument/2006/relationships" id="269" r:id="R47642ecfba7f4a6f"/>
-    <p:sldId xmlns:r="http://schemas.openxmlformats.org/officeDocument/2006/relationships" id="270" r:id="R921d96d02d9849a7"/>
-    <p:sldId xmlns:r="http://schemas.openxmlformats.org/officeDocument/2006/relationships" id="271" r:id="R18bb3c58be2148fe"/>
+    <p:sldId xmlns:r="http://schemas.openxmlformats.org/officeDocument/2006/relationships" id="256" r:id="R3f90ea4fda104249"/>
+    <p:sldId xmlns:r="http://schemas.openxmlformats.org/officeDocument/2006/relationships" id="257" r:id="R463206e1e93c4be3"/>
+    <p:sldId xmlns:r="http://schemas.openxmlformats.org/officeDocument/2006/relationships" id="258" r:id="R310549ad93e14db4"/>
+    <p:sldId xmlns:r="http://schemas.openxmlformats.org/officeDocument/2006/relationships" id="259" r:id="R948d2b514a1a487d"/>
+    <p:sldId xmlns:r="http://schemas.openxmlformats.org/officeDocument/2006/relationships" id="260" r:id="R259a62b3149240a3"/>
+    <p:sldId xmlns:r="http://schemas.openxmlformats.org/officeDocument/2006/relationships" id="261" r:id="Rc6c034c837a14ba0"/>
+    <p:sldId xmlns:r="http://schemas.openxmlformats.org/officeDocument/2006/relationships" id="262" r:id="Re3f4c510dc364c13"/>
+    <p:sldId xmlns:r="http://schemas.openxmlformats.org/officeDocument/2006/relationships" id="263" r:id="Rb6b1f8ec3fe447fc"/>
+    <p:sldId xmlns:r="http://schemas.openxmlformats.org/officeDocument/2006/relationships" id="264" r:id="R2a2a6b5fab234b81"/>
+    <p:sldId xmlns:r="http://schemas.openxmlformats.org/officeDocument/2006/relationships" id="265" r:id="R16190909563c4309"/>
+    <p:sldId xmlns:r="http://schemas.openxmlformats.org/officeDocument/2006/relationships" id="266" r:id="R5fb1764b6b214a70"/>
+    <p:sldId xmlns:r="http://schemas.openxmlformats.org/officeDocument/2006/relationships" id="267" r:id="Rc0356b2d9d2c41d4"/>
+    <p:sldId xmlns:r="http://schemas.openxmlformats.org/officeDocument/2006/relationships" id="268" r:id="R1dcfb5e0c93849e0"/>
+    <p:sldId xmlns:r="http://schemas.openxmlformats.org/officeDocument/2006/relationships" id="269" r:id="Rdb819213c59c41d0"/>
+    <p:sldId xmlns:r="http://schemas.openxmlformats.org/officeDocument/2006/relationships" id="270" r:id="R66db5e98db7d4e24"/>
+    <p:sldId xmlns:r="http://schemas.openxmlformats.org/officeDocument/2006/relationships" id="271" r:id="Rb7f60f6f907c4549"/>
   </p:sldIdLst>
   <p:sldSz cx="12192000" cy="6858000"/>
   <p:notesSz cx="6858000" cy="9144000"/>
@@ -472,12 +472,12 @@
           </a:p>
           <a:p xmlns:a="http://schemas.openxmlformats.org/drawingml/2006/main">
             <a:r>
-              <a:t>- /Users/hongbo/Documents/Codex/2026-08-02/https-yyhdbl-github-io/outputs/agenticqwen-reproduction/artifacts/cloud_runs/qwen3-8b-qlora-20260804-v2/evidence/run_summary.json</a:t>
-            </a:r>
-          </a:p>
-          <a:p xmlns:a="http://schemas.openxmlformats.org/drawingml/2006/main">
-            <a:r>
-              <a:t>- /Users/hongbo/Documents/Codex/2026-08-02/https-yyhdbl-github-io/outputs/agenticqwen-reproduction/artifacts/cloud_runs/qwen3-8b-qlora-20260804-v2/evidence/verification.json</a:t>
+              <a:t>- /Users/hongbo/Documents/Codex/2026-08-02/https-yyhdbl-github-io/outputs/agenticqwen-reproduction/artifacts/cloud_codelab/agenticqwen_codelab_curriculum_run1/run_summary.json</a:t>
+            </a:r>
+          </a:p>
+          <a:p xmlns:a="http://schemas.openxmlformats.org/drawingml/2006/main">
+            <a:r>
+              <a:t>- /Users/hongbo/Documents/Codex/2026-08-02/https-yyhdbl-github-io/outputs/agenticqwen-reproduction/artifacts/cloud_codelab/agenticqwen_codelab_curriculum_run1/verification.json</a:t>
             </a:r>
           </a:p>
           <a:p xmlns:a="http://schemas.openxmlformats.org/drawingml/2006/main">
@@ -572,12 +572,12 @@
           </a:p>
           <a:p xmlns:a="http://schemas.openxmlformats.org/drawingml/2006/main">
             <a:r>
-              <a:t>- /Users/hongbo/Documents/Codex/2026-08-02/https-yyhdbl-github-io/outputs/agenticqwen-reproduction/artifacts/cloud_runs/qwen3-8b-qlora-20260804-v2/evidence/stage2/summary.json</a:t>
-            </a:r>
-          </a:p>
-          <a:p xmlns:a="http://schemas.openxmlformats.org/drawingml/2006/main">
-            <a:r>
-              <a:t>- /Users/hongbo/Documents/Codex/2026-08-02/https-yyhdbl-github-io/outputs/agenticqwen-reproduction/artifacts/cloud_runs/qwen3-8b-qlora-20260804-v2/evidence/fresh_replay/summary.json</a:t>
+              <a:t>- /Users/hongbo/Documents/Codex/2026-08-02/https-yyhdbl-github-io/outputs/agenticqwen-reproduction/artifacts/cloud_codelab/agenticqwen_codelab_curriculum_run1/stage2/summary.json</a:t>
+            </a:r>
+          </a:p>
+          <a:p xmlns:a="http://schemas.openxmlformats.org/drawingml/2006/main">
+            <a:r>
+              <a:t>- /Users/hongbo/Documents/Codex/2026-08-02/https-yyhdbl-github-io/outputs/agenticqwen-reproduction/artifacts/cloud_codelab/agenticqwen_codelab_curriculum_run1/fresh_replay/summary.json</a:t>
             </a:r>
           </a:p>
           <a:p xmlns:a="http://schemas.openxmlformats.org/drawingml/2006/main">
@@ -667,7 +667,7 @@
           </a:p>
           <a:p xmlns:a="http://schemas.openxmlformats.org/drawingml/2006/main">
             <a:r>
-              <a:t>- /Users/hongbo/Documents/Codex/2026-08-02/https-yyhdbl-github-io/outputs/agenticqwen-reproduction/artifacts/cloud_runs/qwen3-8b-qlora-20260804-v2/evidence/stage2/eval_final_traces.jsonl</a:t>
+              <a:t>- /Users/hongbo/Documents/Codex/2026-08-02/https-yyhdbl-github-io/outputs/agenticqwen-reproduction/artifacts/cloud_codelab/agenticqwen_codelab_curriculum_run1/stage2/eval_final_traces.jsonl</a:t>
             </a:r>
           </a:p>
           <a:p xmlns:a="http://schemas.openxmlformats.org/drawingml/2006/main">
@@ -742,7 +742,7 @@
           <a:lstStyle xmlns:a="http://schemas.openxmlformats.org/drawingml/2006/main"/>
           <a:p xmlns:a="http://schemas.openxmlformats.org/drawingml/2006/main">
             <a:r>
-              <a:t>这页主动声明 BFCL 未运行；代码就绪不等于实验完成。</a:t>
+              <a:t>这页区分官方 evaluator 流水线是否成功与模型实际得分；本次四类 smoke 的 base 和 Stage-2 得分均为 0.00%。</a:t>
             </a:r>
           </a:p>
           <a:p xmlns:a="http://schemas.openxmlformats.org/drawingml/2006/main">
@@ -758,6 +758,11 @@
           <a:p xmlns:a="http://schemas.openxmlformats.org/drawingml/2006/main">
             <a:r>
               <a:t>- /Users/hongbo/Documents/Codex/2026-08-02/https-yyhdbl-github-io/outputs/agenticqwen-reproduction/docs/benchmark_protocol.md</a:t>
+            </a:r>
+          </a:p>
+          <a:p xmlns:a="http://schemas.openxmlformats.org/drawingml/2006/main">
+            <a:r>
+              <a:t>- /Users/hongbo/Documents/Codex/2026-08-02/https-yyhdbl-github-io/outputs/agenticqwen-reproduction/artifacts/cloud_codelab/agenticqwen_codelab_curriculum_run1/benchmarks/bfcl_smoke/manifest.json</a:t>
             </a:r>
           </a:p>
           <a:p xmlns:a="http://schemas.openxmlformats.org/drawingml/2006/main">
@@ -852,17 +857,17 @@
           </a:p>
           <a:p xmlns:a="http://schemas.openxmlformats.org/drawingml/2006/main">
             <a:r>
-              <a:t>- /Users/hongbo/Documents/Codex/2026-08-02/https-yyhdbl-github-io/outputs/agenticqwen-reproduction/artifacts/cloud_runs/qwen3-8b-qlora-20260804-v2/evidence/verification.json</a:t>
-            </a:r>
-          </a:p>
-          <a:p xmlns:a="http://schemas.openxmlformats.org/drawingml/2006/main">
-            <a:r>
-              <a:t>- /Users/hongbo/Documents/Codex/2026-08-02/https-yyhdbl-github-io/outputs/agenticqwen-reproduction/artifacts/cloud_runs/qwen3-8b-qlora-20260804-v2/evidence/stage1/summary.json</a:t>
-            </a:r>
-          </a:p>
-          <a:p xmlns:a="http://schemas.openxmlformats.org/drawingml/2006/main">
-            <a:r>
-              <a:t>- /Users/hongbo/Documents/Codex/2026-08-02/https-yyhdbl-github-io/outputs/agenticqwen-reproduction/artifacts/cloud_runs/qwen3-8b-qlora-20260804-v2/evidence/stage2/summary.json</a:t>
+              <a:t>- /Users/hongbo/Documents/Codex/2026-08-02/https-yyhdbl-github-io/outputs/agenticqwen-reproduction/artifacts/cloud_codelab/agenticqwen_codelab_curriculum_run1/verification.json</a:t>
+            </a:r>
+          </a:p>
+          <a:p xmlns:a="http://schemas.openxmlformats.org/drawingml/2006/main">
+            <a:r>
+              <a:t>- /Users/hongbo/Documents/Codex/2026-08-02/https-yyhdbl-github-io/outputs/agenticqwen-reproduction/artifacts/cloud_codelab/agenticqwen_codelab_curriculum_run1/stage1/summary.json</a:t>
+            </a:r>
+          </a:p>
+          <a:p xmlns:a="http://schemas.openxmlformats.org/drawingml/2006/main">
+            <a:r>
+              <a:t>- /Users/hongbo/Documents/Codex/2026-08-02/https-yyhdbl-github-io/outputs/agenticqwen-reproduction/artifacts/cloud_codelab/agenticqwen_codelab_curriculum_run1/stage2/summary.json</a:t>
             </a:r>
           </a:p>
           <a:p xmlns:a="http://schemas.openxmlformats.org/drawingml/2006/main">
@@ -952,7 +957,7 @@
           </a:p>
           <a:p xmlns:a="http://schemas.openxmlformats.org/drawingml/2006/main">
             <a:r>
-              <a:t>- /Users/hongbo/Documents/Codex/2026-08-02/https-yyhdbl-github-io/outputs/agenticqwen-reproduction/artifacts/cloud_runs/qwen3-8b-qlora-20260804-v2/evidence/run_summary.json</a:t>
+              <a:t>- /Users/hongbo/Documents/Codex/2026-08-02/https-yyhdbl-github-io/outputs/agenticqwen-reproduction/artifacts/cloud_codelab/agenticqwen_codelab_curriculum_run1/run_summary.json</a:t>
             </a:r>
           </a:p>
           <a:p xmlns:a="http://schemas.openxmlformats.org/drawingml/2006/main">
@@ -1052,7 +1057,7 @@
           </a:p>
           <a:p xmlns:a="http://schemas.openxmlformats.org/drawingml/2006/main">
             <a:r>
-              <a:t>- /Users/hongbo/Documents/Codex/2026-08-02/https-yyhdbl-github-io/outputs/agenticqwen-reproduction/artifacts/cloud_runs/qwen3-8b-qlora-20260804-v2/evidence/stage2/synthesis_manifest.json</a:t>
+              <a:t>- /Users/hongbo/Documents/Codex/2026-08-02/https-yyhdbl-github-io/outputs/agenticqwen-reproduction/artifacts/cloud_codelab/agenticqwen_codelab_curriculum_run1/stage2/synthesis_manifest.json</a:t>
             </a:r>
           </a:p>
           <a:p xmlns:a="http://schemas.openxmlformats.org/drawingml/2006/main">
@@ -1142,7 +1147,7 @@
           </a:p>
           <a:p xmlns:a="http://schemas.openxmlformats.org/drawingml/2006/main">
             <a:r>
-              <a:t>- /Users/hongbo/Documents/Codex/2026-08-02/https-yyhdbl-github-io/outputs/agenticqwen-reproduction/artifacts/cloud_runs/qwen3-8b-qlora-20260804-v2/evidence/verification.json</a:t>
+              <a:t>- /Users/hongbo/Documents/Codex/2026-08-02/https-yyhdbl-github-io/outputs/agenticqwen-reproduction/artifacts/cloud_codelab/agenticqwen_codelab_curriculum_run1/verification.json</a:t>
             </a:r>
           </a:p>
           <a:p xmlns:a="http://schemas.openxmlformats.org/drawingml/2006/main">
@@ -1242,7 +1247,7 @@
           </a:p>
           <a:p xmlns:a="http://schemas.openxmlformats.org/drawingml/2006/main">
             <a:r>
-              <a:t>- /Users/hongbo/Documents/Codex/2026-08-02/https-yyhdbl-github-io/outputs/agenticqwen-reproduction/artifacts/cloud_runs/qwen3-8b-qlora-20260804-v2/evidence/resolved_config.json</a:t>
+              <a:t>- /Users/hongbo/Documents/Codex/2026-08-02/https-yyhdbl-github-io/outputs/agenticqwen-reproduction/artifacts/cloud_codelab/agenticqwen_codelab_curriculum_run1/resolved_config.json</a:t>
             </a:r>
           </a:p>
           <a:p xmlns:a="http://schemas.openxmlformats.org/drawingml/2006/main">
@@ -1337,7 +1342,7 @@
           </a:p>
           <a:p xmlns:a="http://schemas.openxmlformats.org/drawingml/2006/main">
             <a:r>
-              <a:t>- /Users/hongbo/Documents/Codex/2026-08-02/https-yyhdbl-github-io/outputs/agenticqwen-reproduction/artifacts/cloud_runs/qwen3-8b-qlora-20260804-v2/evidence/resolved_config.json</a:t>
+              <a:t>- /Users/hongbo/Documents/Codex/2026-08-02/https-yyhdbl-github-io/outputs/agenticqwen-reproduction/artifacts/cloud_codelab/agenticqwen_codelab_curriculum_run1/resolved_config.json</a:t>
             </a:r>
           </a:p>
           <a:p xmlns:a="http://schemas.openxmlformats.org/drawingml/2006/main">
@@ -1612,7 +1617,7 @@
           </a:p>
           <a:p xmlns:a="http://schemas.openxmlformats.org/drawingml/2006/main">
             <a:r>
-              <a:t>- /Users/hongbo/Documents/Codex/2026-08-02/https-yyhdbl-github-io/outputs/agenticqwen-reproduction/artifacts/cloud_runs/qwen3-8b-qlora-20260804-v2/evidence/resolved_config.json</a:t>
+              <a:t>- /Users/hongbo/Documents/Codex/2026-08-02/https-yyhdbl-github-io/outputs/agenticqwen-reproduction/artifacts/cloud_codelab/agenticqwen_codelab_curriculum_run1/resolved_config.json</a:t>
             </a:r>
           </a:p>
           <a:p xmlns:a="http://schemas.openxmlformats.org/drawingml/2006/main">
@@ -1707,7 +1712,7 @@
           </a:p>
           <a:p xmlns:a="http://schemas.openxmlformats.org/drawingml/2006/main">
             <a:r>
-              <a:t>- /Users/hongbo/Documents/Codex/2026-08-02/https-yyhdbl-github-io/outputs/agenticqwen-reproduction/artifacts/cloud_runs/qwen3-8b-qlora-20260804-v2/evidence/stage2/synthesis_manifest.json</a:t>
+              <a:t>- /Users/hongbo/Documents/Codex/2026-08-02/https-yyhdbl-github-io/outputs/agenticqwen-reproduction/artifacts/cloud_codelab/agenticqwen_codelab_curriculum_run1/stage2/synthesis_manifest.json</a:t>
             </a:r>
           </a:p>
           <a:p xmlns:a="http://schemas.openxmlformats.org/drawingml/2006/main">
@@ -1797,12 +1802,12 @@
           </a:p>
           <a:p xmlns:a="http://schemas.openxmlformats.org/drawingml/2006/main">
             <a:r>
-              <a:t>- /Users/hongbo/Documents/Codex/2026-08-02/https-yyhdbl-github-io/outputs/agenticqwen-reproduction/artifacts/cloud_runs/qwen3-8b-qlora-20260804-v2/evidence/stage1/summary.json</a:t>
-            </a:r>
-          </a:p>
-          <a:p xmlns:a="http://schemas.openxmlformats.org/drawingml/2006/main">
-            <a:r>
-              <a:t>- /Users/hongbo/Documents/Codex/2026-08-02/https-yyhdbl-github-io/outputs/agenticqwen-reproduction/artifacts/cloud_runs/qwen3-8b-qlora-20260804-v2/evidence/stage1/eval_probe_traces.jsonl</a:t>
+              <a:t>- /Users/hongbo/Documents/Codex/2026-08-02/https-yyhdbl-github-io/outputs/agenticqwen-reproduction/artifacts/cloud_codelab/agenticqwen_codelab_curriculum_run1/stage1/summary.json</a:t>
+            </a:r>
+          </a:p>
+          <a:p xmlns:a="http://schemas.openxmlformats.org/drawingml/2006/main">
+            <a:r>
+              <a:t>- /Users/hongbo/Documents/Codex/2026-08-02/https-yyhdbl-github-io/outputs/agenticqwen-reproduction/artifacts/cloud_codelab/agenticqwen_codelab_curriculum_run1/stage1/eval_probe_traces.jsonl</a:t>
             </a:r>
           </a:p>
           <a:p xmlns:a="http://schemas.openxmlformats.org/drawingml/2006/main">
@@ -1892,12 +1897,12 @@
           </a:p>
           <a:p xmlns:a="http://schemas.openxmlformats.org/drawingml/2006/main">
             <a:r>
-              <a:t>- /Users/hongbo/Documents/Codex/2026-08-02/https-yyhdbl-github-io/outputs/agenticqwen-reproduction/artifacts/cloud_runs/qwen3-8b-qlora-20260804-v2/evidence/stage2/synthesis_manifest.json</a:t>
-            </a:r>
-          </a:p>
-          <a:p xmlns:a="http://schemas.openxmlformats.org/drawingml/2006/main">
-            <a:r>
-              <a:t>- /Users/hongbo/Documents/Codex/2026-08-02/https-yyhdbl-github-io/outputs/agenticqwen-reproduction/artifacts/cloud_runs/qwen3-8b-qlora-20260804-v2/evidence/tasks/stage2_hard.jsonl</a:t>
+              <a:t>- /Users/hongbo/Documents/Codex/2026-08-02/https-yyhdbl-github-io/outputs/agenticqwen-reproduction/artifacts/cloud_codelab/agenticqwen_codelab_curriculum_run1/stage2/synthesis_manifest.json</a:t>
+            </a:r>
+          </a:p>
+          <a:p xmlns:a="http://schemas.openxmlformats.org/drawingml/2006/main">
+            <a:r>
+              <a:t>- /Users/hongbo/Documents/Codex/2026-08-02/https-yyhdbl-github-io/outputs/agenticqwen-reproduction/artifacts/cloud_codelab/agenticqwen_codelab_curriculum_run1/tasks/stage2_hard.jsonl</a:t>
             </a:r>
           </a:p>
           <a:p xmlns:a="http://schemas.openxmlformats.org/drawingml/2006/main">
@@ -1970,7 +1975,7 @@
   </p:cSld>
   <p:clrMap bg1="lt1" tx1="dk1" bg2="lt2" tx2="dk2" accent1="accent1" accent2="accent2" accent3="accent3" accent4="accent4" accent5="accent5" accent6="accent6" hlink="hlink" folHlink="folHlink"/>
   <p:sldLayoutIdLst>
-    <p:sldLayoutId xmlns:r="http://schemas.openxmlformats.org/officeDocument/2006/relationships" id="2147483649" r:id="R6db9c6a7199c4d5c"/>
+    <p:sldLayoutId xmlns:r="http://schemas.openxmlformats.org/officeDocument/2006/relationships" id="2147483649" r:id="R257f05dd88e54d27"/>
   </p:sldLayoutIdLst>
   <p:txStyles>
     <p:titleStyle>
@@ -2521,7 +2526,7 @@
           <p:cNvPr id="14" name="cover-copper">
             <a:extLst xmlns:a="http://schemas.openxmlformats.org/drawingml/2006/main">
               <a:ext uri="{FF2B5EF4-FFF2-40B4-BE49-F238E27FC236}">
-                <a16:creationId xmlns:a16="http://schemas.microsoft.com/office/drawing/2014/main" id="{0A22D651-C953-4AA3-8B6B-FD46006DCBF9}"/>
+                <a16:creationId xmlns:a16="http://schemas.microsoft.com/office/drawing/2014/main" id="{70F142B6-09EE-453A-AE77-577EAE9A4B0C}"/>
               </a:ext>
             </a:extLst>
           </p:cNvPr>
@@ -2554,7 +2559,7 @@
           <p:cNvPr id="2" name="cover-teal">
             <a:extLst xmlns:a="http://schemas.openxmlformats.org/drawingml/2006/main">
               <a:ext uri="{FF2B5EF4-FFF2-40B4-BE49-F238E27FC236}">
-                <a16:creationId xmlns:a16="http://schemas.microsoft.com/office/drawing/2014/main" id="{49CE55D6-4171-46E4-BE59-06099F83191A}"/>
+                <a16:creationId xmlns:a16="http://schemas.microsoft.com/office/drawing/2014/main" id="{D5884193-99D2-43C6-8964-033BBF0D043A}"/>
               </a:ext>
             </a:extLst>
           </p:cNvPr>
@@ -2587,7 +2592,7 @@
           <p:cNvPr id="3" name="cover-flourish">
             <a:extLst xmlns:a="http://schemas.openxmlformats.org/drawingml/2006/main">
               <a:ext uri="{FF2B5EF4-FFF2-40B4-BE49-F238E27FC236}">
-                <a16:creationId xmlns:a16="http://schemas.microsoft.com/office/drawing/2014/main" id="{329A963F-16F5-475C-9955-641A23D848A1}"/>
+                <a16:creationId xmlns:a16="http://schemas.microsoft.com/office/drawing/2014/main" id="{C11CDDC1-FCE8-4970-BD06-7E14E27A8460}"/>
               </a:ext>
             </a:extLst>
           </p:cNvPr>
@@ -2637,7 +2642,7 @@
           <p:cNvPr id="4" name="">
             <a:extLst xmlns:a="http://schemas.openxmlformats.org/drawingml/2006/main">
               <a:ext uri="{FF2B5EF4-FFF2-40B4-BE49-F238E27FC236}">
-                <a16:creationId xmlns:a16="http://schemas.microsoft.com/office/drawing/2014/main" id="{48ECE487-E945-4785-93F3-F2EC23CB5042}"/>
+                <a16:creationId xmlns:a16="http://schemas.microsoft.com/office/drawing/2014/main" id="{804EF941-9178-4238-A5B4-FF5CC0345151}"/>
               </a:ext>
             </a:extLst>
           </p:cNvPr>
@@ -2668,7 +2673,7 @@
           <p:cNvPr id="5" name="cover-title">
             <a:extLst xmlns:a="http://schemas.openxmlformats.org/drawingml/2006/main">
               <a:ext uri="{FF2B5EF4-FFF2-40B4-BE49-F238E27FC236}">
-                <a16:creationId xmlns:a16="http://schemas.microsoft.com/office/drawing/2014/main" id="{2BE12064-07AB-4A46-B19A-DD6A9B73CE50}"/>
+                <a16:creationId xmlns:a16="http://schemas.microsoft.com/office/drawing/2014/main" id="{94D3E510-7687-45D0-9E27-822B7EA9E3DB}"/>
               </a:ext>
             </a:extLst>
           </p:cNvPr>
@@ -2743,7 +2748,7 @@
           <p:cNvPr id="6" name="cover-sub">
             <a:extLst xmlns:a="http://schemas.openxmlformats.org/drawingml/2006/main">
               <a:ext uri="{FF2B5EF4-FFF2-40B4-BE49-F238E27FC236}">
-                <a16:creationId xmlns:a16="http://schemas.microsoft.com/office/drawing/2014/main" id="{FD6DC556-103D-4CA0-B414-993B23B9624A}"/>
+                <a16:creationId xmlns:a16="http://schemas.microsoft.com/office/drawing/2014/main" id="{58CE585B-E19A-4696-B794-3B4066871B27}"/>
               </a:ext>
             </a:extLst>
           </p:cNvPr>
@@ -2793,7 +2798,7 @@
           <p:cNvPr id="7" name="cover-meta">
             <a:extLst xmlns:a="http://schemas.openxmlformats.org/drawingml/2006/main">
               <a:ext uri="{FF2B5EF4-FFF2-40B4-BE49-F238E27FC236}">
-                <a16:creationId xmlns:a16="http://schemas.microsoft.com/office/drawing/2014/main" id="{190ECAE5-CA11-4C20-95A2-CC3FC57B23AA}"/>
+                <a16:creationId xmlns:a16="http://schemas.microsoft.com/office/drawing/2014/main" id="{B677DFE2-75A8-4E10-8909-EC2C75594C48}"/>
               </a:ext>
             </a:extLst>
           </p:cNvPr>
@@ -2833,7 +2838,7 @@
                   <a:srgbClr val="ADC3CC"/>
                 </a:solidFill>
               </a:rPr>
-              <a:t>Qwen3-8B · response-token QLoRA-GRPO · NVIDIA RTX PRO 6000 Blackwell Server Edition</a:t>
+              <a:t>Qwen3-8B · response-token QLoRA-GRPO · NVIDIA H200</a:t>
             </a:r>
           </a:p>
           <a:p xmlns:a="http://schemas.openxmlformats.org/drawingml/2006/main">
@@ -2850,7 +2855,7 @@
                   <a:srgbClr val="ADC3CC"/>
                 </a:solidFill>
               </a:rPr>
-              <a:t>/root/autodl-tmp/runs/agenticqwen-qwen3-8b-qlora-v2/qwen3-8b-qlora-20260804-v2</a:t>
+              <a:t>/home/hadoop-aipnlp/agenticqwen-paper-debug-20260804/artifacts/agenticqwen_codelab_curriculum_run1</a:t>
             </a:r>
           </a:p>
         </p:txBody>
@@ -2860,7 +2865,7 @@
           <p:cNvPr id="8" name="cover-02">
             <a:extLst xmlns:a="http://schemas.openxmlformats.org/drawingml/2006/main">
               <a:ext uri="{FF2B5EF4-FFF2-40B4-BE49-F238E27FC236}">
-                <a16:creationId xmlns:a16="http://schemas.microsoft.com/office/drawing/2014/main" id="{4D8F7612-4D96-4C56-9588-82C25A0DBFAE}"/>
+                <a16:creationId xmlns:a16="http://schemas.microsoft.com/office/drawing/2014/main" id="{DA0CB03C-4ABF-4476-B5C9-9480A9490460}"/>
               </a:ext>
             </a:extLst>
           </p:cNvPr>
@@ -2910,7 +2915,7 @@
           <p:cNvPr id="9" name="cover-side">
             <a:extLst xmlns:a="http://schemas.openxmlformats.org/drawingml/2006/main">
               <a:ext uri="{FF2B5EF4-FFF2-40B4-BE49-F238E27FC236}">
-                <a16:creationId xmlns:a16="http://schemas.microsoft.com/office/drawing/2014/main" id="{88CF6F2D-DDCF-4103-8C53-8A5EC7B7F9E5}"/>
+                <a16:creationId xmlns:a16="http://schemas.microsoft.com/office/drawing/2014/main" id="{3A33E0A3-51A6-4F1A-8BC5-A20FC35E1523}"/>
               </a:ext>
             </a:extLst>
           </p:cNvPr>
@@ -3006,7 +3011,7 @@
           <p:cNvPr id="10" name="cover-pass-bg">
             <a:extLst xmlns:a="http://schemas.openxmlformats.org/drawingml/2006/main">
               <a:ext uri="{FF2B5EF4-FFF2-40B4-BE49-F238E27FC236}">
-                <a16:creationId xmlns:a16="http://schemas.microsoft.com/office/drawing/2014/main" id="{7C624002-72A8-4741-A747-887E4B2DF06A}"/>
+                <a16:creationId xmlns:a16="http://schemas.microsoft.com/office/drawing/2014/main" id="{87FEE3B0-DBBD-4175-8D22-F0FD5F2792BD}"/>
               </a:ext>
             </a:extLst>
           </p:cNvPr>
@@ -3041,7 +3046,7 @@
           <p:cNvPr id="11" name="cover-pass-text">
             <a:extLst xmlns:a="http://schemas.openxmlformats.org/drawingml/2006/main">
               <a:ext uri="{FF2B5EF4-FFF2-40B4-BE49-F238E27FC236}">
-                <a16:creationId xmlns:a16="http://schemas.microsoft.com/office/drawing/2014/main" id="{A6EF7121-366E-47E7-9846-21B7248D1002}"/>
+                <a16:creationId xmlns:a16="http://schemas.microsoft.com/office/drawing/2014/main" id="{07B1B00A-B3AF-43F4-A9EA-591F35A1CF8B}"/>
               </a:ext>
             </a:extLst>
           </p:cNvPr>
@@ -3091,7 +3096,7 @@
           <p:cNvPr id="12" name="cover-bfcl-bg">
             <a:extLst xmlns:a="http://schemas.openxmlformats.org/drawingml/2006/main">
               <a:ext uri="{FF2B5EF4-FFF2-40B4-BE49-F238E27FC236}">
-                <a16:creationId xmlns:a16="http://schemas.microsoft.com/office/drawing/2014/main" id="{BD518565-72C8-47F3-A5E0-0058D4AB7837}"/>
+                <a16:creationId xmlns:a16="http://schemas.microsoft.com/office/drawing/2014/main" id="{2AFDCC2C-6D57-4939-8D34-516A420FCFA0}"/>
               </a:ext>
             </a:extLst>
           </p:cNvPr>
@@ -3126,7 +3131,7 @@
           <p:cNvPr id="13" name="cover-bfcl-text">
             <a:extLst xmlns:a="http://schemas.openxmlformats.org/drawingml/2006/main">
               <a:ext uri="{FF2B5EF4-FFF2-40B4-BE49-F238E27FC236}">
-                <a16:creationId xmlns:a16="http://schemas.microsoft.com/office/drawing/2014/main" id="{48714DF7-2C3A-4E5A-8E5B-174FB3BB3C30}"/>
+                <a16:creationId xmlns:a16="http://schemas.microsoft.com/office/drawing/2014/main" id="{9D88E7DB-6E53-414F-AE75-D7C57A9C943A}"/>
               </a:ext>
             </a:extLst>
           </p:cNvPr>
@@ -3166,7 +3171,7 @@
                   <a:srgbClr val="FFFFFF"/>
                 </a:solidFill>
               </a:rPr>
-              <a:t>BFCL NOT RUN</a:t>
+              <a:t>BFCL PASS</a:t>
             </a:r>
           </a:p>
         </p:txBody>
@@ -3174,7 +3179,7 @@
     </p:spTree>
     <p:extLst>
       <p:ext uri="{BB962C8B-B14F-4D97-AF65-F5344CB8AC3E}">
-        <p14:creationId xmlns:p14="http://schemas.microsoft.com/office/powerpoint/2010/main" val="610844466"/>
+        <p14:creationId xmlns:p14="http://schemas.microsoft.com/office/powerpoint/2010/main" val="672282592"/>
       </p:ext>
     </p:extLst>
   </p:cSld>
@@ -3205,7 +3210,7 @@
           <p:cNvPr id="32" name="rail-10">
             <a:extLst xmlns:a="http://schemas.openxmlformats.org/drawingml/2006/main">
               <a:ext uri="{FF2B5EF4-FFF2-40B4-BE49-F238E27FC236}">
-                <a16:creationId xmlns:a16="http://schemas.microsoft.com/office/drawing/2014/main" id="{C6B19692-0D44-419A-AB27-8714EF4BEA90}"/>
+                <a16:creationId xmlns:a16="http://schemas.microsoft.com/office/drawing/2014/main" id="{846E9163-1072-483F-A031-D76EB4027C97}"/>
               </a:ext>
             </a:extLst>
           </p:cNvPr>
@@ -3238,7 +3243,7 @@
           <p:cNvPr id="2" name="flourish-10">
             <a:extLst xmlns:a="http://schemas.openxmlformats.org/drawingml/2006/main">
               <a:ext uri="{FF2B5EF4-FFF2-40B4-BE49-F238E27FC236}">
-                <a16:creationId xmlns:a16="http://schemas.microsoft.com/office/drawing/2014/main" id="{E00154BE-B5CE-491C-A6FF-7810EE3B352C}"/>
+                <a16:creationId xmlns:a16="http://schemas.microsoft.com/office/drawing/2014/main" id="{F9132E4B-4E0F-4E3F-BBBF-5F1651381804}"/>
               </a:ext>
             </a:extLst>
           </p:cNvPr>
@@ -3288,7 +3293,7 @@
           <p:cNvPr id="3" name="chapter-10">
             <a:extLst xmlns:a="http://schemas.openxmlformats.org/drawingml/2006/main">
               <a:ext uri="{FF2B5EF4-FFF2-40B4-BE49-F238E27FC236}">
-                <a16:creationId xmlns:a16="http://schemas.microsoft.com/office/drawing/2014/main" id="{EE849D94-4615-4BCC-AB29-E8FB87450170}"/>
+                <a16:creationId xmlns:a16="http://schemas.microsoft.com/office/drawing/2014/main" id="{10F36FDA-4583-4FDB-B53C-D49E2182B016}"/>
               </a:ext>
             </a:extLst>
           </p:cNvPr>
@@ -3338,7 +3343,7 @@
           <p:cNvPr id="4" name="title-10">
             <a:extLst xmlns:a="http://schemas.openxmlformats.org/drawingml/2006/main">
               <a:ext uri="{FF2B5EF4-FFF2-40B4-BE49-F238E27FC236}">
-                <a16:creationId xmlns:a16="http://schemas.microsoft.com/office/drawing/2014/main" id="{61BF481A-6FA1-4EF4-B0DB-9A6C1F782819}"/>
+                <a16:creationId xmlns:a16="http://schemas.microsoft.com/office/drawing/2014/main" id="{D195182F-0697-44E7-94F4-7A3B7C3A1591}"/>
               </a:ext>
             </a:extLst>
           </p:cNvPr>
@@ -3388,7 +3393,7 @@
           <p:cNvPr id="5" name="subtitle-10">
             <a:extLst xmlns:a="http://schemas.openxmlformats.org/drawingml/2006/main">
               <a:ext uri="{FF2B5EF4-FFF2-40B4-BE49-F238E27FC236}">
-                <a16:creationId xmlns:a16="http://schemas.microsoft.com/office/drawing/2014/main" id="{EAAF3144-7939-4A5B-847F-053E5A914895}"/>
+                <a16:creationId xmlns:a16="http://schemas.microsoft.com/office/drawing/2014/main" id="{C6E91734-E86E-4CD7-A297-ACF665F87C91}"/>
               </a:ext>
             </a:extLst>
           </p:cNvPr>
@@ -3438,7 +3443,7 @@
           <p:cNvPr id="6" name="">
             <a:extLst xmlns:a="http://schemas.openxmlformats.org/drawingml/2006/main">
               <a:ext uri="{FF2B5EF4-FFF2-40B4-BE49-F238E27FC236}">
-                <a16:creationId xmlns:a16="http://schemas.microsoft.com/office/drawing/2014/main" id="{B17E7479-BA7E-4BF5-87A5-EE4083DFF78B}"/>
+                <a16:creationId xmlns:a16="http://schemas.microsoft.com/office/drawing/2014/main" id="{2DE76772-32E6-4F59-B495-D7240EF2A78B}"/>
               </a:ext>
             </a:extLst>
           </p:cNvPr>
@@ -3469,7 +3474,7 @@
           <p:cNvPr id="7" name="page-10">
             <a:extLst xmlns:a="http://schemas.openxmlformats.org/drawingml/2006/main">
               <a:ext uri="{FF2B5EF4-FFF2-40B4-BE49-F238E27FC236}">
-                <a16:creationId xmlns:a16="http://schemas.microsoft.com/office/drawing/2014/main" id="{A1AD820B-9560-47BA-9D68-DFBD05FFC625}"/>
+                <a16:creationId xmlns:a16="http://schemas.microsoft.com/office/drawing/2014/main" id="{4FC35EDA-890C-45BA-AD46-E88818E22BBA}"/>
               </a:ext>
             </a:extLst>
           </p:cNvPr>
@@ -3519,7 +3524,7 @@
           <p:cNvPr id="8" name="s2-label-0">
             <a:extLst xmlns:a="http://schemas.openxmlformats.org/drawingml/2006/main">
               <a:ext uri="{FF2B5EF4-FFF2-40B4-BE49-F238E27FC236}">
-                <a16:creationId xmlns:a16="http://schemas.microsoft.com/office/drawing/2014/main" id="{5288852F-040B-4617-B5F1-FCE1D78698C0}"/>
+                <a16:creationId xmlns:a16="http://schemas.microsoft.com/office/drawing/2014/main" id="{1453389A-5D3A-4FDC-88BC-5AA50BD80903}"/>
               </a:ext>
             </a:extLst>
           </p:cNvPr>
@@ -3569,7 +3574,7 @@
           <p:cNvPr id="9" name="s2-track-a-0">
             <a:extLst xmlns:a="http://schemas.openxmlformats.org/drawingml/2006/main">
               <a:ext uri="{FF2B5EF4-FFF2-40B4-BE49-F238E27FC236}">
-                <a16:creationId xmlns:a16="http://schemas.microsoft.com/office/drawing/2014/main" id="{5CB56315-7780-4E7C-A4AC-C2E13B7527A0}"/>
+                <a16:creationId xmlns:a16="http://schemas.microsoft.com/office/drawing/2014/main" id="{4405C75A-7F5C-4331-A611-48A76AEA9FFD}"/>
               </a:ext>
             </a:extLst>
           </p:cNvPr>
@@ -3604,7 +3609,7 @@
           <p:cNvPr id="10" name="s2-a-0">
             <a:extLst xmlns:a="http://schemas.openxmlformats.org/drawingml/2006/main">
               <a:ext uri="{FF2B5EF4-FFF2-40B4-BE49-F238E27FC236}">
-                <a16:creationId xmlns:a16="http://schemas.microsoft.com/office/drawing/2014/main" id="{13DD2263-F356-4330-B36D-1962A0C28B08}"/>
+                <a16:creationId xmlns:a16="http://schemas.microsoft.com/office/drawing/2014/main" id="{33A52E19-33EC-4AFC-BBD4-54D072558314}"/>
               </a:ext>
             </a:extLst>
           </p:cNvPr>
@@ -3616,7 +3621,7 @@
         <p:spPr>
           <a:xfrm xmlns:a="http://schemas.openxmlformats.org/drawingml/2006/main">
             <a:off x="3905250" y="2524125"/>
-            <a:ext cx="3619500" cy="209550"/>
+            <a:ext cx="5429250" cy="209550"/>
           </a:xfrm>
           <a:prstGeom xmlns:a="http://schemas.openxmlformats.org/drawingml/2006/main" prst="roundRect">
             <a:avLst>
@@ -3639,7 +3644,7 @@
           <p:cNvPr id="11" name="s2-track-b-0">
             <a:extLst xmlns:a="http://schemas.openxmlformats.org/drawingml/2006/main">
               <a:ext uri="{FF2B5EF4-FFF2-40B4-BE49-F238E27FC236}">
-                <a16:creationId xmlns:a16="http://schemas.microsoft.com/office/drawing/2014/main" id="{01119389-3DC4-473E-8D0B-019291FD614D}"/>
+                <a16:creationId xmlns:a16="http://schemas.microsoft.com/office/drawing/2014/main" id="{B4E18613-BC60-4F16-88AE-D62664A2832D}"/>
               </a:ext>
             </a:extLst>
           </p:cNvPr>
@@ -3674,7 +3679,7 @@
           <p:cNvPr id="12" name="s2-b-0">
             <a:extLst xmlns:a="http://schemas.openxmlformats.org/drawingml/2006/main">
               <a:ext uri="{FF2B5EF4-FFF2-40B4-BE49-F238E27FC236}">
-                <a16:creationId xmlns:a16="http://schemas.microsoft.com/office/drawing/2014/main" id="{ADE730FF-4176-4A8D-94DF-BEB879880099}"/>
+                <a16:creationId xmlns:a16="http://schemas.microsoft.com/office/drawing/2014/main" id="{89AC094F-1491-49CB-9253-7410A415D3DA}"/>
               </a:ext>
             </a:extLst>
           </p:cNvPr>
@@ -3709,7 +3714,7 @@
           <p:cNvPr id="13" name="s2-value-0">
             <a:extLst xmlns:a="http://schemas.openxmlformats.org/drawingml/2006/main">
               <a:ext uri="{FF2B5EF4-FFF2-40B4-BE49-F238E27FC236}">
-                <a16:creationId xmlns:a16="http://schemas.microsoft.com/office/drawing/2014/main" id="{4CCB58AF-D849-4C5F-A910-93485322C391}"/>
+                <a16:creationId xmlns:a16="http://schemas.microsoft.com/office/drawing/2014/main" id="{685F312B-3FD5-4A69-9378-221DADB35984}"/>
               </a:ext>
             </a:extLst>
           </p:cNvPr>
@@ -3749,7 +3754,7 @@
                   <a:srgbClr val="228B67"/>
                 </a:solidFill>
               </a:rPr>
-              <a:t>66.7%  →  100.0%</a:t>
+              <a:t>100.0%  →  100.0%</a:t>
             </a:r>
           </a:p>
         </p:txBody>
@@ -3759,7 +3764,7 @@
           <p:cNvPr id="14" name="s2-label-1">
             <a:extLst xmlns:a="http://schemas.openxmlformats.org/drawingml/2006/main">
               <a:ext uri="{FF2B5EF4-FFF2-40B4-BE49-F238E27FC236}">
-                <a16:creationId xmlns:a16="http://schemas.microsoft.com/office/drawing/2014/main" id="{8471F093-F785-4019-9E94-D0A6DB193B94}"/>
+                <a16:creationId xmlns:a16="http://schemas.microsoft.com/office/drawing/2014/main" id="{3333F335-2851-4863-92E5-B8C9FCE634F3}"/>
               </a:ext>
             </a:extLst>
           </p:cNvPr>
@@ -3809,7 +3814,7 @@
           <p:cNvPr id="15" name="s2-track-a-1">
             <a:extLst xmlns:a="http://schemas.openxmlformats.org/drawingml/2006/main">
               <a:ext uri="{FF2B5EF4-FFF2-40B4-BE49-F238E27FC236}">
-                <a16:creationId xmlns:a16="http://schemas.microsoft.com/office/drawing/2014/main" id="{FB57BC36-139C-43AF-AE9B-4F9C52272930}"/>
+                <a16:creationId xmlns:a16="http://schemas.microsoft.com/office/drawing/2014/main" id="{F2F06AF3-5D57-4D63-8112-3BF00B53CC9A}"/>
               </a:ext>
             </a:extLst>
           </p:cNvPr>
@@ -3844,7 +3849,7 @@
           <p:cNvPr id="16" name="s2-a-1">
             <a:extLst xmlns:a="http://schemas.openxmlformats.org/drawingml/2006/main">
               <a:ext uri="{FF2B5EF4-FFF2-40B4-BE49-F238E27FC236}">
-                <a16:creationId xmlns:a16="http://schemas.microsoft.com/office/drawing/2014/main" id="{072C0C04-E116-443F-BE05-968674C3D31E}"/>
+                <a16:creationId xmlns:a16="http://schemas.microsoft.com/office/drawing/2014/main" id="{C1C57106-5CF2-435F-8E0F-1F5F80FCE637}"/>
               </a:ext>
             </a:extLst>
           </p:cNvPr>
@@ -3856,7 +3861,7 @@
         <p:spPr>
           <a:xfrm xmlns:a="http://schemas.openxmlformats.org/drawingml/2006/main">
             <a:off x="3905250" y="3952875"/>
-            <a:ext cx="3498131" cy="209550"/>
+            <a:ext cx="5231110" cy="209550"/>
           </a:xfrm>
           <a:prstGeom xmlns:a="http://schemas.openxmlformats.org/drawingml/2006/main" prst="roundRect">
             <a:avLst>
@@ -3879,7 +3884,7 @@
           <p:cNvPr id="17" name="s2-track-b-1">
             <a:extLst xmlns:a="http://schemas.openxmlformats.org/drawingml/2006/main">
               <a:ext uri="{FF2B5EF4-FFF2-40B4-BE49-F238E27FC236}">
-                <a16:creationId xmlns:a16="http://schemas.microsoft.com/office/drawing/2014/main" id="{3AAF5E1C-7997-4FA5-8144-7A8117E0DAEE}"/>
+                <a16:creationId xmlns:a16="http://schemas.microsoft.com/office/drawing/2014/main" id="{D66EBAF3-0D90-420D-9593-F1902C71C7AA}"/>
               </a:ext>
             </a:extLst>
           </p:cNvPr>
@@ -3914,7 +3919,7 @@
           <p:cNvPr id="18" name="s2-b-1">
             <a:extLst xmlns:a="http://schemas.openxmlformats.org/drawingml/2006/main">
               <a:ext uri="{FF2B5EF4-FFF2-40B4-BE49-F238E27FC236}">
-                <a16:creationId xmlns:a16="http://schemas.microsoft.com/office/drawing/2014/main" id="{E92194CE-522F-4A55-BA27-4B722C5DA00C}"/>
+                <a16:creationId xmlns:a16="http://schemas.microsoft.com/office/drawing/2014/main" id="{20DE278D-5342-45FD-8876-4D812CC5324A}"/>
               </a:ext>
             </a:extLst>
           </p:cNvPr>
@@ -3926,7 +3931,7 @@
         <p:spPr>
           <a:xfrm xmlns:a="http://schemas.openxmlformats.org/drawingml/2006/main">
             <a:off x="3905250" y="4410075"/>
-            <a:ext cx="5222315" cy="209550"/>
+            <a:ext cx="5230890" cy="209550"/>
           </a:xfrm>
           <a:prstGeom xmlns:a="http://schemas.openxmlformats.org/drawingml/2006/main" prst="roundRect">
             <a:avLst>
@@ -3949,7 +3954,7 @@
           <p:cNvPr id="19" name="s2-value-1">
             <a:extLst xmlns:a="http://schemas.openxmlformats.org/drawingml/2006/main">
               <a:ext uri="{FF2B5EF4-FFF2-40B4-BE49-F238E27FC236}">
-                <a16:creationId xmlns:a16="http://schemas.microsoft.com/office/drawing/2014/main" id="{AF728E05-5BE8-4918-91CE-2B45E1EF9C5F}"/>
+                <a16:creationId xmlns:a16="http://schemas.microsoft.com/office/drawing/2014/main" id="{8F6B6F56-472B-40D0-B76C-E2909AA1103E}"/>
               </a:ext>
             </a:extLst>
           </p:cNvPr>
@@ -3979,17 +3984,17 @@
             <a:pPr algn="r">
               <a:defRPr sz="1500" b="1">
                 <a:solidFill>
-                  <a:srgbClr val="228B67"/>
+                  <a:srgbClr val="B44C4C"/>
                 </a:solidFill>
               </a:defRPr>
             </a:pPr>
             <a:r>
               <a:rPr sz="1500" b="1">
                 <a:solidFill>
-                  <a:srgbClr val="228B67"/>
-                </a:solidFill>
-              </a:rPr>
-              <a:t>0.838  →  1.250</a:t>
+                  <a:srgbClr val="B44C4C"/>
+                </a:solidFill>
+              </a:rPr>
+              <a:t>1.253  →  1.253</a:t>
             </a:r>
           </a:p>
         </p:txBody>
@@ -3999,7 +4004,7 @@
           <p:cNvPr id="20" name="">
             <a:extLst xmlns:a="http://schemas.openxmlformats.org/drawingml/2006/main">
               <a:ext uri="{FF2B5EF4-FFF2-40B4-BE49-F238E27FC236}">
-                <a16:creationId xmlns:a16="http://schemas.microsoft.com/office/drawing/2014/main" id="{D7701E91-97B1-4CA5-AF8B-56424B40EA07}"/>
+                <a16:creationId xmlns:a16="http://schemas.microsoft.com/office/drawing/2014/main" id="{93DB2FAE-4D0A-4568-AEF6-A5FDFB52C145}"/>
               </a:ext>
             </a:extLst>
           </p:cNvPr>
@@ -4030,7 +4035,7 @@
           <p:cNvPr id="21" name="s2-step-value">
             <a:extLst xmlns:a="http://schemas.openxmlformats.org/drawingml/2006/main">
               <a:ext uri="{FF2B5EF4-FFF2-40B4-BE49-F238E27FC236}">
-                <a16:creationId xmlns:a16="http://schemas.microsoft.com/office/drawing/2014/main" id="{518D27E0-5C61-429F-855D-2EDCAAA27AEB}"/>
+                <a16:creationId xmlns:a16="http://schemas.microsoft.com/office/drawing/2014/main" id="{6B51B2B4-B095-4144-AD31-31A390798E57}"/>
               </a:ext>
             </a:extLst>
           </p:cNvPr>
@@ -4080,7 +4085,7 @@
           <p:cNvPr id="22" name="s2-step-label">
             <a:extLst xmlns:a="http://schemas.openxmlformats.org/drawingml/2006/main">
               <a:ext uri="{FF2B5EF4-FFF2-40B4-BE49-F238E27FC236}">
-                <a16:creationId xmlns:a16="http://schemas.microsoft.com/office/drawing/2014/main" id="{F0D8968E-036A-45CC-9A5F-850FF1C269B3}"/>
+                <a16:creationId xmlns:a16="http://schemas.microsoft.com/office/drawing/2014/main" id="{37ABE640-5F80-4B3E-892F-822F9B8C0FEF}"/>
               </a:ext>
             </a:extLst>
           </p:cNvPr>
@@ -4130,7 +4135,7 @@
           <p:cNvPr id="23" name="">
             <a:extLst xmlns:a="http://schemas.openxmlformats.org/drawingml/2006/main">
               <a:ext uri="{FF2B5EF4-FFF2-40B4-BE49-F238E27FC236}">
-                <a16:creationId xmlns:a16="http://schemas.microsoft.com/office/drawing/2014/main" id="{F88F88ED-631B-4238-9A65-8D363E19CDAF}"/>
+                <a16:creationId xmlns:a16="http://schemas.microsoft.com/office/drawing/2014/main" id="{E762D2CC-92E9-42C3-A319-E90054703029}"/>
               </a:ext>
             </a:extLst>
           </p:cNvPr>
@@ -4161,7 +4166,7 @@
           <p:cNvPr id="24" name="s2-time-value">
             <a:extLst xmlns:a="http://schemas.openxmlformats.org/drawingml/2006/main">
               <a:ext uri="{FF2B5EF4-FFF2-40B4-BE49-F238E27FC236}">
-                <a16:creationId xmlns:a16="http://schemas.microsoft.com/office/drawing/2014/main" id="{373DC0CA-A7CC-4D77-8677-08879BBFFE80}"/>
+                <a16:creationId xmlns:a16="http://schemas.microsoft.com/office/drawing/2014/main" id="{9CC4F79F-D9F8-48B3-872B-B026178BAA20}"/>
               </a:ext>
             </a:extLst>
           </p:cNvPr>
@@ -4211,7 +4216,7 @@
           <p:cNvPr id="25" name="s2-time-label">
             <a:extLst xmlns:a="http://schemas.openxmlformats.org/drawingml/2006/main">
               <a:ext uri="{FF2B5EF4-FFF2-40B4-BE49-F238E27FC236}">
-                <a16:creationId xmlns:a16="http://schemas.microsoft.com/office/drawing/2014/main" id="{5FECCEFA-94CF-4302-9A60-7D6576573EE1}"/>
+                <a16:creationId xmlns:a16="http://schemas.microsoft.com/office/drawing/2014/main" id="{CB2122EE-DADA-4A0F-891F-F74115A78583}"/>
               </a:ext>
             </a:extLst>
           </p:cNvPr>
@@ -4261,7 +4266,7 @@
           <p:cNvPr id="26" name="">
             <a:extLst xmlns:a="http://schemas.openxmlformats.org/drawingml/2006/main">
               <a:ext uri="{FF2B5EF4-FFF2-40B4-BE49-F238E27FC236}">
-                <a16:creationId xmlns:a16="http://schemas.microsoft.com/office/drawing/2014/main" id="{96409DB0-22F4-4285-8938-50063C2BBD57}"/>
+                <a16:creationId xmlns:a16="http://schemas.microsoft.com/office/drawing/2014/main" id="{C7524F4B-D2BD-4A4C-B207-7A510631C876}"/>
               </a:ext>
             </a:extLst>
           </p:cNvPr>
@@ -4292,7 +4297,7 @@
           <p:cNvPr id="27" name="s2-replay-value">
             <a:extLst xmlns:a="http://schemas.openxmlformats.org/drawingml/2006/main">
               <a:ext uri="{FF2B5EF4-FFF2-40B4-BE49-F238E27FC236}">
-                <a16:creationId xmlns:a16="http://schemas.microsoft.com/office/drawing/2014/main" id="{232C82E8-76CB-4ABF-805F-5A03E33F2222}"/>
+                <a16:creationId xmlns:a16="http://schemas.microsoft.com/office/drawing/2014/main" id="{F8FDBD75-7098-4AB7-99BD-8A43F140A042}"/>
               </a:ext>
             </a:extLst>
           </p:cNvPr>
@@ -4342,7 +4347,7 @@
           <p:cNvPr id="28" name="s2-replay-label">
             <a:extLst xmlns:a="http://schemas.openxmlformats.org/drawingml/2006/main">
               <a:ext uri="{FF2B5EF4-FFF2-40B4-BE49-F238E27FC236}">
-                <a16:creationId xmlns:a16="http://schemas.microsoft.com/office/drawing/2014/main" id="{FC590F31-BBC9-47C0-B00E-46F694CF3882}"/>
+                <a16:creationId xmlns:a16="http://schemas.microsoft.com/office/drawing/2014/main" id="{E258F0E0-DD7A-41DF-843D-E3279E949F7B}"/>
               </a:ext>
             </a:extLst>
           </p:cNvPr>
@@ -4392,7 +4397,7 @@
           <p:cNvPr id="29" name="">
             <a:extLst xmlns:a="http://schemas.openxmlformats.org/drawingml/2006/main">
               <a:ext uri="{FF2B5EF4-FFF2-40B4-BE49-F238E27FC236}">
-                <a16:creationId xmlns:a16="http://schemas.microsoft.com/office/drawing/2014/main" id="{CAF25E5D-A6B2-4349-A9E8-0274B55C43B7}"/>
+                <a16:creationId xmlns:a16="http://schemas.microsoft.com/office/drawing/2014/main" id="{F432B5F4-9E1B-4B72-85E2-5DFC0BACB798}"/>
               </a:ext>
             </a:extLst>
           </p:cNvPr>
@@ -4423,7 +4428,7 @@
           <p:cNvPr id="30" name="s2-gpu-value">
             <a:extLst xmlns:a="http://schemas.openxmlformats.org/drawingml/2006/main">
               <a:ext uri="{FF2B5EF4-FFF2-40B4-BE49-F238E27FC236}">
-                <a16:creationId xmlns:a16="http://schemas.microsoft.com/office/drawing/2014/main" id="{1FF82135-94E7-461C-B7DF-CA33C21C61A1}"/>
+                <a16:creationId xmlns:a16="http://schemas.microsoft.com/office/drawing/2014/main" id="{E68B4812-2C4E-4523-A638-26F136D0BCC4}"/>
               </a:ext>
             </a:extLst>
           </p:cNvPr>
@@ -4473,7 +4478,7 @@
           <p:cNvPr id="31" name="s2-gpu-label">
             <a:extLst xmlns:a="http://schemas.openxmlformats.org/drawingml/2006/main">
               <a:ext uri="{FF2B5EF4-FFF2-40B4-BE49-F238E27FC236}">
-                <a16:creationId xmlns:a16="http://schemas.microsoft.com/office/drawing/2014/main" id="{E34962AA-1E06-4F77-9BFD-934E23A9C564}"/>
+                <a16:creationId xmlns:a16="http://schemas.microsoft.com/office/drawing/2014/main" id="{3E978D4C-95D0-48DF-A6AD-9BF34EE72B94}"/>
               </a:ext>
             </a:extLst>
           </p:cNvPr>
@@ -4513,7 +4518,7 @@
                   <a:srgbClr val="64747B"/>
                 </a:solidFill>
               </a:rPr>
-              <a:t>RTX PRO 6000 · 96GB</a:t>
+              <a:t>NVIDIA H200 · 139.719 GiB</a:t>
             </a:r>
           </a:p>
         </p:txBody>
@@ -4521,7 +4526,7 @@
     </p:spTree>
     <p:extLst>
       <p:ext uri="{BB962C8B-B14F-4D97-AF65-F5344CB8AC3E}">
-        <p14:creationId xmlns:p14="http://schemas.microsoft.com/office/powerpoint/2010/main" val="740780276"/>
+        <p14:creationId xmlns:p14="http://schemas.microsoft.com/office/powerpoint/2010/main" val="2111542157"/>
       </p:ext>
     </p:extLst>
   </p:cSld>
@@ -4552,7 +4557,7 @@
           <p:cNvPr id="39" name="rail-11">
             <a:extLst xmlns:a="http://schemas.openxmlformats.org/drawingml/2006/main">
               <a:ext uri="{FF2B5EF4-FFF2-40B4-BE49-F238E27FC236}">
-                <a16:creationId xmlns:a16="http://schemas.microsoft.com/office/drawing/2014/main" id="{0F01EF6B-63EE-46CE-AEC0-A10CFC6CBA69}"/>
+                <a16:creationId xmlns:a16="http://schemas.microsoft.com/office/drawing/2014/main" id="{45253415-ED7F-44A1-8BA2-C3EA19175EFF}"/>
               </a:ext>
             </a:extLst>
           </p:cNvPr>
@@ -4585,7 +4590,7 @@
           <p:cNvPr id="2" name="flourish-11">
             <a:extLst xmlns:a="http://schemas.openxmlformats.org/drawingml/2006/main">
               <a:ext uri="{FF2B5EF4-FFF2-40B4-BE49-F238E27FC236}">
-                <a16:creationId xmlns:a16="http://schemas.microsoft.com/office/drawing/2014/main" id="{432C530B-89F6-45F0-9A62-2B17B438EA89}"/>
+                <a16:creationId xmlns:a16="http://schemas.microsoft.com/office/drawing/2014/main" id="{C769EFF0-CD2B-4E8F-AAC3-B8EBBBEAC0E3}"/>
               </a:ext>
             </a:extLst>
           </p:cNvPr>
@@ -4635,7 +4640,7 @@
           <p:cNvPr id="3" name="chapter-11">
             <a:extLst xmlns:a="http://schemas.openxmlformats.org/drawingml/2006/main">
               <a:ext uri="{FF2B5EF4-FFF2-40B4-BE49-F238E27FC236}">
-                <a16:creationId xmlns:a16="http://schemas.microsoft.com/office/drawing/2014/main" id="{EA995694-0084-45B9-8FDA-3F755E0D9534}"/>
+                <a16:creationId xmlns:a16="http://schemas.microsoft.com/office/drawing/2014/main" id="{A6CC07FB-2A85-4CB6-AB55-F3BE8907FE63}"/>
               </a:ext>
             </a:extLst>
           </p:cNvPr>
@@ -4685,7 +4690,7 @@
           <p:cNvPr id="4" name="title-11">
             <a:extLst xmlns:a="http://schemas.openxmlformats.org/drawingml/2006/main">
               <a:ext uri="{FF2B5EF4-FFF2-40B4-BE49-F238E27FC236}">
-                <a16:creationId xmlns:a16="http://schemas.microsoft.com/office/drawing/2014/main" id="{F135672C-524A-4DE5-A8B0-D35B7E79BE41}"/>
+                <a16:creationId xmlns:a16="http://schemas.microsoft.com/office/drawing/2014/main" id="{2E62F51E-0F1F-43B2-A96D-FA05CC7FB77F}"/>
               </a:ext>
             </a:extLst>
           </p:cNvPr>
@@ -4735,7 +4740,7 @@
           <p:cNvPr id="5" name="subtitle-11">
             <a:extLst xmlns:a="http://schemas.openxmlformats.org/drawingml/2006/main">
               <a:ext uri="{FF2B5EF4-FFF2-40B4-BE49-F238E27FC236}">
-                <a16:creationId xmlns:a16="http://schemas.microsoft.com/office/drawing/2014/main" id="{A104AD44-4749-45A6-A5F0-9662ABBBE654}"/>
+                <a16:creationId xmlns:a16="http://schemas.microsoft.com/office/drawing/2014/main" id="{2277AB01-C5B4-4C2F-A2CF-A9B2CB5CE19B}"/>
               </a:ext>
             </a:extLst>
           </p:cNvPr>
@@ -4785,7 +4790,7 @@
           <p:cNvPr id="6" name="">
             <a:extLst xmlns:a="http://schemas.openxmlformats.org/drawingml/2006/main">
               <a:ext uri="{FF2B5EF4-FFF2-40B4-BE49-F238E27FC236}">
-                <a16:creationId xmlns:a16="http://schemas.microsoft.com/office/drawing/2014/main" id="{EC57AF87-BA96-4233-AF64-0DBEAE25FDC4}"/>
+                <a16:creationId xmlns:a16="http://schemas.microsoft.com/office/drawing/2014/main" id="{F10CC192-8472-4B8E-BD24-C634F13FEE98}"/>
               </a:ext>
             </a:extLst>
           </p:cNvPr>
@@ -4816,7 +4821,7 @@
           <p:cNvPr id="7" name="page-11">
             <a:extLst xmlns:a="http://schemas.openxmlformats.org/drawingml/2006/main">
               <a:ext uri="{FF2B5EF4-FFF2-40B4-BE49-F238E27FC236}">
-                <a16:creationId xmlns:a16="http://schemas.microsoft.com/office/drawing/2014/main" id="{CFA9DF39-F2DC-453D-B81F-2A57FBB049BB}"/>
+                <a16:creationId xmlns:a16="http://schemas.microsoft.com/office/drawing/2014/main" id="{81E131FE-01DD-48F5-9F00-70B509E4D2C7}"/>
               </a:ext>
             </a:extLst>
           </p:cNvPr>
@@ -4866,7 +4871,7 @@
           <p:cNvPr id="8" name="traj-spine">
             <a:extLst xmlns:a="http://schemas.openxmlformats.org/drawingml/2006/main">
               <a:ext uri="{FF2B5EF4-FFF2-40B4-BE49-F238E27FC236}">
-                <a16:creationId xmlns:a16="http://schemas.microsoft.com/office/drawing/2014/main" id="{DC75547B-04E8-4388-898B-5C060DC353CA}"/>
+                <a16:creationId xmlns:a16="http://schemas.microsoft.com/office/drawing/2014/main" id="{FDB69B23-061C-45A6-A263-C029D7442EE4}"/>
               </a:ext>
             </a:extLst>
           </p:cNvPr>
@@ -4899,7 +4904,7 @@
           <p:cNvPr id="9" name="traj-dot-0">
             <a:extLst xmlns:a="http://schemas.openxmlformats.org/drawingml/2006/main">
               <a:ext uri="{FF2B5EF4-FFF2-40B4-BE49-F238E27FC236}">
-                <a16:creationId xmlns:a16="http://schemas.microsoft.com/office/drawing/2014/main" id="{C8F70D9B-F784-4DEE-B2F3-A4A0C7E18E57}"/>
+                <a16:creationId xmlns:a16="http://schemas.microsoft.com/office/drawing/2014/main" id="{A2F43B5E-B037-4A88-96EA-01D6D5E2D2A3}"/>
               </a:ext>
             </a:extLst>
           </p:cNvPr>
@@ -4934,7 +4939,7 @@
           <p:cNvPr id="10" name="traj-num-0">
             <a:extLst xmlns:a="http://schemas.openxmlformats.org/drawingml/2006/main">
               <a:ext uri="{FF2B5EF4-FFF2-40B4-BE49-F238E27FC236}">
-                <a16:creationId xmlns:a16="http://schemas.microsoft.com/office/drawing/2014/main" id="{D23037C4-5DE2-42E1-97C7-20DCB9F0C7DD}"/>
+                <a16:creationId xmlns:a16="http://schemas.microsoft.com/office/drawing/2014/main" id="{0A4601ED-F501-4C31-9AE5-247FF20FF9C2}"/>
               </a:ext>
             </a:extLst>
           </p:cNvPr>
@@ -4984,7 +4989,7 @@
           <p:cNvPr id="11" name="traj-tool-0">
             <a:extLst xmlns:a="http://schemas.openxmlformats.org/drawingml/2006/main">
               <a:ext uri="{FF2B5EF4-FFF2-40B4-BE49-F238E27FC236}">
-                <a16:creationId xmlns:a16="http://schemas.microsoft.com/office/drawing/2014/main" id="{25262CB1-A164-4DD6-99D0-4281D36D4773}"/>
+                <a16:creationId xmlns:a16="http://schemas.microsoft.com/office/drawing/2014/main" id="{E18CD4E0-F1DE-4D83-AB5A-844E2152DCFE}"/>
               </a:ext>
             </a:extLst>
           </p:cNvPr>
@@ -5034,7 +5039,7 @@
           <p:cNvPr id="12" name="traj-obs-0">
             <a:extLst xmlns:a="http://schemas.openxmlformats.org/drawingml/2006/main">
               <a:ext uri="{FF2B5EF4-FFF2-40B4-BE49-F238E27FC236}">
-                <a16:creationId xmlns:a16="http://schemas.microsoft.com/office/drawing/2014/main" id="{2F43E74B-C511-4EEC-988E-A8822A577EC5}"/>
+                <a16:creationId xmlns:a16="http://schemas.microsoft.com/office/drawing/2014/main" id="{3C193EBC-C905-48A5-BD4C-E0A8A9F96C2F}"/>
               </a:ext>
             </a:extLst>
           </p:cNvPr>
@@ -5084,7 +5089,7 @@
           <p:cNvPr id="13" name="traj-dot-1">
             <a:extLst xmlns:a="http://schemas.openxmlformats.org/drawingml/2006/main">
               <a:ext uri="{FF2B5EF4-FFF2-40B4-BE49-F238E27FC236}">
-                <a16:creationId xmlns:a16="http://schemas.microsoft.com/office/drawing/2014/main" id="{9D2791AA-BB3A-454B-9A57-D64E94119975}"/>
+                <a16:creationId xmlns:a16="http://schemas.microsoft.com/office/drawing/2014/main" id="{D6D085A7-6BED-47C8-9090-2E6E867BC9D1}"/>
               </a:ext>
             </a:extLst>
           </p:cNvPr>
@@ -5119,7 +5124,7 @@
           <p:cNvPr id="14" name="traj-num-1">
             <a:extLst xmlns:a="http://schemas.openxmlformats.org/drawingml/2006/main">
               <a:ext uri="{FF2B5EF4-FFF2-40B4-BE49-F238E27FC236}">
-                <a16:creationId xmlns:a16="http://schemas.microsoft.com/office/drawing/2014/main" id="{DE93DADA-758D-45DB-9C44-EA0FE946AC8F}"/>
+                <a16:creationId xmlns:a16="http://schemas.microsoft.com/office/drawing/2014/main" id="{4F76CFCF-EE40-470C-A7EC-3AD5E792F417}"/>
               </a:ext>
             </a:extLst>
           </p:cNvPr>
@@ -5169,7 +5174,7 @@
           <p:cNvPr id="15" name="traj-tool-1">
             <a:extLst xmlns:a="http://schemas.openxmlformats.org/drawingml/2006/main">
               <a:ext uri="{FF2B5EF4-FFF2-40B4-BE49-F238E27FC236}">
-                <a16:creationId xmlns:a16="http://schemas.microsoft.com/office/drawing/2014/main" id="{C7C0E9C7-A056-4E90-83DB-07F43A713384}"/>
+                <a16:creationId xmlns:a16="http://schemas.microsoft.com/office/drawing/2014/main" id="{9E9CF642-A673-4288-9B12-F7DD30BC70E2}"/>
               </a:ext>
             </a:extLst>
           </p:cNvPr>
@@ -5219,7 +5224,7 @@
           <p:cNvPr id="16" name="traj-obs-1">
             <a:extLst xmlns:a="http://schemas.openxmlformats.org/drawingml/2006/main">
               <a:ext uri="{FF2B5EF4-FFF2-40B4-BE49-F238E27FC236}">
-                <a16:creationId xmlns:a16="http://schemas.microsoft.com/office/drawing/2014/main" id="{1DBF575B-B63A-44BB-A946-BC263DE074D6}"/>
+                <a16:creationId xmlns:a16="http://schemas.microsoft.com/office/drawing/2014/main" id="{69BE1AFF-8AB9-4F7A-AA4D-75AEC9194BD0}"/>
               </a:ext>
             </a:extLst>
           </p:cNvPr>
@@ -5269,7 +5274,7 @@
           <p:cNvPr id="17" name="traj-dot-2">
             <a:extLst xmlns:a="http://schemas.openxmlformats.org/drawingml/2006/main">
               <a:ext uri="{FF2B5EF4-FFF2-40B4-BE49-F238E27FC236}">
-                <a16:creationId xmlns:a16="http://schemas.microsoft.com/office/drawing/2014/main" id="{AF94B954-C75E-4CF1-B30B-09B673B806F3}"/>
+                <a16:creationId xmlns:a16="http://schemas.microsoft.com/office/drawing/2014/main" id="{1242D489-DD8E-4CA4-96E2-71FFC65E0106}"/>
               </a:ext>
             </a:extLst>
           </p:cNvPr>
@@ -5304,7 +5309,7 @@
           <p:cNvPr id="18" name="traj-num-2">
             <a:extLst xmlns:a="http://schemas.openxmlformats.org/drawingml/2006/main">
               <a:ext uri="{FF2B5EF4-FFF2-40B4-BE49-F238E27FC236}">
-                <a16:creationId xmlns:a16="http://schemas.microsoft.com/office/drawing/2014/main" id="{70AED5EB-52DF-4CC1-918D-B12D8389424F}"/>
+                <a16:creationId xmlns:a16="http://schemas.microsoft.com/office/drawing/2014/main" id="{750B89FD-AA1A-42F6-993B-FAAFFC66259D}"/>
               </a:ext>
             </a:extLst>
           </p:cNvPr>
@@ -5354,7 +5359,7 @@
           <p:cNvPr id="19" name="traj-tool-2">
             <a:extLst xmlns:a="http://schemas.openxmlformats.org/drawingml/2006/main">
               <a:ext uri="{FF2B5EF4-FFF2-40B4-BE49-F238E27FC236}">
-                <a16:creationId xmlns:a16="http://schemas.microsoft.com/office/drawing/2014/main" id="{2C23F83E-C3AE-41D5-B7B8-29F6D44714E0}"/>
+                <a16:creationId xmlns:a16="http://schemas.microsoft.com/office/drawing/2014/main" id="{05E14A60-AE03-4821-B28C-80D94C3C0386}"/>
               </a:ext>
             </a:extLst>
           </p:cNvPr>
@@ -5404,7 +5409,7 @@
           <p:cNvPr id="20" name="traj-obs-2">
             <a:extLst xmlns:a="http://schemas.openxmlformats.org/drawingml/2006/main">
               <a:ext uri="{FF2B5EF4-FFF2-40B4-BE49-F238E27FC236}">
-                <a16:creationId xmlns:a16="http://schemas.microsoft.com/office/drawing/2014/main" id="{E4DFC978-D59A-4D27-8828-12DE90B01089}"/>
+                <a16:creationId xmlns:a16="http://schemas.microsoft.com/office/drawing/2014/main" id="{FE7B8E6E-7FA9-4938-9833-9C0361C3BAE3}"/>
               </a:ext>
             </a:extLst>
           </p:cNvPr>
@@ -5454,7 +5459,7 @@
           <p:cNvPr id="21" name="traj-dot-3">
             <a:extLst xmlns:a="http://schemas.openxmlformats.org/drawingml/2006/main">
               <a:ext uri="{FF2B5EF4-FFF2-40B4-BE49-F238E27FC236}">
-                <a16:creationId xmlns:a16="http://schemas.microsoft.com/office/drawing/2014/main" id="{F0394C59-8F4F-42DE-874A-0766AA20AF7A}"/>
+                <a16:creationId xmlns:a16="http://schemas.microsoft.com/office/drawing/2014/main" id="{1A9788F3-8192-42AC-97A3-970FC45095C4}"/>
               </a:ext>
             </a:extLst>
           </p:cNvPr>
@@ -5489,7 +5494,7 @@
           <p:cNvPr id="22" name="traj-num-3">
             <a:extLst xmlns:a="http://schemas.openxmlformats.org/drawingml/2006/main">
               <a:ext uri="{FF2B5EF4-FFF2-40B4-BE49-F238E27FC236}">
-                <a16:creationId xmlns:a16="http://schemas.microsoft.com/office/drawing/2014/main" id="{590BE3E3-2060-4A7B-936E-4443BD14D99B}"/>
+                <a16:creationId xmlns:a16="http://schemas.microsoft.com/office/drawing/2014/main" id="{A9C27B96-4DC8-48CA-B83C-307CF3392E48}"/>
               </a:ext>
             </a:extLst>
           </p:cNvPr>
@@ -5539,7 +5544,7 @@
           <p:cNvPr id="23" name="traj-tool-3">
             <a:extLst xmlns:a="http://schemas.openxmlformats.org/drawingml/2006/main">
               <a:ext uri="{FF2B5EF4-FFF2-40B4-BE49-F238E27FC236}">
-                <a16:creationId xmlns:a16="http://schemas.microsoft.com/office/drawing/2014/main" id="{F80E561B-8F55-4934-AE67-FB3F66306A98}"/>
+                <a16:creationId xmlns:a16="http://schemas.microsoft.com/office/drawing/2014/main" id="{BBEA6BE3-CB94-4D4F-B7FB-B3F5ED0D739A}"/>
               </a:ext>
             </a:extLst>
           </p:cNvPr>
@@ -5589,7 +5594,7 @@
           <p:cNvPr id="24" name="traj-obs-3">
             <a:extLst xmlns:a="http://schemas.openxmlformats.org/drawingml/2006/main">
               <a:ext uri="{FF2B5EF4-FFF2-40B4-BE49-F238E27FC236}">
-                <a16:creationId xmlns:a16="http://schemas.microsoft.com/office/drawing/2014/main" id="{D4AE48B6-B475-4F76-AD08-0E2E66C46B2E}"/>
+                <a16:creationId xmlns:a16="http://schemas.microsoft.com/office/drawing/2014/main" id="{F873FD7A-20B1-4AA5-8302-41B5A2F02EF9}"/>
               </a:ext>
             </a:extLst>
           </p:cNvPr>
@@ -5639,7 +5644,7 @@
           <p:cNvPr id="25" name="traj-dot-4">
             <a:extLst xmlns:a="http://schemas.openxmlformats.org/drawingml/2006/main">
               <a:ext uri="{FF2B5EF4-FFF2-40B4-BE49-F238E27FC236}">
-                <a16:creationId xmlns:a16="http://schemas.microsoft.com/office/drawing/2014/main" id="{6FC548C1-1B14-4DFF-BD83-B5606A05DEEA}"/>
+                <a16:creationId xmlns:a16="http://schemas.microsoft.com/office/drawing/2014/main" id="{0D84FB06-9BC4-4281-A720-6F5882A9797C}"/>
               </a:ext>
             </a:extLst>
           </p:cNvPr>
@@ -5674,7 +5679,7 @@
           <p:cNvPr id="26" name="traj-num-4">
             <a:extLst xmlns:a="http://schemas.openxmlformats.org/drawingml/2006/main">
               <a:ext uri="{FF2B5EF4-FFF2-40B4-BE49-F238E27FC236}">
-                <a16:creationId xmlns:a16="http://schemas.microsoft.com/office/drawing/2014/main" id="{BFE22536-D06A-4F10-8389-C0DCA08CEFFB}"/>
+                <a16:creationId xmlns:a16="http://schemas.microsoft.com/office/drawing/2014/main" id="{3B476BE7-5CAA-487A-BC70-46E6A2EBB63C}"/>
               </a:ext>
             </a:extLst>
           </p:cNvPr>
@@ -5724,7 +5729,7 @@
           <p:cNvPr id="27" name="traj-tool-4">
             <a:extLst xmlns:a="http://schemas.openxmlformats.org/drawingml/2006/main">
               <a:ext uri="{FF2B5EF4-FFF2-40B4-BE49-F238E27FC236}">
-                <a16:creationId xmlns:a16="http://schemas.microsoft.com/office/drawing/2014/main" id="{AECC7637-40E9-4FB3-BE73-20A0F4519599}"/>
+                <a16:creationId xmlns:a16="http://schemas.microsoft.com/office/drawing/2014/main" id="{78E7AE13-F0C6-41D7-A49B-E028021ECAB6}"/>
               </a:ext>
             </a:extLst>
           </p:cNvPr>
@@ -5774,7 +5779,7 @@
           <p:cNvPr id="28" name="traj-obs-4">
             <a:extLst xmlns:a="http://schemas.openxmlformats.org/drawingml/2006/main">
               <a:ext uri="{FF2B5EF4-FFF2-40B4-BE49-F238E27FC236}">
-                <a16:creationId xmlns:a16="http://schemas.microsoft.com/office/drawing/2014/main" id="{87E339A4-860B-4BFC-BC56-F0E0B61377F9}"/>
+                <a16:creationId xmlns:a16="http://schemas.microsoft.com/office/drawing/2014/main" id="{18993677-DA6C-4F15-B52A-C050A2D67E14}"/>
               </a:ext>
             </a:extLst>
           </p:cNvPr>
@@ -5824,7 +5829,7 @@
           <p:cNvPr id="29" name="traj-dot-5">
             <a:extLst xmlns:a="http://schemas.openxmlformats.org/drawingml/2006/main">
               <a:ext uri="{FF2B5EF4-FFF2-40B4-BE49-F238E27FC236}">
-                <a16:creationId xmlns:a16="http://schemas.microsoft.com/office/drawing/2014/main" id="{AF89F9B8-CD1F-442B-A759-37E7A0E6A87D}"/>
+                <a16:creationId xmlns:a16="http://schemas.microsoft.com/office/drawing/2014/main" id="{DE7B7989-CE07-484E-AC13-8A30FB08F4BC}"/>
               </a:ext>
             </a:extLst>
           </p:cNvPr>
@@ -5859,7 +5864,7 @@
           <p:cNvPr id="30" name="traj-num-5">
             <a:extLst xmlns:a="http://schemas.openxmlformats.org/drawingml/2006/main">
               <a:ext uri="{FF2B5EF4-FFF2-40B4-BE49-F238E27FC236}">
-                <a16:creationId xmlns:a16="http://schemas.microsoft.com/office/drawing/2014/main" id="{24BB051D-8FFC-4DBF-A710-D057FC26123F}"/>
+                <a16:creationId xmlns:a16="http://schemas.microsoft.com/office/drawing/2014/main" id="{79A2A69B-3F5B-43CD-A1CD-01A4399D2C85}"/>
               </a:ext>
             </a:extLst>
           </p:cNvPr>
@@ -5909,7 +5914,7 @@
           <p:cNvPr id="31" name="traj-tool-5">
             <a:extLst xmlns:a="http://schemas.openxmlformats.org/drawingml/2006/main">
               <a:ext uri="{FF2B5EF4-FFF2-40B4-BE49-F238E27FC236}">
-                <a16:creationId xmlns:a16="http://schemas.microsoft.com/office/drawing/2014/main" id="{75C6DEE8-B15B-4A81-8CCD-15359D5182D2}"/>
+                <a16:creationId xmlns:a16="http://schemas.microsoft.com/office/drawing/2014/main" id="{20867DE7-2517-4FB5-A65F-79C49C426B27}"/>
               </a:ext>
             </a:extLst>
           </p:cNvPr>
@@ -5959,7 +5964,7 @@
           <p:cNvPr id="32" name="traj-obs-5">
             <a:extLst xmlns:a="http://schemas.openxmlformats.org/drawingml/2006/main">
               <a:ext uri="{FF2B5EF4-FFF2-40B4-BE49-F238E27FC236}">
-                <a16:creationId xmlns:a16="http://schemas.microsoft.com/office/drawing/2014/main" id="{7802E3D6-3E23-43CD-8C9F-0A652B76D92D}"/>
+                <a16:creationId xmlns:a16="http://schemas.microsoft.com/office/drawing/2014/main" id="{E341F772-7E94-437B-9D97-6A3F832A9AF7}"/>
               </a:ext>
             </a:extLst>
           </p:cNvPr>
@@ -6009,7 +6014,7 @@
           <p:cNvPr id="33" name="traj-dot-6">
             <a:extLst xmlns:a="http://schemas.openxmlformats.org/drawingml/2006/main">
               <a:ext uri="{FF2B5EF4-FFF2-40B4-BE49-F238E27FC236}">
-                <a16:creationId xmlns:a16="http://schemas.microsoft.com/office/drawing/2014/main" id="{8A0D250F-4CED-4F9B-A821-85F0A78F2C4C}"/>
+                <a16:creationId xmlns:a16="http://schemas.microsoft.com/office/drawing/2014/main" id="{785369F1-71C8-4DC9-9DB7-FE8CFEAA473A}"/>
               </a:ext>
             </a:extLst>
           </p:cNvPr>
@@ -6044,7 +6049,7 @@
           <p:cNvPr id="34" name="traj-num-6">
             <a:extLst xmlns:a="http://schemas.openxmlformats.org/drawingml/2006/main">
               <a:ext uri="{FF2B5EF4-FFF2-40B4-BE49-F238E27FC236}">
-                <a16:creationId xmlns:a16="http://schemas.microsoft.com/office/drawing/2014/main" id="{E0A417D9-3D2D-4C91-87F6-42BF47856AB6}"/>
+                <a16:creationId xmlns:a16="http://schemas.microsoft.com/office/drawing/2014/main" id="{14830442-2447-4C39-B8DA-3EFC975408B5}"/>
               </a:ext>
             </a:extLst>
           </p:cNvPr>
@@ -6094,7 +6099,7 @@
           <p:cNvPr id="35" name="traj-tool-6">
             <a:extLst xmlns:a="http://schemas.openxmlformats.org/drawingml/2006/main">
               <a:ext uri="{FF2B5EF4-FFF2-40B4-BE49-F238E27FC236}">
-                <a16:creationId xmlns:a16="http://schemas.microsoft.com/office/drawing/2014/main" id="{B03F13E5-F588-45C4-BB3F-1037D8765C98}"/>
+                <a16:creationId xmlns:a16="http://schemas.microsoft.com/office/drawing/2014/main" id="{AE0C56DA-FFAF-4C93-B9F7-24C1053DA089}"/>
               </a:ext>
             </a:extLst>
           </p:cNvPr>
@@ -6144,7 +6149,7 @@
           <p:cNvPr id="36" name="traj-obs-6">
             <a:extLst xmlns:a="http://schemas.openxmlformats.org/drawingml/2006/main">
               <a:ext uri="{FF2B5EF4-FFF2-40B4-BE49-F238E27FC236}">
-                <a16:creationId xmlns:a16="http://schemas.microsoft.com/office/drawing/2014/main" id="{01E9F964-A657-4C68-AA4E-6949F0D19274}"/>
+                <a16:creationId xmlns:a16="http://schemas.microsoft.com/office/drawing/2014/main" id="{4ECECDAC-EDF4-4F7A-AA7C-3A7B6C8B0B77}"/>
               </a:ext>
             </a:extLst>
           </p:cNvPr>
@@ -6194,7 +6199,7 @@
           <p:cNvPr id="37" name="traj-outcome-bg">
             <a:extLst xmlns:a="http://schemas.openxmlformats.org/drawingml/2006/main">
               <a:ext uri="{FF2B5EF4-FFF2-40B4-BE49-F238E27FC236}">
-                <a16:creationId xmlns:a16="http://schemas.microsoft.com/office/drawing/2014/main" id="{0E1B44D5-FCCC-44E2-A5AE-00F194C5B1AE}"/>
+                <a16:creationId xmlns:a16="http://schemas.microsoft.com/office/drawing/2014/main" id="{E3C48573-4DDC-4486-86E2-D0EC282BDE02}"/>
               </a:ext>
             </a:extLst>
           </p:cNvPr>
@@ -6229,7 +6234,7 @@
           <p:cNvPr id="38" name="traj-outcome-text">
             <a:extLst xmlns:a="http://schemas.openxmlformats.org/drawingml/2006/main">
               <a:ext uri="{FF2B5EF4-FFF2-40B4-BE49-F238E27FC236}">
-                <a16:creationId xmlns:a16="http://schemas.microsoft.com/office/drawing/2014/main" id="{3F7AD9FA-52B4-43A7-B4B6-419A635BF2BE}"/>
+                <a16:creationId xmlns:a16="http://schemas.microsoft.com/office/drawing/2014/main" id="{9FCAEF98-6A62-4E4F-83FD-DC1A38090412}"/>
               </a:ext>
             </a:extLst>
           </p:cNvPr>
@@ -6277,7 +6282,7 @@
     </p:spTree>
     <p:extLst>
       <p:ext uri="{BB962C8B-B14F-4D97-AF65-F5344CB8AC3E}">
-        <p14:creationId xmlns:p14="http://schemas.microsoft.com/office/powerpoint/2010/main" val="1166656885"/>
+        <p14:creationId xmlns:p14="http://schemas.microsoft.com/office/powerpoint/2010/main" val="1058272750"/>
       </p:ext>
     </p:extLst>
   </p:cSld>
@@ -6308,7 +6313,7 @@
           <p:cNvPr id="14" name="rail-12">
             <a:extLst xmlns:a="http://schemas.openxmlformats.org/drawingml/2006/main">
               <a:ext uri="{FF2B5EF4-FFF2-40B4-BE49-F238E27FC236}">
-                <a16:creationId xmlns:a16="http://schemas.microsoft.com/office/drawing/2014/main" id="{A984D337-9C3C-41A4-88E8-92B6440D27B2}"/>
+                <a16:creationId xmlns:a16="http://schemas.microsoft.com/office/drawing/2014/main" id="{7DBED2C2-1109-4B4E-9B1B-44E6B0C902F5}"/>
               </a:ext>
             </a:extLst>
           </p:cNvPr>
@@ -6341,7 +6346,7 @@
           <p:cNvPr id="2" name="flourish-12">
             <a:extLst xmlns:a="http://schemas.openxmlformats.org/drawingml/2006/main">
               <a:ext uri="{FF2B5EF4-FFF2-40B4-BE49-F238E27FC236}">
-                <a16:creationId xmlns:a16="http://schemas.microsoft.com/office/drawing/2014/main" id="{9AD2B6A5-D52D-4700-815C-0559E6DF5A25}"/>
+                <a16:creationId xmlns:a16="http://schemas.microsoft.com/office/drawing/2014/main" id="{3D416E70-C4D7-465A-9BD3-A4EC634F0FB4}"/>
               </a:ext>
             </a:extLst>
           </p:cNvPr>
@@ -6391,7 +6396,7 @@
           <p:cNvPr id="3" name="chapter-12">
             <a:extLst xmlns:a="http://schemas.openxmlformats.org/drawingml/2006/main">
               <a:ext uri="{FF2B5EF4-FFF2-40B4-BE49-F238E27FC236}">
-                <a16:creationId xmlns:a16="http://schemas.microsoft.com/office/drawing/2014/main" id="{561371D5-F5A6-4F37-A50B-7150EA8F9ECD}"/>
+                <a16:creationId xmlns:a16="http://schemas.microsoft.com/office/drawing/2014/main" id="{B95EFD7C-A162-4778-B2CD-FC56ABFCCA2E}"/>
               </a:ext>
             </a:extLst>
           </p:cNvPr>
@@ -6441,7 +6446,7 @@
           <p:cNvPr id="4" name="title-12">
             <a:extLst xmlns:a="http://schemas.openxmlformats.org/drawingml/2006/main">
               <a:ext uri="{FF2B5EF4-FFF2-40B4-BE49-F238E27FC236}">
-                <a16:creationId xmlns:a16="http://schemas.microsoft.com/office/drawing/2014/main" id="{7A504ABA-9BDB-4198-99A0-93BBB3CA735D}"/>
+                <a16:creationId xmlns:a16="http://schemas.microsoft.com/office/drawing/2014/main" id="{235A6694-7EF1-4B58-AC5D-5A497BCAA341}"/>
               </a:ext>
             </a:extLst>
           </p:cNvPr>
@@ -6481,7 +6486,7 @@
                   <a:srgbClr val="071A2B"/>
                 </a:solidFill>
               </a:rPr>
-              <a:t>官方 benchmark 没跑，就不应该出现一个分数</a:t>
+              <a:t>官方 benchmark 已跑通，但模型分数仍需如实面对</a:t>
             </a:r>
           </a:p>
         </p:txBody>
@@ -6491,7 +6496,7 @@
           <p:cNvPr id="5" name="subtitle-12">
             <a:extLst xmlns:a="http://schemas.openxmlformats.org/drawingml/2006/main">
               <a:ext uri="{FF2B5EF4-FFF2-40B4-BE49-F238E27FC236}">
-                <a16:creationId xmlns:a16="http://schemas.microsoft.com/office/drawing/2014/main" id="{0F997E42-AE1E-48C5-91D2-2F88B07B93BB}"/>
+                <a16:creationId xmlns:a16="http://schemas.microsoft.com/office/drawing/2014/main" id="{46028726-E087-4706-8CFC-C6209F0401FB}"/>
               </a:ext>
             </a:extLst>
           </p:cNvPr>
@@ -6531,7 +6536,7 @@
                   <a:srgbClr val="64747B"/>
                 </a:solidFill>
               </a:rPr>
-              <a:t>本次验证的是自建 stateful curriculum；BFCL/TAU-2 代码路径保留，但状态必须明确写成 NOT RUN。</a:t>
+              <a:t>本次完成官方 BFCL-V4 multi-turn smoke；PASS 只表示结果与评分 artifact 齐全，不能替代模型质量得分。</a:t>
             </a:r>
           </a:p>
         </p:txBody>
@@ -6541,7 +6546,7 @@
           <p:cNvPr id="6" name="">
             <a:extLst xmlns:a="http://schemas.openxmlformats.org/drawingml/2006/main">
               <a:ext uri="{FF2B5EF4-FFF2-40B4-BE49-F238E27FC236}">
-                <a16:creationId xmlns:a16="http://schemas.microsoft.com/office/drawing/2014/main" id="{EB5B6B54-A759-41EF-A1FF-B1524416B983}"/>
+                <a16:creationId xmlns:a16="http://schemas.microsoft.com/office/drawing/2014/main" id="{AB994FC7-7564-4B0E-8AA8-B1AD8CC04D08}"/>
               </a:ext>
             </a:extLst>
           </p:cNvPr>
@@ -6572,7 +6577,7 @@
           <p:cNvPr id="7" name="page-12">
             <a:extLst xmlns:a="http://schemas.openxmlformats.org/drawingml/2006/main">
               <a:ext uri="{FF2B5EF4-FFF2-40B4-BE49-F238E27FC236}">
-                <a16:creationId xmlns:a16="http://schemas.microsoft.com/office/drawing/2014/main" id="{439F076A-BCC2-49F5-A297-6EFDBA9C1481}"/>
+                <a16:creationId xmlns:a16="http://schemas.microsoft.com/office/drawing/2014/main" id="{EC28B5B3-50CA-4734-8AD7-7E3353AA5D43}"/>
               </a:ext>
             </a:extLst>
           </p:cNvPr>
@@ -6622,19 +6627,19 @@
           <p:cNvPr id="8" name="benchmark-status">
             <a:extLst xmlns:a="http://schemas.openxmlformats.org/drawingml/2006/main">
               <a:ext uri="{FF2B5EF4-FFF2-40B4-BE49-F238E27FC236}">
-                <a16:creationId xmlns:a16="http://schemas.microsoft.com/office/drawing/2014/main" id="{01D2B942-E666-4238-94FE-3885935FE395}"/>
-              </a:ext>
-            </a:extLst>
-          </p:cNvPr>
-          <p:cNvSpPr>
-            <a:spLocks xmlns:a="http://schemas.openxmlformats.org/drawingml/2006/main" noGrp="1"/>
-          </p:cNvSpPr>
-          <p:nvPr/>
-        </p:nvSpPr>
-        <p:spPr>
-          <a:xfrm xmlns:a="http://schemas.openxmlformats.org/drawingml/2006/main">
-            <a:off x="714375" y="2190750"/>
-            <a:ext cx="4476750" cy="1428750"/>
+                <a16:creationId xmlns:a16="http://schemas.microsoft.com/office/drawing/2014/main" id="{D35BB56E-DDB1-440B-8E6E-CD23935A4D81}"/>
+              </a:ext>
+            </a:extLst>
+          </p:cNvPr>
+          <p:cNvSpPr>
+            <a:spLocks xmlns:a="http://schemas.openxmlformats.org/drawingml/2006/main" noGrp="1"/>
+          </p:cNvSpPr>
+          <p:nvPr/>
+        </p:nvSpPr>
+        <p:spPr>
+          <a:xfrm xmlns:a="http://schemas.openxmlformats.org/drawingml/2006/main">
+            <a:off x="523875" y="2190750"/>
+            <a:ext cx="4857750" cy="1428750"/>
           </a:xfrm>
           <a:prstGeom xmlns:a="http://schemas.openxmlformats.org/drawingml/2006/main" prst="rect">
             <a:avLst/>
@@ -6650,19 +6655,19 @@
           <a:lstStyle xmlns:a="http://schemas.openxmlformats.org/drawingml/2006/main"/>
           <a:p xmlns:a="http://schemas.openxmlformats.org/drawingml/2006/main">
             <a:pPr algn="ctr">
-              <a:defRPr sz="5850" b="1">
+              <a:defRPr sz="2775" b="1">
                 <a:solidFill>
                   <a:srgbClr val="C56D4A"/>
                 </a:solidFill>
               </a:defRPr>
             </a:pPr>
             <a:r>
-              <a:rPr sz="5850" b="1">
+              <a:rPr sz="2775" b="1">
                 <a:solidFill>
                   <a:srgbClr val="C56D4A"/>
                 </a:solidFill>
               </a:rPr>
-              <a:t>NOT RUN</a:t>
+              <a:t>官方流水线 PASS · base 0.00% · Stage-2 0.00%</a:t>
             </a:r>
           </a:p>
         </p:txBody>
@@ -6672,7 +6677,7 @@
           <p:cNvPr id="9" name="benchmark-label">
             <a:extLst xmlns:a="http://schemas.openxmlformats.org/drawingml/2006/main">
               <a:ext uri="{FF2B5EF4-FFF2-40B4-BE49-F238E27FC236}">
-                <a16:creationId xmlns:a16="http://schemas.microsoft.com/office/drawing/2014/main" id="{3C72E84F-8AB8-4C7E-9232-3065B31F5DC7}"/>
+                <a16:creationId xmlns:a16="http://schemas.microsoft.com/office/drawing/2014/main" id="{488DBD12-EF22-46EE-9473-0E66558DC275}"/>
               </a:ext>
             </a:extLst>
           </p:cNvPr>
@@ -6722,7 +6727,7 @@
           <p:cNvPr id="10" name="">
             <a:extLst xmlns:a="http://schemas.openxmlformats.org/drawingml/2006/main">
               <a:ext uri="{FF2B5EF4-FFF2-40B4-BE49-F238E27FC236}">
-                <a16:creationId xmlns:a16="http://schemas.microsoft.com/office/drawing/2014/main" id="{E06BC403-4C1F-4FE7-98FC-9522A2787465}"/>
+                <a16:creationId xmlns:a16="http://schemas.microsoft.com/office/drawing/2014/main" id="{5485A806-CC9E-4F76-AFDA-D360453B913A}"/>
               </a:ext>
             </a:extLst>
           </p:cNvPr>
@@ -6753,7 +6758,7 @@
           <p:cNvPr id="11" name="benchmark-ready">
             <a:extLst xmlns:a="http://schemas.openxmlformats.org/drawingml/2006/main">
               <a:ext uri="{FF2B5EF4-FFF2-40B4-BE49-F238E27FC236}">
-                <a16:creationId xmlns:a16="http://schemas.microsoft.com/office/drawing/2014/main" id="{AEEE6967-3D77-4F34-A460-D5E983AD8F19}"/>
+                <a16:creationId xmlns:a16="http://schemas.microsoft.com/office/drawing/2014/main" id="{0E4F8E1E-68F1-4C84-8ED7-2281AE95C0BC}"/>
               </a:ext>
             </a:extLst>
           </p:cNvPr>
@@ -6803,7 +6808,7 @@
           <p:cNvPr id="12" name="benchmark-list">
             <a:extLst xmlns:a="http://schemas.openxmlformats.org/drawingml/2006/main">
               <a:ext uri="{FF2B5EF4-FFF2-40B4-BE49-F238E27FC236}">
-                <a16:creationId xmlns:a16="http://schemas.microsoft.com/office/drawing/2014/main" id="{0F90DE71-DAF6-4BFE-90A8-7A64A27D4FF3}"/>
+                <a16:creationId xmlns:a16="http://schemas.microsoft.com/office/drawing/2014/main" id="{4F530AD8-E068-4401-AD89-4927670650EF}"/>
               </a:ext>
             </a:extLst>
           </p:cNvPr>
@@ -6889,7 +6894,7 @@
                   <a:srgbClr val="64747B"/>
                 </a:solidFill>
               </a:rPr>
-              <a:t>• smoke 与 4×200 paper profile 分开</a:t>
+              <a:t>• 4 个类别各 1 题，属于 smoke，不是论文规模</a:t>
             </a:r>
           </a:p>
           <a:p xmlns:a="http://schemas.openxmlformats.org/drawingml/2006/main">
@@ -6910,7 +6915,7 @@
                   <a:srgbClr val="64747B"/>
                 </a:solidFill>
               </a:rPr>
-              <a:t>• 缺 manifest 时报告和 PPT 不生成分数</a:t>
+              <a:t>• 流水线 PASS ≠ 模型得分 PASS（本次得分为 0.00%）</a:t>
             </a:r>
           </a:p>
         </p:txBody>
@@ -6920,19 +6925,19 @@
           <p:cNvPr id="13" name="benchmark-boundary">
             <a:extLst xmlns:a="http://schemas.openxmlformats.org/drawingml/2006/main">
               <a:ext uri="{FF2B5EF4-FFF2-40B4-BE49-F238E27FC236}">
-                <a16:creationId xmlns:a16="http://schemas.microsoft.com/office/drawing/2014/main" id="{EBD72A3C-0A66-4D2B-BE04-44349F8ADA5B}"/>
-              </a:ext>
-            </a:extLst>
-          </p:cNvPr>
-          <p:cNvSpPr>
-            <a:spLocks xmlns:a="http://schemas.openxmlformats.org/drawingml/2006/main" noGrp="1"/>
-          </p:cNvSpPr>
-          <p:nvPr/>
-        </p:nvSpPr>
-        <p:spPr>
-          <a:xfrm xmlns:a="http://schemas.openxmlformats.org/drawingml/2006/main">
-            <a:off x="1666875" y="5476875"/>
-            <a:ext cx="8858250" cy="400050"/>
+                <a16:creationId xmlns:a16="http://schemas.microsoft.com/office/drawing/2014/main" id="{DE483CF6-7947-414F-8A8B-3C8033E85DA6}"/>
+              </a:ext>
+            </a:extLst>
+          </p:cNvPr>
+          <p:cNvSpPr>
+            <a:spLocks xmlns:a="http://schemas.openxmlformats.org/drawingml/2006/main" noGrp="1"/>
+          </p:cNvSpPr>
+          <p:nvPr/>
+        </p:nvSpPr>
+        <p:spPr>
+          <a:xfrm xmlns:a="http://schemas.openxmlformats.org/drawingml/2006/main">
+            <a:off x="1190625" y="5476875"/>
+            <a:ext cx="9810750" cy="400050"/>
           </a:xfrm>
           <a:prstGeom xmlns:a="http://schemas.openxmlformats.org/drawingml/2006/main" prst="rect">
             <a:avLst/>
@@ -6948,19 +6953,19 @@
           <a:lstStyle xmlns:a="http://schemas.openxmlformats.org/drawingml/2006/main"/>
           <a:p xmlns:a="http://schemas.openxmlformats.org/drawingml/2006/main">
             <a:pPr algn="ctr">
-              <a:defRPr sz="1725" b="1">
+              <a:defRPr sz="1575" b="1">
                 <a:solidFill>
                   <a:srgbClr val="0B797B"/>
                 </a:solidFill>
               </a:defRPr>
             </a:pPr>
             <a:r>
-              <a:rPr sz="1725" b="1">
+              <a:rPr sz="1575" b="1">
                 <a:solidFill>
                   <a:srgbClr val="0B797B"/>
                 </a:solidFill>
               </a:rPr>
-              <a:t>能写：curriculum micro-run PASS    不能写：论文 benchmark 已复现</a:t>
+              <a:t>能写：官方 smoke 流水线 PASS、模型得分 0.00%    不能写：论文 benchmark 已复现</a:t>
             </a:r>
           </a:p>
         </p:txBody>
@@ -6968,7 +6973,7 @@
     </p:spTree>
     <p:extLst>
       <p:ext uri="{BB962C8B-B14F-4D97-AF65-F5344CB8AC3E}">
-        <p14:creationId xmlns:p14="http://schemas.microsoft.com/office/powerpoint/2010/main" val="352939769"/>
+        <p14:creationId xmlns:p14="http://schemas.microsoft.com/office/powerpoint/2010/main" val="1533858610"/>
       </p:ext>
     </p:extLst>
   </p:cSld>
@@ -6999,7 +7004,7 @@
           <p:cNvPr id="42" name="rail-13">
             <a:extLst xmlns:a="http://schemas.openxmlformats.org/drawingml/2006/main">
               <a:ext uri="{FF2B5EF4-FFF2-40B4-BE49-F238E27FC236}">
-                <a16:creationId xmlns:a16="http://schemas.microsoft.com/office/drawing/2014/main" id="{4D2449D2-A449-46F3-9605-5795C0120B5E}"/>
+                <a16:creationId xmlns:a16="http://schemas.microsoft.com/office/drawing/2014/main" id="{0FBB1F5C-9C8B-405F-8F0D-76E7EC5829CC}"/>
               </a:ext>
             </a:extLst>
           </p:cNvPr>
@@ -7032,7 +7037,7 @@
           <p:cNvPr id="2" name="flourish-13">
             <a:extLst xmlns:a="http://schemas.openxmlformats.org/drawingml/2006/main">
               <a:ext uri="{FF2B5EF4-FFF2-40B4-BE49-F238E27FC236}">
-                <a16:creationId xmlns:a16="http://schemas.microsoft.com/office/drawing/2014/main" id="{E793C783-C2B4-4059-AF67-B70D2C6B4FCE}"/>
+                <a16:creationId xmlns:a16="http://schemas.microsoft.com/office/drawing/2014/main" id="{586039B1-182B-4513-B819-254E9168B711}"/>
               </a:ext>
             </a:extLst>
           </p:cNvPr>
@@ -7082,7 +7087,7 @@
           <p:cNvPr id="3" name="chapter-13">
             <a:extLst xmlns:a="http://schemas.openxmlformats.org/drawingml/2006/main">
               <a:ext uri="{FF2B5EF4-FFF2-40B4-BE49-F238E27FC236}">
-                <a16:creationId xmlns:a16="http://schemas.microsoft.com/office/drawing/2014/main" id="{8421FB8A-D7DD-4485-ACE1-1DA3E2D95F7F}"/>
+                <a16:creationId xmlns:a16="http://schemas.microsoft.com/office/drawing/2014/main" id="{C12F7335-D728-4A1C-85ED-F9CB3ED2C55F}"/>
               </a:ext>
             </a:extLst>
           </p:cNvPr>
@@ -7132,7 +7137,7 @@
           <p:cNvPr id="4" name="title-13">
             <a:extLst xmlns:a="http://schemas.openxmlformats.org/drawingml/2006/main">
               <a:ext uri="{FF2B5EF4-FFF2-40B4-BE49-F238E27FC236}">
-                <a16:creationId xmlns:a16="http://schemas.microsoft.com/office/drawing/2014/main" id="{C3B9567E-9EAD-47D5-BA88-D94E2272398B}"/>
+                <a16:creationId xmlns:a16="http://schemas.microsoft.com/office/drawing/2014/main" id="{CD843C8C-BB08-49F7-92F2-83CC2442A83D}"/>
               </a:ext>
             </a:extLst>
           </p:cNvPr>
@@ -7182,7 +7187,7 @@
           <p:cNvPr id="5" name="subtitle-13">
             <a:extLst xmlns:a="http://schemas.openxmlformats.org/drawingml/2006/main">
               <a:ext uri="{FF2B5EF4-FFF2-40B4-BE49-F238E27FC236}">
-                <a16:creationId xmlns:a16="http://schemas.microsoft.com/office/drawing/2014/main" id="{0EF67892-131C-4489-93DE-C417A056827C}"/>
+                <a16:creationId xmlns:a16="http://schemas.microsoft.com/office/drawing/2014/main" id="{ADFF68FB-40E0-4517-8A85-09B96B993563}"/>
               </a:ext>
             </a:extLst>
           </p:cNvPr>
@@ -7232,7 +7237,7 @@
           <p:cNvPr id="6" name="">
             <a:extLst xmlns:a="http://schemas.openxmlformats.org/drawingml/2006/main">
               <a:ext uri="{FF2B5EF4-FFF2-40B4-BE49-F238E27FC236}">
-                <a16:creationId xmlns:a16="http://schemas.microsoft.com/office/drawing/2014/main" id="{1F84950F-00B5-484E-A738-9E117D0BA980}"/>
+                <a16:creationId xmlns:a16="http://schemas.microsoft.com/office/drawing/2014/main" id="{05E53B85-4BC8-4FD1-8891-8EB7D9CDAD6E}"/>
               </a:ext>
             </a:extLst>
           </p:cNvPr>
@@ -7263,7 +7268,7 @@
           <p:cNvPr id="7" name="page-13">
             <a:extLst xmlns:a="http://schemas.openxmlformats.org/drawingml/2006/main">
               <a:ext uri="{FF2B5EF4-FFF2-40B4-BE49-F238E27FC236}">
-                <a16:creationId xmlns:a16="http://schemas.microsoft.com/office/drawing/2014/main" id="{B149894F-1736-47BC-8911-2BECBF65E6D8}"/>
+                <a16:creationId xmlns:a16="http://schemas.microsoft.com/office/drawing/2014/main" id="{2EE004D4-C4E8-44E0-B801-C275E73CCF25}"/>
               </a:ext>
             </a:extLst>
           </p:cNvPr>
@@ -7313,7 +7318,7 @@
           <p:cNvPr id="8" name="audit-bg-0">
             <a:extLst xmlns:a="http://schemas.openxmlformats.org/drawingml/2006/main">
               <a:ext uri="{FF2B5EF4-FFF2-40B4-BE49-F238E27FC236}">
-                <a16:creationId xmlns:a16="http://schemas.microsoft.com/office/drawing/2014/main" id="{E18390E8-4C00-4338-A862-90E4E28DFA04}"/>
+                <a16:creationId xmlns:a16="http://schemas.microsoft.com/office/drawing/2014/main" id="{450422E3-8049-4423-841F-568B44E19C8A}"/>
               </a:ext>
             </a:extLst>
           </p:cNvPr>
@@ -7348,7 +7353,7 @@
           <p:cNvPr id="9" name="audit-pill-0-bg">
             <a:extLst xmlns:a="http://schemas.openxmlformats.org/drawingml/2006/main">
               <a:ext uri="{FF2B5EF4-FFF2-40B4-BE49-F238E27FC236}">
-                <a16:creationId xmlns:a16="http://schemas.microsoft.com/office/drawing/2014/main" id="{9E785704-8EDC-476E-B248-7C2E130725E7}"/>
+                <a16:creationId xmlns:a16="http://schemas.microsoft.com/office/drawing/2014/main" id="{744B9330-60DE-4218-B47B-3E02B7307535}"/>
               </a:ext>
             </a:extLst>
           </p:cNvPr>
@@ -7383,7 +7388,7 @@
           <p:cNvPr id="10" name="audit-pill-0-text">
             <a:extLst xmlns:a="http://schemas.openxmlformats.org/drawingml/2006/main">
               <a:ext uri="{FF2B5EF4-FFF2-40B4-BE49-F238E27FC236}">
-                <a16:creationId xmlns:a16="http://schemas.microsoft.com/office/drawing/2014/main" id="{4B5A7504-1152-49D0-9347-F5744142E916}"/>
+                <a16:creationId xmlns:a16="http://schemas.microsoft.com/office/drawing/2014/main" id="{86336609-370D-4560-ACC1-30CCA83360FF}"/>
               </a:ext>
             </a:extLst>
           </p:cNvPr>
@@ -7433,7 +7438,7 @@
           <p:cNvPr id="11" name="audit-name-0">
             <a:extLst xmlns:a="http://schemas.openxmlformats.org/drawingml/2006/main">
               <a:ext uri="{FF2B5EF4-FFF2-40B4-BE49-F238E27FC236}">
-                <a16:creationId xmlns:a16="http://schemas.microsoft.com/office/drawing/2014/main" id="{590892B8-3BA1-4532-8E75-1389839232AB}"/>
+                <a16:creationId xmlns:a16="http://schemas.microsoft.com/office/drawing/2014/main" id="{BB81F361-260F-4BF7-9847-CC5D5C297A93}"/>
               </a:ext>
             </a:extLst>
           </p:cNvPr>
@@ -7483,7 +7488,7 @@
           <p:cNvPr id="12" name="audit-bg-1">
             <a:extLst xmlns:a="http://schemas.openxmlformats.org/drawingml/2006/main">
               <a:ext uri="{FF2B5EF4-FFF2-40B4-BE49-F238E27FC236}">
-                <a16:creationId xmlns:a16="http://schemas.microsoft.com/office/drawing/2014/main" id="{EFB26290-595E-412E-8798-B81B9B0F664E}"/>
+                <a16:creationId xmlns:a16="http://schemas.microsoft.com/office/drawing/2014/main" id="{E7E8A1DA-EC56-4B72-A05C-C013ABC46D70}"/>
               </a:ext>
             </a:extLst>
           </p:cNvPr>
@@ -7518,7 +7523,7 @@
           <p:cNvPr id="13" name="audit-pill-1-bg">
             <a:extLst xmlns:a="http://schemas.openxmlformats.org/drawingml/2006/main">
               <a:ext uri="{FF2B5EF4-FFF2-40B4-BE49-F238E27FC236}">
-                <a16:creationId xmlns:a16="http://schemas.microsoft.com/office/drawing/2014/main" id="{8BACFDE8-EF38-4396-99ED-D1172B8F2C94}"/>
+                <a16:creationId xmlns:a16="http://schemas.microsoft.com/office/drawing/2014/main" id="{1F8ABD38-2749-4D1E-AFF4-DA9D914893F7}"/>
               </a:ext>
             </a:extLst>
           </p:cNvPr>
@@ -7553,7 +7558,7 @@
           <p:cNvPr id="14" name="audit-pill-1-text">
             <a:extLst xmlns:a="http://schemas.openxmlformats.org/drawingml/2006/main">
               <a:ext uri="{FF2B5EF4-FFF2-40B4-BE49-F238E27FC236}">
-                <a16:creationId xmlns:a16="http://schemas.microsoft.com/office/drawing/2014/main" id="{21EA203D-BCAA-4C3D-A7AB-ADE7E0445287}"/>
+                <a16:creationId xmlns:a16="http://schemas.microsoft.com/office/drawing/2014/main" id="{51CE7948-1FB5-41B8-9E3A-DC97EA4C4B74}"/>
               </a:ext>
             </a:extLst>
           </p:cNvPr>
@@ -7603,7 +7608,7 @@
           <p:cNvPr id="15" name="audit-name-1">
             <a:extLst xmlns:a="http://schemas.openxmlformats.org/drawingml/2006/main">
               <a:ext uri="{FF2B5EF4-FFF2-40B4-BE49-F238E27FC236}">
-                <a16:creationId xmlns:a16="http://schemas.microsoft.com/office/drawing/2014/main" id="{4EF6F57A-79D8-491D-AA3C-F3996918FCCD}"/>
+                <a16:creationId xmlns:a16="http://schemas.microsoft.com/office/drawing/2014/main" id="{1DF6C1B3-89CB-4045-8F67-B9BFAA934798}"/>
               </a:ext>
             </a:extLst>
           </p:cNvPr>
@@ -7653,7 +7658,7 @@
           <p:cNvPr id="16" name="audit-bg-2">
             <a:extLst xmlns:a="http://schemas.openxmlformats.org/drawingml/2006/main">
               <a:ext uri="{FF2B5EF4-FFF2-40B4-BE49-F238E27FC236}">
-                <a16:creationId xmlns:a16="http://schemas.microsoft.com/office/drawing/2014/main" id="{02219D7D-0782-4C3D-A51E-D6BE02A60962}"/>
+                <a16:creationId xmlns:a16="http://schemas.microsoft.com/office/drawing/2014/main" id="{CCFDD183-37F2-4774-8D21-36E97BA5D3A3}"/>
               </a:ext>
             </a:extLst>
           </p:cNvPr>
@@ -7688,7 +7693,7 @@
           <p:cNvPr id="17" name="audit-pill-2-bg">
             <a:extLst xmlns:a="http://schemas.openxmlformats.org/drawingml/2006/main">
               <a:ext uri="{FF2B5EF4-FFF2-40B4-BE49-F238E27FC236}">
-                <a16:creationId xmlns:a16="http://schemas.microsoft.com/office/drawing/2014/main" id="{2CDC8CB2-C78B-4051-BC7D-CB8F90E666DF}"/>
+                <a16:creationId xmlns:a16="http://schemas.microsoft.com/office/drawing/2014/main" id="{FDFB4156-B9F9-4FCA-A8B3-5DE5DDAF8ACC}"/>
               </a:ext>
             </a:extLst>
           </p:cNvPr>
@@ -7723,7 +7728,7 @@
           <p:cNvPr id="18" name="audit-pill-2-text">
             <a:extLst xmlns:a="http://schemas.openxmlformats.org/drawingml/2006/main">
               <a:ext uri="{FF2B5EF4-FFF2-40B4-BE49-F238E27FC236}">
-                <a16:creationId xmlns:a16="http://schemas.microsoft.com/office/drawing/2014/main" id="{C49F3254-1DC2-4A3E-BE03-32439F29FD4C}"/>
+                <a16:creationId xmlns:a16="http://schemas.microsoft.com/office/drawing/2014/main" id="{ECA28ECB-DF93-42CE-BA9B-421E8EA87470}"/>
               </a:ext>
             </a:extLst>
           </p:cNvPr>
@@ -7773,7 +7778,7 @@
           <p:cNvPr id="19" name="audit-name-2">
             <a:extLst xmlns:a="http://schemas.openxmlformats.org/drawingml/2006/main">
               <a:ext uri="{FF2B5EF4-FFF2-40B4-BE49-F238E27FC236}">
-                <a16:creationId xmlns:a16="http://schemas.microsoft.com/office/drawing/2014/main" id="{42C1948D-F8B5-4C2F-BEE7-87ED30B5EB50}"/>
+                <a16:creationId xmlns:a16="http://schemas.microsoft.com/office/drawing/2014/main" id="{F1F70CB4-646A-4FC4-B743-DCA573E2FE9D}"/>
               </a:ext>
             </a:extLst>
           </p:cNvPr>
@@ -7823,7 +7828,7 @@
           <p:cNvPr id="20" name="audit-bg-3">
             <a:extLst xmlns:a="http://schemas.openxmlformats.org/drawingml/2006/main">
               <a:ext uri="{FF2B5EF4-FFF2-40B4-BE49-F238E27FC236}">
-                <a16:creationId xmlns:a16="http://schemas.microsoft.com/office/drawing/2014/main" id="{66D4C7D0-9504-48FD-BB8E-745411994683}"/>
+                <a16:creationId xmlns:a16="http://schemas.microsoft.com/office/drawing/2014/main" id="{8D2F535C-33DF-41F8-ADF5-45AA1A44A8B4}"/>
               </a:ext>
             </a:extLst>
           </p:cNvPr>
@@ -7858,7 +7863,7 @@
           <p:cNvPr id="21" name="audit-pill-3-bg">
             <a:extLst xmlns:a="http://schemas.openxmlformats.org/drawingml/2006/main">
               <a:ext uri="{FF2B5EF4-FFF2-40B4-BE49-F238E27FC236}">
-                <a16:creationId xmlns:a16="http://schemas.microsoft.com/office/drawing/2014/main" id="{9CA4CE5E-532C-4750-956E-2FE4F3089081}"/>
+                <a16:creationId xmlns:a16="http://schemas.microsoft.com/office/drawing/2014/main" id="{7EB444F9-C9F0-4FA9-B4F7-CF068F5A02CE}"/>
               </a:ext>
             </a:extLst>
           </p:cNvPr>
@@ -7893,7 +7898,7 @@
           <p:cNvPr id="22" name="audit-pill-3-text">
             <a:extLst xmlns:a="http://schemas.openxmlformats.org/drawingml/2006/main">
               <a:ext uri="{FF2B5EF4-FFF2-40B4-BE49-F238E27FC236}">
-                <a16:creationId xmlns:a16="http://schemas.microsoft.com/office/drawing/2014/main" id="{D770A415-D1C5-4FBE-9829-249205C636B6}"/>
+                <a16:creationId xmlns:a16="http://schemas.microsoft.com/office/drawing/2014/main" id="{6DCAAE8D-C13F-4173-BF43-8394BC5EF68B}"/>
               </a:ext>
             </a:extLst>
           </p:cNvPr>
@@ -7943,7 +7948,7 @@
           <p:cNvPr id="23" name="audit-name-3">
             <a:extLst xmlns:a="http://schemas.openxmlformats.org/drawingml/2006/main">
               <a:ext uri="{FF2B5EF4-FFF2-40B4-BE49-F238E27FC236}">
-                <a16:creationId xmlns:a16="http://schemas.microsoft.com/office/drawing/2014/main" id="{23DF560D-6762-4598-A68B-FD9860B92396}"/>
+                <a16:creationId xmlns:a16="http://schemas.microsoft.com/office/drawing/2014/main" id="{8C4AC109-C200-42B1-8560-ED65966F454A}"/>
               </a:ext>
             </a:extLst>
           </p:cNvPr>
@@ -7993,7 +7998,7 @@
           <p:cNvPr id="24" name="audit-bg-4">
             <a:extLst xmlns:a="http://schemas.openxmlformats.org/drawingml/2006/main">
               <a:ext uri="{FF2B5EF4-FFF2-40B4-BE49-F238E27FC236}">
-                <a16:creationId xmlns:a16="http://schemas.microsoft.com/office/drawing/2014/main" id="{9369210E-7414-4FD8-816F-397B1423B268}"/>
+                <a16:creationId xmlns:a16="http://schemas.microsoft.com/office/drawing/2014/main" id="{D5401B5B-224F-42A5-9683-4913EB098B0F}"/>
               </a:ext>
             </a:extLst>
           </p:cNvPr>
@@ -8028,7 +8033,7 @@
           <p:cNvPr id="25" name="audit-pill-4-bg">
             <a:extLst xmlns:a="http://schemas.openxmlformats.org/drawingml/2006/main">
               <a:ext uri="{FF2B5EF4-FFF2-40B4-BE49-F238E27FC236}">
-                <a16:creationId xmlns:a16="http://schemas.microsoft.com/office/drawing/2014/main" id="{2D92F620-EFE9-47F1-B900-542B2C0021D7}"/>
+                <a16:creationId xmlns:a16="http://schemas.microsoft.com/office/drawing/2014/main" id="{12B93ED4-DD0F-4620-9398-E05AC02750AE}"/>
               </a:ext>
             </a:extLst>
           </p:cNvPr>
@@ -8063,7 +8068,7 @@
           <p:cNvPr id="26" name="audit-pill-4-text">
             <a:extLst xmlns:a="http://schemas.openxmlformats.org/drawingml/2006/main">
               <a:ext uri="{FF2B5EF4-FFF2-40B4-BE49-F238E27FC236}">
-                <a16:creationId xmlns:a16="http://schemas.microsoft.com/office/drawing/2014/main" id="{567233B0-9BA3-4E60-A2EE-B8018C306C0E}"/>
+                <a16:creationId xmlns:a16="http://schemas.microsoft.com/office/drawing/2014/main" id="{C60CCB61-FE7A-4637-9BB7-B9854909FEF1}"/>
               </a:ext>
             </a:extLst>
           </p:cNvPr>
@@ -8113,7 +8118,7 @@
           <p:cNvPr id="27" name="audit-name-4">
             <a:extLst xmlns:a="http://schemas.openxmlformats.org/drawingml/2006/main">
               <a:ext uri="{FF2B5EF4-FFF2-40B4-BE49-F238E27FC236}">
-                <a16:creationId xmlns:a16="http://schemas.microsoft.com/office/drawing/2014/main" id="{042EBF2A-71A8-41BD-8D9E-0894A275E528}"/>
+                <a16:creationId xmlns:a16="http://schemas.microsoft.com/office/drawing/2014/main" id="{F49068F4-9D75-4F06-A733-F31BD4279D28}"/>
               </a:ext>
             </a:extLst>
           </p:cNvPr>
@@ -8163,7 +8168,7 @@
           <p:cNvPr id="28" name="audit-bg-5">
             <a:extLst xmlns:a="http://schemas.openxmlformats.org/drawingml/2006/main">
               <a:ext uri="{FF2B5EF4-FFF2-40B4-BE49-F238E27FC236}">
-                <a16:creationId xmlns:a16="http://schemas.microsoft.com/office/drawing/2014/main" id="{26C5818B-1C3F-44F9-ADF3-21A98414A76D}"/>
+                <a16:creationId xmlns:a16="http://schemas.microsoft.com/office/drawing/2014/main" id="{0171B229-61F4-4A2C-B89A-9DE049592B3A}"/>
               </a:ext>
             </a:extLst>
           </p:cNvPr>
@@ -8198,7 +8203,7 @@
           <p:cNvPr id="29" name="audit-pill-5-bg">
             <a:extLst xmlns:a="http://schemas.openxmlformats.org/drawingml/2006/main">
               <a:ext uri="{FF2B5EF4-FFF2-40B4-BE49-F238E27FC236}">
-                <a16:creationId xmlns:a16="http://schemas.microsoft.com/office/drawing/2014/main" id="{388CEC4D-08A4-4238-86AE-B134786BC765}"/>
+                <a16:creationId xmlns:a16="http://schemas.microsoft.com/office/drawing/2014/main" id="{754E400E-A8C2-47E5-B193-4CB30E5AA27D}"/>
               </a:ext>
             </a:extLst>
           </p:cNvPr>
@@ -8233,7 +8238,7 @@
           <p:cNvPr id="30" name="audit-pill-5-text">
             <a:extLst xmlns:a="http://schemas.openxmlformats.org/drawingml/2006/main">
               <a:ext uri="{FF2B5EF4-FFF2-40B4-BE49-F238E27FC236}">
-                <a16:creationId xmlns:a16="http://schemas.microsoft.com/office/drawing/2014/main" id="{B848046E-C889-4653-98C6-83A630C4FA48}"/>
+                <a16:creationId xmlns:a16="http://schemas.microsoft.com/office/drawing/2014/main" id="{B68DF527-A59A-4E4E-814E-9FD9A90BC44F}"/>
               </a:ext>
             </a:extLst>
           </p:cNvPr>
@@ -8283,7 +8288,7 @@
           <p:cNvPr id="31" name="audit-name-5">
             <a:extLst xmlns:a="http://schemas.openxmlformats.org/drawingml/2006/main">
               <a:ext uri="{FF2B5EF4-FFF2-40B4-BE49-F238E27FC236}">
-                <a16:creationId xmlns:a16="http://schemas.microsoft.com/office/drawing/2014/main" id="{2BD07168-858A-4E3C-88F9-0AD19D5DDCBF}"/>
+                <a16:creationId xmlns:a16="http://schemas.microsoft.com/office/drawing/2014/main" id="{E0E372E5-744F-420E-B37C-D70E3BE3F473}"/>
               </a:ext>
             </a:extLst>
           </p:cNvPr>
@@ -8333,7 +8338,7 @@
           <p:cNvPr id="32" name="audit-bg-6">
             <a:extLst xmlns:a="http://schemas.openxmlformats.org/drawingml/2006/main">
               <a:ext uri="{FF2B5EF4-FFF2-40B4-BE49-F238E27FC236}">
-                <a16:creationId xmlns:a16="http://schemas.microsoft.com/office/drawing/2014/main" id="{5F8F0E62-ABCF-4938-9E11-5BCC8B456401}"/>
+                <a16:creationId xmlns:a16="http://schemas.microsoft.com/office/drawing/2014/main" id="{97E14EBF-C72C-49DA-9CD2-B8925F04C907}"/>
               </a:ext>
             </a:extLst>
           </p:cNvPr>
@@ -8368,7 +8373,7 @@
           <p:cNvPr id="33" name="audit-pill-6-bg">
             <a:extLst xmlns:a="http://schemas.openxmlformats.org/drawingml/2006/main">
               <a:ext uri="{FF2B5EF4-FFF2-40B4-BE49-F238E27FC236}">
-                <a16:creationId xmlns:a16="http://schemas.microsoft.com/office/drawing/2014/main" id="{5BEB3EA9-73AD-4D66-BB11-EB6A90528457}"/>
+                <a16:creationId xmlns:a16="http://schemas.microsoft.com/office/drawing/2014/main" id="{30B4D637-091A-4F56-9023-207DBC36D177}"/>
               </a:ext>
             </a:extLst>
           </p:cNvPr>
@@ -8403,7 +8408,7 @@
           <p:cNvPr id="34" name="audit-pill-6-text">
             <a:extLst xmlns:a="http://schemas.openxmlformats.org/drawingml/2006/main">
               <a:ext uri="{FF2B5EF4-FFF2-40B4-BE49-F238E27FC236}">
-                <a16:creationId xmlns:a16="http://schemas.microsoft.com/office/drawing/2014/main" id="{552EE86E-2D7F-4013-89BF-7C03AD28B20D}"/>
+                <a16:creationId xmlns:a16="http://schemas.microsoft.com/office/drawing/2014/main" id="{5914E9FA-5ECB-41BF-ABF9-72380D413D6F}"/>
               </a:ext>
             </a:extLst>
           </p:cNvPr>
@@ -8453,7 +8458,7 @@
           <p:cNvPr id="35" name="audit-name-6">
             <a:extLst xmlns:a="http://schemas.openxmlformats.org/drawingml/2006/main">
               <a:ext uri="{FF2B5EF4-FFF2-40B4-BE49-F238E27FC236}">
-                <a16:creationId xmlns:a16="http://schemas.microsoft.com/office/drawing/2014/main" id="{E1EBC173-5E98-44C1-8F93-B52EDECD7DE1}"/>
+                <a16:creationId xmlns:a16="http://schemas.microsoft.com/office/drawing/2014/main" id="{F7471D21-B31E-4BDA-85DF-AD3B60CA02A5}"/>
               </a:ext>
             </a:extLst>
           </p:cNvPr>
@@ -8503,7 +8508,7 @@
           <p:cNvPr id="36" name="audit-bg-7">
             <a:extLst xmlns:a="http://schemas.openxmlformats.org/drawingml/2006/main">
               <a:ext uri="{FF2B5EF4-FFF2-40B4-BE49-F238E27FC236}">
-                <a16:creationId xmlns:a16="http://schemas.microsoft.com/office/drawing/2014/main" id="{F99EEAF8-D532-4F56-8E1B-86078270154B}"/>
+                <a16:creationId xmlns:a16="http://schemas.microsoft.com/office/drawing/2014/main" id="{70FB99AA-F56A-4F41-8939-89254E069E03}"/>
               </a:ext>
             </a:extLst>
           </p:cNvPr>
@@ -8538,7 +8543,7 @@
           <p:cNvPr id="37" name="audit-pill-7-bg">
             <a:extLst xmlns:a="http://schemas.openxmlformats.org/drawingml/2006/main">
               <a:ext uri="{FF2B5EF4-FFF2-40B4-BE49-F238E27FC236}">
-                <a16:creationId xmlns:a16="http://schemas.microsoft.com/office/drawing/2014/main" id="{34DAD203-4088-403E-A561-F7A332816DED}"/>
+                <a16:creationId xmlns:a16="http://schemas.microsoft.com/office/drawing/2014/main" id="{6EB6800B-758B-4AC5-AADB-27518BD303F7}"/>
               </a:ext>
             </a:extLst>
           </p:cNvPr>
@@ -8573,7 +8578,7 @@
           <p:cNvPr id="38" name="audit-pill-7-text">
             <a:extLst xmlns:a="http://schemas.openxmlformats.org/drawingml/2006/main">
               <a:ext uri="{FF2B5EF4-FFF2-40B4-BE49-F238E27FC236}">
-                <a16:creationId xmlns:a16="http://schemas.microsoft.com/office/drawing/2014/main" id="{DA0E974D-718C-465D-80C2-50996045DD75}"/>
+                <a16:creationId xmlns:a16="http://schemas.microsoft.com/office/drawing/2014/main" id="{4FFAB466-E297-450B-8CE4-FBAC1A689044}"/>
               </a:ext>
             </a:extLst>
           </p:cNvPr>
@@ -8623,7 +8628,7 @@
           <p:cNvPr id="39" name="audit-name-7">
             <a:extLst xmlns:a="http://schemas.openxmlformats.org/drawingml/2006/main">
               <a:ext uri="{FF2B5EF4-FFF2-40B4-BE49-F238E27FC236}">
-                <a16:creationId xmlns:a16="http://schemas.microsoft.com/office/drawing/2014/main" id="{30F453F1-5D94-4365-8E01-8B1095A55190}"/>
+                <a16:creationId xmlns:a16="http://schemas.microsoft.com/office/drawing/2014/main" id="{6AFE48F3-1987-4A8E-8346-709F55F0AD4F}"/>
               </a:ext>
             </a:extLst>
           </p:cNvPr>
@@ -8673,7 +8678,7 @@
           <p:cNvPr id="40" name="audit-hash">
             <a:extLst xmlns:a="http://schemas.openxmlformats.org/drawingml/2006/main">
               <a:ext uri="{FF2B5EF4-FFF2-40B4-BE49-F238E27FC236}">
-                <a16:creationId xmlns:a16="http://schemas.microsoft.com/office/drawing/2014/main" id="{70D5A568-8ABC-4193-867E-452D91615394}"/>
+                <a16:creationId xmlns:a16="http://schemas.microsoft.com/office/drawing/2014/main" id="{FC73BBEB-674D-471A-9574-52106463720A}"/>
               </a:ext>
             </a:extLst>
           </p:cNvPr>
@@ -8708,7 +8713,7 @@
           <p:cNvPr id="41" name="audit-hash-text">
             <a:extLst xmlns:a="http://schemas.openxmlformats.org/drawingml/2006/main">
               <a:ext uri="{FF2B5EF4-FFF2-40B4-BE49-F238E27FC236}">
-                <a16:creationId xmlns:a16="http://schemas.microsoft.com/office/drawing/2014/main" id="{9ADBDD96-75D7-4BEF-958E-99DFFE3706E4}"/>
+                <a16:creationId xmlns:a16="http://schemas.microsoft.com/office/drawing/2014/main" id="{EC5A7AD3-5BBF-457A-BC8D-EC15B22300D0}"/>
               </a:ext>
             </a:extLst>
           </p:cNvPr>
@@ -8748,7 +8753,7 @@
                   <a:srgbClr val="F7F1E8"/>
                 </a:solidFill>
               </a:rPr>
-              <a:t>S1 7d3c6d223209f…   →   S2 920f76c8c0f35…   ·   child PID 6913</a:t>
+              <a:t>S1 f0fad889000fb…   →   S2 ea699445f74d8…   ·   child PID 72418</a:t>
             </a:r>
           </a:p>
         </p:txBody>
@@ -8756,7 +8761,7 @@
     </p:spTree>
     <p:extLst>
       <p:ext uri="{BB962C8B-B14F-4D97-AF65-F5344CB8AC3E}">
-        <p14:creationId xmlns:p14="http://schemas.microsoft.com/office/powerpoint/2010/main" val="1067733725"/>
+        <p14:creationId xmlns:p14="http://schemas.microsoft.com/office/powerpoint/2010/main" val="411111673"/>
       </p:ext>
     </p:extLst>
   </p:cSld>
@@ -8787,7 +8792,7 @@
           <p:cNvPr id="26" name="rail-14">
             <a:extLst xmlns:a="http://schemas.openxmlformats.org/drawingml/2006/main">
               <a:ext uri="{FF2B5EF4-FFF2-40B4-BE49-F238E27FC236}">
-                <a16:creationId xmlns:a16="http://schemas.microsoft.com/office/drawing/2014/main" id="{51535F1D-A575-4799-ADA8-7C1DF786BCEF}"/>
+                <a16:creationId xmlns:a16="http://schemas.microsoft.com/office/drawing/2014/main" id="{0F7BB806-C3DB-4889-81A3-0429FAAFBC49}"/>
               </a:ext>
             </a:extLst>
           </p:cNvPr>
@@ -8820,7 +8825,7 @@
           <p:cNvPr id="2" name="flourish-14">
             <a:extLst xmlns:a="http://schemas.openxmlformats.org/drawingml/2006/main">
               <a:ext uri="{FF2B5EF4-FFF2-40B4-BE49-F238E27FC236}">
-                <a16:creationId xmlns:a16="http://schemas.microsoft.com/office/drawing/2014/main" id="{15AAD097-5167-4892-ACA9-071EA2CC7372}"/>
+                <a16:creationId xmlns:a16="http://schemas.microsoft.com/office/drawing/2014/main" id="{76EF35BF-17C1-4A97-BA94-44C5AE5E7E7E}"/>
               </a:ext>
             </a:extLst>
           </p:cNvPr>
@@ -8870,7 +8875,7 @@
           <p:cNvPr id="3" name="chapter-14">
             <a:extLst xmlns:a="http://schemas.openxmlformats.org/drawingml/2006/main">
               <a:ext uri="{FF2B5EF4-FFF2-40B4-BE49-F238E27FC236}">
-                <a16:creationId xmlns:a16="http://schemas.microsoft.com/office/drawing/2014/main" id="{601EB705-5983-4A03-89F0-9F917D1C880E}"/>
+                <a16:creationId xmlns:a16="http://schemas.microsoft.com/office/drawing/2014/main" id="{605154D0-8D91-4D1C-BEF7-C364F6FF865A}"/>
               </a:ext>
             </a:extLst>
           </p:cNvPr>
@@ -8920,7 +8925,7 @@
           <p:cNvPr id="4" name="title-14">
             <a:extLst xmlns:a="http://schemas.openxmlformats.org/drawingml/2006/main">
               <a:ext uri="{FF2B5EF4-FFF2-40B4-BE49-F238E27FC236}">
-                <a16:creationId xmlns:a16="http://schemas.microsoft.com/office/drawing/2014/main" id="{3F39B751-A65C-4F71-B891-07F680175C99}"/>
+                <a16:creationId xmlns:a16="http://schemas.microsoft.com/office/drawing/2014/main" id="{B7FDEF5D-CCCF-408B-A05A-C400EDD7C87E}"/>
               </a:ext>
             </a:extLst>
           </p:cNvPr>
@@ -8970,7 +8975,7 @@
           <p:cNvPr id="5" name="subtitle-14">
             <a:extLst xmlns:a="http://schemas.openxmlformats.org/drawingml/2006/main">
               <a:ext uri="{FF2B5EF4-FFF2-40B4-BE49-F238E27FC236}">
-                <a16:creationId xmlns:a16="http://schemas.microsoft.com/office/drawing/2014/main" id="{318EB085-A843-42CB-8B85-D003D73E58C6}"/>
+                <a16:creationId xmlns:a16="http://schemas.microsoft.com/office/drawing/2014/main" id="{598C323A-F38A-4731-8484-4E93EEE21272}"/>
               </a:ext>
             </a:extLst>
           </p:cNvPr>
@@ -9020,7 +9025,7 @@
           <p:cNvPr id="6" name="">
             <a:extLst xmlns:a="http://schemas.openxmlformats.org/drawingml/2006/main">
               <a:ext uri="{FF2B5EF4-FFF2-40B4-BE49-F238E27FC236}">
-                <a16:creationId xmlns:a16="http://schemas.microsoft.com/office/drawing/2014/main" id="{B2F086C7-CE60-4E27-946F-D559109B890C}"/>
+                <a16:creationId xmlns:a16="http://schemas.microsoft.com/office/drawing/2014/main" id="{14F622D4-1E4E-48C7-89DB-760E36B6B873}"/>
               </a:ext>
             </a:extLst>
           </p:cNvPr>
@@ -9051,7 +9056,7 @@
           <p:cNvPr id="7" name="page-14">
             <a:extLst xmlns:a="http://schemas.openxmlformats.org/drawingml/2006/main">
               <a:ext uri="{FF2B5EF4-FFF2-40B4-BE49-F238E27FC236}">
-                <a16:creationId xmlns:a16="http://schemas.microsoft.com/office/drawing/2014/main" id="{B3510A3B-73A0-4301-A9A8-FF09D87B26A5}"/>
+                <a16:creationId xmlns:a16="http://schemas.microsoft.com/office/drawing/2014/main" id="{C6A209A1-1C85-48D6-A94D-1EA7B64040D9}"/>
               </a:ext>
             </a:extLst>
           </p:cNvPr>
@@ -9101,7 +9106,7 @@
           <p:cNvPr id="8" name="limit-0">
             <a:extLst xmlns:a="http://schemas.openxmlformats.org/drawingml/2006/main">
               <a:ext uri="{FF2B5EF4-FFF2-40B4-BE49-F238E27FC236}">
-                <a16:creationId xmlns:a16="http://schemas.microsoft.com/office/drawing/2014/main" id="{E6F22D8C-BA29-4387-BE30-59A44A541D7A}"/>
+                <a16:creationId xmlns:a16="http://schemas.microsoft.com/office/drawing/2014/main" id="{93380E2B-3920-4DE1-9168-B9EBA9D9225C}"/>
               </a:ext>
             </a:extLst>
           </p:cNvPr>
@@ -9136,7 +9141,7 @@
           <p:cNvPr id="9" name="limit-k-0">
             <a:extLst xmlns:a="http://schemas.openxmlformats.org/drawingml/2006/main">
               <a:ext uri="{FF2B5EF4-FFF2-40B4-BE49-F238E27FC236}">
-                <a16:creationId xmlns:a16="http://schemas.microsoft.com/office/drawing/2014/main" id="{5774EE42-2AE9-4C39-A261-503CCAB9C96C}"/>
+                <a16:creationId xmlns:a16="http://schemas.microsoft.com/office/drawing/2014/main" id="{51DB1D3A-00F9-4787-9605-F5E607856603}"/>
               </a:ext>
             </a:extLst>
           </p:cNvPr>
@@ -9186,7 +9191,7 @@
           <p:cNvPr id="10" name="limit-v-0-0">
             <a:extLst xmlns:a="http://schemas.openxmlformats.org/drawingml/2006/main">
               <a:ext uri="{FF2B5EF4-FFF2-40B4-BE49-F238E27FC236}">
-                <a16:creationId xmlns:a16="http://schemas.microsoft.com/office/drawing/2014/main" id="{73888BBB-C226-4B14-B760-5B08C284054C}"/>
+                <a16:creationId xmlns:a16="http://schemas.microsoft.com/office/drawing/2014/main" id="{293A51D6-CD41-4D6D-944E-9AF81DF08642}"/>
               </a:ext>
             </a:extLst>
           </p:cNvPr>
@@ -9236,7 +9241,7 @@
           <p:cNvPr id="11" name="limit-v-0-1">
             <a:extLst xmlns:a="http://schemas.openxmlformats.org/drawingml/2006/main">
               <a:ext uri="{FF2B5EF4-FFF2-40B4-BE49-F238E27FC236}">
-                <a16:creationId xmlns:a16="http://schemas.microsoft.com/office/drawing/2014/main" id="{FBB22901-198A-4F72-932E-3D7B29D5DE19}"/>
+                <a16:creationId xmlns:a16="http://schemas.microsoft.com/office/drawing/2014/main" id="{E6112189-78CB-4BAF-9D32-91A8520CE7FC}"/>
               </a:ext>
             </a:extLst>
           </p:cNvPr>
@@ -9286,7 +9291,7 @@
           <p:cNvPr id="12" name="limit-v-0-2">
             <a:extLst xmlns:a="http://schemas.openxmlformats.org/drawingml/2006/main">
               <a:ext uri="{FF2B5EF4-FFF2-40B4-BE49-F238E27FC236}">
-                <a16:creationId xmlns:a16="http://schemas.microsoft.com/office/drawing/2014/main" id="{45885CF8-C680-4125-9FE3-B595BF7468DD}"/>
+                <a16:creationId xmlns:a16="http://schemas.microsoft.com/office/drawing/2014/main" id="{F402F10F-3810-4B82-8E30-CD1985FF1178}"/>
               </a:ext>
             </a:extLst>
           </p:cNvPr>
@@ -9336,7 +9341,7 @@
           <p:cNvPr id="13" name="limit-v-0-3">
             <a:extLst xmlns:a="http://schemas.openxmlformats.org/drawingml/2006/main">
               <a:ext uri="{FF2B5EF4-FFF2-40B4-BE49-F238E27FC236}">
-                <a16:creationId xmlns:a16="http://schemas.microsoft.com/office/drawing/2014/main" id="{7B0B6E46-7F8B-43B8-A5CD-AEE8F358E839}"/>
+                <a16:creationId xmlns:a16="http://schemas.microsoft.com/office/drawing/2014/main" id="{924DE668-897C-4F9F-8143-765243BDCA56}"/>
               </a:ext>
             </a:extLst>
           </p:cNvPr>
@@ -9386,7 +9391,7 @@
           <p:cNvPr id="14" name="limit-1">
             <a:extLst xmlns:a="http://schemas.openxmlformats.org/drawingml/2006/main">
               <a:ext uri="{FF2B5EF4-FFF2-40B4-BE49-F238E27FC236}">
-                <a16:creationId xmlns:a16="http://schemas.microsoft.com/office/drawing/2014/main" id="{AE5D5C6A-A3CB-4DE5-A80C-BDCDD46802F4}"/>
+                <a16:creationId xmlns:a16="http://schemas.microsoft.com/office/drawing/2014/main" id="{690F267C-EDC4-43A8-A898-893675450C25}"/>
               </a:ext>
             </a:extLst>
           </p:cNvPr>
@@ -9421,7 +9426,7 @@
           <p:cNvPr id="15" name="limit-k-1">
             <a:extLst xmlns:a="http://schemas.openxmlformats.org/drawingml/2006/main">
               <a:ext uri="{FF2B5EF4-FFF2-40B4-BE49-F238E27FC236}">
-                <a16:creationId xmlns:a16="http://schemas.microsoft.com/office/drawing/2014/main" id="{80A22A39-E52C-4EF8-83F9-A9EA74461822}"/>
+                <a16:creationId xmlns:a16="http://schemas.microsoft.com/office/drawing/2014/main" id="{E5937F55-E731-4560-AF98-4F6EE23D1FF8}"/>
               </a:ext>
             </a:extLst>
           </p:cNvPr>
@@ -9461,7 +9466,7 @@
                   <a:srgbClr val="C56D4A"/>
                 </a:solidFill>
               </a:rPr>
-              <a:t>CODE READY / NOT RUN</a:t>
+              <a:t>BFCL SMOKE PASS · PAPER NOT RUN</a:t>
             </a:r>
           </a:p>
         </p:txBody>
@@ -9471,7 +9476,7 @@
           <p:cNvPr id="16" name="limit-v-1-0">
             <a:extLst xmlns:a="http://schemas.openxmlformats.org/drawingml/2006/main">
               <a:ext uri="{FF2B5EF4-FFF2-40B4-BE49-F238E27FC236}">
-                <a16:creationId xmlns:a16="http://schemas.microsoft.com/office/drawing/2014/main" id="{168C3CA6-17FC-497C-9CC2-EEE56C6A254C}"/>
+                <a16:creationId xmlns:a16="http://schemas.microsoft.com/office/drawing/2014/main" id="{9BAB8907-25CA-49FC-A88E-C28F199BC539}"/>
               </a:ext>
             </a:extLst>
           </p:cNvPr>
@@ -9511,7 +9516,7 @@
                   <a:srgbClr val="102330"/>
                 </a:solidFill>
               </a:rPr>
-              <a:t>◇  BFCL-V4 smoke / paper profile</a:t>
+              <a:t>◇  BFCL-V4 smoke：流水线 PASS，得分 0.00%</a:t>
             </a:r>
           </a:p>
         </p:txBody>
@@ -9521,7 +9526,7 @@
           <p:cNvPr id="17" name="limit-v-1-1">
             <a:extLst xmlns:a="http://schemas.openxmlformats.org/drawingml/2006/main">
               <a:ext uri="{FF2B5EF4-FFF2-40B4-BE49-F238E27FC236}">
-                <a16:creationId xmlns:a16="http://schemas.microsoft.com/office/drawing/2014/main" id="{5124EEDD-6AC5-4C85-956F-7C1C8F6CB611}"/>
+                <a16:creationId xmlns:a16="http://schemas.microsoft.com/office/drawing/2014/main" id="{BE9C5151-6EDC-46C2-A8F8-BD9C2C44BA99}"/>
               </a:ext>
             </a:extLst>
           </p:cNvPr>
@@ -9561,7 +9566,7 @@
                   <a:srgbClr val="102330"/>
                 </a:solidFill>
               </a:rPr>
-              <a:t>◇  TAU-2 Avg@4</a:t>
+              <a:t>◇  BFCL paper profile：4 类 × 200 未运行</a:t>
             </a:r>
           </a:p>
         </p:txBody>
@@ -9571,7 +9576,7 @@
           <p:cNvPr id="18" name="limit-v-1-2">
             <a:extLst xmlns:a="http://schemas.openxmlformats.org/drawingml/2006/main">
               <a:ext uri="{FF2B5EF4-FFF2-40B4-BE49-F238E27FC236}">
-                <a16:creationId xmlns:a16="http://schemas.microsoft.com/office/drawing/2014/main" id="{A998EA74-E44C-4BAA-B304-42A0A0A43FF6}"/>
+                <a16:creationId xmlns:a16="http://schemas.microsoft.com/office/drawing/2014/main" id="{4ACE0DD7-2AB8-4A0F-829F-F0E49530FF2B}"/>
               </a:ext>
             </a:extLst>
           </p:cNvPr>
@@ -9611,7 +9616,7 @@
                   <a:srgbClr val="102330"/>
                 </a:solidFill>
               </a:rPr>
-              <a:t>◇  3 seeds × ablation matrix</a:t>
+              <a:t>◇  TAU-2 Avg@4：未运行</a:t>
             </a:r>
           </a:p>
         </p:txBody>
@@ -9621,7 +9626,7 @@
           <p:cNvPr id="19" name="limit-v-1-3">
             <a:extLst xmlns:a="http://schemas.openxmlformats.org/drawingml/2006/main">
               <a:ext uri="{FF2B5EF4-FFF2-40B4-BE49-F238E27FC236}">
-                <a16:creationId xmlns:a16="http://schemas.microsoft.com/office/drawing/2014/main" id="{6984425E-ADC3-43FC-B310-ABFF5658E294}"/>
+                <a16:creationId xmlns:a16="http://schemas.microsoft.com/office/drawing/2014/main" id="{9D2B0C0B-7C35-458F-B74F-A2E10C674C71}"/>
               </a:ext>
             </a:extLst>
           </p:cNvPr>
@@ -9661,7 +9666,7 @@
                   <a:srgbClr val="102330"/>
                 </a:solidFill>
               </a:rPr>
-              <a:t>◇  更长训练与 replay-ratio sweep</a:t>
+              <a:t>◇  3 seeds × ablation / 更长训练未运行</a:t>
             </a:r>
           </a:p>
         </p:txBody>
@@ -9671,7 +9676,7 @@
           <p:cNvPr id="20" name="limit-2">
             <a:extLst xmlns:a="http://schemas.openxmlformats.org/drawingml/2006/main">
               <a:ext uri="{FF2B5EF4-FFF2-40B4-BE49-F238E27FC236}">
-                <a16:creationId xmlns:a16="http://schemas.microsoft.com/office/drawing/2014/main" id="{4BEC41D0-DDA5-40EE-8E22-D7BC06BFC549}"/>
+                <a16:creationId xmlns:a16="http://schemas.microsoft.com/office/drawing/2014/main" id="{63C20E22-714B-4DC6-91A9-E12DEAF5021F}"/>
               </a:ext>
             </a:extLst>
           </p:cNvPr>
@@ -9706,7 +9711,7 @@
           <p:cNvPr id="21" name="limit-k-2">
             <a:extLst xmlns:a="http://schemas.openxmlformats.org/drawingml/2006/main">
               <a:ext uri="{FF2B5EF4-FFF2-40B4-BE49-F238E27FC236}">
-                <a16:creationId xmlns:a16="http://schemas.microsoft.com/office/drawing/2014/main" id="{0D5CF265-A655-47AA-971F-27FEA53B788F}"/>
+                <a16:creationId xmlns:a16="http://schemas.microsoft.com/office/drawing/2014/main" id="{10585864-4ABF-46F0-8CB6-024636BB7D60}"/>
               </a:ext>
             </a:extLst>
           </p:cNvPr>
@@ -9756,7 +9761,7 @@
           <p:cNvPr id="22" name="limit-v-2-0">
             <a:extLst xmlns:a="http://schemas.openxmlformats.org/drawingml/2006/main">
               <a:ext uri="{FF2B5EF4-FFF2-40B4-BE49-F238E27FC236}">
-                <a16:creationId xmlns:a16="http://schemas.microsoft.com/office/drawing/2014/main" id="{08DAC514-C3E3-43CD-87D7-F2BCEB5F1973}"/>
+                <a16:creationId xmlns:a16="http://schemas.microsoft.com/office/drawing/2014/main" id="{611DA583-32CA-4AFA-9AD6-3C45123542D3}"/>
               </a:ext>
             </a:extLst>
           </p:cNvPr>
@@ -9806,7 +9811,7 @@
           <p:cNvPr id="23" name="limit-v-2-1">
             <a:extLst xmlns:a="http://schemas.openxmlformats.org/drawingml/2006/main">
               <a:ext uri="{FF2B5EF4-FFF2-40B4-BE49-F238E27FC236}">
-                <a16:creationId xmlns:a16="http://schemas.microsoft.com/office/drawing/2014/main" id="{7F0B4D1F-EECD-410F-BB79-95AD2B49AC75}"/>
+                <a16:creationId xmlns:a16="http://schemas.microsoft.com/office/drawing/2014/main" id="{5BDC7AED-A2B2-4B28-BA22-790506CAFC9F}"/>
               </a:ext>
             </a:extLst>
           </p:cNvPr>
@@ -9856,7 +9861,7 @@
           <p:cNvPr id="24" name="limit-v-2-2">
             <a:extLst xmlns:a="http://schemas.openxmlformats.org/drawingml/2006/main">
               <a:ext uri="{FF2B5EF4-FFF2-40B4-BE49-F238E27FC236}">
-                <a16:creationId xmlns:a16="http://schemas.microsoft.com/office/drawing/2014/main" id="{17F844C4-6B42-4A60-8501-559DB975BF0D}"/>
+                <a16:creationId xmlns:a16="http://schemas.microsoft.com/office/drawing/2014/main" id="{39BD4D5C-6ED0-4FE4-AFC6-40BA96A15278}"/>
               </a:ext>
             </a:extLst>
           </p:cNvPr>
@@ -9906,7 +9911,7 @@
           <p:cNvPr id="25" name="limit-v-2-3">
             <a:extLst xmlns:a="http://schemas.openxmlformats.org/drawingml/2006/main">
               <a:ext uri="{FF2B5EF4-FFF2-40B4-BE49-F238E27FC236}">
-                <a16:creationId xmlns:a16="http://schemas.microsoft.com/office/drawing/2014/main" id="{9E8D51AC-4F4A-4259-9753-0A7705ED81C1}"/>
+                <a16:creationId xmlns:a16="http://schemas.microsoft.com/office/drawing/2014/main" id="{A3C7E3B0-DEE5-434B-BF86-F2EE855FF313}"/>
               </a:ext>
             </a:extLst>
           </p:cNvPr>
@@ -9954,7 +9959,7 @@
     </p:spTree>
     <p:extLst>
       <p:ext uri="{BB962C8B-B14F-4D97-AF65-F5344CB8AC3E}">
-        <p14:creationId xmlns:p14="http://schemas.microsoft.com/office/powerpoint/2010/main" val="589666834"/>
+        <p14:creationId xmlns:p14="http://schemas.microsoft.com/office/powerpoint/2010/main" val="117898889"/>
       </p:ext>
     </p:extLst>
   </p:cSld>
@@ -9985,7 +9990,7 @@
           <p:cNvPr id="7" name="mechanism-rail">
             <a:extLst xmlns:a="http://schemas.openxmlformats.org/drawingml/2006/main">
               <a:ext uri="{FF2B5EF4-FFF2-40B4-BE49-F238E27FC236}">
-                <a16:creationId xmlns:a16="http://schemas.microsoft.com/office/drawing/2014/main" id="{468AF987-B726-4EB5-B88C-CF6AA42E4E3A}"/>
+                <a16:creationId xmlns:a16="http://schemas.microsoft.com/office/drawing/2014/main" id="{9FCFDFFE-72C8-461A-80BC-CCA9C5C478B5}"/>
               </a:ext>
             </a:extLst>
           </p:cNvPr>
@@ -10018,7 +10023,7 @@
           <p:cNvPr id="2" name="mechanism-title">
             <a:extLst xmlns:a="http://schemas.openxmlformats.org/drawingml/2006/main">
               <a:ext uri="{FF2B5EF4-FFF2-40B4-BE49-F238E27FC236}">
-                <a16:creationId xmlns:a16="http://schemas.microsoft.com/office/drawing/2014/main" id="{DDAEF585-7984-44B8-B55E-35398F7441F9}"/>
+                <a16:creationId xmlns:a16="http://schemas.microsoft.com/office/drawing/2014/main" id="{3ADE5CEB-CA9F-4D60-881E-A2D52B95AD94}"/>
               </a:ext>
             </a:extLst>
           </p:cNvPr>
@@ -10068,7 +10073,7 @@
           <p:cNvPr id="3" name="mechanism-subtitle">
             <a:extLst xmlns:a="http://schemas.openxmlformats.org/drawingml/2006/main">
               <a:ext uri="{FF2B5EF4-FFF2-40B4-BE49-F238E27FC236}">
-                <a16:creationId xmlns:a16="http://schemas.microsoft.com/office/drawing/2014/main" id="{1AE09CB3-A913-40E8-9CFA-615A4624F0B5}"/>
+                <a16:creationId xmlns:a16="http://schemas.microsoft.com/office/drawing/2014/main" id="{3CFB4A96-3728-4405-BE27-9D52D53A78FF}"/>
               </a:ext>
             </a:extLst>
           </p:cNvPr>
@@ -10118,7 +10123,7 @@
           <p:cNvPr id="4" name="">
             <a:extLst xmlns:a="http://schemas.openxmlformats.org/drawingml/2006/main">
               <a:ext uri="{FF2B5EF4-FFF2-40B4-BE49-F238E27FC236}">
-                <a16:creationId xmlns:a16="http://schemas.microsoft.com/office/drawing/2014/main" id="{0820BAB4-72A9-43EE-93A9-FA4485580BBE}"/>
+                <a16:creationId xmlns:a16="http://schemas.microsoft.com/office/drawing/2014/main" id="{A6FF1DC3-1486-4725-8211-356844AE3EEB}"/>
               </a:ext>
             </a:extLst>
           </p:cNvPr>
@@ -10153,7 +10158,7 @@
           <p:nvPr/>
         </p:nvPicPr>
         <p:blipFill>
-          <a:blip xmlns:r="http://schemas.openxmlformats.org/officeDocument/2006/relationships" xmlns:a="http://schemas.openxmlformats.org/drawingml/2006/main" r:embed="Rd4c7a094aa2646bb"/>
+          <a:blip xmlns:r="http://schemas.openxmlformats.org/officeDocument/2006/relationships" xmlns:a="http://schemas.openxmlformats.org/drawingml/2006/main" r:embed="R7eab3be56b494a28"/>
           <a:stretch xmlns:a="http://schemas.openxmlformats.org/drawingml/2006/main"/>
         </p:blipFill>
         <p:spPr>
@@ -10171,7 +10176,7 @@
           <p:cNvPr id="6" name="mechanism-page">
             <a:extLst xmlns:a="http://schemas.openxmlformats.org/drawingml/2006/main">
               <a:ext uri="{FF2B5EF4-FFF2-40B4-BE49-F238E27FC236}">
-                <a16:creationId xmlns:a16="http://schemas.microsoft.com/office/drawing/2014/main" id="{EA940490-31A4-4DA0-8E18-E42DF97D61BD}"/>
+                <a16:creationId xmlns:a16="http://schemas.microsoft.com/office/drawing/2014/main" id="{544EEBDF-A244-4648-A586-6FA1E3ADFCA2}"/>
               </a:ext>
             </a:extLst>
           </p:cNvPr>
@@ -10219,7 +10224,7 @@
     </p:spTree>
     <p:extLst>
       <p:ext uri="{BB962C8B-B14F-4D97-AF65-F5344CB8AC3E}">
-        <p14:creationId xmlns:p14="http://schemas.microsoft.com/office/powerpoint/2010/main" val="1845188322"/>
+        <p14:creationId xmlns:p14="http://schemas.microsoft.com/office/powerpoint/2010/main" val="853379674"/>
       </p:ext>
     </p:extLst>
   </p:cSld>
@@ -10250,7 +10255,7 @@
           <p:cNvPr id="11" name="copper-16">
             <a:extLst xmlns:a="http://schemas.openxmlformats.org/drawingml/2006/main">
               <a:ext uri="{FF2B5EF4-FFF2-40B4-BE49-F238E27FC236}">
-                <a16:creationId xmlns:a16="http://schemas.microsoft.com/office/drawing/2014/main" id="{69A0B52E-0F5E-4C4E-84D5-2EB07AD078A7}"/>
+                <a16:creationId xmlns:a16="http://schemas.microsoft.com/office/drawing/2014/main" id="{825B7E01-F8BE-40D8-A8DC-E0053C0F9A45}"/>
               </a:ext>
             </a:extLst>
           </p:cNvPr>
@@ -10283,7 +10288,7 @@
           <p:cNvPr id="2" name="chapter-script-16">
             <a:extLst xmlns:a="http://schemas.openxmlformats.org/drawingml/2006/main">
               <a:ext uri="{FF2B5EF4-FFF2-40B4-BE49-F238E27FC236}">
-                <a16:creationId xmlns:a16="http://schemas.microsoft.com/office/drawing/2014/main" id="{E076BC11-02C1-4AA1-B242-A5A00C0D9BAC}"/>
+                <a16:creationId xmlns:a16="http://schemas.microsoft.com/office/drawing/2014/main" id="{DC26CBA7-61EE-4B70-9395-327651136118}"/>
               </a:ext>
             </a:extLst>
           </p:cNvPr>
@@ -10333,7 +10338,7 @@
           <p:cNvPr id="3" name="roman-16">
             <a:extLst xmlns:a="http://schemas.openxmlformats.org/drawingml/2006/main">
               <a:ext uri="{FF2B5EF4-FFF2-40B4-BE49-F238E27FC236}">
-                <a16:creationId xmlns:a16="http://schemas.microsoft.com/office/drawing/2014/main" id="{94B0A66A-38A4-4FFC-807D-40FB1E3C746B}"/>
+                <a16:creationId xmlns:a16="http://schemas.microsoft.com/office/drawing/2014/main" id="{DE5B312E-35BD-4711-8E4B-2FFE049E6C0A}"/>
               </a:ext>
             </a:extLst>
           </p:cNvPr>
@@ -10383,7 +10388,7 @@
           <p:cNvPr id="4" name="">
             <a:extLst xmlns:a="http://schemas.openxmlformats.org/drawingml/2006/main">
               <a:ext uri="{FF2B5EF4-FFF2-40B4-BE49-F238E27FC236}">
-                <a16:creationId xmlns:a16="http://schemas.microsoft.com/office/drawing/2014/main" id="{8B10209B-2E18-4447-8F40-933D21814AA9}"/>
+                <a16:creationId xmlns:a16="http://schemas.microsoft.com/office/drawing/2014/main" id="{7364F5DC-99B1-44FB-B5A9-5116CC061A29}"/>
               </a:ext>
             </a:extLst>
           </p:cNvPr>
@@ -10414,7 +10419,7 @@
           <p:cNvPr id="5" name="zh-16">
             <a:extLst xmlns:a="http://schemas.openxmlformats.org/drawingml/2006/main">
               <a:ext uri="{FF2B5EF4-FFF2-40B4-BE49-F238E27FC236}">
-                <a16:creationId xmlns:a16="http://schemas.microsoft.com/office/drawing/2014/main" id="{E6AA5AEA-2806-48A3-AC37-D8D0411DDFC9}"/>
+                <a16:creationId xmlns:a16="http://schemas.microsoft.com/office/drawing/2014/main" id="{E1117231-295A-48EE-B29C-4391C2B313B3}"/>
               </a:ext>
             </a:extLst>
           </p:cNvPr>
@@ -10464,7 +10469,7 @@
           <p:cNvPr id="6" name="en-16">
             <a:extLst xmlns:a="http://schemas.openxmlformats.org/drawingml/2006/main">
               <a:ext uri="{FF2B5EF4-FFF2-40B4-BE49-F238E27FC236}">
-                <a16:creationId xmlns:a16="http://schemas.microsoft.com/office/drawing/2014/main" id="{CC4BD1B9-902E-4D89-98BB-E7B9592A3A66}"/>
+                <a16:creationId xmlns:a16="http://schemas.microsoft.com/office/drawing/2014/main" id="{F2D61261-B03F-4FA0-9395-A2E1D754DEB7}"/>
               </a:ext>
             </a:extLst>
           </p:cNvPr>
@@ -10514,7 +10519,7 @@
           <p:cNvPr id="7" name="body-16">
             <a:extLst xmlns:a="http://schemas.openxmlformats.org/drawingml/2006/main">
               <a:ext uri="{FF2B5EF4-FFF2-40B4-BE49-F238E27FC236}">
-                <a16:creationId xmlns:a16="http://schemas.microsoft.com/office/drawing/2014/main" id="{1B89B987-F299-4CAA-9E66-5812922C9B11}"/>
+                <a16:creationId xmlns:a16="http://schemas.microsoft.com/office/drawing/2014/main" id="{ED7F7590-5BC2-47EF-8893-D0D2B58E0F23}"/>
               </a:ext>
             </a:extLst>
           </p:cNvPr>
@@ -10568,7 +10573,7 @@
           <p:cNvPr id="8" name="chapter-pill-16-bg">
             <a:extLst xmlns:a="http://schemas.openxmlformats.org/drawingml/2006/main">
               <a:ext uri="{FF2B5EF4-FFF2-40B4-BE49-F238E27FC236}">
-                <a16:creationId xmlns:a16="http://schemas.microsoft.com/office/drawing/2014/main" id="{6159B46F-FAA5-4C8D-9CE7-BCFAC1AF4A25}"/>
+                <a16:creationId xmlns:a16="http://schemas.microsoft.com/office/drawing/2014/main" id="{7E51E6F3-FC24-46ED-BBD0-B050FFF981A5}"/>
               </a:ext>
             </a:extLst>
           </p:cNvPr>
@@ -10603,7 +10608,7 @@
           <p:cNvPr id="9" name="chapter-pill-16-text">
             <a:extLst xmlns:a="http://schemas.openxmlformats.org/drawingml/2006/main">
               <a:ext uri="{FF2B5EF4-FFF2-40B4-BE49-F238E27FC236}">
-                <a16:creationId xmlns:a16="http://schemas.microsoft.com/office/drawing/2014/main" id="{A873AC04-3E9F-4132-BC21-587FE75D0D9A}"/>
+                <a16:creationId xmlns:a16="http://schemas.microsoft.com/office/drawing/2014/main" id="{D9FF8126-7057-4213-9010-C0D49FCACC58}"/>
               </a:ext>
             </a:extLst>
           </p:cNvPr>
@@ -10653,7 +10658,7 @@
           <p:cNvPr id="10" name="close-command">
             <a:extLst xmlns:a="http://schemas.openxmlformats.org/drawingml/2006/main">
               <a:ext uri="{FF2B5EF4-FFF2-40B4-BE49-F238E27FC236}">
-                <a16:creationId xmlns:a16="http://schemas.microsoft.com/office/drawing/2014/main" id="{C7A82972-D710-46E4-8648-6AE16F04BE90}"/>
+                <a16:creationId xmlns:a16="http://schemas.microsoft.com/office/drawing/2014/main" id="{04517DEA-7A83-493C-B95C-1AE815291865}"/>
               </a:ext>
             </a:extLst>
           </p:cNvPr>
@@ -10701,7 +10706,7 @@
     </p:spTree>
     <p:extLst>
       <p:ext uri="{BB962C8B-B14F-4D97-AF65-F5344CB8AC3E}">
-        <p14:creationId xmlns:p14="http://schemas.microsoft.com/office/powerpoint/2010/main" val="657582875"/>
+        <p14:creationId xmlns:p14="http://schemas.microsoft.com/office/powerpoint/2010/main" val="437487157"/>
       </p:ext>
     </p:extLst>
   </p:cSld>
@@ -10732,7 +10737,7 @@
           <p:cNvPr id="25" name="rail-2">
             <a:extLst xmlns:a="http://schemas.openxmlformats.org/drawingml/2006/main">
               <a:ext uri="{FF2B5EF4-FFF2-40B4-BE49-F238E27FC236}">
-                <a16:creationId xmlns:a16="http://schemas.microsoft.com/office/drawing/2014/main" id="{39C6AB00-80E0-4688-9AB7-9B8AAD3616A7}"/>
+                <a16:creationId xmlns:a16="http://schemas.microsoft.com/office/drawing/2014/main" id="{251ABAD9-51A0-46C8-878F-9B92915AB88A}"/>
               </a:ext>
             </a:extLst>
           </p:cNvPr>
@@ -10765,7 +10770,7 @@
           <p:cNvPr id="2" name="flourish-2">
             <a:extLst xmlns:a="http://schemas.openxmlformats.org/drawingml/2006/main">
               <a:ext uri="{FF2B5EF4-FFF2-40B4-BE49-F238E27FC236}">
-                <a16:creationId xmlns:a16="http://schemas.microsoft.com/office/drawing/2014/main" id="{3034A68A-8082-4CDB-AF65-7FD0BAF1643D}"/>
+                <a16:creationId xmlns:a16="http://schemas.microsoft.com/office/drawing/2014/main" id="{515AF971-5C7C-48AB-80D7-56ED389860A5}"/>
               </a:ext>
             </a:extLst>
           </p:cNvPr>
@@ -10815,7 +10820,7 @@
           <p:cNvPr id="3" name="chapter-2">
             <a:extLst xmlns:a="http://schemas.openxmlformats.org/drawingml/2006/main">
               <a:ext uri="{FF2B5EF4-FFF2-40B4-BE49-F238E27FC236}">
-                <a16:creationId xmlns:a16="http://schemas.microsoft.com/office/drawing/2014/main" id="{79AB3039-0783-45E7-9319-8FE1765DB34E}"/>
+                <a16:creationId xmlns:a16="http://schemas.microsoft.com/office/drawing/2014/main" id="{B9C3FBBE-681E-49D6-B64E-BF2D43CEF1BA}"/>
               </a:ext>
             </a:extLst>
           </p:cNvPr>
@@ -10865,7 +10870,7 @@
           <p:cNvPr id="4" name="title-2">
             <a:extLst xmlns:a="http://schemas.openxmlformats.org/drawingml/2006/main">
               <a:ext uri="{FF2B5EF4-FFF2-40B4-BE49-F238E27FC236}">
-                <a16:creationId xmlns:a16="http://schemas.microsoft.com/office/drawing/2014/main" id="{0739C487-E8C9-474F-8D36-73EB4CD23BF0}"/>
+                <a16:creationId xmlns:a16="http://schemas.microsoft.com/office/drawing/2014/main" id="{67E2B74F-CD4B-4780-B6D6-313F59ADEC36}"/>
               </a:ext>
             </a:extLst>
           </p:cNvPr>
@@ -10915,7 +10920,7 @@
           <p:cNvPr id="5" name="subtitle-2">
             <a:extLst xmlns:a="http://schemas.openxmlformats.org/drawingml/2006/main">
               <a:ext uri="{FF2B5EF4-FFF2-40B4-BE49-F238E27FC236}">
-                <a16:creationId xmlns:a16="http://schemas.microsoft.com/office/drawing/2014/main" id="{90BEAE92-36E7-4E87-BCFE-769504B834B2}"/>
+                <a16:creationId xmlns:a16="http://schemas.microsoft.com/office/drawing/2014/main" id="{74D24A47-C48C-4855-A136-D096538DC562}"/>
               </a:ext>
             </a:extLst>
           </p:cNvPr>
@@ -10965,7 +10970,7 @@
           <p:cNvPr id="6" name="">
             <a:extLst xmlns:a="http://schemas.openxmlformats.org/drawingml/2006/main">
               <a:ext uri="{FF2B5EF4-FFF2-40B4-BE49-F238E27FC236}">
-                <a16:creationId xmlns:a16="http://schemas.microsoft.com/office/drawing/2014/main" id="{AAD8BD17-52B8-4776-BA2D-1292D217999B}"/>
+                <a16:creationId xmlns:a16="http://schemas.microsoft.com/office/drawing/2014/main" id="{54AFC74D-33E9-431F-9685-1ABB20EB304C}"/>
               </a:ext>
             </a:extLst>
           </p:cNvPr>
@@ -10996,7 +11001,7 @@
           <p:cNvPr id="7" name="page-2">
             <a:extLst xmlns:a="http://schemas.openxmlformats.org/drawingml/2006/main">
               <a:ext uri="{FF2B5EF4-FFF2-40B4-BE49-F238E27FC236}">
-                <a16:creationId xmlns:a16="http://schemas.microsoft.com/office/drawing/2014/main" id="{F2D5A237-C7C7-4C3B-81A5-FB9A98D3B2B8}"/>
+                <a16:creationId xmlns:a16="http://schemas.microsoft.com/office/drawing/2014/main" id="{D1276B06-1E9A-4863-886E-2D63F428CF65}"/>
               </a:ext>
             </a:extLst>
           </p:cNvPr>
@@ -11046,7 +11051,7 @@
           <p:cNvPr id="8" name="map-0">
             <a:extLst xmlns:a="http://schemas.openxmlformats.org/drawingml/2006/main">
               <a:ext uri="{FF2B5EF4-FFF2-40B4-BE49-F238E27FC236}">
-                <a16:creationId xmlns:a16="http://schemas.microsoft.com/office/drawing/2014/main" id="{322A9FA2-EA4B-41B1-97B8-FEC2D56BB598}"/>
+                <a16:creationId xmlns:a16="http://schemas.microsoft.com/office/drawing/2014/main" id="{C33AB961-8E96-4E07-9D16-E65507B7442A}"/>
               </a:ext>
             </a:extLst>
           </p:cNvPr>
@@ -11081,7 +11086,7 @@
           <p:cNvPr id="9" name="map-num-0">
             <a:extLst xmlns:a="http://schemas.openxmlformats.org/drawingml/2006/main">
               <a:ext uri="{FF2B5EF4-FFF2-40B4-BE49-F238E27FC236}">
-                <a16:creationId xmlns:a16="http://schemas.microsoft.com/office/drawing/2014/main" id="{798389D7-E659-429C-AC4E-6FEEA6B79CE1}"/>
+                <a16:creationId xmlns:a16="http://schemas.microsoft.com/office/drawing/2014/main" id="{0D18D9F0-C1EE-4ED0-BA95-2F4EACD623F2}"/>
               </a:ext>
             </a:extLst>
           </p:cNvPr>
@@ -11131,7 +11136,7 @@
           <p:cNvPr id="10" name="map-name-0">
             <a:extLst xmlns:a="http://schemas.openxmlformats.org/drawingml/2006/main">
               <a:ext uri="{FF2B5EF4-FFF2-40B4-BE49-F238E27FC236}">
-                <a16:creationId xmlns:a16="http://schemas.microsoft.com/office/drawing/2014/main" id="{0CA8D4EB-1908-4702-9BCC-E296C22116D8}"/>
+                <a16:creationId xmlns:a16="http://schemas.microsoft.com/office/drawing/2014/main" id="{BC070E0B-742C-4BAD-8D3A-51522E2E829D}"/>
               </a:ext>
             </a:extLst>
           </p:cNvPr>
@@ -11181,7 +11186,7 @@
           <p:cNvPr id="11" name="map-body-0">
             <a:extLst xmlns:a="http://schemas.openxmlformats.org/drawingml/2006/main">
               <a:ext uri="{FF2B5EF4-FFF2-40B4-BE49-F238E27FC236}">
-                <a16:creationId xmlns:a16="http://schemas.microsoft.com/office/drawing/2014/main" id="{973BC3FB-D032-449B-95AC-DD7DBC5DF5EC}"/>
+                <a16:creationId xmlns:a16="http://schemas.microsoft.com/office/drawing/2014/main" id="{29852A5A-93DB-4466-94AC-919D1CA3AB58}"/>
               </a:ext>
             </a:extLst>
           </p:cNvPr>
@@ -11235,7 +11240,7 @@
           <p:cNvPr id="12" name="map-1">
             <a:extLst xmlns:a="http://schemas.openxmlformats.org/drawingml/2006/main">
               <a:ext uri="{FF2B5EF4-FFF2-40B4-BE49-F238E27FC236}">
-                <a16:creationId xmlns:a16="http://schemas.microsoft.com/office/drawing/2014/main" id="{11D9E507-CE18-44B0-908A-0C3123C3730B}"/>
+                <a16:creationId xmlns:a16="http://schemas.microsoft.com/office/drawing/2014/main" id="{B83DC54D-E94D-4A6B-85A6-1680707D0B6C}"/>
               </a:ext>
             </a:extLst>
           </p:cNvPr>
@@ -11270,7 +11275,7 @@
           <p:cNvPr id="13" name="map-num-1">
             <a:extLst xmlns:a="http://schemas.openxmlformats.org/drawingml/2006/main">
               <a:ext uri="{FF2B5EF4-FFF2-40B4-BE49-F238E27FC236}">
-                <a16:creationId xmlns:a16="http://schemas.microsoft.com/office/drawing/2014/main" id="{4FE0DE80-7625-495E-867F-F626E7F54512}"/>
+                <a16:creationId xmlns:a16="http://schemas.microsoft.com/office/drawing/2014/main" id="{4B14D295-88CA-4A54-8C54-BBB5F4666032}"/>
               </a:ext>
             </a:extLst>
           </p:cNvPr>
@@ -11320,7 +11325,7 @@
           <p:cNvPr id="14" name="map-name-1">
             <a:extLst xmlns:a="http://schemas.openxmlformats.org/drawingml/2006/main">
               <a:ext uri="{FF2B5EF4-FFF2-40B4-BE49-F238E27FC236}">
-                <a16:creationId xmlns:a16="http://schemas.microsoft.com/office/drawing/2014/main" id="{2749930E-38D8-4DF1-9C8A-D75BA2F9E74D}"/>
+                <a16:creationId xmlns:a16="http://schemas.microsoft.com/office/drawing/2014/main" id="{A7F721CF-A393-4CAC-8C5E-47AAA2D5235B}"/>
               </a:ext>
             </a:extLst>
           </p:cNvPr>
@@ -11370,7 +11375,7 @@
           <p:cNvPr id="15" name="map-body-1">
             <a:extLst xmlns:a="http://schemas.openxmlformats.org/drawingml/2006/main">
               <a:ext uri="{FF2B5EF4-FFF2-40B4-BE49-F238E27FC236}">
-                <a16:creationId xmlns:a16="http://schemas.microsoft.com/office/drawing/2014/main" id="{2022192D-E33A-4F4A-8F11-0B051DF8C08B}"/>
+                <a16:creationId xmlns:a16="http://schemas.microsoft.com/office/drawing/2014/main" id="{7ED2C38C-FB0B-4292-A952-DF3C9EFCC6BE}"/>
               </a:ext>
             </a:extLst>
           </p:cNvPr>
@@ -11424,7 +11429,7 @@
           <p:cNvPr id="16" name="map-2">
             <a:extLst xmlns:a="http://schemas.openxmlformats.org/drawingml/2006/main">
               <a:ext uri="{FF2B5EF4-FFF2-40B4-BE49-F238E27FC236}">
-                <a16:creationId xmlns:a16="http://schemas.microsoft.com/office/drawing/2014/main" id="{72BEF085-9EB9-4AE3-8CEA-EE981495D674}"/>
+                <a16:creationId xmlns:a16="http://schemas.microsoft.com/office/drawing/2014/main" id="{E8BCB5D0-5D8F-450A-8604-8CBA8BCA0794}"/>
               </a:ext>
             </a:extLst>
           </p:cNvPr>
@@ -11459,7 +11464,7 @@
           <p:cNvPr id="17" name="map-num-2">
             <a:extLst xmlns:a="http://schemas.openxmlformats.org/drawingml/2006/main">
               <a:ext uri="{FF2B5EF4-FFF2-40B4-BE49-F238E27FC236}">
-                <a16:creationId xmlns:a16="http://schemas.microsoft.com/office/drawing/2014/main" id="{B53AB7E3-D0F8-46F8-B225-3E04B9826AD2}"/>
+                <a16:creationId xmlns:a16="http://schemas.microsoft.com/office/drawing/2014/main" id="{BD8C4EE5-C98F-481A-974A-334B946B8FC4}"/>
               </a:ext>
             </a:extLst>
           </p:cNvPr>
@@ -11509,7 +11514,7 @@
           <p:cNvPr id="18" name="map-name-2">
             <a:extLst xmlns:a="http://schemas.openxmlformats.org/drawingml/2006/main">
               <a:ext uri="{FF2B5EF4-FFF2-40B4-BE49-F238E27FC236}">
-                <a16:creationId xmlns:a16="http://schemas.microsoft.com/office/drawing/2014/main" id="{26AC4D05-7787-4A80-9182-9EB39390079C}"/>
+                <a16:creationId xmlns:a16="http://schemas.microsoft.com/office/drawing/2014/main" id="{258E7CC3-0AFB-4B8C-BC26-4CC76D632C49}"/>
               </a:ext>
             </a:extLst>
           </p:cNvPr>
@@ -11559,7 +11564,7 @@
           <p:cNvPr id="19" name="map-body-2">
             <a:extLst xmlns:a="http://schemas.openxmlformats.org/drawingml/2006/main">
               <a:ext uri="{FF2B5EF4-FFF2-40B4-BE49-F238E27FC236}">
-                <a16:creationId xmlns:a16="http://schemas.microsoft.com/office/drawing/2014/main" id="{525DDCCA-14AB-4475-8D3B-D931A5300785}"/>
+                <a16:creationId xmlns:a16="http://schemas.microsoft.com/office/drawing/2014/main" id="{3D168BEC-CA99-41CB-94B0-219469E66E66}"/>
               </a:ext>
             </a:extLst>
           </p:cNvPr>
@@ -11613,7 +11618,7 @@
           <p:cNvPr id="20" name="map-3">
             <a:extLst xmlns:a="http://schemas.openxmlformats.org/drawingml/2006/main">
               <a:ext uri="{FF2B5EF4-FFF2-40B4-BE49-F238E27FC236}">
-                <a16:creationId xmlns:a16="http://schemas.microsoft.com/office/drawing/2014/main" id="{8FF360D8-3B04-483E-9497-3054C3726578}"/>
+                <a16:creationId xmlns:a16="http://schemas.microsoft.com/office/drawing/2014/main" id="{60948E6F-9609-4AA0-91BB-0D8543708CB7}"/>
               </a:ext>
             </a:extLst>
           </p:cNvPr>
@@ -11648,7 +11653,7 @@
           <p:cNvPr id="21" name="map-num-3">
             <a:extLst xmlns:a="http://schemas.openxmlformats.org/drawingml/2006/main">
               <a:ext uri="{FF2B5EF4-FFF2-40B4-BE49-F238E27FC236}">
-                <a16:creationId xmlns:a16="http://schemas.microsoft.com/office/drawing/2014/main" id="{FA8D37A4-619A-4C53-AA29-E4F2023B6F3A}"/>
+                <a16:creationId xmlns:a16="http://schemas.microsoft.com/office/drawing/2014/main" id="{1E23409C-EF76-4E90-89B4-C12FBEF20EEC}"/>
               </a:ext>
             </a:extLst>
           </p:cNvPr>
@@ -11698,7 +11703,7 @@
           <p:cNvPr id="22" name="map-name-3">
             <a:extLst xmlns:a="http://schemas.openxmlformats.org/drawingml/2006/main">
               <a:ext uri="{FF2B5EF4-FFF2-40B4-BE49-F238E27FC236}">
-                <a16:creationId xmlns:a16="http://schemas.microsoft.com/office/drawing/2014/main" id="{C25F1259-D72C-46F3-A044-C40DFACF89D4}"/>
+                <a16:creationId xmlns:a16="http://schemas.microsoft.com/office/drawing/2014/main" id="{B8DDDCC2-5A01-4C37-9693-3051F6DEE1D0}"/>
               </a:ext>
             </a:extLst>
           </p:cNvPr>
@@ -11748,7 +11753,7 @@
           <p:cNvPr id="23" name="map-body-3">
             <a:extLst xmlns:a="http://schemas.openxmlformats.org/drawingml/2006/main">
               <a:ext uri="{FF2B5EF4-FFF2-40B4-BE49-F238E27FC236}">
-                <a16:creationId xmlns:a16="http://schemas.microsoft.com/office/drawing/2014/main" id="{30E1A9DD-0404-4580-B6A8-5F010F981C6F}"/>
+                <a16:creationId xmlns:a16="http://schemas.microsoft.com/office/drawing/2014/main" id="{74830F03-C31F-4BC6-9AF2-7540CEF08C92}"/>
               </a:ext>
             </a:extLst>
           </p:cNvPr>
@@ -11802,7 +11807,7 @@
           <p:cNvPr id="24" name="map-foot">
             <a:extLst xmlns:a="http://schemas.openxmlformats.org/drawingml/2006/main">
               <a:ext uri="{FF2B5EF4-FFF2-40B4-BE49-F238E27FC236}">
-                <a16:creationId xmlns:a16="http://schemas.microsoft.com/office/drawing/2014/main" id="{DC7077EA-C832-4BDA-AEDD-D9B516AF6C18}"/>
+                <a16:creationId xmlns:a16="http://schemas.microsoft.com/office/drawing/2014/main" id="{BDA19CA5-50FC-4F68-9155-C7927D425966}"/>
               </a:ext>
             </a:extLst>
           </p:cNvPr>
@@ -11850,7 +11855,7 @@
     </p:spTree>
     <p:extLst>
       <p:ext uri="{BB962C8B-B14F-4D97-AF65-F5344CB8AC3E}">
-        <p14:creationId xmlns:p14="http://schemas.microsoft.com/office/powerpoint/2010/main" val="1366980109"/>
+        <p14:creationId xmlns:p14="http://schemas.microsoft.com/office/powerpoint/2010/main" val="556109581"/>
       </p:ext>
     </p:extLst>
   </p:cSld>
@@ -11881,7 +11886,7 @@
           <p:cNvPr id="21" name="rail-3">
             <a:extLst xmlns:a="http://schemas.openxmlformats.org/drawingml/2006/main">
               <a:ext uri="{FF2B5EF4-FFF2-40B4-BE49-F238E27FC236}">
-                <a16:creationId xmlns:a16="http://schemas.microsoft.com/office/drawing/2014/main" id="{5D3B8405-6D9E-4CB3-B41D-C51C331C57B7}"/>
+                <a16:creationId xmlns:a16="http://schemas.microsoft.com/office/drawing/2014/main" id="{2B1DF3EE-D2CC-43F8-B706-9D2FFFE8D977}"/>
               </a:ext>
             </a:extLst>
           </p:cNvPr>
@@ -11914,7 +11919,7 @@
           <p:cNvPr id="2" name="flourish-3">
             <a:extLst xmlns:a="http://schemas.openxmlformats.org/drawingml/2006/main">
               <a:ext uri="{FF2B5EF4-FFF2-40B4-BE49-F238E27FC236}">
-                <a16:creationId xmlns:a16="http://schemas.microsoft.com/office/drawing/2014/main" id="{E19CA2E1-14CE-4BEE-85F8-1E5C761C588B}"/>
+                <a16:creationId xmlns:a16="http://schemas.microsoft.com/office/drawing/2014/main" id="{7F9C3B62-AEC7-45E2-A287-6AE2EBE89B19}"/>
               </a:ext>
             </a:extLst>
           </p:cNvPr>
@@ -11964,7 +11969,7 @@
           <p:cNvPr id="3" name="chapter-3">
             <a:extLst xmlns:a="http://schemas.openxmlformats.org/drawingml/2006/main">
               <a:ext uri="{FF2B5EF4-FFF2-40B4-BE49-F238E27FC236}">
-                <a16:creationId xmlns:a16="http://schemas.microsoft.com/office/drawing/2014/main" id="{5A4E3F51-ED70-401F-8369-C87422C4C2A0}"/>
+                <a16:creationId xmlns:a16="http://schemas.microsoft.com/office/drawing/2014/main" id="{5EDA809F-8273-41DA-993B-B0139E0D018F}"/>
               </a:ext>
             </a:extLst>
           </p:cNvPr>
@@ -12014,7 +12019,7 @@
           <p:cNvPr id="4" name="title-3">
             <a:extLst xmlns:a="http://schemas.openxmlformats.org/drawingml/2006/main">
               <a:ext uri="{FF2B5EF4-FFF2-40B4-BE49-F238E27FC236}">
-                <a16:creationId xmlns:a16="http://schemas.microsoft.com/office/drawing/2014/main" id="{56EBF8CC-D705-42A4-8502-50CD4FEB79FD}"/>
+                <a16:creationId xmlns:a16="http://schemas.microsoft.com/office/drawing/2014/main" id="{9FBCEC35-756A-4160-B7CC-79CA06041132}"/>
               </a:ext>
             </a:extLst>
           </p:cNvPr>
@@ -12064,7 +12069,7 @@
           <p:cNvPr id="5" name="subtitle-3">
             <a:extLst xmlns:a="http://schemas.openxmlformats.org/drawingml/2006/main">
               <a:ext uri="{FF2B5EF4-FFF2-40B4-BE49-F238E27FC236}">
-                <a16:creationId xmlns:a16="http://schemas.microsoft.com/office/drawing/2014/main" id="{606A6262-205A-4779-B3AD-70BAE88A668A}"/>
+                <a16:creationId xmlns:a16="http://schemas.microsoft.com/office/drawing/2014/main" id="{01AE1184-6DEF-4AA5-8054-516658A428FD}"/>
               </a:ext>
             </a:extLst>
           </p:cNvPr>
@@ -12114,7 +12119,7 @@
           <p:cNvPr id="6" name="">
             <a:extLst xmlns:a="http://schemas.openxmlformats.org/drawingml/2006/main">
               <a:ext uri="{FF2B5EF4-FFF2-40B4-BE49-F238E27FC236}">
-                <a16:creationId xmlns:a16="http://schemas.microsoft.com/office/drawing/2014/main" id="{C121E721-452D-487C-9A4C-8A379385FE96}"/>
+                <a16:creationId xmlns:a16="http://schemas.microsoft.com/office/drawing/2014/main" id="{86C0D0F2-0348-455B-8965-694B2B2D1920}"/>
               </a:ext>
             </a:extLst>
           </p:cNvPr>
@@ -12145,7 +12150,7 @@
           <p:cNvPr id="7" name="page-3">
             <a:extLst xmlns:a="http://schemas.openxmlformats.org/drawingml/2006/main">
               <a:ext uri="{FF2B5EF4-FFF2-40B4-BE49-F238E27FC236}">
-                <a16:creationId xmlns:a16="http://schemas.microsoft.com/office/drawing/2014/main" id="{8FF4B582-F3A2-4FB4-AD48-8F18FC90FEA6}"/>
+                <a16:creationId xmlns:a16="http://schemas.microsoft.com/office/drawing/2014/main" id="{8D80C023-C7B2-4FB3-9A42-834D592026F2}"/>
               </a:ext>
             </a:extLst>
           </p:cNvPr>
@@ -12199,7 +12204,7 @@
           <p:nvPr/>
         </p:nvPicPr>
         <p:blipFill>
-          <a:blip xmlns:r="http://schemas.openxmlformats.org/officeDocument/2006/relationships" xmlns:a="http://schemas.openxmlformats.org/drawingml/2006/main" r:embed="Ra82f6f11675f48ec"/>
+          <a:blip xmlns:r="http://schemas.openxmlformats.org/officeDocument/2006/relationships" xmlns:a="http://schemas.openxmlformats.org/drawingml/2006/main" r:embed="Rd922421901d04ff8"/>
           <a:stretch xmlns:a="http://schemas.openxmlformats.org/drawingml/2006/main"/>
         </p:blipFill>
         <p:spPr>
@@ -12217,7 +12222,7 @@
           <p:cNvPr id="9" name="">
             <a:extLst xmlns:a="http://schemas.openxmlformats.org/drawingml/2006/main">
               <a:ext uri="{FF2B5EF4-FFF2-40B4-BE49-F238E27FC236}">
-                <a16:creationId xmlns:a16="http://schemas.microsoft.com/office/drawing/2014/main" id="{096C0D8D-7541-4937-B039-2EA5F239A93F}"/>
+                <a16:creationId xmlns:a16="http://schemas.microsoft.com/office/drawing/2014/main" id="{D178A17E-197D-4033-BE49-B9E44B68FDED}"/>
               </a:ext>
             </a:extLst>
           </p:cNvPr>
@@ -12248,7 +12253,7 @@
           <p:cNvPr id="10" name="paper-k-0">
             <a:extLst xmlns:a="http://schemas.openxmlformats.org/drawingml/2006/main">
               <a:ext uri="{FF2B5EF4-FFF2-40B4-BE49-F238E27FC236}">
-                <a16:creationId xmlns:a16="http://schemas.microsoft.com/office/drawing/2014/main" id="{81E60B18-59CC-4AA4-B246-2154FABCA0F1}"/>
+                <a16:creationId xmlns:a16="http://schemas.microsoft.com/office/drawing/2014/main" id="{F62AA5E2-1439-4E7A-A841-E19F1BC62AFA}"/>
               </a:ext>
             </a:extLst>
           </p:cNvPr>
@@ -12298,7 +12303,7 @@
           <p:cNvPr id="11" name="paper-v-0">
             <a:extLst xmlns:a="http://schemas.openxmlformats.org/drawingml/2006/main">
               <a:ext uri="{FF2B5EF4-FFF2-40B4-BE49-F238E27FC236}">
-                <a16:creationId xmlns:a16="http://schemas.microsoft.com/office/drawing/2014/main" id="{00EBF084-41C8-4058-81D2-E9997CECEDBA}"/>
+                <a16:creationId xmlns:a16="http://schemas.microsoft.com/office/drawing/2014/main" id="{F1E698E5-4ECA-4F35-865B-753A032A54A7}"/>
               </a:ext>
             </a:extLst>
           </p:cNvPr>
@@ -12348,7 +12353,7 @@
           <p:cNvPr id="12" name="">
             <a:extLst xmlns:a="http://schemas.openxmlformats.org/drawingml/2006/main">
               <a:ext uri="{FF2B5EF4-FFF2-40B4-BE49-F238E27FC236}">
-                <a16:creationId xmlns:a16="http://schemas.microsoft.com/office/drawing/2014/main" id="{B382B7EE-EFC3-4D39-8D0D-199D2CDE5EB7}"/>
+                <a16:creationId xmlns:a16="http://schemas.microsoft.com/office/drawing/2014/main" id="{C60BEE0D-8AAC-438D-8A50-4D9A92A10C22}"/>
               </a:ext>
             </a:extLst>
           </p:cNvPr>
@@ -12379,7 +12384,7 @@
           <p:cNvPr id="13" name="paper-k-1">
             <a:extLst xmlns:a="http://schemas.openxmlformats.org/drawingml/2006/main">
               <a:ext uri="{FF2B5EF4-FFF2-40B4-BE49-F238E27FC236}">
-                <a16:creationId xmlns:a16="http://schemas.microsoft.com/office/drawing/2014/main" id="{C3209759-9341-4AA5-AE0D-109A6751184E}"/>
+                <a16:creationId xmlns:a16="http://schemas.microsoft.com/office/drawing/2014/main" id="{AC60F34E-B1F3-4E18-A184-EFFA0C390E1F}"/>
               </a:ext>
             </a:extLst>
           </p:cNvPr>
@@ -12429,7 +12434,7 @@
           <p:cNvPr id="14" name="paper-v-1">
             <a:extLst xmlns:a="http://schemas.openxmlformats.org/drawingml/2006/main">
               <a:ext uri="{FF2B5EF4-FFF2-40B4-BE49-F238E27FC236}">
-                <a16:creationId xmlns:a16="http://schemas.microsoft.com/office/drawing/2014/main" id="{9432115A-C090-4F6D-964F-D3B9D9C20795}"/>
+                <a16:creationId xmlns:a16="http://schemas.microsoft.com/office/drawing/2014/main" id="{60D3593E-EC8A-49F0-B45D-032A761120BB}"/>
               </a:ext>
             </a:extLst>
           </p:cNvPr>
@@ -12469,7 +12474,7 @@
                   <a:srgbClr val="64747B"/>
                 </a:solidFill>
               </a:rPr>
-              <a:t>8+12 训练任务 · 24 optimizer steps · 1×NVIDIA RTX PRO 6000 Blackwell Server Edition</a:t>
+              <a:t>8+12 训练任务 · 24 optimizer steps · 1×NVIDIA H200</a:t>
             </a:r>
           </a:p>
         </p:txBody>
@@ -12479,7 +12484,7 @@
           <p:cNvPr id="15" name="">
             <a:extLst xmlns:a="http://schemas.openxmlformats.org/drawingml/2006/main">
               <a:ext uri="{FF2B5EF4-FFF2-40B4-BE49-F238E27FC236}">
-                <a16:creationId xmlns:a16="http://schemas.microsoft.com/office/drawing/2014/main" id="{8FC65A7C-2283-4593-989A-2E7AE3744FAF}"/>
+                <a16:creationId xmlns:a16="http://schemas.microsoft.com/office/drawing/2014/main" id="{45FE5486-AE4D-48F5-AFCD-2B5F1C7A8C1D}"/>
               </a:ext>
             </a:extLst>
           </p:cNvPr>
@@ -12510,7 +12515,7 @@
           <p:cNvPr id="16" name="paper-k-2">
             <a:extLst xmlns:a="http://schemas.openxmlformats.org/drawingml/2006/main">
               <a:ext uri="{FF2B5EF4-FFF2-40B4-BE49-F238E27FC236}">
-                <a16:creationId xmlns:a16="http://schemas.microsoft.com/office/drawing/2014/main" id="{DEFB3AE3-67EA-47AE-B065-98AA466CB67C}"/>
+                <a16:creationId xmlns:a16="http://schemas.microsoft.com/office/drawing/2014/main" id="{05DFBBDA-DCFB-4D64-ADA6-0B6418A74D0D}"/>
               </a:ext>
             </a:extLst>
           </p:cNvPr>
@@ -12560,7 +12565,7 @@
           <p:cNvPr id="17" name="paper-v-2">
             <a:extLst xmlns:a="http://schemas.openxmlformats.org/drawingml/2006/main">
               <a:ext uri="{FF2B5EF4-FFF2-40B4-BE49-F238E27FC236}">
-                <a16:creationId xmlns:a16="http://schemas.microsoft.com/office/drawing/2014/main" id="{2D8F8A85-E003-43F1-BD38-60CFD79AB6E9}"/>
+                <a16:creationId xmlns:a16="http://schemas.microsoft.com/office/drawing/2014/main" id="{0544EBEE-BD5B-4D2B-8E38-3270FE4E60CE}"/>
               </a:ext>
             </a:extLst>
           </p:cNvPr>
@@ -12610,7 +12615,7 @@
           <p:cNvPr id="18" name="">
             <a:extLst xmlns:a="http://schemas.openxmlformats.org/drawingml/2006/main">
               <a:ext uri="{FF2B5EF4-FFF2-40B4-BE49-F238E27FC236}">
-                <a16:creationId xmlns:a16="http://schemas.microsoft.com/office/drawing/2014/main" id="{32A5FA17-CF6D-4847-8930-EB8C075A6C1F}"/>
+                <a16:creationId xmlns:a16="http://schemas.microsoft.com/office/drawing/2014/main" id="{9DD11A86-1492-4D31-8ABC-B4A5EA900EBB}"/>
               </a:ext>
             </a:extLst>
           </p:cNvPr>
@@ -12641,7 +12646,7 @@
           <p:cNvPr id="19" name="paper-k-3">
             <a:extLst xmlns:a="http://schemas.openxmlformats.org/drawingml/2006/main">
               <a:ext uri="{FF2B5EF4-FFF2-40B4-BE49-F238E27FC236}">
-                <a16:creationId xmlns:a16="http://schemas.microsoft.com/office/drawing/2014/main" id="{4082D73F-D614-406D-A9FA-DB97B8F55047}"/>
+                <a16:creationId xmlns:a16="http://schemas.microsoft.com/office/drawing/2014/main" id="{3BBEA9BD-A04F-47E0-816B-70EB370C5158}"/>
               </a:ext>
             </a:extLst>
           </p:cNvPr>
@@ -12691,7 +12696,7 @@
           <p:cNvPr id="20" name="paper-v-3">
             <a:extLst xmlns:a="http://schemas.openxmlformats.org/drawingml/2006/main">
               <a:ext uri="{FF2B5EF4-FFF2-40B4-BE49-F238E27FC236}">
-                <a16:creationId xmlns:a16="http://schemas.microsoft.com/office/drawing/2014/main" id="{C7A88290-65FE-4036-A6DC-5569BE039AB8}"/>
+                <a16:creationId xmlns:a16="http://schemas.microsoft.com/office/drawing/2014/main" id="{4831035E-E961-4E65-8D42-182BB7CB9BE1}"/>
               </a:ext>
             </a:extLst>
           </p:cNvPr>
@@ -12739,7 +12744,7 @@
     </p:spTree>
     <p:extLst>
       <p:ext uri="{BB962C8B-B14F-4D97-AF65-F5344CB8AC3E}">
-        <p14:creationId xmlns:p14="http://schemas.microsoft.com/office/powerpoint/2010/main" val="1665567531"/>
+        <p14:creationId xmlns:p14="http://schemas.microsoft.com/office/powerpoint/2010/main" val="1081484946"/>
       </p:ext>
     </p:extLst>
   </p:cSld>
@@ -12770,7 +12775,7 @@
           <p:cNvPr id="40" name="rail-4">
             <a:extLst xmlns:a="http://schemas.openxmlformats.org/drawingml/2006/main">
               <a:ext uri="{FF2B5EF4-FFF2-40B4-BE49-F238E27FC236}">
-                <a16:creationId xmlns:a16="http://schemas.microsoft.com/office/drawing/2014/main" id="{E9E59F5F-0E45-4BE7-8C8C-DBFED9B8DD43}"/>
+                <a16:creationId xmlns:a16="http://schemas.microsoft.com/office/drawing/2014/main" id="{25712915-4426-4E8F-9BFD-B314C70F8682}"/>
               </a:ext>
             </a:extLst>
           </p:cNvPr>
@@ -12803,7 +12808,7 @@
           <p:cNvPr id="2" name="flourish-4">
             <a:extLst xmlns:a="http://schemas.openxmlformats.org/drawingml/2006/main">
               <a:ext uri="{FF2B5EF4-FFF2-40B4-BE49-F238E27FC236}">
-                <a16:creationId xmlns:a16="http://schemas.microsoft.com/office/drawing/2014/main" id="{E100F91C-F930-4D46-AAD5-DA6C6949D88D}"/>
+                <a16:creationId xmlns:a16="http://schemas.microsoft.com/office/drawing/2014/main" id="{FAB95C4F-2BD9-4370-8AB5-66C3BC97A147}"/>
               </a:ext>
             </a:extLst>
           </p:cNvPr>
@@ -12853,7 +12858,7 @@
           <p:cNvPr id="3" name="chapter-4">
             <a:extLst xmlns:a="http://schemas.openxmlformats.org/drawingml/2006/main">
               <a:ext uri="{FF2B5EF4-FFF2-40B4-BE49-F238E27FC236}">
-                <a16:creationId xmlns:a16="http://schemas.microsoft.com/office/drawing/2014/main" id="{B6E4666D-6F65-4403-B127-CE52B0F512A4}"/>
+                <a16:creationId xmlns:a16="http://schemas.microsoft.com/office/drawing/2014/main" id="{A5A0048D-A2FD-48AE-931A-968E3692075D}"/>
               </a:ext>
             </a:extLst>
           </p:cNvPr>
@@ -12903,7 +12908,7 @@
           <p:cNvPr id="4" name="title-4">
             <a:extLst xmlns:a="http://schemas.openxmlformats.org/drawingml/2006/main">
               <a:ext uri="{FF2B5EF4-FFF2-40B4-BE49-F238E27FC236}">
-                <a16:creationId xmlns:a16="http://schemas.microsoft.com/office/drawing/2014/main" id="{94DD244E-EEDA-4F38-B1CD-B663E6727A48}"/>
+                <a16:creationId xmlns:a16="http://schemas.microsoft.com/office/drawing/2014/main" id="{22D87F0B-B729-4BF9-8215-F485D6EC8223}"/>
               </a:ext>
             </a:extLst>
           </p:cNvPr>
@@ -12953,7 +12958,7 @@
           <p:cNvPr id="5" name="subtitle-4">
             <a:extLst xmlns:a="http://schemas.openxmlformats.org/drawingml/2006/main">
               <a:ext uri="{FF2B5EF4-FFF2-40B4-BE49-F238E27FC236}">
-                <a16:creationId xmlns:a16="http://schemas.microsoft.com/office/drawing/2014/main" id="{2EAE2C5A-0D9F-43CB-B6C9-10671A40E0CF}"/>
+                <a16:creationId xmlns:a16="http://schemas.microsoft.com/office/drawing/2014/main" id="{953A31EC-789C-4D96-A1F2-CCB0EB759CCB}"/>
               </a:ext>
             </a:extLst>
           </p:cNvPr>
@@ -13003,7 +13008,7 @@
           <p:cNvPr id="6" name="">
             <a:extLst xmlns:a="http://schemas.openxmlformats.org/drawingml/2006/main">
               <a:ext uri="{FF2B5EF4-FFF2-40B4-BE49-F238E27FC236}">
-                <a16:creationId xmlns:a16="http://schemas.microsoft.com/office/drawing/2014/main" id="{B890FB67-4A60-43A7-ABD1-2D71DD79D116}"/>
+                <a16:creationId xmlns:a16="http://schemas.microsoft.com/office/drawing/2014/main" id="{50821572-66A4-432F-A6FF-D30EDFB5C193}"/>
               </a:ext>
             </a:extLst>
           </p:cNvPr>
@@ -13034,7 +13039,7 @@
           <p:cNvPr id="7" name="page-4">
             <a:extLst xmlns:a="http://schemas.openxmlformats.org/drawingml/2006/main">
               <a:ext uri="{FF2B5EF4-FFF2-40B4-BE49-F238E27FC236}">
-                <a16:creationId xmlns:a16="http://schemas.microsoft.com/office/drawing/2014/main" id="{FFE5E00D-211D-4393-9EF0-8F221A562DE8}"/>
+                <a16:creationId xmlns:a16="http://schemas.microsoft.com/office/drawing/2014/main" id="{8E4D1BF1-92B0-4B0F-A0A9-DC6C49E89C6D}"/>
               </a:ext>
             </a:extLst>
           </p:cNvPr>
@@ -13084,7 +13089,7 @@
           <p:cNvPr id="8" name="">
             <a:extLst xmlns:a="http://schemas.openxmlformats.org/drawingml/2006/main">
               <a:ext uri="{FF2B5EF4-FFF2-40B4-BE49-F238E27FC236}">
-                <a16:creationId xmlns:a16="http://schemas.microsoft.com/office/drawing/2014/main" id="{4FC7625F-C935-4460-A146-D040245BF218}"/>
+                <a16:creationId xmlns:a16="http://schemas.microsoft.com/office/drawing/2014/main" id="{0C09F84B-62FD-4C35-B2E4-46A7278020D8}"/>
               </a:ext>
             </a:extLst>
           </p:cNvPr>
@@ -13115,7 +13120,7 @@
           <p:cNvPr id="9" name="">
             <a:extLst xmlns:a="http://schemas.openxmlformats.org/drawingml/2006/main">
               <a:ext uri="{FF2B5EF4-FFF2-40B4-BE49-F238E27FC236}">
-                <a16:creationId xmlns:a16="http://schemas.microsoft.com/office/drawing/2014/main" id="{9C89CF2B-27E4-4C49-BCF1-83076BE8FD6C}"/>
+                <a16:creationId xmlns:a16="http://schemas.microsoft.com/office/drawing/2014/main" id="{527B47FB-546C-4507-B55D-7C3192FC7025}"/>
               </a:ext>
             </a:extLst>
           </p:cNvPr>
@@ -13146,7 +13151,7 @@
           <p:cNvPr id="10" name="">
             <a:extLst xmlns:a="http://schemas.openxmlformats.org/drawingml/2006/main">
               <a:ext uri="{FF2B5EF4-FFF2-40B4-BE49-F238E27FC236}">
-                <a16:creationId xmlns:a16="http://schemas.microsoft.com/office/drawing/2014/main" id="{9E3D1CBE-DEB3-4810-B82A-9051F95506FD}"/>
+                <a16:creationId xmlns:a16="http://schemas.microsoft.com/office/drawing/2014/main" id="{4C867E7A-6205-4FBE-89DD-D406C4EB48D0}"/>
               </a:ext>
             </a:extLst>
           </p:cNvPr>
@@ -13177,7 +13182,7 @@
           <p:cNvPr id="11" name="">
             <a:extLst xmlns:a="http://schemas.openxmlformats.org/drawingml/2006/main">
               <a:ext uri="{FF2B5EF4-FFF2-40B4-BE49-F238E27FC236}">
-                <a16:creationId xmlns:a16="http://schemas.microsoft.com/office/drawing/2014/main" id="{37681327-F996-41F1-B7A2-501B27ADA11F}"/>
+                <a16:creationId xmlns:a16="http://schemas.microsoft.com/office/drawing/2014/main" id="{619E800F-2858-4AF9-A7FA-E3E0D56644E8}"/>
               </a:ext>
             </a:extLst>
           </p:cNvPr>
@@ -13208,7 +13213,7 @@
           <p:cNvPr id="12" name="arch-0">
             <a:extLst xmlns:a="http://schemas.openxmlformats.org/drawingml/2006/main">
               <a:ext uri="{FF2B5EF4-FFF2-40B4-BE49-F238E27FC236}">
-                <a16:creationId xmlns:a16="http://schemas.microsoft.com/office/drawing/2014/main" id="{6B82774A-535C-47B5-A0AD-E6EF2799A31D}"/>
+                <a16:creationId xmlns:a16="http://schemas.microsoft.com/office/drawing/2014/main" id="{4D3D6D4E-B0B9-44C0-9BFB-4888000BF839}"/>
               </a:ext>
             </a:extLst>
           </p:cNvPr>
@@ -13243,7 +13248,7 @@
           <p:cNvPr id="13" name="arch-k-0">
             <a:extLst xmlns:a="http://schemas.openxmlformats.org/drawingml/2006/main">
               <a:ext uri="{FF2B5EF4-FFF2-40B4-BE49-F238E27FC236}">
-                <a16:creationId xmlns:a16="http://schemas.microsoft.com/office/drawing/2014/main" id="{8506D3DF-2224-488A-872D-1204D0DEF03B}"/>
+                <a16:creationId xmlns:a16="http://schemas.microsoft.com/office/drawing/2014/main" id="{254AF8BE-AFC8-4354-81DB-52898930F3BB}"/>
               </a:ext>
             </a:extLst>
           </p:cNvPr>
@@ -13293,7 +13298,7 @@
           <p:cNvPr id="14" name="arch-v-0">
             <a:extLst xmlns:a="http://schemas.openxmlformats.org/drawingml/2006/main">
               <a:ext uri="{FF2B5EF4-FFF2-40B4-BE49-F238E27FC236}">
-                <a16:creationId xmlns:a16="http://schemas.microsoft.com/office/drawing/2014/main" id="{01E06543-D5C1-455D-A945-1FA318E08B69}"/>
+                <a16:creationId xmlns:a16="http://schemas.microsoft.com/office/drawing/2014/main" id="{700CC552-C2FE-4775-8319-FF85968F0400}"/>
               </a:ext>
             </a:extLst>
           </p:cNvPr>
@@ -13343,7 +13348,7 @@
           <p:cNvPr id="15" name="arch-1">
             <a:extLst xmlns:a="http://schemas.openxmlformats.org/drawingml/2006/main">
               <a:ext uri="{FF2B5EF4-FFF2-40B4-BE49-F238E27FC236}">
-                <a16:creationId xmlns:a16="http://schemas.microsoft.com/office/drawing/2014/main" id="{3D25D797-DE2C-45D0-AAB5-09C7910DA6E6}"/>
+                <a16:creationId xmlns:a16="http://schemas.microsoft.com/office/drawing/2014/main" id="{41EAE2C1-3337-410F-9D69-778A6D46C00C}"/>
               </a:ext>
             </a:extLst>
           </p:cNvPr>
@@ -13378,7 +13383,7 @@
           <p:cNvPr id="16" name="arch-k-1">
             <a:extLst xmlns:a="http://schemas.openxmlformats.org/drawingml/2006/main">
               <a:ext uri="{FF2B5EF4-FFF2-40B4-BE49-F238E27FC236}">
-                <a16:creationId xmlns:a16="http://schemas.microsoft.com/office/drawing/2014/main" id="{62AB2D31-E2AC-43D8-86F0-71A5D6751DED}"/>
+                <a16:creationId xmlns:a16="http://schemas.microsoft.com/office/drawing/2014/main" id="{E968C422-A40B-46E3-8DB7-A5CD36A4952E}"/>
               </a:ext>
             </a:extLst>
           </p:cNvPr>
@@ -13428,7 +13433,7 @@
           <p:cNvPr id="17" name="arch-v-1">
             <a:extLst xmlns:a="http://schemas.openxmlformats.org/drawingml/2006/main">
               <a:ext uri="{FF2B5EF4-FFF2-40B4-BE49-F238E27FC236}">
-                <a16:creationId xmlns:a16="http://schemas.microsoft.com/office/drawing/2014/main" id="{56FFB859-E2C3-4E70-B6A9-F2C5AF5A48A9}"/>
+                <a16:creationId xmlns:a16="http://schemas.microsoft.com/office/drawing/2014/main" id="{0CD20252-D9C0-4C5C-B5D8-C20D4DF5ADD2}"/>
               </a:ext>
             </a:extLst>
           </p:cNvPr>
@@ -13495,7 +13500,7 @@
           <p:cNvPr id="18" name="arch-2">
             <a:extLst xmlns:a="http://schemas.openxmlformats.org/drawingml/2006/main">
               <a:ext uri="{FF2B5EF4-FFF2-40B4-BE49-F238E27FC236}">
-                <a16:creationId xmlns:a16="http://schemas.microsoft.com/office/drawing/2014/main" id="{EDBF17AB-ED54-4C6C-BA4F-FF805F1A6147}"/>
+                <a16:creationId xmlns:a16="http://schemas.microsoft.com/office/drawing/2014/main" id="{57EE7BD2-9FEB-4E6C-8F9C-61BFDA0AA842}"/>
               </a:ext>
             </a:extLst>
           </p:cNvPr>
@@ -13530,7 +13535,7 @@
           <p:cNvPr id="19" name="arch-k-2">
             <a:extLst xmlns:a="http://schemas.openxmlformats.org/drawingml/2006/main">
               <a:ext uri="{FF2B5EF4-FFF2-40B4-BE49-F238E27FC236}">
-                <a16:creationId xmlns:a16="http://schemas.microsoft.com/office/drawing/2014/main" id="{CBD45942-0774-4215-BB63-3425EE1ED498}"/>
+                <a16:creationId xmlns:a16="http://schemas.microsoft.com/office/drawing/2014/main" id="{2810FE73-0B19-49E0-8866-416B45BB0923}"/>
               </a:ext>
             </a:extLst>
           </p:cNvPr>
@@ -13580,7 +13585,7 @@
           <p:cNvPr id="20" name="arch-v-2">
             <a:extLst xmlns:a="http://schemas.openxmlformats.org/drawingml/2006/main">
               <a:ext uri="{FF2B5EF4-FFF2-40B4-BE49-F238E27FC236}">
-                <a16:creationId xmlns:a16="http://schemas.microsoft.com/office/drawing/2014/main" id="{4D9A7B68-7528-40EF-94BE-4D9DEDE89325}"/>
+                <a16:creationId xmlns:a16="http://schemas.microsoft.com/office/drawing/2014/main" id="{925F35FB-6F9C-4A3A-8004-1E235A65A05F}"/>
               </a:ext>
             </a:extLst>
           </p:cNvPr>
@@ -13647,7 +13652,7 @@
           <p:cNvPr id="21" name="arch-3">
             <a:extLst xmlns:a="http://schemas.openxmlformats.org/drawingml/2006/main">
               <a:ext uri="{FF2B5EF4-FFF2-40B4-BE49-F238E27FC236}">
-                <a16:creationId xmlns:a16="http://schemas.microsoft.com/office/drawing/2014/main" id="{3AC05581-FFA3-4EDB-9686-25AA83E50B12}"/>
+                <a16:creationId xmlns:a16="http://schemas.microsoft.com/office/drawing/2014/main" id="{3A48335F-48E2-49C8-AD6A-BF86A1C8069B}"/>
               </a:ext>
             </a:extLst>
           </p:cNvPr>
@@ -13682,7 +13687,7 @@
           <p:cNvPr id="22" name="arch-k-3">
             <a:extLst xmlns:a="http://schemas.openxmlformats.org/drawingml/2006/main">
               <a:ext uri="{FF2B5EF4-FFF2-40B4-BE49-F238E27FC236}">
-                <a16:creationId xmlns:a16="http://schemas.microsoft.com/office/drawing/2014/main" id="{0CF34868-33CD-4018-9E4F-C6A46A274FAE}"/>
+                <a16:creationId xmlns:a16="http://schemas.microsoft.com/office/drawing/2014/main" id="{11AE2CBA-E856-4527-9787-67D2773E7D41}"/>
               </a:ext>
             </a:extLst>
           </p:cNvPr>
@@ -13732,7 +13737,7 @@
           <p:cNvPr id="23" name="arch-v-3">
             <a:extLst xmlns:a="http://schemas.openxmlformats.org/drawingml/2006/main">
               <a:ext uri="{FF2B5EF4-FFF2-40B4-BE49-F238E27FC236}">
-                <a16:creationId xmlns:a16="http://schemas.microsoft.com/office/drawing/2014/main" id="{CF5AC2D5-B0DB-4B40-8507-BA3CBBDAD9ED}"/>
+                <a16:creationId xmlns:a16="http://schemas.microsoft.com/office/drawing/2014/main" id="{5492B061-2DD5-47B7-9512-02F3F5DB6004}"/>
               </a:ext>
             </a:extLst>
           </p:cNvPr>
@@ -13799,7 +13804,7 @@
           <p:cNvPr id="24" name="arch-4">
             <a:extLst xmlns:a="http://schemas.openxmlformats.org/drawingml/2006/main">
               <a:ext uri="{FF2B5EF4-FFF2-40B4-BE49-F238E27FC236}">
-                <a16:creationId xmlns:a16="http://schemas.microsoft.com/office/drawing/2014/main" id="{C81B2248-D1B8-4002-B791-7FE0CEEC71C7}"/>
+                <a16:creationId xmlns:a16="http://schemas.microsoft.com/office/drawing/2014/main" id="{0A3E7378-4388-4D94-B088-45808592E1AB}"/>
               </a:ext>
             </a:extLst>
           </p:cNvPr>
@@ -13834,7 +13839,7 @@
           <p:cNvPr id="25" name="arch-k-4">
             <a:extLst xmlns:a="http://schemas.openxmlformats.org/drawingml/2006/main">
               <a:ext uri="{FF2B5EF4-FFF2-40B4-BE49-F238E27FC236}">
-                <a16:creationId xmlns:a16="http://schemas.microsoft.com/office/drawing/2014/main" id="{33D28780-A538-4B05-9299-CFDB7D36C250}"/>
+                <a16:creationId xmlns:a16="http://schemas.microsoft.com/office/drawing/2014/main" id="{7C2B3C0E-E089-4951-B7C4-FC357F2D3A99}"/>
               </a:ext>
             </a:extLst>
           </p:cNvPr>
@@ -13884,7 +13889,7 @@
           <p:cNvPr id="26" name="arch-v-4">
             <a:extLst xmlns:a="http://schemas.openxmlformats.org/drawingml/2006/main">
               <a:ext uri="{FF2B5EF4-FFF2-40B4-BE49-F238E27FC236}">
-                <a16:creationId xmlns:a16="http://schemas.microsoft.com/office/drawing/2014/main" id="{3F8CEBDA-6CE9-481F-BDB6-D86C7CD48433}"/>
+                <a16:creationId xmlns:a16="http://schemas.microsoft.com/office/drawing/2014/main" id="{ED229051-10A1-4092-80FB-E5327ACC4681}"/>
               </a:ext>
             </a:extLst>
           </p:cNvPr>
@@ -13951,7 +13956,7 @@
           <p:cNvPr id="27" name="arch-loop">
             <a:extLst xmlns:a="http://schemas.openxmlformats.org/drawingml/2006/main">
               <a:ext uri="{FF2B5EF4-FFF2-40B4-BE49-F238E27FC236}">
-                <a16:creationId xmlns:a16="http://schemas.microsoft.com/office/drawing/2014/main" id="{EED8A4B3-6FA2-448B-9642-A3B9C659725B}"/>
+                <a16:creationId xmlns:a16="http://schemas.microsoft.com/office/drawing/2014/main" id="{E53E1922-CCA0-40D4-BFD6-8B0742946B50}"/>
               </a:ext>
             </a:extLst>
           </p:cNvPr>
@@ -14001,7 +14006,7 @@
           <p:cNvPr id="28" name="">
             <a:extLst xmlns:a="http://schemas.openxmlformats.org/drawingml/2006/main">
               <a:ext uri="{FF2B5EF4-FFF2-40B4-BE49-F238E27FC236}">
-                <a16:creationId xmlns:a16="http://schemas.microsoft.com/office/drawing/2014/main" id="{5531A032-E084-4AA9-8F0D-F203E558267A}"/>
+                <a16:creationId xmlns:a16="http://schemas.microsoft.com/office/drawing/2014/main" id="{F5577310-8D00-4BD6-988A-F063F306E682}"/>
               </a:ext>
             </a:extLst>
           </p:cNvPr>
@@ -14032,7 +14037,7 @@
           <p:cNvPr id="29" name="arch-tools-value">
             <a:extLst xmlns:a="http://schemas.openxmlformats.org/drawingml/2006/main">
               <a:ext uri="{FF2B5EF4-FFF2-40B4-BE49-F238E27FC236}">
-                <a16:creationId xmlns:a16="http://schemas.microsoft.com/office/drawing/2014/main" id="{A2009986-9B25-4C5D-AC9B-ED5A6D0CF27E}"/>
+                <a16:creationId xmlns:a16="http://schemas.microsoft.com/office/drawing/2014/main" id="{3E44AC19-A84F-4FA5-83EC-38A68DDC045B}"/>
               </a:ext>
             </a:extLst>
           </p:cNvPr>
@@ -14082,7 +14087,7 @@
           <p:cNvPr id="30" name="arch-tools-label">
             <a:extLst xmlns:a="http://schemas.openxmlformats.org/drawingml/2006/main">
               <a:ext uri="{FF2B5EF4-FFF2-40B4-BE49-F238E27FC236}">
-                <a16:creationId xmlns:a16="http://schemas.microsoft.com/office/drawing/2014/main" id="{63B7DE04-36D8-4A16-A212-F74EE3F9455A}"/>
+                <a16:creationId xmlns:a16="http://schemas.microsoft.com/office/drawing/2014/main" id="{ED3E3C91-20D1-472A-A987-EFF654D994FC}"/>
               </a:ext>
             </a:extLst>
           </p:cNvPr>
@@ -14132,7 +14137,7 @@
           <p:cNvPr id="31" name="">
             <a:extLst xmlns:a="http://schemas.openxmlformats.org/drawingml/2006/main">
               <a:ext uri="{FF2B5EF4-FFF2-40B4-BE49-F238E27FC236}">
-                <a16:creationId xmlns:a16="http://schemas.microsoft.com/office/drawing/2014/main" id="{C1D23482-56AB-4513-A466-D52E23BDCA9C}"/>
+                <a16:creationId xmlns:a16="http://schemas.microsoft.com/office/drawing/2014/main" id="{2A8B98F9-B889-4679-9826-96AA937771D6}"/>
               </a:ext>
             </a:extLst>
           </p:cNvPr>
@@ -14163,7 +14168,7 @@
           <p:cNvPr id="32" name="arch-group-value">
             <a:extLst xmlns:a="http://schemas.openxmlformats.org/drawingml/2006/main">
               <a:ext uri="{FF2B5EF4-FFF2-40B4-BE49-F238E27FC236}">
-                <a16:creationId xmlns:a16="http://schemas.microsoft.com/office/drawing/2014/main" id="{CC93E92A-E5DF-4712-814E-C5D11B583780}"/>
+                <a16:creationId xmlns:a16="http://schemas.microsoft.com/office/drawing/2014/main" id="{0B3ABCCC-5745-4A2F-A777-9E50756627B3}"/>
               </a:ext>
             </a:extLst>
           </p:cNvPr>
@@ -14213,7 +14218,7 @@
           <p:cNvPr id="33" name="arch-group-label">
             <a:extLst xmlns:a="http://schemas.openxmlformats.org/drawingml/2006/main">
               <a:ext uri="{FF2B5EF4-FFF2-40B4-BE49-F238E27FC236}">
-                <a16:creationId xmlns:a16="http://schemas.microsoft.com/office/drawing/2014/main" id="{7B8EEB50-A202-497E-AFE9-2E5D267FD0C2}"/>
+                <a16:creationId xmlns:a16="http://schemas.microsoft.com/office/drawing/2014/main" id="{14A19D6F-57DF-40A7-A8C4-67707E133B03}"/>
               </a:ext>
             </a:extLst>
           </p:cNvPr>
@@ -14263,7 +14268,7 @@
           <p:cNvPr id="34" name="">
             <a:extLst xmlns:a="http://schemas.openxmlformats.org/drawingml/2006/main">
               <a:ext uri="{FF2B5EF4-FFF2-40B4-BE49-F238E27FC236}">
-                <a16:creationId xmlns:a16="http://schemas.microsoft.com/office/drawing/2014/main" id="{FA5540FC-FE8F-480B-8E26-9A4F2056FBD8}"/>
+                <a16:creationId xmlns:a16="http://schemas.microsoft.com/office/drawing/2014/main" id="{3C0362F0-DB80-46B0-93C0-C1D8E2EA9EEB}"/>
               </a:ext>
             </a:extLst>
           </p:cNvPr>
@@ -14294,7 +14299,7 @@
           <p:cNvPr id="35" name="arch-max-value">
             <a:extLst xmlns:a="http://schemas.openxmlformats.org/drawingml/2006/main">
               <a:ext uri="{FF2B5EF4-FFF2-40B4-BE49-F238E27FC236}">
-                <a16:creationId xmlns:a16="http://schemas.microsoft.com/office/drawing/2014/main" id="{768E1B46-B243-47A0-A2E6-D3297554367D}"/>
+                <a16:creationId xmlns:a16="http://schemas.microsoft.com/office/drawing/2014/main" id="{DDC2DC88-A352-4622-8513-55410B8C7B71}"/>
               </a:ext>
             </a:extLst>
           </p:cNvPr>
@@ -14344,7 +14349,7 @@
           <p:cNvPr id="36" name="arch-max-label">
             <a:extLst xmlns:a="http://schemas.openxmlformats.org/drawingml/2006/main">
               <a:ext uri="{FF2B5EF4-FFF2-40B4-BE49-F238E27FC236}">
-                <a16:creationId xmlns:a16="http://schemas.microsoft.com/office/drawing/2014/main" id="{23982825-558B-4716-94BA-13E91509F7B6}"/>
+                <a16:creationId xmlns:a16="http://schemas.microsoft.com/office/drawing/2014/main" id="{7B355EF2-E393-43A2-A7C7-AF580D3DD2C8}"/>
               </a:ext>
             </a:extLst>
           </p:cNvPr>
@@ -14394,7 +14399,7 @@
           <p:cNvPr id="37" name="">
             <a:extLst xmlns:a="http://schemas.openxmlformats.org/drawingml/2006/main">
               <a:ext uri="{FF2B5EF4-FFF2-40B4-BE49-F238E27FC236}">
-                <a16:creationId xmlns:a16="http://schemas.microsoft.com/office/drawing/2014/main" id="{629DD5E3-DF64-4181-9F5B-27262414CB6C}"/>
+                <a16:creationId xmlns:a16="http://schemas.microsoft.com/office/drawing/2014/main" id="{C5A44CF4-68D6-4458-9BFB-9BD48A84A7CB}"/>
               </a:ext>
             </a:extLst>
           </p:cNvPr>
@@ -14425,7 +14430,7 @@
           <p:cNvPr id="38" name="arch-token-value">
             <a:extLst xmlns:a="http://schemas.openxmlformats.org/drawingml/2006/main">
               <a:ext uri="{FF2B5EF4-FFF2-40B4-BE49-F238E27FC236}">
-                <a16:creationId xmlns:a16="http://schemas.microsoft.com/office/drawing/2014/main" id="{54372F1D-819E-4158-943F-ED70DDED5DA7}"/>
+                <a16:creationId xmlns:a16="http://schemas.microsoft.com/office/drawing/2014/main" id="{6EAC9FEC-CD52-462A-93E9-3A87AC18667F}"/>
               </a:ext>
             </a:extLst>
           </p:cNvPr>
@@ -14475,7 +14480,7 @@
           <p:cNvPr id="39" name="arch-token-label">
             <a:extLst xmlns:a="http://schemas.openxmlformats.org/drawingml/2006/main">
               <a:ext uri="{FF2B5EF4-FFF2-40B4-BE49-F238E27FC236}">
-                <a16:creationId xmlns:a16="http://schemas.microsoft.com/office/drawing/2014/main" id="{FCA33248-8CFE-49D8-A5AA-1179C14F9472}"/>
+                <a16:creationId xmlns:a16="http://schemas.microsoft.com/office/drawing/2014/main" id="{CB63B9FC-8B24-40D4-8516-486ED1D320D0}"/>
               </a:ext>
             </a:extLst>
           </p:cNvPr>
@@ -14523,7 +14528,7 @@
     </p:spTree>
     <p:extLst>
       <p:ext uri="{BB962C8B-B14F-4D97-AF65-F5344CB8AC3E}">
-        <p14:creationId xmlns:p14="http://schemas.microsoft.com/office/powerpoint/2010/main" val="1231843830"/>
+        <p14:creationId xmlns:p14="http://schemas.microsoft.com/office/powerpoint/2010/main" val="575894917"/>
       </p:ext>
     </p:extLst>
   </p:cSld>
@@ -14554,7 +14559,7 @@
           <p:cNvPr id="37" name="rail-5">
             <a:extLst xmlns:a="http://schemas.openxmlformats.org/drawingml/2006/main">
               <a:ext uri="{FF2B5EF4-FFF2-40B4-BE49-F238E27FC236}">
-                <a16:creationId xmlns:a16="http://schemas.microsoft.com/office/drawing/2014/main" id="{4D02E208-639D-4EB9-A9A6-9B4883214922}"/>
+                <a16:creationId xmlns:a16="http://schemas.microsoft.com/office/drawing/2014/main" id="{61923480-4E79-4B18-BA1C-115E5B00961F}"/>
               </a:ext>
             </a:extLst>
           </p:cNvPr>
@@ -14587,7 +14592,7 @@
           <p:cNvPr id="2" name="flourish-5">
             <a:extLst xmlns:a="http://schemas.openxmlformats.org/drawingml/2006/main">
               <a:ext uri="{FF2B5EF4-FFF2-40B4-BE49-F238E27FC236}">
-                <a16:creationId xmlns:a16="http://schemas.microsoft.com/office/drawing/2014/main" id="{F2353754-F881-47AB-A0AC-96DEC7869F33}"/>
+                <a16:creationId xmlns:a16="http://schemas.microsoft.com/office/drawing/2014/main" id="{352D1874-8E1F-401E-B8EE-BA766A682435}"/>
               </a:ext>
             </a:extLst>
           </p:cNvPr>
@@ -14637,7 +14642,7 @@
           <p:cNvPr id="3" name="chapter-5">
             <a:extLst xmlns:a="http://schemas.openxmlformats.org/drawingml/2006/main">
               <a:ext uri="{FF2B5EF4-FFF2-40B4-BE49-F238E27FC236}">
-                <a16:creationId xmlns:a16="http://schemas.microsoft.com/office/drawing/2014/main" id="{FA030FF4-79F5-4BB5-B907-8389BC2B0E48}"/>
+                <a16:creationId xmlns:a16="http://schemas.microsoft.com/office/drawing/2014/main" id="{797FDCB2-3E41-4184-BD1C-B78E01AE57A6}"/>
               </a:ext>
             </a:extLst>
           </p:cNvPr>
@@ -14687,7 +14692,7 @@
           <p:cNvPr id="4" name="title-5">
             <a:extLst xmlns:a="http://schemas.openxmlformats.org/drawingml/2006/main">
               <a:ext uri="{FF2B5EF4-FFF2-40B4-BE49-F238E27FC236}">
-                <a16:creationId xmlns:a16="http://schemas.microsoft.com/office/drawing/2014/main" id="{5D7A8EB1-B63D-4A1F-91CF-C8071081ECBA}"/>
+                <a16:creationId xmlns:a16="http://schemas.microsoft.com/office/drawing/2014/main" id="{9F3208AB-0569-4059-88C1-E18B7AD1DF5B}"/>
               </a:ext>
             </a:extLst>
           </p:cNvPr>
@@ -14737,7 +14742,7 @@
           <p:cNvPr id="5" name="subtitle-5">
             <a:extLst xmlns:a="http://schemas.openxmlformats.org/drawingml/2006/main">
               <a:ext uri="{FF2B5EF4-FFF2-40B4-BE49-F238E27FC236}">
-                <a16:creationId xmlns:a16="http://schemas.microsoft.com/office/drawing/2014/main" id="{84CDB97D-1EEF-4269-BF23-E5CE6332F888}"/>
+                <a16:creationId xmlns:a16="http://schemas.microsoft.com/office/drawing/2014/main" id="{FAEDCE4C-7B78-480F-A459-517816F0BBFA}"/>
               </a:ext>
             </a:extLst>
           </p:cNvPr>
@@ -14787,7 +14792,7 @@
           <p:cNvPr id="6" name="">
             <a:extLst xmlns:a="http://schemas.openxmlformats.org/drawingml/2006/main">
               <a:ext uri="{FF2B5EF4-FFF2-40B4-BE49-F238E27FC236}">
-                <a16:creationId xmlns:a16="http://schemas.microsoft.com/office/drawing/2014/main" id="{891CB09B-4EFC-49F6-A7F3-672265C0188A}"/>
+                <a16:creationId xmlns:a16="http://schemas.microsoft.com/office/drawing/2014/main" id="{75900F2F-222D-4A8E-8782-896E75FB7421}"/>
               </a:ext>
             </a:extLst>
           </p:cNvPr>
@@ -14818,7 +14823,7 @@
           <p:cNvPr id="7" name="page-5">
             <a:extLst xmlns:a="http://schemas.openxmlformats.org/drawingml/2006/main">
               <a:ext uri="{FF2B5EF4-FFF2-40B4-BE49-F238E27FC236}">
-                <a16:creationId xmlns:a16="http://schemas.microsoft.com/office/drawing/2014/main" id="{55AC8BE0-6B44-4E17-96E3-18F760572E54}"/>
+                <a16:creationId xmlns:a16="http://schemas.microsoft.com/office/drawing/2014/main" id="{D43AC12D-D5B8-465C-BF62-2304BADFF6AC}"/>
               </a:ext>
             </a:extLst>
           </p:cNvPr>
@@ -14868,7 +14873,7 @@
           <p:cNvPr id="8" name="">
             <a:extLst xmlns:a="http://schemas.openxmlformats.org/drawingml/2006/main">
               <a:ext uri="{FF2B5EF4-FFF2-40B4-BE49-F238E27FC236}">
-                <a16:creationId xmlns:a16="http://schemas.microsoft.com/office/drawing/2014/main" id="{A2A16F02-99B1-4B0B-94CF-366A8DB25C34}"/>
+                <a16:creationId xmlns:a16="http://schemas.microsoft.com/office/drawing/2014/main" id="{61EA9A92-0BF5-4849-A401-DE07876E3AE4}"/>
               </a:ext>
             </a:extLst>
           </p:cNvPr>
@@ -14899,7 +14904,7 @@
           <p:cNvPr id="9" name="">
             <a:extLst xmlns:a="http://schemas.openxmlformats.org/drawingml/2006/main">
               <a:ext uri="{FF2B5EF4-FFF2-40B4-BE49-F238E27FC236}">
-                <a16:creationId xmlns:a16="http://schemas.microsoft.com/office/drawing/2014/main" id="{B3887594-90AE-44B1-92D3-801C40E65475}"/>
+                <a16:creationId xmlns:a16="http://schemas.microsoft.com/office/drawing/2014/main" id="{FD488DD5-BF2C-4632-AEFF-437C4B3C0402}"/>
               </a:ext>
             </a:extLst>
           </p:cNvPr>
@@ -14930,7 +14935,7 @@
           <p:cNvPr id="10" name="">
             <a:extLst xmlns:a="http://schemas.openxmlformats.org/drawingml/2006/main">
               <a:ext uri="{FF2B5EF4-FFF2-40B4-BE49-F238E27FC236}">
-                <a16:creationId xmlns:a16="http://schemas.microsoft.com/office/drawing/2014/main" id="{E0FB6290-A3C9-4FB6-9B1A-714B75C70950}"/>
+                <a16:creationId xmlns:a16="http://schemas.microsoft.com/office/drawing/2014/main" id="{8DDC4A85-01EC-428F-BD07-587E9458CDA6}"/>
               </a:ext>
             </a:extLst>
           </p:cNvPr>
@@ -14961,7 +14966,7 @@
           <p:cNvPr id="11" name="">
             <a:extLst xmlns:a="http://schemas.openxmlformats.org/drawingml/2006/main">
               <a:ext uri="{FF2B5EF4-FFF2-40B4-BE49-F238E27FC236}">
-                <a16:creationId xmlns:a16="http://schemas.microsoft.com/office/drawing/2014/main" id="{C68A739E-27AE-44B8-95EC-7869D2337CA1}"/>
+                <a16:creationId xmlns:a16="http://schemas.microsoft.com/office/drawing/2014/main" id="{99635A45-F373-4F57-902C-BE1A42A66281}"/>
               </a:ext>
             </a:extLst>
           </p:cNvPr>
@@ -14992,7 +14997,7 @@
           <p:cNvPr id="12" name="">
             <a:extLst xmlns:a="http://schemas.openxmlformats.org/drawingml/2006/main">
               <a:ext uri="{FF2B5EF4-FFF2-40B4-BE49-F238E27FC236}">
-                <a16:creationId xmlns:a16="http://schemas.microsoft.com/office/drawing/2014/main" id="{2189E8CD-D7D2-4392-8093-81B3C0A38010}"/>
+                <a16:creationId xmlns:a16="http://schemas.microsoft.com/office/drawing/2014/main" id="{95610F0F-0B76-4C4A-A069-151B7DD34257}"/>
               </a:ext>
             </a:extLst>
           </p:cNvPr>
@@ -15023,7 +15028,7 @@
           <p:cNvPr id="13" name="">
             <a:extLst xmlns:a="http://schemas.openxmlformats.org/drawingml/2006/main">
               <a:ext uri="{FF2B5EF4-FFF2-40B4-BE49-F238E27FC236}">
-                <a16:creationId xmlns:a16="http://schemas.microsoft.com/office/drawing/2014/main" id="{D04BCE65-BCD2-46CC-BC5A-329EAA89D772}"/>
+                <a16:creationId xmlns:a16="http://schemas.microsoft.com/office/drawing/2014/main" id="{B730BF38-118C-4D61-B046-C7C550787543}"/>
               </a:ext>
             </a:extLst>
           </p:cNvPr>
@@ -15054,7 +15059,7 @@
           <p:cNvPr id="14" name="state-dot-0">
             <a:extLst xmlns:a="http://schemas.openxmlformats.org/drawingml/2006/main">
               <a:ext uri="{FF2B5EF4-FFF2-40B4-BE49-F238E27FC236}">
-                <a16:creationId xmlns:a16="http://schemas.microsoft.com/office/drawing/2014/main" id="{CE126283-A038-4F5C-B750-B3F841610A25}"/>
+                <a16:creationId xmlns:a16="http://schemas.microsoft.com/office/drawing/2014/main" id="{25266659-B19C-4F13-B2E9-D432B9B804A9}"/>
               </a:ext>
             </a:extLst>
           </p:cNvPr>
@@ -15089,7 +15094,7 @@
           <p:cNvPr id="15" name="state-n-0">
             <a:extLst xmlns:a="http://schemas.openxmlformats.org/drawingml/2006/main">
               <a:ext uri="{FF2B5EF4-FFF2-40B4-BE49-F238E27FC236}">
-                <a16:creationId xmlns:a16="http://schemas.microsoft.com/office/drawing/2014/main" id="{6B5225F3-1B5E-45CC-8BCC-6955F96A661D}"/>
+                <a16:creationId xmlns:a16="http://schemas.microsoft.com/office/drawing/2014/main" id="{9AF4244B-2B21-4C3D-98AA-C5F2F9D681C8}"/>
               </a:ext>
             </a:extLst>
           </p:cNvPr>
@@ -15139,7 +15144,7 @@
           <p:cNvPr id="16" name="state-label-0">
             <a:extLst xmlns:a="http://schemas.openxmlformats.org/drawingml/2006/main">
               <a:ext uri="{FF2B5EF4-FFF2-40B4-BE49-F238E27FC236}">
-                <a16:creationId xmlns:a16="http://schemas.microsoft.com/office/drawing/2014/main" id="{F9B6568D-D529-4C96-A71A-F6CD6E6A9587}"/>
+                <a16:creationId xmlns:a16="http://schemas.microsoft.com/office/drawing/2014/main" id="{03327AD5-EA60-4A2E-B9F4-F9C1644EADEC}"/>
               </a:ext>
             </a:extLst>
           </p:cNvPr>
@@ -15189,7 +15194,7 @@
           <p:cNvPr id="17" name="state-dot-1">
             <a:extLst xmlns:a="http://schemas.openxmlformats.org/drawingml/2006/main">
               <a:ext uri="{FF2B5EF4-FFF2-40B4-BE49-F238E27FC236}">
-                <a16:creationId xmlns:a16="http://schemas.microsoft.com/office/drawing/2014/main" id="{EDF8E3D6-833A-40D4-A01A-BD8F8F5E470D}"/>
+                <a16:creationId xmlns:a16="http://schemas.microsoft.com/office/drawing/2014/main" id="{CC5A8B23-A899-472F-AF06-5FE0BB38C2E5}"/>
               </a:ext>
             </a:extLst>
           </p:cNvPr>
@@ -15224,7 +15229,7 @@
           <p:cNvPr id="18" name="state-n-1">
             <a:extLst xmlns:a="http://schemas.openxmlformats.org/drawingml/2006/main">
               <a:ext uri="{FF2B5EF4-FFF2-40B4-BE49-F238E27FC236}">
-                <a16:creationId xmlns:a16="http://schemas.microsoft.com/office/drawing/2014/main" id="{FD5DA091-6BBD-4E1B-BE7B-BC3DEEA59F39}"/>
+                <a16:creationId xmlns:a16="http://schemas.microsoft.com/office/drawing/2014/main" id="{2B43A021-E494-4FBE-B16B-9F485FDB2CB5}"/>
               </a:ext>
             </a:extLst>
           </p:cNvPr>
@@ -15274,7 +15279,7 @@
           <p:cNvPr id="19" name="state-label-1">
             <a:extLst xmlns:a="http://schemas.openxmlformats.org/drawingml/2006/main">
               <a:ext uri="{FF2B5EF4-FFF2-40B4-BE49-F238E27FC236}">
-                <a16:creationId xmlns:a16="http://schemas.microsoft.com/office/drawing/2014/main" id="{B2847533-1222-47D3-9499-585B09D71A23}"/>
+                <a16:creationId xmlns:a16="http://schemas.microsoft.com/office/drawing/2014/main" id="{0D9E8A91-6CE6-423E-8559-0484EDE09BE8}"/>
               </a:ext>
             </a:extLst>
           </p:cNvPr>
@@ -15324,7 +15329,7 @@
           <p:cNvPr id="20" name="state-dot-2">
             <a:extLst xmlns:a="http://schemas.openxmlformats.org/drawingml/2006/main">
               <a:ext uri="{FF2B5EF4-FFF2-40B4-BE49-F238E27FC236}">
-                <a16:creationId xmlns:a16="http://schemas.microsoft.com/office/drawing/2014/main" id="{3FF6BB2A-22C6-4724-A624-82A01E2183E6}"/>
+                <a16:creationId xmlns:a16="http://schemas.microsoft.com/office/drawing/2014/main" id="{4C364DBC-140E-4DE2-9923-539F34030D80}"/>
               </a:ext>
             </a:extLst>
           </p:cNvPr>
@@ -15359,7 +15364,7 @@
           <p:cNvPr id="21" name="state-n-2">
             <a:extLst xmlns:a="http://schemas.openxmlformats.org/drawingml/2006/main">
               <a:ext uri="{FF2B5EF4-FFF2-40B4-BE49-F238E27FC236}">
-                <a16:creationId xmlns:a16="http://schemas.microsoft.com/office/drawing/2014/main" id="{00561299-3D92-453C-A8DE-CE70354DF6FE}"/>
+                <a16:creationId xmlns:a16="http://schemas.microsoft.com/office/drawing/2014/main" id="{1DD22662-1257-4636-B424-8242DE22CE60}"/>
               </a:ext>
             </a:extLst>
           </p:cNvPr>
@@ -15409,7 +15414,7 @@
           <p:cNvPr id="22" name="state-label-2">
             <a:extLst xmlns:a="http://schemas.openxmlformats.org/drawingml/2006/main">
               <a:ext uri="{FF2B5EF4-FFF2-40B4-BE49-F238E27FC236}">
-                <a16:creationId xmlns:a16="http://schemas.microsoft.com/office/drawing/2014/main" id="{71F18C0F-81CB-440D-A8B5-1FA64515E07D}"/>
+                <a16:creationId xmlns:a16="http://schemas.microsoft.com/office/drawing/2014/main" id="{53BF0AF4-6393-455B-A8A2-1315E460AC0F}"/>
               </a:ext>
             </a:extLst>
           </p:cNvPr>
@@ -15459,7 +15464,7 @@
           <p:cNvPr id="23" name="state-dot-3">
             <a:extLst xmlns:a="http://schemas.openxmlformats.org/drawingml/2006/main">
               <a:ext uri="{FF2B5EF4-FFF2-40B4-BE49-F238E27FC236}">
-                <a16:creationId xmlns:a16="http://schemas.microsoft.com/office/drawing/2014/main" id="{6163BDD7-CC95-489A-8A0E-4FC640B725A5}"/>
+                <a16:creationId xmlns:a16="http://schemas.microsoft.com/office/drawing/2014/main" id="{C182CB6B-9A78-4C38-B071-6FBA1EF3E07F}"/>
               </a:ext>
             </a:extLst>
           </p:cNvPr>
@@ -15494,7 +15499,7 @@
           <p:cNvPr id="24" name="state-n-3">
             <a:extLst xmlns:a="http://schemas.openxmlformats.org/drawingml/2006/main">
               <a:ext uri="{FF2B5EF4-FFF2-40B4-BE49-F238E27FC236}">
-                <a16:creationId xmlns:a16="http://schemas.microsoft.com/office/drawing/2014/main" id="{92B03E2B-A0B1-497A-B23C-98398D8CC237}"/>
+                <a16:creationId xmlns:a16="http://schemas.microsoft.com/office/drawing/2014/main" id="{6259D46B-0B38-4B9B-BE8D-BA75C742951B}"/>
               </a:ext>
             </a:extLst>
           </p:cNvPr>
@@ -15544,7 +15549,7 @@
           <p:cNvPr id="25" name="state-label-3">
             <a:extLst xmlns:a="http://schemas.openxmlformats.org/drawingml/2006/main">
               <a:ext uri="{FF2B5EF4-FFF2-40B4-BE49-F238E27FC236}">
-                <a16:creationId xmlns:a16="http://schemas.microsoft.com/office/drawing/2014/main" id="{38050D48-9E5C-497C-A141-99251682AD4B}"/>
+                <a16:creationId xmlns:a16="http://schemas.microsoft.com/office/drawing/2014/main" id="{715A0C48-88DC-4787-B61E-94C9C4A138B7}"/>
               </a:ext>
             </a:extLst>
           </p:cNvPr>
@@ -15594,7 +15599,7 @@
           <p:cNvPr id="26" name="state-dot-4">
             <a:extLst xmlns:a="http://schemas.openxmlformats.org/drawingml/2006/main">
               <a:ext uri="{FF2B5EF4-FFF2-40B4-BE49-F238E27FC236}">
-                <a16:creationId xmlns:a16="http://schemas.microsoft.com/office/drawing/2014/main" id="{C6BC4F10-64D4-4094-9237-0AB858269E11}"/>
+                <a16:creationId xmlns:a16="http://schemas.microsoft.com/office/drawing/2014/main" id="{16552393-702E-4CDC-8EE6-2AF64F7D8BEA}"/>
               </a:ext>
             </a:extLst>
           </p:cNvPr>
@@ -15629,7 +15634,7 @@
           <p:cNvPr id="27" name="state-n-4">
             <a:extLst xmlns:a="http://schemas.openxmlformats.org/drawingml/2006/main">
               <a:ext uri="{FF2B5EF4-FFF2-40B4-BE49-F238E27FC236}">
-                <a16:creationId xmlns:a16="http://schemas.microsoft.com/office/drawing/2014/main" id="{6CF8985C-C8DA-48D2-B5E7-DF66F6675597}"/>
+                <a16:creationId xmlns:a16="http://schemas.microsoft.com/office/drawing/2014/main" id="{E52043EB-E5BA-41C0-9A24-CFC1E5F79B77}"/>
               </a:ext>
             </a:extLst>
           </p:cNvPr>
@@ -15679,7 +15684,7 @@
           <p:cNvPr id="28" name="state-label-4">
             <a:extLst xmlns:a="http://schemas.openxmlformats.org/drawingml/2006/main">
               <a:ext uri="{FF2B5EF4-FFF2-40B4-BE49-F238E27FC236}">
-                <a16:creationId xmlns:a16="http://schemas.microsoft.com/office/drawing/2014/main" id="{61155C8F-82B1-4D21-866A-38001EDCBAE4}"/>
+                <a16:creationId xmlns:a16="http://schemas.microsoft.com/office/drawing/2014/main" id="{811A9C8A-4671-4E4A-BF56-AA60E84CBD24}"/>
               </a:ext>
             </a:extLst>
           </p:cNvPr>
@@ -15729,7 +15734,7 @@
           <p:cNvPr id="29" name="state-dot-5">
             <a:extLst xmlns:a="http://schemas.openxmlformats.org/drawingml/2006/main">
               <a:ext uri="{FF2B5EF4-FFF2-40B4-BE49-F238E27FC236}">
-                <a16:creationId xmlns:a16="http://schemas.microsoft.com/office/drawing/2014/main" id="{0418815E-8169-4B65-B417-ED02D21E5BD2}"/>
+                <a16:creationId xmlns:a16="http://schemas.microsoft.com/office/drawing/2014/main" id="{DA4674C9-054E-4EE5-AF32-C9F34DCE20C3}"/>
               </a:ext>
             </a:extLst>
           </p:cNvPr>
@@ -15764,7 +15769,7 @@
           <p:cNvPr id="30" name="state-n-5">
             <a:extLst xmlns:a="http://schemas.openxmlformats.org/drawingml/2006/main">
               <a:ext uri="{FF2B5EF4-FFF2-40B4-BE49-F238E27FC236}">
-                <a16:creationId xmlns:a16="http://schemas.microsoft.com/office/drawing/2014/main" id="{9AD7CBB8-9FCC-4018-8BB9-0E2F27A09F2B}"/>
+                <a16:creationId xmlns:a16="http://schemas.microsoft.com/office/drawing/2014/main" id="{791211E9-5290-48B5-B42C-399828DA6D0F}"/>
               </a:ext>
             </a:extLst>
           </p:cNvPr>
@@ -15814,7 +15819,7 @@
           <p:cNvPr id="31" name="state-label-5">
             <a:extLst xmlns:a="http://schemas.openxmlformats.org/drawingml/2006/main">
               <a:ext uri="{FF2B5EF4-FFF2-40B4-BE49-F238E27FC236}">
-                <a16:creationId xmlns:a16="http://schemas.microsoft.com/office/drawing/2014/main" id="{1962910B-74D6-4E88-BEAE-E9933AC4CB04}"/>
+                <a16:creationId xmlns:a16="http://schemas.microsoft.com/office/drawing/2014/main" id="{0094E523-5FE4-46CB-94BE-0B0AE7FC9681}"/>
               </a:ext>
             </a:extLst>
           </p:cNvPr>
@@ -15864,7 +15869,7 @@
           <p:cNvPr id="32" name="state-dot-6">
             <a:extLst xmlns:a="http://schemas.openxmlformats.org/drawingml/2006/main">
               <a:ext uri="{FF2B5EF4-FFF2-40B4-BE49-F238E27FC236}">
-                <a16:creationId xmlns:a16="http://schemas.microsoft.com/office/drawing/2014/main" id="{CA094696-3592-4E4E-AA18-34B480CEB8E2}"/>
+                <a16:creationId xmlns:a16="http://schemas.microsoft.com/office/drawing/2014/main" id="{157792AC-CE9C-4130-9771-0C9A2C62125D}"/>
               </a:ext>
             </a:extLst>
           </p:cNvPr>
@@ -15899,7 +15904,7 @@
           <p:cNvPr id="33" name="state-n-6">
             <a:extLst xmlns:a="http://schemas.openxmlformats.org/drawingml/2006/main">
               <a:ext uri="{FF2B5EF4-FFF2-40B4-BE49-F238E27FC236}">
-                <a16:creationId xmlns:a16="http://schemas.microsoft.com/office/drawing/2014/main" id="{4E89DB94-6029-4810-9123-9116E62307C5}"/>
+                <a16:creationId xmlns:a16="http://schemas.microsoft.com/office/drawing/2014/main" id="{C09365DF-1A5D-47D0-B80B-CB8AE50F6A61}"/>
               </a:ext>
             </a:extLst>
           </p:cNvPr>
@@ -15949,7 +15954,7 @@
           <p:cNvPr id="34" name="state-label-6">
             <a:extLst xmlns:a="http://schemas.openxmlformats.org/drawingml/2006/main">
               <a:ext uri="{FF2B5EF4-FFF2-40B4-BE49-F238E27FC236}">
-                <a16:creationId xmlns:a16="http://schemas.microsoft.com/office/drawing/2014/main" id="{E4A63DCF-080A-4B23-BE91-1A5493341154}"/>
+                <a16:creationId xmlns:a16="http://schemas.microsoft.com/office/drawing/2014/main" id="{4F973D1B-506A-46F7-BAC6-E1989894B964}"/>
               </a:ext>
             </a:extLst>
           </p:cNvPr>
@@ -15999,7 +16004,7 @@
           <p:cNvPr id="35" name="state-guard">
             <a:extLst xmlns:a="http://schemas.openxmlformats.org/drawingml/2006/main">
               <a:ext uri="{FF2B5EF4-FFF2-40B4-BE49-F238E27FC236}">
-                <a16:creationId xmlns:a16="http://schemas.microsoft.com/office/drawing/2014/main" id="{3FF09005-8710-47B7-8BF6-FB24A7955A7F}"/>
+                <a16:creationId xmlns:a16="http://schemas.microsoft.com/office/drawing/2014/main" id="{62EA6CFB-2472-474E-8778-87238EE6A948}"/>
               </a:ext>
             </a:extLst>
           </p:cNvPr>
@@ -16034,7 +16039,7 @@
           <p:cNvPr id="36" name="state-guard-text">
             <a:extLst xmlns:a="http://schemas.openxmlformats.org/drawingml/2006/main">
               <a:ext uri="{FF2B5EF4-FFF2-40B4-BE49-F238E27FC236}">
-                <a16:creationId xmlns:a16="http://schemas.microsoft.com/office/drawing/2014/main" id="{BCCF84B2-3FE3-4B3B-82C4-404257A35370}"/>
+                <a16:creationId xmlns:a16="http://schemas.microsoft.com/office/drawing/2014/main" id="{DDDF9A70-9751-45E4-9DB6-6EB9FDC9A173}"/>
               </a:ext>
             </a:extLst>
           </p:cNvPr>
@@ -16082,7 +16087,7 @@
     </p:spTree>
     <p:extLst>
       <p:ext uri="{BB962C8B-B14F-4D97-AF65-F5344CB8AC3E}">
-        <p14:creationId xmlns:p14="http://schemas.microsoft.com/office/powerpoint/2010/main" val="1346657268"/>
+        <p14:creationId xmlns:p14="http://schemas.microsoft.com/office/powerpoint/2010/main" val="1341806939"/>
       </p:ext>
     </p:extLst>
   </p:cSld>
@@ -16113,7 +16118,7 @@
           <p:cNvPr id="24" name="rail-6">
             <a:extLst xmlns:a="http://schemas.openxmlformats.org/drawingml/2006/main">
               <a:ext uri="{FF2B5EF4-FFF2-40B4-BE49-F238E27FC236}">
-                <a16:creationId xmlns:a16="http://schemas.microsoft.com/office/drawing/2014/main" id="{BCAA05A5-28DA-4F68-8B41-C19B33692E22}"/>
+                <a16:creationId xmlns:a16="http://schemas.microsoft.com/office/drawing/2014/main" id="{0E0E0400-6913-4F2A-84B3-44DB639629D5}"/>
               </a:ext>
             </a:extLst>
           </p:cNvPr>
@@ -16146,7 +16151,7 @@
           <p:cNvPr id="2" name="flourish-6">
             <a:extLst xmlns:a="http://schemas.openxmlformats.org/drawingml/2006/main">
               <a:ext uri="{FF2B5EF4-FFF2-40B4-BE49-F238E27FC236}">
-                <a16:creationId xmlns:a16="http://schemas.microsoft.com/office/drawing/2014/main" id="{3A9CB027-ABC3-47DB-A122-22980D3A263E}"/>
+                <a16:creationId xmlns:a16="http://schemas.microsoft.com/office/drawing/2014/main" id="{3FA51A5A-D09B-44AC-9914-119DBB13C457}"/>
               </a:ext>
             </a:extLst>
           </p:cNvPr>
@@ -16196,7 +16201,7 @@
           <p:cNvPr id="3" name="chapter-6">
             <a:extLst xmlns:a="http://schemas.openxmlformats.org/drawingml/2006/main">
               <a:ext uri="{FF2B5EF4-FFF2-40B4-BE49-F238E27FC236}">
-                <a16:creationId xmlns:a16="http://schemas.microsoft.com/office/drawing/2014/main" id="{6294523F-142E-4C76-BF58-87FCB65728BE}"/>
+                <a16:creationId xmlns:a16="http://schemas.microsoft.com/office/drawing/2014/main" id="{6BC728F9-A9DA-4250-B502-92236366C5E0}"/>
               </a:ext>
             </a:extLst>
           </p:cNvPr>
@@ -16246,7 +16251,7 @@
           <p:cNvPr id="4" name="title-6">
             <a:extLst xmlns:a="http://schemas.openxmlformats.org/drawingml/2006/main">
               <a:ext uri="{FF2B5EF4-FFF2-40B4-BE49-F238E27FC236}">
-                <a16:creationId xmlns:a16="http://schemas.microsoft.com/office/drawing/2014/main" id="{B1FB5992-AD19-44D9-9A17-966B430F9EA7}"/>
+                <a16:creationId xmlns:a16="http://schemas.microsoft.com/office/drawing/2014/main" id="{2312A1AE-479B-481F-84A6-F73813010774}"/>
               </a:ext>
             </a:extLst>
           </p:cNvPr>
@@ -16296,7 +16301,7 @@
           <p:cNvPr id="5" name="subtitle-6">
             <a:extLst xmlns:a="http://schemas.openxmlformats.org/drawingml/2006/main">
               <a:ext uri="{FF2B5EF4-FFF2-40B4-BE49-F238E27FC236}">
-                <a16:creationId xmlns:a16="http://schemas.microsoft.com/office/drawing/2014/main" id="{6D578DF2-01C2-4419-A0FB-AC476C805BA6}"/>
+                <a16:creationId xmlns:a16="http://schemas.microsoft.com/office/drawing/2014/main" id="{E534FB07-1849-4B8F-BF27-FCA001C2279A}"/>
               </a:ext>
             </a:extLst>
           </p:cNvPr>
@@ -16346,7 +16351,7 @@
           <p:cNvPr id="6" name="">
             <a:extLst xmlns:a="http://schemas.openxmlformats.org/drawingml/2006/main">
               <a:ext uri="{FF2B5EF4-FFF2-40B4-BE49-F238E27FC236}">
-                <a16:creationId xmlns:a16="http://schemas.microsoft.com/office/drawing/2014/main" id="{036CE4B7-E144-4A20-B5EE-EFB19B7744DB}"/>
+                <a16:creationId xmlns:a16="http://schemas.microsoft.com/office/drawing/2014/main" id="{D374763E-E0C2-4E53-AE62-5C39F7044B5F}"/>
               </a:ext>
             </a:extLst>
           </p:cNvPr>
@@ -16377,7 +16382,7 @@
           <p:cNvPr id="7" name="page-6">
             <a:extLst xmlns:a="http://schemas.openxmlformats.org/drawingml/2006/main">
               <a:ext uri="{FF2B5EF4-FFF2-40B4-BE49-F238E27FC236}">
-                <a16:creationId xmlns:a16="http://schemas.microsoft.com/office/drawing/2014/main" id="{CC687F5C-18E1-4E35-A758-4ADA970F0423}"/>
+                <a16:creationId xmlns:a16="http://schemas.microsoft.com/office/drawing/2014/main" id="{A839A490-AEE0-4E64-975A-944857AF35F0}"/>
               </a:ext>
             </a:extLst>
           </p:cNvPr>
@@ -16427,7 +16432,7 @@
           <p:cNvPr id="8" name="grpo-formula">
             <a:extLst xmlns:a="http://schemas.openxmlformats.org/drawingml/2006/main">
               <a:ext uri="{FF2B5EF4-FFF2-40B4-BE49-F238E27FC236}">
-                <a16:creationId xmlns:a16="http://schemas.microsoft.com/office/drawing/2014/main" id="{98C4A971-91F8-4573-AF86-87C76BEA5544}"/>
+                <a16:creationId xmlns:a16="http://schemas.microsoft.com/office/drawing/2014/main" id="{25999C7A-E2FA-49F2-BF1C-93C4FCAFD955}"/>
               </a:ext>
             </a:extLst>
           </p:cNvPr>
@@ -16462,7 +16467,7 @@
           <p:cNvPr id="9" name="grpo-formula-title">
             <a:extLst xmlns:a="http://schemas.openxmlformats.org/drawingml/2006/main">
               <a:ext uri="{FF2B5EF4-FFF2-40B4-BE49-F238E27FC236}">
-                <a16:creationId xmlns:a16="http://schemas.microsoft.com/office/drawing/2014/main" id="{07F4DFF1-D44E-4DB7-AC3A-EFE0D3B0ADD0}"/>
+                <a16:creationId xmlns:a16="http://schemas.microsoft.com/office/drawing/2014/main" id="{CB6BE685-7A1E-4B51-A26E-4C19FA60E48C}"/>
               </a:ext>
             </a:extLst>
           </p:cNvPr>
@@ -16512,7 +16517,7 @@
           <p:cNvPr id="10" name="grpo-formula-main">
             <a:extLst xmlns:a="http://schemas.openxmlformats.org/drawingml/2006/main">
               <a:ext uri="{FF2B5EF4-FFF2-40B4-BE49-F238E27FC236}">
-                <a16:creationId xmlns:a16="http://schemas.microsoft.com/office/drawing/2014/main" id="{6C8F6B7A-D97B-4493-B394-A9A0070FB8BD}"/>
+                <a16:creationId xmlns:a16="http://schemas.microsoft.com/office/drawing/2014/main" id="{6C87645E-B279-4C3C-9B7C-D9069C9071BB}"/>
               </a:ext>
             </a:extLst>
           </p:cNvPr>
@@ -16562,7 +16567,7 @@
           <p:cNvPr id="11" name="grpo-reward">
             <a:extLst xmlns:a="http://schemas.openxmlformats.org/drawingml/2006/main">
               <a:ext uri="{FF2B5EF4-FFF2-40B4-BE49-F238E27FC236}">
-                <a16:creationId xmlns:a16="http://schemas.microsoft.com/office/drawing/2014/main" id="{5356876F-CE20-40DD-9195-0F8863994E46}"/>
+                <a16:creationId xmlns:a16="http://schemas.microsoft.com/office/drawing/2014/main" id="{D1E0DABA-E737-4ED7-A201-075DBB97908B}"/>
               </a:ext>
             </a:extLst>
           </p:cNvPr>
@@ -16612,7 +16617,7 @@
           <p:cNvPr id="12" name="grpo-num-0">
             <a:extLst xmlns:a="http://schemas.openxmlformats.org/drawingml/2006/main">
               <a:ext uri="{FF2B5EF4-FFF2-40B4-BE49-F238E27FC236}">
-                <a16:creationId xmlns:a16="http://schemas.microsoft.com/office/drawing/2014/main" id="{F41725E5-95FD-499C-86CC-AAA40C9F2684}"/>
+                <a16:creationId xmlns:a16="http://schemas.microsoft.com/office/drawing/2014/main" id="{6B2A1735-43CA-4411-A55C-1FAB66F9BF63}"/>
               </a:ext>
             </a:extLst>
           </p:cNvPr>
@@ -16662,7 +16667,7 @@
           <p:cNvPr id="13" name="grpo-head-0">
             <a:extLst xmlns:a="http://schemas.openxmlformats.org/drawingml/2006/main">
               <a:ext uri="{FF2B5EF4-FFF2-40B4-BE49-F238E27FC236}">
-                <a16:creationId xmlns:a16="http://schemas.microsoft.com/office/drawing/2014/main" id="{46346720-E3C8-4C2A-B19C-72138C413998}"/>
+                <a16:creationId xmlns:a16="http://schemas.microsoft.com/office/drawing/2014/main" id="{49386B27-4844-42A7-9561-D81DEB5D1D0E}"/>
               </a:ext>
             </a:extLst>
           </p:cNvPr>
@@ -16712,7 +16717,7 @@
           <p:cNvPr id="14" name="grpo-sub-0">
             <a:extLst xmlns:a="http://schemas.openxmlformats.org/drawingml/2006/main">
               <a:ext uri="{FF2B5EF4-FFF2-40B4-BE49-F238E27FC236}">
-                <a16:creationId xmlns:a16="http://schemas.microsoft.com/office/drawing/2014/main" id="{420814CA-143D-4E2B-AEB9-DC9706BE4AD6}"/>
+                <a16:creationId xmlns:a16="http://schemas.microsoft.com/office/drawing/2014/main" id="{3FF3F384-579F-4A94-867E-81009A686193}"/>
               </a:ext>
             </a:extLst>
           </p:cNvPr>
@@ -16762,7 +16767,7 @@
           <p:cNvPr id="15" name="grpo-num-1">
             <a:extLst xmlns:a="http://schemas.openxmlformats.org/drawingml/2006/main">
               <a:ext uri="{FF2B5EF4-FFF2-40B4-BE49-F238E27FC236}">
-                <a16:creationId xmlns:a16="http://schemas.microsoft.com/office/drawing/2014/main" id="{FD2C9AB9-CCF8-4140-A603-9BF932CD4246}"/>
+                <a16:creationId xmlns:a16="http://schemas.microsoft.com/office/drawing/2014/main" id="{337F4681-8488-43BA-B761-7035E945E363}"/>
               </a:ext>
             </a:extLst>
           </p:cNvPr>
@@ -16812,7 +16817,7 @@
           <p:cNvPr id="16" name="grpo-head-1">
             <a:extLst xmlns:a="http://schemas.openxmlformats.org/drawingml/2006/main">
               <a:ext uri="{FF2B5EF4-FFF2-40B4-BE49-F238E27FC236}">
-                <a16:creationId xmlns:a16="http://schemas.microsoft.com/office/drawing/2014/main" id="{5625E605-1F28-4300-B46B-538333B8C4CB}"/>
+                <a16:creationId xmlns:a16="http://schemas.microsoft.com/office/drawing/2014/main" id="{35189033-90AF-42F3-8669-FE240E378BFF}"/>
               </a:ext>
             </a:extLst>
           </p:cNvPr>
@@ -16862,7 +16867,7 @@
           <p:cNvPr id="17" name="grpo-sub-1">
             <a:extLst xmlns:a="http://schemas.openxmlformats.org/drawingml/2006/main">
               <a:ext uri="{FF2B5EF4-FFF2-40B4-BE49-F238E27FC236}">
-                <a16:creationId xmlns:a16="http://schemas.microsoft.com/office/drawing/2014/main" id="{E54D189D-9FCD-484B-ADA9-EB1C76FB486F}"/>
+                <a16:creationId xmlns:a16="http://schemas.microsoft.com/office/drawing/2014/main" id="{C5400195-5019-4C41-8DD7-69DE19F1F29C}"/>
               </a:ext>
             </a:extLst>
           </p:cNvPr>
@@ -16912,7 +16917,7 @@
           <p:cNvPr id="18" name="grpo-num-2">
             <a:extLst xmlns:a="http://schemas.openxmlformats.org/drawingml/2006/main">
               <a:ext uri="{FF2B5EF4-FFF2-40B4-BE49-F238E27FC236}">
-                <a16:creationId xmlns:a16="http://schemas.microsoft.com/office/drawing/2014/main" id="{C6A5256D-CC42-4D41-BFD1-39D4D4C8425B}"/>
+                <a16:creationId xmlns:a16="http://schemas.microsoft.com/office/drawing/2014/main" id="{8B582AE4-5120-45B1-85EB-5BC30E41123D}"/>
               </a:ext>
             </a:extLst>
           </p:cNvPr>
@@ -16962,7 +16967,7 @@
           <p:cNvPr id="19" name="grpo-head-2">
             <a:extLst xmlns:a="http://schemas.openxmlformats.org/drawingml/2006/main">
               <a:ext uri="{FF2B5EF4-FFF2-40B4-BE49-F238E27FC236}">
-                <a16:creationId xmlns:a16="http://schemas.microsoft.com/office/drawing/2014/main" id="{C8D910D9-85E9-41CE-BA4F-231B5BC686F7}"/>
+                <a16:creationId xmlns:a16="http://schemas.microsoft.com/office/drawing/2014/main" id="{51278A02-D4ED-4CEE-B1D2-BB675E98634E}"/>
               </a:ext>
             </a:extLst>
           </p:cNvPr>
@@ -17012,7 +17017,7 @@
           <p:cNvPr id="20" name="grpo-sub-2">
             <a:extLst xmlns:a="http://schemas.openxmlformats.org/drawingml/2006/main">
               <a:ext uri="{FF2B5EF4-FFF2-40B4-BE49-F238E27FC236}">
-                <a16:creationId xmlns:a16="http://schemas.microsoft.com/office/drawing/2014/main" id="{9B1D5AE4-9B9B-43AE-936C-42A140016315}"/>
+                <a16:creationId xmlns:a16="http://schemas.microsoft.com/office/drawing/2014/main" id="{9F9B0E57-ED8F-432C-BE2E-B0747BC9CB9F}"/>
               </a:ext>
             </a:extLst>
           </p:cNvPr>
@@ -17052,7 +17057,7 @@
                   <a:srgbClr val="64747B"/>
                 </a:solidFill>
               </a:rPr>
-              <a:t>在单张 NVIDIA RTX PRO 6000 Blackwell Server Edition 上完成</a:t>
+              <a:t>在单张 NVIDIA H200 上完成</a:t>
             </a:r>
           </a:p>
         </p:txBody>
@@ -17062,7 +17067,7 @@
           <p:cNvPr id="21" name="grpo-num-3">
             <a:extLst xmlns:a="http://schemas.openxmlformats.org/drawingml/2006/main">
               <a:ext uri="{FF2B5EF4-FFF2-40B4-BE49-F238E27FC236}">
-                <a16:creationId xmlns:a16="http://schemas.microsoft.com/office/drawing/2014/main" id="{57B35903-ACC5-4C90-A75B-A4C9CEEAE799}"/>
+                <a16:creationId xmlns:a16="http://schemas.microsoft.com/office/drawing/2014/main" id="{1F3FCF52-0AC1-4829-982F-98627EA82E81}"/>
               </a:ext>
             </a:extLst>
           </p:cNvPr>
@@ -17112,7 +17117,7 @@
           <p:cNvPr id="22" name="grpo-head-3">
             <a:extLst xmlns:a="http://schemas.openxmlformats.org/drawingml/2006/main">
               <a:ext uri="{FF2B5EF4-FFF2-40B4-BE49-F238E27FC236}">
-                <a16:creationId xmlns:a16="http://schemas.microsoft.com/office/drawing/2014/main" id="{C02005E9-FD66-4539-BDE7-58D0116568FF}"/>
+                <a16:creationId xmlns:a16="http://schemas.microsoft.com/office/drawing/2014/main" id="{182D024C-3DD5-43BE-94F8-858B4F492A3C}"/>
               </a:ext>
             </a:extLst>
           </p:cNvPr>
@@ -17162,7 +17167,7 @@
           <p:cNvPr id="23" name="grpo-sub-3">
             <a:extLst xmlns:a="http://schemas.openxmlformats.org/drawingml/2006/main">
               <a:ext uri="{FF2B5EF4-FFF2-40B4-BE49-F238E27FC236}">
-                <a16:creationId xmlns:a16="http://schemas.microsoft.com/office/drawing/2014/main" id="{2AC60FAB-6713-4C2F-9900-FF7C224D6F86}"/>
+                <a16:creationId xmlns:a16="http://schemas.microsoft.com/office/drawing/2014/main" id="{8380093F-8776-4FFD-970B-6601AB84852E}"/>
               </a:ext>
             </a:extLst>
           </p:cNvPr>
@@ -17210,7 +17215,7 @@
     </p:spTree>
     <p:extLst>
       <p:ext uri="{BB962C8B-B14F-4D97-AF65-F5344CB8AC3E}">
-        <p14:creationId xmlns:p14="http://schemas.microsoft.com/office/powerpoint/2010/main" val="1427664023"/>
+        <p14:creationId xmlns:p14="http://schemas.microsoft.com/office/powerpoint/2010/main" val="1446781046"/>
       </p:ext>
     </p:extLst>
   </p:cSld>
@@ -17241,7 +17246,7 @@
           <p:cNvPr id="10" name="copper-7">
             <a:extLst xmlns:a="http://schemas.openxmlformats.org/drawingml/2006/main">
               <a:ext uri="{FF2B5EF4-FFF2-40B4-BE49-F238E27FC236}">
-                <a16:creationId xmlns:a16="http://schemas.microsoft.com/office/drawing/2014/main" id="{5DFDFC0E-0AFA-4F61-A49B-901B29071648}"/>
+                <a16:creationId xmlns:a16="http://schemas.microsoft.com/office/drawing/2014/main" id="{F07DE91A-F153-4142-A040-B583E50C7352}"/>
               </a:ext>
             </a:extLst>
           </p:cNvPr>
@@ -17274,7 +17279,7 @@
           <p:cNvPr id="2" name="chapter-script-7">
             <a:extLst xmlns:a="http://schemas.openxmlformats.org/drawingml/2006/main">
               <a:ext uri="{FF2B5EF4-FFF2-40B4-BE49-F238E27FC236}">
-                <a16:creationId xmlns:a16="http://schemas.microsoft.com/office/drawing/2014/main" id="{DB331F41-7F78-45FF-A16D-71A814FD8523}"/>
+                <a16:creationId xmlns:a16="http://schemas.microsoft.com/office/drawing/2014/main" id="{FB08A8D0-8A25-446D-AD9B-BA706F983AA4}"/>
               </a:ext>
             </a:extLst>
           </p:cNvPr>
@@ -17324,7 +17329,7 @@
           <p:cNvPr id="3" name="roman-7">
             <a:extLst xmlns:a="http://schemas.openxmlformats.org/drawingml/2006/main">
               <a:ext uri="{FF2B5EF4-FFF2-40B4-BE49-F238E27FC236}">
-                <a16:creationId xmlns:a16="http://schemas.microsoft.com/office/drawing/2014/main" id="{2953FD2C-B7E5-424E-A4F3-055EFA6FEDDB}"/>
+                <a16:creationId xmlns:a16="http://schemas.microsoft.com/office/drawing/2014/main" id="{F7BA3A62-E1A7-4692-B795-B52BC7363570}"/>
               </a:ext>
             </a:extLst>
           </p:cNvPr>
@@ -17374,7 +17379,7 @@
           <p:cNvPr id="4" name="">
             <a:extLst xmlns:a="http://schemas.openxmlformats.org/drawingml/2006/main">
               <a:ext uri="{FF2B5EF4-FFF2-40B4-BE49-F238E27FC236}">
-                <a16:creationId xmlns:a16="http://schemas.microsoft.com/office/drawing/2014/main" id="{514C573A-00B3-48CA-8A32-DAE146595145}"/>
+                <a16:creationId xmlns:a16="http://schemas.microsoft.com/office/drawing/2014/main" id="{F8F95CA4-DF6D-448F-AFE1-900995D1219F}"/>
               </a:ext>
             </a:extLst>
           </p:cNvPr>
@@ -17405,7 +17410,7 @@
           <p:cNvPr id="5" name="zh-7">
             <a:extLst xmlns:a="http://schemas.openxmlformats.org/drawingml/2006/main">
               <a:ext uri="{FF2B5EF4-FFF2-40B4-BE49-F238E27FC236}">
-                <a16:creationId xmlns:a16="http://schemas.microsoft.com/office/drawing/2014/main" id="{8D0D8BAA-66E7-4E73-B4A4-1CA3AADE34B5}"/>
+                <a16:creationId xmlns:a16="http://schemas.microsoft.com/office/drawing/2014/main" id="{2FEE802C-4CF5-4DB0-AAAF-DF1FEE44E9AC}"/>
               </a:ext>
             </a:extLst>
           </p:cNvPr>
@@ -17455,7 +17460,7 @@
           <p:cNvPr id="6" name="en-7">
             <a:extLst xmlns:a="http://schemas.openxmlformats.org/drawingml/2006/main">
               <a:ext uri="{FF2B5EF4-FFF2-40B4-BE49-F238E27FC236}">
-                <a16:creationId xmlns:a16="http://schemas.microsoft.com/office/drawing/2014/main" id="{1E17C02B-8774-44CD-9AB7-99A9A14C6D1E}"/>
+                <a16:creationId xmlns:a16="http://schemas.microsoft.com/office/drawing/2014/main" id="{B591350E-5D5A-44C2-A310-EE04A7094901}"/>
               </a:ext>
             </a:extLst>
           </p:cNvPr>
@@ -17505,7 +17510,7 @@
           <p:cNvPr id="7" name="body-7">
             <a:extLst xmlns:a="http://schemas.openxmlformats.org/drawingml/2006/main">
               <a:ext uri="{FF2B5EF4-FFF2-40B4-BE49-F238E27FC236}">
-                <a16:creationId xmlns:a16="http://schemas.microsoft.com/office/drawing/2014/main" id="{8F5EDA68-BA96-4F2F-9A9E-0BFF51E35EE8}"/>
+                <a16:creationId xmlns:a16="http://schemas.microsoft.com/office/drawing/2014/main" id="{57B79237-C71C-48C6-B5D1-1630B128D816}"/>
               </a:ext>
             </a:extLst>
           </p:cNvPr>
@@ -17559,7 +17564,7 @@
           <p:cNvPr id="8" name="chapter-pill-7-bg">
             <a:extLst xmlns:a="http://schemas.openxmlformats.org/drawingml/2006/main">
               <a:ext uri="{FF2B5EF4-FFF2-40B4-BE49-F238E27FC236}">
-                <a16:creationId xmlns:a16="http://schemas.microsoft.com/office/drawing/2014/main" id="{7E920D57-743B-437C-91FC-B0AD4F27FAD6}"/>
+                <a16:creationId xmlns:a16="http://schemas.microsoft.com/office/drawing/2014/main" id="{8876D663-0707-45C3-B4E1-3187C9360B8F}"/>
               </a:ext>
             </a:extLst>
           </p:cNvPr>
@@ -17594,7 +17599,7 @@
           <p:cNvPr id="9" name="chapter-pill-7-text">
             <a:extLst xmlns:a="http://schemas.openxmlformats.org/drawingml/2006/main">
               <a:ext uri="{FF2B5EF4-FFF2-40B4-BE49-F238E27FC236}">
-                <a16:creationId xmlns:a16="http://schemas.microsoft.com/office/drawing/2014/main" id="{6035B461-DC46-47FF-B354-89750044F9EB}"/>
+                <a16:creationId xmlns:a16="http://schemas.microsoft.com/office/drawing/2014/main" id="{47D3FFB8-2727-4B32-B369-788EB212BB0B}"/>
               </a:ext>
             </a:extLst>
           </p:cNvPr>
@@ -17642,7 +17647,7 @@
     </p:spTree>
     <p:extLst>
       <p:ext uri="{BB962C8B-B14F-4D97-AF65-F5344CB8AC3E}">
-        <p14:creationId xmlns:p14="http://schemas.microsoft.com/office/powerpoint/2010/main" val="1123570574"/>
+        <p14:creationId xmlns:p14="http://schemas.microsoft.com/office/powerpoint/2010/main" val="736577123"/>
       </p:ext>
     </p:extLst>
   </p:cSld>
@@ -17673,7 +17678,7 @@
           <p:cNvPr id="26" name="rail-8">
             <a:extLst xmlns:a="http://schemas.openxmlformats.org/drawingml/2006/main">
               <a:ext uri="{FF2B5EF4-FFF2-40B4-BE49-F238E27FC236}">
-                <a16:creationId xmlns:a16="http://schemas.microsoft.com/office/drawing/2014/main" id="{D8391327-3467-47BE-A746-7E413447B7C6}"/>
+                <a16:creationId xmlns:a16="http://schemas.microsoft.com/office/drawing/2014/main" id="{B0549258-4B2D-4EDE-8970-71743819ABCE}"/>
               </a:ext>
             </a:extLst>
           </p:cNvPr>
@@ -17706,7 +17711,7 @@
           <p:cNvPr id="2" name="flourish-8">
             <a:extLst xmlns:a="http://schemas.openxmlformats.org/drawingml/2006/main">
               <a:ext uri="{FF2B5EF4-FFF2-40B4-BE49-F238E27FC236}">
-                <a16:creationId xmlns:a16="http://schemas.microsoft.com/office/drawing/2014/main" id="{46C9AB09-42CD-457E-B73C-28EE97908DA4}"/>
+                <a16:creationId xmlns:a16="http://schemas.microsoft.com/office/drawing/2014/main" id="{E3662FCF-887C-464C-8FC7-16855B50C490}"/>
               </a:ext>
             </a:extLst>
           </p:cNvPr>
@@ -17756,7 +17761,7 @@
           <p:cNvPr id="3" name="chapter-8">
             <a:extLst xmlns:a="http://schemas.openxmlformats.org/drawingml/2006/main">
               <a:ext uri="{FF2B5EF4-FFF2-40B4-BE49-F238E27FC236}">
-                <a16:creationId xmlns:a16="http://schemas.microsoft.com/office/drawing/2014/main" id="{FFAF42DA-DCC1-48F1-9321-5FF4F8B0074B}"/>
+                <a16:creationId xmlns:a16="http://schemas.microsoft.com/office/drawing/2014/main" id="{273CD08F-5C31-456B-9FEF-D8F77CD63226}"/>
               </a:ext>
             </a:extLst>
           </p:cNvPr>
@@ -17806,7 +17811,7 @@
           <p:cNvPr id="4" name="title-8">
             <a:extLst xmlns:a="http://schemas.openxmlformats.org/drawingml/2006/main">
               <a:ext uri="{FF2B5EF4-FFF2-40B4-BE49-F238E27FC236}">
-                <a16:creationId xmlns:a16="http://schemas.microsoft.com/office/drawing/2014/main" id="{39D12A8E-B5D7-48B5-9EF1-92F45CCEF1E3}"/>
+                <a16:creationId xmlns:a16="http://schemas.microsoft.com/office/drawing/2014/main" id="{3FCDF0A0-3130-4649-A31C-047FC3BEC323}"/>
               </a:ext>
             </a:extLst>
           </p:cNvPr>
@@ -17856,7 +17861,7 @@
           <p:cNvPr id="5" name="subtitle-8">
             <a:extLst xmlns:a="http://schemas.openxmlformats.org/drawingml/2006/main">
               <a:ext uri="{FF2B5EF4-FFF2-40B4-BE49-F238E27FC236}">
-                <a16:creationId xmlns:a16="http://schemas.microsoft.com/office/drawing/2014/main" id="{909D991E-252C-442D-B313-776231396B23}"/>
+                <a16:creationId xmlns:a16="http://schemas.microsoft.com/office/drawing/2014/main" id="{F2961246-526A-4C32-B7D1-E77187323039}"/>
               </a:ext>
             </a:extLst>
           </p:cNvPr>
@@ -17906,7 +17911,7 @@
           <p:cNvPr id="6" name="">
             <a:extLst xmlns:a="http://schemas.openxmlformats.org/drawingml/2006/main">
               <a:ext uri="{FF2B5EF4-FFF2-40B4-BE49-F238E27FC236}">
-                <a16:creationId xmlns:a16="http://schemas.microsoft.com/office/drawing/2014/main" id="{4B3CEF65-02E3-4C41-8D9F-41EE41DEE84F}"/>
+                <a16:creationId xmlns:a16="http://schemas.microsoft.com/office/drawing/2014/main" id="{E42CED7B-A673-4292-A064-5E9F4049CA54}"/>
               </a:ext>
             </a:extLst>
           </p:cNvPr>
@@ -17937,7 +17942,7 @@
           <p:cNvPr id="7" name="page-8">
             <a:extLst xmlns:a="http://schemas.openxmlformats.org/drawingml/2006/main">
               <a:ext uri="{FF2B5EF4-FFF2-40B4-BE49-F238E27FC236}">
-                <a16:creationId xmlns:a16="http://schemas.microsoft.com/office/drawing/2014/main" id="{31F041FA-CF49-4A59-9527-90CE2CA3C062}"/>
+                <a16:creationId xmlns:a16="http://schemas.microsoft.com/office/drawing/2014/main" id="{AC3263D2-C8EB-460A-89FE-1932E504E214}"/>
               </a:ext>
             </a:extLst>
           </p:cNvPr>
@@ -17987,7 +17992,7 @@
           <p:cNvPr id="8" name="">
             <a:extLst xmlns:a="http://schemas.openxmlformats.org/drawingml/2006/main">
               <a:ext uri="{FF2B5EF4-FFF2-40B4-BE49-F238E27FC236}">
-                <a16:creationId xmlns:a16="http://schemas.microsoft.com/office/drawing/2014/main" id="{78E2A55F-7891-47D0-AF13-6EB8DEC75C1C}"/>
+                <a16:creationId xmlns:a16="http://schemas.microsoft.com/office/drawing/2014/main" id="{7943AE99-E1CC-42E6-B01C-612716519118}"/>
               </a:ext>
             </a:extLst>
           </p:cNvPr>
@@ -18018,7 +18023,7 @@
           <p:cNvPr id="9" name="s1-before-value">
             <a:extLst xmlns:a="http://schemas.openxmlformats.org/drawingml/2006/main">
               <a:ext uri="{FF2B5EF4-FFF2-40B4-BE49-F238E27FC236}">
-                <a16:creationId xmlns:a16="http://schemas.microsoft.com/office/drawing/2014/main" id="{1C0608AC-2845-4F78-85EE-18D31533CCC5}"/>
+                <a16:creationId xmlns:a16="http://schemas.microsoft.com/office/drawing/2014/main" id="{C34860DA-DB12-47C3-B75F-C0164E1E1E79}"/>
               </a:ext>
             </a:extLst>
           </p:cNvPr>
@@ -18068,7 +18073,7 @@
           <p:cNvPr id="10" name="s1-before-label">
             <a:extLst xmlns:a="http://schemas.openxmlformats.org/drawingml/2006/main">
               <a:ext uri="{FF2B5EF4-FFF2-40B4-BE49-F238E27FC236}">
-                <a16:creationId xmlns:a16="http://schemas.microsoft.com/office/drawing/2014/main" id="{04624CA6-3897-4196-98A3-5EA004A84168}"/>
+                <a16:creationId xmlns:a16="http://schemas.microsoft.com/office/drawing/2014/main" id="{82FD2C4F-4712-4917-BAB6-116AEB021EBA}"/>
               </a:ext>
             </a:extLst>
           </p:cNvPr>
@@ -18118,7 +18123,7 @@
           <p:cNvPr id="11" name="">
             <a:extLst xmlns:a="http://schemas.openxmlformats.org/drawingml/2006/main">
               <a:ext uri="{FF2B5EF4-FFF2-40B4-BE49-F238E27FC236}">
-                <a16:creationId xmlns:a16="http://schemas.microsoft.com/office/drawing/2014/main" id="{8609C180-BA98-48CB-8B10-122627B234A8}"/>
+                <a16:creationId xmlns:a16="http://schemas.microsoft.com/office/drawing/2014/main" id="{4C97AAB6-3678-4207-8D15-A6204E234A98}"/>
               </a:ext>
             </a:extLst>
           </p:cNvPr>
@@ -18149,7 +18154,7 @@
           <p:cNvPr id="12" name="s1-after-value">
             <a:extLst xmlns:a="http://schemas.openxmlformats.org/drawingml/2006/main">
               <a:ext uri="{FF2B5EF4-FFF2-40B4-BE49-F238E27FC236}">
-                <a16:creationId xmlns:a16="http://schemas.microsoft.com/office/drawing/2014/main" id="{A47FA299-EF01-4309-88A2-1A19874F1818}"/>
+                <a16:creationId xmlns:a16="http://schemas.microsoft.com/office/drawing/2014/main" id="{20355646-2BA1-47B2-9820-A197779BC5C0}"/>
               </a:ext>
             </a:extLst>
           </p:cNvPr>
@@ -18199,7 +18204,7 @@
           <p:cNvPr id="13" name="s1-after-label">
             <a:extLst xmlns:a="http://schemas.openxmlformats.org/drawingml/2006/main">
               <a:ext uri="{FF2B5EF4-FFF2-40B4-BE49-F238E27FC236}">
-                <a16:creationId xmlns:a16="http://schemas.microsoft.com/office/drawing/2014/main" id="{7FA813F2-F9EE-4635-98E0-E192F3171C4A}"/>
+                <a16:creationId xmlns:a16="http://schemas.microsoft.com/office/drawing/2014/main" id="{511F4118-19F8-46A9-9AF7-FF007E525CFB}"/>
               </a:ext>
             </a:extLst>
           </p:cNvPr>
@@ -18249,7 +18254,7 @@
           <p:cNvPr id="14" name="">
             <a:extLst xmlns:a="http://schemas.openxmlformats.org/drawingml/2006/main">
               <a:ext uri="{FF2B5EF4-FFF2-40B4-BE49-F238E27FC236}">
-                <a16:creationId xmlns:a16="http://schemas.microsoft.com/office/drawing/2014/main" id="{36C4F12B-71E8-4049-9EC3-7BED064D177B}"/>
+                <a16:creationId xmlns:a16="http://schemas.microsoft.com/office/drawing/2014/main" id="{8268E76A-BA8E-4FA8-A8CC-94BA880D8350}"/>
               </a:ext>
             </a:extLst>
           </p:cNvPr>
@@ -18280,7 +18285,7 @@
           <p:cNvPr id="15" name="s1-delta-value">
             <a:extLst xmlns:a="http://schemas.openxmlformats.org/drawingml/2006/main">
               <a:ext uri="{FF2B5EF4-FFF2-40B4-BE49-F238E27FC236}">
-                <a16:creationId xmlns:a16="http://schemas.microsoft.com/office/drawing/2014/main" id="{6FF36055-7F2B-4FAE-AEED-81FEE17580CF}"/>
+                <a16:creationId xmlns:a16="http://schemas.microsoft.com/office/drawing/2014/main" id="{E84C9E59-5905-4A99-B631-8FE99F23B357}"/>
               </a:ext>
             </a:extLst>
           </p:cNvPr>
@@ -18330,7 +18335,7 @@
           <p:cNvPr id="16" name="s1-delta-label">
             <a:extLst xmlns:a="http://schemas.openxmlformats.org/drawingml/2006/main">
               <a:ext uri="{FF2B5EF4-FFF2-40B4-BE49-F238E27FC236}">
-                <a16:creationId xmlns:a16="http://schemas.microsoft.com/office/drawing/2014/main" id="{73680A00-5E0B-47E1-AE2A-40E2FB04A185}"/>
+                <a16:creationId xmlns:a16="http://schemas.microsoft.com/office/drawing/2014/main" id="{F445619B-1DE9-44F0-B151-CA14090C8F9E}"/>
               </a:ext>
             </a:extLst>
           </p:cNvPr>
@@ -18380,7 +18385,7 @@
           <p:cNvPr id="17" name="">
             <a:extLst xmlns:a="http://schemas.openxmlformats.org/drawingml/2006/main">
               <a:ext uri="{FF2B5EF4-FFF2-40B4-BE49-F238E27FC236}">
-                <a16:creationId xmlns:a16="http://schemas.microsoft.com/office/drawing/2014/main" id="{8C44683A-B32C-4CC7-8263-FD8AFB9B258B}"/>
+                <a16:creationId xmlns:a16="http://schemas.microsoft.com/office/drawing/2014/main" id="{6DEACA59-4D07-4FDF-A3AE-CD1E37857817}"/>
               </a:ext>
             </a:extLst>
           </p:cNvPr>
@@ -18411,7 +18416,7 @@
           <p:cNvPr id="18" name="s1-steps-value">
             <a:extLst xmlns:a="http://schemas.openxmlformats.org/drawingml/2006/main">
               <a:ext uri="{FF2B5EF4-FFF2-40B4-BE49-F238E27FC236}">
-                <a16:creationId xmlns:a16="http://schemas.microsoft.com/office/drawing/2014/main" id="{55F7870D-C6CA-489A-A51F-6D256BD4F0EA}"/>
+                <a16:creationId xmlns:a16="http://schemas.microsoft.com/office/drawing/2014/main" id="{452215A1-B299-4614-B1E1-5AAC8434B2FF}"/>
               </a:ext>
             </a:extLst>
           </p:cNvPr>
@@ -18461,7 +18466,7 @@
           <p:cNvPr id="19" name="s1-steps-label">
             <a:extLst xmlns:a="http://schemas.openxmlformats.org/drawingml/2006/main">
               <a:ext uri="{FF2B5EF4-FFF2-40B4-BE49-F238E27FC236}">
-                <a16:creationId xmlns:a16="http://schemas.microsoft.com/office/drawing/2014/main" id="{09A3D27D-3B64-4FE3-BD17-6F2676DA4365}"/>
+                <a16:creationId xmlns:a16="http://schemas.microsoft.com/office/drawing/2014/main" id="{F027325A-2809-4070-BF5F-4D86BD39657A}"/>
               </a:ext>
             </a:extLst>
           </p:cNvPr>
@@ -18511,7 +18516,7 @@
           <p:cNvPr id="20" name="failure-head">
             <a:extLst xmlns:a="http://schemas.openxmlformats.org/drawingml/2006/main">
               <a:ext uri="{FF2B5EF4-FFF2-40B4-BE49-F238E27FC236}">
-                <a16:creationId xmlns:a16="http://schemas.microsoft.com/office/drawing/2014/main" id="{13037BF1-45CA-4B95-9F4D-7EC1E0DF0624}"/>
+                <a16:creationId xmlns:a16="http://schemas.microsoft.com/office/drawing/2014/main" id="{F67EE0AE-9D5E-45EF-85A8-F32470FF9CD6}"/>
               </a:ext>
             </a:extLst>
           </p:cNvPr>
@@ -18561,7 +18566,7 @@
           <p:cNvPr id="21" name="failure-name-0">
             <a:extLst xmlns:a="http://schemas.openxmlformats.org/drawingml/2006/main">
               <a:ext uri="{FF2B5EF4-FFF2-40B4-BE49-F238E27FC236}">
-                <a16:creationId xmlns:a16="http://schemas.microsoft.com/office/drawing/2014/main" id="{E24E53B8-3C59-4DAE-B980-41FAACDB94FD}"/>
+                <a16:creationId xmlns:a16="http://schemas.microsoft.com/office/drawing/2014/main" id="{BE4EC4BF-B564-46CE-86C2-8DF648B8E62A}"/>
               </a:ext>
             </a:extLst>
           </p:cNvPr>
@@ -18611,7 +18616,7 @@
           <p:cNvPr id="22" name="failure-track-0">
             <a:extLst xmlns:a="http://schemas.openxmlformats.org/drawingml/2006/main">
               <a:ext uri="{FF2B5EF4-FFF2-40B4-BE49-F238E27FC236}">
-                <a16:creationId xmlns:a16="http://schemas.microsoft.com/office/drawing/2014/main" id="{D01A6B1B-0A9F-4D99-80B8-D3F3A381CCB7}"/>
+                <a16:creationId xmlns:a16="http://schemas.microsoft.com/office/drawing/2014/main" id="{CED5DE4C-75B7-4F71-9F5A-C1D40239DA04}"/>
               </a:ext>
             </a:extLst>
           </p:cNvPr>
@@ -18646,7 +18651,7 @@
           <p:cNvPr id="23" name="failure-before-0">
             <a:extLst xmlns:a="http://schemas.openxmlformats.org/drawingml/2006/main">
               <a:ext uri="{FF2B5EF4-FFF2-40B4-BE49-F238E27FC236}">
-                <a16:creationId xmlns:a16="http://schemas.microsoft.com/office/drawing/2014/main" id="{82042E93-91F6-420B-854F-6169FF61E16D}"/>
+                <a16:creationId xmlns:a16="http://schemas.microsoft.com/office/drawing/2014/main" id="{17EB89DE-6AD0-4A27-943E-F5158E120CBF}"/>
               </a:ext>
             </a:extLst>
           </p:cNvPr>
@@ -18681,7 +18686,7 @@
           <p:cNvPr id="24" name="failure-after-0">
             <a:extLst xmlns:a="http://schemas.openxmlformats.org/drawingml/2006/main">
               <a:ext uri="{FF2B5EF4-FFF2-40B4-BE49-F238E27FC236}">
-                <a16:creationId xmlns:a16="http://schemas.microsoft.com/office/drawing/2014/main" id="{9478D7AB-4CB9-44F7-A237-95717A67687E}"/>
+                <a16:creationId xmlns:a16="http://schemas.microsoft.com/office/drawing/2014/main" id="{A3D9B5ED-35FA-4F63-8325-854FBDE379D0}"/>
               </a:ext>
             </a:extLst>
           </p:cNvPr>
@@ -18716,7 +18721,7 @@
           <p:cNvPr id="25" name="failure-count-0">
             <a:extLst xmlns:a="http://schemas.openxmlformats.org/drawingml/2006/main">
               <a:ext uri="{FF2B5EF4-FFF2-40B4-BE49-F238E27FC236}">
-                <a16:creationId xmlns:a16="http://schemas.microsoft.com/office/drawing/2014/main" id="{AEA7C6C8-B26C-48DD-864A-8A395104C68E}"/>
+                <a16:creationId xmlns:a16="http://schemas.microsoft.com/office/drawing/2014/main" id="{97B4BAF6-B4A4-4E6E-A510-1C84E62CE97C}"/>
               </a:ext>
             </a:extLst>
           </p:cNvPr>
@@ -18764,7 +18769,7 @@
     </p:spTree>
     <p:extLst>
       <p:ext uri="{BB962C8B-B14F-4D97-AF65-F5344CB8AC3E}">
-        <p14:creationId xmlns:p14="http://schemas.microsoft.com/office/powerpoint/2010/main" val="68153127"/>
+        <p14:creationId xmlns:p14="http://schemas.microsoft.com/office/powerpoint/2010/main" val="267666660"/>
       </p:ext>
     </p:extLst>
   </p:cSld>
@@ -18795,7 +18800,7 @@
           <p:cNvPr id="20" name="rail-9">
             <a:extLst xmlns:a="http://schemas.openxmlformats.org/drawingml/2006/main">
               <a:ext uri="{FF2B5EF4-FFF2-40B4-BE49-F238E27FC236}">
-                <a16:creationId xmlns:a16="http://schemas.microsoft.com/office/drawing/2014/main" id="{1F2B7517-5E2C-4E5F-A91B-03A059FB7FA2}"/>
+                <a16:creationId xmlns:a16="http://schemas.microsoft.com/office/drawing/2014/main" id="{8D09FA97-A0F2-4277-A115-42574C8EBD2C}"/>
               </a:ext>
             </a:extLst>
           </p:cNvPr>
@@ -18828,7 +18833,7 @@
           <p:cNvPr id="2" name="flourish-9">
             <a:extLst xmlns:a="http://schemas.openxmlformats.org/drawingml/2006/main">
               <a:ext uri="{FF2B5EF4-FFF2-40B4-BE49-F238E27FC236}">
-                <a16:creationId xmlns:a16="http://schemas.microsoft.com/office/drawing/2014/main" id="{982387D9-7BDA-40FB-A771-6F0A49A1F12E}"/>
+                <a16:creationId xmlns:a16="http://schemas.microsoft.com/office/drawing/2014/main" id="{24D410B9-3720-432E-B62C-ACCE352D5397}"/>
               </a:ext>
             </a:extLst>
           </p:cNvPr>
@@ -18878,7 +18883,7 @@
           <p:cNvPr id="3" name="chapter-9">
             <a:extLst xmlns:a="http://schemas.openxmlformats.org/drawingml/2006/main">
               <a:ext uri="{FF2B5EF4-FFF2-40B4-BE49-F238E27FC236}">
-                <a16:creationId xmlns:a16="http://schemas.microsoft.com/office/drawing/2014/main" id="{42A3D572-5F4D-42F7-A9E9-4BE67B7135AE}"/>
+                <a16:creationId xmlns:a16="http://schemas.microsoft.com/office/drawing/2014/main" id="{3DE7445B-5A56-45FC-BE93-75741121C065}"/>
               </a:ext>
             </a:extLst>
           </p:cNvPr>
@@ -18928,7 +18933,7 @@
           <p:cNvPr id="4" name="title-9">
             <a:extLst xmlns:a="http://schemas.openxmlformats.org/drawingml/2006/main">
               <a:ext uri="{FF2B5EF4-FFF2-40B4-BE49-F238E27FC236}">
-                <a16:creationId xmlns:a16="http://schemas.microsoft.com/office/drawing/2014/main" id="{6A83479E-C6BD-40EB-B617-C8ED4B9CF71F}"/>
+                <a16:creationId xmlns:a16="http://schemas.microsoft.com/office/drawing/2014/main" id="{81491FA3-D4FB-4A44-B928-FB0F72629188}"/>
               </a:ext>
             </a:extLst>
           </p:cNvPr>
@@ -18978,7 +18983,7 @@
           <p:cNvPr id="5" name="subtitle-9">
             <a:extLst xmlns:a="http://schemas.openxmlformats.org/drawingml/2006/main">
               <a:ext uri="{FF2B5EF4-FFF2-40B4-BE49-F238E27FC236}">
-                <a16:creationId xmlns:a16="http://schemas.microsoft.com/office/drawing/2014/main" id="{1482DBD7-034D-4E51-8BFB-C9C4CC51C4A6}"/>
+                <a16:creationId xmlns:a16="http://schemas.microsoft.com/office/drawing/2014/main" id="{BA86F256-3AC9-4C79-B7AB-2DDDA304F6F9}"/>
               </a:ext>
             </a:extLst>
           </p:cNvPr>
@@ -19028,7 +19033,7 @@
           <p:cNvPr id="6" name="">
             <a:extLst xmlns:a="http://schemas.openxmlformats.org/drawingml/2006/main">
               <a:ext uri="{FF2B5EF4-FFF2-40B4-BE49-F238E27FC236}">
-                <a16:creationId xmlns:a16="http://schemas.microsoft.com/office/drawing/2014/main" id="{52AEFCCD-6FBE-4EDC-85DC-291E07C17C33}"/>
+                <a16:creationId xmlns:a16="http://schemas.microsoft.com/office/drawing/2014/main" id="{9618BEC3-A57E-4D33-B9E3-095E14B83EAD}"/>
               </a:ext>
             </a:extLst>
           </p:cNvPr>
@@ -19059,7 +19064,7 @@
           <p:cNvPr id="7" name="page-9">
             <a:extLst xmlns:a="http://schemas.openxmlformats.org/drawingml/2006/main">
               <a:ext uri="{FF2B5EF4-FFF2-40B4-BE49-F238E27FC236}">
-                <a16:creationId xmlns:a16="http://schemas.microsoft.com/office/drawing/2014/main" id="{A1F4788C-EA70-4459-8834-72CFDEAB53AC}"/>
+                <a16:creationId xmlns:a16="http://schemas.microsoft.com/office/drawing/2014/main" id="{542EDAD2-FCFA-4452-B230-1A35DD1047A8}"/>
               </a:ext>
             </a:extLst>
           </p:cNvPr>
@@ -19109,7 +19114,7 @@
           <p:cNvPr id="8" name="">
             <a:extLst xmlns:a="http://schemas.openxmlformats.org/drawingml/2006/main">
               <a:ext uri="{FF2B5EF4-FFF2-40B4-BE49-F238E27FC236}">
-                <a16:creationId xmlns:a16="http://schemas.microsoft.com/office/drawing/2014/main" id="{6C346D1E-45C8-4B97-BA41-DE80FE660BC8}"/>
+                <a16:creationId xmlns:a16="http://schemas.microsoft.com/office/drawing/2014/main" id="{CBAC4E96-532A-4890-A777-257D1CF7F7AB}"/>
               </a:ext>
             </a:extLst>
           </p:cNvPr>
@@ -19140,7 +19145,7 @@
           <p:cNvPr id="9" name="">
             <a:extLst xmlns:a="http://schemas.openxmlformats.org/drawingml/2006/main">
               <a:ext uri="{FF2B5EF4-FFF2-40B4-BE49-F238E27FC236}">
-                <a16:creationId xmlns:a16="http://schemas.microsoft.com/office/drawing/2014/main" id="{F1E9D0BD-BA3A-42BB-817A-62138E994EB6}"/>
+                <a16:creationId xmlns:a16="http://schemas.microsoft.com/office/drawing/2014/main" id="{9343FCDE-520E-423B-AE4D-991821E39530}"/>
               </a:ext>
             </a:extLst>
           </p:cNvPr>
@@ -19171,7 +19176,7 @@
           <p:cNvPr id="10" name="synth-left">
             <a:extLst xmlns:a="http://schemas.openxmlformats.org/drawingml/2006/main">
               <a:ext uri="{FF2B5EF4-FFF2-40B4-BE49-F238E27FC236}">
-                <a16:creationId xmlns:a16="http://schemas.microsoft.com/office/drawing/2014/main" id="{2E43D0FA-7096-4B31-9058-C35694D1EAEC}"/>
+                <a16:creationId xmlns:a16="http://schemas.microsoft.com/office/drawing/2014/main" id="{BE10167B-B4C0-4D63-A7C1-B03F26EB0647}"/>
               </a:ext>
             </a:extLst>
           </p:cNvPr>
@@ -19206,7 +19211,7 @@
           <p:cNvPr id="11" name="synth-mid">
             <a:extLst xmlns:a="http://schemas.openxmlformats.org/drawingml/2006/main">
               <a:ext uri="{FF2B5EF4-FFF2-40B4-BE49-F238E27FC236}">
-                <a16:creationId xmlns:a16="http://schemas.microsoft.com/office/drawing/2014/main" id="{ED6CD5BE-CDCC-4E92-AC60-26F963683C42}"/>
+                <a16:creationId xmlns:a16="http://schemas.microsoft.com/office/drawing/2014/main" id="{13D6B1F5-C83C-40BF-B739-2622934E34DD}"/>
               </a:ext>
             </a:extLst>
           </p:cNvPr>
@@ -19241,7 +19246,7 @@
           <p:cNvPr id="12" name="synth-right">
             <a:extLst xmlns:a="http://schemas.openxmlformats.org/drawingml/2006/main">
               <a:ext uri="{FF2B5EF4-FFF2-40B4-BE49-F238E27FC236}">
-                <a16:creationId xmlns:a16="http://schemas.microsoft.com/office/drawing/2014/main" id="{C2BCF01D-BB8D-46C3-8450-C760C24D7B76}"/>
+                <a16:creationId xmlns:a16="http://schemas.microsoft.com/office/drawing/2014/main" id="{6781C529-A2C5-4EF8-BB64-FBB65378B808}"/>
               </a:ext>
             </a:extLst>
           </p:cNvPr>
@@ -19276,7 +19281,7 @@
           <p:cNvPr id="13" name="synth-left-k">
             <a:extLst xmlns:a="http://schemas.openxmlformats.org/drawingml/2006/main">
               <a:ext uri="{FF2B5EF4-FFF2-40B4-BE49-F238E27FC236}">
-                <a16:creationId xmlns:a16="http://schemas.microsoft.com/office/drawing/2014/main" id="{904EB983-4246-4296-9C9E-A2CCE0DC3576}"/>
+                <a16:creationId xmlns:a16="http://schemas.microsoft.com/office/drawing/2014/main" id="{2CE97276-27DD-4E01-BC3C-5EEA433D76C6}"/>
               </a:ext>
             </a:extLst>
           </p:cNvPr>
@@ -19326,7 +19331,7 @@
           <p:cNvPr id="14" name="synth-left-v">
             <a:extLst xmlns:a="http://schemas.openxmlformats.org/drawingml/2006/main">
               <a:ext uri="{FF2B5EF4-FFF2-40B4-BE49-F238E27FC236}">
-                <a16:creationId xmlns:a16="http://schemas.microsoft.com/office/drawing/2014/main" id="{36C13FFA-84AB-4AFE-B7BC-F088E6E75148}"/>
+                <a16:creationId xmlns:a16="http://schemas.microsoft.com/office/drawing/2014/main" id="{188F3C1B-04B1-4685-80D3-E673EB51ADC3}"/>
               </a:ext>
             </a:extLst>
           </p:cNvPr>
@@ -19366,7 +19371,7 @@
                   <a:srgbClr val="102330"/>
                 </a:solidFill>
               </a:rPr>
-              <a:t>no observed failure</a:t>
+              <a:t>POLICY_NOT_INSPECTED  ×11</a:t>
             </a:r>
           </a:p>
           <a:p xmlns:a="http://schemas.openxmlformats.org/drawingml/2006/main">
@@ -19383,7 +19388,7 @@
                   <a:srgbClr val="102330"/>
                 </a:solidFill>
               </a:rPr>
-              <a:t>→ fallback taxonomy</a:t>
+              <a:t>TOOL_ERROR_NOT_RECOVERED  ×1</a:t>
             </a:r>
           </a:p>
         </p:txBody>
@@ -19393,7 +19398,7 @@
           <p:cNvPr id="15" name="synth-mid-k">
             <a:extLst xmlns:a="http://schemas.openxmlformats.org/drawingml/2006/main">
               <a:ext uri="{FF2B5EF4-FFF2-40B4-BE49-F238E27FC236}">
-                <a16:creationId xmlns:a16="http://schemas.microsoft.com/office/drawing/2014/main" id="{9D2A2012-433F-43BA-BF2E-D36A2F3536B3}"/>
+                <a16:creationId xmlns:a16="http://schemas.microsoft.com/office/drawing/2014/main" id="{8F18A5D2-D41B-4960-90FC-17C839E9E14A}"/>
               </a:ext>
             </a:extLst>
           </p:cNvPr>
@@ -19460,7 +19465,7 @@
           <p:cNvPr id="16" name="synth-mid-v">
             <a:extLst xmlns:a="http://schemas.openxmlformats.org/drawingml/2006/main">
               <a:ext uri="{FF2B5EF4-FFF2-40B4-BE49-F238E27FC236}">
-                <a16:creationId xmlns:a16="http://schemas.microsoft.com/office/drawing/2014/main" id="{754452FF-1BA5-4EEE-8209-BAD97C1C8F6F}"/>
+                <a16:creationId xmlns:a16="http://schemas.microsoft.com/office/drawing/2014/main" id="{5F28B06A-4C0C-468D-AFB9-3ED1BE81DAFB}"/>
               </a:ext>
             </a:extLst>
           </p:cNvPr>
@@ -19577,7 +19582,7 @@
           <p:cNvPr id="17" name="synth-right-k">
             <a:extLst xmlns:a="http://schemas.openxmlformats.org/drawingml/2006/main">
               <a:ext uri="{FF2B5EF4-FFF2-40B4-BE49-F238E27FC236}">
-                <a16:creationId xmlns:a16="http://schemas.microsoft.com/office/drawing/2014/main" id="{9FC74C2D-7AA5-41EB-856F-5FCECD09E6CD}"/>
+                <a16:creationId xmlns:a16="http://schemas.microsoft.com/office/drawing/2014/main" id="{54652350-DBE1-4820-A6A5-5B40A1CBCDD4}"/>
               </a:ext>
             </a:extLst>
           </p:cNvPr>
@@ -19627,7 +19632,7 @@
           <p:cNvPr id="18" name="synth-right-v">
             <a:extLst xmlns:a="http://schemas.openxmlformats.org/drawingml/2006/main">
               <a:ext uri="{FF2B5EF4-FFF2-40B4-BE49-F238E27FC236}">
-                <a16:creationId xmlns:a16="http://schemas.microsoft.com/office/drawing/2014/main" id="{E8A91F2A-C5DB-4E71-BCC5-5EF03D38996E}"/>
+                <a16:creationId xmlns:a16="http://schemas.microsoft.com/office/drawing/2014/main" id="{E5F5F287-03C4-4684-BD2D-93FD468881DD}"/>
               </a:ext>
             </a:extLst>
           </p:cNvPr>
@@ -19711,7 +19716,7 @@
           <p:cNvPr id="19" name="synth-hash">
             <a:extLst xmlns:a="http://schemas.openxmlformats.org/drawingml/2006/main">
               <a:ext uri="{FF2B5EF4-FFF2-40B4-BE49-F238E27FC236}">
-                <a16:creationId xmlns:a16="http://schemas.microsoft.com/office/drawing/2014/main" id="{85C966BD-C507-43EB-B5A2-98B9E59C7B95}"/>
+                <a16:creationId xmlns:a16="http://schemas.microsoft.com/office/drawing/2014/main" id="{64D92B63-EE34-4FB7-B995-AD2F91007787}"/>
               </a:ext>
             </a:extLst>
           </p:cNvPr>
@@ -19751,7 +19756,7 @@
                   <a:srgbClr val="64747B"/>
                 </a:solidFill>
               </a:rPr>
-              <a:t>source trace  ca0d54b78a400…    stage2 data  5790304c792b7…</a:t>
+              <a:t>source trace  7388b93f024da…    stage2 data  222bd26ad5247…</a:t>
             </a:r>
           </a:p>
         </p:txBody>
@@ -19759,7 +19764,7 @@
     </p:spTree>
     <p:extLst>
       <p:ext uri="{BB962C8B-B14F-4D97-AF65-F5344CB8AC3E}">
-        <p14:creationId xmlns:p14="http://schemas.microsoft.com/office/powerpoint/2010/main" val="1387776807"/>
+        <p14:creationId xmlns:p14="http://schemas.microsoft.com/office/powerpoint/2010/main" val="893588770"/>
       </p:ext>
     </p:extLst>
   </p:cSld>

</xml_diff>